<commit_message>
Passer la presentation au fond blanc et a la palette midnightblue
Fond blanc sur toutes les diapositives de contenu, cartes en teinte
tres claire, palette recentree sur le midnightblue avec l'orange en
seul accent. Les logos de l'ENSAE et de l'ANSD figurent sur la page
de titre et la page finale, le logo de l'ENSAE en pied de page.
Les tirets doubles de la bibliographie sont remplaces par un tiret
simple.

Co-Authored-By: Claude <noreply@anthropic.com>
Claude-Session: https://claude.ai/code/session_01837AJxDdpW6rUH9DV9QD1H
</commit_message>
<xml_diff>
--- a/infographie/presentation_infographique.pptx
+++ b/infographie/presentation_infographique.pptx
@@ -3171,7 +3171,7 @@
     <p:bg>
       <p:bgPr>
         <a:solidFill>
-          <a:srgbClr val="16213D"/>
+          <a:srgbClr val="101038"/>
         </a:solidFill>
       </p:bgPr>
     </p:bg>
@@ -3204,7 +3204,7 @@
             <a:avLst/>
           </a:prstGeom>
           <a:solidFill>
-            <a:srgbClr val="24365E"/>
+            <a:srgbClr val="23236B"/>
           </a:solidFill>
           <a:ln/>
         </p:spPr>
@@ -3224,14 +3224,120 @@
             <a:avLst/>
           </a:prstGeom>
           <a:solidFill>
-            <a:srgbClr val="24365E"/>
+            <a:srgbClr val="23236B"/>
           </a:solidFill>
           <a:ln/>
         </p:spPr>
       </p:sp>
       <p:sp>
         <p:nvSpPr>
-          <p:cNvPr id="4" name="Text 2"/>
+          <p:cNvPr id="4" name="Shape 2"/>
+          <p:cNvSpPr/>
+          <p:nvPr/>
+        </p:nvSpPr>
+        <p:spPr>
+          <a:xfrm>
+            <a:off x="566928" y="411480"/>
+            <a:ext cx="1234440" cy="1234440"/>
+          </a:xfrm>
+          <a:prstGeom prst="roundRect">
+            <a:avLst>
+              <a:gd name="adj" fmla="val 7407"/>
+            </a:avLst>
+          </a:prstGeom>
+          <a:solidFill>
+            <a:srgbClr val="FFFFFF"/>
+          </a:solidFill>
+          <a:ln/>
+          <a:effectLst>
+            <a:outerShdw sx="100000" sy="100000" kx="0" ky="0" algn="bl" rotWithShape="0" blurRad="127000" dist="25400" dir="5400000">
+              <a:srgbClr val="13134F">
+                <a:alpha val="22000"/>
+              </a:srgbClr>
+            </a:outerShdw>
+          </a:effectLst>
+        </p:spPr>
+      </p:sp>
+      <p:pic>
+        <p:nvPicPr>
+          <p:cNvPr id="5" name="Image 0" descr="logos/logo_ensae_new.png">    </p:cNvPr>
+          <p:cNvPicPr>
+            <a:picLocks noChangeAspect="1"/>
+          </p:cNvPicPr>
+          <p:nvPr/>
+        </p:nvPicPr>
+        <p:blipFill>
+          <a:blip r:embed="rId1"/>
+          <a:stretch>
+            <a:fillRect/>
+          </a:stretch>
+        </p:blipFill>
+        <p:spPr>
+          <a:xfrm>
+            <a:off x="685800" y="530352"/>
+            <a:ext cx="996696" cy="996696"/>
+          </a:xfrm>
+          <a:prstGeom prst="rect">
+            <a:avLst/>
+          </a:prstGeom>
+        </p:spPr>
+      </p:pic>
+      <p:sp>
+        <p:nvSpPr>
+          <p:cNvPr id="6" name="Shape 3"/>
+          <p:cNvSpPr/>
+          <p:nvPr/>
+        </p:nvSpPr>
+        <p:spPr>
+          <a:xfrm>
+            <a:off x="10387584" y="411480"/>
+            <a:ext cx="1234440" cy="1234440"/>
+          </a:xfrm>
+          <a:prstGeom prst="roundRect">
+            <a:avLst>
+              <a:gd name="adj" fmla="val 7407"/>
+            </a:avLst>
+          </a:prstGeom>
+          <a:solidFill>
+            <a:srgbClr val="FFFFFF"/>
+          </a:solidFill>
+          <a:ln/>
+          <a:effectLst>
+            <a:outerShdw sx="100000" sy="100000" kx="0" ky="0" algn="bl" rotWithShape="0" blurRad="127000" dist="25400" dir="5400000">
+              <a:srgbClr val="13134F">
+                <a:alpha val="22000"/>
+              </a:srgbClr>
+            </a:outerShdw>
+          </a:effectLst>
+        </p:spPr>
+      </p:sp>
+      <p:pic>
+        <p:nvPicPr>
+          <p:cNvPr id="7" name="Image 1" descr="logos/logo_ansd.jpg">    </p:cNvPr>
+          <p:cNvPicPr>
+            <a:picLocks noChangeAspect="1"/>
+          </p:cNvPicPr>
+          <p:nvPr/>
+        </p:nvPicPr>
+        <p:blipFill>
+          <a:blip r:embed="rId2"/>
+          <a:stretch>
+            <a:fillRect/>
+          </a:stretch>
+        </p:blipFill>
+        <p:spPr>
+          <a:xfrm>
+            <a:off x="10506456" y="612648"/>
+            <a:ext cx="996696" cy="832104"/>
+          </a:xfrm>
+          <a:prstGeom prst="rect">
+            <a:avLst/>
+          </a:prstGeom>
+        </p:spPr>
+      </p:pic>
+      <p:sp>
+        <p:nvSpPr>
+          <p:cNvPr id="8" name="Text 4"/>
           <p:cNvSpPr/>
           <p:nvPr/>
         </p:nvSpPr>
@@ -3270,7 +3376,7 @@
       </p:sp>
       <p:sp>
         <p:nvSpPr>
-          <p:cNvPr id="5" name="Text 3"/>
+          <p:cNvPr id="9" name="Text 5"/>
           <p:cNvSpPr/>
           <p:nvPr/>
         </p:nvSpPr>
@@ -3295,7 +3401,7 @@
             <a:r>
               <a:rPr lang="en-US" sz="1250" dirty="0">
                 <a:solidFill>
-                  <a:srgbClr val="AFC0DA"/>
+                  <a:srgbClr val="B7B7DB"/>
                 </a:solidFill>
                 <a:latin typeface="Calibri" pitchFamily="34" charset="0"/>
                 <a:ea typeface="Calibri" pitchFamily="34" charset="-122"/>
@@ -3309,7 +3415,7 @@
       </p:sp>
       <p:sp>
         <p:nvSpPr>
-          <p:cNvPr id="6" name="Text 4"/>
+          <p:cNvPr id="10" name="Text 6"/>
           <p:cNvSpPr/>
           <p:nvPr/>
         </p:nvSpPr>
@@ -3371,7 +3477,7 @@
       </p:sp>
       <p:sp>
         <p:nvSpPr>
-          <p:cNvPr id="7" name="Text 5"/>
+          <p:cNvPr id="11" name="Text 7"/>
           <p:cNvSpPr/>
           <p:nvPr/>
         </p:nvSpPr>
@@ -3410,7 +3516,7 @@
       </p:sp>
       <p:sp>
         <p:nvSpPr>
-          <p:cNvPr id="8" name="Text 6"/>
+          <p:cNvPr id="12" name="Text 8"/>
           <p:cNvSpPr/>
           <p:nvPr/>
         </p:nvSpPr>
@@ -3449,7 +3555,7 @@
       </p:sp>
       <p:sp>
         <p:nvSpPr>
-          <p:cNvPr id="9" name="Text 7"/>
+          <p:cNvPr id="13" name="Text 9"/>
           <p:cNvSpPr/>
           <p:nvPr/>
         </p:nvSpPr>
@@ -3488,7 +3594,7 @@
       </p:sp>
       <p:sp>
         <p:nvSpPr>
-          <p:cNvPr id="10" name="Text 8"/>
+          <p:cNvPr id="14" name="Text 10"/>
           <p:cNvSpPr/>
           <p:nvPr/>
         </p:nvSpPr>
@@ -3516,7 +3622,7 @@
             <a:r>
               <a:rPr lang="en-US" sz="1050" dirty="0">
                 <a:solidFill>
-                  <a:srgbClr val="AFC0DA"/>
+                  <a:srgbClr val="B7B7DB"/>
                 </a:solidFill>
                 <a:latin typeface="Calibri" pitchFamily="34" charset="0"/>
                 <a:ea typeface="Calibri" pitchFamily="34" charset="-122"/>
@@ -3530,7 +3636,7 @@
       </p:sp>
       <p:sp>
         <p:nvSpPr>
-          <p:cNvPr id="11" name="Text 9"/>
+          <p:cNvPr id="15" name="Text 11"/>
           <p:cNvSpPr/>
           <p:nvPr/>
         </p:nvSpPr>
@@ -3569,7 +3675,7 @@
       </p:sp>
       <p:sp>
         <p:nvSpPr>
-          <p:cNvPr id="12" name="Text 10"/>
+          <p:cNvPr id="16" name="Text 12"/>
           <p:cNvSpPr/>
           <p:nvPr/>
         </p:nvSpPr>
@@ -3608,7 +3714,7 @@
       </p:sp>
       <p:sp>
         <p:nvSpPr>
-          <p:cNvPr id="13" name="Text 11"/>
+          <p:cNvPr id="17" name="Text 13"/>
           <p:cNvSpPr/>
           <p:nvPr/>
         </p:nvSpPr>
@@ -3636,7 +3742,7 @@
             <a:r>
               <a:rPr lang="en-US" sz="1050" dirty="0">
                 <a:solidFill>
-                  <a:srgbClr val="AFC0DA"/>
+                  <a:srgbClr val="B7B7DB"/>
                 </a:solidFill>
                 <a:latin typeface="Calibri" pitchFamily="34" charset="0"/>
                 <a:ea typeface="Calibri" pitchFamily="34" charset="-122"/>
@@ -3650,7 +3756,7 @@
       </p:sp>
       <p:sp>
         <p:nvSpPr>
-          <p:cNvPr id="14" name="Text 12"/>
+          <p:cNvPr id="18" name="Text 14"/>
           <p:cNvSpPr/>
           <p:nvPr/>
         </p:nvSpPr>
@@ -3701,7 +3807,7 @@
     <p:bg>
       <p:bgPr>
         <a:solidFill>
-          <a:srgbClr val="FBFAF8"/>
+          <a:srgbClr val="FFFFFF"/>
         </a:solidFill>
       </p:bgPr>
     </p:bg>
@@ -3746,7 +3852,7 @@
             <a:r>
               <a:rPr lang="en-US" sz="2700" b="1" dirty="0">
                 <a:solidFill>
-                  <a:srgbClr val="1E2B4A"/>
+                  <a:srgbClr val="191970"/>
                 </a:solidFill>
                 <a:latin typeface="Calibri" pitchFamily="34" charset="0"/>
                 <a:ea typeface="Calibri" pitchFamily="34" charset="-122"/>
@@ -3817,13 +3923,13 @@
             </a:avLst>
           </a:prstGeom>
           <a:solidFill>
-            <a:srgbClr val="FFFFFF"/>
+            <a:srgbClr val="F4F5FA"/>
           </a:solidFill>
           <a:ln/>
           <a:effectLst>
             <a:outerShdw sx="100000" sy="100000" kx="0" ky="0" algn="bl" rotWithShape="0" blurRad="127000" dist="25400" dir="5400000">
-              <a:srgbClr val="1E2B4A">
-                <a:alpha val="13000"/>
+              <a:srgbClr val="13134F">
+                <a:alpha val="10000"/>
               </a:srgbClr>
             </a:outerShdw>
           </a:effectLst>
@@ -3844,7 +3950,7 @@
             <a:avLst/>
           </a:prstGeom>
           <a:solidFill>
-            <a:srgbClr val="41639E"/>
+            <a:srgbClr val="4444AD"/>
           </a:solidFill>
           <a:ln w="31750">
             <a:solidFill>
@@ -3854,7 +3960,7 @@
           </a:ln>
           <a:effectLst>
             <a:outerShdw sx="100000" sy="100000" kx="0" ky="0" algn="bl" rotWithShape="0" blurRad="127000" dist="25400" dir="5400000">
-              <a:srgbClr val="1E2B4A">
+              <a:srgbClr val="13134F">
                 <a:alpha val="18000"/>
               </a:srgbClr>
             </a:outerShdw>
@@ -3944,13 +4050,13 @@
             </a:avLst>
           </a:prstGeom>
           <a:solidFill>
-            <a:srgbClr val="FFFFFF"/>
+            <a:srgbClr val="F4F5FA"/>
           </a:solidFill>
           <a:ln/>
           <a:effectLst>
             <a:outerShdw sx="100000" sy="100000" kx="0" ky="0" algn="bl" rotWithShape="0" blurRad="127000" dist="25400" dir="5400000">
-              <a:srgbClr val="1E2B4A">
-                <a:alpha val="13000"/>
+              <a:srgbClr val="13134F">
+                <a:alpha val="10000"/>
               </a:srgbClr>
             </a:outerShdw>
           </a:effectLst>
@@ -3971,7 +4077,7 @@
             <a:avLst/>
           </a:prstGeom>
           <a:solidFill>
-            <a:srgbClr val="3E8C9A"/>
+            <a:srgbClr val="2A2A80"/>
           </a:solidFill>
           <a:ln w="31750">
             <a:solidFill>
@@ -3981,7 +4087,7 @@
           </a:ln>
           <a:effectLst>
             <a:outerShdw sx="100000" sy="100000" kx="0" ky="0" algn="bl" rotWithShape="0" blurRad="127000" dist="25400" dir="5400000">
-              <a:srgbClr val="1E2B4A">
+              <a:srgbClr val="13134F">
                 <a:alpha val="18000"/>
               </a:srgbClr>
             </a:outerShdw>
@@ -4071,13 +4177,13 @@
             </a:avLst>
           </a:prstGeom>
           <a:solidFill>
-            <a:srgbClr val="FFFFFF"/>
+            <a:srgbClr val="F4F5FA"/>
           </a:solidFill>
           <a:ln/>
           <a:effectLst>
             <a:outerShdw sx="100000" sy="100000" kx="0" ky="0" algn="bl" rotWithShape="0" blurRad="127000" dist="25400" dir="5400000">
-              <a:srgbClr val="1E2B4A">
-                <a:alpha val="13000"/>
+              <a:srgbClr val="13134F">
+                <a:alpha val="10000"/>
               </a:srgbClr>
             </a:outerShdw>
           </a:effectLst>
@@ -4098,7 +4204,7 @@
             <a:avLst/>
           </a:prstGeom>
           <a:solidFill>
-            <a:srgbClr val="41639E"/>
+            <a:srgbClr val="4444AD"/>
           </a:solidFill>
           <a:ln w="31750">
             <a:solidFill>
@@ -4108,7 +4214,7 @@
           </a:ln>
           <a:effectLst>
             <a:outerShdw sx="100000" sy="100000" kx="0" ky="0" algn="bl" rotWithShape="0" blurRad="127000" dist="25400" dir="5400000">
-              <a:srgbClr val="1E2B4A">
+              <a:srgbClr val="13134F">
                 <a:alpha val="18000"/>
               </a:srgbClr>
             </a:outerShdw>
@@ -4198,13 +4304,13 @@
             </a:avLst>
           </a:prstGeom>
           <a:solidFill>
-            <a:srgbClr val="FFFFFF"/>
+            <a:srgbClr val="F4F5FA"/>
           </a:solidFill>
           <a:ln/>
           <a:effectLst>
             <a:outerShdw sx="100000" sy="100000" kx="0" ky="0" algn="bl" rotWithShape="0" blurRad="127000" dist="25400" dir="5400000">
-              <a:srgbClr val="1E2B4A">
-                <a:alpha val="13000"/>
+              <a:srgbClr val="13134F">
+                <a:alpha val="10000"/>
               </a:srgbClr>
             </a:outerShdw>
           </a:effectLst>
@@ -4235,7 +4341,7 @@
           </a:ln>
           <a:effectLst>
             <a:outerShdw sx="100000" sy="100000" kx="0" ky="0" algn="bl" rotWithShape="0" blurRad="127000" dist="25400" dir="5400000">
-              <a:srgbClr val="1E2B4A">
+              <a:srgbClr val="13134F">
                 <a:alpha val="18000"/>
               </a:srgbClr>
             </a:outerShdw>
@@ -4325,13 +4431,13 @@
             </a:avLst>
           </a:prstGeom>
           <a:solidFill>
-            <a:srgbClr val="FFFFFF"/>
+            <a:srgbClr val="F4F5FA"/>
           </a:solidFill>
           <a:ln/>
           <a:effectLst>
             <a:outerShdw sx="100000" sy="100000" kx="0" ky="0" algn="bl" rotWithShape="0" blurRad="127000" dist="25400" dir="5400000">
-              <a:srgbClr val="1E2B4A">
-                <a:alpha val="13000"/>
+              <a:srgbClr val="13134F">
+                <a:alpha val="10000"/>
               </a:srgbClr>
             </a:outerShdw>
           </a:effectLst>
@@ -4352,7 +4458,7 @@
             <a:avLst/>
           </a:prstGeom>
           <a:solidFill>
-            <a:srgbClr val="C98A24"/>
+            <a:srgbClr val="6E6ECB"/>
           </a:solidFill>
           <a:ln w="31750">
             <a:solidFill>
@@ -4362,7 +4468,7 @@
           </a:ln>
           <a:effectLst>
             <a:outerShdw sx="100000" sy="100000" kx="0" ky="0" algn="bl" rotWithShape="0" blurRad="127000" dist="25400" dir="5400000">
-              <a:srgbClr val="1E2B4A">
+              <a:srgbClr val="13134F">
                 <a:alpha val="18000"/>
               </a:srgbClr>
             </a:outerShdw>
@@ -4452,13 +4558,13 @@
             </a:avLst>
           </a:prstGeom>
           <a:solidFill>
-            <a:srgbClr val="FFFFFF"/>
+            <a:srgbClr val="F4F5FA"/>
           </a:solidFill>
           <a:ln/>
           <a:effectLst>
             <a:outerShdw sx="100000" sy="100000" kx="0" ky="0" algn="bl" rotWithShape="0" blurRad="127000" dist="25400" dir="5400000">
-              <a:srgbClr val="1E2B4A">
-                <a:alpha val="13000"/>
+              <a:srgbClr val="13134F">
+                <a:alpha val="10000"/>
               </a:srgbClr>
             </a:outerShdw>
           </a:effectLst>
@@ -4479,7 +4585,7 @@
             <a:avLst/>
           </a:prstGeom>
           <a:solidFill>
-            <a:srgbClr val="3E8C9A"/>
+            <a:srgbClr val="2A2A80"/>
           </a:solidFill>
           <a:ln w="31750">
             <a:solidFill>
@@ -4489,7 +4595,7 @@
           </a:ln>
           <a:effectLst>
             <a:outerShdw sx="100000" sy="100000" kx="0" ky="0" algn="bl" rotWithShape="0" blurRad="127000" dist="25400" dir="5400000">
-              <a:srgbClr val="1E2B4A">
+              <a:srgbClr val="13134F">
                 <a:alpha val="18000"/>
               </a:srgbClr>
             </a:outerShdw>
@@ -4579,13 +4685,13 @@
             </a:avLst>
           </a:prstGeom>
           <a:solidFill>
-            <a:srgbClr val="FFFFFF"/>
+            <a:srgbClr val="F4F5FA"/>
           </a:solidFill>
           <a:ln/>
           <a:effectLst>
             <a:outerShdw sx="100000" sy="100000" kx="0" ky="0" algn="bl" rotWithShape="0" blurRad="127000" dist="25400" dir="5400000">
-              <a:srgbClr val="1E2B4A">
-                <a:alpha val="13000"/>
+              <a:srgbClr val="13134F">
+                <a:alpha val="10000"/>
               </a:srgbClr>
             </a:outerShdw>
           </a:effectLst>
@@ -4606,7 +4712,7 @@
             <a:avLst/>
           </a:prstGeom>
           <a:solidFill>
-            <a:srgbClr val="41639E"/>
+            <a:srgbClr val="4444AD"/>
           </a:solidFill>
           <a:ln w="31750">
             <a:solidFill>
@@ -4616,7 +4722,7 @@
           </a:ln>
           <a:effectLst>
             <a:outerShdw sx="100000" sy="100000" kx="0" ky="0" algn="bl" rotWithShape="0" blurRad="127000" dist="25400" dir="5400000">
-              <a:srgbClr val="1E2B4A">
+              <a:srgbClr val="13134F">
                 <a:alpha val="18000"/>
               </a:srgbClr>
             </a:outerShdw>
@@ -4706,13 +4812,13 @@
             </a:avLst>
           </a:prstGeom>
           <a:solidFill>
-            <a:srgbClr val="FFFFFF"/>
+            <a:srgbClr val="F4F5FA"/>
           </a:solidFill>
           <a:ln/>
           <a:effectLst>
             <a:outerShdw sx="100000" sy="100000" kx="0" ky="0" algn="bl" rotWithShape="0" blurRad="127000" dist="25400" dir="5400000">
-              <a:srgbClr val="1E2B4A">
-                <a:alpha val="13000"/>
+              <a:srgbClr val="13134F">
+                <a:alpha val="10000"/>
               </a:srgbClr>
             </a:outerShdw>
           </a:effectLst>
@@ -4836,13 +4942,13 @@
             </a:avLst>
           </a:prstGeom>
           <a:solidFill>
-            <a:srgbClr val="FFFFFF"/>
+            <a:srgbClr val="F4F5FA"/>
           </a:solidFill>
           <a:ln/>
           <a:effectLst>
             <a:outerShdw sx="100000" sy="100000" kx="0" ky="0" algn="bl" rotWithShape="0" blurRad="127000" dist="25400" dir="5400000">
-              <a:srgbClr val="1E2B4A">
-                <a:alpha val="13000"/>
+              <a:srgbClr val="13134F">
+                <a:alpha val="10000"/>
               </a:srgbClr>
             </a:outerShdw>
           </a:effectLst>
@@ -5210,8 +5316,8 @@
         </p:nvSpPr>
         <p:spPr>
           <a:xfrm>
-            <a:off x="10972800" y="6455664"/>
-            <a:ext cx="685800" cy="237744"/>
+            <a:off x="10881360" y="6455664"/>
+            <a:ext cx="365760" cy="237744"/>
           </a:xfrm>
           <a:prstGeom prst="rect">
             <a:avLst/>
@@ -5241,6 +5347,30 @@
           </a:p>
         </p:txBody>
       </p:sp>
+      <p:pic>
+        <p:nvPicPr>
+          <p:cNvPr id="46" name="Image 7" descr="logos/logo_ensae_new.png">    </p:cNvPr>
+          <p:cNvPicPr>
+            <a:picLocks noChangeAspect="1"/>
+          </p:cNvPicPr>
+          <p:nvPr/>
+        </p:nvPicPr>
+        <p:blipFill>
+          <a:blip r:embed="rId8"/>
+          <a:stretch>
+            <a:fillRect/>
+          </a:stretch>
+        </p:blipFill>
+        <p:spPr>
+          <a:xfrm>
+            <a:off x="11384280" y="6355080"/>
+            <a:ext cx="384048" cy="384048"/>
+          </a:xfrm>
+          <a:prstGeom prst="rect">
+            <a:avLst/>
+          </a:prstGeom>
+        </p:spPr>
+      </p:pic>
     </p:spTree>
   </p:cSld>
   <p:clrMapOvr>
@@ -5255,7 +5385,7 @@
     <p:bg>
       <p:bgPr>
         <a:solidFill>
-          <a:srgbClr val="FBFAF8"/>
+          <a:srgbClr val="FFFFFF"/>
         </a:solidFill>
       </p:bgPr>
     </p:bg>
@@ -5300,7 +5430,7 @@
             <a:r>
               <a:rPr lang="en-US" sz="2700" b="1" dirty="0">
                 <a:solidFill>
-                  <a:srgbClr val="1E2B4A"/>
+                  <a:srgbClr val="191970"/>
                 </a:solidFill>
                 <a:latin typeface="Calibri" pitchFamily="34" charset="0"/>
                 <a:ea typeface="Calibri" pitchFamily="34" charset="-122"/>
@@ -5371,13 +5501,13 @@
             </a:avLst>
           </a:prstGeom>
           <a:solidFill>
-            <a:srgbClr val="FFFFFF"/>
+            <a:srgbClr val="F4F5FA"/>
           </a:solidFill>
           <a:ln/>
           <a:effectLst>
             <a:outerShdw sx="100000" sy="100000" kx="0" ky="0" algn="bl" rotWithShape="0" blurRad="127000" dist="25400" dir="5400000">
-              <a:srgbClr val="1E2B4A">
-                <a:alpha val="13000"/>
+              <a:srgbClr val="13134F">
+                <a:alpha val="10000"/>
               </a:srgbClr>
             </a:outerShdw>
           </a:effectLst>
@@ -5410,7 +5540,7 @@
             <a:r>
               <a:rPr lang="en-US" sz="3200" b="1" dirty="0">
                 <a:solidFill>
-                  <a:srgbClr val="41639E"/>
+                  <a:srgbClr val="4444AD"/>
                 </a:solidFill>
                 <a:latin typeface="Calibri" pitchFamily="34" charset="0"/>
                 <a:ea typeface="Calibri" pitchFamily="34" charset="-122"/>
@@ -5501,13 +5631,13 @@
             </a:avLst>
           </a:prstGeom>
           <a:solidFill>
-            <a:srgbClr val="FFFFFF"/>
+            <a:srgbClr val="F4F5FA"/>
           </a:solidFill>
           <a:ln/>
           <a:effectLst>
             <a:outerShdw sx="100000" sy="100000" kx="0" ky="0" algn="bl" rotWithShape="0" blurRad="127000" dist="25400" dir="5400000">
-              <a:srgbClr val="1E2B4A">
-                <a:alpha val="13000"/>
+              <a:srgbClr val="13134F">
+                <a:alpha val="10000"/>
               </a:srgbClr>
             </a:outerShdw>
           </a:effectLst>
@@ -5540,7 +5670,7 @@
             <a:r>
               <a:rPr lang="en-US" sz="3200" b="1" dirty="0">
                 <a:solidFill>
-                  <a:srgbClr val="41639E"/>
+                  <a:srgbClr val="4444AD"/>
                 </a:solidFill>
                 <a:latin typeface="Calibri" pitchFamily="34" charset="0"/>
                 <a:ea typeface="Calibri" pitchFamily="34" charset="-122"/>
@@ -5631,13 +5761,13 @@
             </a:avLst>
           </a:prstGeom>
           <a:solidFill>
-            <a:srgbClr val="FFFFFF"/>
+            <a:srgbClr val="F4F5FA"/>
           </a:solidFill>
           <a:ln/>
           <a:effectLst>
             <a:outerShdw sx="100000" sy="100000" kx="0" ky="0" algn="bl" rotWithShape="0" blurRad="127000" dist="25400" dir="5400000">
-              <a:srgbClr val="1E2B4A">
-                <a:alpha val="13000"/>
+              <a:srgbClr val="13134F">
+                <a:alpha val="10000"/>
               </a:srgbClr>
             </a:outerShdw>
           </a:effectLst>
@@ -5761,13 +5891,13 @@
             </a:avLst>
           </a:prstGeom>
           <a:solidFill>
-            <a:srgbClr val="FFFFFF"/>
+            <a:srgbClr val="F4F5FA"/>
           </a:solidFill>
           <a:ln/>
           <a:effectLst>
             <a:outerShdw sx="100000" sy="100000" kx="0" ky="0" algn="bl" rotWithShape="0" blurRad="127000" dist="25400" dir="5400000">
-              <a:srgbClr val="1E2B4A">
-                <a:alpha val="13000"/>
+              <a:srgbClr val="13134F">
+                <a:alpha val="10000"/>
               </a:srgbClr>
             </a:outerShdw>
           </a:effectLst>
@@ -5891,13 +6021,13 @@
             </a:avLst>
           </a:prstGeom>
           <a:solidFill>
-            <a:srgbClr val="FFFFFF"/>
+            <a:srgbClr val="F4F5FA"/>
           </a:solidFill>
           <a:ln/>
           <a:effectLst>
             <a:outerShdw sx="100000" sy="100000" kx="0" ky="0" algn="bl" rotWithShape="0" blurRad="127000" dist="25400" dir="5400000">
-              <a:srgbClr val="1E2B4A">
-                <a:alpha val="13000"/>
+              <a:srgbClr val="13134F">
+                <a:alpha val="10000"/>
               </a:srgbClr>
             </a:outerShdw>
           </a:effectLst>
@@ -5918,7 +6048,7 @@
             <a:avLst/>
           </a:prstGeom>
           <a:solidFill>
-            <a:srgbClr val="3E8C9A"/>
+            <a:srgbClr val="2A2A80"/>
           </a:solidFill>
           <a:ln w="31750">
             <a:solidFill>
@@ -5928,7 +6058,7 @@
           </a:ln>
           <a:effectLst>
             <a:outerShdw sx="100000" sy="100000" kx="0" ky="0" algn="bl" rotWithShape="0" blurRad="127000" dist="25400" dir="5400000">
-              <a:srgbClr val="1E2B4A">
+              <a:srgbClr val="13134F">
                 <a:alpha val="18000"/>
               </a:srgbClr>
             </a:outerShdw>
@@ -6057,13 +6187,13 @@
             </a:avLst>
           </a:prstGeom>
           <a:solidFill>
-            <a:srgbClr val="FFFFFF"/>
+            <a:srgbClr val="F4F5FA"/>
           </a:solidFill>
           <a:ln/>
           <a:effectLst>
             <a:outerShdw sx="100000" sy="100000" kx="0" ky="0" algn="bl" rotWithShape="0" blurRad="127000" dist="25400" dir="5400000">
-              <a:srgbClr val="1E2B4A">
-                <a:alpha val="13000"/>
+              <a:srgbClr val="13134F">
+                <a:alpha val="10000"/>
               </a:srgbClr>
             </a:outerShdw>
           </a:effectLst>
@@ -6084,7 +6214,7 @@
             <a:avLst/>
           </a:prstGeom>
           <a:solidFill>
-            <a:srgbClr val="C98A24"/>
+            <a:srgbClr val="6E6ECB"/>
           </a:solidFill>
           <a:ln w="31750">
             <a:solidFill>
@@ -6094,7 +6224,7 @@
           </a:ln>
           <a:effectLst>
             <a:outerShdw sx="100000" sy="100000" kx="0" ky="0" algn="bl" rotWithShape="0" blurRad="127000" dist="25400" dir="5400000">
-              <a:srgbClr val="1E2B4A">
+              <a:srgbClr val="13134F">
                 <a:alpha val="18000"/>
               </a:srgbClr>
             </a:outerShdw>
@@ -6220,7 +6350,7 @@
             </a:avLst>
           </a:prstGeom>
           <a:solidFill>
-            <a:srgbClr val="C98A24"/>
+            <a:srgbClr val="6E6ECB"/>
           </a:solidFill>
           <a:ln/>
         </p:spPr>
@@ -6320,7 +6450,7 @@
             </a:avLst>
           </a:prstGeom>
           <a:solidFill>
-            <a:srgbClr val="E8EBF0"/>
+            <a:srgbClr val="E2E3EC"/>
           </a:solidFill>
           <a:ln/>
         </p:spPr>
@@ -6420,7 +6550,7 @@
             </a:avLst>
           </a:prstGeom>
           <a:solidFill>
-            <a:srgbClr val="E8EBF0"/>
+            <a:srgbClr val="E2E3EC"/>
           </a:solidFill>
           <a:ln/>
         </p:spPr>
@@ -6520,7 +6650,7 @@
             </a:avLst>
           </a:prstGeom>
           <a:solidFill>
-            <a:srgbClr val="E8EBF0"/>
+            <a:srgbClr val="E2E3EC"/>
           </a:solidFill>
           <a:ln/>
         </p:spPr>
@@ -6611,8 +6741,8 @@
         </p:nvSpPr>
         <p:spPr>
           <a:xfrm>
-            <a:off x="10972800" y="6455664"/>
-            <a:ext cx="685800" cy="237744"/>
+            <a:off x="10881360" y="6455664"/>
+            <a:ext cx="365760" cy="237744"/>
           </a:xfrm>
           <a:prstGeom prst="rect">
             <a:avLst/>
@@ -6642,6 +6772,30 @@
           </a:p>
         </p:txBody>
       </p:sp>
+      <p:pic>
+        <p:nvPicPr>
+          <p:cNvPr id="39" name="Image 2" descr="logos/logo_ensae_new.png">    </p:cNvPr>
+          <p:cNvPicPr>
+            <a:picLocks noChangeAspect="1"/>
+          </p:cNvPicPr>
+          <p:nvPr/>
+        </p:nvPicPr>
+        <p:blipFill>
+          <a:blip r:embed="rId3"/>
+          <a:stretch>
+            <a:fillRect/>
+          </a:stretch>
+        </p:blipFill>
+        <p:spPr>
+          <a:xfrm>
+            <a:off x="11384280" y="6355080"/>
+            <a:ext cx="384048" cy="384048"/>
+          </a:xfrm>
+          <a:prstGeom prst="rect">
+            <a:avLst/>
+          </a:prstGeom>
+        </p:spPr>
+      </p:pic>
     </p:spTree>
   </p:cSld>
   <p:clrMapOvr>
@@ -6656,7 +6810,7 @@
     <p:bg>
       <p:bgPr>
         <a:solidFill>
-          <a:srgbClr val="FBFAF8"/>
+          <a:srgbClr val="FFFFFF"/>
         </a:solidFill>
       </p:bgPr>
     </p:bg>
@@ -6701,7 +6855,7 @@
             <a:r>
               <a:rPr lang="en-US" sz="2700" b="1" dirty="0">
                 <a:solidFill>
-                  <a:srgbClr val="1E2B4A"/>
+                  <a:srgbClr val="191970"/>
                 </a:solidFill>
                 <a:latin typeface="Calibri" pitchFamily="34" charset="0"/>
                 <a:ea typeface="Calibri" pitchFamily="34" charset="-122"/>
@@ -6772,13 +6926,13 @@
             </a:avLst>
           </a:prstGeom>
           <a:solidFill>
-            <a:srgbClr val="FFFFFF"/>
+            <a:srgbClr val="F4F5FA"/>
           </a:solidFill>
           <a:ln/>
           <a:effectLst>
             <a:outerShdw sx="100000" sy="100000" kx="0" ky="0" algn="bl" rotWithShape="0" blurRad="127000" dist="25400" dir="5400000">
-              <a:srgbClr val="1E2B4A">
-                <a:alpha val="13000"/>
+              <a:srgbClr val="13134F">
+                <a:alpha val="10000"/>
               </a:srgbClr>
             </a:outerShdw>
           </a:effectLst>
@@ -6799,7 +6953,7 @@
             <a:avLst/>
           </a:prstGeom>
           <a:solidFill>
-            <a:srgbClr val="41639E"/>
+            <a:srgbClr val="4444AD"/>
           </a:solidFill>
           <a:ln w="31750">
             <a:solidFill>
@@ -6809,7 +6963,7 @@
           </a:ln>
           <a:effectLst>
             <a:outerShdw sx="100000" sy="100000" kx="0" ky="0" algn="bl" rotWithShape="0" blurRad="127000" dist="25400" dir="5400000">
-              <a:srgbClr val="1E2B4A">
+              <a:srgbClr val="13134F">
                 <a:alpha val="18000"/>
               </a:srgbClr>
             </a:outerShdw>
@@ -6867,7 +7021,7 @@
             <a:r>
               <a:rPr lang="en-US" sz="3400" b="1" dirty="0">
                 <a:solidFill>
-                  <a:srgbClr val="E8EBF0"/>
+                  <a:srgbClr val="E2E3EC"/>
                 </a:solidFill>
                 <a:latin typeface="Calibri" pitchFamily="34" charset="0"/>
                 <a:ea typeface="Calibri" pitchFamily="34" charset="-122"/>
@@ -6977,13 +7131,13 @@
             </a:avLst>
           </a:prstGeom>
           <a:solidFill>
-            <a:srgbClr val="FFFFFF"/>
+            <a:srgbClr val="F4F5FA"/>
           </a:solidFill>
           <a:ln/>
           <a:effectLst>
             <a:outerShdw sx="100000" sy="100000" kx="0" ky="0" algn="bl" rotWithShape="0" blurRad="127000" dist="25400" dir="5400000">
-              <a:srgbClr val="1E2B4A">
-                <a:alpha val="13000"/>
+              <a:srgbClr val="13134F">
+                <a:alpha val="10000"/>
               </a:srgbClr>
             </a:outerShdw>
           </a:effectLst>
@@ -7004,7 +7158,7 @@
             <a:avLst/>
           </a:prstGeom>
           <a:solidFill>
-            <a:srgbClr val="3E8C9A"/>
+            <a:srgbClr val="2A2A80"/>
           </a:solidFill>
           <a:ln w="31750">
             <a:solidFill>
@@ -7014,7 +7168,7 @@
           </a:ln>
           <a:effectLst>
             <a:outerShdw sx="100000" sy="100000" kx="0" ky="0" algn="bl" rotWithShape="0" blurRad="127000" dist="25400" dir="5400000">
-              <a:srgbClr val="1E2B4A">
+              <a:srgbClr val="13134F">
                 <a:alpha val="18000"/>
               </a:srgbClr>
             </a:outerShdw>
@@ -7072,7 +7226,7 @@
             <a:r>
               <a:rPr lang="en-US" sz="3400" b="1" dirty="0">
                 <a:solidFill>
-                  <a:srgbClr val="E8EBF0"/>
+                  <a:srgbClr val="E2E3EC"/>
                 </a:solidFill>
                 <a:latin typeface="Calibri" pitchFamily="34" charset="0"/>
                 <a:ea typeface="Calibri" pitchFamily="34" charset="-122"/>
@@ -7182,13 +7336,13 @@
             </a:avLst>
           </a:prstGeom>
           <a:solidFill>
-            <a:srgbClr val="FFFFFF"/>
+            <a:srgbClr val="F4F5FA"/>
           </a:solidFill>
           <a:ln/>
           <a:effectLst>
             <a:outerShdw sx="100000" sy="100000" kx="0" ky="0" algn="bl" rotWithShape="0" blurRad="127000" dist="25400" dir="5400000">
-              <a:srgbClr val="1E2B4A">
-                <a:alpha val="13000"/>
+              <a:srgbClr val="13134F">
+                <a:alpha val="10000"/>
               </a:srgbClr>
             </a:outerShdw>
           </a:effectLst>
@@ -7219,7 +7373,7 @@
           </a:ln>
           <a:effectLst>
             <a:outerShdw sx="100000" sy="100000" kx="0" ky="0" algn="bl" rotWithShape="0" blurRad="127000" dist="25400" dir="5400000">
-              <a:srgbClr val="1E2B4A">
+              <a:srgbClr val="13134F">
                 <a:alpha val="18000"/>
               </a:srgbClr>
             </a:outerShdw>
@@ -7277,7 +7431,7 @@
             <a:r>
               <a:rPr lang="en-US" sz="3400" b="1" dirty="0">
                 <a:solidFill>
-                  <a:srgbClr val="E8EBF0"/>
+                  <a:srgbClr val="E2E3EC"/>
                 </a:solidFill>
                 <a:latin typeface="Calibri" pitchFamily="34" charset="0"/>
                 <a:ea typeface="Calibri" pitchFamily="34" charset="-122"/>
@@ -7387,13 +7541,13 @@
             </a:avLst>
           </a:prstGeom>
           <a:solidFill>
-            <a:srgbClr val="1E2B4A"/>
+            <a:srgbClr val="191970"/>
           </a:solidFill>
           <a:ln/>
           <a:effectLst>
             <a:outerShdw sx="100000" sy="100000" kx="0" ky="0" algn="bl" rotWithShape="0" blurRad="127000" dist="25400" dir="5400000">
-              <a:srgbClr val="1E2B4A">
-                <a:alpha val="13000"/>
+              <a:srgbClr val="13134F">
+                <a:alpha val="10000"/>
               </a:srgbClr>
             </a:outerShdw>
           </a:effectLst>
@@ -7449,8 +7603,8 @@
         </p:nvSpPr>
         <p:spPr>
           <a:xfrm>
-            <a:off x="10972800" y="6455664"/>
-            <a:ext cx="685800" cy="237744"/>
+            <a:off x="10881360" y="6455664"/>
+            <a:ext cx="365760" cy="237744"/>
           </a:xfrm>
           <a:prstGeom prst="rect">
             <a:avLst/>
@@ -7480,6 +7634,30 @@
           </a:p>
         </p:txBody>
       </p:sp>
+      <p:pic>
+        <p:nvPicPr>
+          <p:cNvPr id="25" name="Image 3" descr="logos/logo_ensae_new.png">    </p:cNvPr>
+          <p:cNvPicPr>
+            <a:picLocks noChangeAspect="1"/>
+          </p:cNvPicPr>
+          <p:nvPr/>
+        </p:nvPicPr>
+        <p:blipFill>
+          <a:blip r:embed="rId4"/>
+          <a:stretch>
+            <a:fillRect/>
+          </a:stretch>
+        </p:blipFill>
+        <p:spPr>
+          <a:xfrm>
+            <a:off x="11384280" y="6355080"/>
+            <a:ext cx="384048" cy="384048"/>
+          </a:xfrm>
+          <a:prstGeom prst="rect">
+            <a:avLst/>
+          </a:prstGeom>
+        </p:spPr>
+      </p:pic>
     </p:spTree>
   </p:cSld>
   <p:clrMapOvr>
@@ -7494,7 +7672,7 @@
     <p:bg>
       <p:bgPr>
         <a:solidFill>
-          <a:srgbClr val="16213D"/>
+          <a:srgbClr val="101038"/>
         </a:solidFill>
       </p:bgPr>
     </p:bg>
@@ -7527,7 +7705,7 @@
             <a:avLst/>
           </a:prstGeom>
           <a:solidFill>
-            <a:srgbClr val="24365E"/>
+            <a:srgbClr val="23236B"/>
           </a:solidFill>
           <a:ln/>
         </p:spPr>
@@ -7547,7 +7725,7 @@
             <a:avLst/>
           </a:prstGeom>
           <a:solidFill>
-            <a:srgbClr val="24365E"/>
+            <a:srgbClr val="23236B"/>
           </a:solidFill>
           <a:ln/>
         </p:spPr>
@@ -7660,7 +7838,7 @@
             <a:r>
               <a:rPr lang="en-US" sz="1400" dirty="0">
                 <a:solidFill>
-                  <a:srgbClr val="AFC0DA"/>
+                  <a:srgbClr val="B7B7DB"/>
                 </a:solidFill>
                 <a:latin typeface="Calibri" pitchFamily="34" charset="0"/>
                 <a:ea typeface="Calibri" pitchFamily="34" charset="-122"/>
@@ -7686,7 +7864,7 @@
     <p:bg>
       <p:bgPr>
         <a:solidFill>
-          <a:srgbClr val="FBFAF8"/>
+          <a:srgbClr val="FFFFFF"/>
         </a:solidFill>
       </p:bgPr>
     </p:bg>
@@ -7731,7 +7909,7 @@
             <a:r>
               <a:rPr lang="en-US" sz="2700" b="1" dirty="0">
                 <a:solidFill>
-                  <a:srgbClr val="1E2B4A"/>
+                  <a:srgbClr val="191970"/>
                 </a:solidFill>
                 <a:latin typeface="Calibri" pitchFamily="34" charset="0"/>
                 <a:ea typeface="Calibri" pitchFamily="34" charset="-122"/>
@@ -7802,13 +7980,13 @@
             </a:avLst>
           </a:prstGeom>
           <a:solidFill>
-            <a:srgbClr val="FFFFFF"/>
+            <a:srgbClr val="F4F5FA"/>
           </a:solidFill>
           <a:ln/>
           <a:effectLst>
             <a:outerShdw sx="100000" sy="100000" kx="0" ky="0" algn="bl" rotWithShape="0" blurRad="127000" dist="25400" dir="5400000">
-              <a:srgbClr val="1E2B4A">
-                <a:alpha val="13000"/>
+              <a:srgbClr val="13134F">
+                <a:alpha val="10000"/>
               </a:srgbClr>
             </a:outerShdw>
           </a:effectLst>
@@ -8013,7 +8191,7 @@
             <a:avLst/>
           </a:prstGeom>
           <a:solidFill>
-            <a:srgbClr val="E8EBF0"/>
+            <a:srgbClr val="E2E3EC"/>
           </a:solidFill>
           <a:ln/>
         </p:spPr>
@@ -8084,7 +8262,7 @@
             <a:r>
               <a:rPr lang="en-US" sz="1500" b="1" dirty="0">
                 <a:solidFill>
-                  <a:srgbClr val="1E2B4A"/>
+                  <a:srgbClr val="191970"/>
                 </a:solidFill>
                 <a:latin typeface="Calibri" pitchFamily="34" charset="0"/>
                 <a:ea typeface="Calibri" pitchFamily="34" charset="-122"/>
@@ -8123,7 +8301,7 @@
             <a:r>
               <a:rPr lang="en-US" sz="1500" b="1" dirty="0">
                 <a:solidFill>
-                  <a:srgbClr val="1E2B4A"/>
+                  <a:srgbClr val="191970"/>
                 </a:solidFill>
                 <a:latin typeface="Calibri" pitchFamily="34" charset="0"/>
                 <a:ea typeface="Calibri" pitchFamily="34" charset="-122"/>
@@ -8189,7 +8367,7 @@
             <a:avLst/>
           </a:prstGeom>
           <a:solidFill>
-            <a:srgbClr val="E8EBF0"/>
+            <a:srgbClr val="E2E3EC"/>
           </a:solidFill>
           <a:ln/>
         </p:spPr>
@@ -8260,7 +8438,7 @@
             <a:r>
               <a:rPr lang="en-US" sz="1500" b="1" dirty="0">
                 <a:solidFill>
-                  <a:srgbClr val="1E2B4A"/>
+                  <a:srgbClr val="191970"/>
                 </a:solidFill>
                 <a:latin typeface="Calibri" pitchFamily="34" charset="0"/>
                 <a:ea typeface="Calibri" pitchFamily="34" charset="-122"/>
@@ -8299,7 +8477,7 @@
             <a:r>
               <a:rPr lang="en-US" sz="1500" b="1" dirty="0">
                 <a:solidFill>
-                  <a:srgbClr val="1E2B4A"/>
+                  <a:srgbClr val="191970"/>
                 </a:solidFill>
                 <a:latin typeface="Calibri" pitchFamily="34" charset="0"/>
                 <a:ea typeface="Calibri" pitchFamily="34" charset="-122"/>
@@ -8365,7 +8543,7 @@
             <a:avLst/>
           </a:prstGeom>
           <a:solidFill>
-            <a:srgbClr val="E8EBF0"/>
+            <a:srgbClr val="E2E3EC"/>
           </a:solidFill>
           <a:ln/>
         </p:spPr>
@@ -8436,7 +8614,7 @@
             <a:r>
               <a:rPr lang="en-US" sz="1500" b="1" dirty="0">
                 <a:solidFill>
-                  <a:srgbClr val="1E2B4A"/>
+                  <a:srgbClr val="191970"/>
                 </a:solidFill>
                 <a:latin typeface="Calibri" pitchFamily="34" charset="0"/>
                 <a:ea typeface="Calibri" pitchFamily="34" charset="-122"/>
@@ -8475,7 +8653,7 @@
             <a:r>
               <a:rPr lang="en-US" sz="1500" b="1" dirty="0">
                 <a:solidFill>
-                  <a:srgbClr val="1E2B4A"/>
+                  <a:srgbClr val="191970"/>
                 </a:solidFill>
                 <a:latin typeface="Calibri" pitchFamily="34" charset="0"/>
                 <a:ea typeface="Calibri" pitchFamily="34" charset="-122"/>
@@ -8585,13 +8763,13 @@
             </a:avLst>
           </a:prstGeom>
           <a:solidFill>
-            <a:srgbClr val="FFFFFF"/>
+            <a:srgbClr val="F4F5FA"/>
           </a:solidFill>
           <a:ln/>
           <a:effectLst>
             <a:outerShdw sx="100000" sy="100000" kx="0" ky="0" algn="bl" rotWithShape="0" blurRad="127000" dist="25400" dir="5400000">
-              <a:srgbClr val="1E2B4A">
-                <a:alpha val="13000"/>
+              <a:srgbClr val="13134F">
+                <a:alpha val="10000"/>
               </a:srgbClr>
             </a:outerShdw>
           </a:effectLst>
@@ -8731,7 +8909,7 @@
             </a:avLst>
           </a:prstGeom>
           <a:solidFill>
-            <a:srgbClr val="41639E"/>
+            <a:srgbClr val="4444AD"/>
           </a:solidFill>
           <a:ln/>
         </p:spPr>
@@ -8831,7 +9009,7 @@
             </a:avLst>
           </a:prstGeom>
           <a:solidFill>
-            <a:srgbClr val="41639E"/>
+            <a:srgbClr val="4444AD"/>
           </a:solidFill>
           <a:ln/>
         </p:spPr>
@@ -9203,8 +9381,8 @@
         </p:nvSpPr>
         <p:spPr>
           <a:xfrm>
-            <a:off x="10972800" y="6455664"/>
-            <a:ext cx="685800" cy="237744"/>
+            <a:off x="10881360" y="6455664"/>
+            <a:ext cx="365760" cy="237744"/>
           </a:xfrm>
           <a:prstGeom prst="rect">
             <a:avLst/>
@@ -9234,6 +9412,30 @@
           </a:p>
         </p:txBody>
       </p:sp>
+      <p:pic>
+        <p:nvPicPr>
+          <p:cNvPr id="45" name="Image 0" descr="logos/logo_ensae_new.png">    </p:cNvPr>
+          <p:cNvPicPr>
+            <a:picLocks noChangeAspect="1"/>
+          </p:cNvPicPr>
+          <p:nvPr/>
+        </p:nvPicPr>
+        <p:blipFill>
+          <a:blip r:embed="rId1"/>
+          <a:stretch>
+            <a:fillRect/>
+          </a:stretch>
+        </p:blipFill>
+        <p:spPr>
+          <a:xfrm>
+            <a:off x="11384280" y="6355080"/>
+            <a:ext cx="384048" cy="384048"/>
+          </a:xfrm>
+          <a:prstGeom prst="rect">
+            <a:avLst/>
+          </a:prstGeom>
+        </p:spPr>
+      </p:pic>
     </p:spTree>
   </p:cSld>
   <p:clrMapOvr>
@@ -9248,7 +9450,7 @@
     <p:bg>
       <p:bgPr>
         <a:solidFill>
-          <a:srgbClr val="FBFAF8"/>
+          <a:srgbClr val="FFFFFF"/>
         </a:solidFill>
       </p:bgPr>
     </p:bg>
@@ -9293,7 +9495,7 @@
             <a:r>
               <a:rPr lang="en-US" sz="2700" b="1" dirty="0">
                 <a:solidFill>
-                  <a:srgbClr val="1E2B4A"/>
+                  <a:srgbClr val="191970"/>
                 </a:solidFill>
                 <a:latin typeface="Calibri" pitchFamily="34" charset="0"/>
                 <a:ea typeface="Calibri" pitchFamily="34" charset="-122"/>
@@ -9364,13 +9566,13 @@
             </a:avLst>
           </a:prstGeom>
           <a:solidFill>
-            <a:srgbClr val="FFFFFF"/>
+            <a:srgbClr val="F4F5FA"/>
           </a:solidFill>
           <a:ln/>
           <a:effectLst>
             <a:outerShdw sx="100000" sy="100000" kx="0" ky="0" algn="bl" rotWithShape="0" blurRad="127000" dist="25400" dir="5400000">
-              <a:srgbClr val="1E2B4A">
-                <a:alpha val="13000"/>
+              <a:srgbClr val="13134F">
+                <a:alpha val="10000"/>
               </a:srgbClr>
             </a:outerShdw>
           </a:effectLst>
@@ -9494,13 +9696,13 @@
             </a:avLst>
           </a:prstGeom>
           <a:solidFill>
-            <a:srgbClr val="FFFFFF"/>
+            <a:srgbClr val="F4F5FA"/>
           </a:solidFill>
           <a:ln/>
           <a:effectLst>
             <a:outerShdw sx="100000" sy="100000" kx="0" ky="0" algn="bl" rotWithShape="0" blurRad="127000" dist="25400" dir="5400000">
-              <a:srgbClr val="1E2B4A">
-                <a:alpha val="13000"/>
+              <a:srgbClr val="13134F">
+                <a:alpha val="10000"/>
               </a:srgbClr>
             </a:outerShdw>
           </a:effectLst>
@@ -9533,7 +9735,7 @@
             <a:r>
               <a:rPr lang="en-US" sz="3000" b="1" dirty="0">
                 <a:solidFill>
-                  <a:srgbClr val="3E8C9A"/>
+                  <a:srgbClr val="2A2A80"/>
                 </a:solidFill>
                 <a:latin typeface="Calibri" pitchFamily="34" charset="0"/>
                 <a:ea typeface="Calibri" pitchFamily="34" charset="-122"/>
@@ -9624,13 +9826,13 @@
             </a:avLst>
           </a:prstGeom>
           <a:solidFill>
-            <a:srgbClr val="FFFFFF"/>
+            <a:srgbClr val="F4F5FA"/>
           </a:solidFill>
           <a:ln/>
           <a:effectLst>
             <a:outerShdw sx="100000" sy="100000" kx="0" ky="0" algn="bl" rotWithShape="0" blurRad="127000" dist="25400" dir="5400000">
-              <a:srgbClr val="1E2B4A">
-                <a:alpha val="13000"/>
+              <a:srgbClr val="13134F">
+                <a:alpha val="10000"/>
               </a:srgbClr>
             </a:outerShdw>
           </a:effectLst>
@@ -9663,7 +9865,7 @@
             <a:r>
               <a:rPr lang="en-US" sz="3000" b="1" dirty="0">
                 <a:solidFill>
-                  <a:srgbClr val="41639E"/>
+                  <a:srgbClr val="4444AD"/>
                 </a:solidFill>
                 <a:latin typeface="Calibri" pitchFamily="34" charset="0"/>
                 <a:ea typeface="Calibri" pitchFamily="34" charset="-122"/>
@@ -9754,13 +9956,13 @@
             </a:avLst>
           </a:prstGeom>
           <a:solidFill>
-            <a:srgbClr val="FFFFFF"/>
+            <a:srgbClr val="F4F5FA"/>
           </a:solidFill>
           <a:ln/>
           <a:effectLst>
             <a:outerShdw sx="100000" sy="100000" kx="0" ky="0" algn="bl" rotWithShape="0" blurRad="127000" dist="25400" dir="5400000">
-              <a:srgbClr val="1E2B4A">
-                <a:alpha val="13000"/>
+              <a:srgbClr val="13134F">
+                <a:alpha val="10000"/>
               </a:srgbClr>
             </a:outerShdw>
           </a:effectLst>
@@ -9793,7 +9995,7 @@
             <a:r>
               <a:rPr lang="en-US" sz="3000" b="1" dirty="0">
                 <a:solidFill>
-                  <a:srgbClr val="41639E"/>
+                  <a:srgbClr val="4444AD"/>
                 </a:solidFill>
                 <a:latin typeface="Calibri" pitchFamily="34" charset="0"/>
                 <a:ea typeface="Calibri" pitchFamily="34" charset="-122"/>
@@ -9884,13 +10086,13 @@
             </a:avLst>
           </a:prstGeom>
           <a:solidFill>
-            <a:srgbClr val="FFFFFF"/>
+            <a:srgbClr val="F4F5FA"/>
           </a:solidFill>
           <a:ln/>
           <a:effectLst>
             <a:outerShdw sx="100000" sy="100000" kx="0" ky="0" algn="bl" rotWithShape="0" blurRad="127000" dist="25400" dir="5400000">
-              <a:srgbClr val="1E2B4A">
-                <a:alpha val="13000"/>
+              <a:srgbClr val="13134F">
+                <a:alpha val="10000"/>
               </a:srgbClr>
             </a:outerShdw>
           </a:effectLst>
@@ -9991,7 +10193,7 @@
             </a:avLst>
           </a:prstGeom>
           <a:solidFill>
-            <a:srgbClr val="E8EBF0"/>
+            <a:srgbClr val="E2E3EC"/>
           </a:solidFill>
           <a:ln/>
         </p:spPr>
@@ -10013,7 +10215,7 @@
             </a:avLst>
           </a:prstGeom>
           <a:solidFill>
-            <a:srgbClr val="3E8C9A"/>
+            <a:srgbClr val="2A2A80"/>
           </a:solidFill>
           <a:ln/>
         </p:spPr>
@@ -10113,7 +10315,7 @@
             </a:avLst>
           </a:prstGeom>
           <a:solidFill>
-            <a:srgbClr val="E8EBF0"/>
+            <a:srgbClr val="E2E3EC"/>
           </a:solidFill>
           <a:ln/>
         </p:spPr>
@@ -10135,7 +10337,7 @@
             </a:avLst>
           </a:prstGeom>
           <a:solidFill>
-            <a:srgbClr val="3E8C9A"/>
+            <a:srgbClr val="2A2A80"/>
           </a:solidFill>
           <a:ln/>
         </p:spPr>
@@ -10235,7 +10437,7 @@
             </a:avLst>
           </a:prstGeom>
           <a:solidFill>
-            <a:srgbClr val="E8EBF0"/>
+            <a:srgbClr val="E2E3EC"/>
           </a:solidFill>
           <a:ln/>
         </p:spPr>
@@ -10257,7 +10459,7 @@
             </a:avLst>
           </a:prstGeom>
           <a:solidFill>
-            <a:srgbClr val="3E8C9A"/>
+            <a:srgbClr val="2A2A80"/>
           </a:solidFill>
           <a:ln/>
         </p:spPr>
@@ -10357,7 +10559,7 @@
             </a:avLst>
           </a:prstGeom>
           <a:solidFill>
-            <a:srgbClr val="E8EBF0"/>
+            <a:srgbClr val="E2E3EC"/>
           </a:solidFill>
           <a:ln/>
         </p:spPr>
@@ -10379,7 +10581,7 @@
             </a:avLst>
           </a:prstGeom>
           <a:solidFill>
-            <a:srgbClr val="3E8C9A"/>
+            <a:srgbClr val="2A2A80"/>
           </a:solidFill>
           <a:ln/>
         </p:spPr>
@@ -10479,7 +10681,7 @@
             </a:avLst>
           </a:prstGeom>
           <a:solidFill>
-            <a:srgbClr val="E8EBF0"/>
+            <a:srgbClr val="E2E3EC"/>
           </a:solidFill>
           <a:ln/>
         </p:spPr>
@@ -10501,7 +10703,7 @@
             </a:avLst>
           </a:prstGeom>
           <a:solidFill>
-            <a:srgbClr val="3E8C9A"/>
+            <a:srgbClr val="2A2A80"/>
           </a:solidFill>
           <a:ln/>
         </p:spPr>
@@ -10601,7 +10803,7 @@
             </a:avLst>
           </a:prstGeom>
           <a:solidFill>
-            <a:srgbClr val="E8EBF0"/>
+            <a:srgbClr val="E2E3EC"/>
           </a:solidFill>
           <a:ln/>
         </p:spPr>
@@ -10623,7 +10825,7 @@
             </a:avLst>
           </a:prstGeom>
           <a:solidFill>
-            <a:srgbClr val="3E8C9A"/>
+            <a:srgbClr val="2A2A80"/>
           </a:solidFill>
           <a:ln/>
         </p:spPr>
@@ -10714,8 +10916,8 @@
         </p:nvSpPr>
         <p:spPr>
           <a:xfrm>
-            <a:off x="10972800" y="6455664"/>
-            <a:ext cx="685800" cy="237744"/>
+            <a:off x="10881360" y="6455664"/>
+            <a:ext cx="365760" cy="237744"/>
           </a:xfrm>
           <a:prstGeom prst="rect">
             <a:avLst/>
@@ -10745,6 +10947,30 @@
           </a:p>
         </p:txBody>
       </p:sp>
+      <p:pic>
+        <p:nvPicPr>
+          <p:cNvPr id="44" name="Image 0" descr="logos/logo_ensae_new.png">    </p:cNvPr>
+          <p:cNvPicPr>
+            <a:picLocks noChangeAspect="1"/>
+          </p:cNvPicPr>
+          <p:nvPr/>
+        </p:nvPicPr>
+        <p:blipFill>
+          <a:blip r:embed="rId1"/>
+          <a:stretch>
+            <a:fillRect/>
+          </a:stretch>
+        </p:blipFill>
+        <p:spPr>
+          <a:xfrm>
+            <a:off x="11384280" y="6355080"/>
+            <a:ext cx="384048" cy="384048"/>
+          </a:xfrm>
+          <a:prstGeom prst="rect">
+            <a:avLst/>
+          </a:prstGeom>
+        </p:spPr>
+      </p:pic>
     </p:spTree>
   </p:cSld>
   <p:clrMapOvr>
@@ -10759,7 +10985,7 @@
     <p:bg>
       <p:bgPr>
         <a:solidFill>
-          <a:srgbClr val="FBFAF8"/>
+          <a:srgbClr val="FFFFFF"/>
         </a:solidFill>
       </p:bgPr>
     </p:bg>
@@ -10804,7 +11030,7 @@
             <a:r>
               <a:rPr lang="en-US" sz="2700" b="1" dirty="0">
                 <a:solidFill>
-                  <a:srgbClr val="1E2B4A"/>
+                  <a:srgbClr val="191970"/>
                 </a:solidFill>
                 <a:latin typeface="Calibri" pitchFamily="34" charset="0"/>
                 <a:ea typeface="Calibri" pitchFamily="34" charset="-122"/>
@@ -10833,13 +11059,13 @@
             </a:avLst>
           </a:prstGeom>
           <a:solidFill>
-            <a:srgbClr val="1E2B4A"/>
+            <a:srgbClr val="191970"/>
           </a:solidFill>
           <a:ln/>
           <a:effectLst>
             <a:outerShdw sx="100000" sy="100000" kx="0" ky="0" algn="bl" rotWithShape="0" blurRad="127000" dist="25400" dir="5400000">
-              <a:srgbClr val="1E2B4A">
-                <a:alpha val="13000"/>
+              <a:srgbClr val="13134F">
+                <a:alpha val="10000"/>
               </a:srgbClr>
             </a:outerShdw>
           </a:effectLst>
@@ -11021,13 +11247,13 @@
             </a:avLst>
           </a:prstGeom>
           <a:solidFill>
-            <a:srgbClr val="FFFFFF"/>
+            <a:srgbClr val="F4F5FA"/>
           </a:solidFill>
           <a:ln/>
           <a:effectLst>
             <a:outerShdw sx="100000" sy="100000" kx="0" ky="0" algn="bl" rotWithShape="0" blurRad="127000" dist="25400" dir="5400000">
-              <a:srgbClr val="1E2B4A">
-                <a:alpha val="13000"/>
+              <a:srgbClr val="13134F">
+                <a:alpha val="10000"/>
               </a:srgbClr>
             </a:outerShdw>
           </a:effectLst>
@@ -11192,7 +11418,7 @@
             </a:avLst>
           </a:prstGeom>
           <a:solidFill>
-            <a:srgbClr val="41639E"/>
+            <a:srgbClr val="4444AD"/>
           </a:solidFill>
           <a:ln/>
         </p:spPr>
@@ -11374,13 +11600,13 @@
             </a:avLst>
           </a:prstGeom>
           <a:solidFill>
-            <a:srgbClr val="FFFFFF"/>
+            <a:srgbClr val="F4F5FA"/>
           </a:solidFill>
           <a:ln/>
           <a:effectLst>
             <a:outerShdw sx="100000" sy="100000" kx="0" ky="0" algn="bl" rotWithShape="0" blurRad="127000" dist="25400" dir="5400000">
-              <a:srgbClr val="1E2B4A">
-                <a:alpha val="13000"/>
+              <a:srgbClr val="13134F">
+                <a:alpha val="10000"/>
               </a:srgbClr>
             </a:outerShdw>
           </a:effectLst>
@@ -11494,7 +11720,7 @@
             <a:r>
               <a:rPr lang="en-US" sz="1500" b="1" dirty="0">
                 <a:solidFill>
-                  <a:srgbClr val="1E2B4A"/>
+                  <a:srgbClr val="191970"/>
                 </a:solidFill>
                 <a:latin typeface="Calibri" pitchFamily="34" charset="0"/>
                 <a:ea typeface="Calibri" pitchFamily="34" charset="-122"/>
@@ -11521,7 +11747,7 @@
             <a:avLst/>
           </a:prstGeom>
           <a:solidFill>
-            <a:srgbClr val="E8EBF0"/>
+            <a:srgbClr val="E2E3EC"/>
           </a:solidFill>
           <a:ln/>
         </p:spPr>
@@ -11595,7 +11821,7 @@
             <a:r>
               <a:rPr lang="en-US" sz="1500" b="1" dirty="0">
                 <a:solidFill>
-                  <a:srgbClr val="1E2B4A"/>
+                  <a:srgbClr val="191970"/>
                 </a:solidFill>
                 <a:latin typeface="Calibri" pitchFamily="34" charset="0"/>
                 <a:ea typeface="Calibri" pitchFamily="34" charset="-122"/>
@@ -11622,7 +11848,7 @@
             <a:avLst/>
           </a:prstGeom>
           <a:solidFill>
-            <a:srgbClr val="E8EBF0"/>
+            <a:srgbClr val="E2E3EC"/>
           </a:solidFill>
           <a:ln/>
         </p:spPr>
@@ -11696,7 +11922,7 @@
             <a:r>
               <a:rPr lang="en-US" sz="1500" b="1" dirty="0">
                 <a:solidFill>
-                  <a:srgbClr val="1E2B4A"/>
+                  <a:srgbClr val="191970"/>
                 </a:solidFill>
                 <a:latin typeface="Calibri" pitchFamily="34" charset="0"/>
                 <a:ea typeface="Calibri" pitchFamily="34" charset="-122"/>
@@ -11723,7 +11949,7 @@
             <a:avLst/>
           </a:prstGeom>
           <a:solidFill>
-            <a:srgbClr val="E8EBF0"/>
+            <a:srgbClr val="E2E3EC"/>
           </a:solidFill>
           <a:ln/>
         </p:spPr>
@@ -11824,7 +12050,7 @@
             <a:avLst/>
           </a:prstGeom>
           <a:solidFill>
-            <a:srgbClr val="E8EBF0"/>
+            <a:srgbClr val="E2E3EC"/>
           </a:solidFill>
           <a:ln/>
         </p:spPr>
@@ -11918,8 +12144,8 @@
         </p:nvSpPr>
         <p:spPr>
           <a:xfrm>
-            <a:off x="10972800" y="6455664"/>
-            <a:ext cx="685800" cy="237744"/>
+            <a:off x="10881360" y="6455664"/>
+            <a:ext cx="365760" cy="237744"/>
           </a:xfrm>
           <a:prstGeom prst="rect">
             <a:avLst/>
@@ -11949,6 +12175,30 @@
           </a:p>
         </p:txBody>
       </p:sp>
+      <p:pic>
+        <p:nvPicPr>
+          <p:cNvPr id="35" name="Image 0" descr="logos/logo_ensae_new.png">    </p:cNvPr>
+          <p:cNvPicPr>
+            <a:picLocks noChangeAspect="1"/>
+          </p:cNvPicPr>
+          <p:nvPr/>
+        </p:nvPicPr>
+        <p:blipFill>
+          <a:blip r:embed="rId1"/>
+          <a:stretch>
+            <a:fillRect/>
+          </a:stretch>
+        </p:blipFill>
+        <p:spPr>
+          <a:xfrm>
+            <a:off x="11384280" y="6355080"/>
+            <a:ext cx="384048" cy="384048"/>
+          </a:xfrm>
+          <a:prstGeom prst="rect">
+            <a:avLst/>
+          </a:prstGeom>
+        </p:spPr>
+      </p:pic>
     </p:spTree>
   </p:cSld>
   <p:clrMapOvr>
@@ -11963,7 +12213,7 @@
     <p:bg>
       <p:bgPr>
         <a:solidFill>
-          <a:srgbClr val="FBFAF8"/>
+          <a:srgbClr val="FFFFFF"/>
         </a:solidFill>
       </p:bgPr>
     </p:bg>
@@ -12008,7 +12258,7 @@
             <a:r>
               <a:rPr lang="en-US" sz="2700" b="1" dirty="0">
                 <a:solidFill>
-                  <a:srgbClr val="1E2B4A"/>
+                  <a:srgbClr val="191970"/>
                 </a:solidFill>
                 <a:latin typeface="Calibri" pitchFamily="34" charset="0"/>
                 <a:ea typeface="Calibri" pitchFamily="34" charset="-122"/>
@@ -12079,13 +12329,13 @@
             </a:avLst>
           </a:prstGeom>
           <a:solidFill>
-            <a:srgbClr val="FFFFFF"/>
+            <a:srgbClr val="F4F5FA"/>
           </a:solidFill>
           <a:ln/>
           <a:effectLst>
             <a:outerShdw sx="100000" sy="100000" kx="0" ky="0" algn="bl" rotWithShape="0" blurRad="127000" dist="25400" dir="5400000">
-              <a:srgbClr val="1E2B4A">
-                <a:alpha val="13000"/>
+              <a:srgbClr val="13134F">
+                <a:alpha val="10000"/>
               </a:srgbClr>
             </a:outerShdw>
           </a:effectLst>
@@ -12325,7 +12575,7 @@
             </a:avLst>
           </a:prstGeom>
           <a:solidFill>
-            <a:srgbClr val="E8EBF0"/>
+            <a:srgbClr val="E2E3EC"/>
           </a:solidFill>
           <a:ln/>
         </p:spPr>
@@ -12425,7 +12675,7 @@
             </a:avLst>
           </a:prstGeom>
           <a:solidFill>
-            <a:srgbClr val="E8EBF0"/>
+            <a:srgbClr val="E2E3EC"/>
           </a:solidFill>
           <a:ln/>
         </p:spPr>
@@ -12525,7 +12775,7 @@
             </a:avLst>
           </a:prstGeom>
           <a:solidFill>
-            <a:srgbClr val="E8EBF0"/>
+            <a:srgbClr val="E2E3EC"/>
           </a:solidFill>
           <a:ln/>
         </p:spPr>
@@ -12625,7 +12875,7 @@
             </a:avLst>
           </a:prstGeom>
           <a:solidFill>
-            <a:srgbClr val="E8EBF0"/>
+            <a:srgbClr val="E2E3EC"/>
           </a:solidFill>
           <a:ln/>
         </p:spPr>
@@ -12725,7 +12975,7 @@
             </a:avLst>
           </a:prstGeom>
           <a:solidFill>
-            <a:srgbClr val="E8EBF0"/>
+            <a:srgbClr val="E2E3EC"/>
           </a:solidFill>
           <a:ln/>
         </p:spPr>
@@ -12825,7 +13075,7 @@
             </a:avLst>
           </a:prstGeom>
           <a:solidFill>
-            <a:srgbClr val="E8EBF0"/>
+            <a:srgbClr val="E2E3EC"/>
           </a:solidFill>
           <a:ln/>
         </p:spPr>
@@ -12891,8 +13141,8 @@
           <a:ln/>
           <a:effectLst>
             <a:outerShdw sx="100000" sy="100000" kx="0" ky="0" algn="bl" rotWithShape="0" blurRad="127000" dist="25400" dir="5400000">
-              <a:srgbClr val="1E2B4A">
-                <a:alpha val="13000"/>
+              <a:srgbClr val="13134F">
+                <a:alpha val="10000"/>
               </a:srgbClr>
             </a:outerShdw>
           </a:effectLst>
@@ -12923,7 +13173,7 @@
           </a:ln>
           <a:effectLst>
             <a:outerShdw sx="100000" sy="100000" kx="0" ky="0" algn="bl" rotWithShape="0" blurRad="127000" dist="25400" dir="5400000">
-              <a:srgbClr val="1E2B4A">
+              <a:srgbClr val="13134F">
                 <a:alpha val="18000"/>
               </a:srgbClr>
             </a:outerShdw>
@@ -13055,13 +13305,13 @@
             </a:avLst>
           </a:prstGeom>
           <a:solidFill>
-            <a:srgbClr val="FFFFFF"/>
+            <a:srgbClr val="F4F5FA"/>
           </a:solidFill>
           <a:ln/>
           <a:effectLst>
             <a:outerShdw sx="100000" sy="100000" kx="0" ky="0" algn="bl" rotWithShape="0" blurRad="127000" dist="25400" dir="5400000">
-              <a:srgbClr val="1E2B4A">
-                <a:alpha val="13000"/>
+              <a:srgbClr val="13134F">
+                <a:alpha val="10000"/>
               </a:srgbClr>
             </a:outerShdw>
           </a:effectLst>
@@ -13367,7 +13617,7 @@
             <a:r>
               <a:rPr lang="en-US" sz="100" dirty="0">
                 <a:solidFill>
-                  <a:srgbClr val="FBFAF8"/>
+                  <a:srgbClr val="FFFFFF"/>
                 </a:solidFill>
                 <a:latin typeface="Calibri" pitchFamily="34" charset="0"/>
                 <a:ea typeface="Calibri" pitchFamily="34" charset="-122"/>
@@ -13426,8 +13676,8 @@
         </p:nvSpPr>
         <p:spPr>
           <a:xfrm>
-            <a:off x="10972800" y="6455664"/>
-            <a:ext cx="685800" cy="237744"/>
+            <a:off x="10881360" y="6455664"/>
+            <a:ext cx="365760" cy="237744"/>
           </a:xfrm>
           <a:prstGeom prst="rect">
             <a:avLst/>
@@ -13457,6 +13707,30 @@
           </a:p>
         </p:txBody>
       </p:sp>
+      <p:pic>
+        <p:nvPicPr>
+          <p:cNvPr id="44" name="Image 1" descr="logos/logo_ensae_new.png">    </p:cNvPr>
+          <p:cNvPicPr>
+            <a:picLocks noChangeAspect="1"/>
+          </p:cNvPicPr>
+          <p:nvPr/>
+        </p:nvPicPr>
+        <p:blipFill>
+          <a:blip r:embed="rId2"/>
+          <a:stretch>
+            <a:fillRect/>
+          </a:stretch>
+        </p:blipFill>
+        <p:spPr>
+          <a:xfrm>
+            <a:off x="11384280" y="6355080"/>
+            <a:ext cx="384048" cy="384048"/>
+          </a:xfrm>
+          <a:prstGeom prst="rect">
+            <a:avLst/>
+          </a:prstGeom>
+        </p:spPr>
+      </p:pic>
     </p:spTree>
   </p:cSld>
   <p:clrMapOvr>
@@ -13471,7 +13745,7 @@
     <p:bg>
       <p:bgPr>
         <a:solidFill>
-          <a:srgbClr val="FBFAF8"/>
+          <a:srgbClr val="FFFFFF"/>
         </a:solidFill>
       </p:bgPr>
     </p:bg>
@@ -13516,7 +13790,7 @@
             <a:r>
               <a:rPr lang="en-US" sz="2700" b="1" dirty="0">
                 <a:solidFill>
-                  <a:srgbClr val="1E2B4A"/>
+                  <a:srgbClr val="191970"/>
                 </a:solidFill>
                 <a:latin typeface="Calibri" pitchFamily="34" charset="0"/>
                 <a:ea typeface="Calibri" pitchFamily="34" charset="-122"/>
@@ -13587,13 +13861,13 @@
             </a:avLst>
           </a:prstGeom>
           <a:solidFill>
-            <a:srgbClr val="FFFFFF"/>
+            <a:srgbClr val="F4F5FA"/>
           </a:solidFill>
           <a:ln/>
           <a:effectLst>
             <a:outerShdw sx="100000" sy="100000" kx="0" ky="0" algn="bl" rotWithShape="0" blurRad="127000" dist="25400" dir="5400000">
-              <a:srgbClr val="1E2B4A">
-                <a:alpha val="13000"/>
+              <a:srgbClr val="13134F">
+                <a:alpha val="10000"/>
               </a:srgbClr>
             </a:outerShdw>
           </a:effectLst>
@@ -14089,7 +14363,7 @@
             </a:avLst>
           </a:prstGeom>
           <a:solidFill>
-            <a:srgbClr val="E8EBF0"/>
+            <a:srgbClr val="E2E3EC"/>
           </a:solidFill>
           <a:ln/>
         </p:spPr>
@@ -14228,7 +14502,7 @@
             </a:avLst>
           </a:prstGeom>
           <a:solidFill>
-            <a:srgbClr val="E8EBF0"/>
+            <a:srgbClr val="E2E3EC"/>
           </a:solidFill>
           <a:ln/>
         </p:spPr>
@@ -14367,7 +14641,7 @@
             </a:avLst>
           </a:prstGeom>
           <a:solidFill>
-            <a:srgbClr val="E8EBF0"/>
+            <a:srgbClr val="E2E3EC"/>
           </a:solidFill>
           <a:ln/>
         </p:spPr>
@@ -14448,13 +14722,13 @@
             </a:avLst>
           </a:prstGeom>
           <a:solidFill>
-            <a:srgbClr val="1E2B4A"/>
+            <a:srgbClr val="191970"/>
           </a:solidFill>
           <a:ln/>
           <a:effectLst>
             <a:outerShdw sx="100000" sy="100000" kx="0" ky="0" algn="bl" rotWithShape="0" blurRad="127000" dist="25400" dir="5400000">
-              <a:srgbClr val="1E2B4A">
-                <a:alpha val="13000"/>
+              <a:srgbClr val="13134F">
+                <a:alpha val="10000"/>
               </a:srgbClr>
             </a:outerShdw>
           </a:effectLst>
@@ -14597,13 +14871,13 @@
             </a:avLst>
           </a:prstGeom>
           <a:solidFill>
-            <a:srgbClr val="FFFFFF"/>
+            <a:srgbClr val="F4F5FA"/>
           </a:solidFill>
           <a:ln/>
           <a:effectLst>
             <a:outerShdw sx="100000" sy="100000" kx="0" ky="0" algn="bl" rotWithShape="0" blurRad="127000" dist="25400" dir="5400000">
-              <a:srgbClr val="1E2B4A">
-                <a:alpha val="13000"/>
+              <a:srgbClr val="13134F">
+                <a:alpha val="10000"/>
               </a:srgbClr>
             </a:outerShdw>
           </a:effectLst>
@@ -14737,8 +15011,8 @@
         </p:nvSpPr>
         <p:spPr>
           <a:xfrm>
-            <a:off x="10972800" y="6455664"/>
-            <a:ext cx="685800" cy="237744"/>
+            <a:off x="10881360" y="6455664"/>
+            <a:ext cx="365760" cy="237744"/>
           </a:xfrm>
           <a:prstGeom prst="rect">
             <a:avLst/>
@@ -14768,6 +15042,30 @@
           </a:p>
         </p:txBody>
       </p:sp>
+      <p:pic>
+        <p:nvPicPr>
+          <p:cNvPr id="38" name="Image 0" descr="logos/logo_ensae_new.png">    </p:cNvPr>
+          <p:cNvPicPr>
+            <a:picLocks noChangeAspect="1"/>
+          </p:cNvPicPr>
+          <p:nvPr/>
+        </p:nvPicPr>
+        <p:blipFill>
+          <a:blip r:embed="rId1"/>
+          <a:stretch>
+            <a:fillRect/>
+          </a:stretch>
+        </p:blipFill>
+        <p:spPr>
+          <a:xfrm>
+            <a:off x="11384280" y="6355080"/>
+            <a:ext cx="384048" cy="384048"/>
+          </a:xfrm>
+          <a:prstGeom prst="rect">
+            <a:avLst/>
+          </a:prstGeom>
+        </p:spPr>
+      </p:pic>
     </p:spTree>
   </p:cSld>
   <p:clrMapOvr>
@@ -14782,7 +15080,7 @@
     <p:bg>
       <p:bgPr>
         <a:solidFill>
-          <a:srgbClr val="16213D"/>
+          <a:srgbClr val="101038"/>
         </a:solidFill>
       </p:bgPr>
     </p:bg>
@@ -14815,7 +15113,7 @@
             <a:avLst/>
           </a:prstGeom>
           <a:solidFill>
-            <a:srgbClr val="24365E"/>
+            <a:srgbClr val="23236B"/>
           </a:solidFill>
           <a:ln/>
         </p:spPr>
@@ -14835,7 +15133,7 @@
             <a:avLst/>
           </a:prstGeom>
           <a:solidFill>
-            <a:srgbClr val="24365E"/>
+            <a:srgbClr val="23236B"/>
           </a:solidFill>
           <a:ln/>
         </p:spPr>
@@ -14948,7 +15246,7 @@
             <a:r>
               <a:rPr lang="en-US" sz="1400" dirty="0">
                 <a:solidFill>
-                  <a:srgbClr val="AFC0DA"/>
+                  <a:srgbClr val="B7B7DB"/>
                 </a:solidFill>
                 <a:latin typeface="Calibri" pitchFamily="34" charset="0"/>
                 <a:ea typeface="Calibri" pitchFamily="34" charset="-122"/>
@@ -14974,7 +15272,7 @@
     <p:bg>
       <p:bgPr>
         <a:solidFill>
-          <a:srgbClr val="FBFAF8"/>
+          <a:srgbClr val="FFFFFF"/>
         </a:solidFill>
       </p:bgPr>
     </p:bg>
@@ -15019,7 +15317,7 @@
             <a:r>
               <a:rPr lang="en-US" sz="2700" b="1" dirty="0">
                 <a:solidFill>
-                  <a:srgbClr val="1E2B4A"/>
+                  <a:srgbClr val="191970"/>
                 </a:solidFill>
                 <a:latin typeface="Calibri" pitchFamily="34" charset="0"/>
                 <a:ea typeface="Calibri" pitchFamily="34" charset="-122"/>
@@ -15048,13 +15346,13 @@
             </a:avLst>
           </a:prstGeom>
           <a:solidFill>
-            <a:srgbClr val="FFFFFF"/>
+            <a:srgbClr val="F4F5FA"/>
           </a:solidFill>
           <a:ln/>
           <a:effectLst>
             <a:outerShdw sx="100000" sy="100000" kx="0" ky="0" algn="bl" rotWithShape="0" blurRad="127000" dist="25400" dir="5400000">
-              <a:srgbClr val="1E2B4A">
-                <a:alpha val="13000"/>
+              <a:srgbClr val="13134F">
+                <a:alpha val="10000"/>
               </a:srgbClr>
             </a:outerShdw>
           </a:effectLst>
@@ -15075,7 +15373,7 @@
             <a:avLst/>
           </a:prstGeom>
           <a:solidFill>
-            <a:srgbClr val="41639E"/>
+            <a:srgbClr val="4444AD"/>
           </a:solidFill>
           <a:ln w="31750">
             <a:solidFill>
@@ -15085,7 +15383,7 @@
           </a:ln>
           <a:effectLst>
             <a:outerShdw sx="100000" sy="100000" kx="0" ky="0" algn="bl" rotWithShape="0" blurRad="127000" dist="25400" dir="5400000">
-              <a:srgbClr val="1E2B4A">
+              <a:srgbClr val="13134F">
                 <a:alpha val="18000"/>
               </a:srgbClr>
             </a:outerShdw>
@@ -15143,7 +15441,7 @@
             <a:r>
               <a:rPr lang="en-US" sz="3000" b="1" dirty="0">
                 <a:solidFill>
-                  <a:srgbClr val="E8EBF0"/>
+                  <a:srgbClr val="E2E3EC"/>
                 </a:solidFill>
                 <a:latin typeface="Calibri" pitchFamily="34" charset="0"/>
                 <a:ea typeface="Calibri" pitchFamily="34" charset="-122"/>
@@ -15250,13 +15548,13 @@
             </a:avLst>
           </a:prstGeom>
           <a:solidFill>
-            <a:srgbClr val="FFFFFF"/>
+            <a:srgbClr val="F4F5FA"/>
           </a:solidFill>
           <a:ln/>
           <a:effectLst>
             <a:outerShdw sx="100000" sy="100000" kx="0" ky="0" algn="bl" rotWithShape="0" blurRad="127000" dist="25400" dir="5400000">
-              <a:srgbClr val="1E2B4A">
-                <a:alpha val="13000"/>
+              <a:srgbClr val="13134F">
+                <a:alpha val="10000"/>
               </a:srgbClr>
             </a:outerShdw>
           </a:effectLst>
@@ -15287,7 +15585,7 @@
           </a:ln>
           <a:effectLst>
             <a:outerShdw sx="100000" sy="100000" kx="0" ky="0" algn="bl" rotWithShape="0" blurRad="127000" dist="25400" dir="5400000">
-              <a:srgbClr val="1E2B4A">
+              <a:srgbClr val="13134F">
                 <a:alpha val="18000"/>
               </a:srgbClr>
             </a:outerShdw>
@@ -15345,7 +15643,7 @@
             <a:r>
               <a:rPr lang="en-US" sz="3000" b="1" dirty="0">
                 <a:solidFill>
-                  <a:srgbClr val="E8EBF0"/>
+                  <a:srgbClr val="E2E3EC"/>
                 </a:solidFill>
                 <a:latin typeface="Calibri" pitchFamily="34" charset="0"/>
                 <a:ea typeface="Calibri" pitchFamily="34" charset="-122"/>
@@ -15452,13 +15750,13 @@
             </a:avLst>
           </a:prstGeom>
           <a:solidFill>
-            <a:srgbClr val="FFFFFF"/>
+            <a:srgbClr val="F4F5FA"/>
           </a:solidFill>
           <a:ln/>
           <a:effectLst>
             <a:outerShdw sx="100000" sy="100000" kx="0" ky="0" algn="bl" rotWithShape="0" blurRad="127000" dist="25400" dir="5400000">
-              <a:srgbClr val="1E2B4A">
-                <a:alpha val="13000"/>
+              <a:srgbClr val="13134F">
+                <a:alpha val="10000"/>
               </a:srgbClr>
             </a:outerShdw>
           </a:effectLst>
@@ -15479,7 +15777,7 @@
             <a:avLst/>
           </a:prstGeom>
           <a:solidFill>
-            <a:srgbClr val="3E8C9A"/>
+            <a:srgbClr val="2A2A80"/>
           </a:solidFill>
           <a:ln w="31750">
             <a:solidFill>
@@ -15489,7 +15787,7 @@
           </a:ln>
           <a:effectLst>
             <a:outerShdw sx="100000" sy="100000" kx="0" ky="0" algn="bl" rotWithShape="0" blurRad="127000" dist="25400" dir="5400000">
-              <a:srgbClr val="1E2B4A">
+              <a:srgbClr val="13134F">
                 <a:alpha val="18000"/>
               </a:srgbClr>
             </a:outerShdw>
@@ -15547,7 +15845,7 @@
             <a:r>
               <a:rPr lang="en-US" sz="3000" b="1" dirty="0">
                 <a:solidFill>
-                  <a:srgbClr val="E8EBF0"/>
+                  <a:srgbClr val="E2E3EC"/>
                 </a:solidFill>
                 <a:latin typeface="Calibri" pitchFamily="34" charset="0"/>
                 <a:ea typeface="Calibri" pitchFamily="34" charset="-122"/>
@@ -15654,13 +15952,13 @@
             </a:avLst>
           </a:prstGeom>
           <a:solidFill>
-            <a:srgbClr val="FFFFFF"/>
+            <a:srgbClr val="F4F5FA"/>
           </a:solidFill>
           <a:ln/>
           <a:effectLst>
             <a:outerShdw sx="100000" sy="100000" kx="0" ky="0" algn="bl" rotWithShape="0" blurRad="127000" dist="25400" dir="5400000">
-              <a:srgbClr val="1E2B4A">
-                <a:alpha val="13000"/>
+              <a:srgbClr val="13134F">
+                <a:alpha val="10000"/>
               </a:srgbClr>
             </a:outerShdw>
           </a:effectLst>
@@ -15681,7 +15979,7 @@
             <a:avLst/>
           </a:prstGeom>
           <a:solidFill>
-            <a:srgbClr val="C98A24"/>
+            <a:srgbClr val="6E6ECB"/>
           </a:solidFill>
           <a:ln w="31750">
             <a:solidFill>
@@ -15691,7 +15989,7 @@
           </a:ln>
           <a:effectLst>
             <a:outerShdw sx="100000" sy="100000" kx="0" ky="0" algn="bl" rotWithShape="0" blurRad="127000" dist="25400" dir="5400000">
-              <a:srgbClr val="1E2B4A">
+              <a:srgbClr val="13134F">
                 <a:alpha val="18000"/>
               </a:srgbClr>
             </a:outerShdw>
@@ -15749,7 +16047,7 @@
             <a:r>
               <a:rPr lang="en-US" sz="3000" b="1" dirty="0">
                 <a:solidFill>
-                  <a:srgbClr val="E8EBF0"/>
+                  <a:srgbClr val="E2E3EC"/>
                 </a:solidFill>
                 <a:latin typeface="Calibri" pitchFamily="34" charset="0"/>
                 <a:ea typeface="Calibri" pitchFamily="34" charset="-122"/>
@@ -15856,13 +16154,13 @@
             </a:avLst>
           </a:prstGeom>
           <a:solidFill>
-            <a:srgbClr val="FFFFFF"/>
+            <a:srgbClr val="F4F5FA"/>
           </a:solidFill>
           <a:ln/>
           <a:effectLst>
             <a:outerShdw sx="100000" sy="100000" kx="0" ky="0" algn="bl" rotWithShape="0" blurRad="127000" dist="25400" dir="5400000">
-              <a:srgbClr val="1E2B4A">
-                <a:alpha val="13000"/>
+              <a:srgbClr val="13134F">
+                <a:alpha val="10000"/>
               </a:srgbClr>
             </a:outerShdw>
           </a:effectLst>
@@ -15883,7 +16181,7 @@
             <a:avLst/>
           </a:prstGeom>
           <a:solidFill>
-            <a:srgbClr val="41639E"/>
+            <a:srgbClr val="4444AD"/>
           </a:solidFill>
           <a:ln w="31750">
             <a:solidFill>
@@ -15893,7 +16191,7 @@
           </a:ln>
           <a:effectLst>
             <a:outerShdw sx="100000" sy="100000" kx="0" ky="0" algn="bl" rotWithShape="0" blurRad="127000" dist="25400" dir="5400000">
-              <a:srgbClr val="1E2B4A">
+              <a:srgbClr val="13134F">
                 <a:alpha val="18000"/>
               </a:srgbClr>
             </a:outerShdw>
@@ -15951,7 +16249,7 @@
             <a:r>
               <a:rPr lang="en-US" sz="3000" b="1" dirty="0">
                 <a:solidFill>
-                  <a:srgbClr val="E8EBF0"/>
+                  <a:srgbClr val="E2E3EC"/>
                 </a:solidFill>
                 <a:latin typeface="Calibri" pitchFamily="34" charset="0"/>
                 <a:ea typeface="Calibri" pitchFamily="34" charset="-122"/>
@@ -16058,13 +16356,13 @@
             </a:avLst>
           </a:prstGeom>
           <a:solidFill>
-            <a:srgbClr val="FFFFFF"/>
+            <a:srgbClr val="F4F5FA"/>
           </a:solidFill>
           <a:ln/>
           <a:effectLst>
             <a:outerShdw sx="100000" sy="100000" kx="0" ky="0" algn="bl" rotWithShape="0" blurRad="127000" dist="25400" dir="5400000">
-              <a:srgbClr val="1E2B4A">
-                <a:alpha val="13000"/>
+              <a:srgbClr val="13134F">
+                <a:alpha val="10000"/>
               </a:srgbClr>
             </a:outerShdw>
           </a:effectLst>
@@ -16095,7 +16393,7 @@
           </a:ln>
           <a:effectLst>
             <a:outerShdw sx="100000" sy="100000" kx="0" ky="0" algn="bl" rotWithShape="0" blurRad="127000" dist="25400" dir="5400000">
-              <a:srgbClr val="1E2B4A">
+              <a:srgbClr val="13134F">
                 <a:alpha val="18000"/>
               </a:srgbClr>
             </a:outerShdw>
@@ -16153,7 +16451,7 @@
             <a:r>
               <a:rPr lang="en-US" sz="3000" b="1" dirty="0">
                 <a:solidFill>
-                  <a:srgbClr val="E8EBF0"/>
+                  <a:srgbClr val="E2E3EC"/>
                 </a:solidFill>
                 <a:latin typeface="Calibri" pitchFamily="34" charset="0"/>
                 <a:ea typeface="Calibri" pitchFamily="34" charset="-122"/>
@@ -16251,8 +16549,8 @@
         </p:nvSpPr>
         <p:spPr>
           <a:xfrm>
-            <a:off x="10972800" y="6455664"/>
-            <a:ext cx="685800" cy="237744"/>
+            <a:off x="10881360" y="6455664"/>
+            <a:ext cx="365760" cy="237744"/>
           </a:xfrm>
           <a:prstGeom prst="rect">
             <a:avLst/>
@@ -16282,6 +16580,30 @@
           </a:p>
         </p:txBody>
       </p:sp>
+      <p:pic>
+        <p:nvPicPr>
+          <p:cNvPr id="40" name="Image 6" descr="logos/logo_ensae_new.png">    </p:cNvPr>
+          <p:cNvPicPr>
+            <a:picLocks noChangeAspect="1"/>
+          </p:cNvPicPr>
+          <p:nvPr/>
+        </p:nvPicPr>
+        <p:blipFill>
+          <a:blip r:embed="rId7"/>
+          <a:stretch>
+            <a:fillRect/>
+          </a:stretch>
+        </p:blipFill>
+        <p:spPr>
+          <a:xfrm>
+            <a:off x="11384280" y="6355080"/>
+            <a:ext cx="384048" cy="384048"/>
+          </a:xfrm>
+          <a:prstGeom prst="rect">
+            <a:avLst/>
+          </a:prstGeom>
+        </p:spPr>
+      </p:pic>
     </p:spTree>
   </p:cSld>
   <p:clrMapOvr>
@@ -16296,7 +16618,7 @@
     <p:bg>
       <p:bgPr>
         <a:solidFill>
-          <a:srgbClr val="FBFAF8"/>
+          <a:srgbClr val="FFFFFF"/>
         </a:solidFill>
       </p:bgPr>
     </p:bg>
@@ -16341,7 +16663,7 @@
             <a:r>
               <a:rPr lang="en-US" sz="2700" b="1" dirty="0">
                 <a:solidFill>
-                  <a:srgbClr val="1E2B4A"/>
+                  <a:srgbClr val="191970"/>
                 </a:solidFill>
                 <a:latin typeface="Calibri" pitchFamily="34" charset="0"/>
                 <a:ea typeface="Calibri" pitchFamily="34" charset="-122"/>
@@ -16370,13 +16692,13 @@
             </a:avLst>
           </a:prstGeom>
           <a:solidFill>
-            <a:srgbClr val="FFFFFF"/>
+            <a:srgbClr val="F4F5FA"/>
           </a:solidFill>
           <a:ln/>
           <a:effectLst>
             <a:outerShdw sx="100000" sy="100000" kx="0" ky="0" algn="bl" rotWithShape="0" blurRad="127000" dist="25400" dir="5400000">
-              <a:srgbClr val="1E2B4A">
-                <a:alpha val="13000"/>
+              <a:srgbClr val="13134F">
+                <a:alpha val="10000"/>
               </a:srgbClr>
             </a:outerShdw>
           </a:effectLst>
@@ -16397,7 +16719,7 @@
             <a:avLst/>
           </a:prstGeom>
           <a:solidFill>
-            <a:srgbClr val="41639E"/>
+            <a:srgbClr val="4444AD"/>
           </a:solidFill>
           <a:ln w="31750">
             <a:solidFill>
@@ -16407,7 +16729,7 @@
           </a:ln>
           <a:effectLst>
             <a:outerShdw sx="100000" sy="100000" kx="0" ky="0" algn="bl" rotWithShape="0" blurRad="127000" dist="25400" dir="5400000">
-              <a:srgbClr val="1E2B4A">
+              <a:srgbClr val="13134F">
                 <a:alpha val="18000"/>
               </a:srgbClr>
             </a:outerShdw>
@@ -16504,7 +16826,7 @@
             <a:r>
               <a:rPr lang="en-US" sz="1100" b="1" dirty="0">
                 <a:solidFill>
-                  <a:srgbClr val="41639E"/>
+                  <a:srgbClr val="4444AD"/>
                 </a:solidFill>
                 <a:latin typeface="Calibri" pitchFamily="34" charset="0"/>
                 <a:ea typeface="Calibri" pitchFamily="34" charset="-122"/>
@@ -16575,13 +16897,13 @@
             </a:avLst>
           </a:prstGeom>
           <a:solidFill>
-            <a:srgbClr val="FFFFFF"/>
+            <a:srgbClr val="F4F5FA"/>
           </a:solidFill>
           <a:ln/>
           <a:effectLst>
             <a:outerShdw sx="100000" sy="100000" kx="0" ky="0" algn="bl" rotWithShape="0" blurRad="127000" dist="25400" dir="5400000">
-              <a:srgbClr val="1E2B4A">
-                <a:alpha val="13000"/>
+              <a:srgbClr val="13134F">
+                <a:alpha val="10000"/>
               </a:srgbClr>
             </a:outerShdw>
           </a:effectLst>
@@ -16602,7 +16924,7 @@
             <a:avLst/>
           </a:prstGeom>
           <a:solidFill>
-            <a:srgbClr val="3E8C9A"/>
+            <a:srgbClr val="2A2A80"/>
           </a:solidFill>
           <a:ln w="31750">
             <a:solidFill>
@@ -16612,7 +16934,7 @@
           </a:ln>
           <a:effectLst>
             <a:outerShdw sx="100000" sy="100000" kx="0" ky="0" algn="bl" rotWithShape="0" blurRad="127000" dist="25400" dir="5400000">
-              <a:srgbClr val="1E2B4A">
+              <a:srgbClr val="13134F">
                 <a:alpha val="18000"/>
               </a:srgbClr>
             </a:outerShdw>
@@ -16709,7 +17031,7 @@
             <a:r>
               <a:rPr lang="en-US" sz="1100" b="1" dirty="0">
                 <a:solidFill>
-                  <a:srgbClr val="3E8C9A"/>
+                  <a:srgbClr val="2A2A80"/>
                 </a:solidFill>
                 <a:latin typeface="Calibri" pitchFamily="34" charset="0"/>
                 <a:ea typeface="Calibri" pitchFamily="34" charset="-122"/>
@@ -16780,13 +17102,13 @@
             </a:avLst>
           </a:prstGeom>
           <a:solidFill>
-            <a:srgbClr val="FFFFFF"/>
+            <a:srgbClr val="F4F5FA"/>
           </a:solidFill>
           <a:ln/>
           <a:effectLst>
             <a:outerShdw sx="100000" sy="100000" kx="0" ky="0" algn="bl" rotWithShape="0" blurRad="127000" dist="25400" dir="5400000">
-              <a:srgbClr val="1E2B4A">
-                <a:alpha val="13000"/>
+              <a:srgbClr val="13134F">
+                <a:alpha val="10000"/>
               </a:srgbClr>
             </a:outerShdw>
           </a:effectLst>
@@ -16807,7 +17129,7 @@
             <a:avLst/>
           </a:prstGeom>
           <a:solidFill>
-            <a:srgbClr val="C98A24"/>
+            <a:srgbClr val="6E6ECB"/>
           </a:solidFill>
           <a:ln w="31750">
             <a:solidFill>
@@ -16817,7 +17139,7 @@
           </a:ln>
           <a:effectLst>
             <a:outerShdw sx="100000" sy="100000" kx="0" ky="0" algn="bl" rotWithShape="0" blurRad="127000" dist="25400" dir="5400000">
-              <a:srgbClr val="1E2B4A">
+              <a:srgbClr val="13134F">
                 <a:alpha val="18000"/>
               </a:srgbClr>
             </a:outerShdw>
@@ -16914,7 +17236,7 @@
             <a:r>
               <a:rPr lang="en-US" sz="1100" b="1" dirty="0">
                 <a:solidFill>
-                  <a:srgbClr val="C98A24"/>
+                  <a:srgbClr val="6E6ECB"/>
                 </a:solidFill>
                 <a:latin typeface="Calibri" pitchFamily="34" charset="0"/>
                 <a:ea typeface="Calibri" pitchFamily="34" charset="-122"/>
@@ -16985,13 +17307,13 @@
             </a:avLst>
           </a:prstGeom>
           <a:solidFill>
-            <a:srgbClr val="FFFFFF"/>
+            <a:srgbClr val="F4F5FA"/>
           </a:solidFill>
           <a:ln/>
           <a:effectLst>
             <a:outerShdw sx="100000" sy="100000" kx="0" ky="0" algn="bl" rotWithShape="0" blurRad="127000" dist="25400" dir="5400000">
-              <a:srgbClr val="1E2B4A">
-                <a:alpha val="13000"/>
+              <a:srgbClr val="13134F">
+                <a:alpha val="10000"/>
               </a:srgbClr>
             </a:outerShdw>
           </a:effectLst>
@@ -17022,7 +17344,7 @@
           </a:ln>
           <a:effectLst>
             <a:outerShdw sx="100000" sy="100000" kx="0" ky="0" algn="bl" rotWithShape="0" blurRad="127000" dist="25400" dir="5400000">
-              <a:srgbClr val="1E2B4A">
+              <a:srgbClr val="13134F">
                 <a:alpha val="18000"/>
               </a:srgbClr>
             </a:outerShdw>
@@ -17190,13 +17512,13 @@
             </a:avLst>
           </a:prstGeom>
           <a:solidFill>
-            <a:srgbClr val="FBFAF8"/>
+            <a:srgbClr val="FFFFFF"/>
           </a:solidFill>
           <a:ln/>
           <a:effectLst>
             <a:outerShdw sx="100000" sy="100000" kx="0" ky="0" algn="bl" rotWithShape="0" blurRad="127000" dist="25400" dir="5400000">
-              <a:srgbClr val="1E2B4A">
-                <a:alpha val="13000"/>
+              <a:srgbClr val="13134F">
+                <a:alpha val="10000"/>
               </a:srgbClr>
             </a:outerShdw>
           </a:effectLst>
@@ -17249,8 +17571,8 @@
         </p:nvSpPr>
         <p:spPr>
           <a:xfrm>
-            <a:off x="10972800" y="6455664"/>
-            <a:ext cx="685800" cy="237744"/>
+            <a:off x="10881360" y="6455664"/>
+            <a:ext cx="365760" cy="237744"/>
           </a:xfrm>
           <a:prstGeom prst="rect">
             <a:avLst/>
@@ -17280,6 +17602,30 @@
           </a:p>
         </p:txBody>
       </p:sp>
+      <p:pic>
+        <p:nvPicPr>
+          <p:cNvPr id="30" name="Image 4" descr="logos/logo_ensae_new.png">    </p:cNvPr>
+          <p:cNvPicPr>
+            <a:picLocks noChangeAspect="1"/>
+          </p:cNvPicPr>
+          <p:nvPr/>
+        </p:nvPicPr>
+        <p:blipFill>
+          <a:blip r:embed="rId5"/>
+          <a:stretch>
+            <a:fillRect/>
+          </a:stretch>
+        </p:blipFill>
+        <p:spPr>
+          <a:xfrm>
+            <a:off x="11384280" y="6355080"/>
+            <a:ext cx="384048" cy="384048"/>
+          </a:xfrm>
+          <a:prstGeom prst="rect">
+            <a:avLst/>
+          </a:prstGeom>
+        </p:spPr>
+      </p:pic>
     </p:spTree>
   </p:cSld>
   <p:clrMapOvr>
@@ -17294,7 +17640,7 @@
     <p:bg>
       <p:bgPr>
         <a:solidFill>
-          <a:srgbClr val="FBFAF8"/>
+          <a:srgbClr val="FFFFFF"/>
         </a:solidFill>
       </p:bgPr>
     </p:bg>
@@ -17339,7 +17685,7 @@
             <a:r>
               <a:rPr lang="en-US" sz="2700" b="1" dirty="0">
                 <a:solidFill>
-                  <a:srgbClr val="1E2B4A"/>
+                  <a:srgbClr val="191970"/>
                 </a:solidFill>
                 <a:latin typeface="Calibri" pitchFamily="34" charset="0"/>
                 <a:ea typeface="Calibri" pitchFamily="34" charset="-122"/>
@@ -17368,13 +17714,13 @@
             </a:avLst>
           </a:prstGeom>
           <a:solidFill>
-            <a:srgbClr val="FFFFFF"/>
+            <a:srgbClr val="F4F5FA"/>
           </a:solidFill>
           <a:ln/>
           <a:effectLst>
             <a:outerShdw sx="100000" sy="100000" kx="0" ky="0" algn="bl" rotWithShape="0" blurRad="127000" dist="25400" dir="5400000">
-              <a:srgbClr val="1E2B4A">
-                <a:alpha val="13000"/>
+              <a:srgbClr val="13134F">
+                <a:alpha val="10000"/>
               </a:srgbClr>
             </a:outerShdw>
           </a:effectLst>
@@ -17559,13 +17905,13 @@
             </a:avLst>
           </a:prstGeom>
           <a:solidFill>
-            <a:srgbClr val="FFFFFF"/>
+            <a:srgbClr val="F4F5FA"/>
           </a:solidFill>
           <a:ln/>
           <a:effectLst>
             <a:outerShdw sx="100000" sy="100000" kx="0" ky="0" algn="bl" rotWithShape="0" blurRad="127000" dist="25400" dir="5400000">
-              <a:srgbClr val="1E2B4A">
-                <a:alpha val="13000"/>
+              <a:srgbClr val="13134F">
+                <a:alpha val="10000"/>
               </a:srgbClr>
             </a:outerShdw>
           </a:effectLst>
@@ -17598,7 +17944,7 @@
             <a:r>
               <a:rPr lang="en-US" sz="2600" b="1" dirty="0">
                 <a:solidFill>
-                  <a:srgbClr val="3E8C9A"/>
+                  <a:srgbClr val="2A2A80"/>
                 </a:solidFill>
                 <a:latin typeface="Calibri" pitchFamily="34" charset="0"/>
                 <a:ea typeface="Calibri" pitchFamily="34" charset="-122"/>
@@ -17721,7 +18067,7 @@
             <a:r>
               <a:rPr lang="en-US" sz="1350" b="1" dirty="0">
                 <a:solidFill>
-                  <a:srgbClr val="3E8C9A"/>
+                  <a:srgbClr val="2A2A80"/>
                 </a:solidFill>
                 <a:latin typeface="Calibri" pitchFamily="34" charset="0"/>
                 <a:ea typeface="Calibri" pitchFamily="34" charset="-122"/>
@@ -17758,7 +18104,7 @@
           </a:ln>
           <a:effectLst>
             <a:outerShdw sx="100000" sy="100000" kx="0" ky="0" algn="bl" rotWithShape="0" blurRad="127000" dist="25400" dir="5400000">
-              <a:srgbClr val="1E2B4A">
+              <a:srgbClr val="13134F">
                 <a:alpha val="18000"/>
               </a:srgbClr>
             </a:outerShdw>
@@ -17804,7 +18150,7 @@
             <a:avLst/>
           </a:prstGeom>
           <a:solidFill>
-            <a:srgbClr val="3E8C9A"/>
+            <a:srgbClr val="2A2A80"/>
           </a:solidFill>
           <a:ln w="31750">
             <a:solidFill>
@@ -17814,7 +18160,7 @@
           </a:ln>
           <a:effectLst>
             <a:outerShdw sx="100000" sy="100000" kx="0" ky="0" algn="bl" rotWithShape="0" blurRad="127000" dist="25400" dir="5400000">
-              <a:srgbClr val="1E2B4A">
+              <a:srgbClr val="13134F">
                 <a:alpha val="18000"/>
               </a:srgbClr>
             </a:outerShdw>
@@ -17853,8 +18199,8 @@
         </p:nvSpPr>
         <p:spPr>
           <a:xfrm>
-            <a:off x="10972800" y="6455664"/>
-            <a:ext cx="685800" cy="237744"/>
+            <a:off x="10881360" y="6455664"/>
+            <a:ext cx="365760" cy="237744"/>
           </a:xfrm>
           <a:prstGeom prst="rect">
             <a:avLst/>
@@ -17884,6 +18230,30 @@
           </a:p>
         </p:txBody>
       </p:sp>
+      <p:pic>
+        <p:nvPicPr>
+          <p:cNvPr id="18" name="Image 2" descr="logos/logo_ensae_new.png">    </p:cNvPr>
+          <p:cNvPicPr>
+            <a:picLocks noChangeAspect="1"/>
+          </p:cNvPicPr>
+          <p:nvPr/>
+        </p:nvPicPr>
+        <p:blipFill>
+          <a:blip r:embed="rId3"/>
+          <a:stretch>
+            <a:fillRect/>
+          </a:stretch>
+        </p:blipFill>
+        <p:spPr>
+          <a:xfrm>
+            <a:off x="11384280" y="6355080"/>
+            <a:ext cx="384048" cy="384048"/>
+          </a:xfrm>
+          <a:prstGeom prst="rect">
+            <a:avLst/>
+          </a:prstGeom>
+        </p:spPr>
+      </p:pic>
     </p:spTree>
   </p:cSld>
   <p:clrMapOvr>
@@ -17898,7 +18268,7 @@
     <p:bg>
       <p:bgPr>
         <a:solidFill>
-          <a:srgbClr val="FBFAF8"/>
+          <a:srgbClr val="FFFFFF"/>
         </a:solidFill>
       </p:bgPr>
     </p:bg>
@@ -17943,7 +18313,7 @@
             <a:r>
               <a:rPr lang="en-US" sz="2700" b="1" dirty="0">
                 <a:solidFill>
-                  <a:srgbClr val="1E2B4A"/>
+                  <a:srgbClr val="191970"/>
                 </a:solidFill>
                 <a:latin typeface="Calibri" pitchFamily="34" charset="0"/>
                 <a:ea typeface="Calibri" pitchFamily="34" charset="-122"/>
@@ -18014,13 +18384,13 @@
             </a:avLst>
           </a:prstGeom>
           <a:solidFill>
-            <a:srgbClr val="FFFFFF"/>
+            <a:srgbClr val="F4F5FA"/>
           </a:solidFill>
           <a:ln/>
           <a:effectLst>
             <a:outerShdw sx="100000" sy="100000" kx="0" ky="0" algn="bl" rotWithShape="0" blurRad="127000" dist="25400" dir="5400000">
-              <a:srgbClr val="1E2B4A">
-                <a:alpha val="13000"/>
+              <a:srgbClr val="13134F">
+                <a:alpha val="10000"/>
               </a:srgbClr>
             </a:outerShdw>
           </a:effectLst>
@@ -18041,7 +18411,7 @@
             <a:avLst/>
           </a:prstGeom>
           <a:solidFill>
-            <a:srgbClr val="C98A24"/>
+            <a:srgbClr val="6E6ECB"/>
           </a:solidFill>
           <a:ln w="31750">
             <a:solidFill>
@@ -18051,7 +18421,7 @@
           </a:ln>
           <a:effectLst>
             <a:outerShdw sx="100000" sy="100000" kx="0" ky="0" algn="bl" rotWithShape="0" blurRad="127000" dist="25400" dir="5400000">
-              <a:srgbClr val="1E2B4A">
+              <a:srgbClr val="13134F">
                 <a:alpha val="18000"/>
               </a:srgbClr>
             </a:outerShdw>
@@ -18183,13 +18553,13 @@
             </a:avLst>
           </a:prstGeom>
           <a:solidFill>
-            <a:srgbClr val="FFFFFF"/>
+            <a:srgbClr val="F4F5FA"/>
           </a:solidFill>
           <a:ln/>
           <a:effectLst>
             <a:outerShdw sx="100000" sy="100000" kx="0" ky="0" algn="bl" rotWithShape="0" blurRad="127000" dist="25400" dir="5400000">
-              <a:srgbClr val="1E2B4A">
-                <a:alpha val="13000"/>
+              <a:srgbClr val="13134F">
+                <a:alpha val="10000"/>
               </a:srgbClr>
             </a:outerShdw>
           </a:effectLst>
@@ -18210,7 +18580,7 @@
             <a:avLst/>
           </a:prstGeom>
           <a:solidFill>
-            <a:srgbClr val="41639E"/>
+            <a:srgbClr val="4444AD"/>
           </a:solidFill>
           <a:ln w="31750">
             <a:solidFill>
@@ -18220,7 +18590,7 @@
           </a:ln>
           <a:effectLst>
             <a:outerShdw sx="100000" sy="100000" kx="0" ky="0" algn="bl" rotWithShape="0" blurRad="127000" dist="25400" dir="5400000">
-              <a:srgbClr val="1E2B4A">
+              <a:srgbClr val="13134F">
                 <a:alpha val="18000"/>
               </a:srgbClr>
             </a:outerShdw>
@@ -18352,13 +18722,13 @@
             </a:avLst>
           </a:prstGeom>
           <a:solidFill>
-            <a:srgbClr val="FFFFFF"/>
+            <a:srgbClr val="F4F5FA"/>
           </a:solidFill>
           <a:ln/>
           <a:effectLst>
             <a:outerShdw sx="100000" sy="100000" kx="0" ky="0" algn="bl" rotWithShape="0" blurRad="127000" dist="25400" dir="5400000">
-              <a:srgbClr val="1E2B4A">
-                <a:alpha val="13000"/>
+              <a:srgbClr val="13134F">
+                <a:alpha val="10000"/>
               </a:srgbClr>
             </a:outerShdw>
           </a:effectLst>
@@ -18379,7 +18749,7 @@
             <a:avLst/>
           </a:prstGeom>
           <a:solidFill>
-            <a:srgbClr val="3E8C9A"/>
+            <a:srgbClr val="2A2A80"/>
           </a:solidFill>
           <a:ln w="31750">
             <a:solidFill>
@@ -18389,7 +18759,7 @@
           </a:ln>
           <a:effectLst>
             <a:outerShdw sx="100000" sy="100000" kx="0" ky="0" algn="bl" rotWithShape="0" blurRad="127000" dist="25400" dir="5400000">
-              <a:srgbClr val="1E2B4A">
+              <a:srgbClr val="13134F">
                 <a:alpha val="18000"/>
               </a:srgbClr>
             </a:outerShdw>
@@ -18512,8 +18882,8 @@
         </p:nvSpPr>
         <p:spPr>
           <a:xfrm>
-            <a:off x="10972800" y="6455664"/>
-            <a:ext cx="685800" cy="237744"/>
+            <a:off x="10881360" y="6455664"/>
+            <a:ext cx="365760" cy="237744"/>
           </a:xfrm>
           <a:prstGeom prst="rect">
             <a:avLst/>
@@ -18543,6 +18913,30 @@
           </a:p>
         </p:txBody>
       </p:sp>
+      <p:pic>
+        <p:nvPicPr>
+          <p:cNvPr id="20" name="Image 3" descr="logos/logo_ensae_new.png">    </p:cNvPr>
+          <p:cNvPicPr>
+            <a:picLocks noChangeAspect="1"/>
+          </p:cNvPicPr>
+          <p:nvPr/>
+        </p:nvPicPr>
+        <p:blipFill>
+          <a:blip r:embed="rId4"/>
+          <a:stretch>
+            <a:fillRect/>
+          </a:stretch>
+        </p:blipFill>
+        <p:spPr>
+          <a:xfrm>
+            <a:off x="11384280" y="6355080"/>
+            <a:ext cx="384048" cy="384048"/>
+          </a:xfrm>
+          <a:prstGeom prst="rect">
+            <a:avLst/>
+          </a:prstGeom>
+        </p:spPr>
+      </p:pic>
     </p:spTree>
   </p:cSld>
   <p:clrMapOvr>
@@ -18557,7 +18951,7 @@
     <p:bg>
       <p:bgPr>
         <a:solidFill>
-          <a:srgbClr val="FBFAF8"/>
+          <a:srgbClr val="FFFFFF"/>
         </a:solidFill>
       </p:bgPr>
     </p:bg>
@@ -18602,7 +18996,7 @@
             <a:r>
               <a:rPr lang="en-US" sz="2700" b="1" dirty="0">
                 <a:solidFill>
-                  <a:srgbClr val="1E2B4A"/>
+                  <a:srgbClr val="191970"/>
                 </a:solidFill>
                 <a:latin typeface="Calibri" pitchFamily="34" charset="0"/>
                 <a:ea typeface="Calibri" pitchFamily="34" charset="-122"/>
@@ -18631,13 +19025,13 @@
             </a:avLst>
           </a:prstGeom>
           <a:solidFill>
-            <a:srgbClr val="FFFFFF"/>
+            <a:srgbClr val="F4F5FA"/>
           </a:solidFill>
           <a:ln/>
           <a:effectLst>
             <a:outerShdw sx="100000" sy="100000" kx="0" ky="0" algn="bl" rotWithShape="0" blurRad="127000" dist="25400" dir="5400000">
-              <a:srgbClr val="1E2B4A">
-                <a:alpha val="13000"/>
+              <a:srgbClr val="13134F">
+                <a:alpha val="10000"/>
               </a:srgbClr>
             </a:outerShdw>
           </a:effectLst>
@@ -18668,7 +19062,7 @@
           </a:ln>
           <a:effectLst>
             <a:outerShdw sx="100000" sy="100000" kx="0" ky="0" algn="bl" rotWithShape="0" blurRad="127000" dist="25400" dir="5400000">
-              <a:srgbClr val="1E2B4A">
+              <a:srgbClr val="13134F">
                 <a:alpha val="18000"/>
               </a:srgbClr>
             </a:outerShdw>
@@ -18917,13 +19311,13 @@
             </a:avLst>
           </a:prstGeom>
           <a:solidFill>
-            <a:srgbClr val="FFFFFF"/>
+            <a:srgbClr val="F4F5FA"/>
           </a:solidFill>
           <a:ln/>
           <a:effectLst>
             <a:outerShdw sx="100000" sy="100000" kx="0" ky="0" algn="bl" rotWithShape="0" blurRad="127000" dist="25400" dir="5400000">
-              <a:srgbClr val="1E2B4A">
-                <a:alpha val="13000"/>
+              <a:srgbClr val="13134F">
+                <a:alpha val="10000"/>
               </a:srgbClr>
             </a:outerShdw>
           </a:effectLst>
@@ -18944,7 +19338,7 @@
             <a:avLst/>
           </a:prstGeom>
           <a:solidFill>
-            <a:srgbClr val="3E8C9A"/>
+            <a:srgbClr val="2A2A80"/>
           </a:solidFill>
           <a:ln w="31750">
             <a:solidFill>
@@ -18954,7 +19348,7 @@
           </a:ln>
           <a:effectLst>
             <a:outerShdw sx="100000" sy="100000" kx="0" ky="0" algn="bl" rotWithShape="0" blurRad="127000" dist="25400" dir="5400000">
-              <a:srgbClr val="1E2B4A">
+              <a:srgbClr val="13134F">
                 <a:alpha val="18000"/>
               </a:srgbClr>
             </a:outerShdw>
@@ -19039,7 +19433,7 @@
             <a:avLst/>
           </a:prstGeom>
           <a:solidFill>
-            <a:srgbClr val="3E8C9A"/>
+            <a:srgbClr val="2A2A80"/>
           </a:solidFill>
           <a:ln/>
         </p:spPr>
@@ -19140,7 +19534,7 @@
             <a:avLst/>
           </a:prstGeom>
           <a:solidFill>
-            <a:srgbClr val="3E8C9A"/>
+            <a:srgbClr val="2A2A80"/>
           </a:solidFill>
           <a:ln/>
         </p:spPr>
@@ -19241,7 +19635,7 @@
             <a:avLst/>
           </a:prstGeom>
           <a:solidFill>
-            <a:srgbClr val="3E8C9A"/>
+            <a:srgbClr val="2A2A80"/>
           </a:solidFill>
           <a:ln/>
         </p:spPr>
@@ -19335,8 +19729,8 @@
         </p:nvSpPr>
         <p:spPr>
           <a:xfrm>
-            <a:off x="10972800" y="6455664"/>
-            <a:ext cx="685800" cy="237744"/>
+            <a:off x="10881360" y="6455664"/>
+            <a:ext cx="365760" cy="237744"/>
           </a:xfrm>
           <a:prstGeom prst="rect">
             <a:avLst/>
@@ -19366,6 +19760,30 @@
           </a:p>
         </p:txBody>
       </p:sp>
+      <p:pic>
+        <p:nvPicPr>
+          <p:cNvPr id="25" name="Image 2" descr="logos/logo_ensae_new.png">    </p:cNvPr>
+          <p:cNvPicPr>
+            <a:picLocks noChangeAspect="1"/>
+          </p:cNvPicPr>
+          <p:nvPr/>
+        </p:nvPicPr>
+        <p:blipFill>
+          <a:blip r:embed="rId3"/>
+          <a:stretch>
+            <a:fillRect/>
+          </a:stretch>
+        </p:blipFill>
+        <p:spPr>
+          <a:xfrm>
+            <a:off x="11384280" y="6355080"/>
+            <a:ext cx="384048" cy="384048"/>
+          </a:xfrm>
+          <a:prstGeom prst="rect">
+            <a:avLst/>
+          </a:prstGeom>
+        </p:spPr>
+      </p:pic>
     </p:spTree>
   </p:cSld>
   <p:clrMapOvr>
@@ -19380,7 +19798,7 @@
     <p:bg>
       <p:bgPr>
         <a:solidFill>
-          <a:srgbClr val="16213D"/>
+          <a:srgbClr val="101038"/>
         </a:solidFill>
       </p:bgPr>
     </p:bg>
@@ -19413,7 +19831,7 @@
             <a:avLst/>
           </a:prstGeom>
           <a:solidFill>
-            <a:srgbClr val="24365E"/>
+            <a:srgbClr val="23236B"/>
           </a:solidFill>
           <a:ln/>
         </p:spPr>
@@ -19433,7 +19851,7 @@
             <a:avLst/>
           </a:prstGeom>
           <a:solidFill>
-            <a:srgbClr val="24365E"/>
+            <a:srgbClr val="23236B"/>
           </a:solidFill>
           <a:ln/>
         </p:spPr>
@@ -19546,7 +19964,7 @@
             <a:r>
               <a:rPr lang="en-US" sz="1400" dirty="0">
                 <a:solidFill>
-                  <a:srgbClr val="AFC0DA"/>
+                  <a:srgbClr val="B7B7DB"/>
                 </a:solidFill>
                 <a:latin typeface="Calibri" pitchFamily="34" charset="0"/>
                 <a:ea typeface="Calibri" pitchFamily="34" charset="-122"/>
@@ -19572,7 +19990,7 @@
     <p:bg>
       <p:bgPr>
         <a:solidFill>
-          <a:srgbClr val="FBFAF8"/>
+          <a:srgbClr val="FFFFFF"/>
         </a:solidFill>
       </p:bgPr>
     </p:bg>
@@ -19617,7 +20035,7 @@
             <a:r>
               <a:rPr lang="en-US" sz="2700" b="1" dirty="0">
                 <a:solidFill>
-                  <a:srgbClr val="1E2B4A"/>
+                  <a:srgbClr val="191970"/>
                 </a:solidFill>
                 <a:latin typeface="Calibri" pitchFamily="34" charset="0"/>
                 <a:ea typeface="Calibri" pitchFamily="34" charset="-122"/>
@@ -19646,13 +20064,13 @@
             </a:avLst>
           </a:prstGeom>
           <a:solidFill>
-            <a:srgbClr val="1E2B4A"/>
+            <a:srgbClr val="191970"/>
           </a:solidFill>
           <a:ln/>
           <a:effectLst>
             <a:outerShdw sx="100000" sy="100000" kx="0" ky="0" algn="bl" rotWithShape="0" blurRad="127000" dist="25400" dir="5400000">
-              <a:srgbClr val="1E2B4A">
-                <a:alpha val="13000"/>
+              <a:srgbClr val="13134F">
+                <a:alpha val="10000"/>
               </a:srgbClr>
             </a:outerShdw>
           </a:effectLst>
@@ -19717,13 +20135,13 @@
             </a:avLst>
           </a:prstGeom>
           <a:solidFill>
-            <a:srgbClr val="FFFFFF"/>
+            <a:srgbClr val="F4F5FA"/>
           </a:solidFill>
           <a:ln/>
           <a:effectLst>
             <a:outerShdw sx="100000" sy="100000" kx="0" ky="0" algn="bl" rotWithShape="0" blurRad="127000" dist="25400" dir="5400000">
-              <a:srgbClr val="1E2B4A">
-                <a:alpha val="13000"/>
+              <a:srgbClr val="13134F">
+                <a:alpha val="10000"/>
               </a:srgbClr>
             </a:outerShdw>
           </a:effectLst>
@@ -19866,13 +20284,13 @@
             </a:avLst>
           </a:prstGeom>
           <a:solidFill>
-            <a:srgbClr val="FFFFFF"/>
+            <a:srgbClr val="F4F5FA"/>
           </a:solidFill>
           <a:ln/>
           <a:effectLst>
             <a:outerShdw sx="100000" sy="100000" kx="0" ky="0" algn="bl" rotWithShape="0" blurRad="127000" dist="25400" dir="5400000">
-              <a:srgbClr val="1E2B4A">
-                <a:alpha val="13000"/>
+              <a:srgbClr val="13134F">
+                <a:alpha val="10000"/>
               </a:srgbClr>
             </a:outerShdw>
           </a:effectLst>
@@ -19905,7 +20323,7 @@
             <a:r>
               <a:rPr lang="en-US" sz="3600" b="1" dirty="0">
                 <a:solidFill>
-                  <a:srgbClr val="41639E"/>
+                  <a:srgbClr val="4444AD"/>
                 </a:solidFill>
                 <a:latin typeface="Calibri" pitchFamily="34" charset="0"/>
                 <a:ea typeface="Calibri" pitchFamily="34" charset="-122"/>
@@ -20015,13 +20433,13 @@
             </a:avLst>
           </a:prstGeom>
           <a:solidFill>
-            <a:srgbClr val="FFFFFF"/>
+            <a:srgbClr val="F4F5FA"/>
           </a:solidFill>
           <a:ln/>
           <a:effectLst>
             <a:outerShdw sx="100000" sy="100000" kx="0" ky="0" algn="bl" rotWithShape="0" blurRad="127000" dist="25400" dir="5400000">
-              <a:srgbClr val="1E2B4A">
-                <a:alpha val="13000"/>
+              <a:srgbClr val="13134F">
+                <a:alpha val="10000"/>
               </a:srgbClr>
             </a:outerShdw>
           </a:effectLst>
@@ -20054,7 +20472,7 @@
             <a:r>
               <a:rPr lang="en-US" sz="3600" b="1" dirty="0">
                 <a:solidFill>
-                  <a:srgbClr val="3E8C9A"/>
+                  <a:srgbClr val="2A2A80"/>
                 </a:solidFill>
                 <a:latin typeface="Calibri" pitchFamily="34" charset="0"/>
                 <a:ea typeface="Calibri" pitchFamily="34" charset="-122"/>
@@ -20164,13 +20582,13 @@
             </a:avLst>
           </a:prstGeom>
           <a:solidFill>
-            <a:srgbClr val="FFFFFF"/>
+            <a:srgbClr val="F4F5FA"/>
           </a:solidFill>
           <a:ln/>
           <a:effectLst>
             <a:outerShdw sx="100000" sy="100000" kx="0" ky="0" algn="bl" rotWithShape="0" blurRad="127000" dist="25400" dir="5400000">
-              <a:srgbClr val="1E2B4A">
-                <a:alpha val="13000"/>
+              <a:srgbClr val="13134F">
+                <a:alpha val="10000"/>
               </a:srgbClr>
             </a:outerShdw>
           </a:effectLst>
@@ -20203,7 +20621,7 @@
             <a:r>
               <a:rPr lang="en-US" sz="3600" b="1" dirty="0">
                 <a:solidFill>
-                  <a:srgbClr val="C98A24"/>
+                  <a:srgbClr val="6E6ECB"/>
                 </a:solidFill>
                 <a:latin typeface="Calibri" pitchFamily="34" charset="0"/>
                 <a:ea typeface="Calibri" pitchFamily="34" charset="-122"/>
@@ -20304,8 +20722,8 @@
         </p:nvSpPr>
         <p:spPr>
           <a:xfrm>
-            <a:off x="10972800" y="6455664"/>
-            <a:ext cx="685800" cy="237744"/>
+            <a:off x="10881360" y="6455664"/>
+            <a:ext cx="365760" cy="237744"/>
           </a:xfrm>
           <a:prstGeom prst="rect">
             <a:avLst/>
@@ -20335,6 +20753,30 @@
           </a:p>
         </p:txBody>
       </p:sp>
+      <p:pic>
+        <p:nvPicPr>
+          <p:cNvPr id="22" name="Image 0" descr="logos/logo_ensae_new.png">    </p:cNvPr>
+          <p:cNvPicPr>
+            <a:picLocks noChangeAspect="1"/>
+          </p:cNvPicPr>
+          <p:nvPr/>
+        </p:nvPicPr>
+        <p:blipFill>
+          <a:blip r:embed="rId1"/>
+          <a:stretch>
+            <a:fillRect/>
+          </a:stretch>
+        </p:blipFill>
+        <p:spPr>
+          <a:xfrm>
+            <a:off x="11384280" y="6355080"/>
+            <a:ext cx="384048" cy="384048"/>
+          </a:xfrm>
+          <a:prstGeom prst="rect">
+            <a:avLst/>
+          </a:prstGeom>
+        </p:spPr>
+      </p:pic>
     </p:spTree>
   </p:cSld>
   <p:clrMapOvr>
@@ -20349,7 +20791,7 @@
     <p:bg>
       <p:bgPr>
         <a:solidFill>
-          <a:srgbClr val="FBFAF8"/>
+          <a:srgbClr val="FFFFFF"/>
         </a:solidFill>
       </p:bgPr>
     </p:bg>
@@ -20394,7 +20836,7 @@
             <a:r>
               <a:rPr lang="en-US" sz="2700" b="1" dirty="0">
                 <a:solidFill>
-                  <a:srgbClr val="1E2B4A"/>
+                  <a:srgbClr val="191970"/>
                 </a:solidFill>
                 <a:latin typeface="Calibri" pitchFamily="34" charset="0"/>
                 <a:ea typeface="Calibri" pitchFamily="34" charset="-122"/>
@@ -20465,13 +20907,13 @@
             </a:avLst>
           </a:prstGeom>
           <a:solidFill>
-            <a:srgbClr val="FFFFFF"/>
+            <a:srgbClr val="F4F5FA"/>
           </a:solidFill>
           <a:ln/>
           <a:effectLst>
             <a:outerShdw sx="100000" sy="100000" kx="0" ky="0" algn="bl" rotWithShape="0" blurRad="127000" dist="25400" dir="5400000">
-              <a:srgbClr val="1E2B4A">
-                <a:alpha val="13000"/>
+              <a:srgbClr val="13134F">
+                <a:alpha val="10000"/>
               </a:srgbClr>
             </a:outerShdw>
           </a:effectLst>
@@ -20492,7 +20934,7 @@
             <a:avLst/>
           </a:prstGeom>
           <a:solidFill>
-            <a:srgbClr val="C98A24"/>
+            <a:srgbClr val="6E6ECB"/>
           </a:solidFill>
           <a:ln w="31750">
             <a:solidFill>
@@ -20502,7 +20944,7 @@
           </a:ln>
           <a:effectLst>
             <a:outerShdw sx="100000" sy="100000" kx="0" ky="0" algn="bl" rotWithShape="0" blurRad="127000" dist="25400" dir="5400000">
-              <a:srgbClr val="1E2B4A">
+              <a:srgbClr val="13134F">
                 <a:alpha val="18000"/>
               </a:srgbClr>
             </a:outerShdw>
@@ -20634,13 +21076,13 @@
             </a:avLst>
           </a:prstGeom>
           <a:solidFill>
-            <a:srgbClr val="FFFFFF"/>
+            <a:srgbClr val="F4F5FA"/>
           </a:solidFill>
           <a:ln/>
           <a:effectLst>
             <a:outerShdw sx="100000" sy="100000" kx="0" ky="0" algn="bl" rotWithShape="0" blurRad="127000" dist="25400" dir="5400000">
-              <a:srgbClr val="1E2B4A">
-                <a:alpha val="13000"/>
+              <a:srgbClr val="13134F">
+                <a:alpha val="10000"/>
               </a:srgbClr>
             </a:outerShdw>
           </a:effectLst>
@@ -20661,7 +21103,7 @@
             <a:avLst/>
           </a:prstGeom>
           <a:solidFill>
-            <a:srgbClr val="41639E"/>
+            <a:srgbClr val="4444AD"/>
           </a:solidFill>
           <a:ln w="31750">
             <a:solidFill>
@@ -20671,7 +21113,7 @@
           </a:ln>
           <a:effectLst>
             <a:outerShdw sx="100000" sy="100000" kx="0" ky="0" algn="bl" rotWithShape="0" blurRad="127000" dist="25400" dir="5400000">
-              <a:srgbClr val="1E2B4A">
+              <a:srgbClr val="13134F">
                 <a:alpha val="18000"/>
               </a:srgbClr>
             </a:outerShdw>
@@ -20803,13 +21245,13 @@
             </a:avLst>
           </a:prstGeom>
           <a:solidFill>
-            <a:srgbClr val="FFFFFF"/>
+            <a:srgbClr val="F4F5FA"/>
           </a:solidFill>
           <a:ln/>
           <a:effectLst>
             <a:outerShdw sx="100000" sy="100000" kx="0" ky="0" algn="bl" rotWithShape="0" blurRad="127000" dist="25400" dir="5400000">
-              <a:srgbClr val="1E2B4A">
-                <a:alpha val="13000"/>
+              <a:srgbClr val="13134F">
+                <a:alpha val="10000"/>
               </a:srgbClr>
             </a:outerShdw>
           </a:effectLst>
@@ -20830,7 +21272,7 @@
             <a:avLst/>
           </a:prstGeom>
           <a:solidFill>
-            <a:srgbClr val="3E8C9A"/>
+            <a:srgbClr val="2A2A80"/>
           </a:solidFill>
           <a:ln w="31750">
             <a:solidFill>
@@ -20840,7 +21282,7 @@
           </a:ln>
           <a:effectLst>
             <a:outerShdw sx="100000" sy="100000" kx="0" ky="0" algn="bl" rotWithShape="0" blurRad="127000" dist="25400" dir="5400000">
-              <a:srgbClr val="1E2B4A">
+              <a:srgbClr val="13134F">
                 <a:alpha val="18000"/>
               </a:srgbClr>
             </a:outerShdw>
@@ -20963,8 +21405,8 @@
         </p:nvSpPr>
         <p:spPr>
           <a:xfrm>
-            <a:off x="10972800" y="6455664"/>
-            <a:ext cx="685800" cy="237744"/>
+            <a:off x="10881360" y="6455664"/>
+            <a:ext cx="365760" cy="237744"/>
           </a:xfrm>
           <a:prstGeom prst="rect">
             <a:avLst/>
@@ -20994,6 +21436,30 @@
           </a:p>
         </p:txBody>
       </p:sp>
+      <p:pic>
+        <p:nvPicPr>
+          <p:cNvPr id="20" name="Image 3" descr="logos/logo_ensae_new.png">    </p:cNvPr>
+          <p:cNvPicPr>
+            <a:picLocks noChangeAspect="1"/>
+          </p:cNvPicPr>
+          <p:nvPr/>
+        </p:nvPicPr>
+        <p:blipFill>
+          <a:blip r:embed="rId4"/>
+          <a:stretch>
+            <a:fillRect/>
+          </a:stretch>
+        </p:blipFill>
+        <p:spPr>
+          <a:xfrm>
+            <a:off x="11384280" y="6355080"/>
+            <a:ext cx="384048" cy="384048"/>
+          </a:xfrm>
+          <a:prstGeom prst="rect">
+            <a:avLst/>
+          </a:prstGeom>
+        </p:spPr>
+      </p:pic>
     </p:spTree>
   </p:cSld>
   <p:clrMapOvr>
@@ -21008,7 +21474,7 @@
     <p:bg>
       <p:bgPr>
         <a:solidFill>
-          <a:srgbClr val="16213D"/>
+          <a:srgbClr val="101038"/>
         </a:solidFill>
       </p:bgPr>
     </p:bg>
@@ -21041,7 +21507,7 @@
             <a:avLst/>
           </a:prstGeom>
           <a:solidFill>
-            <a:srgbClr val="24365E"/>
+            <a:srgbClr val="23236B"/>
           </a:solidFill>
           <a:ln/>
         </p:spPr>
@@ -21061,7 +21527,7 @@
             <a:avLst/>
           </a:prstGeom>
           <a:solidFill>
-            <a:srgbClr val="24365E"/>
+            <a:srgbClr val="23236B"/>
           </a:solidFill>
           <a:ln/>
         </p:spPr>
@@ -21197,7 +21663,7 @@
     <p:bg>
       <p:bgPr>
         <a:solidFill>
-          <a:srgbClr val="16213D"/>
+          <a:srgbClr val="101038"/>
         </a:solidFill>
       </p:bgPr>
     </p:bg>
@@ -21230,7 +21696,7 @@
             <a:avLst/>
           </a:prstGeom>
           <a:solidFill>
-            <a:srgbClr val="24365E"/>
+            <a:srgbClr val="23236B"/>
           </a:solidFill>
           <a:ln/>
         </p:spPr>
@@ -21250,7 +21716,7 @@
             <a:avLst/>
           </a:prstGeom>
           <a:solidFill>
-            <a:srgbClr val="24365E"/>
+            <a:srgbClr val="23236B"/>
           </a:solidFill>
           <a:ln/>
         </p:spPr>
@@ -21363,7 +21829,7 @@
             <a:r>
               <a:rPr lang="en-US" sz="1400" dirty="0">
                 <a:solidFill>
-                  <a:srgbClr val="AFC0DA"/>
+                  <a:srgbClr val="B7B7DB"/>
                 </a:solidFill>
                 <a:latin typeface="Calibri" pitchFamily="34" charset="0"/>
                 <a:ea typeface="Calibri" pitchFamily="34" charset="-122"/>
@@ -21389,7 +21855,7 @@
     <p:bg>
       <p:bgPr>
         <a:solidFill>
-          <a:srgbClr val="FBFAF8"/>
+          <a:srgbClr val="FFFFFF"/>
         </a:solidFill>
       </p:bgPr>
     </p:bg>
@@ -21434,7 +21900,7 @@
             <a:r>
               <a:rPr lang="en-US" sz="2700" b="1" dirty="0">
                 <a:solidFill>
-                  <a:srgbClr val="1E2B4A"/>
+                  <a:srgbClr val="191970"/>
                 </a:solidFill>
                 <a:latin typeface="Calibri" pitchFamily="34" charset="0"/>
                 <a:ea typeface="Calibri" pitchFamily="34" charset="-122"/>
@@ -21463,13 +21929,13 @@
             </a:avLst>
           </a:prstGeom>
           <a:solidFill>
-            <a:srgbClr val="FFFFFF"/>
+            <a:srgbClr val="F4F5FA"/>
           </a:solidFill>
           <a:ln/>
           <a:effectLst>
             <a:outerShdw sx="100000" sy="100000" kx="0" ky="0" algn="bl" rotWithShape="0" blurRad="127000" dist="25400" dir="5400000">
-              <a:srgbClr val="1E2B4A">
-                <a:alpha val="13000"/>
+              <a:srgbClr val="13134F">
+                <a:alpha val="10000"/>
               </a:srgbClr>
             </a:outerShdw>
           </a:effectLst>
@@ -21490,7 +21956,7 @@
             <a:avLst/>
           </a:prstGeom>
           <a:solidFill>
-            <a:srgbClr val="41639E"/>
+            <a:srgbClr val="4444AD"/>
           </a:solidFill>
           <a:ln w="31750">
             <a:solidFill>
@@ -21500,7 +21966,7 @@
           </a:ln>
           <a:effectLst>
             <a:outerShdw sx="100000" sy="100000" kx="0" ky="0" algn="bl" rotWithShape="0" blurRad="127000" dist="25400" dir="5400000">
-              <a:srgbClr val="1E2B4A">
+              <a:srgbClr val="13134F">
                 <a:alpha val="18000"/>
               </a:srgbClr>
             </a:outerShdw>
@@ -21600,7 +22066,7 @@
             <a:r>
               <a:rPr lang="en-US" sz="3400" b="1" dirty="0">
                 <a:solidFill>
-                  <a:srgbClr val="41639E"/>
+                  <a:srgbClr val="4444AD"/>
                 </a:solidFill>
                 <a:latin typeface="Calibri" pitchFamily="34" charset="0"/>
                 <a:ea typeface="Calibri" pitchFamily="34" charset="-122"/>
@@ -21701,7 +22167,7 @@
             <a:r>
               <a:rPr lang="en-US" sz="3400" b="1" dirty="0">
                 <a:solidFill>
-                  <a:srgbClr val="41639E"/>
+                  <a:srgbClr val="4444AD"/>
                 </a:solidFill>
                 <a:latin typeface="Calibri" pitchFamily="34" charset="0"/>
                 <a:ea typeface="Calibri" pitchFamily="34" charset="-122"/>
@@ -21873,13 +22339,13 @@
             </a:avLst>
           </a:prstGeom>
           <a:solidFill>
-            <a:srgbClr val="FFFFFF"/>
+            <a:srgbClr val="F4F5FA"/>
           </a:solidFill>
           <a:ln/>
           <a:effectLst>
             <a:outerShdw sx="100000" sy="100000" kx="0" ky="0" algn="bl" rotWithShape="0" blurRad="127000" dist="25400" dir="5400000">
-              <a:srgbClr val="1E2B4A">
-                <a:alpha val="13000"/>
+              <a:srgbClr val="13134F">
+                <a:alpha val="10000"/>
               </a:srgbClr>
             </a:outerShdw>
           </a:effectLst>
@@ -21910,7 +22376,7 @@
           </a:ln>
           <a:effectLst>
             <a:outerShdw sx="100000" sy="100000" kx="0" ky="0" algn="bl" rotWithShape="0" blurRad="127000" dist="25400" dir="5400000">
-              <a:srgbClr val="1E2B4A">
+              <a:srgbClr val="13134F">
                 <a:alpha val="18000"/>
               </a:srgbClr>
             </a:outerShdw>
@@ -22274,8 +22740,8 @@
         </p:nvSpPr>
         <p:spPr>
           <a:xfrm>
-            <a:off x="10972800" y="6455664"/>
-            <a:ext cx="685800" cy="237744"/>
+            <a:off x="10881360" y="6455664"/>
+            <a:ext cx="365760" cy="237744"/>
           </a:xfrm>
           <a:prstGeom prst="rect">
             <a:avLst/>
@@ -22305,6 +22771,30 @@
           </a:p>
         </p:txBody>
       </p:sp>
+      <p:pic>
+        <p:nvPicPr>
+          <p:cNvPr id="24" name="Image 2" descr="logos/logo_ensae_new.png">    </p:cNvPr>
+          <p:cNvPicPr>
+            <a:picLocks noChangeAspect="1"/>
+          </p:cNvPicPr>
+          <p:nvPr/>
+        </p:nvPicPr>
+        <p:blipFill>
+          <a:blip r:embed="rId3"/>
+          <a:stretch>
+            <a:fillRect/>
+          </a:stretch>
+        </p:blipFill>
+        <p:spPr>
+          <a:xfrm>
+            <a:off x="11384280" y="6355080"/>
+            <a:ext cx="384048" cy="384048"/>
+          </a:xfrm>
+          <a:prstGeom prst="rect">
+            <a:avLst/>
+          </a:prstGeom>
+        </p:spPr>
+      </p:pic>
     </p:spTree>
   </p:cSld>
   <p:clrMapOvr>
@@ -22319,7 +22809,7 @@
     <p:bg>
       <p:bgPr>
         <a:solidFill>
-          <a:srgbClr val="FBFAF8"/>
+          <a:srgbClr val="FFFFFF"/>
         </a:solidFill>
       </p:bgPr>
     </p:bg>
@@ -22364,7 +22854,7 @@
             <a:r>
               <a:rPr lang="en-US" sz="2700" b="1" dirty="0">
                 <a:solidFill>
-                  <a:srgbClr val="1E2B4A"/>
+                  <a:srgbClr val="191970"/>
                 </a:solidFill>
                 <a:latin typeface="Calibri" pitchFamily="34" charset="0"/>
                 <a:ea typeface="Calibri" pitchFamily="34" charset="-122"/>
@@ -22393,13 +22883,13 @@
             </a:avLst>
           </a:prstGeom>
           <a:solidFill>
-            <a:srgbClr val="1E2B4A"/>
+            <a:srgbClr val="191970"/>
           </a:solidFill>
           <a:ln/>
           <a:effectLst>
             <a:outerShdw sx="100000" sy="100000" kx="0" ky="0" algn="bl" rotWithShape="0" blurRad="127000" dist="25400" dir="5400000">
-              <a:srgbClr val="1E2B4A">
-                <a:alpha val="13000"/>
+              <a:srgbClr val="13134F">
+                <a:alpha val="10000"/>
               </a:srgbClr>
             </a:outerShdw>
           </a:effectLst>
@@ -22484,13 +22974,13 @@
             </a:avLst>
           </a:prstGeom>
           <a:solidFill>
-            <a:srgbClr val="FFFFFF"/>
+            <a:srgbClr val="F4F5FA"/>
           </a:solidFill>
           <a:ln/>
           <a:effectLst>
             <a:outerShdw sx="100000" sy="100000" kx="0" ky="0" algn="bl" rotWithShape="0" blurRad="127000" dist="25400" dir="5400000">
-              <a:srgbClr val="1E2B4A">
-                <a:alpha val="13000"/>
+              <a:srgbClr val="13134F">
+                <a:alpha val="10000"/>
               </a:srgbClr>
             </a:outerShdw>
           </a:effectLst>
@@ -22597,13 +23087,13 @@
             </a:avLst>
           </a:prstGeom>
           <a:solidFill>
-            <a:srgbClr val="FFFFFF"/>
+            <a:srgbClr val="F4F5FA"/>
           </a:solidFill>
           <a:ln/>
           <a:effectLst>
             <a:outerShdw sx="100000" sy="100000" kx="0" ky="0" algn="bl" rotWithShape="0" blurRad="127000" dist="25400" dir="5400000">
-              <a:srgbClr val="1E2B4A">
-                <a:alpha val="13000"/>
+              <a:srgbClr val="13134F">
+                <a:alpha val="10000"/>
               </a:srgbClr>
             </a:outerShdw>
           </a:effectLst>
@@ -22710,13 +23200,13 @@
             </a:avLst>
           </a:prstGeom>
           <a:solidFill>
-            <a:srgbClr val="FFFFFF"/>
+            <a:srgbClr val="F4F5FA"/>
           </a:solidFill>
           <a:ln/>
           <a:effectLst>
             <a:outerShdw sx="100000" sy="100000" kx="0" ky="0" algn="bl" rotWithShape="0" blurRad="127000" dist="25400" dir="5400000">
-              <a:srgbClr val="1E2B4A">
-                <a:alpha val="13000"/>
+              <a:srgbClr val="13134F">
+                <a:alpha val="10000"/>
               </a:srgbClr>
             </a:outerShdw>
           </a:effectLst>
@@ -22831,7 +23321,7 @@
           </a:ln>
           <a:effectLst>
             <a:outerShdw sx="100000" sy="100000" kx="0" ky="0" algn="bl" rotWithShape="0" blurRad="127000" dist="25400" dir="5400000">
-              <a:srgbClr val="1E2B4A">
+              <a:srgbClr val="13134F">
                 <a:alpha val="18000"/>
               </a:srgbClr>
             </a:outerShdw>
@@ -22877,7 +23367,7 @@
             <a:avLst/>
           </a:prstGeom>
           <a:solidFill>
-            <a:srgbClr val="C98A24"/>
+            <a:srgbClr val="6E6ECB"/>
           </a:solidFill>
           <a:ln w="31750">
             <a:solidFill>
@@ -22887,7 +23377,7 @@
           </a:ln>
           <a:effectLst>
             <a:outerShdw sx="100000" sy="100000" kx="0" ky="0" algn="bl" rotWithShape="0" blurRad="127000" dist="25400" dir="5400000">
-              <a:srgbClr val="1E2B4A">
+              <a:srgbClr val="13134F">
                 <a:alpha val="18000"/>
               </a:srgbClr>
             </a:outerShdw>
@@ -22933,7 +23423,7 @@
             <a:avLst/>
           </a:prstGeom>
           <a:solidFill>
-            <a:srgbClr val="3E8C9A"/>
+            <a:srgbClr val="2A2A80"/>
           </a:solidFill>
           <a:ln w="31750">
             <a:solidFill>
@@ -22943,7 +23433,7 @@
           </a:ln>
           <a:effectLst>
             <a:outerShdw sx="100000" sy="100000" kx="0" ky="0" algn="bl" rotWithShape="0" blurRad="127000" dist="25400" dir="5400000">
-              <a:srgbClr val="1E2B4A">
+              <a:srgbClr val="13134F">
                 <a:alpha val="18000"/>
               </a:srgbClr>
             </a:outerShdw>
@@ -22982,8 +23472,8 @@
         </p:nvSpPr>
         <p:spPr>
           <a:xfrm>
-            <a:off x="10972800" y="6455664"/>
-            <a:ext cx="685800" cy="237744"/>
+            <a:off x="10881360" y="6455664"/>
+            <a:ext cx="365760" cy="237744"/>
           </a:xfrm>
           <a:prstGeom prst="rect">
             <a:avLst/>
@@ -23013,6 +23503,30 @@
           </a:p>
         </p:txBody>
       </p:sp>
+      <p:pic>
+        <p:nvPicPr>
+          <p:cNvPr id="21" name="Image 3" descr="logos/logo_ensae_new.png">    </p:cNvPr>
+          <p:cNvPicPr>
+            <a:picLocks noChangeAspect="1"/>
+          </p:cNvPicPr>
+          <p:nvPr/>
+        </p:nvPicPr>
+        <p:blipFill>
+          <a:blip r:embed="rId4"/>
+          <a:stretch>
+            <a:fillRect/>
+          </a:stretch>
+        </p:blipFill>
+        <p:spPr>
+          <a:xfrm>
+            <a:off x="11384280" y="6355080"/>
+            <a:ext cx="384048" cy="384048"/>
+          </a:xfrm>
+          <a:prstGeom prst="rect">
+            <a:avLst/>
+          </a:prstGeom>
+        </p:spPr>
+      </p:pic>
     </p:spTree>
   </p:cSld>
   <p:clrMapOvr>
@@ -23027,7 +23541,7 @@
     <p:bg>
       <p:bgPr>
         <a:solidFill>
-          <a:srgbClr val="FBFAF8"/>
+          <a:srgbClr val="FFFFFF"/>
         </a:solidFill>
       </p:bgPr>
     </p:bg>
@@ -23072,7 +23586,7 @@
             <a:r>
               <a:rPr lang="en-US" sz="2700" b="1" dirty="0">
                 <a:solidFill>
-                  <a:srgbClr val="1E2B4A"/>
+                  <a:srgbClr val="191970"/>
                 </a:solidFill>
                 <a:latin typeface="Calibri" pitchFamily="34" charset="0"/>
                 <a:ea typeface="Calibri" pitchFamily="34" charset="-122"/>
@@ -23101,13 +23615,13 @@
             </a:avLst>
           </a:prstGeom>
           <a:solidFill>
-            <a:srgbClr val="FFFFFF"/>
+            <a:srgbClr val="F4F5FA"/>
           </a:solidFill>
           <a:ln/>
           <a:effectLst>
             <a:outerShdw sx="100000" sy="100000" kx="0" ky="0" algn="bl" rotWithShape="0" blurRad="127000" dist="25400" dir="5400000">
-              <a:srgbClr val="1E2B4A">
-                <a:alpha val="13000"/>
+              <a:srgbClr val="13134F">
+                <a:alpha val="10000"/>
               </a:srgbClr>
             </a:outerShdw>
           </a:effectLst>
@@ -23128,7 +23642,7 @@
             <a:avLst/>
           </a:prstGeom>
           <a:solidFill>
-            <a:srgbClr val="41639E"/>
+            <a:srgbClr val="4444AD"/>
           </a:solidFill>
           <a:ln w="31750">
             <a:solidFill>
@@ -23138,7 +23652,7 @@
           </a:ln>
           <a:effectLst>
             <a:outerShdw sx="100000" sy="100000" kx="0" ky="0" algn="bl" rotWithShape="0" blurRad="127000" dist="25400" dir="5400000">
-              <a:srgbClr val="1E2B4A">
+              <a:srgbClr val="13134F">
                 <a:alpha val="18000"/>
               </a:srgbClr>
             </a:outerShdw>
@@ -23265,7 +23779,7 @@
             <a:avLst/>
           </a:prstGeom>
           <a:solidFill>
-            <a:srgbClr val="41639E"/>
+            <a:srgbClr val="4444AD"/>
           </a:solidFill>
           <a:ln/>
         </p:spPr>
@@ -23366,7 +23880,7 @@
             <a:avLst/>
           </a:prstGeom>
           <a:solidFill>
-            <a:srgbClr val="41639E"/>
+            <a:srgbClr val="4444AD"/>
           </a:solidFill>
           <a:ln/>
         </p:spPr>
@@ -23469,13 +23983,13 @@
             </a:avLst>
           </a:prstGeom>
           <a:solidFill>
-            <a:srgbClr val="FFFFFF"/>
+            <a:srgbClr val="F4F5FA"/>
           </a:solidFill>
           <a:ln/>
           <a:effectLst>
             <a:outerShdw sx="100000" sy="100000" kx="0" ky="0" algn="bl" rotWithShape="0" blurRad="127000" dist="25400" dir="5400000">
-              <a:srgbClr val="1E2B4A">
-                <a:alpha val="13000"/>
+              <a:srgbClr val="13134F">
+                <a:alpha val="10000"/>
               </a:srgbClr>
             </a:outerShdw>
           </a:effectLst>
@@ -23506,7 +24020,7 @@
           </a:ln>
           <a:effectLst>
             <a:outerShdw sx="100000" sy="100000" kx="0" ky="0" algn="bl" rotWithShape="0" blurRad="127000" dist="25400" dir="5400000">
-              <a:srgbClr val="1E2B4A">
+              <a:srgbClr val="13134F">
                 <a:alpha val="18000"/>
               </a:srgbClr>
             </a:outerShdw>
@@ -23593,13 +24107,13 @@
             </a:avLst>
           </a:prstGeom>
           <a:solidFill>
-            <a:srgbClr val="FBFAF8"/>
+            <a:srgbClr val="E7E7F3"/>
           </a:solidFill>
           <a:ln/>
           <a:effectLst>
             <a:outerShdw sx="100000" sy="100000" kx="0" ky="0" algn="bl" rotWithShape="0" blurRad="127000" dist="25400" dir="5400000">
-              <a:srgbClr val="1E2B4A">
-                <a:alpha val="13000"/>
+              <a:srgbClr val="13134F">
+                <a:alpha val="10000"/>
               </a:srgbClr>
             </a:outerShdw>
           </a:effectLst>
@@ -23703,13 +24217,13 @@
             </a:avLst>
           </a:prstGeom>
           <a:solidFill>
-            <a:srgbClr val="FBFAF8"/>
+            <a:srgbClr val="E7E7F3"/>
           </a:solidFill>
           <a:ln/>
           <a:effectLst>
             <a:outerShdw sx="100000" sy="100000" kx="0" ky="0" algn="bl" rotWithShape="0" blurRad="127000" dist="25400" dir="5400000">
-              <a:srgbClr val="1E2B4A">
-                <a:alpha val="13000"/>
+              <a:srgbClr val="13134F">
+                <a:alpha val="10000"/>
               </a:srgbClr>
             </a:outerShdw>
           </a:effectLst>
@@ -23804,8 +24318,8 @@
         </p:nvSpPr>
         <p:spPr>
           <a:xfrm>
-            <a:off x="10972800" y="6455664"/>
-            <a:ext cx="685800" cy="237744"/>
+            <a:off x="10881360" y="6455664"/>
+            <a:ext cx="365760" cy="237744"/>
           </a:xfrm>
           <a:prstGeom prst="rect">
             <a:avLst/>
@@ -23835,6 +24349,30 @@
           </a:p>
         </p:txBody>
       </p:sp>
+      <p:pic>
+        <p:nvPicPr>
+          <p:cNvPr id="25" name="Image 2" descr="logos/logo_ensae_new.png">    </p:cNvPr>
+          <p:cNvPicPr>
+            <a:picLocks noChangeAspect="1"/>
+          </p:cNvPicPr>
+          <p:nvPr/>
+        </p:nvPicPr>
+        <p:blipFill>
+          <a:blip r:embed="rId3"/>
+          <a:stretch>
+            <a:fillRect/>
+          </a:stretch>
+        </p:blipFill>
+        <p:spPr>
+          <a:xfrm>
+            <a:off x="11384280" y="6355080"/>
+            <a:ext cx="384048" cy="384048"/>
+          </a:xfrm>
+          <a:prstGeom prst="rect">
+            <a:avLst/>
+          </a:prstGeom>
+        </p:spPr>
+      </p:pic>
     </p:spTree>
   </p:cSld>
   <p:clrMapOvr>
@@ -23849,7 +24387,7 @@
     <p:bg>
       <p:bgPr>
         <a:solidFill>
-          <a:srgbClr val="16213D"/>
+          <a:srgbClr val="101038"/>
         </a:solidFill>
       </p:bgPr>
     </p:bg>
@@ -23882,7 +24420,7 @@
             <a:avLst/>
           </a:prstGeom>
           <a:solidFill>
-            <a:srgbClr val="24365E"/>
+            <a:srgbClr val="23236B"/>
           </a:solidFill>
           <a:ln/>
         </p:spPr>
@@ -23902,7 +24440,7 @@
             <a:avLst/>
           </a:prstGeom>
           <a:solidFill>
-            <a:srgbClr val="24365E"/>
+            <a:srgbClr val="23236B"/>
           </a:solidFill>
           <a:ln/>
         </p:spPr>
@@ -24015,7 +24553,7 @@
             <a:r>
               <a:rPr lang="en-US" sz="1400" dirty="0">
                 <a:solidFill>
-                  <a:srgbClr val="AFC0DA"/>
+                  <a:srgbClr val="B7B7DB"/>
                 </a:solidFill>
                 <a:latin typeface="Calibri" pitchFamily="34" charset="0"/>
                 <a:ea typeface="Calibri" pitchFamily="34" charset="-122"/>
@@ -24041,7 +24579,7 @@
     <p:bg>
       <p:bgPr>
         <a:solidFill>
-          <a:srgbClr val="FBFAF8"/>
+          <a:srgbClr val="FFFFFF"/>
         </a:solidFill>
       </p:bgPr>
     </p:bg>
@@ -24086,7 +24624,7 @@
             <a:r>
               <a:rPr lang="en-US" sz="2700" b="1" dirty="0">
                 <a:solidFill>
-                  <a:srgbClr val="1E2B4A"/>
+                  <a:srgbClr val="191970"/>
                 </a:solidFill>
                 <a:latin typeface="Calibri" pitchFamily="34" charset="0"/>
                 <a:ea typeface="Calibri" pitchFamily="34" charset="-122"/>
@@ -24115,13 +24653,13 @@
             </a:avLst>
           </a:prstGeom>
           <a:solidFill>
-            <a:srgbClr val="FFFFFF"/>
+            <a:srgbClr val="F4F5FA"/>
           </a:solidFill>
           <a:ln/>
           <a:effectLst>
             <a:outerShdw sx="100000" sy="100000" kx="0" ky="0" algn="bl" rotWithShape="0" blurRad="127000" dist="25400" dir="5400000">
-              <a:srgbClr val="1E2B4A">
-                <a:alpha val="13000"/>
+              <a:srgbClr val="13134F">
+                <a:alpha val="10000"/>
               </a:srgbClr>
             </a:outerShdw>
           </a:effectLst>
@@ -24181,7 +24719,7 @@
             <a:avLst/>
           </a:prstGeom>
           <a:solidFill>
-            <a:srgbClr val="41639E"/>
+            <a:srgbClr val="4444AD"/>
           </a:solidFill>
           <a:ln/>
         </p:spPr>
@@ -24321,7 +24859,7 @@
             <a:avLst/>
           </a:prstGeom>
           <a:solidFill>
-            <a:srgbClr val="41639E"/>
+            <a:srgbClr val="4444AD"/>
           </a:solidFill>
           <a:ln/>
         </p:spPr>
@@ -24461,7 +24999,7 @@
             <a:avLst/>
           </a:prstGeom>
           <a:solidFill>
-            <a:srgbClr val="41639E"/>
+            <a:srgbClr val="4444AD"/>
           </a:solidFill>
           <a:ln/>
         </p:spPr>
@@ -24603,13 +25141,13 @@
             </a:avLst>
           </a:prstGeom>
           <a:solidFill>
-            <a:srgbClr val="FFFFFF"/>
+            <a:srgbClr val="F4F5FA"/>
           </a:solidFill>
           <a:ln/>
           <a:effectLst>
             <a:outerShdw sx="100000" sy="100000" kx="0" ky="0" algn="bl" rotWithShape="0" blurRad="127000" dist="25400" dir="5400000">
-              <a:srgbClr val="1E2B4A">
-                <a:alpha val="13000"/>
+              <a:srgbClr val="13134F">
+                <a:alpha val="10000"/>
               </a:srgbClr>
             </a:outerShdw>
           </a:effectLst>
@@ -25029,7 +25567,7 @@
             <a:avLst/>
           </a:prstGeom>
           <a:solidFill>
-            <a:srgbClr val="41639E"/>
+            <a:srgbClr val="4444AD"/>
           </a:solidFill>
           <a:ln w="31750">
             <a:solidFill>
@@ -25039,7 +25577,7 @@
           </a:ln>
           <a:effectLst>
             <a:outerShdw sx="100000" sy="100000" kx="0" ky="0" algn="bl" rotWithShape="0" blurRad="127000" dist="25400" dir="5400000">
-              <a:srgbClr val="1E2B4A">
+              <a:srgbClr val="13134F">
                 <a:alpha val="18000"/>
               </a:srgbClr>
             </a:outerShdw>
@@ -25085,7 +25623,7 @@
             <a:avLst/>
           </a:prstGeom>
           <a:solidFill>
-            <a:srgbClr val="C98A24"/>
+            <a:srgbClr val="6E6ECB"/>
           </a:solidFill>
           <a:ln w="31750">
             <a:solidFill>
@@ -25095,7 +25633,7 @@
           </a:ln>
           <a:effectLst>
             <a:outerShdw sx="100000" sy="100000" kx="0" ky="0" algn="bl" rotWithShape="0" blurRad="127000" dist="25400" dir="5400000">
-              <a:srgbClr val="1E2B4A">
+              <a:srgbClr val="13134F">
                 <a:alpha val="18000"/>
               </a:srgbClr>
             </a:outerShdw>
@@ -25151,7 +25689,7 @@
           </a:ln>
           <a:effectLst>
             <a:outerShdw sx="100000" sy="100000" kx="0" ky="0" algn="bl" rotWithShape="0" blurRad="127000" dist="25400" dir="5400000">
-              <a:srgbClr val="1E2B4A">
+              <a:srgbClr val="13134F">
                 <a:alpha val="18000"/>
               </a:srgbClr>
             </a:outerShdw>
@@ -25190,8 +25728,8 @@
         </p:nvSpPr>
         <p:spPr>
           <a:xfrm>
-            <a:off x="10972800" y="6455664"/>
-            <a:ext cx="685800" cy="237744"/>
+            <a:off x="10881360" y="6455664"/>
+            <a:ext cx="365760" cy="237744"/>
           </a:xfrm>
           <a:prstGeom prst="rect">
             <a:avLst/>
@@ -25221,6 +25759,30 @@
           </a:p>
         </p:txBody>
       </p:sp>
+      <p:pic>
+        <p:nvPicPr>
+          <p:cNvPr id="35" name="Image 3" descr="logos/logo_ensae_new.png">    </p:cNvPr>
+          <p:cNvPicPr>
+            <a:picLocks noChangeAspect="1"/>
+          </p:cNvPicPr>
+          <p:nvPr/>
+        </p:nvPicPr>
+        <p:blipFill>
+          <a:blip r:embed="rId4"/>
+          <a:stretch>
+            <a:fillRect/>
+          </a:stretch>
+        </p:blipFill>
+        <p:spPr>
+          <a:xfrm>
+            <a:off x="11384280" y="6355080"/>
+            <a:ext cx="384048" cy="384048"/>
+          </a:xfrm>
+          <a:prstGeom prst="rect">
+            <a:avLst/>
+          </a:prstGeom>
+        </p:spPr>
+      </p:pic>
     </p:spTree>
   </p:cSld>
   <p:clrMapOvr>
@@ -25235,7 +25797,7 @@
     <p:bg>
       <p:bgPr>
         <a:solidFill>
-          <a:srgbClr val="16213D"/>
+          <a:srgbClr val="101038"/>
         </a:solidFill>
       </p:bgPr>
     </p:bg>
@@ -25268,7 +25830,7 @@
             <a:avLst/>
           </a:prstGeom>
           <a:solidFill>
-            <a:srgbClr val="24365E"/>
+            <a:srgbClr val="23236B"/>
           </a:solidFill>
           <a:ln/>
         </p:spPr>
@@ -25288,7 +25850,7 @@
             <a:avLst/>
           </a:prstGeom>
           <a:solidFill>
-            <a:srgbClr val="24365E"/>
+            <a:srgbClr val="23236B"/>
           </a:solidFill>
           <a:ln/>
         </p:spPr>
@@ -25401,7 +25963,7 @@
             <a:r>
               <a:rPr lang="en-US" sz="1400" dirty="0">
                 <a:solidFill>
-                  <a:srgbClr val="AFC0DA"/>
+                  <a:srgbClr val="B7B7DB"/>
                 </a:solidFill>
                 <a:latin typeface="Calibri" pitchFamily="34" charset="0"/>
                 <a:ea typeface="Calibri" pitchFamily="34" charset="-122"/>

</xml_diff>

<commit_message>
Passer la presentation au fond blanc et a la palette midnightblue (#701)
Fond blanc sur toutes les diapositives de contenu, cartes en teinte
tres claire, palette recentree sur le midnightblue avec l'orange en
seul accent. Les logos de l'ENSAE et de l'ANSD figurent sur la page
de titre et la page finale, le logo de l'ENSAE en pied de page.
Les tirets doubles de la bibliographie sont remplaces par un tiret
simple.


Claude-Session: https://claude.ai/code/session_01837AJxDdpW6rUH9DV9QD1H

Co-authored-by: Claude <noreply@anthropic.com>
</commit_message>
<xml_diff>
--- a/infographie/presentation_infographique.pptx
+++ b/infographie/presentation_infographique.pptx
@@ -3171,7 +3171,7 @@
     <p:bg>
       <p:bgPr>
         <a:solidFill>
-          <a:srgbClr val="16213D"/>
+          <a:srgbClr val="101038"/>
         </a:solidFill>
       </p:bgPr>
     </p:bg>
@@ -3204,7 +3204,7 @@
             <a:avLst/>
           </a:prstGeom>
           <a:solidFill>
-            <a:srgbClr val="24365E"/>
+            <a:srgbClr val="23236B"/>
           </a:solidFill>
           <a:ln/>
         </p:spPr>
@@ -3224,14 +3224,120 @@
             <a:avLst/>
           </a:prstGeom>
           <a:solidFill>
-            <a:srgbClr val="24365E"/>
+            <a:srgbClr val="23236B"/>
           </a:solidFill>
           <a:ln/>
         </p:spPr>
       </p:sp>
       <p:sp>
         <p:nvSpPr>
-          <p:cNvPr id="4" name="Text 2"/>
+          <p:cNvPr id="4" name="Shape 2"/>
+          <p:cNvSpPr/>
+          <p:nvPr/>
+        </p:nvSpPr>
+        <p:spPr>
+          <a:xfrm>
+            <a:off x="566928" y="411480"/>
+            <a:ext cx="1234440" cy="1234440"/>
+          </a:xfrm>
+          <a:prstGeom prst="roundRect">
+            <a:avLst>
+              <a:gd name="adj" fmla="val 7407"/>
+            </a:avLst>
+          </a:prstGeom>
+          <a:solidFill>
+            <a:srgbClr val="FFFFFF"/>
+          </a:solidFill>
+          <a:ln/>
+          <a:effectLst>
+            <a:outerShdw sx="100000" sy="100000" kx="0" ky="0" algn="bl" rotWithShape="0" blurRad="127000" dist="25400" dir="5400000">
+              <a:srgbClr val="13134F">
+                <a:alpha val="22000"/>
+              </a:srgbClr>
+            </a:outerShdw>
+          </a:effectLst>
+        </p:spPr>
+      </p:sp>
+      <p:pic>
+        <p:nvPicPr>
+          <p:cNvPr id="5" name="Image 0" descr="logos/logo_ensae_new.png">    </p:cNvPr>
+          <p:cNvPicPr>
+            <a:picLocks noChangeAspect="1"/>
+          </p:cNvPicPr>
+          <p:nvPr/>
+        </p:nvPicPr>
+        <p:blipFill>
+          <a:blip r:embed="rId1"/>
+          <a:stretch>
+            <a:fillRect/>
+          </a:stretch>
+        </p:blipFill>
+        <p:spPr>
+          <a:xfrm>
+            <a:off x="685800" y="530352"/>
+            <a:ext cx="996696" cy="996696"/>
+          </a:xfrm>
+          <a:prstGeom prst="rect">
+            <a:avLst/>
+          </a:prstGeom>
+        </p:spPr>
+      </p:pic>
+      <p:sp>
+        <p:nvSpPr>
+          <p:cNvPr id="6" name="Shape 3"/>
+          <p:cNvSpPr/>
+          <p:nvPr/>
+        </p:nvSpPr>
+        <p:spPr>
+          <a:xfrm>
+            <a:off x="10387584" y="411480"/>
+            <a:ext cx="1234440" cy="1234440"/>
+          </a:xfrm>
+          <a:prstGeom prst="roundRect">
+            <a:avLst>
+              <a:gd name="adj" fmla="val 7407"/>
+            </a:avLst>
+          </a:prstGeom>
+          <a:solidFill>
+            <a:srgbClr val="FFFFFF"/>
+          </a:solidFill>
+          <a:ln/>
+          <a:effectLst>
+            <a:outerShdw sx="100000" sy="100000" kx="0" ky="0" algn="bl" rotWithShape="0" blurRad="127000" dist="25400" dir="5400000">
+              <a:srgbClr val="13134F">
+                <a:alpha val="22000"/>
+              </a:srgbClr>
+            </a:outerShdw>
+          </a:effectLst>
+        </p:spPr>
+      </p:sp>
+      <p:pic>
+        <p:nvPicPr>
+          <p:cNvPr id="7" name="Image 1" descr="logos/logo_ansd.jpg">    </p:cNvPr>
+          <p:cNvPicPr>
+            <a:picLocks noChangeAspect="1"/>
+          </p:cNvPicPr>
+          <p:nvPr/>
+        </p:nvPicPr>
+        <p:blipFill>
+          <a:blip r:embed="rId2"/>
+          <a:stretch>
+            <a:fillRect/>
+          </a:stretch>
+        </p:blipFill>
+        <p:spPr>
+          <a:xfrm>
+            <a:off x="10506456" y="612648"/>
+            <a:ext cx="996696" cy="832104"/>
+          </a:xfrm>
+          <a:prstGeom prst="rect">
+            <a:avLst/>
+          </a:prstGeom>
+        </p:spPr>
+      </p:pic>
+      <p:sp>
+        <p:nvSpPr>
+          <p:cNvPr id="8" name="Text 4"/>
           <p:cNvSpPr/>
           <p:nvPr/>
         </p:nvSpPr>
@@ -3270,7 +3376,7 @@
       </p:sp>
       <p:sp>
         <p:nvSpPr>
-          <p:cNvPr id="5" name="Text 3"/>
+          <p:cNvPr id="9" name="Text 5"/>
           <p:cNvSpPr/>
           <p:nvPr/>
         </p:nvSpPr>
@@ -3295,7 +3401,7 @@
             <a:r>
               <a:rPr lang="en-US" sz="1250" dirty="0">
                 <a:solidFill>
-                  <a:srgbClr val="AFC0DA"/>
+                  <a:srgbClr val="B7B7DB"/>
                 </a:solidFill>
                 <a:latin typeface="Calibri" pitchFamily="34" charset="0"/>
                 <a:ea typeface="Calibri" pitchFamily="34" charset="-122"/>
@@ -3309,7 +3415,7 @@
       </p:sp>
       <p:sp>
         <p:nvSpPr>
-          <p:cNvPr id="6" name="Text 4"/>
+          <p:cNvPr id="10" name="Text 6"/>
           <p:cNvSpPr/>
           <p:nvPr/>
         </p:nvSpPr>
@@ -3371,7 +3477,7 @@
       </p:sp>
       <p:sp>
         <p:nvSpPr>
-          <p:cNvPr id="7" name="Text 5"/>
+          <p:cNvPr id="11" name="Text 7"/>
           <p:cNvSpPr/>
           <p:nvPr/>
         </p:nvSpPr>
@@ -3410,7 +3516,7 @@
       </p:sp>
       <p:sp>
         <p:nvSpPr>
-          <p:cNvPr id="8" name="Text 6"/>
+          <p:cNvPr id="12" name="Text 8"/>
           <p:cNvSpPr/>
           <p:nvPr/>
         </p:nvSpPr>
@@ -3449,7 +3555,7 @@
       </p:sp>
       <p:sp>
         <p:nvSpPr>
-          <p:cNvPr id="9" name="Text 7"/>
+          <p:cNvPr id="13" name="Text 9"/>
           <p:cNvSpPr/>
           <p:nvPr/>
         </p:nvSpPr>
@@ -3488,7 +3594,7 @@
       </p:sp>
       <p:sp>
         <p:nvSpPr>
-          <p:cNvPr id="10" name="Text 8"/>
+          <p:cNvPr id="14" name="Text 10"/>
           <p:cNvSpPr/>
           <p:nvPr/>
         </p:nvSpPr>
@@ -3516,7 +3622,7 @@
             <a:r>
               <a:rPr lang="en-US" sz="1050" dirty="0">
                 <a:solidFill>
-                  <a:srgbClr val="AFC0DA"/>
+                  <a:srgbClr val="B7B7DB"/>
                 </a:solidFill>
                 <a:latin typeface="Calibri" pitchFamily="34" charset="0"/>
                 <a:ea typeface="Calibri" pitchFamily="34" charset="-122"/>
@@ -3530,7 +3636,7 @@
       </p:sp>
       <p:sp>
         <p:nvSpPr>
-          <p:cNvPr id="11" name="Text 9"/>
+          <p:cNvPr id="15" name="Text 11"/>
           <p:cNvSpPr/>
           <p:nvPr/>
         </p:nvSpPr>
@@ -3569,7 +3675,7 @@
       </p:sp>
       <p:sp>
         <p:nvSpPr>
-          <p:cNvPr id="12" name="Text 10"/>
+          <p:cNvPr id="16" name="Text 12"/>
           <p:cNvSpPr/>
           <p:nvPr/>
         </p:nvSpPr>
@@ -3608,7 +3714,7 @@
       </p:sp>
       <p:sp>
         <p:nvSpPr>
-          <p:cNvPr id="13" name="Text 11"/>
+          <p:cNvPr id="17" name="Text 13"/>
           <p:cNvSpPr/>
           <p:nvPr/>
         </p:nvSpPr>
@@ -3636,7 +3742,7 @@
             <a:r>
               <a:rPr lang="en-US" sz="1050" dirty="0">
                 <a:solidFill>
-                  <a:srgbClr val="AFC0DA"/>
+                  <a:srgbClr val="B7B7DB"/>
                 </a:solidFill>
                 <a:latin typeface="Calibri" pitchFamily="34" charset="0"/>
                 <a:ea typeface="Calibri" pitchFamily="34" charset="-122"/>
@@ -3650,7 +3756,7 @@
       </p:sp>
       <p:sp>
         <p:nvSpPr>
-          <p:cNvPr id="14" name="Text 12"/>
+          <p:cNvPr id="18" name="Text 14"/>
           <p:cNvSpPr/>
           <p:nvPr/>
         </p:nvSpPr>
@@ -3701,7 +3807,7 @@
     <p:bg>
       <p:bgPr>
         <a:solidFill>
-          <a:srgbClr val="FBFAF8"/>
+          <a:srgbClr val="FFFFFF"/>
         </a:solidFill>
       </p:bgPr>
     </p:bg>
@@ -3746,7 +3852,7 @@
             <a:r>
               <a:rPr lang="en-US" sz="2700" b="1" dirty="0">
                 <a:solidFill>
-                  <a:srgbClr val="1E2B4A"/>
+                  <a:srgbClr val="191970"/>
                 </a:solidFill>
                 <a:latin typeface="Calibri" pitchFamily="34" charset="0"/>
                 <a:ea typeface="Calibri" pitchFamily="34" charset="-122"/>
@@ -3817,13 +3923,13 @@
             </a:avLst>
           </a:prstGeom>
           <a:solidFill>
-            <a:srgbClr val="FFFFFF"/>
+            <a:srgbClr val="F4F5FA"/>
           </a:solidFill>
           <a:ln/>
           <a:effectLst>
             <a:outerShdw sx="100000" sy="100000" kx="0" ky="0" algn="bl" rotWithShape="0" blurRad="127000" dist="25400" dir="5400000">
-              <a:srgbClr val="1E2B4A">
-                <a:alpha val="13000"/>
+              <a:srgbClr val="13134F">
+                <a:alpha val="10000"/>
               </a:srgbClr>
             </a:outerShdw>
           </a:effectLst>
@@ -3844,7 +3950,7 @@
             <a:avLst/>
           </a:prstGeom>
           <a:solidFill>
-            <a:srgbClr val="41639E"/>
+            <a:srgbClr val="4444AD"/>
           </a:solidFill>
           <a:ln w="31750">
             <a:solidFill>
@@ -3854,7 +3960,7 @@
           </a:ln>
           <a:effectLst>
             <a:outerShdw sx="100000" sy="100000" kx="0" ky="0" algn="bl" rotWithShape="0" blurRad="127000" dist="25400" dir="5400000">
-              <a:srgbClr val="1E2B4A">
+              <a:srgbClr val="13134F">
                 <a:alpha val="18000"/>
               </a:srgbClr>
             </a:outerShdw>
@@ -3944,13 +4050,13 @@
             </a:avLst>
           </a:prstGeom>
           <a:solidFill>
-            <a:srgbClr val="FFFFFF"/>
+            <a:srgbClr val="F4F5FA"/>
           </a:solidFill>
           <a:ln/>
           <a:effectLst>
             <a:outerShdw sx="100000" sy="100000" kx="0" ky="0" algn="bl" rotWithShape="0" blurRad="127000" dist="25400" dir="5400000">
-              <a:srgbClr val="1E2B4A">
-                <a:alpha val="13000"/>
+              <a:srgbClr val="13134F">
+                <a:alpha val="10000"/>
               </a:srgbClr>
             </a:outerShdw>
           </a:effectLst>
@@ -3971,7 +4077,7 @@
             <a:avLst/>
           </a:prstGeom>
           <a:solidFill>
-            <a:srgbClr val="3E8C9A"/>
+            <a:srgbClr val="2A2A80"/>
           </a:solidFill>
           <a:ln w="31750">
             <a:solidFill>
@@ -3981,7 +4087,7 @@
           </a:ln>
           <a:effectLst>
             <a:outerShdw sx="100000" sy="100000" kx="0" ky="0" algn="bl" rotWithShape="0" blurRad="127000" dist="25400" dir="5400000">
-              <a:srgbClr val="1E2B4A">
+              <a:srgbClr val="13134F">
                 <a:alpha val="18000"/>
               </a:srgbClr>
             </a:outerShdw>
@@ -4071,13 +4177,13 @@
             </a:avLst>
           </a:prstGeom>
           <a:solidFill>
-            <a:srgbClr val="FFFFFF"/>
+            <a:srgbClr val="F4F5FA"/>
           </a:solidFill>
           <a:ln/>
           <a:effectLst>
             <a:outerShdw sx="100000" sy="100000" kx="0" ky="0" algn="bl" rotWithShape="0" blurRad="127000" dist="25400" dir="5400000">
-              <a:srgbClr val="1E2B4A">
-                <a:alpha val="13000"/>
+              <a:srgbClr val="13134F">
+                <a:alpha val="10000"/>
               </a:srgbClr>
             </a:outerShdw>
           </a:effectLst>
@@ -4098,7 +4204,7 @@
             <a:avLst/>
           </a:prstGeom>
           <a:solidFill>
-            <a:srgbClr val="41639E"/>
+            <a:srgbClr val="4444AD"/>
           </a:solidFill>
           <a:ln w="31750">
             <a:solidFill>
@@ -4108,7 +4214,7 @@
           </a:ln>
           <a:effectLst>
             <a:outerShdw sx="100000" sy="100000" kx="0" ky="0" algn="bl" rotWithShape="0" blurRad="127000" dist="25400" dir="5400000">
-              <a:srgbClr val="1E2B4A">
+              <a:srgbClr val="13134F">
                 <a:alpha val="18000"/>
               </a:srgbClr>
             </a:outerShdw>
@@ -4198,13 +4304,13 @@
             </a:avLst>
           </a:prstGeom>
           <a:solidFill>
-            <a:srgbClr val="FFFFFF"/>
+            <a:srgbClr val="F4F5FA"/>
           </a:solidFill>
           <a:ln/>
           <a:effectLst>
             <a:outerShdw sx="100000" sy="100000" kx="0" ky="0" algn="bl" rotWithShape="0" blurRad="127000" dist="25400" dir="5400000">
-              <a:srgbClr val="1E2B4A">
-                <a:alpha val="13000"/>
+              <a:srgbClr val="13134F">
+                <a:alpha val="10000"/>
               </a:srgbClr>
             </a:outerShdw>
           </a:effectLst>
@@ -4235,7 +4341,7 @@
           </a:ln>
           <a:effectLst>
             <a:outerShdw sx="100000" sy="100000" kx="0" ky="0" algn="bl" rotWithShape="0" blurRad="127000" dist="25400" dir="5400000">
-              <a:srgbClr val="1E2B4A">
+              <a:srgbClr val="13134F">
                 <a:alpha val="18000"/>
               </a:srgbClr>
             </a:outerShdw>
@@ -4325,13 +4431,13 @@
             </a:avLst>
           </a:prstGeom>
           <a:solidFill>
-            <a:srgbClr val="FFFFFF"/>
+            <a:srgbClr val="F4F5FA"/>
           </a:solidFill>
           <a:ln/>
           <a:effectLst>
             <a:outerShdw sx="100000" sy="100000" kx="0" ky="0" algn="bl" rotWithShape="0" blurRad="127000" dist="25400" dir="5400000">
-              <a:srgbClr val="1E2B4A">
-                <a:alpha val="13000"/>
+              <a:srgbClr val="13134F">
+                <a:alpha val="10000"/>
               </a:srgbClr>
             </a:outerShdw>
           </a:effectLst>
@@ -4352,7 +4458,7 @@
             <a:avLst/>
           </a:prstGeom>
           <a:solidFill>
-            <a:srgbClr val="C98A24"/>
+            <a:srgbClr val="6E6ECB"/>
           </a:solidFill>
           <a:ln w="31750">
             <a:solidFill>
@@ -4362,7 +4468,7 @@
           </a:ln>
           <a:effectLst>
             <a:outerShdw sx="100000" sy="100000" kx="0" ky="0" algn="bl" rotWithShape="0" blurRad="127000" dist="25400" dir="5400000">
-              <a:srgbClr val="1E2B4A">
+              <a:srgbClr val="13134F">
                 <a:alpha val="18000"/>
               </a:srgbClr>
             </a:outerShdw>
@@ -4452,13 +4558,13 @@
             </a:avLst>
           </a:prstGeom>
           <a:solidFill>
-            <a:srgbClr val="FFFFFF"/>
+            <a:srgbClr val="F4F5FA"/>
           </a:solidFill>
           <a:ln/>
           <a:effectLst>
             <a:outerShdw sx="100000" sy="100000" kx="0" ky="0" algn="bl" rotWithShape="0" blurRad="127000" dist="25400" dir="5400000">
-              <a:srgbClr val="1E2B4A">
-                <a:alpha val="13000"/>
+              <a:srgbClr val="13134F">
+                <a:alpha val="10000"/>
               </a:srgbClr>
             </a:outerShdw>
           </a:effectLst>
@@ -4479,7 +4585,7 @@
             <a:avLst/>
           </a:prstGeom>
           <a:solidFill>
-            <a:srgbClr val="3E8C9A"/>
+            <a:srgbClr val="2A2A80"/>
           </a:solidFill>
           <a:ln w="31750">
             <a:solidFill>
@@ -4489,7 +4595,7 @@
           </a:ln>
           <a:effectLst>
             <a:outerShdw sx="100000" sy="100000" kx="0" ky="0" algn="bl" rotWithShape="0" blurRad="127000" dist="25400" dir="5400000">
-              <a:srgbClr val="1E2B4A">
+              <a:srgbClr val="13134F">
                 <a:alpha val="18000"/>
               </a:srgbClr>
             </a:outerShdw>
@@ -4579,13 +4685,13 @@
             </a:avLst>
           </a:prstGeom>
           <a:solidFill>
-            <a:srgbClr val="FFFFFF"/>
+            <a:srgbClr val="F4F5FA"/>
           </a:solidFill>
           <a:ln/>
           <a:effectLst>
             <a:outerShdw sx="100000" sy="100000" kx="0" ky="0" algn="bl" rotWithShape="0" blurRad="127000" dist="25400" dir="5400000">
-              <a:srgbClr val="1E2B4A">
-                <a:alpha val="13000"/>
+              <a:srgbClr val="13134F">
+                <a:alpha val="10000"/>
               </a:srgbClr>
             </a:outerShdw>
           </a:effectLst>
@@ -4606,7 +4712,7 @@
             <a:avLst/>
           </a:prstGeom>
           <a:solidFill>
-            <a:srgbClr val="41639E"/>
+            <a:srgbClr val="4444AD"/>
           </a:solidFill>
           <a:ln w="31750">
             <a:solidFill>
@@ -4616,7 +4722,7 @@
           </a:ln>
           <a:effectLst>
             <a:outerShdw sx="100000" sy="100000" kx="0" ky="0" algn="bl" rotWithShape="0" blurRad="127000" dist="25400" dir="5400000">
-              <a:srgbClr val="1E2B4A">
+              <a:srgbClr val="13134F">
                 <a:alpha val="18000"/>
               </a:srgbClr>
             </a:outerShdw>
@@ -4706,13 +4812,13 @@
             </a:avLst>
           </a:prstGeom>
           <a:solidFill>
-            <a:srgbClr val="FFFFFF"/>
+            <a:srgbClr val="F4F5FA"/>
           </a:solidFill>
           <a:ln/>
           <a:effectLst>
             <a:outerShdw sx="100000" sy="100000" kx="0" ky="0" algn="bl" rotWithShape="0" blurRad="127000" dist="25400" dir="5400000">
-              <a:srgbClr val="1E2B4A">
-                <a:alpha val="13000"/>
+              <a:srgbClr val="13134F">
+                <a:alpha val="10000"/>
               </a:srgbClr>
             </a:outerShdw>
           </a:effectLst>
@@ -4836,13 +4942,13 @@
             </a:avLst>
           </a:prstGeom>
           <a:solidFill>
-            <a:srgbClr val="FFFFFF"/>
+            <a:srgbClr val="F4F5FA"/>
           </a:solidFill>
           <a:ln/>
           <a:effectLst>
             <a:outerShdw sx="100000" sy="100000" kx="0" ky="0" algn="bl" rotWithShape="0" blurRad="127000" dist="25400" dir="5400000">
-              <a:srgbClr val="1E2B4A">
-                <a:alpha val="13000"/>
+              <a:srgbClr val="13134F">
+                <a:alpha val="10000"/>
               </a:srgbClr>
             </a:outerShdw>
           </a:effectLst>
@@ -5210,8 +5316,8 @@
         </p:nvSpPr>
         <p:spPr>
           <a:xfrm>
-            <a:off x="10972800" y="6455664"/>
-            <a:ext cx="685800" cy="237744"/>
+            <a:off x="10881360" y="6455664"/>
+            <a:ext cx="365760" cy="237744"/>
           </a:xfrm>
           <a:prstGeom prst="rect">
             <a:avLst/>
@@ -5241,6 +5347,30 @@
           </a:p>
         </p:txBody>
       </p:sp>
+      <p:pic>
+        <p:nvPicPr>
+          <p:cNvPr id="46" name="Image 7" descr="logos/logo_ensae_new.png">    </p:cNvPr>
+          <p:cNvPicPr>
+            <a:picLocks noChangeAspect="1"/>
+          </p:cNvPicPr>
+          <p:nvPr/>
+        </p:nvPicPr>
+        <p:blipFill>
+          <a:blip r:embed="rId8"/>
+          <a:stretch>
+            <a:fillRect/>
+          </a:stretch>
+        </p:blipFill>
+        <p:spPr>
+          <a:xfrm>
+            <a:off x="11384280" y="6355080"/>
+            <a:ext cx="384048" cy="384048"/>
+          </a:xfrm>
+          <a:prstGeom prst="rect">
+            <a:avLst/>
+          </a:prstGeom>
+        </p:spPr>
+      </p:pic>
     </p:spTree>
   </p:cSld>
   <p:clrMapOvr>
@@ -5255,7 +5385,7 @@
     <p:bg>
       <p:bgPr>
         <a:solidFill>
-          <a:srgbClr val="FBFAF8"/>
+          <a:srgbClr val="FFFFFF"/>
         </a:solidFill>
       </p:bgPr>
     </p:bg>
@@ -5300,7 +5430,7 @@
             <a:r>
               <a:rPr lang="en-US" sz="2700" b="1" dirty="0">
                 <a:solidFill>
-                  <a:srgbClr val="1E2B4A"/>
+                  <a:srgbClr val="191970"/>
                 </a:solidFill>
                 <a:latin typeface="Calibri" pitchFamily="34" charset="0"/>
                 <a:ea typeface="Calibri" pitchFamily="34" charset="-122"/>
@@ -5371,13 +5501,13 @@
             </a:avLst>
           </a:prstGeom>
           <a:solidFill>
-            <a:srgbClr val="FFFFFF"/>
+            <a:srgbClr val="F4F5FA"/>
           </a:solidFill>
           <a:ln/>
           <a:effectLst>
             <a:outerShdw sx="100000" sy="100000" kx="0" ky="0" algn="bl" rotWithShape="0" blurRad="127000" dist="25400" dir="5400000">
-              <a:srgbClr val="1E2B4A">
-                <a:alpha val="13000"/>
+              <a:srgbClr val="13134F">
+                <a:alpha val="10000"/>
               </a:srgbClr>
             </a:outerShdw>
           </a:effectLst>
@@ -5410,7 +5540,7 @@
             <a:r>
               <a:rPr lang="en-US" sz="3200" b="1" dirty="0">
                 <a:solidFill>
-                  <a:srgbClr val="41639E"/>
+                  <a:srgbClr val="4444AD"/>
                 </a:solidFill>
                 <a:latin typeface="Calibri" pitchFamily="34" charset="0"/>
                 <a:ea typeface="Calibri" pitchFamily="34" charset="-122"/>
@@ -5501,13 +5631,13 @@
             </a:avLst>
           </a:prstGeom>
           <a:solidFill>
-            <a:srgbClr val="FFFFFF"/>
+            <a:srgbClr val="F4F5FA"/>
           </a:solidFill>
           <a:ln/>
           <a:effectLst>
             <a:outerShdw sx="100000" sy="100000" kx="0" ky="0" algn="bl" rotWithShape="0" blurRad="127000" dist="25400" dir="5400000">
-              <a:srgbClr val="1E2B4A">
-                <a:alpha val="13000"/>
+              <a:srgbClr val="13134F">
+                <a:alpha val="10000"/>
               </a:srgbClr>
             </a:outerShdw>
           </a:effectLst>
@@ -5540,7 +5670,7 @@
             <a:r>
               <a:rPr lang="en-US" sz="3200" b="1" dirty="0">
                 <a:solidFill>
-                  <a:srgbClr val="41639E"/>
+                  <a:srgbClr val="4444AD"/>
                 </a:solidFill>
                 <a:latin typeface="Calibri" pitchFamily="34" charset="0"/>
                 <a:ea typeface="Calibri" pitchFamily="34" charset="-122"/>
@@ -5631,13 +5761,13 @@
             </a:avLst>
           </a:prstGeom>
           <a:solidFill>
-            <a:srgbClr val="FFFFFF"/>
+            <a:srgbClr val="F4F5FA"/>
           </a:solidFill>
           <a:ln/>
           <a:effectLst>
             <a:outerShdw sx="100000" sy="100000" kx="0" ky="0" algn="bl" rotWithShape="0" blurRad="127000" dist="25400" dir="5400000">
-              <a:srgbClr val="1E2B4A">
-                <a:alpha val="13000"/>
+              <a:srgbClr val="13134F">
+                <a:alpha val="10000"/>
               </a:srgbClr>
             </a:outerShdw>
           </a:effectLst>
@@ -5761,13 +5891,13 @@
             </a:avLst>
           </a:prstGeom>
           <a:solidFill>
-            <a:srgbClr val="FFFFFF"/>
+            <a:srgbClr val="F4F5FA"/>
           </a:solidFill>
           <a:ln/>
           <a:effectLst>
             <a:outerShdw sx="100000" sy="100000" kx="0" ky="0" algn="bl" rotWithShape="0" blurRad="127000" dist="25400" dir="5400000">
-              <a:srgbClr val="1E2B4A">
-                <a:alpha val="13000"/>
+              <a:srgbClr val="13134F">
+                <a:alpha val="10000"/>
               </a:srgbClr>
             </a:outerShdw>
           </a:effectLst>
@@ -5891,13 +6021,13 @@
             </a:avLst>
           </a:prstGeom>
           <a:solidFill>
-            <a:srgbClr val="FFFFFF"/>
+            <a:srgbClr val="F4F5FA"/>
           </a:solidFill>
           <a:ln/>
           <a:effectLst>
             <a:outerShdw sx="100000" sy="100000" kx="0" ky="0" algn="bl" rotWithShape="0" blurRad="127000" dist="25400" dir="5400000">
-              <a:srgbClr val="1E2B4A">
-                <a:alpha val="13000"/>
+              <a:srgbClr val="13134F">
+                <a:alpha val="10000"/>
               </a:srgbClr>
             </a:outerShdw>
           </a:effectLst>
@@ -5918,7 +6048,7 @@
             <a:avLst/>
           </a:prstGeom>
           <a:solidFill>
-            <a:srgbClr val="3E8C9A"/>
+            <a:srgbClr val="2A2A80"/>
           </a:solidFill>
           <a:ln w="31750">
             <a:solidFill>
@@ -5928,7 +6058,7 @@
           </a:ln>
           <a:effectLst>
             <a:outerShdw sx="100000" sy="100000" kx="0" ky="0" algn="bl" rotWithShape="0" blurRad="127000" dist="25400" dir="5400000">
-              <a:srgbClr val="1E2B4A">
+              <a:srgbClr val="13134F">
                 <a:alpha val="18000"/>
               </a:srgbClr>
             </a:outerShdw>
@@ -6057,13 +6187,13 @@
             </a:avLst>
           </a:prstGeom>
           <a:solidFill>
-            <a:srgbClr val="FFFFFF"/>
+            <a:srgbClr val="F4F5FA"/>
           </a:solidFill>
           <a:ln/>
           <a:effectLst>
             <a:outerShdw sx="100000" sy="100000" kx="0" ky="0" algn="bl" rotWithShape="0" blurRad="127000" dist="25400" dir="5400000">
-              <a:srgbClr val="1E2B4A">
-                <a:alpha val="13000"/>
+              <a:srgbClr val="13134F">
+                <a:alpha val="10000"/>
               </a:srgbClr>
             </a:outerShdw>
           </a:effectLst>
@@ -6084,7 +6214,7 @@
             <a:avLst/>
           </a:prstGeom>
           <a:solidFill>
-            <a:srgbClr val="C98A24"/>
+            <a:srgbClr val="6E6ECB"/>
           </a:solidFill>
           <a:ln w="31750">
             <a:solidFill>
@@ -6094,7 +6224,7 @@
           </a:ln>
           <a:effectLst>
             <a:outerShdw sx="100000" sy="100000" kx="0" ky="0" algn="bl" rotWithShape="0" blurRad="127000" dist="25400" dir="5400000">
-              <a:srgbClr val="1E2B4A">
+              <a:srgbClr val="13134F">
                 <a:alpha val="18000"/>
               </a:srgbClr>
             </a:outerShdw>
@@ -6220,7 +6350,7 @@
             </a:avLst>
           </a:prstGeom>
           <a:solidFill>
-            <a:srgbClr val="C98A24"/>
+            <a:srgbClr val="6E6ECB"/>
           </a:solidFill>
           <a:ln/>
         </p:spPr>
@@ -6320,7 +6450,7 @@
             </a:avLst>
           </a:prstGeom>
           <a:solidFill>
-            <a:srgbClr val="E8EBF0"/>
+            <a:srgbClr val="E2E3EC"/>
           </a:solidFill>
           <a:ln/>
         </p:spPr>
@@ -6420,7 +6550,7 @@
             </a:avLst>
           </a:prstGeom>
           <a:solidFill>
-            <a:srgbClr val="E8EBF0"/>
+            <a:srgbClr val="E2E3EC"/>
           </a:solidFill>
           <a:ln/>
         </p:spPr>
@@ -6520,7 +6650,7 @@
             </a:avLst>
           </a:prstGeom>
           <a:solidFill>
-            <a:srgbClr val="E8EBF0"/>
+            <a:srgbClr val="E2E3EC"/>
           </a:solidFill>
           <a:ln/>
         </p:spPr>
@@ -6611,8 +6741,8 @@
         </p:nvSpPr>
         <p:spPr>
           <a:xfrm>
-            <a:off x="10972800" y="6455664"/>
-            <a:ext cx="685800" cy="237744"/>
+            <a:off x="10881360" y="6455664"/>
+            <a:ext cx="365760" cy="237744"/>
           </a:xfrm>
           <a:prstGeom prst="rect">
             <a:avLst/>
@@ -6642,6 +6772,30 @@
           </a:p>
         </p:txBody>
       </p:sp>
+      <p:pic>
+        <p:nvPicPr>
+          <p:cNvPr id="39" name="Image 2" descr="logos/logo_ensae_new.png">    </p:cNvPr>
+          <p:cNvPicPr>
+            <a:picLocks noChangeAspect="1"/>
+          </p:cNvPicPr>
+          <p:nvPr/>
+        </p:nvPicPr>
+        <p:blipFill>
+          <a:blip r:embed="rId3"/>
+          <a:stretch>
+            <a:fillRect/>
+          </a:stretch>
+        </p:blipFill>
+        <p:spPr>
+          <a:xfrm>
+            <a:off x="11384280" y="6355080"/>
+            <a:ext cx="384048" cy="384048"/>
+          </a:xfrm>
+          <a:prstGeom prst="rect">
+            <a:avLst/>
+          </a:prstGeom>
+        </p:spPr>
+      </p:pic>
     </p:spTree>
   </p:cSld>
   <p:clrMapOvr>
@@ -6656,7 +6810,7 @@
     <p:bg>
       <p:bgPr>
         <a:solidFill>
-          <a:srgbClr val="FBFAF8"/>
+          <a:srgbClr val="FFFFFF"/>
         </a:solidFill>
       </p:bgPr>
     </p:bg>
@@ -6701,7 +6855,7 @@
             <a:r>
               <a:rPr lang="en-US" sz="2700" b="1" dirty="0">
                 <a:solidFill>
-                  <a:srgbClr val="1E2B4A"/>
+                  <a:srgbClr val="191970"/>
                 </a:solidFill>
                 <a:latin typeface="Calibri" pitchFamily="34" charset="0"/>
                 <a:ea typeface="Calibri" pitchFamily="34" charset="-122"/>
@@ -6772,13 +6926,13 @@
             </a:avLst>
           </a:prstGeom>
           <a:solidFill>
-            <a:srgbClr val="FFFFFF"/>
+            <a:srgbClr val="F4F5FA"/>
           </a:solidFill>
           <a:ln/>
           <a:effectLst>
             <a:outerShdw sx="100000" sy="100000" kx="0" ky="0" algn="bl" rotWithShape="0" blurRad="127000" dist="25400" dir="5400000">
-              <a:srgbClr val="1E2B4A">
-                <a:alpha val="13000"/>
+              <a:srgbClr val="13134F">
+                <a:alpha val="10000"/>
               </a:srgbClr>
             </a:outerShdw>
           </a:effectLst>
@@ -6799,7 +6953,7 @@
             <a:avLst/>
           </a:prstGeom>
           <a:solidFill>
-            <a:srgbClr val="41639E"/>
+            <a:srgbClr val="4444AD"/>
           </a:solidFill>
           <a:ln w="31750">
             <a:solidFill>
@@ -6809,7 +6963,7 @@
           </a:ln>
           <a:effectLst>
             <a:outerShdw sx="100000" sy="100000" kx="0" ky="0" algn="bl" rotWithShape="0" blurRad="127000" dist="25400" dir="5400000">
-              <a:srgbClr val="1E2B4A">
+              <a:srgbClr val="13134F">
                 <a:alpha val="18000"/>
               </a:srgbClr>
             </a:outerShdw>
@@ -6867,7 +7021,7 @@
             <a:r>
               <a:rPr lang="en-US" sz="3400" b="1" dirty="0">
                 <a:solidFill>
-                  <a:srgbClr val="E8EBF0"/>
+                  <a:srgbClr val="E2E3EC"/>
                 </a:solidFill>
                 <a:latin typeface="Calibri" pitchFamily="34" charset="0"/>
                 <a:ea typeface="Calibri" pitchFamily="34" charset="-122"/>
@@ -6977,13 +7131,13 @@
             </a:avLst>
           </a:prstGeom>
           <a:solidFill>
-            <a:srgbClr val="FFFFFF"/>
+            <a:srgbClr val="F4F5FA"/>
           </a:solidFill>
           <a:ln/>
           <a:effectLst>
             <a:outerShdw sx="100000" sy="100000" kx="0" ky="0" algn="bl" rotWithShape="0" blurRad="127000" dist="25400" dir="5400000">
-              <a:srgbClr val="1E2B4A">
-                <a:alpha val="13000"/>
+              <a:srgbClr val="13134F">
+                <a:alpha val="10000"/>
               </a:srgbClr>
             </a:outerShdw>
           </a:effectLst>
@@ -7004,7 +7158,7 @@
             <a:avLst/>
           </a:prstGeom>
           <a:solidFill>
-            <a:srgbClr val="3E8C9A"/>
+            <a:srgbClr val="2A2A80"/>
           </a:solidFill>
           <a:ln w="31750">
             <a:solidFill>
@@ -7014,7 +7168,7 @@
           </a:ln>
           <a:effectLst>
             <a:outerShdw sx="100000" sy="100000" kx="0" ky="0" algn="bl" rotWithShape="0" blurRad="127000" dist="25400" dir="5400000">
-              <a:srgbClr val="1E2B4A">
+              <a:srgbClr val="13134F">
                 <a:alpha val="18000"/>
               </a:srgbClr>
             </a:outerShdw>
@@ -7072,7 +7226,7 @@
             <a:r>
               <a:rPr lang="en-US" sz="3400" b="1" dirty="0">
                 <a:solidFill>
-                  <a:srgbClr val="E8EBF0"/>
+                  <a:srgbClr val="E2E3EC"/>
                 </a:solidFill>
                 <a:latin typeface="Calibri" pitchFamily="34" charset="0"/>
                 <a:ea typeface="Calibri" pitchFamily="34" charset="-122"/>
@@ -7182,13 +7336,13 @@
             </a:avLst>
           </a:prstGeom>
           <a:solidFill>
-            <a:srgbClr val="FFFFFF"/>
+            <a:srgbClr val="F4F5FA"/>
           </a:solidFill>
           <a:ln/>
           <a:effectLst>
             <a:outerShdw sx="100000" sy="100000" kx="0" ky="0" algn="bl" rotWithShape="0" blurRad="127000" dist="25400" dir="5400000">
-              <a:srgbClr val="1E2B4A">
-                <a:alpha val="13000"/>
+              <a:srgbClr val="13134F">
+                <a:alpha val="10000"/>
               </a:srgbClr>
             </a:outerShdw>
           </a:effectLst>
@@ -7219,7 +7373,7 @@
           </a:ln>
           <a:effectLst>
             <a:outerShdw sx="100000" sy="100000" kx="0" ky="0" algn="bl" rotWithShape="0" blurRad="127000" dist="25400" dir="5400000">
-              <a:srgbClr val="1E2B4A">
+              <a:srgbClr val="13134F">
                 <a:alpha val="18000"/>
               </a:srgbClr>
             </a:outerShdw>
@@ -7277,7 +7431,7 @@
             <a:r>
               <a:rPr lang="en-US" sz="3400" b="1" dirty="0">
                 <a:solidFill>
-                  <a:srgbClr val="E8EBF0"/>
+                  <a:srgbClr val="E2E3EC"/>
                 </a:solidFill>
                 <a:latin typeface="Calibri" pitchFamily="34" charset="0"/>
                 <a:ea typeface="Calibri" pitchFamily="34" charset="-122"/>
@@ -7387,13 +7541,13 @@
             </a:avLst>
           </a:prstGeom>
           <a:solidFill>
-            <a:srgbClr val="1E2B4A"/>
+            <a:srgbClr val="191970"/>
           </a:solidFill>
           <a:ln/>
           <a:effectLst>
             <a:outerShdw sx="100000" sy="100000" kx="0" ky="0" algn="bl" rotWithShape="0" blurRad="127000" dist="25400" dir="5400000">
-              <a:srgbClr val="1E2B4A">
-                <a:alpha val="13000"/>
+              <a:srgbClr val="13134F">
+                <a:alpha val="10000"/>
               </a:srgbClr>
             </a:outerShdw>
           </a:effectLst>
@@ -7449,8 +7603,8 @@
         </p:nvSpPr>
         <p:spPr>
           <a:xfrm>
-            <a:off x="10972800" y="6455664"/>
-            <a:ext cx="685800" cy="237744"/>
+            <a:off x="10881360" y="6455664"/>
+            <a:ext cx="365760" cy="237744"/>
           </a:xfrm>
           <a:prstGeom prst="rect">
             <a:avLst/>
@@ -7480,6 +7634,30 @@
           </a:p>
         </p:txBody>
       </p:sp>
+      <p:pic>
+        <p:nvPicPr>
+          <p:cNvPr id="25" name="Image 3" descr="logos/logo_ensae_new.png">    </p:cNvPr>
+          <p:cNvPicPr>
+            <a:picLocks noChangeAspect="1"/>
+          </p:cNvPicPr>
+          <p:nvPr/>
+        </p:nvPicPr>
+        <p:blipFill>
+          <a:blip r:embed="rId4"/>
+          <a:stretch>
+            <a:fillRect/>
+          </a:stretch>
+        </p:blipFill>
+        <p:spPr>
+          <a:xfrm>
+            <a:off x="11384280" y="6355080"/>
+            <a:ext cx="384048" cy="384048"/>
+          </a:xfrm>
+          <a:prstGeom prst="rect">
+            <a:avLst/>
+          </a:prstGeom>
+        </p:spPr>
+      </p:pic>
     </p:spTree>
   </p:cSld>
   <p:clrMapOvr>
@@ -7494,7 +7672,7 @@
     <p:bg>
       <p:bgPr>
         <a:solidFill>
-          <a:srgbClr val="16213D"/>
+          <a:srgbClr val="101038"/>
         </a:solidFill>
       </p:bgPr>
     </p:bg>
@@ -7527,7 +7705,7 @@
             <a:avLst/>
           </a:prstGeom>
           <a:solidFill>
-            <a:srgbClr val="24365E"/>
+            <a:srgbClr val="23236B"/>
           </a:solidFill>
           <a:ln/>
         </p:spPr>
@@ -7547,7 +7725,7 @@
             <a:avLst/>
           </a:prstGeom>
           <a:solidFill>
-            <a:srgbClr val="24365E"/>
+            <a:srgbClr val="23236B"/>
           </a:solidFill>
           <a:ln/>
         </p:spPr>
@@ -7660,7 +7838,7 @@
             <a:r>
               <a:rPr lang="en-US" sz="1400" dirty="0">
                 <a:solidFill>
-                  <a:srgbClr val="AFC0DA"/>
+                  <a:srgbClr val="B7B7DB"/>
                 </a:solidFill>
                 <a:latin typeface="Calibri" pitchFamily="34" charset="0"/>
                 <a:ea typeface="Calibri" pitchFamily="34" charset="-122"/>
@@ -7686,7 +7864,7 @@
     <p:bg>
       <p:bgPr>
         <a:solidFill>
-          <a:srgbClr val="FBFAF8"/>
+          <a:srgbClr val="FFFFFF"/>
         </a:solidFill>
       </p:bgPr>
     </p:bg>
@@ -7731,7 +7909,7 @@
             <a:r>
               <a:rPr lang="en-US" sz="2700" b="1" dirty="0">
                 <a:solidFill>
-                  <a:srgbClr val="1E2B4A"/>
+                  <a:srgbClr val="191970"/>
                 </a:solidFill>
                 <a:latin typeface="Calibri" pitchFamily="34" charset="0"/>
                 <a:ea typeface="Calibri" pitchFamily="34" charset="-122"/>
@@ -7802,13 +7980,13 @@
             </a:avLst>
           </a:prstGeom>
           <a:solidFill>
-            <a:srgbClr val="FFFFFF"/>
+            <a:srgbClr val="F4F5FA"/>
           </a:solidFill>
           <a:ln/>
           <a:effectLst>
             <a:outerShdw sx="100000" sy="100000" kx="0" ky="0" algn="bl" rotWithShape="0" blurRad="127000" dist="25400" dir="5400000">
-              <a:srgbClr val="1E2B4A">
-                <a:alpha val="13000"/>
+              <a:srgbClr val="13134F">
+                <a:alpha val="10000"/>
               </a:srgbClr>
             </a:outerShdw>
           </a:effectLst>
@@ -8013,7 +8191,7 @@
             <a:avLst/>
           </a:prstGeom>
           <a:solidFill>
-            <a:srgbClr val="E8EBF0"/>
+            <a:srgbClr val="E2E3EC"/>
           </a:solidFill>
           <a:ln/>
         </p:spPr>
@@ -8084,7 +8262,7 @@
             <a:r>
               <a:rPr lang="en-US" sz="1500" b="1" dirty="0">
                 <a:solidFill>
-                  <a:srgbClr val="1E2B4A"/>
+                  <a:srgbClr val="191970"/>
                 </a:solidFill>
                 <a:latin typeface="Calibri" pitchFamily="34" charset="0"/>
                 <a:ea typeface="Calibri" pitchFamily="34" charset="-122"/>
@@ -8123,7 +8301,7 @@
             <a:r>
               <a:rPr lang="en-US" sz="1500" b="1" dirty="0">
                 <a:solidFill>
-                  <a:srgbClr val="1E2B4A"/>
+                  <a:srgbClr val="191970"/>
                 </a:solidFill>
                 <a:latin typeface="Calibri" pitchFamily="34" charset="0"/>
                 <a:ea typeface="Calibri" pitchFamily="34" charset="-122"/>
@@ -8189,7 +8367,7 @@
             <a:avLst/>
           </a:prstGeom>
           <a:solidFill>
-            <a:srgbClr val="E8EBF0"/>
+            <a:srgbClr val="E2E3EC"/>
           </a:solidFill>
           <a:ln/>
         </p:spPr>
@@ -8260,7 +8438,7 @@
             <a:r>
               <a:rPr lang="en-US" sz="1500" b="1" dirty="0">
                 <a:solidFill>
-                  <a:srgbClr val="1E2B4A"/>
+                  <a:srgbClr val="191970"/>
                 </a:solidFill>
                 <a:latin typeface="Calibri" pitchFamily="34" charset="0"/>
                 <a:ea typeface="Calibri" pitchFamily="34" charset="-122"/>
@@ -8299,7 +8477,7 @@
             <a:r>
               <a:rPr lang="en-US" sz="1500" b="1" dirty="0">
                 <a:solidFill>
-                  <a:srgbClr val="1E2B4A"/>
+                  <a:srgbClr val="191970"/>
                 </a:solidFill>
                 <a:latin typeface="Calibri" pitchFamily="34" charset="0"/>
                 <a:ea typeface="Calibri" pitchFamily="34" charset="-122"/>
@@ -8365,7 +8543,7 @@
             <a:avLst/>
           </a:prstGeom>
           <a:solidFill>
-            <a:srgbClr val="E8EBF0"/>
+            <a:srgbClr val="E2E3EC"/>
           </a:solidFill>
           <a:ln/>
         </p:spPr>
@@ -8436,7 +8614,7 @@
             <a:r>
               <a:rPr lang="en-US" sz="1500" b="1" dirty="0">
                 <a:solidFill>
-                  <a:srgbClr val="1E2B4A"/>
+                  <a:srgbClr val="191970"/>
                 </a:solidFill>
                 <a:latin typeface="Calibri" pitchFamily="34" charset="0"/>
                 <a:ea typeface="Calibri" pitchFamily="34" charset="-122"/>
@@ -8475,7 +8653,7 @@
             <a:r>
               <a:rPr lang="en-US" sz="1500" b="1" dirty="0">
                 <a:solidFill>
-                  <a:srgbClr val="1E2B4A"/>
+                  <a:srgbClr val="191970"/>
                 </a:solidFill>
                 <a:latin typeface="Calibri" pitchFamily="34" charset="0"/>
                 <a:ea typeface="Calibri" pitchFamily="34" charset="-122"/>
@@ -8585,13 +8763,13 @@
             </a:avLst>
           </a:prstGeom>
           <a:solidFill>
-            <a:srgbClr val="FFFFFF"/>
+            <a:srgbClr val="F4F5FA"/>
           </a:solidFill>
           <a:ln/>
           <a:effectLst>
             <a:outerShdw sx="100000" sy="100000" kx="0" ky="0" algn="bl" rotWithShape="0" blurRad="127000" dist="25400" dir="5400000">
-              <a:srgbClr val="1E2B4A">
-                <a:alpha val="13000"/>
+              <a:srgbClr val="13134F">
+                <a:alpha val="10000"/>
               </a:srgbClr>
             </a:outerShdw>
           </a:effectLst>
@@ -8731,7 +8909,7 @@
             </a:avLst>
           </a:prstGeom>
           <a:solidFill>
-            <a:srgbClr val="41639E"/>
+            <a:srgbClr val="4444AD"/>
           </a:solidFill>
           <a:ln/>
         </p:spPr>
@@ -8831,7 +9009,7 @@
             </a:avLst>
           </a:prstGeom>
           <a:solidFill>
-            <a:srgbClr val="41639E"/>
+            <a:srgbClr val="4444AD"/>
           </a:solidFill>
           <a:ln/>
         </p:spPr>
@@ -9203,8 +9381,8 @@
         </p:nvSpPr>
         <p:spPr>
           <a:xfrm>
-            <a:off x="10972800" y="6455664"/>
-            <a:ext cx="685800" cy="237744"/>
+            <a:off x="10881360" y="6455664"/>
+            <a:ext cx="365760" cy="237744"/>
           </a:xfrm>
           <a:prstGeom prst="rect">
             <a:avLst/>
@@ -9234,6 +9412,30 @@
           </a:p>
         </p:txBody>
       </p:sp>
+      <p:pic>
+        <p:nvPicPr>
+          <p:cNvPr id="45" name="Image 0" descr="logos/logo_ensae_new.png">    </p:cNvPr>
+          <p:cNvPicPr>
+            <a:picLocks noChangeAspect="1"/>
+          </p:cNvPicPr>
+          <p:nvPr/>
+        </p:nvPicPr>
+        <p:blipFill>
+          <a:blip r:embed="rId1"/>
+          <a:stretch>
+            <a:fillRect/>
+          </a:stretch>
+        </p:blipFill>
+        <p:spPr>
+          <a:xfrm>
+            <a:off x="11384280" y="6355080"/>
+            <a:ext cx="384048" cy="384048"/>
+          </a:xfrm>
+          <a:prstGeom prst="rect">
+            <a:avLst/>
+          </a:prstGeom>
+        </p:spPr>
+      </p:pic>
     </p:spTree>
   </p:cSld>
   <p:clrMapOvr>
@@ -9248,7 +9450,7 @@
     <p:bg>
       <p:bgPr>
         <a:solidFill>
-          <a:srgbClr val="FBFAF8"/>
+          <a:srgbClr val="FFFFFF"/>
         </a:solidFill>
       </p:bgPr>
     </p:bg>
@@ -9293,7 +9495,7 @@
             <a:r>
               <a:rPr lang="en-US" sz="2700" b="1" dirty="0">
                 <a:solidFill>
-                  <a:srgbClr val="1E2B4A"/>
+                  <a:srgbClr val="191970"/>
                 </a:solidFill>
                 <a:latin typeface="Calibri" pitchFamily="34" charset="0"/>
                 <a:ea typeface="Calibri" pitchFamily="34" charset="-122"/>
@@ -9364,13 +9566,13 @@
             </a:avLst>
           </a:prstGeom>
           <a:solidFill>
-            <a:srgbClr val="FFFFFF"/>
+            <a:srgbClr val="F4F5FA"/>
           </a:solidFill>
           <a:ln/>
           <a:effectLst>
             <a:outerShdw sx="100000" sy="100000" kx="0" ky="0" algn="bl" rotWithShape="0" blurRad="127000" dist="25400" dir="5400000">
-              <a:srgbClr val="1E2B4A">
-                <a:alpha val="13000"/>
+              <a:srgbClr val="13134F">
+                <a:alpha val="10000"/>
               </a:srgbClr>
             </a:outerShdw>
           </a:effectLst>
@@ -9494,13 +9696,13 @@
             </a:avLst>
           </a:prstGeom>
           <a:solidFill>
-            <a:srgbClr val="FFFFFF"/>
+            <a:srgbClr val="F4F5FA"/>
           </a:solidFill>
           <a:ln/>
           <a:effectLst>
             <a:outerShdw sx="100000" sy="100000" kx="0" ky="0" algn="bl" rotWithShape="0" blurRad="127000" dist="25400" dir="5400000">
-              <a:srgbClr val="1E2B4A">
-                <a:alpha val="13000"/>
+              <a:srgbClr val="13134F">
+                <a:alpha val="10000"/>
               </a:srgbClr>
             </a:outerShdw>
           </a:effectLst>
@@ -9533,7 +9735,7 @@
             <a:r>
               <a:rPr lang="en-US" sz="3000" b="1" dirty="0">
                 <a:solidFill>
-                  <a:srgbClr val="3E8C9A"/>
+                  <a:srgbClr val="2A2A80"/>
                 </a:solidFill>
                 <a:latin typeface="Calibri" pitchFamily="34" charset="0"/>
                 <a:ea typeface="Calibri" pitchFamily="34" charset="-122"/>
@@ -9624,13 +9826,13 @@
             </a:avLst>
           </a:prstGeom>
           <a:solidFill>
-            <a:srgbClr val="FFFFFF"/>
+            <a:srgbClr val="F4F5FA"/>
           </a:solidFill>
           <a:ln/>
           <a:effectLst>
             <a:outerShdw sx="100000" sy="100000" kx="0" ky="0" algn="bl" rotWithShape="0" blurRad="127000" dist="25400" dir="5400000">
-              <a:srgbClr val="1E2B4A">
-                <a:alpha val="13000"/>
+              <a:srgbClr val="13134F">
+                <a:alpha val="10000"/>
               </a:srgbClr>
             </a:outerShdw>
           </a:effectLst>
@@ -9663,7 +9865,7 @@
             <a:r>
               <a:rPr lang="en-US" sz="3000" b="1" dirty="0">
                 <a:solidFill>
-                  <a:srgbClr val="41639E"/>
+                  <a:srgbClr val="4444AD"/>
                 </a:solidFill>
                 <a:latin typeface="Calibri" pitchFamily="34" charset="0"/>
                 <a:ea typeface="Calibri" pitchFamily="34" charset="-122"/>
@@ -9754,13 +9956,13 @@
             </a:avLst>
           </a:prstGeom>
           <a:solidFill>
-            <a:srgbClr val="FFFFFF"/>
+            <a:srgbClr val="F4F5FA"/>
           </a:solidFill>
           <a:ln/>
           <a:effectLst>
             <a:outerShdw sx="100000" sy="100000" kx="0" ky="0" algn="bl" rotWithShape="0" blurRad="127000" dist="25400" dir="5400000">
-              <a:srgbClr val="1E2B4A">
-                <a:alpha val="13000"/>
+              <a:srgbClr val="13134F">
+                <a:alpha val="10000"/>
               </a:srgbClr>
             </a:outerShdw>
           </a:effectLst>
@@ -9793,7 +9995,7 @@
             <a:r>
               <a:rPr lang="en-US" sz="3000" b="1" dirty="0">
                 <a:solidFill>
-                  <a:srgbClr val="41639E"/>
+                  <a:srgbClr val="4444AD"/>
                 </a:solidFill>
                 <a:latin typeface="Calibri" pitchFamily="34" charset="0"/>
                 <a:ea typeface="Calibri" pitchFamily="34" charset="-122"/>
@@ -9884,13 +10086,13 @@
             </a:avLst>
           </a:prstGeom>
           <a:solidFill>
-            <a:srgbClr val="FFFFFF"/>
+            <a:srgbClr val="F4F5FA"/>
           </a:solidFill>
           <a:ln/>
           <a:effectLst>
             <a:outerShdw sx="100000" sy="100000" kx="0" ky="0" algn="bl" rotWithShape="0" blurRad="127000" dist="25400" dir="5400000">
-              <a:srgbClr val="1E2B4A">
-                <a:alpha val="13000"/>
+              <a:srgbClr val="13134F">
+                <a:alpha val="10000"/>
               </a:srgbClr>
             </a:outerShdw>
           </a:effectLst>
@@ -9991,7 +10193,7 @@
             </a:avLst>
           </a:prstGeom>
           <a:solidFill>
-            <a:srgbClr val="E8EBF0"/>
+            <a:srgbClr val="E2E3EC"/>
           </a:solidFill>
           <a:ln/>
         </p:spPr>
@@ -10013,7 +10215,7 @@
             </a:avLst>
           </a:prstGeom>
           <a:solidFill>
-            <a:srgbClr val="3E8C9A"/>
+            <a:srgbClr val="2A2A80"/>
           </a:solidFill>
           <a:ln/>
         </p:spPr>
@@ -10113,7 +10315,7 @@
             </a:avLst>
           </a:prstGeom>
           <a:solidFill>
-            <a:srgbClr val="E8EBF0"/>
+            <a:srgbClr val="E2E3EC"/>
           </a:solidFill>
           <a:ln/>
         </p:spPr>
@@ -10135,7 +10337,7 @@
             </a:avLst>
           </a:prstGeom>
           <a:solidFill>
-            <a:srgbClr val="3E8C9A"/>
+            <a:srgbClr val="2A2A80"/>
           </a:solidFill>
           <a:ln/>
         </p:spPr>
@@ -10235,7 +10437,7 @@
             </a:avLst>
           </a:prstGeom>
           <a:solidFill>
-            <a:srgbClr val="E8EBF0"/>
+            <a:srgbClr val="E2E3EC"/>
           </a:solidFill>
           <a:ln/>
         </p:spPr>
@@ -10257,7 +10459,7 @@
             </a:avLst>
           </a:prstGeom>
           <a:solidFill>
-            <a:srgbClr val="3E8C9A"/>
+            <a:srgbClr val="2A2A80"/>
           </a:solidFill>
           <a:ln/>
         </p:spPr>
@@ -10357,7 +10559,7 @@
             </a:avLst>
           </a:prstGeom>
           <a:solidFill>
-            <a:srgbClr val="E8EBF0"/>
+            <a:srgbClr val="E2E3EC"/>
           </a:solidFill>
           <a:ln/>
         </p:spPr>
@@ -10379,7 +10581,7 @@
             </a:avLst>
           </a:prstGeom>
           <a:solidFill>
-            <a:srgbClr val="3E8C9A"/>
+            <a:srgbClr val="2A2A80"/>
           </a:solidFill>
           <a:ln/>
         </p:spPr>
@@ -10479,7 +10681,7 @@
             </a:avLst>
           </a:prstGeom>
           <a:solidFill>
-            <a:srgbClr val="E8EBF0"/>
+            <a:srgbClr val="E2E3EC"/>
           </a:solidFill>
           <a:ln/>
         </p:spPr>
@@ -10501,7 +10703,7 @@
             </a:avLst>
           </a:prstGeom>
           <a:solidFill>
-            <a:srgbClr val="3E8C9A"/>
+            <a:srgbClr val="2A2A80"/>
           </a:solidFill>
           <a:ln/>
         </p:spPr>
@@ -10601,7 +10803,7 @@
             </a:avLst>
           </a:prstGeom>
           <a:solidFill>
-            <a:srgbClr val="E8EBF0"/>
+            <a:srgbClr val="E2E3EC"/>
           </a:solidFill>
           <a:ln/>
         </p:spPr>
@@ -10623,7 +10825,7 @@
             </a:avLst>
           </a:prstGeom>
           <a:solidFill>
-            <a:srgbClr val="3E8C9A"/>
+            <a:srgbClr val="2A2A80"/>
           </a:solidFill>
           <a:ln/>
         </p:spPr>
@@ -10714,8 +10916,8 @@
         </p:nvSpPr>
         <p:spPr>
           <a:xfrm>
-            <a:off x="10972800" y="6455664"/>
-            <a:ext cx="685800" cy="237744"/>
+            <a:off x="10881360" y="6455664"/>
+            <a:ext cx="365760" cy="237744"/>
           </a:xfrm>
           <a:prstGeom prst="rect">
             <a:avLst/>
@@ -10745,6 +10947,30 @@
           </a:p>
         </p:txBody>
       </p:sp>
+      <p:pic>
+        <p:nvPicPr>
+          <p:cNvPr id="44" name="Image 0" descr="logos/logo_ensae_new.png">    </p:cNvPr>
+          <p:cNvPicPr>
+            <a:picLocks noChangeAspect="1"/>
+          </p:cNvPicPr>
+          <p:nvPr/>
+        </p:nvPicPr>
+        <p:blipFill>
+          <a:blip r:embed="rId1"/>
+          <a:stretch>
+            <a:fillRect/>
+          </a:stretch>
+        </p:blipFill>
+        <p:spPr>
+          <a:xfrm>
+            <a:off x="11384280" y="6355080"/>
+            <a:ext cx="384048" cy="384048"/>
+          </a:xfrm>
+          <a:prstGeom prst="rect">
+            <a:avLst/>
+          </a:prstGeom>
+        </p:spPr>
+      </p:pic>
     </p:spTree>
   </p:cSld>
   <p:clrMapOvr>
@@ -10759,7 +10985,7 @@
     <p:bg>
       <p:bgPr>
         <a:solidFill>
-          <a:srgbClr val="FBFAF8"/>
+          <a:srgbClr val="FFFFFF"/>
         </a:solidFill>
       </p:bgPr>
     </p:bg>
@@ -10804,7 +11030,7 @@
             <a:r>
               <a:rPr lang="en-US" sz="2700" b="1" dirty="0">
                 <a:solidFill>
-                  <a:srgbClr val="1E2B4A"/>
+                  <a:srgbClr val="191970"/>
                 </a:solidFill>
                 <a:latin typeface="Calibri" pitchFamily="34" charset="0"/>
                 <a:ea typeface="Calibri" pitchFamily="34" charset="-122"/>
@@ -10833,13 +11059,13 @@
             </a:avLst>
           </a:prstGeom>
           <a:solidFill>
-            <a:srgbClr val="1E2B4A"/>
+            <a:srgbClr val="191970"/>
           </a:solidFill>
           <a:ln/>
           <a:effectLst>
             <a:outerShdw sx="100000" sy="100000" kx="0" ky="0" algn="bl" rotWithShape="0" blurRad="127000" dist="25400" dir="5400000">
-              <a:srgbClr val="1E2B4A">
-                <a:alpha val="13000"/>
+              <a:srgbClr val="13134F">
+                <a:alpha val="10000"/>
               </a:srgbClr>
             </a:outerShdw>
           </a:effectLst>
@@ -11021,13 +11247,13 @@
             </a:avLst>
           </a:prstGeom>
           <a:solidFill>
-            <a:srgbClr val="FFFFFF"/>
+            <a:srgbClr val="F4F5FA"/>
           </a:solidFill>
           <a:ln/>
           <a:effectLst>
             <a:outerShdw sx="100000" sy="100000" kx="0" ky="0" algn="bl" rotWithShape="0" blurRad="127000" dist="25400" dir="5400000">
-              <a:srgbClr val="1E2B4A">
-                <a:alpha val="13000"/>
+              <a:srgbClr val="13134F">
+                <a:alpha val="10000"/>
               </a:srgbClr>
             </a:outerShdw>
           </a:effectLst>
@@ -11192,7 +11418,7 @@
             </a:avLst>
           </a:prstGeom>
           <a:solidFill>
-            <a:srgbClr val="41639E"/>
+            <a:srgbClr val="4444AD"/>
           </a:solidFill>
           <a:ln/>
         </p:spPr>
@@ -11374,13 +11600,13 @@
             </a:avLst>
           </a:prstGeom>
           <a:solidFill>
-            <a:srgbClr val="FFFFFF"/>
+            <a:srgbClr val="F4F5FA"/>
           </a:solidFill>
           <a:ln/>
           <a:effectLst>
             <a:outerShdw sx="100000" sy="100000" kx="0" ky="0" algn="bl" rotWithShape="0" blurRad="127000" dist="25400" dir="5400000">
-              <a:srgbClr val="1E2B4A">
-                <a:alpha val="13000"/>
+              <a:srgbClr val="13134F">
+                <a:alpha val="10000"/>
               </a:srgbClr>
             </a:outerShdw>
           </a:effectLst>
@@ -11494,7 +11720,7 @@
             <a:r>
               <a:rPr lang="en-US" sz="1500" b="1" dirty="0">
                 <a:solidFill>
-                  <a:srgbClr val="1E2B4A"/>
+                  <a:srgbClr val="191970"/>
                 </a:solidFill>
                 <a:latin typeface="Calibri" pitchFamily="34" charset="0"/>
                 <a:ea typeface="Calibri" pitchFamily="34" charset="-122"/>
@@ -11521,7 +11747,7 @@
             <a:avLst/>
           </a:prstGeom>
           <a:solidFill>
-            <a:srgbClr val="E8EBF0"/>
+            <a:srgbClr val="E2E3EC"/>
           </a:solidFill>
           <a:ln/>
         </p:spPr>
@@ -11595,7 +11821,7 @@
             <a:r>
               <a:rPr lang="en-US" sz="1500" b="1" dirty="0">
                 <a:solidFill>
-                  <a:srgbClr val="1E2B4A"/>
+                  <a:srgbClr val="191970"/>
                 </a:solidFill>
                 <a:latin typeface="Calibri" pitchFamily="34" charset="0"/>
                 <a:ea typeface="Calibri" pitchFamily="34" charset="-122"/>
@@ -11622,7 +11848,7 @@
             <a:avLst/>
           </a:prstGeom>
           <a:solidFill>
-            <a:srgbClr val="E8EBF0"/>
+            <a:srgbClr val="E2E3EC"/>
           </a:solidFill>
           <a:ln/>
         </p:spPr>
@@ -11696,7 +11922,7 @@
             <a:r>
               <a:rPr lang="en-US" sz="1500" b="1" dirty="0">
                 <a:solidFill>
-                  <a:srgbClr val="1E2B4A"/>
+                  <a:srgbClr val="191970"/>
                 </a:solidFill>
                 <a:latin typeface="Calibri" pitchFamily="34" charset="0"/>
                 <a:ea typeface="Calibri" pitchFamily="34" charset="-122"/>
@@ -11723,7 +11949,7 @@
             <a:avLst/>
           </a:prstGeom>
           <a:solidFill>
-            <a:srgbClr val="E8EBF0"/>
+            <a:srgbClr val="E2E3EC"/>
           </a:solidFill>
           <a:ln/>
         </p:spPr>
@@ -11824,7 +12050,7 @@
             <a:avLst/>
           </a:prstGeom>
           <a:solidFill>
-            <a:srgbClr val="E8EBF0"/>
+            <a:srgbClr val="E2E3EC"/>
           </a:solidFill>
           <a:ln/>
         </p:spPr>
@@ -11918,8 +12144,8 @@
         </p:nvSpPr>
         <p:spPr>
           <a:xfrm>
-            <a:off x="10972800" y="6455664"/>
-            <a:ext cx="685800" cy="237744"/>
+            <a:off x="10881360" y="6455664"/>
+            <a:ext cx="365760" cy="237744"/>
           </a:xfrm>
           <a:prstGeom prst="rect">
             <a:avLst/>
@@ -11949,6 +12175,30 @@
           </a:p>
         </p:txBody>
       </p:sp>
+      <p:pic>
+        <p:nvPicPr>
+          <p:cNvPr id="35" name="Image 0" descr="logos/logo_ensae_new.png">    </p:cNvPr>
+          <p:cNvPicPr>
+            <a:picLocks noChangeAspect="1"/>
+          </p:cNvPicPr>
+          <p:nvPr/>
+        </p:nvPicPr>
+        <p:blipFill>
+          <a:blip r:embed="rId1"/>
+          <a:stretch>
+            <a:fillRect/>
+          </a:stretch>
+        </p:blipFill>
+        <p:spPr>
+          <a:xfrm>
+            <a:off x="11384280" y="6355080"/>
+            <a:ext cx="384048" cy="384048"/>
+          </a:xfrm>
+          <a:prstGeom prst="rect">
+            <a:avLst/>
+          </a:prstGeom>
+        </p:spPr>
+      </p:pic>
     </p:spTree>
   </p:cSld>
   <p:clrMapOvr>
@@ -11963,7 +12213,7 @@
     <p:bg>
       <p:bgPr>
         <a:solidFill>
-          <a:srgbClr val="FBFAF8"/>
+          <a:srgbClr val="FFFFFF"/>
         </a:solidFill>
       </p:bgPr>
     </p:bg>
@@ -12008,7 +12258,7 @@
             <a:r>
               <a:rPr lang="en-US" sz="2700" b="1" dirty="0">
                 <a:solidFill>
-                  <a:srgbClr val="1E2B4A"/>
+                  <a:srgbClr val="191970"/>
                 </a:solidFill>
                 <a:latin typeface="Calibri" pitchFamily="34" charset="0"/>
                 <a:ea typeface="Calibri" pitchFamily="34" charset="-122"/>
@@ -12079,13 +12329,13 @@
             </a:avLst>
           </a:prstGeom>
           <a:solidFill>
-            <a:srgbClr val="FFFFFF"/>
+            <a:srgbClr val="F4F5FA"/>
           </a:solidFill>
           <a:ln/>
           <a:effectLst>
             <a:outerShdw sx="100000" sy="100000" kx="0" ky="0" algn="bl" rotWithShape="0" blurRad="127000" dist="25400" dir="5400000">
-              <a:srgbClr val="1E2B4A">
-                <a:alpha val="13000"/>
+              <a:srgbClr val="13134F">
+                <a:alpha val="10000"/>
               </a:srgbClr>
             </a:outerShdw>
           </a:effectLst>
@@ -12325,7 +12575,7 @@
             </a:avLst>
           </a:prstGeom>
           <a:solidFill>
-            <a:srgbClr val="E8EBF0"/>
+            <a:srgbClr val="E2E3EC"/>
           </a:solidFill>
           <a:ln/>
         </p:spPr>
@@ -12425,7 +12675,7 @@
             </a:avLst>
           </a:prstGeom>
           <a:solidFill>
-            <a:srgbClr val="E8EBF0"/>
+            <a:srgbClr val="E2E3EC"/>
           </a:solidFill>
           <a:ln/>
         </p:spPr>
@@ -12525,7 +12775,7 @@
             </a:avLst>
           </a:prstGeom>
           <a:solidFill>
-            <a:srgbClr val="E8EBF0"/>
+            <a:srgbClr val="E2E3EC"/>
           </a:solidFill>
           <a:ln/>
         </p:spPr>
@@ -12625,7 +12875,7 @@
             </a:avLst>
           </a:prstGeom>
           <a:solidFill>
-            <a:srgbClr val="E8EBF0"/>
+            <a:srgbClr val="E2E3EC"/>
           </a:solidFill>
           <a:ln/>
         </p:spPr>
@@ -12725,7 +12975,7 @@
             </a:avLst>
           </a:prstGeom>
           <a:solidFill>
-            <a:srgbClr val="E8EBF0"/>
+            <a:srgbClr val="E2E3EC"/>
           </a:solidFill>
           <a:ln/>
         </p:spPr>
@@ -12825,7 +13075,7 @@
             </a:avLst>
           </a:prstGeom>
           <a:solidFill>
-            <a:srgbClr val="E8EBF0"/>
+            <a:srgbClr val="E2E3EC"/>
           </a:solidFill>
           <a:ln/>
         </p:spPr>
@@ -12891,8 +13141,8 @@
           <a:ln/>
           <a:effectLst>
             <a:outerShdw sx="100000" sy="100000" kx="0" ky="0" algn="bl" rotWithShape="0" blurRad="127000" dist="25400" dir="5400000">
-              <a:srgbClr val="1E2B4A">
-                <a:alpha val="13000"/>
+              <a:srgbClr val="13134F">
+                <a:alpha val="10000"/>
               </a:srgbClr>
             </a:outerShdw>
           </a:effectLst>
@@ -12923,7 +13173,7 @@
           </a:ln>
           <a:effectLst>
             <a:outerShdw sx="100000" sy="100000" kx="0" ky="0" algn="bl" rotWithShape="0" blurRad="127000" dist="25400" dir="5400000">
-              <a:srgbClr val="1E2B4A">
+              <a:srgbClr val="13134F">
                 <a:alpha val="18000"/>
               </a:srgbClr>
             </a:outerShdw>
@@ -13055,13 +13305,13 @@
             </a:avLst>
           </a:prstGeom>
           <a:solidFill>
-            <a:srgbClr val="FFFFFF"/>
+            <a:srgbClr val="F4F5FA"/>
           </a:solidFill>
           <a:ln/>
           <a:effectLst>
             <a:outerShdw sx="100000" sy="100000" kx="0" ky="0" algn="bl" rotWithShape="0" blurRad="127000" dist="25400" dir="5400000">
-              <a:srgbClr val="1E2B4A">
-                <a:alpha val="13000"/>
+              <a:srgbClr val="13134F">
+                <a:alpha val="10000"/>
               </a:srgbClr>
             </a:outerShdw>
           </a:effectLst>
@@ -13367,7 +13617,7 @@
             <a:r>
               <a:rPr lang="en-US" sz="100" dirty="0">
                 <a:solidFill>
-                  <a:srgbClr val="FBFAF8"/>
+                  <a:srgbClr val="FFFFFF"/>
                 </a:solidFill>
                 <a:latin typeface="Calibri" pitchFamily="34" charset="0"/>
                 <a:ea typeface="Calibri" pitchFamily="34" charset="-122"/>
@@ -13426,8 +13676,8 @@
         </p:nvSpPr>
         <p:spPr>
           <a:xfrm>
-            <a:off x="10972800" y="6455664"/>
-            <a:ext cx="685800" cy="237744"/>
+            <a:off x="10881360" y="6455664"/>
+            <a:ext cx="365760" cy="237744"/>
           </a:xfrm>
           <a:prstGeom prst="rect">
             <a:avLst/>
@@ -13457,6 +13707,30 @@
           </a:p>
         </p:txBody>
       </p:sp>
+      <p:pic>
+        <p:nvPicPr>
+          <p:cNvPr id="44" name="Image 1" descr="logos/logo_ensae_new.png">    </p:cNvPr>
+          <p:cNvPicPr>
+            <a:picLocks noChangeAspect="1"/>
+          </p:cNvPicPr>
+          <p:nvPr/>
+        </p:nvPicPr>
+        <p:blipFill>
+          <a:blip r:embed="rId2"/>
+          <a:stretch>
+            <a:fillRect/>
+          </a:stretch>
+        </p:blipFill>
+        <p:spPr>
+          <a:xfrm>
+            <a:off x="11384280" y="6355080"/>
+            <a:ext cx="384048" cy="384048"/>
+          </a:xfrm>
+          <a:prstGeom prst="rect">
+            <a:avLst/>
+          </a:prstGeom>
+        </p:spPr>
+      </p:pic>
     </p:spTree>
   </p:cSld>
   <p:clrMapOvr>
@@ -13471,7 +13745,7 @@
     <p:bg>
       <p:bgPr>
         <a:solidFill>
-          <a:srgbClr val="FBFAF8"/>
+          <a:srgbClr val="FFFFFF"/>
         </a:solidFill>
       </p:bgPr>
     </p:bg>
@@ -13516,7 +13790,7 @@
             <a:r>
               <a:rPr lang="en-US" sz="2700" b="1" dirty="0">
                 <a:solidFill>
-                  <a:srgbClr val="1E2B4A"/>
+                  <a:srgbClr val="191970"/>
                 </a:solidFill>
                 <a:latin typeface="Calibri" pitchFamily="34" charset="0"/>
                 <a:ea typeface="Calibri" pitchFamily="34" charset="-122"/>
@@ -13587,13 +13861,13 @@
             </a:avLst>
           </a:prstGeom>
           <a:solidFill>
-            <a:srgbClr val="FFFFFF"/>
+            <a:srgbClr val="F4F5FA"/>
           </a:solidFill>
           <a:ln/>
           <a:effectLst>
             <a:outerShdw sx="100000" sy="100000" kx="0" ky="0" algn="bl" rotWithShape="0" blurRad="127000" dist="25400" dir="5400000">
-              <a:srgbClr val="1E2B4A">
-                <a:alpha val="13000"/>
+              <a:srgbClr val="13134F">
+                <a:alpha val="10000"/>
               </a:srgbClr>
             </a:outerShdw>
           </a:effectLst>
@@ -14089,7 +14363,7 @@
             </a:avLst>
           </a:prstGeom>
           <a:solidFill>
-            <a:srgbClr val="E8EBF0"/>
+            <a:srgbClr val="E2E3EC"/>
           </a:solidFill>
           <a:ln/>
         </p:spPr>
@@ -14228,7 +14502,7 @@
             </a:avLst>
           </a:prstGeom>
           <a:solidFill>
-            <a:srgbClr val="E8EBF0"/>
+            <a:srgbClr val="E2E3EC"/>
           </a:solidFill>
           <a:ln/>
         </p:spPr>
@@ -14367,7 +14641,7 @@
             </a:avLst>
           </a:prstGeom>
           <a:solidFill>
-            <a:srgbClr val="E8EBF0"/>
+            <a:srgbClr val="E2E3EC"/>
           </a:solidFill>
           <a:ln/>
         </p:spPr>
@@ -14448,13 +14722,13 @@
             </a:avLst>
           </a:prstGeom>
           <a:solidFill>
-            <a:srgbClr val="1E2B4A"/>
+            <a:srgbClr val="191970"/>
           </a:solidFill>
           <a:ln/>
           <a:effectLst>
             <a:outerShdw sx="100000" sy="100000" kx="0" ky="0" algn="bl" rotWithShape="0" blurRad="127000" dist="25400" dir="5400000">
-              <a:srgbClr val="1E2B4A">
-                <a:alpha val="13000"/>
+              <a:srgbClr val="13134F">
+                <a:alpha val="10000"/>
               </a:srgbClr>
             </a:outerShdw>
           </a:effectLst>
@@ -14597,13 +14871,13 @@
             </a:avLst>
           </a:prstGeom>
           <a:solidFill>
-            <a:srgbClr val="FFFFFF"/>
+            <a:srgbClr val="F4F5FA"/>
           </a:solidFill>
           <a:ln/>
           <a:effectLst>
             <a:outerShdw sx="100000" sy="100000" kx="0" ky="0" algn="bl" rotWithShape="0" blurRad="127000" dist="25400" dir="5400000">
-              <a:srgbClr val="1E2B4A">
-                <a:alpha val="13000"/>
+              <a:srgbClr val="13134F">
+                <a:alpha val="10000"/>
               </a:srgbClr>
             </a:outerShdw>
           </a:effectLst>
@@ -14737,8 +15011,8 @@
         </p:nvSpPr>
         <p:spPr>
           <a:xfrm>
-            <a:off x="10972800" y="6455664"/>
-            <a:ext cx="685800" cy="237744"/>
+            <a:off x="10881360" y="6455664"/>
+            <a:ext cx="365760" cy="237744"/>
           </a:xfrm>
           <a:prstGeom prst="rect">
             <a:avLst/>
@@ -14768,6 +15042,30 @@
           </a:p>
         </p:txBody>
       </p:sp>
+      <p:pic>
+        <p:nvPicPr>
+          <p:cNvPr id="38" name="Image 0" descr="logos/logo_ensae_new.png">    </p:cNvPr>
+          <p:cNvPicPr>
+            <a:picLocks noChangeAspect="1"/>
+          </p:cNvPicPr>
+          <p:nvPr/>
+        </p:nvPicPr>
+        <p:blipFill>
+          <a:blip r:embed="rId1"/>
+          <a:stretch>
+            <a:fillRect/>
+          </a:stretch>
+        </p:blipFill>
+        <p:spPr>
+          <a:xfrm>
+            <a:off x="11384280" y="6355080"/>
+            <a:ext cx="384048" cy="384048"/>
+          </a:xfrm>
+          <a:prstGeom prst="rect">
+            <a:avLst/>
+          </a:prstGeom>
+        </p:spPr>
+      </p:pic>
     </p:spTree>
   </p:cSld>
   <p:clrMapOvr>
@@ -14782,7 +15080,7 @@
     <p:bg>
       <p:bgPr>
         <a:solidFill>
-          <a:srgbClr val="16213D"/>
+          <a:srgbClr val="101038"/>
         </a:solidFill>
       </p:bgPr>
     </p:bg>
@@ -14815,7 +15113,7 @@
             <a:avLst/>
           </a:prstGeom>
           <a:solidFill>
-            <a:srgbClr val="24365E"/>
+            <a:srgbClr val="23236B"/>
           </a:solidFill>
           <a:ln/>
         </p:spPr>
@@ -14835,7 +15133,7 @@
             <a:avLst/>
           </a:prstGeom>
           <a:solidFill>
-            <a:srgbClr val="24365E"/>
+            <a:srgbClr val="23236B"/>
           </a:solidFill>
           <a:ln/>
         </p:spPr>
@@ -14948,7 +15246,7 @@
             <a:r>
               <a:rPr lang="en-US" sz="1400" dirty="0">
                 <a:solidFill>
-                  <a:srgbClr val="AFC0DA"/>
+                  <a:srgbClr val="B7B7DB"/>
                 </a:solidFill>
                 <a:latin typeface="Calibri" pitchFamily="34" charset="0"/>
                 <a:ea typeface="Calibri" pitchFamily="34" charset="-122"/>
@@ -14974,7 +15272,7 @@
     <p:bg>
       <p:bgPr>
         <a:solidFill>
-          <a:srgbClr val="FBFAF8"/>
+          <a:srgbClr val="FFFFFF"/>
         </a:solidFill>
       </p:bgPr>
     </p:bg>
@@ -15019,7 +15317,7 @@
             <a:r>
               <a:rPr lang="en-US" sz="2700" b="1" dirty="0">
                 <a:solidFill>
-                  <a:srgbClr val="1E2B4A"/>
+                  <a:srgbClr val="191970"/>
                 </a:solidFill>
                 <a:latin typeface="Calibri" pitchFamily="34" charset="0"/>
                 <a:ea typeface="Calibri" pitchFamily="34" charset="-122"/>
@@ -15048,13 +15346,13 @@
             </a:avLst>
           </a:prstGeom>
           <a:solidFill>
-            <a:srgbClr val="FFFFFF"/>
+            <a:srgbClr val="F4F5FA"/>
           </a:solidFill>
           <a:ln/>
           <a:effectLst>
             <a:outerShdw sx="100000" sy="100000" kx="0" ky="0" algn="bl" rotWithShape="0" blurRad="127000" dist="25400" dir="5400000">
-              <a:srgbClr val="1E2B4A">
-                <a:alpha val="13000"/>
+              <a:srgbClr val="13134F">
+                <a:alpha val="10000"/>
               </a:srgbClr>
             </a:outerShdw>
           </a:effectLst>
@@ -15075,7 +15373,7 @@
             <a:avLst/>
           </a:prstGeom>
           <a:solidFill>
-            <a:srgbClr val="41639E"/>
+            <a:srgbClr val="4444AD"/>
           </a:solidFill>
           <a:ln w="31750">
             <a:solidFill>
@@ -15085,7 +15383,7 @@
           </a:ln>
           <a:effectLst>
             <a:outerShdw sx="100000" sy="100000" kx="0" ky="0" algn="bl" rotWithShape="0" blurRad="127000" dist="25400" dir="5400000">
-              <a:srgbClr val="1E2B4A">
+              <a:srgbClr val="13134F">
                 <a:alpha val="18000"/>
               </a:srgbClr>
             </a:outerShdw>
@@ -15143,7 +15441,7 @@
             <a:r>
               <a:rPr lang="en-US" sz="3000" b="1" dirty="0">
                 <a:solidFill>
-                  <a:srgbClr val="E8EBF0"/>
+                  <a:srgbClr val="E2E3EC"/>
                 </a:solidFill>
                 <a:latin typeface="Calibri" pitchFamily="34" charset="0"/>
                 <a:ea typeface="Calibri" pitchFamily="34" charset="-122"/>
@@ -15250,13 +15548,13 @@
             </a:avLst>
           </a:prstGeom>
           <a:solidFill>
-            <a:srgbClr val="FFFFFF"/>
+            <a:srgbClr val="F4F5FA"/>
           </a:solidFill>
           <a:ln/>
           <a:effectLst>
             <a:outerShdw sx="100000" sy="100000" kx="0" ky="0" algn="bl" rotWithShape="0" blurRad="127000" dist="25400" dir="5400000">
-              <a:srgbClr val="1E2B4A">
-                <a:alpha val="13000"/>
+              <a:srgbClr val="13134F">
+                <a:alpha val="10000"/>
               </a:srgbClr>
             </a:outerShdw>
           </a:effectLst>
@@ -15287,7 +15585,7 @@
           </a:ln>
           <a:effectLst>
             <a:outerShdw sx="100000" sy="100000" kx="0" ky="0" algn="bl" rotWithShape="0" blurRad="127000" dist="25400" dir="5400000">
-              <a:srgbClr val="1E2B4A">
+              <a:srgbClr val="13134F">
                 <a:alpha val="18000"/>
               </a:srgbClr>
             </a:outerShdw>
@@ -15345,7 +15643,7 @@
             <a:r>
               <a:rPr lang="en-US" sz="3000" b="1" dirty="0">
                 <a:solidFill>
-                  <a:srgbClr val="E8EBF0"/>
+                  <a:srgbClr val="E2E3EC"/>
                 </a:solidFill>
                 <a:latin typeface="Calibri" pitchFamily="34" charset="0"/>
                 <a:ea typeface="Calibri" pitchFamily="34" charset="-122"/>
@@ -15452,13 +15750,13 @@
             </a:avLst>
           </a:prstGeom>
           <a:solidFill>
-            <a:srgbClr val="FFFFFF"/>
+            <a:srgbClr val="F4F5FA"/>
           </a:solidFill>
           <a:ln/>
           <a:effectLst>
             <a:outerShdw sx="100000" sy="100000" kx="0" ky="0" algn="bl" rotWithShape="0" blurRad="127000" dist="25400" dir="5400000">
-              <a:srgbClr val="1E2B4A">
-                <a:alpha val="13000"/>
+              <a:srgbClr val="13134F">
+                <a:alpha val="10000"/>
               </a:srgbClr>
             </a:outerShdw>
           </a:effectLst>
@@ -15479,7 +15777,7 @@
             <a:avLst/>
           </a:prstGeom>
           <a:solidFill>
-            <a:srgbClr val="3E8C9A"/>
+            <a:srgbClr val="2A2A80"/>
           </a:solidFill>
           <a:ln w="31750">
             <a:solidFill>
@@ -15489,7 +15787,7 @@
           </a:ln>
           <a:effectLst>
             <a:outerShdw sx="100000" sy="100000" kx="0" ky="0" algn="bl" rotWithShape="0" blurRad="127000" dist="25400" dir="5400000">
-              <a:srgbClr val="1E2B4A">
+              <a:srgbClr val="13134F">
                 <a:alpha val="18000"/>
               </a:srgbClr>
             </a:outerShdw>
@@ -15547,7 +15845,7 @@
             <a:r>
               <a:rPr lang="en-US" sz="3000" b="1" dirty="0">
                 <a:solidFill>
-                  <a:srgbClr val="E8EBF0"/>
+                  <a:srgbClr val="E2E3EC"/>
                 </a:solidFill>
                 <a:latin typeface="Calibri" pitchFamily="34" charset="0"/>
                 <a:ea typeface="Calibri" pitchFamily="34" charset="-122"/>
@@ -15654,13 +15952,13 @@
             </a:avLst>
           </a:prstGeom>
           <a:solidFill>
-            <a:srgbClr val="FFFFFF"/>
+            <a:srgbClr val="F4F5FA"/>
           </a:solidFill>
           <a:ln/>
           <a:effectLst>
             <a:outerShdw sx="100000" sy="100000" kx="0" ky="0" algn="bl" rotWithShape="0" blurRad="127000" dist="25400" dir="5400000">
-              <a:srgbClr val="1E2B4A">
-                <a:alpha val="13000"/>
+              <a:srgbClr val="13134F">
+                <a:alpha val="10000"/>
               </a:srgbClr>
             </a:outerShdw>
           </a:effectLst>
@@ -15681,7 +15979,7 @@
             <a:avLst/>
           </a:prstGeom>
           <a:solidFill>
-            <a:srgbClr val="C98A24"/>
+            <a:srgbClr val="6E6ECB"/>
           </a:solidFill>
           <a:ln w="31750">
             <a:solidFill>
@@ -15691,7 +15989,7 @@
           </a:ln>
           <a:effectLst>
             <a:outerShdw sx="100000" sy="100000" kx="0" ky="0" algn="bl" rotWithShape="0" blurRad="127000" dist="25400" dir="5400000">
-              <a:srgbClr val="1E2B4A">
+              <a:srgbClr val="13134F">
                 <a:alpha val="18000"/>
               </a:srgbClr>
             </a:outerShdw>
@@ -15749,7 +16047,7 @@
             <a:r>
               <a:rPr lang="en-US" sz="3000" b="1" dirty="0">
                 <a:solidFill>
-                  <a:srgbClr val="E8EBF0"/>
+                  <a:srgbClr val="E2E3EC"/>
                 </a:solidFill>
                 <a:latin typeface="Calibri" pitchFamily="34" charset="0"/>
                 <a:ea typeface="Calibri" pitchFamily="34" charset="-122"/>
@@ -15856,13 +16154,13 @@
             </a:avLst>
           </a:prstGeom>
           <a:solidFill>
-            <a:srgbClr val="FFFFFF"/>
+            <a:srgbClr val="F4F5FA"/>
           </a:solidFill>
           <a:ln/>
           <a:effectLst>
             <a:outerShdw sx="100000" sy="100000" kx="0" ky="0" algn="bl" rotWithShape="0" blurRad="127000" dist="25400" dir="5400000">
-              <a:srgbClr val="1E2B4A">
-                <a:alpha val="13000"/>
+              <a:srgbClr val="13134F">
+                <a:alpha val="10000"/>
               </a:srgbClr>
             </a:outerShdw>
           </a:effectLst>
@@ -15883,7 +16181,7 @@
             <a:avLst/>
           </a:prstGeom>
           <a:solidFill>
-            <a:srgbClr val="41639E"/>
+            <a:srgbClr val="4444AD"/>
           </a:solidFill>
           <a:ln w="31750">
             <a:solidFill>
@@ -15893,7 +16191,7 @@
           </a:ln>
           <a:effectLst>
             <a:outerShdw sx="100000" sy="100000" kx="0" ky="0" algn="bl" rotWithShape="0" blurRad="127000" dist="25400" dir="5400000">
-              <a:srgbClr val="1E2B4A">
+              <a:srgbClr val="13134F">
                 <a:alpha val="18000"/>
               </a:srgbClr>
             </a:outerShdw>
@@ -15951,7 +16249,7 @@
             <a:r>
               <a:rPr lang="en-US" sz="3000" b="1" dirty="0">
                 <a:solidFill>
-                  <a:srgbClr val="E8EBF0"/>
+                  <a:srgbClr val="E2E3EC"/>
                 </a:solidFill>
                 <a:latin typeface="Calibri" pitchFamily="34" charset="0"/>
                 <a:ea typeface="Calibri" pitchFamily="34" charset="-122"/>
@@ -16058,13 +16356,13 @@
             </a:avLst>
           </a:prstGeom>
           <a:solidFill>
-            <a:srgbClr val="FFFFFF"/>
+            <a:srgbClr val="F4F5FA"/>
           </a:solidFill>
           <a:ln/>
           <a:effectLst>
             <a:outerShdw sx="100000" sy="100000" kx="0" ky="0" algn="bl" rotWithShape="0" blurRad="127000" dist="25400" dir="5400000">
-              <a:srgbClr val="1E2B4A">
-                <a:alpha val="13000"/>
+              <a:srgbClr val="13134F">
+                <a:alpha val="10000"/>
               </a:srgbClr>
             </a:outerShdw>
           </a:effectLst>
@@ -16095,7 +16393,7 @@
           </a:ln>
           <a:effectLst>
             <a:outerShdw sx="100000" sy="100000" kx="0" ky="0" algn="bl" rotWithShape="0" blurRad="127000" dist="25400" dir="5400000">
-              <a:srgbClr val="1E2B4A">
+              <a:srgbClr val="13134F">
                 <a:alpha val="18000"/>
               </a:srgbClr>
             </a:outerShdw>
@@ -16153,7 +16451,7 @@
             <a:r>
               <a:rPr lang="en-US" sz="3000" b="1" dirty="0">
                 <a:solidFill>
-                  <a:srgbClr val="E8EBF0"/>
+                  <a:srgbClr val="E2E3EC"/>
                 </a:solidFill>
                 <a:latin typeface="Calibri" pitchFamily="34" charset="0"/>
                 <a:ea typeface="Calibri" pitchFamily="34" charset="-122"/>
@@ -16251,8 +16549,8 @@
         </p:nvSpPr>
         <p:spPr>
           <a:xfrm>
-            <a:off x="10972800" y="6455664"/>
-            <a:ext cx="685800" cy="237744"/>
+            <a:off x="10881360" y="6455664"/>
+            <a:ext cx="365760" cy="237744"/>
           </a:xfrm>
           <a:prstGeom prst="rect">
             <a:avLst/>
@@ -16282,6 +16580,30 @@
           </a:p>
         </p:txBody>
       </p:sp>
+      <p:pic>
+        <p:nvPicPr>
+          <p:cNvPr id="40" name="Image 6" descr="logos/logo_ensae_new.png">    </p:cNvPr>
+          <p:cNvPicPr>
+            <a:picLocks noChangeAspect="1"/>
+          </p:cNvPicPr>
+          <p:nvPr/>
+        </p:nvPicPr>
+        <p:blipFill>
+          <a:blip r:embed="rId7"/>
+          <a:stretch>
+            <a:fillRect/>
+          </a:stretch>
+        </p:blipFill>
+        <p:spPr>
+          <a:xfrm>
+            <a:off x="11384280" y="6355080"/>
+            <a:ext cx="384048" cy="384048"/>
+          </a:xfrm>
+          <a:prstGeom prst="rect">
+            <a:avLst/>
+          </a:prstGeom>
+        </p:spPr>
+      </p:pic>
     </p:spTree>
   </p:cSld>
   <p:clrMapOvr>
@@ -16296,7 +16618,7 @@
     <p:bg>
       <p:bgPr>
         <a:solidFill>
-          <a:srgbClr val="FBFAF8"/>
+          <a:srgbClr val="FFFFFF"/>
         </a:solidFill>
       </p:bgPr>
     </p:bg>
@@ -16341,7 +16663,7 @@
             <a:r>
               <a:rPr lang="en-US" sz="2700" b="1" dirty="0">
                 <a:solidFill>
-                  <a:srgbClr val="1E2B4A"/>
+                  <a:srgbClr val="191970"/>
                 </a:solidFill>
                 <a:latin typeface="Calibri" pitchFamily="34" charset="0"/>
                 <a:ea typeface="Calibri" pitchFamily="34" charset="-122"/>
@@ -16370,13 +16692,13 @@
             </a:avLst>
           </a:prstGeom>
           <a:solidFill>
-            <a:srgbClr val="FFFFFF"/>
+            <a:srgbClr val="F4F5FA"/>
           </a:solidFill>
           <a:ln/>
           <a:effectLst>
             <a:outerShdw sx="100000" sy="100000" kx="0" ky="0" algn="bl" rotWithShape="0" blurRad="127000" dist="25400" dir="5400000">
-              <a:srgbClr val="1E2B4A">
-                <a:alpha val="13000"/>
+              <a:srgbClr val="13134F">
+                <a:alpha val="10000"/>
               </a:srgbClr>
             </a:outerShdw>
           </a:effectLst>
@@ -16397,7 +16719,7 @@
             <a:avLst/>
           </a:prstGeom>
           <a:solidFill>
-            <a:srgbClr val="41639E"/>
+            <a:srgbClr val="4444AD"/>
           </a:solidFill>
           <a:ln w="31750">
             <a:solidFill>
@@ -16407,7 +16729,7 @@
           </a:ln>
           <a:effectLst>
             <a:outerShdw sx="100000" sy="100000" kx="0" ky="0" algn="bl" rotWithShape="0" blurRad="127000" dist="25400" dir="5400000">
-              <a:srgbClr val="1E2B4A">
+              <a:srgbClr val="13134F">
                 <a:alpha val="18000"/>
               </a:srgbClr>
             </a:outerShdw>
@@ -16504,7 +16826,7 @@
             <a:r>
               <a:rPr lang="en-US" sz="1100" b="1" dirty="0">
                 <a:solidFill>
-                  <a:srgbClr val="41639E"/>
+                  <a:srgbClr val="4444AD"/>
                 </a:solidFill>
                 <a:latin typeface="Calibri" pitchFamily="34" charset="0"/>
                 <a:ea typeface="Calibri" pitchFamily="34" charset="-122"/>
@@ -16575,13 +16897,13 @@
             </a:avLst>
           </a:prstGeom>
           <a:solidFill>
-            <a:srgbClr val="FFFFFF"/>
+            <a:srgbClr val="F4F5FA"/>
           </a:solidFill>
           <a:ln/>
           <a:effectLst>
             <a:outerShdw sx="100000" sy="100000" kx="0" ky="0" algn="bl" rotWithShape="0" blurRad="127000" dist="25400" dir="5400000">
-              <a:srgbClr val="1E2B4A">
-                <a:alpha val="13000"/>
+              <a:srgbClr val="13134F">
+                <a:alpha val="10000"/>
               </a:srgbClr>
             </a:outerShdw>
           </a:effectLst>
@@ -16602,7 +16924,7 @@
             <a:avLst/>
           </a:prstGeom>
           <a:solidFill>
-            <a:srgbClr val="3E8C9A"/>
+            <a:srgbClr val="2A2A80"/>
           </a:solidFill>
           <a:ln w="31750">
             <a:solidFill>
@@ -16612,7 +16934,7 @@
           </a:ln>
           <a:effectLst>
             <a:outerShdw sx="100000" sy="100000" kx="0" ky="0" algn="bl" rotWithShape="0" blurRad="127000" dist="25400" dir="5400000">
-              <a:srgbClr val="1E2B4A">
+              <a:srgbClr val="13134F">
                 <a:alpha val="18000"/>
               </a:srgbClr>
             </a:outerShdw>
@@ -16709,7 +17031,7 @@
             <a:r>
               <a:rPr lang="en-US" sz="1100" b="1" dirty="0">
                 <a:solidFill>
-                  <a:srgbClr val="3E8C9A"/>
+                  <a:srgbClr val="2A2A80"/>
                 </a:solidFill>
                 <a:latin typeface="Calibri" pitchFamily="34" charset="0"/>
                 <a:ea typeface="Calibri" pitchFamily="34" charset="-122"/>
@@ -16780,13 +17102,13 @@
             </a:avLst>
           </a:prstGeom>
           <a:solidFill>
-            <a:srgbClr val="FFFFFF"/>
+            <a:srgbClr val="F4F5FA"/>
           </a:solidFill>
           <a:ln/>
           <a:effectLst>
             <a:outerShdw sx="100000" sy="100000" kx="0" ky="0" algn="bl" rotWithShape="0" blurRad="127000" dist="25400" dir="5400000">
-              <a:srgbClr val="1E2B4A">
-                <a:alpha val="13000"/>
+              <a:srgbClr val="13134F">
+                <a:alpha val="10000"/>
               </a:srgbClr>
             </a:outerShdw>
           </a:effectLst>
@@ -16807,7 +17129,7 @@
             <a:avLst/>
           </a:prstGeom>
           <a:solidFill>
-            <a:srgbClr val="C98A24"/>
+            <a:srgbClr val="6E6ECB"/>
           </a:solidFill>
           <a:ln w="31750">
             <a:solidFill>
@@ -16817,7 +17139,7 @@
           </a:ln>
           <a:effectLst>
             <a:outerShdw sx="100000" sy="100000" kx="0" ky="0" algn="bl" rotWithShape="0" blurRad="127000" dist="25400" dir="5400000">
-              <a:srgbClr val="1E2B4A">
+              <a:srgbClr val="13134F">
                 <a:alpha val="18000"/>
               </a:srgbClr>
             </a:outerShdw>
@@ -16914,7 +17236,7 @@
             <a:r>
               <a:rPr lang="en-US" sz="1100" b="1" dirty="0">
                 <a:solidFill>
-                  <a:srgbClr val="C98A24"/>
+                  <a:srgbClr val="6E6ECB"/>
                 </a:solidFill>
                 <a:latin typeface="Calibri" pitchFamily="34" charset="0"/>
                 <a:ea typeface="Calibri" pitchFamily="34" charset="-122"/>
@@ -16985,13 +17307,13 @@
             </a:avLst>
           </a:prstGeom>
           <a:solidFill>
-            <a:srgbClr val="FFFFFF"/>
+            <a:srgbClr val="F4F5FA"/>
           </a:solidFill>
           <a:ln/>
           <a:effectLst>
             <a:outerShdw sx="100000" sy="100000" kx="0" ky="0" algn="bl" rotWithShape="0" blurRad="127000" dist="25400" dir="5400000">
-              <a:srgbClr val="1E2B4A">
-                <a:alpha val="13000"/>
+              <a:srgbClr val="13134F">
+                <a:alpha val="10000"/>
               </a:srgbClr>
             </a:outerShdw>
           </a:effectLst>
@@ -17022,7 +17344,7 @@
           </a:ln>
           <a:effectLst>
             <a:outerShdw sx="100000" sy="100000" kx="0" ky="0" algn="bl" rotWithShape="0" blurRad="127000" dist="25400" dir="5400000">
-              <a:srgbClr val="1E2B4A">
+              <a:srgbClr val="13134F">
                 <a:alpha val="18000"/>
               </a:srgbClr>
             </a:outerShdw>
@@ -17190,13 +17512,13 @@
             </a:avLst>
           </a:prstGeom>
           <a:solidFill>
-            <a:srgbClr val="FBFAF8"/>
+            <a:srgbClr val="FFFFFF"/>
           </a:solidFill>
           <a:ln/>
           <a:effectLst>
             <a:outerShdw sx="100000" sy="100000" kx="0" ky="0" algn="bl" rotWithShape="0" blurRad="127000" dist="25400" dir="5400000">
-              <a:srgbClr val="1E2B4A">
-                <a:alpha val="13000"/>
+              <a:srgbClr val="13134F">
+                <a:alpha val="10000"/>
               </a:srgbClr>
             </a:outerShdw>
           </a:effectLst>
@@ -17249,8 +17571,8 @@
         </p:nvSpPr>
         <p:spPr>
           <a:xfrm>
-            <a:off x="10972800" y="6455664"/>
-            <a:ext cx="685800" cy="237744"/>
+            <a:off x="10881360" y="6455664"/>
+            <a:ext cx="365760" cy="237744"/>
           </a:xfrm>
           <a:prstGeom prst="rect">
             <a:avLst/>
@@ -17280,6 +17602,30 @@
           </a:p>
         </p:txBody>
       </p:sp>
+      <p:pic>
+        <p:nvPicPr>
+          <p:cNvPr id="30" name="Image 4" descr="logos/logo_ensae_new.png">    </p:cNvPr>
+          <p:cNvPicPr>
+            <a:picLocks noChangeAspect="1"/>
+          </p:cNvPicPr>
+          <p:nvPr/>
+        </p:nvPicPr>
+        <p:blipFill>
+          <a:blip r:embed="rId5"/>
+          <a:stretch>
+            <a:fillRect/>
+          </a:stretch>
+        </p:blipFill>
+        <p:spPr>
+          <a:xfrm>
+            <a:off x="11384280" y="6355080"/>
+            <a:ext cx="384048" cy="384048"/>
+          </a:xfrm>
+          <a:prstGeom prst="rect">
+            <a:avLst/>
+          </a:prstGeom>
+        </p:spPr>
+      </p:pic>
     </p:spTree>
   </p:cSld>
   <p:clrMapOvr>
@@ -17294,7 +17640,7 @@
     <p:bg>
       <p:bgPr>
         <a:solidFill>
-          <a:srgbClr val="FBFAF8"/>
+          <a:srgbClr val="FFFFFF"/>
         </a:solidFill>
       </p:bgPr>
     </p:bg>
@@ -17339,7 +17685,7 @@
             <a:r>
               <a:rPr lang="en-US" sz="2700" b="1" dirty="0">
                 <a:solidFill>
-                  <a:srgbClr val="1E2B4A"/>
+                  <a:srgbClr val="191970"/>
                 </a:solidFill>
                 <a:latin typeface="Calibri" pitchFamily="34" charset="0"/>
                 <a:ea typeface="Calibri" pitchFamily="34" charset="-122"/>
@@ -17368,13 +17714,13 @@
             </a:avLst>
           </a:prstGeom>
           <a:solidFill>
-            <a:srgbClr val="FFFFFF"/>
+            <a:srgbClr val="F4F5FA"/>
           </a:solidFill>
           <a:ln/>
           <a:effectLst>
             <a:outerShdw sx="100000" sy="100000" kx="0" ky="0" algn="bl" rotWithShape="0" blurRad="127000" dist="25400" dir="5400000">
-              <a:srgbClr val="1E2B4A">
-                <a:alpha val="13000"/>
+              <a:srgbClr val="13134F">
+                <a:alpha val="10000"/>
               </a:srgbClr>
             </a:outerShdw>
           </a:effectLst>
@@ -17559,13 +17905,13 @@
             </a:avLst>
           </a:prstGeom>
           <a:solidFill>
-            <a:srgbClr val="FFFFFF"/>
+            <a:srgbClr val="F4F5FA"/>
           </a:solidFill>
           <a:ln/>
           <a:effectLst>
             <a:outerShdw sx="100000" sy="100000" kx="0" ky="0" algn="bl" rotWithShape="0" blurRad="127000" dist="25400" dir="5400000">
-              <a:srgbClr val="1E2B4A">
-                <a:alpha val="13000"/>
+              <a:srgbClr val="13134F">
+                <a:alpha val="10000"/>
               </a:srgbClr>
             </a:outerShdw>
           </a:effectLst>
@@ -17598,7 +17944,7 @@
             <a:r>
               <a:rPr lang="en-US" sz="2600" b="1" dirty="0">
                 <a:solidFill>
-                  <a:srgbClr val="3E8C9A"/>
+                  <a:srgbClr val="2A2A80"/>
                 </a:solidFill>
                 <a:latin typeface="Calibri" pitchFamily="34" charset="0"/>
                 <a:ea typeface="Calibri" pitchFamily="34" charset="-122"/>
@@ -17721,7 +18067,7 @@
             <a:r>
               <a:rPr lang="en-US" sz="1350" b="1" dirty="0">
                 <a:solidFill>
-                  <a:srgbClr val="3E8C9A"/>
+                  <a:srgbClr val="2A2A80"/>
                 </a:solidFill>
                 <a:latin typeface="Calibri" pitchFamily="34" charset="0"/>
                 <a:ea typeface="Calibri" pitchFamily="34" charset="-122"/>
@@ -17758,7 +18104,7 @@
           </a:ln>
           <a:effectLst>
             <a:outerShdw sx="100000" sy="100000" kx="0" ky="0" algn="bl" rotWithShape="0" blurRad="127000" dist="25400" dir="5400000">
-              <a:srgbClr val="1E2B4A">
+              <a:srgbClr val="13134F">
                 <a:alpha val="18000"/>
               </a:srgbClr>
             </a:outerShdw>
@@ -17804,7 +18150,7 @@
             <a:avLst/>
           </a:prstGeom>
           <a:solidFill>
-            <a:srgbClr val="3E8C9A"/>
+            <a:srgbClr val="2A2A80"/>
           </a:solidFill>
           <a:ln w="31750">
             <a:solidFill>
@@ -17814,7 +18160,7 @@
           </a:ln>
           <a:effectLst>
             <a:outerShdw sx="100000" sy="100000" kx="0" ky="0" algn="bl" rotWithShape="0" blurRad="127000" dist="25400" dir="5400000">
-              <a:srgbClr val="1E2B4A">
+              <a:srgbClr val="13134F">
                 <a:alpha val="18000"/>
               </a:srgbClr>
             </a:outerShdw>
@@ -17853,8 +18199,8 @@
         </p:nvSpPr>
         <p:spPr>
           <a:xfrm>
-            <a:off x="10972800" y="6455664"/>
-            <a:ext cx="685800" cy="237744"/>
+            <a:off x="10881360" y="6455664"/>
+            <a:ext cx="365760" cy="237744"/>
           </a:xfrm>
           <a:prstGeom prst="rect">
             <a:avLst/>
@@ -17884,6 +18230,30 @@
           </a:p>
         </p:txBody>
       </p:sp>
+      <p:pic>
+        <p:nvPicPr>
+          <p:cNvPr id="18" name="Image 2" descr="logos/logo_ensae_new.png">    </p:cNvPr>
+          <p:cNvPicPr>
+            <a:picLocks noChangeAspect="1"/>
+          </p:cNvPicPr>
+          <p:nvPr/>
+        </p:nvPicPr>
+        <p:blipFill>
+          <a:blip r:embed="rId3"/>
+          <a:stretch>
+            <a:fillRect/>
+          </a:stretch>
+        </p:blipFill>
+        <p:spPr>
+          <a:xfrm>
+            <a:off x="11384280" y="6355080"/>
+            <a:ext cx="384048" cy="384048"/>
+          </a:xfrm>
+          <a:prstGeom prst="rect">
+            <a:avLst/>
+          </a:prstGeom>
+        </p:spPr>
+      </p:pic>
     </p:spTree>
   </p:cSld>
   <p:clrMapOvr>
@@ -17898,7 +18268,7 @@
     <p:bg>
       <p:bgPr>
         <a:solidFill>
-          <a:srgbClr val="FBFAF8"/>
+          <a:srgbClr val="FFFFFF"/>
         </a:solidFill>
       </p:bgPr>
     </p:bg>
@@ -17943,7 +18313,7 @@
             <a:r>
               <a:rPr lang="en-US" sz="2700" b="1" dirty="0">
                 <a:solidFill>
-                  <a:srgbClr val="1E2B4A"/>
+                  <a:srgbClr val="191970"/>
                 </a:solidFill>
                 <a:latin typeface="Calibri" pitchFamily="34" charset="0"/>
                 <a:ea typeface="Calibri" pitchFamily="34" charset="-122"/>
@@ -18014,13 +18384,13 @@
             </a:avLst>
           </a:prstGeom>
           <a:solidFill>
-            <a:srgbClr val="FFFFFF"/>
+            <a:srgbClr val="F4F5FA"/>
           </a:solidFill>
           <a:ln/>
           <a:effectLst>
             <a:outerShdw sx="100000" sy="100000" kx="0" ky="0" algn="bl" rotWithShape="0" blurRad="127000" dist="25400" dir="5400000">
-              <a:srgbClr val="1E2B4A">
-                <a:alpha val="13000"/>
+              <a:srgbClr val="13134F">
+                <a:alpha val="10000"/>
               </a:srgbClr>
             </a:outerShdw>
           </a:effectLst>
@@ -18041,7 +18411,7 @@
             <a:avLst/>
           </a:prstGeom>
           <a:solidFill>
-            <a:srgbClr val="C98A24"/>
+            <a:srgbClr val="6E6ECB"/>
           </a:solidFill>
           <a:ln w="31750">
             <a:solidFill>
@@ -18051,7 +18421,7 @@
           </a:ln>
           <a:effectLst>
             <a:outerShdw sx="100000" sy="100000" kx="0" ky="0" algn="bl" rotWithShape="0" blurRad="127000" dist="25400" dir="5400000">
-              <a:srgbClr val="1E2B4A">
+              <a:srgbClr val="13134F">
                 <a:alpha val="18000"/>
               </a:srgbClr>
             </a:outerShdw>
@@ -18183,13 +18553,13 @@
             </a:avLst>
           </a:prstGeom>
           <a:solidFill>
-            <a:srgbClr val="FFFFFF"/>
+            <a:srgbClr val="F4F5FA"/>
           </a:solidFill>
           <a:ln/>
           <a:effectLst>
             <a:outerShdw sx="100000" sy="100000" kx="0" ky="0" algn="bl" rotWithShape="0" blurRad="127000" dist="25400" dir="5400000">
-              <a:srgbClr val="1E2B4A">
-                <a:alpha val="13000"/>
+              <a:srgbClr val="13134F">
+                <a:alpha val="10000"/>
               </a:srgbClr>
             </a:outerShdw>
           </a:effectLst>
@@ -18210,7 +18580,7 @@
             <a:avLst/>
           </a:prstGeom>
           <a:solidFill>
-            <a:srgbClr val="41639E"/>
+            <a:srgbClr val="4444AD"/>
           </a:solidFill>
           <a:ln w="31750">
             <a:solidFill>
@@ -18220,7 +18590,7 @@
           </a:ln>
           <a:effectLst>
             <a:outerShdw sx="100000" sy="100000" kx="0" ky="0" algn="bl" rotWithShape="0" blurRad="127000" dist="25400" dir="5400000">
-              <a:srgbClr val="1E2B4A">
+              <a:srgbClr val="13134F">
                 <a:alpha val="18000"/>
               </a:srgbClr>
             </a:outerShdw>
@@ -18352,13 +18722,13 @@
             </a:avLst>
           </a:prstGeom>
           <a:solidFill>
-            <a:srgbClr val="FFFFFF"/>
+            <a:srgbClr val="F4F5FA"/>
           </a:solidFill>
           <a:ln/>
           <a:effectLst>
             <a:outerShdw sx="100000" sy="100000" kx="0" ky="0" algn="bl" rotWithShape="0" blurRad="127000" dist="25400" dir="5400000">
-              <a:srgbClr val="1E2B4A">
-                <a:alpha val="13000"/>
+              <a:srgbClr val="13134F">
+                <a:alpha val="10000"/>
               </a:srgbClr>
             </a:outerShdw>
           </a:effectLst>
@@ -18379,7 +18749,7 @@
             <a:avLst/>
           </a:prstGeom>
           <a:solidFill>
-            <a:srgbClr val="3E8C9A"/>
+            <a:srgbClr val="2A2A80"/>
           </a:solidFill>
           <a:ln w="31750">
             <a:solidFill>
@@ -18389,7 +18759,7 @@
           </a:ln>
           <a:effectLst>
             <a:outerShdw sx="100000" sy="100000" kx="0" ky="0" algn="bl" rotWithShape="0" blurRad="127000" dist="25400" dir="5400000">
-              <a:srgbClr val="1E2B4A">
+              <a:srgbClr val="13134F">
                 <a:alpha val="18000"/>
               </a:srgbClr>
             </a:outerShdw>
@@ -18512,8 +18882,8 @@
         </p:nvSpPr>
         <p:spPr>
           <a:xfrm>
-            <a:off x="10972800" y="6455664"/>
-            <a:ext cx="685800" cy="237744"/>
+            <a:off x="10881360" y="6455664"/>
+            <a:ext cx="365760" cy="237744"/>
           </a:xfrm>
           <a:prstGeom prst="rect">
             <a:avLst/>
@@ -18543,6 +18913,30 @@
           </a:p>
         </p:txBody>
       </p:sp>
+      <p:pic>
+        <p:nvPicPr>
+          <p:cNvPr id="20" name="Image 3" descr="logos/logo_ensae_new.png">    </p:cNvPr>
+          <p:cNvPicPr>
+            <a:picLocks noChangeAspect="1"/>
+          </p:cNvPicPr>
+          <p:nvPr/>
+        </p:nvPicPr>
+        <p:blipFill>
+          <a:blip r:embed="rId4"/>
+          <a:stretch>
+            <a:fillRect/>
+          </a:stretch>
+        </p:blipFill>
+        <p:spPr>
+          <a:xfrm>
+            <a:off x="11384280" y="6355080"/>
+            <a:ext cx="384048" cy="384048"/>
+          </a:xfrm>
+          <a:prstGeom prst="rect">
+            <a:avLst/>
+          </a:prstGeom>
+        </p:spPr>
+      </p:pic>
     </p:spTree>
   </p:cSld>
   <p:clrMapOvr>
@@ -18557,7 +18951,7 @@
     <p:bg>
       <p:bgPr>
         <a:solidFill>
-          <a:srgbClr val="FBFAF8"/>
+          <a:srgbClr val="FFFFFF"/>
         </a:solidFill>
       </p:bgPr>
     </p:bg>
@@ -18602,7 +18996,7 @@
             <a:r>
               <a:rPr lang="en-US" sz="2700" b="1" dirty="0">
                 <a:solidFill>
-                  <a:srgbClr val="1E2B4A"/>
+                  <a:srgbClr val="191970"/>
                 </a:solidFill>
                 <a:latin typeface="Calibri" pitchFamily="34" charset="0"/>
                 <a:ea typeface="Calibri" pitchFamily="34" charset="-122"/>
@@ -18631,13 +19025,13 @@
             </a:avLst>
           </a:prstGeom>
           <a:solidFill>
-            <a:srgbClr val="FFFFFF"/>
+            <a:srgbClr val="F4F5FA"/>
           </a:solidFill>
           <a:ln/>
           <a:effectLst>
             <a:outerShdw sx="100000" sy="100000" kx="0" ky="0" algn="bl" rotWithShape="0" blurRad="127000" dist="25400" dir="5400000">
-              <a:srgbClr val="1E2B4A">
-                <a:alpha val="13000"/>
+              <a:srgbClr val="13134F">
+                <a:alpha val="10000"/>
               </a:srgbClr>
             </a:outerShdw>
           </a:effectLst>
@@ -18668,7 +19062,7 @@
           </a:ln>
           <a:effectLst>
             <a:outerShdw sx="100000" sy="100000" kx="0" ky="0" algn="bl" rotWithShape="0" blurRad="127000" dist="25400" dir="5400000">
-              <a:srgbClr val="1E2B4A">
+              <a:srgbClr val="13134F">
                 <a:alpha val="18000"/>
               </a:srgbClr>
             </a:outerShdw>
@@ -18917,13 +19311,13 @@
             </a:avLst>
           </a:prstGeom>
           <a:solidFill>
-            <a:srgbClr val="FFFFFF"/>
+            <a:srgbClr val="F4F5FA"/>
           </a:solidFill>
           <a:ln/>
           <a:effectLst>
             <a:outerShdw sx="100000" sy="100000" kx="0" ky="0" algn="bl" rotWithShape="0" blurRad="127000" dist="25400" dir="5400000">
-              <a:srgbClr val="1E2B4A">
-                <a:alpha val="13000"/>
+              <a:srgbClr val="13134F">
+                <a:alpha val="10000"/>
               </a:srgbClr>
             </a:outerShdw>
           </a:effectLst>
@@ -18944,7 +19338,7 @@
             <a:avLst/>
           </a:prstGeom>
           <a:solidFill>
-            <a:srgbClr val="3E8C9A"/>
+            <a:srgbClr val="2A2A80"/>
           </a:solidFill>
           <a:ln w="31750">
             <a:solidFill>
@@ -18954,7 +19348,7 @@
           </a:ln>
           <a:effectLst>
             <a:outerShdw sx="100000" sy="100000" kx="0" ky="0" algn="bl" rotWithShape="0" blurRad="127000" dist="25400" dir="5400000">
-              <a:srgbClr val="1E2B4A">
+              <a:srgbClr val="13134F">
                 <a:alpha val="18000"/>
               </a:srgbClr>
             </a:outerShdw>
@@ -19039,7 +19433,7 @@
             <a:avLst/>
           </a:prstGeom>
           <a:solidFill>
-            <a:srgbClr val="3E8C9A"/>
+            <a:srgbClr val="2A2A80"/>
           </a:solidFill>
           <a:ln/>
         </p:spPr>
@@ -19140,7 +19534,7 @@
             <a:avLst/>
           </a:prstGeom>
           <a:solidFill>
-            <a:srgbClr val="3E8C9A"/>
+            <a:srgbClr val="2A2A80"/>
           </a:solidFill>
           <a:ln/>
         </p:spPr>
@@ -19241,7 +19635,7 @@
             <a:avLst/>
           </a:prstGeom>
           <a:solidFill>
-            <a:srgbClr val="3E8C9A"/>
+            <a:srgbClr val="2A2A80"/>
           </a:solidFill>
           <a:ln/>
         </p:spPr>
@@ -19335,8 +19729,8 @@
         </p:nvSpPr>
         <p:spPr>
           <a:xfrm>
-            <a:off x="10972800" y="6455664"/>
-            <a:ext cx="685800" cy="237744"/>
+            <a:off x="10881360" y="6455664"/>
+            <a:ext cx="365760" cy="237744"/>
           </a:xfrm>
           <a:prstGeom prst="rect">
             <a:avLst/>
@@ -19366,6 +19760,30 @@
           </a:p>
         </p:txBody>
       </p:sp>
+      <p:pic>
+        <p:nvPicPr>
+          <p:cNvPr id="25" name="Image 2" descr="logos/logo_ensae_new.png">    </p:cNvPr>
+          <p:cNvPicPr>
+            <a:picLocks noChangeAspect="1"/>
+          </p:cNvPicPr>
+          <p:nvPr/>
+        </p:nvPicPr>
+        <p:blipFill>
+          <a:blip r:embed="rId3"/>
+          <a:stretch>
+            <a:fillRect/>
+          </a:stretch>
+        </p:blipFill>
+        <p:spPr>
+          <a:xfrm>
+            <a:off x="11384280" y="6355080"/>
+            <a:ext cx="384048" cy="384048"/>
+          </a:xfrm>
+          <a:prstGeom prst="rect">
+            <a:avLst/>
+          </a:prstGeom>
+        </p:spPr>
+      </p:pic>
     </p:spTree>
   </p:cSld>
   <p:clrMapOvr>
@@ -19380,7 +19798,7 @@
     <p:bg>
       <p:bgPr>
         <a:solidFill>
-          <a:srgbClr val="16213D"/>
+          <a:srgbClr val="101038"/>
         </a:solidFill>
       </p:bgPr>
     </p:bg>
@@ -19413,7 +19831,7 @@
             <a:avLst/>
           </a:prstGeom>
           <a:solidFill>
-            <a:srgbClr val="24365E"/>
+            <a:srgbClr val="23236B"/>
           </a:solidFill>
           <a:ln/>
         </p:spPr>
@@ -19433,7 +19851,7 @@
             <a:avLst/>
           </a:prstGeom>
           <a:solidFill>
-            <a:srgbClr val="24365E"/>
+            <a:srgbClr val="23236B"/>
           </a:solidFill>
           <a:ln/>
         </p:spPr>
@@ -19546,7 +19964,7 @@
             <a:r>
               <a:rPr lang="en-US" sz="1400" dirty="0">
                 <a:solidFill>
-                  <a:srgbClr val="AFC0DA"/>
+                  <a:srgbClr val="B7B7DB"/>
                 </a:solidFill>
                 <a:latin typeface="Calibri" pitchFamily="34" charset="0"/>
                 <a:ea typeface="Calibri" pitchFamily="34" charset="-122"/>
@@ -19572,7 +19990,7 @@
     <p:bg>
       <p:bgPr>
         <a:solidFill>
-          <a:srgbClr val="FBFAF8"/>
+          <a:srgbClr val="FFFFFF"/>
         </a:solidFill>
       </p:bgPr>
     </p:bg>
@@ -19617,7 +20035,7 @@
             <a:r>
               <a:rPr lang="en-US" sz="2700" b="1" dirty="0">
                 <a:solidFill>
-                  <a:srgbClr val="1E2B4A"/>
+                  <a:srgbClr val="191970"/>
                 </a:solidFill>
                 <a:latin typeface="Calibri" pitchFamily="34" charset="0"/>
                 <a:ea typeface="Calibri" pitchFamily="34" charset="-122"/>
@@ -19646,13 +20064,13 @@
             </a:avLst>
           </a:prstGeom>
           <a:solidFill>
-            <a:srgbClr val="1E2B4A"/>
+            <a:srgbClr val="191970"/>
           </a:solidFill>
           <a:ln/>
           <a:effectLst>
             <a:outerShdw sx="100000" sy="100000" kx="0" ky="0" algn="bl" rotWithShape="0" blurRad="127000" dist="25400" dir="5400000">
-              <a:srgbClr val="1E2B4A">
-                <a:alpha val="13000"/>
+              <a:srgbClr val="13134F">
+                <a:alpha val="10000"/>
               </a:srgbClr>
             </a:outerShdw>
           </a:effectLst>
@@ -19717,13 +20135,13 @@
             </a:avLst>
           </a:prstGeom>
           <a:solidFill>
-            <a:srgbClr val="FFFFFF"/>
+            <a:srgbClr val="F4F5FA"/>
           </a:solidFill>
           <a:ln/>
           <a:effectLst>
             <a:outerShdw sx="100000" sy="100000" kx="0" ky="0" algn="bl" rotWithShape="0" blurRad="127000" dist="25400" dir="5400000">
-              <a:srgbClr val="1E2B4A">
-                <a:alpha val="13000"/>
+              <a:srgbClr val="13134F">
+                <a:alpha val="10000"/>
               </a:srgbClr>
             </a:outerShdw>
           </a:effectLst>
@@ -19866,13 +20284,13 @@
             </a:avLst>
           </a:prstGeom>
           <a:solidFill>
-            <a:srgbClr val="FFFFFF"/>
+            <a:srgbClr val="F4F5FA"/>
           </a:solidFill>
           <a:ln/>
           <a:effectLst>
             <a:outerShdw sx="100000" sy="100000" kx="0" ky="0" algn="bl" rotWithShape="0" blurRad="127000" dist="25400" dir="5400000">
-              <a:srgbClr val="1E2B4A">
-                <a:alpha val="13000"/>
+              <a:srgbClr val="13134F">
+                <a:alpha val="10000"/>
               </a:srgbClr>
             </a:outerShdw>
           </a:effectLst>
@@ -19905,7 +20323,7 @@
             <a:r>
               <a:rPr lang="en-US" sz="3600" b="1" dirty="0">
                 <a:solidFill>
-                  <a:srgbClr val="41639E"/>
+                  <a:srgbClr val="4444AD"/>
                 </a:solidFill>
                 <a:latin typeface="Calibri" pitchFamily="34" charset="0"/>
                 <a:ea typeface="Calibri" pitchFamily="34" charset="-122"/>
@@ -20015,13 +20433,13 @@
             </a:avLst>
           </a:prstGeom>
           <a:solidFill>
-            <a:srgbClr val="FFFFFF"/>
+            <a:srgbClr val="F4F5FA"/>
           </a:solidFill>
           <a:ln/>
           <a:effectLst>
             <a:outerShdw sx="100000" sy="100000" kx="0" ky="0" algn="bl" rotWithShape="0" blurRad="127000" dist="25400" dir="5400000">
-              <a:srgbClr val="1E2B4A">
-                <a:alpha val="13000"/>
+              <a:srgbClr val="13134F">
+                <a:alpha val="10000"/>
               </a:srgbClr>
             </a:outerShdw>
           </a:effectLst>
@@ -20054,7 +20472,7 @@
             <a:r>
               <a:rPr lang="en-US" sz="3600" b="1" dirty="0">
                 <a:solidFill>
-                  <a:srgbClr val="3E8C9A"/>
+                  <a:srgbClr val="2A2A80"/>
                 </a:solidFill>
                 <a:latin typeface="Calibri" pitchFamily="34" charset="0"/>
                 <a:ea typeface="Calibri" pitchFamily="34" charset="-122"/>
@@ -20164,13 +20582,13 @@
             </a:avLst>
           </a:prstGeom>
           <a:solidFill>
-            <a:srgbClr val="FFFFFF"/>
+            <a:srgbClr val="F4F5FA"/>
           </a:solidFill>
           <a:ln/>
           <a:effectLst>
             <a:outerShdw sx="100000" sy="100000" kx="0" ky="0" algn="bl" rotWithShape="0" blurRad="127000" dist="25400" dir="5400000">
-              <a:srgbClr val="1E2B4A">
-                <a:alpha val="13000"/>
+              <a:srgbClr val="13134F">
+                <a:alpha val="10000"/>
               </a:srgbClr>
             </a:outerShdw>
           </a:effectLst>
@@ -20203,7 +20621,7 @@
             <a:r>
               <a:rPr lang="en-US" sz="3600" b="1" dirty="0">
                 <a:solidFill>
-                  <a:srgbClr val="C98A24"/>
+                  <a:srgbClr val="6E6ECB"/>
                 </a:solidFill>
                 <a:latin typeface="Calibri" pitchFamily="34" charset="0"/>
                 <a:ea typeface="Calibri" pitchFamily="34" charset="-122"/>
@@ -20304,8 +20722,8 @@
         </p:nvSpPr>
         <p:spPr>
           <a:xfrm>
-            <a:off x="10972800" y="6455664"/>
-            <a:ext cx="685800" cy="237744"/>
+            <a:off x="10881360" y="6455664"/>
+            <a:ext cx="365760" cy="237744"/>
           </a:xfrm>
           <a:prstGeom prst="rect">
             <a:avLst/>
@@ -20335,6 +20753,30 @@
           </a:p>
         </p:txBody>
       </p:sp>
+      <p:pic>
+        <p:nvPicPr>
+          <p:cNvPr id="22" name="Image 0" descr="logos/logo_ensae_new.png">    </p:cNvPr>
+          <p:cNvPicPr>
+            <a:picLocks noChangeAspect="1"/>
+          </p:cNvPicPr>
+          <p:nvPr/>
+        </p:nvPicPr>
+        <p:blipFill>
+          <a:blip r:embed="rId1"/>
+          <a:stretch>
+            <a:fillRect/>
+          </a:stretch>
+        </p:blipFill>
+        <p:spPr>
+          <a:xfrm>
+            <a:off x="11384280" y="6355080"/>
+            <a:ext cx="384048" cy="384048"/>
+          </a:xfrm>
+          <a:prstGeom prst="rect">
+            <a:avLst/>
+          </a:prstGeom>
+        </p:spPr>
+      </p:pic>
     </p:spTree>
   </p:cSld>
   <p:clrMapOvr>
@@ -20349,7 +20791,7 @@
     <p:bg>
       <p:bgPr>
         <a:solidFill>
-          <a:srgbClr val="FBFAF8"/>
+          <a:srgbClr val="FFFFFF"/>
         </a:solidFill>
       </p:bgPr>
     </p:bg>
@@ -20394,7 +20836,7 @@
             <a:r>
               <a:rPr lang="en-US" sz="2700" b="1" dirty="0">
                 <a:solidFill>
-                  <a:srgbClr val="1E2B4A"/>
+                  <a:srgbClr val="191970"/>
                 </a:solidFill>
                 <a:latin typeface="Calibri" pitchFamily="34" charset="0"/>
                 <a:ea typeface="Calibri" pitchFamily="34" charset="-122"/>
@@ -20465,13 +20907,13 @@
             </a:avLst>
           </a:prstGeom>
           <a:solidFill>
-            <a:srgbClr val="FFFFFF"/>
+            <a:srgbClr val="F4F5FA"/>
           </a:solidFill>
           <a:ln/>
           <a:effectLst>
             <a:outerShdw sx="100000" sy="100000" kx="0" ky="0" algn="bl" rotWithShape="0" blurRad="127000" dist="25400" dir="5400000">
-              <a:srgbClr val="1E2B4A">
-                <a:alpha val="13000"/>
+              <a:srgbClr val="13134F">
+                <a:alpha val="10000"/>
               </a:srgbClr>
             </a:outerShdw>
           </a:effectLst>
@@ -20492,7 +20934,7 @@
             <a:avLst/>
           </a:prstGeom>
           <a:solidFill>
-            <a:srgbClr val="C98A24"/>
+            <a:srgbClr val="6E6ECB"/>
           </a:solidFill>
           <a:ln w="31750">
             <a:solidFill>
@@ -20502,7 +20944,7 @@
           </a:ln>
           <a:effectLst>
             <a:outerShdw sx="100000" sy="100000" kx="0" ky="0" algn="bl" rotWithShape="0" blurRad="127000" dist="25400" dir="5400000">
-              <a:srgbClr val="1E2B4A">
+              <a:srgbClr val="13134F">
                 <a:alpha val="18000"/>
               </a:srgbClr>
             </a:outerShdw>
@@ -20634,13 +21076,13 @@
             </a:avLst>
           </a:prstGeom>
           <a:solidFill>
-            <a:srgbClr val="FFFFFF"/>
+            <a:srgbClr val="F4F5FA"/>
           </a:solidFill>
           <a:ln/>
           <a:effectLst>
             <a:outerShdw sx="100000" sy="100000" kx="0" ky="0" algn="bl" rotWithShape="0" blurRad="127000" dist="25400" dir="5400000">
-              <a:srgbClr val="1E2B4A">
-                <a:alpha val="13000"/>
+              <a:srgbClr val="13134F">
+                <a:alpha val="10000"/>
               </a:srgbClr>
             </a:outerShdw>
           </a:effectLst>
@@ -20661,7 +21103,7 @@
             <a:avLst/>
           </a:prstGeom>
           <a:solidFill>
-            <a:srgbClr val="41639E"/>
+            <a:srgbClr val="4444AD"/>
           </a:solidFill>
           <a:ln w="31750">
             <a:solidFill>
@@ -20671,7 +21113,7 @@
           </a:ln>
           <a:effectLst>
             <a:outerShdw sx="100000" sy="100000" kx="0" ky="0" algn="bl" rotWithShape="0" blurRad="127000" dist="25400" dir="5400000">
-              <a:srgbClr val="1E2B4A">
+              <a:srgbClr val="13134F">
                 <a:alpha val="18000"/>
               </a:srgbClr>
             </a:outerShdw>
@@ -20803,13 +21245,13 @@
             </a:avLst>
           </a:prstGeom>
           <a:solidFill>
-            <a:srgbClr val="FFFFFF"/>
+            <a:srgbClr val="F4F5FA"/>
           </a:solidFill>
           <a:ln/>
           <a:effectLst>
             <a:outerShdw sx="100000" sy="100000" kx="0" ky="0" algn="bl" rotWithShape="0" blurRad="127000" dist="25400" dir="5400000">
-              <a:srgbClr val="1E2B4A">
-                <a:alpha val="13000"/>
+              <a:srgbClr val="13134F">
+                <a:alpha val="10000"/>
               </a:srgbClr>
             </a:outerShdw>
           </a:effectLst>
@@ -20830,7 +21272,7 @@
             <a:avLst/>
           </a:prstGeom>
           <a:solidFill>
-            <a:srgbClr val="3E8C9A"/>
+            <a:srgbClr val="2A2A80"/>
           </a:solidFill>
           <a:ln w="31750">
             <a:solidFill>
@@ -20840,7 +21282,7 @@
           </a:ln>
           <a:effectLst>
             <a:outerShdw sx="100000" sy="100000" kx="0" ky="0" algn="bl" rotWithShape="0" blurRad="127000" dist="25400" dir="5400000">
-              <a:srgbClr val="1E2B4A">
+              <a:srgbClr val="13134F">
                 <a:alpha val="18000"/>
               </a:srgbClr>
             </a:outerShdw>
@@ -20963,8 +21405,8 @@
         </p:nvSpPr>
         <p:spPr>
           <a:xfrm>
-            <a:off x="10972800" y="6455664"/>
-            <a:ext cx="685800" cy="237744"/>
+            <a:off x="10881360" y="6455664"/>
+            <a:ext cx="365760" cy="237744"/>
           </a:xfrm>
           <a:prstGeom prst="rect">
             <a:avLst/>
@@ -20994,6 +21436,30 @@
           </a:p>
         </p:txBody>
       </p:sp>
+      <p:pic>
+        <p:nvPicPr>
+          <p:cNvPr id="20" name="Image 3" descr="logos/logo_ensae_new.png">    </p:cNvPr>
+          <p:cNvPicPr>
+            <a:picLocks noChangeAspect="1"/>
+          </p:cNvPicPr>
+          <p:nvPr/>
+        </p:nvPicPr>
+        <p:blipFill>
+          <a:blip r:embed="rId4"/>
+          <a:stretch>
+            <a:fillRect/>
+          </a:stretch>
+        </p:blipFill>
+        <p:spPr>
+          <a:xfrm>
+            <a:off x="11384280" y="6355080"/>
+            <a:ext cx="384048" cy="384048"/>
+          </a:xfrm>
+          <a:prstGeom prst="rect">
+            <a:avLst/>
+          </a:prstGeom>
+        </p:spPr>
+      </p:pic>
     </p:spTree>
   </p:cSld>
   <p:clrMapOvr>
@@ -21008,7 +21474,7 @@
     <p:bg>
       <p:bgPr>
         <a:solidFill>
-          <a:srgbClr val="16213D"/>
+          <a:srgbClr val="101038"/>
         </a:solidFill>
       </p:bgPr>
     </p:bg>
@@ -21041,7 +21507,7 @@
             <a:avLst/>
           </a:prstGeom>
           <a:solidFill>
-            <a:srgbClr val="24365E"/>
+            <a:srgbClr val="23236B"/>
           </a:solidFill>
           <a:ln/>
         </p:spPr>
@@ -21061,7 +21527,7 @@
             <a:avLst/>
           </a:prstGeom>
           <a:solidFill>
-            <a:srgbClr val="24365E"/>
+            <a:srgbClr val="23236B"/>
           </a:solidFill>
           <a:ln/>
         </p:spPr>
@@ -21197,7 +21663,7 @@
     <p:bg>
       <p:bgPr>
         <a:solidFill>
-          <a:srgbClr val="16213D"/>
+          <a:srgbClr val="101038"/>
         </a:solidFill>
       </p:bgPr>
     </p:bg>
@@ -21230,7 +21696,7 @@
             <a:avLst/>
           </a:prstGeom>
           <a:solidFill>
-            <a:srgbClr val="24365E"/>
+            <a:srgbClr val="23236B"/>
           </a:solidFill>
           <a:ln/>
         </p:spPr>
@@ -21250,7 +21716,7 @@
             <a:avLst/>
           </a:prstGeom>
           <a:solidFill>
-            <a:srgbClr val="24365E"/>
+            <a:srgbClr val="23236B"/>
           </a:solidFill>
           <a:ln/>
         </p:spPr>
@@ -21363,7 +21829,7 @@
             <a:r>
               <a:rPr lang="en-US" sz="1400" dirty="0">
                 <a:solidFill>
-                  <a:srgbClr val="AFC0DA"/>
+                  <a:srgbClr val="B7B7DB"/>
                 </a:solidFill>
                 <a:latin typeface="Calibri" pitchFamily="34" charset="0"/>
                 <a:ea typeface="Calibri" pitchFamily="34" charset="-122"/>
@@ -21389,7 +21855,7 @@
     <p:bg>
       <p:bgPr>
         <a:solidFill>
-          <a:srgbClr val="FBFAF8"/>
+          <a:srgbClr val="FFFFFF"/>
         </a:solidFill>
       </p:bgPr>
     </p:bg>
@@ -21434,7 +21900,7 @@
             <a:r>
               <a:rPr lang="en-US" sz="2700" b="1" dirty="0">
                 <a:solidFill>
-                  <a:srgbClr val="1E2B4A"/>
+                  <a:srgbClr val="191970"/>
                 </a:solidFill>
                 <a:latin typeface="Calibri" pitchFamily="34" charset="0"/>
                 <a:ea typeface="Calibri" pitchFamily="34" charset="-122"/>
@@ -21463,13 +21929,13 @@
             </a:avLst>
           </a:prstGeom>
           <a:solidFill>
-            <a:srgbClr val="FFFFFF"/>
+            <a:srgbClr val="F4F5FA"/>
           </a:solidFill>
           <a:ln/>
           <a:effectLst>
             <a:outerShdw sx="100000" sy="100000" kx="0" ky="0" algn="bl" rotWithShape="0" blurRad="127000" dist="25400" dir="5400000">
-              <a:srgbClr val="1E2B4A">
-                <a:alpha val="13000"/>
+              <a:srgbClr val="13134F">
+                <a:alpha val="10000"/>
               </a:srgbClr>
             </a:outerShdw>
           </a:effectLst>
@@ -21490,7 +21956,7 @@
             <a:avLst/>
           </a:prstGeom>
           <a:solidFill>
-            <a:srgbClr val="41639E"/>
+            <a:srgbClr val="4444AD"/>
           </a:solidFill>
           <a:ln w="31750">
             <a:solidFill>
@@ -21500,7 +21966,7 @@
           </a:ln>
           <a:effectLst>
             <a:outerShdw sx="100000" sy="100000" kx="0" ky="0" algn="bl" rotWithShape="0" blurRad="127000" dist="25400" dir="5400000">
-              <a:srgbClr val="1E2B4A">
+              <a:srgbClr val="13134F">
                 <a:alpha val="18000"/>
               </a:srgbClr>
             </a:outerShdw>
@@ -21600,7 +22066,7 @@
             <a:r>
               <a:rPr lang="en-US" sz="3400" b="1" dirty="0">
                 <a:solidFill>
-                  <a:srgbClr val="41639E"/>
+                  <a:srgbClr val="4444AD"/>
                 </a:solidFill>
                 <a:latin typeface="Calibri" pitchFamily="34" charset="0"/>
                 <a:ea typeface="Calibri" pitchFamily="34" charset="-122"/>
@@ -21701,7 +22167,7 @@
             <a:r>
               <a:rPr lang="en-US" sz="3400" b="1" dirty="0">
                 <a:solidFill>
-                  <a:srgbClr val="41639E"/>
+                  <a:srgbClr val="4444AD"/>
                 </a:solidFill>
                 <a:latin typeface="Calibri" pitchFamily="34" charset="0"/>
                 <a:ea typeface="Calibri" pitchFamily="34" charset="-122"/>
@@ -21873,13 +22339,13 @@
             </a:avLst>
           </a:prstGeom>
           <a:solidFill>
-            <a:srgbClr val="FFFFFF"/>
+            <a:srgbClr val="F4F5FA"/>
           </a:solidFill>
           <a:ln/>
           <a:effectLst>
             <a:outerShdw sx="100000" sy="100000" kx="0" ky="0" algn="bl" rotWithShape="0" blurRad="127000" dist="25400" dir="5400000">
-              <a:srgbClr val="1E2B4A">
-                <a:alpha val="13000"/>
+              <a:srgbClr val="13134F">
+                <a:alpha val="10000"/>
               </a:srgbClr>
             </a:outerShdw>
           </a:effectLst>
@@ -21910,7 +22376,7 @@
           </a:ln>
           <a:effectLst>
             <a:outerShdw sx="100000" sy="100000" kx="0" ky="0" algn="bl" rotWithShape="0" blurRad="127000" dist="25400" dir="5400000">
-              <a:srgbClr val="1E2B4A">
+              <a:srgbClr val="13134F">
                 <a:alpha val="18000"/>
               </a:srgbClr>
             </a:outerShdw>
@@ -22274,8 +22740,8 @@
         </p:nvSpPr>
         <p:spPr>
           <a:xfrm>
-            <a:off x="10972800" y="6455664"/>
-            <a:ext cx="685800" cy="237744"/>
+            <a:off x="10881360" y="6455664"/>
+            <a:ext cx="365760" cy="237744"/>
           </a:xfrm>
           <a:prstGeom prst="rect">
             <a:avLst/>
@@ -22305,6 +22771,30 @@
           </a:p>
         </p:txBody>
       </p:sp>
+      <p:pic>
+        <p:nvPicPr>
+          <p:cNvPr id="24" name="Image 2" descr="logos/logo_ensae_new.png">    </p:cNvPr>
+          <p:cNvPicPr>
+            <a:picLocks noChangeAspect="1"/>
+          </p:cNvPicPr>
+          <p:nvPr/>
+        </p:nvPicPr>
+        <p:blipFill>
+          <a:blip r:embed="rId3"/>
+          <a:stretch>
+            <a:fillRect/>
+          </a:stretch>
+        </p:blipFill>
+        <p:spPr>
+          <a:xfrm>
+            <a:off x="11384280" y="6355080"/>
+            <a:ext cx="384048" cy="384048"/>
+          </a:xfrm>
+          <a:prstGeom prst="rect">
+            <a:avLst/>
+          </a:prstGeom>
+        </p:spPr>
+      </p:pic>
     </p:spTree>
   </p:cSld>
   <p:clrMapOvr>
@@ -22319,7 +22809,7 @@
     <p:bg>
       <p:bgPr>
         <a:solidFill>
-          <a:srgbClr val="FBFAF8"/>
+          <a:srgbClr val="FFFFFF"/>
         </a:solidFill>
       </p:bgPr>
     </p:bg>
@@ -22364,7 +22854,7 @@
             <a:r>
               <a:rPr lang="en-US" sz="2700" b="1" dirty="0">
                 <a:solidFill>
-                  <a:srgbClr val="1E2B4A"/>
+                  <a:srgbClr val="191970"/>
                 </a:solidFill>
                 <a:latin typeface="Calibri" pitchFamily="34" charset="0"/>
                 <a:ea typeface="Calibri" pitchFamily="34" charset="-122"/>
@@ -22393,13 +22883,13 @@
             </a:avLst>
           </a:prstGeom>
           <a:solidFill>
-            <a:srgbClr val="1E2B4A"/>
+            <a:srgbClr val="191970"/>
           </a:solidFill>
           <a:ln/>
           <a:effectLst>
             <a:outerShdw sx="100000" sy="100000" kx="0" ky="0" algn="bl" rotWithShape="0" blurRad="127000" dist="25400" dir="5400000">
-              <a:srgbClr val="1E2B4A">
-                <a:alpha val="13000"/>
+              <a:srgbClr val="13134F">
+                <a:alpha val="10000"/>
               </a:srgbClr>
             </a:outerShdw>
           </a:effectLst>
@@ -22484,13 +22974,13 @@
             </a:avLst>
           </a:prstGeom>
           <a:solidFill>
-            <a:srgbClr val="FFFFFF"/>
+            <a:srgbClr val="F4F5FA"/>
           </a:solidFill>
           <a:ln/>
           <a:effectLst>
             <a:outerShdw sx="100000" sy="100000" kx="0" ky="0" algn="bl" rotWithShape="0" blurRad="127000" dist="25400" dir="5400000">
-              <a:srgbClr val="1E2B4A">
-                <a:alpha val="13000"/>
+              <a:srgbClr val="13134F">
+                <a:alpha val="10000"/>
               </a:srgbClr>
             </a:outerShdw>
           </a:effectLst>
@@ -22597,13 +23087,13 @@
             </a:avLst>
           </a:prstGeom>
           <a:solidFill>
-            <a:srgbClr val="FFFFFF"/>
+            <a:srgbClr val="F4F5FA"/>
           </a:solidFill>
           <a:ln/>
           <a:effectLst>
             <a:outerShdw sx="100000" sy="100000" kx="0" ky="0" algn="bl" rotWithShape="0" blurRad="127000" dist="25400" dir="5400000">
-              <a:srgbClr val="1E2B4A">
-                <a:alpha val="13000"/>
+              <a:srgbClr val="13134F">
+                <a:alpha val="10000"/>
               </a:srgbClr>
             </a:outerShdw>
           </a:effectLst>
@@ -22710,13 +23200,13 @@
             </a:avLst>
           </a:prstGeom>
           <a:solidFill>
-            <a:srgbClr val="FFFFFF"/>
+            <a:srgbClr val="F4F5FA"/>
           </a:solidFill>
           <a:ln/>
           <a:effectLst>
             <a:outerShdw sx="100000" sy="100000" kx="0" ky="0" algn="bl" rotWithShape="0" blurRad="127000" dist="25400" dir="5400000">
-              <a:srgbClr val="1E2B4A">
-                <a:alpha val="13000"/>
+              <a:srgbClr val="13134F">
+                <a:alpha val="10000"/>
               </a:srgbClr>
             </a:outerShdw>
           </a:effectLst>
@@ -22831,7 +23321,7 @@
           </a:ln>
           <a:effectLst>
             <a:outerShdw sx="100000" sy="100000" kx="0" ky="0" algn="bl" rotWithShape="0" blurRad="127000" dist="25400" dir="5400000">
-              <a:srgbClr val="1E2B4A">
+              <a:srgbClr val="13134F">
                 <a:alpha val="18000"/>
               </a:srgbClr>
             </a:outerShdw>
@@ -22877,7 +23367,7 @@
             <a:avLst/>
           </a:prstGeom>
           <a:solidFill>
-            <a:srgbClr val="C98A24"/>
+            <a:srgbClr val="6E6ECB"/>
           </a:solidFill>
           <a:ln w="31750">
             <a:solidFill>
@@ -22887,7 +23377,7 @@
           </a:ln>
           <a:effectLst>
             <a:outerShdw sx="100000" sy="100000" kx="0" ky="0" algn="bl" rotWithShape="0" blurRad="127000" dist="25400" dir="5400000">
-              <a:srgbClr val="1E2B4A">
+              <a:srgbClr val="13134F">
                 <a:alpha val="18000"/>
               </a:srgbClr>
             </a:outerShdw>
@@ -22933,7 +23423,7 @@
             <a:avLst/>
           </a:prstGeom>
           <a:solidFill>
-            <a:srgbClr val="3E8C9A"/>
+            <a:srgbClr val="2A2A80"/>
           </a:solidFill>
           <a:ln w="31750">
             <a:solidFill>
@@ -22943,7 +23433,7 @@
           </a:ln>
           <a:effectLst>
             <a:outerShdw sx="100000" sy="100000" kx="0" ky="0" algn="bl" rotWithShape="0" blurRad="127000" dist="25400" dir="5400000">
-              <a:srgbClr val="1E2B4A">
+              <a:srgbClr val="13134F">
                 <a:alpha val="18000"/>
               </a:srgbClr>
             </a:outerShdw>
@@ -22982,8 +23472,8 @@
         </p:nvSpPr>
         <p:spPr>
           <a:xfrm>
-            <a:off x="10972800" y="6455664"/>
-            <a:ext cx="685800" cy="237744"/>
+            <a:off x="10881360" y="6455664"/>
+            <a:ext cx="365760" cy="237744"/>
           </a:xfrm>
           <a:prstGeom prst="rect">
             <a:avLst/>
@@ -23013,6 +23503,30 @@
           </a:p>
         </p:txBody>
       </p:sp>
+      <p:pic>
+        <p:nvPicPr>
+          <p:cNvPr id="21" name="Image 3" descr="logos/logo_ensae_new.png">    </p:cNvPr>
+          <p:cNvPicPr>
+            <a:picLocks noChangeAspect="1"/>
+          </p:cNvPicPr>
+          <p:nvPr/>
+        </p:nvPicPr>
+        <p:blipFill>
+          <a:blip r:embed="rId4"/>
+          <a:stretch>
+            <a:fillRect/>
+          </a:stretch>
+        </p:blipFill>
+        <p:spPr>
+          <a:xfrm>
+            <a:off x="11384280" y="6355080"/>
+            <a:ext cx="384048" cy="384048"/>
+          </a:xfrm>
+          <a:prstGeom prst="rect">
+            <a:avLst/>
+          </a:prstGeom>
+        </p:spPr>
+      </p:pic>
     </p:spTree>
   </p:cSld>
   <p:clrMapOvr>
@@ -23027,7 +23541,7 @@
     <p:bg>
       <p:bgPr>
         <a:solidFill>
-          <a:srgbClr val="FBFAF8"/>
+          <a:srgbClr val="FFFFFF"/>
         </a:solidFill>
       </p:bgPr>
     </p:bg>
@@ -23072,7 +23586,7 @@
             <a:r>
               <a:rPr lang="en-US" sz="2700" b="1" dirty="0">
                 <a:solidFill>
-                  <a:srgbClr val="1E2B4A"/>
+                  <a:srgbClr val="191970"/>
                 </a:solidFill>
                 <a:latin typeface="Calibri" pitchFamily="34" charset="0"/>
                 <a:ea typeface="Calibri" pitchFamily="34" charset="-122"/>
@@ -23101,13 +23615,13 @@
             </a:avLst>
           </a:prstGeom>
           <a:solidFill>
-            <a:srgbClr val="FFFFFF"/>
+            <a:srgbClr val="F4F5FA"/>
           </a:solidFill>
           <a:ln/>
           <a:effectLst>
             <a:outerShdw sx="100000" sy="100000" kx="0" ky="0" algn="bl" rotWithShape="0" blurRad="127000" dist="25400" dir="5400000">
-              <a:srgbClr val="1E2B4A">
-                <a:alpha val="13000"/>
+              <a:srgbClr val="13134F">
+                <a:alpha val="10000"/>
               </a:srgbClr>
             </a:outerShdw>
           </a:effectLst>
@@ -23128,7 +23642,7 @@
             <a:avLst/>
           </a:prstGeom>
           <a:solidFill>
-            <a:srgbClr val="41639E"/>
+            <a:srgbClr val="4444AD"/>
           </a:solidFill>
           <a:ln w="31750">
             <a:solidFill>
@@ -23138,7 +23652,7 @@
           </a:ln>
           <a:effectLst>
             <a:outerShdw sx="100000" sy="100000" kx="0" ky="0" algn="bl" rotWithShape="0" blurRad="127000" dist="25400" dir="5400000">
-              <a:srgbClr val="1E2B4A">
+              <a:srgbClr val="13134F">
                 <a:alpha val="18000"/>
               </a:srgbClr>
             </a:outerShdw>
@@ -23265,7 +23779,7 @@
             <a:avLst/>
           </a:prstGeom>
           <a:solidFill>
-            <a:srgbClr val="41639E"/>
+            <a:srgbClr val="4444AD"/>
           </a:solidFill>
           <a:ln/>
         </p:spPr>
@@ -23366,7 +23880,7 @@
             <a:avLst/>
           </a:prstGeom>
           <a:solidFill>
-            <a:srgbClr val="41639E"/>
+            <a:srgbClr val="4444AD"/>
           </a:solidFill>
           <a:ln/>
         </p:spPr>
@@ -23469,13 +23983,13 @@
             </a:avLst>
           </a:prstGeom>
           <a:solidFill>
-            <a:srgbClr val="FFFFFF"/>
+            <a:srgbClr val="F4F5FA"/>
           </a:solidFill>
           <a:ln/>
           <a:effectLst>
             <a:outerShdw sx="100000" sy="100000" kx="0" ky="0" algn="bl" rotWithShape="0" blurRad="127000" dist="25400" dir="5400000">
-              <a:srgbClr val="1E2B4A">
-                <a:alpha val="13000"/>
+              <a:srgbClr val="13134F">
+                <a:alpha val="10000"/>
               </a:srgbClr>
             </a:outerShdw>
           </a:effectLst>
@@ -23506,7 +24020,7 @@
           </a:ln>
           <a:effectLst>
             <a:outerShdw sx="100000" sy="100000" kx="0" ky="0" algn="bl" rotWithShape="0" blurRad="127000" dist="25400" dir="5400000">
-              <a:srgbClr val="1E2B4A">
+              <a:srgbClr val="13134F">
                 <a:alpha val="18000"/>
               </a:srgbClr>
             </a:outerShdw>
@@ -23593,13 +24107,13 @@
             </a:avLst>
           </a:prstGeom>
           <a:solidFill>
-            <a:srgbClr val="FBFAF8"/>
+            <a:srgbClr val="E7E7F3"/>
           </a:solidFill>
           <a:ln/>
           <a:effectLst>
             <a:outerShdw sx="100000" sy="100000" kx="0" ky="0" algn="bl" rotWithShape="0" blurRad="127000" dist="25400" dir="5400000">
-              <a:srgbClr val="1E2B4A">
-                <a:alpha val="13000"/>
+              <a:srgbClr val="13134F">
+                <a:alpha val="10000"/>
               </a:srgbClr>
             </a:outerShdw>
           </a:effectLst>
@@ -23703,13 +24217,13 @@
             </a:avLst>
           </a:prstGeom>
           <a:solidFill>
-            <a:srgbClr val="FBFAF8"/>
+            <a:srgbClr val="E7E7F3"/>
           </a:solidFill>
           <a:ln/>
           <a:effectLst>
             <a:outerShdw sx="100000" sy="100000" kx="0" ky="0" algn="bl" rotWithShape="0" blurRad="127000" dist="25400" dir="5400000">
-              <a:srgbClr val="1E2B4A">
-                <a:alpha val="13000"/>
+              <a:srgbClr val="13134F">
+                <a:alpha val="10000"/>
               </a:srgbClr>
             </a:outerShdw>
           </a:effectLst>
@@ -23804,8 +24318,8 @@
         </p:nvSpPr>
         <p:spPr>
           <a:xfrm>
-            <a:off x="10972800" y="6455664"/>
-            <a:ext cx="685800" cy="237744"/>
+            <a:off x="10881360" y="6455664"/>
+            <a:ext cx="365760" cy="237744"/>
           </a:xfrm>
           <a:prstGeom prst="rect">
             <a:avLst/>
@@ -23835,6 +24349,30 @@
           </a:p>
         </p:txBody>
       </p:sp>
+      <p:pic>
+        <p:nvPicPr>
+          <p:cNvPr id="25" name="Image 2" descr="logos/logo_ensae_new.png">    </p:cNvPr>
+          <p:cNvPicPr>
+            <a:picLocks noChangeAspect="1"/>
+          </p:cNvPicPr>
+          <p:nvPr/>
+        </p:nvPicPr>
+        <p:blipFill>
+          <a:blip r:embed="rId3"/>
+          <a:stretch>
+            <a:fillRect/>
+          </a:stretch>
+        </p:blipFill>
+        <p:spPr>
+          <a:xfrm>
+            <a:off x="11384280" y="6355080"/>
+            <a:ext cx="384048" cy="384048"/>
+          </a:xfrm>
+          <a:prstGeom prst="rect">
+            <a:avLst/>
+          </a:prstGeom>
+        </p:spPr>
+      </p:pic>
     </p:spTree>
   </p:cSld>
   <p:clrMapOvr>
@@ -23849,7 +24387,7 @@
     <p:bg>
       <p:bgPr>
         <a:solidFill>
-          <a:srgbClr val="16213D"/>
+          <a:srgbClr val="101038"/>
         </a:solidFill>
       </p:bgPr>
     </p:bg>
@@ -23882,7 +24420,7 @@
             <a:avLst/>
           </a:prstGeom>
           <a:solidFill>
-            <a:srgbClr val="24365E"/>
+            <a:srgbClr val="23236B"/>
           </a:solidFill>
           <a:ln/>
         </p:spPr>
@@ -23902,7 +24440,7 @@
             <a:avLst/>
           </a:prstGeom>
           <a:solidFill>
-            <a:srgbClr val="24365E"/>
+            <a:srgbClr val="23236B"/>
           </a:solidFill>
           <a:ln/>
         </p:spPr>
@@ -24015,7 +24553,7 @@
             <a:r>
               <a:rPr lang="en-US" sz="1400" dirty="0">
                 <a:solidFill>
-                  <a:srgbClr val="AFC0DA"/>
+                  <a:srgbClr val="B7B7DB"/>
                 </a:solidFill>
                 <a:latin typeface="Calibri" pitchFamily="34" charset="0"/>
                 <a:ea typeface="Calibri" pitchFamily="34" charset="-122"/>
@@ -24041,7 +24579,7 @@
     <p:bg>
       <p:bgPr>
         <a:solidFill>
-          <a:srgbClr val="FBFAF8"/>
+          <a:srgbClr val="FFFFFF"/>
         </a:solidFill>
       </p:bgPr>
     </p:bg>
@@ -24086,7 +24624,7 @@
             <a:r>
               <a:rPr lang="en-US" sz="2700" b="1" dirty="0">
                 <a:solidFill>
-                  <a:srgbClr val="1E2B4A"/>
+                  <a:srgbClr val="191970"/>
                 </a:solidFill>
                 <a:latin typeface="Calibri" pitchFamily="34" charset="0"/>
                 <a:ea typeface="Calibri" pitchFamily="34" charset="-122"/>
@@ -24115,13 +24653,13 @@
             </a:avLst>
           </a:prstGeom>
           <a:solidFill>
-            <a:srgbClr val="FFFFFF"/>
+            <a:srgbClr val="F4F5FA"/>
           </a:solidFill>
           <a:ln/>
           <a:effectLst>
             <a:outerShdw sx="100000" sy="100000" kx="0" ky="0" algn="bl" rotWithShape="0" blurRad="127000" dist="25400" dir="5400000">
-              <a:srgbClr val="1E2B4A">
-                <a:alpha val="13000"/>
+              <a:srgbClr val="13134F">
+                <a:alpha val="10000"/>
               </a:srgbClr>
             </a:outerShdw>
           </a:effectLst>
@@ -24181,7 +24719,7 @@
             <a:avLst/>
           </a:prstGeom>
           <a:solidFill>
-            <a:srgbClr val="41639E"/>
+            <a:srgbClr val="4444AD"/>
           </a:solidFill>
           <a:ln/>
         </p:spPr>
@@ -24321,7 +24859,7 @@
             <a:avLst/>
           </a:prstGeom>
           <a:solidFill>
-            <a:srgbClr val="41639E"/>
+            <a:srgbClr val="4444AD"/>
           </a:solidFill>
           <a:ln/>
         </p:spPr>
@@ -24461,7 +24999,7 @@
             <a:avLst/>
           </a:prstGeom>
           <a:solidFill>
-            <a:srgbClr val="41639E"/>
+            <a:srgbClr val="4444AD"/>
           </a:solidFill>
           <a:ln/>
         </p:spPr>
@@ -24603,13 +25141,13 @@
             </a:avLst>
           </a:prstGeom>
           <a:solidFill>
-            <a:srgbClr val="FFFFFF"/>
+            <a:srgbClr val="F4F5FA"/>
           </a:solidFill>
           <a:ln/>
           <a:effectLst>
             <a:outerShdw sx="100000" sy="100000" kx="0" ky="0" algn="bl" rotWithShape="0" blurRad="127000" dist="25400" dir="5400000">
-              <a:srgbClr val="1E2B4A">
-                <a:alpha val="13000"/>
+              <a:srgbClr val="13134F">
+                <a:alpha val="10000"/>
               </a:srgbClr>
             </a:outerShdw>
           </a:effectLst>
@@ -25029,7 +25567,7 @@
             <a:avLst/>
           </a:prstGeom>
           <a:solidFill>
-            <a:srgbClr val="41639E"/>
+            <a:srgbClr val="4444AD"/>
           </a:solidFill>
           <a:ln w="31750">
             <a:solidFill>
@@ -25039,7 +25577,7 @@
           </a:ln>
           <a:effectLst>
             <a:outerShdw sx="100000" sy="100000" kx="0" ky="0" algn="bl" rotWithShape="0" blurRad="127000" dist="25400" dir="5400000">
-              <a:srgbClr val="1E2B4A">
+              <a:srgbClr val="13134F">
                 <a:alpha val="18000"/>
               </a:srgbClr>
             </a:outerShdw>
@@ -25085,7 +25623,7 @@
             <a:avLst/>
           </a:prstGeom>
           <a:solidFill>
-            <a:srgbClr val="C98A24"/>
+            <a:srgbClr val="6E6ECB"/>
           </a:solidFill>
           <a:ln w="31750">
             <a:solidFill>
@@ -25095,7 +25633,7 @@
           </a:ln>
           <a:effectLst>
             <a:outerShdw sx="100000" sy="100000" kx="0" ky="0" algn="bl" rotWithShape="0" blurRad="127000" dist="25400" dir="5400000">
-              <a:srgbClr val="1E2B4A">
+              <a:srgbClr val="13134F">
                 <a:alpha val="18000"/>
               </a:srgbClr>
             </a:outerShdw>
@@ -25151,7 +25689,7 @@
           </a:ln>
           <a:effectLst>
             <a:outerShdw sx="100000" sy="100000" kx="0" ky="0" algn="bl" rotWithShape="0" blurRad="127000" dist="25400" dir="5400000">
-              <a:srgbClr val="1E2B4A">
+              <a:srgbClr val="13134F">
                 <a:alpha val="18000"/>
               </a:srgbClr>
             </a:outerShdw>
@@ -25190,8 +25728,8 @@
         </p:nvSpPr>
         <p:spPr>
           <a:xfrm>
-            <a:off x="10972800" y="6455664"/>
-            <a:ext cx="685800" cy="237744"/>
+            <a:off x="10881360" y="6455664"/>
+            <a:ext cx="365760" cy="237744"/>
           </a:xfrm>
           <a:prstGeom prst="rect">
             <a:avLst/>
@@ -25221,6 +25759,30 @@
           </a:p>
         </p:txBody>
       </p:sp>
+      <p:pic>
+        <p:nvPicPr>
+          <p:cNvPr id="35" name="Image 3" descr="logos/logo_ensae_new.png">    </p:cNvPr>
+          <p:cNvPicPr>
+            <a:picLocks noChangeAspect="1"/>
+          </p:cNvPicPr>
+          <p:nvPr/>
+        </p:nvPicPr>
+        <p:blipFill>
+          <a:blip r:embed="rId4"/>
+          <a:stretch>
+            <a:fillRect/>
+          </a:stretch>
+        </p:blipFill>
+        <p:spPr>
+          <a:xfrm>
+            <a:off x="11384280" y="6355080"/>
+            <a:ext cx="384048" cy="384048"/>
+          </a:xfrm>
+          <a:prstGeom prst="rect">
+            <a:avLst/>
+          </a:prstGeom>
+        </p:spPr>
+      </p:pic>
     </p:spTree>
   </p:cSld>
   <p:clrMapOvr>
@@ -25235,7 +25797,7 @@
     <p:bg>
       <p:bgPr>
         <a:solidFill>
-          <a:srgbClr val="16213D"/>
+          <a:srgbClr val="101038"/>
         </a:solidFill>
       </p:bgPr>
     </p:bg>
@@ -25268,7 +25830,7 @@
             <a:avLst/>
           </a:prstGeom>
           <a:solidFill>
-            <a:srgbClr val="24365E"/>
+            <a:srgbClr val="23236B"/>
           </a:solidFill>
           <a:ln/>
         </p:spPr>
@@ -25288,7 +25850,7 @@
             <a:avLst/>
           </a:prstGeom>
           <a:solidFill>
-            <a:srgbClr val="24365E"/>
+            <a:srgbClr val="23236B"/>
           </a:solidFill>
           <a:ln/>
         </p:spPr>
@@ -25401,7 +25963,7 @@
             <a:r>
               <a:rPr lang="en-US" sz="1400" dirty="0">
                 <a:solidFill>
-                  <a:srgbClr val="AFC0DA"/>
+                  <a:srgbClr val="B7B7DB"/>
                 </a:solidFill>
                 <a:latin typeface="Calibri" pitchFamily="34" charset="0"/>
                 <a:ea typeface="Calibri" pitchFamily="34" charset="-122"/>

</xml_diff>

<commit_message>
Revenir au bleu ENSAE pour la presentation
La palette midnightblue est abandonnee au profit du bleu initial. Le
fond blanc, les logos et les corrections de mise en page sont conserves.

Co-Authored-By: Claude <noreply@anthropic.com>
Claude-Session: https://claude.ai/code/session_01837AJxDdpW6rUH9DV9QD1H
</commit_message>
<xml_diff>
--- a/infographie/presentation_infographique.pptx
+++ b/infographie/presentation_infographique.pptx
@@ -3171,7 +3171,7 @@
     <p:bg>
       <p:bgPr>
         <a:solidFill>
-          <a:srgbClr val="101038"/>
+          <a:srgbClr val="16213D"/>
         </a:solidFill>
       </p:bgPr>
     </p:bg>
@@ -3204,7 +3204,7 @@
             <a:avLst/>
           </a:prstGeom>
           <a:solidFill>
-            <a:srgbClr val="23236B"/>
+            <a:srgbClr val="24365E"/>
           </a:solidFill>
           <a:ln/>
         </p:spPr>
@@ -3224,7 +3224,7 @@
             <a:avLst/>
           </a:prstGeom>
           <a:solidFill>
-            <a:srgbClr val="23236B"/>
+            <a:srgbClr val="24365E"/>
           </a:solidFill>
           <a:ln/>
         </p:spPr>
@@ -3251,7 +3251,7 @@
           <a:ln/>
           <a:effectLst>
             <a:outerShdw sx="100000" sy="100000" kx="0" ky="0" algn="bl" rotWithShape="0" blurRad="127000" dist="25400" dir="5400000">
-              <a:srgbClr val="13134F">
+              <a:srgbClr val="1E2B4A">
                 <a:alpha val="22000"/>
               </a:srgbClr>
             </a:outerShdw>
@@ -3304,7 +3304,7 @@
           <a:ln/>
           <a:effectLst>
             <a:outerShdw sx="100000" sy="100000" kx="0" ky="0" algn="bl" rotWithShape="0" blurRad="127000" dist="25400" dir="5400000">
-              <a:srgbClr val="13134F">
+              <a:srgbClr val="1E2B4A">
                 <a:alpha val="22000"/>
               </a:srgbClr>
             </a:outerShdw>
@@ -3401,7 +3401,7 @@
             <a:r>
               <a:rPr lang="en-US" sz="1250" dirty="0">
                 <a:solidFill>
-                  <a:srgbClr val="B7B7DB"/>
+                  <a:srgbClr val="AFC0DA"/>
                 </a:solidFill>
                 <a:latin typeface="Calibri" pitchFamily="34" charset="0"/>
                 <a:ea typeface="Calibri" pitchFamily="34" charset="-122"/>
@@ -3622,7 +3622,7 @@
             <a:r>
               <a:rPr lang="en-US" sz="1050" dirty="0">
                 <a:solidFill>
-                  <a:srgbClr val="B7B7DB"/>
+                  <a:srgbClr val="AFC0DA"/>
                 </a:solidFill>
                 <a:latin typeface="Calibri" pitchFamily="34" charset="0"/>
                 <a:ea typeface="Calibri" pitchFamily="34" charset="-122"/>
@@ -3742,7 +3742,7 @@
             <a:r>
               <a:rPr lang="en-US" sz="1050" dirty="0">
                 <a:solidFill>
-                  <a:srgbClr val="B7B7DB"/>
+                  <a:srgbClr val="AFC0DA"/>
                 </a:solidFill>
                 <a:latin typeface="Calibri" pitchFamily="34" charset="0"/>
                 <a:ea typeface="Calibri" pitchFamily="34" charset="-122"/>
@@ -3852,7 +3852,7 @@
             <a:r>
               <a:rPr lang="en-US" sz="2700" b="1" dirty="0">
                 <a:solidFill>
-                  <a:srgbClr val="191970"/>
+                  <a:srgbClr val="1E2B4A"/>
                 </a:solidFill>
                 <a:latin typeface="Calibri" pitchFamily="34" charset="0"/>
                 <a:ea typeface="Calibri" pitchFamily="34" charset="-122"/>
@@ -3928,7 +3928,7 @@
           <a:ln/>
           <a:effectLst>
             <a:outerShdw sx="100000" sy="100000" kx="0" ky="0" algn="bl" rotWithShape="0" blurRad="127000" dist="25400" dir="5400000">
-              <a:srgbClr val="13134F">
+              <a:srgbClr val="1E2B4A">
                 <a:alpha val="10000"/>
               </a:srgbClr>
             </a:outerShdw>
@@ -3950,7 +3950,7 @@
             <a:avLst/>
           </a:prstGeom>
           <a:solidFill>
-            <a:srgbClr val="4444AD"/>
+            <a:srgbClr val="41639E"/>
           </a:solidFill>
           <a:ln w="31750">
             <a:solidFill>
@@ -3960,7 +3960,7 @@
           </a:ln>
           <a:effectLst>
             <a:outerShdw sx="100000" sy="100000" kx="0" ky="0" algn="bl" rotWithShape="0" blurRad="127000" dist="25400" dir="5400000">
-              <a:srgbClr val="13134F">
+              <a:srgbClr val="1E2B4A">
                 <a:alpha val="18000"/>
               </a:srgbClr>
             </a:outerShdw>
@@ -4055,7 +4055,7 @@
           <a:ln/>
           <a:effectLst>
             <a:outerShdw sx="100000" sy="100000" kx="0" ky="0" algn="bl" rotWithShape="0" blurRad="127000" dist="25400" dir="5400000">
-              <a:srgbClr val="13134F">
+              <a:srgbClr val="1E2B4A">
                 <a:alpha val="10000"/>
               </a:srgbClr>
             </a:outerShdw>
@@ -4077,7 +4077,7 @@
             <a:avLst/>
           </a:prstGeom>
           <a:solidFill>
-            <a:srgbClr val="2A2A80"/>
+            <a:srgbClr val="3E8C9A"/>
           </a:solidFill>
           <a:ln w="31750">
             <a:solidFill>
@@ -4087,7 +4087,7 @@
           </a:ln>
           <a:effectLst>
             <a:outerShdw sx="100000" sy="100000" kx="0" ky="0" algn="bl" rotWithShape="0" blurRad="127000" dist="25400" dir="5400000">
-              <a:srgbClr val="13134F">
+              <a:srgbClr val="1E2B4A">
                 <a:alpha val="18000"/>
               </a:srgbClr>
             </a:outerShdw>
@@ -4182,7 +4182,7 @@
           <a:ln/>
           <a:effectLst>
             <a:outerShdw sx="100000" sy="100000" kx="0" ky="0" algn="bl" rotWithShape="0" blurRad="127000" dist="25400" dir="5400000">
-              <a:srgbClr val="13134F">
+              <a:srgbClr val="1E2B4A">
                 <a:alpha val="10000"/>
               </a:srgbClr>
             </a:outerShdw>
@@ -4204,7 +4204,7 @@
             <a:avLst/>
           </a:prstGeom>
           <a:solidFill>
-            <a:srgbClr val="4444AD"/>
+            <a:srgbClr val="41639E"/>
           </a:solidFill>
           <a:ln w="31750">
             <a:solidFill>
@@ -4214,7 +4214,7 @@
           </a:ln>
           <a:effectLst>
             <a:outerShdw sx="100000" sy="100000" kx="0" ky="0" algn="bl" rotWithShape="0" blurRad="127000" dist="25400" dir="5400000">
-              <a:srgbClr val="13134F">
+              <a:srgbClr val="1E2B4A">
                 <a:alpha val="18000"/>
               </a:srgbClr>
             </a:outerShdw>
@@ -4309,7 +4309,7 @@
           <a:ln/>
           <a:effectLst>
             <a:outerShdw sx="100000" sy="100000" kx="0" ky="0" algn="bl" rotWithShape="0" blurRad="127000" dist="25400" dir="5400000">
-              <a:srgbClr val="13134F">
+              <a:srgbClr val="1E2B4A">
                 <a:alpha val="10000"/>
               </a:srgbClr>
             </a:outerShdw>
@@ -4341,7 +4341,7 @@
           </a:ln>
           <a:effectLst>
             <a:outerShdw sx="100000" sy="100000" kx="0" ky="0" algn="bl" rotWithShape="0" blurRad="127000" dist="25400" dir="5400000">
-              <a:srgbClr val="13134F">
+              <a:srgbClr val="1E2B4A">
                 <a:alpha val="18000"/>
               </a:srgbClr>
             </a:outerShdw>
@@ -4436,7 +4436,7 @@
           <a:ln/>
           <a:effectLst>
             <a:outerShdw sx="100000" sy="100000" kx="0" ky="0" algn="bl" rotWithShape="0" blurRad="127000" dist="25400" dir="5400000">
-              <a:srgbClr val="13134F">
+              <a:srgbClr val="1E2B4A">
                 <a:alpha val="10000"/>
               </a:srgbClr>
             </a:outerShdw>
@@ -4458,7 +4458,7 @@
             <a:avLst/>
           </a:prstGeom>
           <a:solidFill>
-            <a:srgbClr val="6E6ECB"/>
+            <a:srgbClr val="C98A24"/>
           </a:solidFill>
           <a:ln w="31750">
             <a:solidFill>
@@ -4468,7 +4468,7 @@
           </a:ln>
           <a:effectLst>
             <a:outerShdw sx="100000" sy="100000" kx="0" ky="0" algn="bl" rotWithShape="0" blurRad="127000" dist="25400" dir="5400000">
-              <a:srgbClr val="13134F">
+              <a:srgbClr val="1E2B4A">
                 <a:alpha val="18000"/>
               </a:srgbClr>
             </a:outerShdw>
@@ -4563,7 +4563,7 @@
           <a:ln/>
           <a:effectLst>
             <a:outerShdw sx="100000" sy="100000" kx="0" ky="0" algn="bl" rotWithShape="0" blurRad="127000" dist="25400" dir="5400000">
-              <a:srgbClr val="13134F">
+              <a:srgbClr val="1E2B4A">
                 <a:alpha val="10000"/>
               </a:srgbClr>
             </a:outerShdw>
@@ -4585,7 +4585,7 @@
             <a:avLst/>
           </a:prstGeom>
           <a:solidFill>
-            <a:srgbClr val="2A2A80"/>
+            <a:srgbClr val="3E8C9A"/>
           </a:solidFill>
           <a:ln w="31750">
             <a:solidFill>
@@ -4595,7 +4595,7 @@
           </a:ln>
           <a:effectLst>
             <a:outerShdw sx="100000" sy="100000" kx="0" ky="0" algn="bl" rotWithShape="0" blurRad="127000" dist="25400" dir="5400000">
-              <a:srgbClr val="13134F">
+              <a:srgbClr val="1E2B4A">
                 <a:alpha val="18000"/>
               </a:srgbClr>
             </a:outerShdw>
@@ -4690,7 +4690,7 @@
           <a:ln/>
           <a:effectLst>
             <a:outerShdw sx="100000" sy="100000" kx="0" ky="0" algn="bl" rotWithShape="0" blurRad="127000" dist="25400" dir="5400000">
-              <a:srgbClr val="13134F">
+              <a:srgbClr val="1E2B4A">
                 <a:alpha val="10000"/>
               </a:srgbClr>
             </a:outerShdw>
@@ -4712,7 +4712,7 @@
             <a:avLst/>
           </a:prstGeom>
           <a:solidFill>
-            <a:srgbClr val="4444AD"/>
+            <a:srgbClr val="41639E"/>
           </a:solidFill>
           <a:ln w="31750">
             <a:solidFill>
@@ -4722,7 +4722,7 @@
           </a:ln>
           <a:effectLst>
             <a:outerShdw sx="100000" sy="100000" kx="0" ky="0" algn="bl" rotWithShape="0" blurRad="127000" dist="25400" dir="5400000">
-              <a:srgbClr val="13134F">
+              <a:srgbClr val="1E2B4A">
                 <a:alpha val="18000"/>
               </a:srgbClr>
             </a:outerShdw>
@@ -4817,7 +4817,7 @@
           <a:ln/>
           <a:effectLst>
             <a:outerShdw sx="100000" sy="100000" kx="0" ky="0" algn="bl" rotWithShape="0" blurRad="127000" dist="25400" dir="5400000">
-              <a:srgbClr val="13134F">
+              <a:srgbClr val="1E2B4A">
                 <a:alpha val="10000"/>
               </a:srgbClr>
             </a:outerShdw>
@@ -4947,7 +4947,7 @@
           <a:ln/>
           <a:effectLst>
             <a:outerShdw sx="100000" sy="100000" kx="0" ky="0" algn="bl" rotWithShape="0" blurRad="127000" dist="25400" dir="5400000">
-              <a:srgbClr val="13134F">
+              <a:srgbClr val="1E2B4A">
                 <a:alpha val="10000"/>
               </a:srgbClr>
             </a:outerShdw>
@@ -5430,7 +5430,7 @@
             <a:r>
               <a:rPr lang="en-US" sz="2700" b="1" dirty="0">
                 <a:solidFill>
-                  <a:srgbClr val="191970"/>
+                  <a:srgbClr val="1E2B4A"/>
                 </a:solidFill>
                 <a:latin typeface="Calibri" pitchFamily="34" charset="0"/>
                 <a:ea typeface="Calibri" pitchFamily="34" charset="-122"/>
@@ -5506,7 +5506,7 @@
           <a:ln/>
           <a:effectLst>
             <a:outerShdw sx="100000" sy="100000" kx="0" ky="0" algn="bl" rotWithShape="0" blurRad="127000" dist="25400" dir="5400000">
-              <a:srgbClr val="13134F">
+              <a:srgbClr val="1E2B4A">
                 <a:alpha val="10000"/>
               </a:srgbClr>
             </a:outerShdw>
@@ -5540,7 +5540,7 @@
             <a:r>
               <a:rPr lang="en-US" sz="3200" b="1" dirty="0">
                 <a:solidFill>
-                  <a:srgbClr val="4444AD"/>
+                  <a:srgbClr val="41639E"/>
                 </a:solidFill>
                 <a:latin typeface="Calibri" pitchFamily="34" charset="0"/>
                 <a:ea typeface="Calibri" pitchFamily="34" charset="-122"/>
@@ -5636,7 +5636,7 @@
           <a:ln/>
           <a:effectLst>
             <a:outerShdw sx="100000" sy="100000" kx="0" ky="0" algn="bl" rotWithShape="0" blurRad="127000" dist="25400" dir="5400000">
-              <a:srgbClr val="13134F">
+              <a:srgbClr val="1E2B4A">
                 <a:alpha val="10000"/>
               </a:srgbClr>
             </a:outerShdw>
@@ -5670,7 +5670,7 @@
             <a:r>
               <a:rPr lang="en-US" sz="3200" b="1" dirty="0">
                 <a:solidFill>
-                  <a:srgbClr val="4444AD"/>
+                  <a:srgbClr val="41639E"/>
                 </a:solidFill>
                 <a:latin typeface="Calibri" pitchFamily="34" charset="0"/>
                 <a:ea typeface="Calibri" pitchFamily="34" charset="-122"/>
@@ -5766,7 +5766,7 @@
           <a:ln/>
           <a:effectLst>
             <a:outerShdw sx="100000" sy="100000" kx="0" ky="0" algn="bl" rotWithShape="0" blurRad="127000" dist="25400" dir="5400000">
-              <a:srgbClr val="13134F">
+              <a:srgbClr val="1E2B4A">
                 <a:alpha val="10000"/>
               </a:srgbClr>
             </a:outerShdw>
@@ -5896,7 +5896,7 @@
           <a:ln/>
           <a:effectLst>
             <a:outerShdw sx="100000" sy="100000" kx="0" ky="0" algn="bl" rotWithShape="0" blurRad="127000" dist="25400" dir="5400000">
-              <a:srgbClr val="13134F">
+              <a:srgbClr val="1E2B4A">
                 <a:alpha val="10000"/>
               </a:srgbClr>
             </a:outerShdw>
@@ -6026,7 +6026,7 @@
           <a:ln/>
           <a:effectLst>
             <a:outerShdw sx="100000" sy="100000" kx="0" ky="0" algn="bl" rotWithShape="0" blurRad="127000" dist="25400" dir="5400000">
-              <a:srgbClr val="13134F">
+              <a:srgbClr val="1E2B4A">
                 <a:alpha val="10000"/>
               </a:srgbClr>
             </a:outerShdw>
@@ -6048,7 +6048,7 @@
             <a:avLst/>
           </a:prstGeom>
           <a:solidFill>
-            <a:srgbClr val="2A2A80"/>
+            <a:srgbClr val="3E8C9A"/>
           </a:solidFill>
           <a:ln w="31750">
             <a:solidFill>
@@ -6058,7 +6058,7 @@
           </a:ln>
           <a:effectLst>
             <a:outerShdw sx="100000" sy="100000" kx="0" ky="0" algn="bl" rotWithShape="0" blurRad="127000" dist="25400" dir="5400000">
-              <a:srgbClr val="13134F">
+              <a:srgbClr val="1E2B4A">
                 <a:alpha val="18000"/>
               </a:srgbClr>
             </a:outerShdw>
@@ -6192,7 +6192,7 @@
           <a:ln/>
           <a:effectLst>
             <a:outerShdw sx="100000" sy="100000" kx="0" ky="0" algn="bl" rotWithShape="0" blurRad="127000" dist="25400" dir="5400000">
-              <a:srgbClr val="13134F">
+              <a:srgbClr val="1E2B4A">
                 <a:alpha val="10000"/>
               </a:srgbClr>
             </a:outerShdw>
@@ -6214,7 +6214,7 @@
             <a:avLst/>
           </a:prstGeom>
           <a:solidFill>
-            <a:srgbClr val="6E6ECB"/>
+            <a:srgbClr val="C98A24"/>
           </a:solidFill>
           <a:ln w="31750">
             <a:solidFill>
@@ -6224,7 +6224,7 @@
           </a:ln>
           <a:effectLst>
             <a:outerShdw sx="100000" sy="100000" kx="0" ky="0" algn="bl" rotWithShape="0" blurRad="127000" dist="25400" dir="5400000">
-              <a:srgbClr val="13134F">
+              <a:srgbClr val="1E2B4A">
                 <a:alpha val="18000"/>
               </a:srgbClr>
             </a:outerShdw>
@@ -6350,7 +6350,7 @@
             </a:avLst>
           </a:prstGeom>
           <a:solidFill>
-            <a:srgbClr val="6E6ECB"/>
+            <a:srgbClr val="C98A24"/>
           </a:solidFill>
           <a:ln/>
         </p:spPr>
@@ -6450,7 +6450,7 @@
             </a:avLst>
           </a:prstGeom>
           <a:solidFill>
-            <a:srgbClr val="E2E3EC"/>
+            <a:srgbClr val="E3E7EE"/>
           </a:solidFill>
           <a:ln/>
         </p:spPr>
@@ -6550,7 +6550,7 @@
             </a:avLst>
           </a:prstGeom>
           <a:solidFill>
-            <a:srgbClr val="E2E3EC"/>
+            <a:srgbClr val="E3E7EE"/>
           </a:solidFill>
           <a:ln/>
         </p:spPr>
@@ -6650,7 +6650,7 @@
             </a:avLst>
           </a:prstGeom>
           <a:solidFill>
-            <a:srgbClr val="E2E3EC"/>
+            <a:srgbClr val="E3E7EE"/>
           </a:solidFill>
           <a:ln/>
         </p:spPr>
@@ -6855,7 +6855,7 @@
             <a:r>
               <a:rPr lang="en-US" sz="2700" b="1" dirty="0">
                 <a:solidFill>
-                  <a:srgbClr val="191970"/>
+                  <a:srgbClr val="1E2B4A"/>
                 </a:solidFill>
                 <a:latin typeface="Calibri" pitchFamily="34" charset="0"/>
                 <a:ea typeface="Calibri" pitchFamily="34" charset="-122"/>
@@ -6931,7 +6931,7 @@
           <a:ln/>
           <a:effectLst>
             <a:outerShdw sx="100000" sy="100000" kx="0" ky="0" algn="bl" rotWithShape="0" blurRad="127000" dist="25400" dir="5400000">
-              <a:srgbClr val="13134F">
+              <a:srgbClr val="1E2B4A">
                 <a:alpha val="10000"/>
               </a:srgbClr>
             </a:outerShdw>
@@ -6953,7 +6953,7 @@
             <a:avLst/>
           </a:prstGeom>
           <a:solidFill>
-            <a:srgbClr val="4444AD"/>
+            <a:srgbClr val="41639E"/>
           </a:solidFill>
           <a:ln w="31750">
             <a:solidFill>
@@ -6963,7 +6963,7 @@
           </a:ln>
           <a:effectLst>
             <a:outerShdw sx="100000" sy="100000" kx="0" ky="0" algn="bl" rotWithShape="0" blurRad="127000" dist="25400" dir="5400000">
-              <a:srgbClr val="13134F">
+              <a:srgbClr val="1E2B4A">
                 <a:alpha val="18000"/>
               </a:srgbClr>
             </a:outerShdw>
@@ -7021,7 +7021,7 @@
             <a:r>
               <a:rPr lang="en-US" sz="3400" b="1" dirty="0">
                 <a:solidFill>
-                  <a:srgbClr val="E2E3EC"/>
+                  <a:srgbClr val="E3E7EE"/>
                 </a:solidFill>
                 <a:latin typeface="Calibri" pitchFamily="34" charset="0"/>
                 <a:ea typeface="Calibri" pitchFamily="34" charset="-122"/>
@@ -7136,7 +7136,7 @@
           <a:ln/>
           <a:effectLst>
             <a:outerShdw sx="100000" sy="100000" kx="0" ky="0" algn="bl" rotWithShape="0" blurRad="127000" dist="25400" dir="5400000">
-              <a:srgbClr val="13134F">
+              <a:srgbClr val="1E2B4A">
                 <a:alpha val="10000"/>
               </a:srgbClr>
             </a:outerShdw>
@@ -7158,7 +7158,7 @@
             <a:avLst/>
           </a:prstGeom>
           <a:solidFill>
-            <a:srgbClr val="2A2A80"/>
+            <a:srgbClr val="3E8C9A"/>
           </a:solidFill>
           <a:ln w="31750">
             <a:solidFill>
@@ -7168,7 +7168,7 @@
           </a:ln>
           <a:effectLst>
             <a:outerShdw sx="100000" sy="100000" kx="0" ky="0" algn="bl" rotWithShape="0" blurRad="127000" dist="25400" dir="5400000">
-              <a:srgbClr val="13134F">
+              <a:srgbClr val="1E2B4A">
                 <a:alpha val="18000"/>
               </a:srgbClr>
             </a:outerShdw>
@@ -7226,7 +7226,7 @@
             <a:r>
               <a:rPr lang="en-US" sz="3400" b="1" dirty="0">
                 <a:solidFill>
-                  <a:srgbClr val="E2E3EC"/>
+                  <a:srgbClr val="E3E7EE"/>
                 </a:solidFill>
                 <a:latin typeface="Calibri" pitchFamily="34" charset="0"/>
                 <a:ea typeface="Calibri" pitchFamily="34" charset="-122"/>
@@ -7341,7 +7341,7 @@
           <a:ln/>
           <a:effectLst>
             <a:outerShdw sx="100000" sy="100000" kx="0" ky="0" algn="bl" rotWithShape="0" blurRad="127000" dist="25400" dir="5400000">
-              <a:srgbClr val="13134F">
+              <a:srgbClr val="1E2B4A">
                 <a:alpha val="10000"/>
               </a:srgbClr>
             </a:outerShdw>
@@ -7373,7 +7373,7 @@
           </a:ln>
           <a:effectLst>
             <a:outerShdw sx="100000" sy="100000" kx="0" ky="0" algn="bl" rotWithShape="0" blurRad="127000" dist="25400" dir="5400000">
-              <a:srgbClr val="13134F">
+              <a:srgbClr val="1E2B4A">
                 <a:alpha val="18000"/>
               </a:srgbClr>
             </a:outerShdw>
@@ -7431,7 +7431,7 @@
             <a:r>
               <a:rPr lang="en-US" sz="3400" b="1" dirty="0">
                 <a:solidFill>
-                  <a:srgbClr val="E2E3EC"/>
+                  <a:srgbClr val="E3E7EE"/>
                 </a:solidFill>
                 <a:latin typeface="Calibri" pitchFamily="34" charset="0"/>
                 <a:ea typeface="Calibri" pitchFamily="34" charset="-122"/>
@@ -7541,12 +7541,12 @@
             </a:avLst>
           </a:prstGeom>
           <a:solidFill>
-            <a:srgbClr val="191970"/>
+            <a:srgbClr val="1E2B4A"/>
           </a:solidFill>
           <a:ln/>
           <a:effectLst>
             <a:outerShdw sx="100000" sy="100000" kx="0" ky="0" algn="bl" rotWithShape="0" blurRad="127000" dist="25400" dir="5400000">
-              <a:srgbClr val="13134F">
+              <a:srgbClr val="1E2B4A">
                 <a:alpha val="10000"/>
               </a:srgbClr>
             </a:outerShdw>
@@ -7672,7 +7672,7 @@
     <p:bg>
       <p:bgPr>
         <a:solidFill>
-          <a:srgbClr val="101038"/>
+          <a:srgbClr val="16213D"/>
         </a:solidFill>
       </p:bgPr>
     </p:bg>
@@ -7705,7 +7705,7 @@
             <a:avLst/>
           </a:prstGeom>
           <a:solidFill>
-            <a:srgbClr val="23236B"/>
+            <a:srgbClr val="24365E"/>
           </a:solidFill>
           <a:ln/>
         </p:spPr>
@@ -7725,7 +7725,7 @@
             <a:avLst/>
           </a:prstGeom>
           <a:solidFill>
-            <a:srgbClr val="23236B"/>
+            <a:srgbClr val="24365E"/>
           </a:solidFill>
           <a:ln/>
         </p:spPr>
@@ -7838,7 +7838,7 @@
             <a:r>
               <a:rPr lang="en-US" sz="1400" dirty="0">
                 <a:solidFill>
-                  <a:srgbClr val="B7B7DB"/>
+                  <a:srgbClr val="AFC0DA"/>
                 </a:solidFill>
                 <a:latin typeface="Calibri" pitchFamily="34" charset="0"/>
                 <a:ea typeface="Calibri" pitchFamily="34" charset="-122"/>
@@ -7909,7 +7909,7 @@
             <a:r>
               <a:rPr lang="en-US" sz="2700" b="1" dirty="0">
                 <a:solidFill>
-                  <a:srgbClr val="191970"/>
+                  <a:srgbClr val="1E2B4A"/>
                 </a:solidFill>
                 <a:latin typeface="Calibri" pitchFamily="34" charset="0"/>
                 <a:ea typeface="Calibri" pitchFamily="34" charset="-122"/>
@@ -7985,7 +7985,7 @@
           <a:ln/>
           <a:effectLst>
             <a:outerShdw sx="100000" sy="100000" kx="0" ky="0" algn="bl" rotWithShape="0" blurRad="127000" dist="25400" dir="5400000">
-              <a:srgbClr val="13134F">
+              <a:srgbClr val="1E2B4A">
                 <a:alpha val="10000"/>
               </a:srgbClr>
             </a:outerShdw>
@@ -8191,7 +8191,7 @@
             <a:avLst/>
           </a:prstGeom>
           <a:solidFill>
-            <a:srgbClr val="E2E3EC"/>
+            <a:srgbClr val="E3E7EE"/>
           </a:solidFill>
           <a:ln/>
         </p:spPr>
@@ -8262,7 +8262,7 @@
             <a:r>
               <a:rPr lang="en-US" sz="1500" b="1" dirty="0">
                 <a:solidFill>
-                  <a:srgbClr val="191970"/>
+                  <a:srgbClr val="1E2B4A"/>
                 </a:solidFill>
                 <a:latin typeface="Calibri" pitchFamily="34" charset="0"/>
                 <a:ea typeface="Calibri" pitchFamily="34" charset="-122"/>
@@ -8301,7 +8301,7 @@
             <a:r>
               <a:rPr lang="en-US" sz="1500" b="1" dirty="0">
                 <a:solidFill>
-                  <a:srgbClr val="191970"/>
+                  <a:srgbClr val="1E2B4A"/>
                 </a:solidFill>
                 <a:latin typeface="Calibri" pitchFamily="34" charset="0"/>
                 <a:ea typeface="Calibri" pitchFamily="34" charset="-122"/>
@@ -8367,7 +8367,7 @@
             <a:avLst/>
           </a:prstGeom>
           <a:solidFill>
-            <a:srgbClr val="E2E3EC"/>
+            <a:srgbClr val="E3E7EE"/>
           </a:solidFill>
           <a:ln/>
         </p:spPr>
@@ -8438,7 +8438,7 @@
             <a:r>
               <a:rPr lang="en-US" sz="1500" b="1" dirty="0">
                 <a:solidFill>
-                  <a:srgbClr val="191970"/>
+                  <a:srgbClr val="1E2B4A"/>
                 </a:solidFill>
                 <a:latin typeface="Calibri" pitchFamily="34" charset="0"/>
                 <a:ea typeface="Calibri" pitchFamily="34" charset="-122"/>
@@ -8477,7 +8477,7 @@
             <a:r>
               <a:rPr lang="en-US" sz="1500" b="1" dirty="0">
                 <a:solidFill>
-                  <a:srgbClr val="191970"/>
+                  <a:srgbClr val="1E2B4A"/>
                 </a:solidFill>
                 <a:latin typeface="Calibri" pitchFamily="34" charset="0"/>
                 <a:ea typeface="Calibri" pitchFamily="34" charset="-122"/>
@@ -8543,7 +8543,7 @@
             <a:avLst/>
           </a:prstGeom>
           <a:solidFill>
-            <a:srgbClr val="E2E3EC"/>
+            <a:srgbClr val="E3E7EE"/>
           </a:solidFill>
           <a:ln/>
         </p:spPr>
@@ -8614,7 +8614,7 @@
             <a:r>
               <a:rPr lang="en-US" sz="1500" b="1" dirty="0">
                 <a:solidFill>
-                  <a:srgbClr val="191970"/>
+                  <a:srgbClr val="1E2B4A"/>
                 </a:solidFill>
                 <a:latin typeface="Calibri" pitchFamily="34" charset="0"/>
                 <a:ea typeface="Calibri" pitchFamily="34" charset="-122"/>
@@ -8653,7 +8653,7 @@
             <a:r>
               <a:rPr lang="en-US" sz="1500" b="1" dirty="0">
                 <a:solidFill>
-                  <a:srgbClr val="191970"/>
+                  <a:srgbClr val="1E2B4A"/>
                 </a:solidFill>
                 <a:latin typeface="Calibri" pitchFamily="34" charset="0"/>
                 <a:ea typeface="Calibri" pitchFamily="34" charset="-122"/>
@@ -8768,7 +8768,7 @@
           <a:ln/>
           <a:effectLst>
             <a:outerShdw sx="100000" sy="100000" kx="0" ky="0" algn="bl" rotWithShape="0" blurRad="127000" dist="25400" dir="5400000">
-              <a:srgbClr val="13134F">
+              <a:srgbClr val="1E2B4A">
                 <a:alpha val="10000"/>
               </a:srgbClr>
             </a:outerShdw>
@@ -8909,7 +8909,7 @@
             </a:avLst>
           </a:prstGeom>
           <a:solidFill>
-            <a:srgbClr val="4444AD"/>
+            <a:srgbClr val="41639E"/>
           </a:solidFill>
           <a:ln/>
         </p:spPr>
@@ -9009,7 +9009,7 @@
             </a:avLst>
           </a:prstGeom>
           <a:solidFill>
-            <a:srgbClr val="4444AD"/>
+            <a:srgbClr val="41639E"/>
           </a:solidFill>
           <a:ln/>
         </p:spPr>
@@ -9495,7 +9495,7 @@
             <a:r>
               <a:rPr lang="en-US" sz="2700" b="1" dirty="0">
                 <a:solidFill>
-                  <a:srgbClr val="191970"/>
+                  <a:srgbClr val="1E2B4A"/>
                 </a:solidFill>
                 <a:latin typeface="Calibri" pitchFamily="34" charset="0"/>
                 <a:ea typeface="Calibri" pitchFamily="34" charset="-122"/>
@@ -9571,7 +9571,7 @@
           <a:ln/>
           <a:effectLst>
             <a:outerShdw sx="100000" sy="100000" kx="0" ky="0" algn="bl" rotWithShape="0" blurRad="127000" dist="25400" dir="5400000">
-              <a:srgbClr val="13134F">
+              <a:srgbClr val="1E2B4A">
                 <a:alpha val="10000"/>
               </a:srgbClr>
             </a:outerShdw>
@@ -9701,7 +9701,7 @@
           <a:ln/>
           <a:effectLst>
             <a:outerShdw sx="100000" sy="100000" kx="0" ky="0" algn="bl" rotWithShape="0" blurRad="127000" dist="25400" dir="5400000">
-              <a:srgbClr val="13134F">
+              <a:srgbClr val="1E2B4A">
                 <a:alpha val="10000"/>
               </a:srgbClr>
             </a:outerShdw>
@@ -9735,7 +9735,7 @@
             <a:r>
               <a:rPr lang="en-US" sz="3000" b="1" dirty="0">
                 <a:solidFill>
-                  <a:srgbClr val="2A2A80"/>
+                  <a:srgbClr val="3E8C9A"/>
                 </a:solidFill>
                 <a:latin typeface="Calibri" pitchFamily="34" charset="0"/>
                 <a:ea typeface="Calibri" pitchFamily="34" charset="-122"/>
@@ -9831,7 +9831,7 @@
           <a:ln/>
           <a:effectLst>
             <a:outerShdw sx="100000" sy="100000" kx="0" ky="0" algn="bl" rotWithShape="0" blurRad="127000" dist="25400" dir="5400000">
-              <a:srgbClr val="13134F">
+              <a:srgbClr val="1E2B4A">
                 <a:alpha val="10000"/>
               </a:srgbClr>
             </a:outerShdw>
@@ -9865,7 +9865,7 @@
             <a:r>
               <a:rPr lang="en-US" sz="3000" b="1" dirty="0">
                 <a:solidFill>
-                  <a:srgbClr val="4444AD"/>
+                  <a:srgbClr val="41639E"/>
                 </a:solidFill>
                 <a:latin typeface="Calibri" pitchFamily="34" charset="0"/>
                 <a:ea typeface="Calibri" pitchFamily="34" charset="-122"/>
@@ -9961,7 +9961,7 @@
           <a:ln/>
           <a:effectLst>
             <a:outerShdw sx="100000" sy="100000" kx="0" ky="0" algn="bl" rotWithShape="0" blurRad="127000" dist="25400" dir="5400000">
-              <a:srgbClr val="13134F">
+              <a:srgbClr val="1E2B4A">
                 <a:alpha val="10000"/>
               </a:srgbClr>
             </a:outerShdw>
@@ -9995,7 +9995,7 @@
             <a:r>
               <a:rPr lang="en-US" sz="3000" b="1" dirty="0">
                 <a:solidFill>
-                  <a:srgbClr val="4444AD"/>
+                  <a:srgbClr val="41639E"/>
                 </a:solidFill>
                 <a:latin typeface="Calibri" pitchFamily="34" charset="0"/>
                 <a:ea typeface="Calibri" pitchFamily="34" charset="-122"/>
@@ -10091,7 +10091,7 @@
           <a:ln/>
           <a:effectLst>
             <a:outerShdw sx="100000" sy="100000" kx="0" ky="0" algn="bl" rotWithShape="0" blurRad="127000" dist="25400" dir="5400000">
-              <a:srgbClr val="13134F">
+              <a:srgbClr val="1E2B4A">
                 <a:alpha val="10000"/>
               </a:srgbClr>
             </a:outerShdw>
@@ -10193,7 +10193,7 @@
             </a:avLst>
           </a:prstGeom>
           <a:solidFill>
-            <a:srgbClr val="E2E3EC"/>
+            <a:srgbClr val="E3E7EE"/>
           </a:solidFill>
           <a:ln/>
         </p:spPr>
@@ -10215,7 +10215,7 @@
             </a:avLst>
           </a:prstGeom>
           <a:solidFill>
-            <a:srgbClr val="2A2A80"/>
+            <a:srgbClr val="3E8C9A"/>
           </a:solidFill>
           <a:ln/>
         </p:spPr>
@@ -10315,7 +10315,7 @@
             </a:avLst>
           </a:prstGeom>
           <a:solidFill>
-            <a:srgbClr val="E2E3EC"/>
+            <a:srgbClr val="E3E7EE"/>
           </a:solidFill>
           <a:ln/>
         </p:spPr>
@@ -10337,7 +10337,7 @@
             </a:avLst>
           </a:prstGeom>
           <a:solidFill>
-            <a:srgbClr val="2A2A80"/>
+            <a:srgbClr val="3E8C9A"/>
           </a:solidFill>
           <a:ln/>
         </p:spPr>
@@ -10437,7 +10437,7 @@
             </a:avLst>
           </a:prstGeom>
           <a:solidFill>
-            <a:srgbClr val="E2E3EC"/>
+            <a:srgbClr val="E3E7EE"/>
           </a:solidFill>
           <a:ln/>
         </p:spPr>
@@ -10459,7 +10459,7 @@
             </a:avLst>
           </a:prstGeom>
           <a:solidFill>
-            <a:srgbClr val="2A2A80"/>
+            <a:srgbClr val="3E8C9A"/>
           </a:solidFill>
           <a:ln/>
         </p:spPr>
@@ -10559,7 +10559,7 @@
             </a:avLst>
           </a:prstGeom>
           <a:solidFill>
-            <a:srgbClr val="E2E3EC"/>
+            <a:srgbClr val="E3E7EE"/>
           </a:solidFill>
           <a:ln/>
         </p:spPr>
@@ -10581,7 +10581,7 @@
             </a:avLst>
           </a:prstGeom>
           <a:solidFill>
-            <a:srgbClr val="2A2A80"/>
+            <a:srgbClr val="3E8C9A"/>
           </a:solidFill>
           <a:ln/>
         </p:spPr>
@@ -10681,7 +10681,7 @@
             </a:avLst>
           </a:prstGeom>
           <a:solidFill>
-            <a:srgbClr val="E2E3EC"/>
+            <a:srgbClr val="E3E7EE"/>
           </a:solidFill>
           <a:ln/>
         </p:spPr>
@@ -10703,7 +10703,7 @@
             </a:avLst>
           </a:prstGeom>
           <a:solidFill>
-            <a:srgbClr val="2A2A80"/>
+            <a:srgbClr val="3E8C9A"/>
           </a:solidFill>
           <a:ln/>
         </p:spPr>
@@ -10803,7 +10803,7 @@
             </a:avLst>
           </a:prstGeom>
           <a:solidFill>
-            <a:srgbClr val="E2E3EC"/>
+            <a:srgbClr val="E3E7EE"/>
           </a:solidFill>
           <a:ln/>
         </p:spPr>
@@ -10825,7 +10825,7 @@
             </a:avLst>
           </a:prstGeom>
           <a:solidFill>
-            <a:srgbClr val="2A2A80"/>
+            <a:srgbClr val="3E8C9A"/>
           </a:solidFill>
           <a:ln/>
         </p:spPr>
@@ -11030,7 +11030,7 @@
             <a:r>
               <a:rPr lang="en-US" sz="2700" b="1" dirty="0">
                 <a:solidFill>
-                  <a:srgbClr val="191970"/>
+                  <a:srgbClr val="1E2B4A"/>
                 </a:solidFill>
                 <a:latin typeface="Calibri" pitchFamily="34" charset="0"/>
                 <a:ea typeface="Calibri" pitchFamily="34" charset="-122"/>
@@ -11059,12 +11059,12 @@
             </a:avLst>
           </a:prstGeom>
           <a:solidFill>
-            <a:srgbClr val="191970"/>
+            <a:srgbClr val="1E2B4A"/>
           </a:solidFill>
           <a:ln/>
           <a:effectLst>
             <a:outerShdw sx="100000" sy="100000" kx="0" ky="0" algn="bl" rotWithShape="0" blurRad="127000" dist="25400" dir="5400000">
-              <a:srgbClr val="13134F">
+              <a:srgbClr val="1E2B4A">
                 <a:alpha val="10000"/>
               </a:srgbClr>
             </a:outerShdw>
@@ -11252,7 +11252,7 @@
           <a:ln/>
           <a:effectLst>
             <a:outerShdw sx="100000" sy="100000" kx="0" ky="0" algn="bl" rotWithShape="0" blurRad="127000" dist="25400" dir="5400000">
-              <a:srgbClr val="13134F">
+              <a:srgbClr val="1E2B4A">
                 <a:alpha val="10000"/>
               </a:srgbClr>
             </a:outerShdw>
@@ -11418,7 +11418,7 @@
             </a:avLst>
           </a:prstGeom>
           <a:solidFill>
-            <a:srgbClr val="4444AD"/>
+            <a:srgbClr val="41639E"/>
           </a:solidFill>
           <a:ln/>
         </p:spPr>
@@ -11605,7 +11605,7 @@
           <a:ln/>
           <a:effectLst>
             <a:outerShdw sx="100000" sy="100000" kx="0" ky="0" algn="bl" rotWithShape="0" blurRad="127000" dist="25400" dir="5400000">
-              <a:srgbClr val="13134F">
+              <a:srgbClr val="1E2B4A">
                 <a:alpha val="10000"/>
               </a:srgbClr>
             </a:outerShdw>
@@ -11720,7 +11720,7 @@
             <a:r>
               <a:rPr lang="en-US" sz="1500" b="1" dirty="0">
                 <a:solidFill>
-                  <a:srgbClr val="191970"/>
+                  <a:srgbClr val="1E2B4A"/>
                 </a:solidFill>
                 <a:latin typeface="Calibri" pitchFamily="34" charset="0"/>
                 <a:ea typeface="Calibri" pitchFamily="34" charset="-122"/>
@@ -11747,7 +11747,7 @@
             <a:avLst/>
           </a:prstGeom>
           <a:solidFill>
-            <a:srgbClr val="E2E3EC"/>
+            <a:srgbClr val="E3E7EE"/>
           </a:solidFill>
           <a:ln/>
         </p:spPr>
@@ -11821,7 +11821,7 @@
             <a:r>
               <a:rPr lang="en-US" sz="1500" b="1" dirty="0">
                 <a:solidFill>
-                  <a:srgbClr val="191970"/>
+                  <a:srgbClr val="1E2B4A"/>
                 </a:solidFill>
                 <a:latin typeface="Calibri" pitchFamily="34" charset="0"/>
                 <a:ea typeface="Calibri" pitchFamily="34" charset="-122"/>
@@ -11848,7 +11848,7 @@
             <a:avLst/>
           </a:prstGeom>
           <a:solidFill>
-            <a:srgbClr val="E2E3EC"/>
+            <a:srgbClr val="E3E7EE"/>
           </a:solidFill>
           <a:ln/>
         </p:spPr>
@@ -11922,7 +11922,7 @@
             <a:r>
               <a:rPr lang="en-US" sz="1500" b="1" dirty="0">
                 <a:solidFill>
-                  <a:srgbClr val="191970"/>
+                  <a:srgbClr val="1E2B4A"/>
                 </a:solidFill>
                 <a:latin typeface="Calibri" pitchFamily="34" charset="0"/>
                 <a:ea typeface="Calibri" pitchFamily="34" charset="-122"/>
@@ -11949,7 +11949,7 @@
             <a:avLst/>
           </a:prstGeom>
           <a:solidFill>
-            <a:srgbClr val="E2E3EC"/>
+            <a:srgbClr val="E3E7EE"/>
           </a:solidFill>
           <a:ln/>
         </p:spPr>
@@ -12050,7 +12050,7 @@
             <a:avLst/>
           </a:prstGeom>
           <a:solidFill>
-            <a:srgbClr val="E2E3EC"/>
+            <a:srgbClr val="E3E7EE"/>
           </a:solidFill>
           <a:ln/>
         </p:spPr>
@@ -12258,7 +12258,7 @@
             <a:r>
               <a:rPr lang="en-US" sz="2700" b="1" dirty="0">
                 <a:solidFill>
-                  <a:srgbClr val="191970"/>
+                  <a:srgbClr val="1E2B4A"/>
                 </a:solidFill>
                 <a:latin typeface="Calibri" pitchFamily="34" charset="0"/>
                 <a:ea typeface="Calibri" pitchFamily="34" charset="-122"/>
@@ -12334,7 +12334,7 @@
           <a:ln/>
           <a:effectLst>
             <a:outerShdw sx="100000" sy="100000" kx="0" ky="0" algn="bl" rotWithShape="0" blurRad="127000" dist="25400" dir="5400000">
-              <a:srgbClr val="13134F">
+              <a:srgbClr val="1E2B4A">
                 <a:alpha val="10000"/>
               </a:srgbClr>
             </a:outerShdw>
@@ -12575,7 +12575,7 @@
             </a:avLst>
           </a:prstGeom>
           <a:solidFill>
-            <a:srgbClr val="E2E3EC"/>
+            <a:srgbClr val="E3E7EE"/>
           </a:solidFill>
           <a:ln/>
         </p:spPr>
@@ -12675,7 +12675,7 @@
             </a:avLst>
           </a:prstGeom>
           <a:solidFill>
-            <a:srgbClr val="E2E3EC"/>
+            <a:srgbClr val="E3E7EE"/>
           </a:solidFill>
           <a:ln/>
         </p:spPr>
@@ -12775,7 +12775,7 @@
             </a:avLst>
           </a:prstGeom>
           <a:solidFill>
-            <a:srgbClr val="E2E3EC"/>
+            <a:srgbClr val="E3E7EE"/>
           </a:solidFill>
           <a:ln/>
         </p:spPr>
@@ -12875,7 +12875,7 @@
             </a:avLst>
           </a:prstGeom>
           <a:solidFill>
-            <a:srgbClr val="E2E3EC"/>
+            <a:srgbClr val="E3E7EE"/>
           </a:solidFill>
           <a:ln/>
         </p:spPr>
@@ -12975,7 +12975,7 @@
             </a:avLst>
           </a:prstGeom>
           <a:solidFill>
-            <a:srgbClr val="E2E3EC"/>
+            <a:srgbClr val="E3E7EE"/>
           </a:solidFill>
           <a:ln/>
         </p:spPr>
@@ -13075,7 +13075,7 @@
             </a:avLst>
           </a:prstGeom>
           <a:solidFill>
-            <a:srgbClr val="E2E3EC"/>
+            <a:srgbClr val="E3E7EE"/>
           </a:solidFill>
           <a:ln/>
         </p:spPr>
@@ -13141,7 +13141,7 @@
           <a:ln/>
           <a:effectLst>
             <a:outerShdw sx="100000" sy="100000" kx="0" ky="0" algn="bl" rotWithShape="0" blurRad="127000" dist="25400" dir="5400000">
-              <a:srgbClr val="13134F">
+              <a:srgbClr val="1E2B4A">
                 <a:alpha val="10000"/>
               </a:srgbClr>
             </a:outerShdw>
@@ -13173,7 +13173,7 @@
           </a:ln>
           <a:effectLst>
             <a:outerShdw sx="100000" sy="100000" kx="0" ky="0" algn="bl" rotWithShape="0" blurRad="127000" dist="25400" dir="5400000">
-              <a:srgbClr val="13134F">
+              <a:srgbClr val="1E2B4A">
                 <a:alpha val="18000"/>
               </a:srgbClr>
             </a:outerShdw>
@@ -13310,7 +13310,7 @@
           <a:ln/>
           <a:effectLst>
             <a:outerShdw sx="100000" sy="100000" kx="0" ky="0" algn="bl" rotWithShape="0" blurRad="127000" dist="25400" dir="5400000">
-              <a:srgbClr val="13134F">
+              <a:srgbClr val="1E2B4A">
                 <a:alpha val="10000"/>
               </a:srgbClr>
             </a:outerShdw>
@@ -13790,7 +13790,7 @@
             <a:r>
               <a:rPr lang="en-US" sz="2700" b="1" dirty="0">
                 <a:solidFill>
-                  <a:srgbClr val="191970"/>
+                  <a:srgbClr val="1E2B4A"/>
                 </a:solidFill>
                 <a:latin typeface="Calibri" pitchFamily="34" charset="0"/>
                 <a:ea typeface="Calibri" pitchFamily="34" charset="-122"/>
@@ -13866,7 +13866,7 @@
           <a:ln/>
           <a:effectLst>
             <a:outerShdw sx="100000" sy="100000" kx="0" ky="0" algn="bl" rotWithShape="0" blurRad="127000" dist="25400" dir="5400000">
-              <a:srgbClr val="13134F">
+              <a:srgbClr val="1E2B4A">
                 <a:alpha val="10000"/>
               </a:srgbClr>
             </a:outerShdw>
@@ -14363,7 +14363,7 @@
             </a:avLst>
           </a:prstGeom>
           <a:solidFill>
-            <a:srgbClr val="E2E3EC"/>
+            <a:srgbClr val="E3E7EE"/>
           </a:solidFill>
           <a:ln/>
         </p:spPr>
@@ -14502,7 +14502,7 @@
             </a:avLst>
           </a:prstGeom>
           <a:solidFill>
-            <a:srgbClr val="E2E3EC"/>
+            <a:srgbClr val="E3E7EE"/>
           </a:solidFill>
           <a:ln/>
         </p:spPr>
@@ -14641,7 +14641,7 @@
             </a:avLst>
           </a:prstGeom>
           <a:solidFill>
-            <a:srgbClr val="E2E3EC"/>
+            <a:srgbClr val="E3E7EE"/>
           </a:solidFill>
           <a:ln/>
         </p:spPr>
@@ -14722,12 +14722,12 @@
             </a:avLst>
           </a:prstGeom>
           <a:solidFill>
-            <a:srgbClr val="191970"/>
+            <a:srgbClr val="1E2B4A"/>
           </a:solidFill>
           <a:ln/>
           <a:effectLst>
             <a:outerShdw sx="100000" sy="100000" kx="0" ky="0" algn="bl" rotWithShape="0" blurRad="127000" dist="25400" dir="5400000">
-              <a:srgbClr val="13134F">
+              <a:srgbClr val="1E2B4A">
                 <a:alpha val="10000"/>
               </a:srgbClr>
             </a:outerShdw>
@@ -14876,7 +14876,7 @@
           <a:ln/>
           <a:effectLst>
             <a:outerShdw sx="100000" sy="100000" kx="0" ky="0" algn="bl" rotWithShape="0" blurRad="127000" dist="25400" dir="5400000">
-              <a:srgbClr val="13134F">
+              <a:srgbClr val="1E2B4A">
                 <a:alpha val="10000"/>
               </a:srgbClr>
             </a:outerShdw>
@@ -15080,7 +15080,7 @@
     <p:bg>
       <p:bgPr>
         <a:solidFill>
-          <a:srgbClr val="101038"/>
+          <a:srgbClr val="16213D"/>
         </a:solidFill>
       </p:bgPr>
     </p:bg>
@@ -15113,7 +15113,7 @@
             <a:avLst/>
           </a:prstGeom>
           <a:solidFill>
-            <a:srgbClr val="23236B"/>
+            <a:srgbClr val="24365E"/>
           </a:solidFill>
           <a:ln/>
         </p:spPr>
@@ -15133,7 +15133,7 @@
             <a:avLst/>
           </a:prstGeom>
           <a:solidFill>
-            <a:srgbClr val="23236B"/>
+            <a:srgbClr val="24365E"/>
           </a:solidFill>
           <a:ln/>
         </p:spPr>
@@ -15246,7 +15246,7 @@
             <a:r>
               <a:rPr lang="en-US" sz="1400" dirty="0">
                 <a:solidFill>
-                  <a:srgbClr val="B7B7DB"/>
+                  <a:srgbClr val="AFC0DA"/>
                 </a:solidFill>
                 <a:latin typeface="Calibri" pitchFamily="34" charset="0"/>
                 <a:ea typeface="Calibri" pitchFamily="34" charset="-122"/>
@@ -15317,7 +15317,7 @@
             <a:r>
               <a:rPr lang="en-US" sz="2700" b="1" dirty="0">
                 <a:solidFill>
-                  <a:srgbClr val="191970"/>
+                  <a:srgbClr val="1E2B4A"/>
                 </a:solidFill>
                 <a:latin typeface="Calibri" pitchFamily="34" charset="0"/>
                 <a:ea typeface="Calibri" pitchFamily="34" charset="-122"/>
@@ -15351,7 +15351,7 @@
           <a:ln/>
           <a:effectLst>
             <a:outerShdw sx="100000" sy="100000" kx="0" ky="0" algn="bl" rotWithShape="0" blurRad="127000" dist="25400" dir="5400000">
-              <a:srgbClr val="13134F">
+              <a:srgbClr val="1E2B4A">
                 <a:alpha val="10000"/>
               </a:srgbClr>
             </a:outerShdw>
@@ -15373,7 +15373,7 @@
             <a:avLst/>
           </a:prstGeom>
           <a:solidFill>
-            <a:srgbClr val="4444AD"/>
+            <a:srgbClr val="41639E"/>
           </a:solidFill>
           <a:ln w="31750">
             <a:solidFill>
@@ -15383,7 +15383,7 @@
           </a:ln>
           <a:effectLst>
             <a:outerShdw sx="100000" sy="100000" kx="0" ky="0" algn="bl" rotWithShape="0" blurRad="127000" dist="25400" dir="5400000">
-              <a:srgbClr val="13134F">
+              <a:srgbClr val="1E2B4A">
                 <a:alpha val="18000"/>
               </a:srgbClr>
             </a:outerShdw>
@@ -15441,7 +15441,7 @@
             <a:r>
               <a:rPr lang="en-US" sz="3000" b="1" dirty="0">
                 <a:solidFill>
-                  <a:srgbClr val="E2E3EC"/>
+                  <a:srgbClr val="E3E7EE"/>
                 </a:solidFill>
                 <a:latin typeface="Calibri" pitchFamily="34" charset="0"/>
                 <a:ea typeface="Calibri" pitchFamily="34" charset="-122"/>
@@ -15553,7 +15553,7 @@
           <a:ln/>
           <a:effectLst>
             <a:outerShdw sx="100000" sy="100000" kx="0" ky="0" algn="bl" rotWithShape="0" blurRad="127000" dist="25400" dir="5400000">
-              <a:srgbClr val="13134F">
+              <a:srgbClr val="1E2B4A">
                 <a:alpha val="10000"/>
               </a:srgbClr>
             </a:outerShdw>
@@ -15585,7 +15585,7 @@
           </a:ln>
           <a:effectLst>
             <a:outerShdw sx="100000" sy="100000" kx="0" ky="0" algn="bl" rotWithShape="0" blurRad="127000" dist="25400" dir="5400000">
-              <a:srgbClr val="13134F">
+              <a:srgbClr val="1E2B4A">
                 <a:alpha val="18000"/>
               </a:srgbClr>
             </a:outerShdw>
@@ -15643,7 +15643,7 @@
             <a:r>
               <a:rPr lang="en-US" sz="3000" b="1" dirty="0">
                 <a:solidFill>
-                  <a:srgbClr val="E2E3EC"/>
+                  <a:srgbClr val="E3E7EE"/>
                 </a:solidFill>
                 <a:latin typeface="Calibri" pitchFamily="34" charset="0"/>
                 <a:ea typeface="Calibri" pitchFamily="34" charset="-122"/>
@@ -15755,7 +15755,7 @@
           <a:ln/>
           <a:effectLst>
             <a:outerShdw sx="100000" sy="100000" kx="0" ky="0" algn="bl" rotWithShape="0" blurRad="127000" dist="25400" dir="5400000">
-              <a:srgbClr val="13134F">
+              <a:srgbClr val="1E2B4A">
                 <a:alpha val="10000"/>
               </a:srgbClr>
             </a:outerShdw>
@@ -15777,7 +15777,7 @@
             <a:avLst/>
           </a:prstGeom>
           <a:solidFill>
-            <a:srgbClr val="2A2A80"/>
+            <a:srgbClr val="3E8C9A"/>
           </a:solidFill>
           <a:ln w="31750">
             <a:solidFill>
@@ -15787,7 +15787,7 @@
           </a:ln>
           <a:effectLst>
             <a:outerShdw sx="100000" sy="100000" kx="0" ky="0" algn="bl" rotWithShape="0" blurRad="127000" dist="25400" dir="5400000">
-              <a:srgbClr val="13134F">
+              <a:srgbClr val="1E2B4A">
                 <a:alpha val="18000"/>
               </a:srgbClr>
             </a:outerShdw>
@@ -15845,7 +15845,7 @@
             <a:r>
               <a:rPr lang="en-US" sz="3000" b="1" dirty="0">
                 <a:solidFill>
-                  <a:srgbClr val="E2E3EC"/>
+                  <a:srgbClr val="E3E7EE"/>
                 </a:solidFill>
                 <a:latin typeface="Calibri" pitchFamily="34" charset="0"/>
                 <a:ea typeface="Calibri" pitchFamily="34" charset="-122"/>
@@ -15957,7 +15957,7 @@
           <a:ln/>
           <a:effectLst>
             <a:outerShdw sx="100000" sy="100000" kx="0" ky="0" algn="bl" rotWithShape="0" blurRad="127000" dist="25400" dir="5400000">
-              <a:srgbClr val="13134F">
+              <a:srgbClr val="1E2B4A">
                 <a:alpha val="10000"/>
               </a:srgbClr>
             </a:outerShdw>
@@ -15979,7 +15979,7 @@
             <a:avLst/>
           </a:prstGeom>
           <a:solidFill>
-            <a:srgbClr val="6E6ECB"/>
+            <a:srgbClr val="C98A24"/>
           </a:solidFill>
           <a:ln w="31750">
             <a:solidFill>
@@ -15989,7 +15989,7 @@
           </a:ln>
           <a:effectLst>
             <a:outerShdw sx="100000" sy="100000" kx="0" ky="0" algn="bl" rotWithShape="0" blurRad="127000" dist="25400" dir="5400000">
-              <a:srgbClr val="13134F">
+              <a:srgbClr val="1E2B4A">
                 <a:alpha val="18000"/>
               </a:srgbClr>
             </a:outerShdw>
@@ -16047,7 +16047,7 @@
             <a:r>
               <a:rPr lang="en-US" sz="3000" b="1" dirty="0">
                 <a:solidFill>
-                  <a:srgbClr val="E2E3EC"/>
+                  <a:srgbClr val="E3E7EE"/>
                 </a:solidFill>
                 <a:latin typeface="Calibri" pitchFamily="34" charset="0"/>
                 <a:ea typeface="Calibri" pitchFamily="34" charset="-122"/>
@@ -16159,7 +16159,7 @@
           <a:ln/>
           <a:effectLst>
             <a:outerShdw sx="100000" sy="100000" kx="0" ky="0" algn="bl" rotWithShape="0" blurRad="127000" dist="25400" dir="5400000">
-              <a:srgbClr val="13134F">
+              <a:srgbClr val="1E2B4A">
                 <a:alpha val="10000"/>
               </a:srgbClr>
             </a:outerShdw>
@@ -16181,7 +16181,7 @@
             <a:avLst/>
           </a:prstGeom>
           <a:solidFill>
-            <a:srgbClr val="4444AD"/>
+            <a:srgbClr val="41639E"/>
           </a:solidFill>
           <a:ln w="31750">
             <a:solidFill>
@@ -16191,7 +16191,7 @@
           </a:ln>
           <a:effectLst>
             <a:outerShdw sx="100000" sy="100000" kx="0" ky="0" algn="bl" rotWithShape="0" blurRad="127000" dist="25400" dir="5400000">
-              <a:srgbClr val="13134F">
+              <a:srgbClr val="1E2B4A">
                 <a:alpha val="18000"/>
               </a:srgbClr>
             </a:outerShdw>
@@ -16249,7 +16249,7 @@
             <a:r>
               <a:rPr lang="en-US" sz="3000" b="1" dirty="0">
                 <a:solidFill>
-                  <a:srgbClr val="E2E3EC"/>
+                  <a:srgbClr val="E3E7EE"/>
                 </a:solidFill>
                 <a:latin typeface="Calibri" pitchFamily="34" charset="0"/>
                 <a:ea typeface="Calibri" pitchFamily="34" charset="-122"/>
@@ -16361,7 +16361,7 @@
           <a:ln/>
           <a:effectLst>
             <a:outerShdw sx="100000" sy="100000" kx="0" ky="0" algn="bl" rotWithShape="0" blurRad="127000" dist="25400" dir="5400000">
-              <a:srgbClr val="13134F">
+              <a:srgbClr val="1E2B4A">
                 <a:alpha val="10000"/>
               </a:srgbClr>
             </a:outerShdw>
@@ -16393,7 +16393,7 @@
           </a:ln>
           <a:effectLst>
             <a:outerShdw sx="100000" sy="100000" kx="0" ky="0" algn="bl" rotWithShape="0" blurRad="127000" dist="25400" dir="5400000">
-              <a:srgbClr val="13134F">
+              <a:srgbClr val="1E2B4A">
                 <a:alpha val="18000"/>
               </a:srgbClr>
             </a:outerShdw>
@@ -16451,7 +16451,7 @@
             <a:r>
               <a:rPr lang="en-US" sz="3000" b="1" dirty="0">
                 <a:solidFill>
-                  <a:srgbClr val="E2E3EC"/>
+                  <a:srgbClr val="E3E7EE"/>
                 </a:solidFill>
                 <a:latin typeface="Calibri" pitchFamily="34" charset="0"/>
                 <a:ea typeface="Calibri" pitchFamily="34" charset="-122"/>
@@ -16663,7 +16663,7 @@
             <a:r>
               <a:rPr lang="en-US" sz="2700" b="1" dirty="0">
                 <a:solidFill>
-                  <a:srgbClr val="191970"/>
+                  <a:srgbClr val="1E2B4A"/>
                 </a:solidFill>
                 <a:latin typeface="Calibri" pitchFamily="34" charset="0"/>
                 <a:ea typeface="Calibri" pitchFamily="34" charset="-122"/>
@@ -16697,7 +16697,7 @@
           <a:ln/>
           <a:effectLst>
             <a:outerShdw sx="100000" sy="100000" kx="0" ky="0" algn="bl" rotWithShape="0" blurRad="127000" dist="25400" dir="5400000">
-              <a:srgbClr val="13134F">
+              <a:srgbClr val="1E2B4A">
                 <a:alpha val="10000"/>
               </a:srgbClr>
             </a:outerShdw>
@@ -16719,7 +16719,7 @@
             <a:avLst/>
           </a:prstGeom>
           <a:solidFill>
-            <a:srgbClr val="4444AD"/>
+            <a:srgbClr val="41639E"/>
           </a:solidFill>
           <a:ln w="31750">
             <a:solidFill>
@@ -16729,7 +16729,7 @@
           </a:ln>
           <a:effectLst>
             <a:outerShdw sx="100000" sy="100000" kx="0" ky="0" algn="bl" rotWithShape="0" blurRad="127000" dist="25400" dir="5400000">
-              <a:srgbClr val="13134F">
+              <a:srgbClr val="1E2B4A">
                 <a:alpha val="18000"/>
               </a:srgbClr>
             </a:outerShdw>
@@ -16826,7 +16826,7 @@
             <a:r>
               <a:rPr lang="en-US" sz="1100" b="1" dirty="0">
                 <a:solidFill>
-                  <a:srgbClr val="4444AD"/>
+                  <a:srgbClr val="41639E"/>
                 </a:solidFill>
                 <a:latin typeface="Calibri" pitchFamily="34" charset="0"/>
                 <a:ea typeface="Calibri" pitchFamily="34" charset="-122"/>
@@ -16902,7 +16902,7 @@
           <a:ln/>
           <a:effectLst>
             <a:outerShdw sx="100000" sy="100000" kx="0" ky="0" algn="bl" rotWithShape="0" blurRad="127000" dist="25400" dir="5400000">
-              <a:srgbClr val="13134F">
+              <a:srgbClr val="1E2B4A">
                 <a:alpha val="10000"/>
               </a:srgbClr>
             </a:outerShdw>
@@ -16924,7 +16924,7 @@
             <a:avLst/>
           </a:prstGeom>
           <a:solidFill>
-            <a:srgbClr val="2A2A80"/>
+            <a:srgbClr val="3E8C9A"/>
           </a:solidFill>
           <a:ln w="31750">
             <a:solidFill>
@@ -16934,7 +16934,7 @@
           </a:ln>
           <a:effectLst>
             <a:outerShdw sx="100000" sy="100000" kx="0" ky="0" algn="bl" rotWithShape="0" blurRad="127000" dist="25400" dir="5400000">
-              <a:srgbClr val="13134F">
+              <a:srgbClr val="1E2B4A">
                 <a:alpha val="18000"/>
               </a:srgbClr>
             </a:outerShdw>
@@ -17031,7 +17031,7 @@
             <a:r>
               <a:rPr lang="en-US" sz="1100" b="1" dirty="0">
                 <a:solidFill>
-                  <a:srgbClr val="2A2A80"/>
+                  <a:srgbClr val="3E8C9A"/>
                 </a:solidFill>
                 <a:latin typeface="Calibri" pitchFamily="34" charset="0"/>
                 <a:ea typeface="Calibri" pitchFamily="34" charset="-122"/>
@@ -17107,7 +17107,7 @@
           <a:ln/>
           <a:effectLst>
             <a:outerShdw sx="100000" sy="100000" kx="0" ky="0" algn="bl" rotWithShape="0" blurRad="127000" dist="25400" dir="5400000">
-              <a:srgbClr val="13134F">
+              <a:srgbClr val="1E2B4A">
                 <a:alpha val="10000"/>
               </a:srgbClr>
             </a:outerShdw>
@@ -17129,7 +17129,7 @@
             <a:avLst/>
           </a:prstGeom>
           <a:solidFill>
-            <a:srgbClr val="6E6ECB"/>
+            <a:srgbClr val="C98A24"/>
           </a:solidFill>
           <a:ln w="31750">
             <a:solidFill>
@@ -17139,7 +17139,7 @@
           </a:ln>
           <a:effectLst>
             <a:outerShdw sx="100000" sy="100000" kx="0" ky="0" algn="bl" rotWithShape="0" blurRad="127000" dist="25400" dir="5400000">
-              <a:srgbClr val="13134F">
+              <a:srgbClr val="1E2B4A">
                 <a:alpha val="18000"/>
               </a:srgbClr>
             </a:outerShdw>
@@ -17236,7 +17236,7 @@
             <a:r>
               <a:rPr lang="en-US" sz="1100" b="1" dirty="0">
                 <a:solidFill>
-                  <a:srgbClr val="6E6ECB"/>
+                  <a:srgbClr val="C98A24"/>
                 </a:solidFill>
                 <a:latin typeface="Calibri" pitchFamily="34" charset="0"/>
                 <a:ea typeface="Calibri" pitchFamily="34" charset="-122"/>
@@ -17312,7 +17312,7 @@
           <a:ln/>
           <a:effectLst>
             <a:outerShdw sx="100000" sy="100000" kx="0" ky="0" algn="bl" rotWithShape="0" blurRad="127000" dist="25400" dir="5400000">
-              <a:srgbClr val="13134F">
+              <a:srgbClr val="1E2B4A">
                 <a:alpha val="10000"/>
               </a:srgbClr>
             </a:outerShdw>
@@ -17344,7 +17344,7 @@
           </a:ln>
           <a:effectLst>
             <a:outerShdw sx="100000" sy="100000" kx="0" ky="0" algn="bl" rotWithShape="0" blurRad="127000" dist="25400" dir="5400000">
-              <a:srgbClr val="13134F">
+              <a:srgbClr val="1E2B4A">
                 <a:alpha val="18000"/>
               </a:srgbClr>
             </a:outerShdw>
@@ -17517,7 +17517,7 @@
           <a:ln/>
           <a:effectLst>
             <a:outerShdw sx="100000" sy="100000" kx="0" ky="0" algn="bl" rotWithShape="0" blurRad="127000" dist="25400" dir="5400000">
-              <a:srgbClr val="13134F">
+              <a:srgbClr val="1E2B4A">
                 <a:alpha val="10000"/>
               </a:srgbClr>
             </a:outerShdw>
@@ -17685,7 +17685,7 @@
             <a:r>
               <a:rPr lang="en-US" sz="2700" b="1" dirty="0">
                 <a:solidFill>
-                  <a:srgbClr val="191970"/>
+                  <a:srgbClr val="1E2B4A"/>
                 </a:solidFill>
                 <a:latin typeface="Calibri" pitchFamily="34" charset="0"/>
                 <a:ea typeface="Calibri" pitchFamily="34" charset="-122"/>
@@ -17719,7 +17719,7 @@
           <a:ln/>
           <a:effectLst>
             <a:outerShdw sx="100000" sy="100000" kx="0" ky="0" algn="bl" rotWithShape="0" blurRad="127000" dist="25400" dir="5400000">
-              <a:srgbClr val="13134F">
+              <a:srgbClr val="1E2B4A">
                 <a:alpha val="10000"/>
               </a:srgbClr>
             </a:outerShdw>
@@ -17910,7 +17910,7 @@
           <a:ln/>
           <a:effectLst>
             <a:outerShdw sx="100000" sy="100000" kx="0" ky="0" algn="bl" rotWithShape="0" blurRad="127000" dist="25400" dir="5400000">
-              <a:srgbClr val="13134F">
+              <a:srgbClr val="1E2B4A">
                 <a:alpha val="10000"/>
               </a:srgbClr>
             </a:outerShdw>
@@ -17944,7 +17944,7 @@
             <a:r>
               <a:rPr lang="en-US" sz="2600" b="1" dirty="0">
                 <a:solidFill>
-                  <a:srgbClr val="2A2A80"/>
+                  <a:srgbClr val="3E8C9A"/>
                 </a:solidFill>
                 <a:latin typeface="Calibri" pitchFamily="34" charset="0"/>
                 <a:ea typeface="Calibri" pitchFamily="34" charset="-122"/>
@@ -18067,7 +18067,7 @@
             <a:r>
               <a:rPr lang="en-US" sz="1350" b="1" dirty="0">
                 <a:solidFill>
-                  <a:srgbClr val="2A2A80"/>
+                  <a:srgbClr val="3E8C9A"/>
                 </a:solidFill>
                 <a:latin typeface="Calibri" pitchFamily="34" charset="0"/>
                 <a:ea typeface="Calibri" pitchFamily="34" charset="-122"/>
@@ -18104,7 +18104,7 @@
           </a:ln>
           <a:effectLst>
             <a:outerShdw sx="100000" sy="100000" kx="0" ky="0" algn="bl" rotWithShape="0" blurRad="127000" dist="25400" dir="5400000">
-              <a:srgbClr val="13134F">
+              <a:srgbClr val="1E2B4A">
                 <a:alpha val="18000"/>
               </a:srgbClr>
             </a:outerShdw>
@@ -18150,7 +18150,7 @@
             <a:avLst/>
           </a:prstGeom>
           <a:solidFill>
-            <a:srgbClr val="2A2A80"/>
+            <a:srgbClr val="3E8C9A"/>
           </a:solidFill>
           <a:ln w="31750">
             <a:solidFill>
@@ -18160,7 +18160,7 @@
           </a:ln>
           <a:effectLst>
             <a:outerShdw sx="100000" sy="100000" kx="0" ky="0" algn="bl" rotWithShape="0" blurRad="127000" dist="25400" dir="5400000">
-              <a:srgbClr val="13134F">
+              <a:srgbClr val="1E2B4A">
                 <a:alpha val="18000"/>
               </a:srgbClr>
             </a:outerShdw>
@@ -18313,7 +18313,7 @@
             <a:r>
               <a:rPr lang="en-US" sz="2700" b="1" dirty="0">
                 <a:solidFill>
-                  <a:srgbClr val="191970"/>
+                  <a:srgbClr val="1E2B4A"/>
                 </a:solidFill>
                 <a:latin typeface="Calibri" pitchFamily="34" charset="0"/>
                 <a:ea typeface="Calibri" pitchFamily="34" charset="-122"/>
@@ -18389,7 +18389,7 @@
           <a:ln/>
           <a:effectLst>
             <a:outerShdw sx="100000" sy="100000" kx="0" ky="0" algn="bl" rotWithShape="0" blurRad="127000" dist="25400" dir="5400000">
-              <a:srgbClr val="13134F">
+              <a:srgbClr val="1E2B4A">
                 <a:alpha val="10000"/>
               </a:srgbClr>
             </a:outerShdw>
@@ -18411,7 +18411,7 @@
             <a:avLst/>
           </a:prstGeom>
           <a:solidFill>
-            <a:srgbClr val="6E6ECB"/>
+            <a:srgbClr val="C98A24"/>
           </a:solidFill>
           <a:ln w="31750">
             <a:solidFill>
@@ -18421,7 +18421,7 @@
           </a:ln>
           <a:effectLst>
             <a:outerShdw sx="100000" sy="100000" kx="0" ky="0" algn="bl" rotWithShape="0" blurRad="127000" dist="25400" dir="5400000">
-              <a:srgbClr val="13134F">
+              <a:srgbClr val="1E2B4A">
                 <a:alpha val="18000"/>
               </a:srgbClr>
             </a:outerShdw>
@@ -18558,7 +18558,7 @@
           <a:ln/>
           <a:effectLst>
             <a:outerShdw sx="100000" sy="100000" kx="0" ky="0" algn="bl" rotWithShape="0" blurRad="127000" dist="25400" dir="5400000">
-              <a:srgbClr val="13134F">
+              <a:srgbClr val="1E2B4A">
                 <a:alpha val="10000"/>
               </a:srgbClr>
             </a:outerShdw>
@@ -18580,7 +18580,7 @@
             <a:avLst/>
           </a:prstGeom>
           <a:solidFill>
-            <a:srgbClr val="4444AD"/>
+            <a:srgbClr val="41639E"/>
           </a:solidFill>
           <a:ln w="31750">
             <a:solidFill>
@@ -18590,7 +18590,7 @@
           </a:ln>
           <a:effectLst>
             <a:outerShdw sx="100000" sy="100000" kx="0" ky="0" algn="bl" rotWithShape="0" blurRad="127000" dist="25400" dir="5400000">
-              <a:srgbClr val="13134F">
+              <a:srgbClr val="1E2B4A">
                 <a:alpha val="18000"/>
               </a:srgbClr>
             </a:outerShdw>
@@ -18727,7 +18727,7 @@
           <a:ln/>
           <a:effectLst>
             <a:outerShdw sx="100000" sy="100000" kx="0" ky="0" algn="bl" rotWithShape="0" blurRad="127000" dist="25400" dir="5400000">
-              <a:srgbClr val="13134F">
+              <a:srgbClr val="1E2B4A">
                 <a:alpha val="10000"/>
               </a:srgbClr>
             </a:outerShdw>
@@ -18749,7 +18749,7 @@
             <a:avLst/>
           </a:prstGeom>
           <a:solidFill>
-            <a:srgbClr val="2A2A80"/>
+            <a:srgbClr val="3E8C9A"/>
           </a:solidFill>
           <a:ln w="31750">
             <a:solidFill>
@@ -18759,7 +18759,7 @@
           </a:ln>
           <a:effectLst>
             <a:outerShdw sx="100000" sy="100000" kx="0" ky="0" algn="bl" rotWithShape="0" blurRad="127000" dist="25400" dir="5400000">
-              <a:srgbClr val="13134F">
+              <a:srgbClr val="1E2B4A">
                 <a:alpha val="18000"/>
               </a:srgbClr>
             </a:outerShdw>
@@ -18996,7 +18996,7 @@
             <a:r>
               <a:rPr lang="en-US" sz="2700" b="1" dirty="0">
                 <a:solidFill>
-                  <a:srgbClr val="191970"/>
+                  <a:srgbClr val="1E2B4A"/>
                 </a:solidFill>
                 <a:latin typeface="Calibri" pitchFamily="34" charset="0"/>
                 <a:ea typeface="Calibri" pitchFamily="34" charset="-122"/>
@@ -19030,7 +19030,7 @@
           <a:ln/>
           <a:effectLst>
             <a:outerShdw sx="100000" sy="100000" kx="0" ky="0" algn="bl" rotWithShape="0" blurRad="127000" dist="25400" dir="5400000">
-              <a:srgbClr val="13134F">
+              <a:srgbClr val="1E2B4A">
                 <a:alpha val="10000"/>
               </a:srgbClr>
             </a:outerShdw>
@@ -19062,7 +19062,7 @@
           </a:ln>
           <a:effectLst>
             <a:outerShdw sx="100000" sy="100000" kx="0" ky="0" algn="bl" rotWithShape="0" blurRad="127000" dist="25400" dir="5400000">
-              <a:srgbClr val="13134F">
+              <a:srgbClr val="1E2B4A">
                 <a:alpha val="18000"/>
               </a:srgbClr>
             </a:outerShdw>
@@ -19316,7 +19316,7 @@
           <a:ln/>
           <a:effectLst>
             <a:outerShdw sx="100000" sy="100000" kx="0" ky="0" algn="bl" rotWithShape="0" blurRad="127000" dist="25400" dir="5400000">
-              <a:srgbClr val="13134F">
+              <a:srgbClr val="1E2B4A">
                 <a:alpha val="10000"/>
               </a:srgbClr>
             </a:outerShdw>
@@ -19338,7 +19338,7 @@
             <a:avLst/>
           </a:prstGeom>
           <a:solidFill>
-            <a:srgbClr val="2A2A80"/>
+            <a:srgbClr val="3E8C9A"/>
           </a:solidFill>
           <a:ln w="31750">
             <a:solidFill>
@@ -19348,7 +19348,7 @@
           </a:ln>
           <a:effectLst>
             <a:outerShdw sx="100000" sy="100000" kx="0" ky="0" algn="bl" rotWithShape="0" blurRad="127000" dist="25400" dir="5400000">
-              <a:srgbClr val="13134F">
+              <a:srgbClr val="1E2B4A">
                 <a:alpha val="18000"/>
               </a:srgbClr>
             </a:outerShdw>
@@ -19433,7 +19433,7 @@
             <a:avLst/>
           </a:prstGeom>
           <a:solidFill>
-            <a:srgbClr val="2A2A80"/>
+            <a:srgbClr val="3E8C9A"/>
           </a:solidFill>
           <a:ln/>
         </p:spPr>
@@ -19534,7 +19534,7 @@
             <a:avLst/>
           </a:prstGeom>
           <a:solidFill>
-            <a:srgbClr val="2A2A80"/>
+            <a:srgbClr val="3E8C9A"/>
           </a:solidFill>
           <a:ln/>
         </p:spPr>
@@ -19635,7 +19635,7 @@
             <a:avLst/>
           </a:prstGeom>
           <a:solidFill>
-            <a:srgbClr val="2A2A80"/>
+            <a:srgbClr val="3E8C9A"/>
           </a:solidFill>
           <a:ln/>
         </p:spPr>
@@ -19798,7 +19798,7 @@
     <p:bg>
       <p:bgPr>
         <a:solidFill>
-          <a:srgbClr val="101038"/>
+          <a:srgbClr val="16213D"/>
         </a:solidFill>
       </p:bgPr>
     </p:bg>
@@ -19831,7 +19831,7 @@
             <a:avLst/>
           </a:prstGeom>
           <a:solidFill>
-            <a:srgbClr val="23236B"/>
+            <a:srgbClr val="24365E"/>
           </a:solidFill>
           <a:ln/>
         </p:spPr>
@@ -19851,7 +19851,7 @@
             <a:avLst/>
           </a:prstGeom>
           <a:solidFill>
-            <a:srgbClr val="23236B"/>
+            <a:srgbClr val="24365E"/>
           </a:solidFill>
           <a:ln/>
         </p:spPr>
@@ -19964,7 +19964,7 @@
             <a:r>
               <a:rPr lang="en-US" sz="1400" dirty="0">
                 <a:solidFill>
-                  <a:srgbClr val="B7B7DB"/>
+                  <a:srgbClr val="AFC0DA"/>
                 </a:solidFill>
                 <a:latin typeface="Calibri" pitchFamily="34" charset="0"/>
                 <a:ea typeface="Calibri" pitchFamily="34" charset="-122"/>
@@ -20035,7 +20035,7 @@
             <a:r>
               <a:rPr lang="en-US" sz="2700" b="1" dirty="0">
                 <a:solidFill>
-                  <a:srgbClr val="191970"/>
+                  <a:srgbClr val="1E2B4A"/>
                 </a:solidFill>
                 <a:latin typeface="Calibri" pitchFamily="34" charset="0"/>
                 <a:ea typeface="Calibri" pitchFamily="34" charset="-122"/>
@@ -20064,12 +20064,12 @@
             </a:avLst>
           </a:prstGeom>
           <a:solidFill>
-            <a:srgbClr val="191970"/>
+            <a:srgbClr val="1E2B4A"/>
           </a:solidFill>
           <a:ln/>
           <a:effectLst>
             <a:outerShdw sx="100000" sy="100000" kx="0" ky="0" algn="bl" rotWithShape="0" blurRad="127000" dist="25400" dir="5400000">
-              <a:srgbClr val="13134F">
+              <a:srgbClr val="1E2B4A">
                 <a:alpha val="10000"/>
               </a:srgbClr>
             </a:outerShdw>
@@ -20140,7 +20140,7 @@
           <a:ln/>
           <a:effectLst>
             <a:outerShdw sx="100000" sy="100000" kx="0" ky="0" algn="bl" rotWithShape="0" blurRad="127000" dist="25400" dir="5400000">
-              <a:srgbClr val="13134F">
+              <a:srgbClr val="1E2B4A">
                 <a:alpha val="10000"/>
               </a:srgbClr>
             </a:outerShdw>
@@ -20289,7 +20289,7 @@
           <a:ln/>
           <a:effectLst>
             <a:outerShdw sx="100000" sy="100000" kx="0" ky="0" algn="bl" rotWithShape="0" blurRad="127000" dist="25400" dir="5400000">
-              <a:srgbClr val="13134F">
+              <a:srgbClr val="1E2B4A">
                 <a:alpha val="10000"/>
               </a:srgbClr>
             </a:outerShdw>
@@ -20323,7 +20323,7 @@
             <a:r>
               <a:rPr lang="en-US" sz="3600" b="1" dirty="0">
                 <a:solidFill>
-                  <a:srgbClr val="4444AD"/>
+                  <a:srgbClr val="41639E"/>
                 </a:solidFill>
                 <a:latin typeface="Calibri" pitchFamily="34" charset="0"/>
                 <a:ea typeface="Calibri" pitchFamily="34" charset="-122"/>
@@ -20438,7 +20438,7 @@
           <a:ln/>
           <a:effectLst>
             <a:outerShdw sx="100000" sy="100000" kx="0" ky="0" algn="bl" rotWithShape="0" blurRad="127000" dist="25400" dir="5400000">
-              <a:srgbClr val="13134F">
+              <a:srgbClr val="1E2B4A">
                 <a:alpha val="10000"/>
               </a:srgbClr>
             </a:outerShdw>
@@ -20472,7 +20472,7 @@
             <a:r>
               <a:rPr lang="en-US" sz="3600" b="1" dirty="0">
                 <a:solidFill>
-                  <a:srgbClr val="2A2A80"/>
+                  <a:srgbClr val="3E8C9A"/>
                 </a:solidFill>
                 <a:latin typeface="Calibri" pitchFamily="34" charset="0"/>
                 <a:ea typeface="Calibri" pitchFamily="34" charset="-122"/>
@@ -20587,7 +20587,7 @@
           <a:ln/>
           <a:effectLst>
             <a:outerShdw sx="100000" sy="100000" kx="0" ky="0" algn="bl" rotWithShape="0" blurRad="127000" dist="25400" dir="5400000">
-              <a:srgbClr val="13134F">
+              <a:srgbClr val="1E2B4A">
                 <a:alpha val="10000"/>
               </a:srgbClr>
             </a:outerShdw>
@@ -20621,7 +20621,7 @@
             <a:r>
               <a:rPr lang="en-US" sz="3600" b="1" dirty="0">
                 <a:solidFill>
-                  <a:srgbClr val="6E6ECB"/>
+                  <a:srgbClr val="C98A24"/>
                 </a:solidFill>
                 <a:latin typeface="Calibri" pitchFamily="34" charset="0"/>
                 <a:ea typeface="Calibri" pitchFamily="34" charset="-122"/>
@@ -20836,7 +20836,7 @@
             <a:r>
               <a:rPr lang="en-US" sz="2700" b="1" dirty="0">
                 <a:solidFill>
-                  <a:srgbClr val="191970"/>
+                  <a:srgbClr val="1E2B4A"/>
                 </a:solidFill>
                 <a:latin typeface="Calibri" pitchFamily="34" charset="0"/>
                 <a:ea typeface="Calibri" pitchFamily="34" charset="-122"/>
@@ -20912,7 +20912,7 @@
           <a:ln/>
           <a:effectLst>
             <a:outerShdw sx="100000" sy="100000" kx="0" ky="0" algn="bl" rotWithShape="0" blurRad="127000" dist="25400" dir="5400000">
-              <a:srgbClr val="13134F">
+              <a:srgbClr val="1E2B4A">
                 <a:alpha val="10000"/>
               </a:srgbClr>
             </a:outerShdw>
@@ -20934,7 +20934,7 @@
             <a:avLst/>
           </a:prstGeom>
           <a:solidFill>
-            <a:srgbClr val="6E6ECB"/>
+            <a:srgbClr val="C98A24"/>
           </a:solidFill>
           <a:ln w="31750">
             <a:solidFill>
@@ -20944,7 +20944,7 @@
           </a:ln>
           <a:effectLst>
             <a:outerShdw sx="100000" sy="100000" kx="0" ky="0" algn="bl" rotWithShape="0" blurRad="127000" dist="25400" dir="5400000">
-              <a:srgbClr val="13134F">
+              <a:srgbClr val="1E2B4A">
                 <a:alpha val="18000"/>
               </a:srgbClr>
             </a:outerShdw>
@@ -21081,7 +21081,7 @@
           <a:ln/>
           <a:effectLst>
             <a:outerShdw sx="100000" sy="100000" kx="0" ky="0" algn="bl" rotWithShape="0" blurRad="127000" dist="25400" dir="5400000">
-              <a:srgbClr val="13134F">
+              <a:srgbClr val="1E2B4A">
                 <a:alpha val="10000"/>
               </a:srgbClr>
             </a:outerShdw>
@@ -21103,7 +21103,7 @@
             <a:avLst/>
           </a:prstGeom>
           <a:solidFill>
-            <a:srgbClr val="4444AD"/>
+            <a:srgbClr val="41639E"/>
           </a:solidFill>
           <a:ln w="31750">
             <a:solidFill>
@@ -21113,7 +21113,7 @@
           </a:ln>
           <a:effectLst>
             <a:outerShdw sx="100000" sy="100000" kx="0" ky="0" algn="bl" rotWithShape="0" blurRad="127000" dist="25400" dir="5400000">
-              <a:srgbClr val="13134F">
+              <a:srgbClr val="1E2B4A">
                 <a:alpha val="18000"/>
               </a:srgbClr>
             </a:outerShdw>
@@ -21250,7 +21250,7 @@
           <a:ln/>
           <a:effectLst>
             <a:outerShdw sx="100000" sy="100000" kx="0" ky="0" algn="bl" rotWithShape="0" blurRad="127000" dist="25400" dir="5400000">
-              <a:srgbClr val="13134F">
+              <a:srgbClr val="1E2B4A">
                 <a:alpha val="10000"/>
               </a:srgbClr>
             </a:outerShdw>
@@ -21272,7 +21272,7 @@
             <a:avLst/>
           </a:prstGeom>
           <a:solidFill>
-            <a:srgbClr val="2A2A80"/>
+            <a:srgbClr val="3E8C9A"/>
           </a:solidFill>
           <a:ln w="31750">
             <a:solidFill>
@@ -21282,7 +21282,7 @@
           </a:ln>
           <a:effectLst>
             <a:outerShdw sx="100000" sy="100000" kx="0" ky="0" algn="bl" rotWithShape="0" blurRad="127000" dist="25400" dir="5400000">
-              <a:srgbClr val="13134F">
+              <a:srgbClr val="1E2B4A">
                 <a:alpha val="18000"/>
               </a:srgbClr>
             </a:outerShdw>
@@ -21474,7 +21474,7 @@
     <p:bg>
       <p:bgPr>
         <a:solidFill>
-          <a:srgbClr val="101038"/>
+          <a:srgbClr val="16213D"/>
         </a:solidFill>
       </p:bgPr>
     </p:bg>
@@ -21507,7 +21507,7 @@
             <a:avLst/>
           </a:prstGeom>
           <a:solidFill>
-            <a:srgbClr val="23236B"/>
+            <a:srgbClr val="24365E"/>
           </a:solidFill>
           <a:ln/>
         </p:spPr>
@@ -21527,7 +21527,7 @@
             <a:avLst/>
           </a:prstGeom>
           <a:solidFill>
-            <a:srgbClr val="23236B"/>
+            <a:srgbClr val="24365E"/>
           </a:solidFill>
           <a:ln/>
         </p:spPr>
@@ -21663,7 +21663,7 @@
     <p:bg>
       <p:bgPr>
         <a:solidFill>
-          <a:srgbClr val="101038"/>
+          <a:srgbClr val="16213D"/>
         </a:solidFill>
       </p:bgPr>
     </p:bg>
@@ -21696,7 +21696,7 @@
             <a:avLst/>
           </a:prstGeom>
           <a:solidFill>
-            <a:srgbClr val="23236B"/>
+            <a:srgbClr val="24365E"/>
           </a:solidFill>
           <a:ln/>
         </p:spPr>
@@ -21716,7 +21716,7 @@
             <a:avLst/>
           </a:prstGeom>
           <a:solidFill>
-            <a:srgbClr val="23236B"/>
+            <a:srgbClr val="24365E"/>
           </a:solidFill>
           <a:ln/>
         </p:spPr>
@@ -21829,7 +21829,7 @@
             <a:r>
               <a:rPr lang="en-US" sz="1400" dirty="0">
                 <a:solidFill>
-                  <a:srgbClr val="B7B7DB"/>
+                  <a:srgbClr val="AFC0DA"/>
                 </a:solidFill>
                 <a:latin typeface="Calibri" pitchFamily="34" charset="0"/>
                 <a:ea typeface="Calibri" pitchFamily="34" charset="-122"/>
@@ -21900,7 +21900,7 @@
             <a:r>
               <a:rPr lang="en-US" sz="2700" b="1" dirty="0">
                 <a:solidFill>
-                  <a:srgbClr val="191970"/>
+                  <a:srgbClr val="1E2B4A"/>
                 </a:solidFill>
                 <a:latin typeface="Calibri" pitchFamily="34" charset="0"/>
                 <a:ea typeface="Calibri" pitchFamily="34" charset="-122"/>
@@ -21934,7 +21934,7 @@
           <a:ln/>
           <a:effectLst>
             <a:outerShdw sx="100000" sy="100000" kx="0" ky="0" algn="bl" rotWithShape="0" blurRad="127000" dist="25400" dir="5400000">
-              <a:srgbClr val="13134F">
+              <a:srgbClr val="1E2B4A">
                 <a:alpha val="10000"/>
               </a:srgbClr>
             </a:outerShdw>
@@ -21956,7 +21956,7 @@
             <a:avLst/>
           </a:prstGeom>
           <a:solidFill>
-            <a:srgbClr val="4444AD"/>
+            <a:srgbClr val="41639E"/>
           </a:solidFill>
           <a:ln w="31750">
             <a:solidFill>
@@ -21966,7 +21966,7 @@
           </a:ln>
           <a:effectLst>
             <a:outerShdw sx="100000" sy="100000" kx="0" ky="0" algn="bl" rotWithShape="0" blurRad="127000" dist="25400" dir="5400000">
-              <a:srgbClr val="13134F">
+              <a:srgbClr val="1E2B4A">
                 <a:alpha val="18000"/>
               </a:srgbClr>
             </a:outerShdw>
@@ -22066,7 +22066,7 @@
             <a:r>
               <a:rPr lang="en-US" sz="3400" b="1" dirty="0">
                 <a:solidFill>
-                  <a:srgbClr val="4444AD"/>
+                  <a:srgbClr val="41639E"/>
                 </a:solidFill>
                 <a:latin typeface="Calibri" pitchFamily="34" charset="0"/>
                 <a:ea typeface="Calibri" pitchFamily="34" charset="-122"/>
@@ -22167,7 +22167,7 @@
             <a:r>
               <a:rPr lang="en-US" sz="3400" b="1" dirty="0">
                 <a:solidFill>
-                  <a:srgbClr val="4444AD"/>
+                  <a:srgbClr val="41639E"/>
                 </a:solidFill>
                 <a:latin typeface="Calibri" pitchFamily="34" charset="0"/>
                 <a:ea typeface="Calibri" pitchFamily="34" charset="-122"/>
@@ -22344,7 +22344,7 @@
           <a:ln/>
           <a:effectLst>
             <a:outerShdw sx="100000" sy="100000" kx="0" ky="0" algn="bl" rotWithShape="0" blurRad="127000" dist="25400" dir="5400000">
-              <a:srgbClr val="13134F">
+              <a:srgbClr val="1E2B4A">
                 <a:alpha val="10000"/>
               </a:srgbClr>
             </a:outerShdw>
@@ -22376,7 +22376,7 @@
           </a:ln>
           <a:effectLst>
             <a:outerShdw sx="100000" sy="100000" kx="0" ky="0" algn="bl" rotWithShape="0" blurRad="127000" dist="25400" dir="5400000">
-              <a:srgbClr val="13134F">
+              <a:srgbClr val="1E2B4A">
                 <a:alpha val="18000"/>
               </a:srgbClr>
             </a:outerShdw>
@@ -22854,7 +22854,7 @@
             <a:r>
               <a:rPr lang="en-US" sz="2700" b="1" dirty="0">
                 <a:solidFill>
-                  <a:srgbClr val="191970"/>
+                  <a:srgbClr val="1E2B4A"/>
                 </a:solidFill>
                 <a:latin typeface="Calibri" pitchFamily="34" charset="0"/>
                 <a:ea typeface="Calibri" pitchFamily="34" charset="-122"/>
@@ -22883,12 +22883,12 @@
             </a:avLst>
           </a:prstGeom>
           <a:solidFill>
-            <a:srgbClr val="191970"/>
+            <a:srgbClr val="1E2B4A"/>
           </a:solidFill>
           <a:ln/>
           <a:effectLst>
             <a:outerShdw sx="100000" sy="100000" kx="0" ky="0" algn="bl" rotWithShape="0" blurRad="127000" dist="25400" dir="5400000">
-              <a:srgbClr val="13134F">
+              <a:srgbClr val="1E2B4A">
                 <a:alpha val="10000"/>
               </a:srgbClr>
             </a:outerShdw>
@@ -22979,7 +22979,7 @@
           <a:ln/>
           <a:effectLst>
             <a:outerShdw sx="100000" sy="100000" kx="0" ky="0" algn="bl" rotWithShape="0" blurRad="127000" dist="25400" dir="5400000">
-              <a:srgbClr val="13134F">
+              <a:srgbClr val="1E2B4A">
                 <a:alpha val="10000"/>
               </a:srgbClr>
             </a:outerShdw>
@@ -23092,7 +23092,7 @@
           <a:ln/>
           <a:effectLst>
             <a:outerShdw sx="100000" sy="100000" kx="0" ky="0" algn="bl" rotWithShape="0" blurRad="127000" dist="25400" dir="5400000">
-              <a:srgbClr val="13134F">
+              <a:srgbClr val="1E2B4A">
                 <a:alpha val="10000"/>
               </a:srgbClr>
             </a:outerShdw>
@@ -23205,7 +23205,7 @@
           <a:ln/>
           <a:effectLst>
             <a:outerShdw sx="100000" sy="100000" kx="0" ky="0" algn="bl" rotWithShape="0" blurRad="127000" dist="25400" dir="5400000">
-              <a:srgbClr val="13134F">
+              <a:srgbClr val="1E2B4A">
                 <a:alpha val="10000"/>
               </a:srgbClr>
             </a:outerShdw>
@@ -23321,7 +23321,7 @@
           </a:ln>
           <a:effectLst>
             <a:outerShdw sx="100000" sy="100000" kx="0" ky="0" algn="bl" rotWithShape="0" blurRad="127000" dist="25400" dir="5400000">
-              <a:srgbClr val="13134F">
+              <a:srgbClr val="1E2B4A">
                 <a:alpha val="18000"/>
               </a:srgbClr>
             </a:outerShdw>
@@ -23367,7 +23367,7 @@
             <a:avLst/>
           </a:prstGeom>
           <a:solidFill>
-            <a:srgbClr val="6E6ECB"/>
+            <a:srgbClr val="C98A24"/>
           </a:solidFill>
           <a:ln w="31750">
             <a:solidFill>
@@ -23377,7 +23377,7 @@
           </a:ln>
           <a:effectLst>
             <a:outerShdw sx="100000" sy="100000" kx="0" ky="0" algn="bl" rotWithShape="0" blurRad="127000" dist="25400" dir="5400000">
-              <a:srgbClr val="13134F">
+              <a:srgbClr val="1E2B4A">
                 <a:alpha val="18000"/>
               </a:srgbClr>
             </a:outerShdw>
@@ -23423,7 +23423,7 @@
             <a:avLst/>
           </a:prstGeom>
           <a:solidFill>
-            <a:srgbClr val="2A2A80"/>
+            <a:srgbClr val="3E8C9A"/>
           </a:solidFill>
           <a:ln w="31750">
             <a:solidFill>
@@ -23433,7 +23433,7 @@
           </a:ln>
           <a:effectLst>
             <a:outerShdw sx="100000" sy="100000" kx="0" ky="0" algn="bl" rotWithShape="0" blurRad="127000" dist="25400" dir="5400000">
-              <a:srgbClr val="13134F">
+              <a:srgbClr val="1E2B4A">
                 <a:alpha val="18000"/>
               </a:srgbClr>
             </a:outerShdw>
@@ -23586,7 +23586,7 @@
             <a:r>
               <a:rPr lang="en-US" sz="2700" b="1" dirty="0">
                 <a:solidFill>
-                  <a:srgbClr val="191970"/>
+                  <a:srgbClr val="1E2B4A"/>
                 </a:solidFill>
                 <a:latin typeface="Calibri" pitchFamily="34" charset="0"/>
                 <a:ea typeface="Calibri" pitchFamily="34" charset="-122"/>
@@ -23620,7 +23620,7 @@
           <a:ln/>
           <a:effectLst>
             <a:outerShdw sx="100000" sy="100000" kx="0" ky="0" algn="bl" rotWithShape="0" blurRad="127000" dist="25400" dir="5400000">
-              <a:srgbClr val="13134F">
+              <a:srgbClr val="1E2B4A">
                 <a:alpha val="10000"/>
               </a:srgbClr>
             </a:outerShdw>
@@ -23642,7 +23642,7 @@
             <a:avLst/>
           </a:prstGeom>
           <a:solidFill>
-            <a:srgbClr val="4444AD"/>
+            <a:srgbClr val="41639E"/>
           </a:solidFill>
           <a:ln w="31750">
             <a:solidFill>
@@ -23652,7 +23652,7 @@
           </a:ln>
           <a:effectLst>
             <a:outerShdw sx="100000" sy="100000" kx="0" ky="0" algn="bl" rotWithShape="0" blurRad="127000" dist="25400" dir="5400000">
-              <a:srgbClr val="13134F">
+              <a:srgbClr val="1E2B4A">
                 <a:alpha val="18000"/>
               </a:srgbClr>
             </a:outerShdw>
@@ -23779,7 +23779,7 @@
             <a:avLst/>
           </a:prstGeom>
           <a:solidFill>
-            <a:srgbClr val="4444AD"/>
+            <a:srgbClr val="41639E"/>
           </a:solidFill>
           <a:ln/>
         </p:spPr>
@@ -23880,7 +23880,7 @@
             <a:avLst/>
           </a:prstGeom>
           <a:solidFill>
-            <a:srgbClr val="4444AD"/>
+            <a:srgbClr val="41639E"/>
           </a:solidFill>
           <a:ln/>
         </p:spPr>
@@ -23988,7 +23988,7 @@
           <a:ln/>
           <a:effectLst>
             <a:outerShdw sx="100000" sy="100000" kx="0" ky="0" algn="bl" rotWithShape="0" blurRad="127000" dist="25400" dir="5400000">
-              <a:srgbClr val="13134F">
+              <a:srgbClr val="1E2B4A">
                 <a:alpha val="10000"/>
               </a:srgbClr>
             </a:outerShdw>
@@ -24020,7 +24020,7 @@
           </a:ln>
           <a:effectLst>
             <a:outerShdw sx="100000" sy="100000" kx="0" ky="0" algn="bl" rotWithShape="0" blurRad="127000" dist="25400" dir="5400000">
-              <a:srgbClr val="13134F">
+              <a:srgbClr val="1E2B4A">
                 <a:alpha val="18000"/>
               </a:srgbClr>
             </a:outerShdw>
@@ -24107,12 +24107,12 @@
             </a:avLst>
           </a:prstGeom>
           <a:solidFill>
-            <a:srgbClr val="E7E7F3"/>
+            <a:srgbClr val="E5EEF4"/>
           </a:solidFill>
           <a:ln/>
           <a:effectLst>
             <a:outerShdw sx="100000" sy="100000" kx="0" ky="0" algn="bl" rotWithShape="0" blurRad="127000" dist="25400" dir="5400000">
-              <a:srgbClr val="13134F">
+              <a:srgbClr val="1E2B4A">
                 <a:alpha val="10000"/>
               </a:srgbClr>
             </a:outerShdw>
@@ -24217,12 +24217,12 @@
             </a:avLst>
           </a:prstGeom>
           <a:solidFill>
-            <a:srgbClr val="E7E7F3"/>
+            <a:srgbClr val="E5EEF4"/>
           </a:solidFill>
           <a:ln/>
           <a:effectLst>
             <a:outerShdw sx="100000" sy="100000" kx="0" ky="0" algn="bl" rotWithShape="0" blurRad="127000" dist="25400" dir="5400000">
-              <a:srgbClr val="13134F">
+              <a:srgbClr val="1E2B4A">
                 <a:alpha val="10000"/>
               </a:srgbClr>
             </a:outerShdw>
@@ -24387,7 +24387,7 @@
     <p:bg>
       <p:bgPr>
         <a:solidFill>
-          <a:srgbClr val="101038"/>
+          <a:srgbClr val="16213D"/>
         </a:solidFill>
       </p:bgPr>
     </p:bg>
@@ -24420,7 +24420,7 @@
             <a:avLst/>
           </a:prstGeom>
           <a:solidFill>
-            <a:srgbClr val="23236B"/>
+            <a:srgbClr val="24365E"/>
           </a:solidFill>
           <a:ln/>
         </p:spPr>
@@ -24440,7 +24440,7 @@
             <a:avLst/>
           </a:prstGeom>
           <a:solidFill>
-            <a:srgbClr val="23236B"/>
+            <a:srgbClr val="24365E"/>
           </a:solidFill>
           <a:ln/>
         </p:spPr>
@@ -24553,7 +24553,7 @@
             <a:r>
               <a:rPr lang="en-US" sz="1400" dirty="0">
                 <a:solidFill>
-                  <a:srgbClr val="B7B7DB"/>
+                  <a:srgbClr val="AFC0DA"/>
                 </a:solidFill>
                 <a:latin typeface="Calibri" pitchFamily="34" charset="0"/>
                 <a:ea typeface="Calibri" pitchFamily="34" charset="-122"/>
@@ -24624,7 +24624,7 @@
             <a:r>
               <a:rPr lang="en-US" sz="2700" b="1" dirty="0">
                 <a:solidFill>
-                  <a:srgbClr val="191970"/>
+                  <a:srgbClr val="1E2B4A"/>
                 </a:solidFill>
                 <a:latin typeface="Calibri" pitchFamily="34" charset="0"/>
                 <a:ea typeface="Calibri" pitchFamily="34" charset="-122"/>
@@ -24658,7 +24658,7 @@
           <a:ln/>
           <a:effectLst>
             <a:outerShdw sx="100000" sy="100000" kx="0" ky="0" algn="bl" rotWithShape="0" blurRad="127000" dist="25400" dir="5400000">
-              <a:srgbClr val="13134F">
+              <a:srgbClr val="1E2B4A">
                 <a:alpha val="10000"/>
               </a:srgbClr>
             </a:outerShdw>
@@ -24719,7 +24719,7 @@
             <a:avLst/>
           </a:prstGeom>
           <a:solidFill>
-            <a:srgbClr val="4444AD"/>
+            <a:srgbClr val="41639E"/>
           </a:solidFill>
           <a:ln/>
         </p:spPr>
@@ -24859,7 +24859,7 @@
             <a:avLst/>
           </a:prstGeom>
           <a:solidFill>
-            <a:srgbClr val="4444AD"/>
+            <a:srgbClr val="41639E"/>
           </a:solidFill>
           <a:ln/>
         </p:spPr>
@@ -24999,7 +24999,7 @@
             <a:avLst/>
           </a:prstGeom>
           <a:solidFill>
-            <a:srgbClr val="4444AD"/>
+            <a:srgbClr val="41639E"/>
           </a:solidFill>
           <a:ln/>
         </p:spPr>
@@ -25146,7 +25146,7 @@
           <a:ln/>
           <a:effectLst>
             <a:outerShdw sx="100000" sy="100000" kx="0" ky="0" algn="bl" rotWithShape="0" blurRad="127000" dist="25400" dir="5400000">
-              <a:srgbClr val="13134F">
+              <a:srgbClr val="1E2B4A">
                 <a:alpha val="10000"/>
               </a:srgbClr>
             </a:outerShdw>
@@ -25567,7 +25567,7 @@
             <a:avLst/>
           </a:prstGeom>
           <a:solidFill>
-            <a:srgbClr val="4444AD"/>
+            <a:srgbClr val="41639E"/>
           </a:solidFill>
           <a:ln w="31750">
             <a:solidFill>
@@ -25577,7 +25577,7 @@
           </a:ln>
           <a:effectLst>
             <a:outerShdw sx="100000" sy="100000" kx="0" ky="0" algn="bl" rotWithShape="0" blurRad="127000" dist="25400" dir="5400000">
-              <a:srgbClr val="13134F">
+              <a:srgbClr val="1E2B4A">
                 <a:alpha val="18000"/>
               </a:srgbClr>
             </a:outerShdw>
@@ -25623,7 +25623,7 @@
             <a:avLst/>
           </a:prstGeom>
           <a:solidFill>
-            <a:srgbClr val="6E6ECB"/>
+            <a:srgbClr val="C98A24"/>
           </a:solidFill>
           <a:ln w="31750">
             <a:solidFill>
@@ -25633,7 +25633,7 @@
           </a:ln>
           <a:effectLst>
             <a:outerShdw sx="100000" sy="100000" kx="0" ky="0" algn="bl" rotWithShape="0" blurRad="127000" dist="25400" dir="5400000">
-              <a:srgbClr val="13134F">
+              <a:srgbClr val="1E2B4A">
                 <a:alpha val="18000"/>
               </a:srgbClr>
             </a:outerShdw>
@@ -25689,7 +25689,7 @@
           </a:ln>
           <a:effectLst>
             <a:outerShdw sx="100000" sy="100000" kx="0" ky="0" algn="bl" rotWithShape="0" blurRad="127000" dist="25400" dir="5400000">
-              <a:srgbClr val="13134F">
+              <a:srgbClr val="1E2B4A">
                 <a:alpha val="18000"/>
               </a:srgbClr>
             </a:outerShdw>
@@ -25797,7 +25797,7 @@
     <p:bg>
       <p:bgPr>
         <a:solidFill>
-          <a:srgbClr val="101038"/>
+          <a:srgbClr val="16213D"/>
         </a:solidFill>
       </p:bgPr>
     </p:bg>
@@ -25830,7 +25830,7 @@
             <a:avLst/>
           </a:prstGeom>
           <a:solidFill>
-            <a:srgbClr val="23236B"/>
+            <a:srgbClr val="24365E"/>
           </a:solidFill>
           <a:ln/>
         </p:spPr>
@@ -25850,7 +25850,7 @@
             <a:avLst/>
           </a:prstGeom>
           <a:solidFill>
-            <a:srgbClr val="23236B"/>
+            <a:srgbClr val="24365E"/>
           </a:solidFill>
           <a:ln/>
         </p:spPr>
@@ -25963,7 +25963,7 @@
             <a:r>
               <a:rPr lang="en-US" sz="1400" dirty="0">
                 <a:solidFill>
-                  <a:srgbClr val="B7B7DB"/>
+                  <a:srgbClr val="AFC0DA"/>
                 </a:solidFill>
                 <a:latin typeface="Calibri" pitchFamily="34" charset="0"/>
                 <a:ea typeface="Calibri" pitchFamily="34" charset="-122"/>

</xml_diff>

<commit_message>
Revenir au bleu ENSAE pour la presentation (#702)
La palette midnightblue est abandonnee au profit du bleu initial. Le
fond blanc, les logos et les corrections de mise en page sont conserves.


Claude-Session: https://claude.ai/code/session_01837AJxDdpW6rUH9DV9QD1H

Co-authored-by: Claude <noreply@anthropic.com>
</commit_message>
<xml_diff>
--- a/infographie/presentation_infographique.pptx
+++ b/infographie/presentation_infographique.pptx
@@ -3171,7 +3171,7 @@
     <p:bg>
       <p:bgPr>
         <a:solidFill>
-          <a:srgbClr val="101038"/>
+          <a:srgbClr val="16213D"/>
         </a:solidFill>
       </p:bgPr>
     </p:bg>
@@ -3204,7 +3204,7 @@
             <a:avLst/>
           </a:prstGeom>
           <a:solidFill>
-            <a:srgbClr val="23236B"/>
+            <a:srgbClr val="24365E"/>
           </a:solidFill>
           <a:ln/>
         </p:spPr>
@@ -3224,7 +3224,7 @@
             <a:avLst/>
           </a:prstGeom>
           <a:solidFill>
-            <a:srgbClr val="23236B"/>
+            <a:srgbClr val="24365E"/>
           </a:solidFill>
           <a:ln/>
         </p:spPr>
@@ -3251,7 +3251,7 @@
           <a:ln/>
           <a:effectLst>
             <a:outerShdw sx="100000" sy="100000" kx="0" ky="0" algn="bl" rotWithShape="0" blurRad="127000" dist="25400" dir="5400000">
-              <a:srgbClr val="13134F">
+              <a:srgbClr val="1E2B4A">
                 <a:alpha val="22000"/>
               </a:srgbClr>
             </a:outerShdw>
@@ -3304,7 +3304,7 @@
           <a:ln/>
           <a:effectLst>
             <a:outerShdw sx="100000" sy="100000" kx="0" ky="0" algn="bl" rotWithShape="0" blurRad="127000" dist="25400" dir="5400000">
-              <a:srgbClr val="13134F">
+              <a:srgbClr val="1E2B4A">
                 <a:alpha val="22000"/>
               </a:srgbClr>
             </a:outerShdw>
@@ -3401,7 +3401,7 @@
             <a:r>
               <a:rPr lang="en-US" sz="1250" dirty="0">
                 <a:solidFill>
-                  <a:srgbClr val="B7B7DB"/>
+                  <a:srgbClr val="AFC0DA"/>
                 </a:solidFill>
                 <a:latin typeface="Calibri" pitchFamily="34" charset="0"/>
                 <a:ea typeface="Calibri" pitchFamily="34" charset="-122"/>
@@ -3622,7 +3622,7 @@
             <a:r>
               <a:rPr lang="en-US" sz="1050" dirty="0">
                 <a:solidFill>
-                  <a:srgbClr val="B7B7DB"/>
+                  <a:srgbClr val="AFC0DA"/>
                 </a:solidFill>
                 <a:latin typeface="Calibri" pitchFamily="34" charset="0"/>
                 <a:ea typeface="Calibri" pitchFamily="34" charset="-122"/>
@@ -3742,7 +3742,7 @@
             <a:r>
               <a:rPr lang="en-US" sz="1050" dirty="0">
                 <a:solidFill>
-                  <a:srgbClr val="B7B7DB"/>
+                  <a:srgbClr val="AFC0DA"/>
                 </a:solidFill>
                 <a:latin typeface="Calibri" pitchFamily="34" charset="0"/>
                 <a:ea typeface="Calibri" pitchFamily="34" charset="-122"/>
@@ -3852,7 +3852,7 @@
             <a:r>
               <a:rPr lang="en-US" sz="2700" b="1" dirty="0">
                 <a:solidFill>
-                  <a:srgbClr val="191970"/>
+                  <a:srgbClr val="1E2B4A"/>
                 </a:solidFill>
                 <a:latin typeface="Calibri" pitchFamily="34" charset="0"/>
                 <a:ea typeface="Calibri" pitchFamily="34" charset="-122"/>
@@ -3928,7 +3928,7 @@
           <a:ln/>
           <a:effectLst>
             <a:outerShdw sx="100000" sy="100000" kx="0" ky="0" algn="bl" rotWithShape="0" blurRad="127000" dist="25400" dir="5400000">
-              <a:srgbClr val="13134F">
+              <a:srgbClr val="1E2B4A">
                 <a:alpha val="10000"/>
               </a:srgbClr>
             </a:outerShdw>
@@ -3950,7 +3950,7 @@
             <a:avLst/>
           </a:prstGeom>
           <a:solidFill>
-            <a:srgbClr val="4444AD"/>
+            <a:srgbClr val="41639E"/>
           </a:solidFill>
           <a:ln w="31750">
             <a:solidFill>
@@ -3960,7 +3960,7 @@
           </a:ln>
           <a:effectLst>
             <a:outerShdw sx="100000" sy="100000" kx="0" ky="0" algn="bl" rotWithShape="0" blurRad="127000" dist="25400" dir="5400000">
-              <a:srgbClr val="13134F">
+              <a:srgbClr val="1E2B4A">
                 <a:alpha val="18000"/>
               </a:srgbClr>
             </a:outerShdw>
@@ -4055,7 +4055,7 @@
           <a:ln/>
           <a:effectLst>
             <a:outerShdw sx="100000" sy="100000" kx="0" ky="0" algn="bl" rotWithShape="0" blurRad="127000" dist="25400" dir="5400000">
-              <a:srgbClr val="13134F">
+              <a:srgbClr val="1E2B4A">
                 <a:alpha val="10000"/>
               </a:srgbClr>
             </a:outerShdw>
@@ -4077,7 +4077,7 @@
             <a:avLst/>
           </a:prstGeom>
           <a:solidFill>
-            <a:srgbClr val="2A2A80"/>
+            <a:srgbClr val="3E8C9A"/>
           </a:solidFill>
           <a:ln w="31750">
             <a:solidFill>
@@ -4087,7 +4087,7 @@
           </a:ln>
           <a:effectLst>
             <a:outerShdw sx="100000" sy="100000" kx="0" ky="0" algn="bl" rotWithShape="0" blurRad="127000" dist="25400" dir="5400000">
-              <a:srgbClr val="13134F">
+              <a:srgbClr val="1E2B4A">
                 <a:alpha val="18000"/>
               </a:srgbClr>
             </a:outerShdw>
@@ -4182,7 +4182,7 @@
           <a:ln/>
           <a:effectLst>
             <a:outerShdw sx="100000" sy="100000" kx="0" ky="0" algn="bl" rotWithShape="0" blurRad="127000" dist="25400" dir="5400000">
-              <a:srgbClr val="13134F">
+              <a:srgbClr val="1E2B4A">
                 <a:alpha val="10000"/>
               </a:srgbClr>
             </a:outerShdw>
@@ -4204,7 +4204,7 @@
             <a:avLst/>
           </a:prstGeom>
           <a:solidFill>
-            <a:srgbClr val="4444AD"/>
+            <a:srgbClr val="41639E"/>
           </a:solidFill>
           <a:ln w="31750">
             <a:solidFill>
@@ -4214,7 +4214,7 @@
           </a:ln>
           <a:effectLst>
             <a:outerShdw sx="100000" sy="100000" kx="0" ky="0" algn="bl" rotWithShape="0" blurRad="127000" dist="25400" dir="5400000">
-              <a:srgbClr val="13134F">
+              <a:srgbClr val="1E2B4A">
                 <a:alpha val="18000"/>
               </a:srgbClr>
             </a:outerShdw>
@@ -4309,7 +4309,7 @@
           <a:ln/>
           <a:effectLst>
             <a:outerShdw sx="100000" sy="100000" kx="0" ky="0" algn="bl" rotWithShape="0" blurRad="127000" dist="25400" dir="5400000">
-              <a:srgbClr val="13134F">
+              <a:srgbClr val="1E2B4A">
                 <a:alpha val="10000"/>
               </a:srgbClr>
             </a:outerShdw>
@@ -4341,7 +4341,7 @@
           </a:ln>
           <a:effectLst>
             <a:outerShdw sx="100000" sy="100000" kx="0" ky="0" algn="bl" rotWithShape="0" blurRad="127000" dist="25400" dir="5400000">
-              <a:srgbClr val="13134F">
+              <a:srgbClr val="1E2B4A">
                 <a:alpha val="18000"/>
               </a:srgbClr>
             </a:outerShdw>
@@ -4436,7 +4436,7 @@
           <a:ln/>
           <a:effectLst>
             <a:outerShdw sx="100000" sy="100000" kx="0" ky="0" algn="bl" rotWithShape="0" blurRad="127000" dist="25400" dir="5400000">
-              <a:srgbClr val="13134F">
+              <a:srgbClr val="1E2B4A">
                 <a:alpha val="10000"/>
               </a:srgbClr>
             </a:outerShdw>
@@ -4458,7 +4458,7 @@
             <a:avLst/>
           </a:prstGeom>
           <a:solidFill>
-            <a:srgbClr val="6E6ECB"/>
+            <a:srgbClr val="C98A24"/>
           </a:solidFill>
           <a:ln w="31750">
             <a:solidFill>
@@ -4468,7 +4468,7 @@
           </a:ln>
           <a:effectLst>
             <a:outerShdw sx="100000" sy="100000" kx="0" ky="0" algn="bl" rotWithShape="0" blurRad="127000" dist="25400" dir="5400000">
-              <a:srgbClr val="13134F">
+              <a:srgbClr val="1E2B4A">
                 <a:alpha val="18000"/>
               </a:srgbClr>
             </a:outerShdw>
@@ -4563,7 +4563,7 @@
           <a:ln/>
           <a:effectLst>
             <a:outerShdw sx="100000" sy="100000" kx="0" ky="0" algn="bl" rotWithShape="0" blurRad="127000" dist="25400" dir="5400000">
-              <a:srgbClr val="13134F">
+              <a:srgbClr val="1E2B4A">
                 <a:alpha val="10000"/>
               </a:srgbClr>
             </a:outerShdw>
@@ -4585,7 +4585,7 @@
             <a:avLst/>
           </a:prstGeom>
           <a:solidFill>
-            <a:srgbClr val="2A2A80"/>
+            <a:srgbClr val="3E8C9A"/>
           </a:solidFill>
           <a:ln w="31750">
             <a:solidFill>
@@ -4595,7 +4595,7 @@
           </a:ln>
           <a:effectLst>
             <a:outerShdw sx="100000" sy="100000" kx="0" ky="0" algn="bl" rotWithShape="0" blurRad="127000" dist="25400" dir="5400000">
-              <a:srgbClr val="13134F">
+              <a:srgbClr val="1E2B4A">
                 <a:alpha val="18000"/>
               </a:srgbClr>
             </a:outerShdw>
@@ -4690,7 +4690,7 @@
           <a:ln/>
           <a:effectLst>
             <a:outerShdw sx="100000" sy="100000" kx="0" ky="0" algn="bl" rotWithShape="0" blurRad="127000" dist="25400" dir="5400000">
-              <a:srgbClr val="13134F">
+              <a:srgbClr val="1E2B4A">
                 <a:alpha val="10000"/>
               </a:srgbClr>
             </a:outerShdw>
@@ -4712,7 +4712,7 @@
             <a:avLst/>
           </a:prstGeom>
           <a:solidFill>
-            <a:srgbClr val="4444AD"/>
+            <a:srgbClr val="41639E"/>
           </a:solidFill>
           <a:ln w="31750">
             <a:solidFill>
@@ -4722,7 +4722,7 @@
           </a:ln>
           <a:effectLst>
             <a:outerShdw sx="100000" sy="100000" kx="0" ky="0" algn="bl" rotWithShape="0" blurRad="127000" dist="25400" dir="5400000">
-              <a:srgbClr val="13134F">
+              <a:srgbClr val="1E2B4A">
                 <a:alpha val="18000"/>
               </a:srgbClr>
             </a:outerShdw>
@@ -4817,7 +4817,7 @@
           <a:ln/>
           <a:effectLst>
             <a:outerShdw sx="100000" sy="100000" kx="0" ky="0" algn="bl" rotWithShape="0" blurRad="127000" dist="25400" dir="5400000">
-              <a:srgbClr val="13134F">
+              <a:srgbClr val="1E2B4A">
                 <a:alpha val="10000"/>
               </a:srgbClr>
             </a:outerShdw>
@@ -4947,7 +4947,7 @@
           <a:ln/>
           <a:effectLst>
             <a:outerShdw sx="100000" sy="100000" kx="0" ky="0" algn="bl" rotWithShape="0" blurRad="127000" dist="25400" dir="5400000">
-              <a:srgbClr val="13134F">
+              <a:srgbClr val="1E2B4A">
                 <a:alpha val="10000"/>
               </a:srgbClr>
             </a:outerShdw>
@@ -5430,7 +5430,7 @@
             <a:r>
               <a:rPr lang="en-US" sz="2700" b="1" dirty="0">
                 <a:solidFill>
-                  <a:srgbClr val="191970"/>
+                  <a:srgbClr val="1E2B4A"/>
                 </a:solidFill>
                 <a:latin typeface="Calibri" pitchFamily="34" charset="0"/>
                 <a:ea typeface="Calibri" pitchFamily="34" charset="-122"/>
@@ -5506,7 +5506,7 @@
           <a:ln/>
           <a:effectLst>
             <a:outerShdw sx="100000" sy="100000" kx="0" ky="0" algn="bl" rotWithShape="0" blurRad="127000" dist="25400" dir="5400000">
-              <a:srgbClr val="13134F">
+              <a:srgbClr val="1E2B4A">
                 <a:alpha val="10000"/>
               </a:srgbClr>
             </a:outerShdw>
@@ -5540,7 +5540,7 @@
             <a:r>
               <a:rPr lang="en-US" sz="3200" b="1" dirty="0">
                 <a:solidFill>
-                  <a:srgbClr val="4444AD"/>
+                  <a:srgbClr val="41639E"/>
                 </a:solidFill>
                 <a:latin typeface="Calibri" pitchFamily="34" charset="0"/>
                 <a:ea typeface="Calibri" pitchFamily="34" charset="-122"/>
@@ -5636,7 +5636,7 @@
           <a:ln/>
           <a:effectLst>
             <a:outerShdw sx="100000" sy="100000" kx="0" ky="0" algn="bl" rotWithShape="0" blurRad="127000" dist="25400" dir="5400000">
-              <a:srgbClr val="13134F">
+              <a:srgbClr val="1E2B4A">
                 <a:alpha val="10000"/>
               </a:srgbClr>
             </a:outerShdw>
@@ -5670,7 +5670,7 @@
             <a:r>
               <a:rPr lang="en-US" sz="3200" b="1" dirty="0">
                 <a:solidFill>
-                  <a:srgbClr val="4444AD"/>
+                  <a:srgbClr val="41639E"/>
                 </a:solidFill>
                 <a:latin typeface="Calibri" pitchFamily="34" charset="0"/>
                 <a:ea typeface="Calibri" pitchFamily="34" charset="-122"/>
@@ -5766,7 +5766,7 @@
           <a:ln/>
           <a:effectLst>
             <a:outerShdw sx="100000" sy="100000" kx="0" ky="0" algn="bl" rotWithShape="0" blurRad="127000" dist="25400" dir="5400000">
-              <a:srgbClr val="13134F">
+              <a:srgbClr val="1E2B4A">
                 <a:alpha val="10000"/>
               </a:srgbClr>
             </a:outerShdw>
@@ -5896,7 +5896,7 @@
           <a:ln/>
           <a:effectLst>
             <a:outerShdw sx="100000" sy="100000" kx="0" ky="0" algn="bl" rotWithShape="0" blurRad="127000" dist="25400" dir="5400000">
-              <a:srgbClr val="13134F">
+              <a:srgbClr val="1E2B4A">
                 <a:alpha val="10000"/>
               </a:srgbClr>
             </a:outerShdw>
@@ -6026,7 +6026,7 @@
           <a:ln/>
           <a:effectLst>
             <a:outerShdw sx="100000" sy="100000" kx="0" ky="0" algn="bl" rotWithShape="0" blurRad="127000" dist="25400" dir="5400000">
-              <a:srgbClr val="13134F">
+              <a:srgbClr val="1E2B4A">
                 <a:alpha val="10000"/>
               </a:srgbClr>
             </a:outerShdw>
@@ -6048,7 +6048,7 @@
             <a:avLst/>
           </a:prstGeom>
           <a:solidFill>
-            <a:srgbClr val="2A2A80"/>
+            <a:srgbClr val="3E8C9A"/>
           </a:solidFill>
           <a:ln w="31750">
             <a:solidFill>
@@ -6058,7 +6058,7 @@
           </a:ln>
           <a:effectLst>
             <a:outerShdw sx="100000" sy="100000" kx="0" ky="0" algn="bl" rotWithShape="0" blurRad="127000" dist="25400" dir="5400000">
-              <a:srgbClr val="13134F">
+              <a:srgbClr val="1E2B4A">
                 <a:alpha val="18000"/>
               </a:srgbClr>
             </a:outerShdw>
@@ -6192,7 +6192,7 @@
           <a:ln/>
           <a:effectLst>
             <a:outerShdw sx="100000" sy="100000" kx="0" ky="0" algn="bl" rotWithShape="0" blurRad="127000" dist="25400" dir="5400000">
-              <a:srgbClr val="13134F">
+              <a:srgbClr val="1E2B4A">
                 <a:alpha val="10000"/>
               </a:srgbClr>
             </a:outerShdw>
@@ -6214,7 +6214,7 @@
             <a:avLst/>
           </a:prstGeom>
           <a:solidFill>
-            <a:srgbClr val="6E6ECB"/>
+            <a:srgbClr val="C98A24"/>
           </a:solidFill>
           <a:ln w="31750">
             <a:solidFill>
@@ -6224,7 +6224,7 @@
           </a:ln>
           <a:effectLst>
             <a:outerShdw sx="100000" sy="100000" kx="0" ky="0" algn="bl" rotWithShape="0" blurRad="127000" dist="25400" dir="5400000">
-              <a:srgbClr val="13134F">
+              <a:srgbClr val="1E2B4A">
                 <a:alpha val="18000"/>
               </a:srgbClr>
             </a:outerShdw>
@@ -6350,7 +6350,7 @@
             </a:avLst>
           </a:prstGeom>
           <a:solidFill>
-            <a:srgbClr val="6E6ECB"/>
+            <a:srgbClr val="C98A24"/>
           </a:solidFill>
           <a:ln/>
         </p:spPr>
@@ -6450,7 +6450,7 @@
             </a:avLst>
           </a:prstGeom>
           <a:solidFill>
-            <a:srgbClr val="E2E3EC"/>
+            <a:srgbClr val="E3E7EE"/>
           </a:solidFill>
           <a:ln/>
         </p:spPr>
@@ -6550,7 +6550,7 @@
             </a:avLst>
           </a:prstGeom>
           <a:solidFill>
-            <a:srgbClr val="E2E3EC"/>
+            <a:srgbClr val="E3E7EE"/>
           </a:solidFill>
           <a:ln/>
         </p:spPr>
@@ -6650,7 +6650,7 @@
             </a:avLst>
           </a:prstGeom>
           <a:solidFill>
-            <a:srgbClr val="E2E3EC"/>
+            <a:srgbClr val="E3E7EE"/>
           </a:solidFill>
           <a:ln/>
         </p:spPr>
@@ -6855,7 +6855,7 @@
             <a:r>
               <a:rPr lang="en-US" sz="2700" b="1" dirty="0">
                 <a:solidFill>
-                  <a:srgbClr val="191970"/>
+                  <a:srgbClr val="1E2B4A"/>
                 </a:solidFill>
                 <a:latin typeface="Calibri" pitchFamily="34" charset="0"/>
                 <a:ea typeface="Calibri" pitchFamily="34" charset="-122"/>
@@ -6931,7 +6931,7 @@
           <a:ln/>
           <a:effectLst>
             <a:outerShdw sx="100000" sy="100000" kx="0" ky="0" algn="bl" rotWithShape="0" blurRad="127000" dist="25400" dir="5400000">
-              <a:srgbClr val="13134F">
+              <a:srgbClr val="1E2B4A">
                 <a:alpha val="10000"/>
               </a:srgbClr>
             </a:outerShdw>
@@ -6953,7 +6953,7 @@
             <a:avLst/>
           </a:prstGeom>
           <a:solidFill>
-            <a:srgbClr val="4444AD"/>
+            <a:srgbClr val="41639E"/>
           </a:solidFill>
           <a:ln w="31750">
             <a:solidFill>
@@ -6963,7 +6963,7 @@
           </a:ln>
           <a:effectLst>
             <a:outerShdw sx="100000" sy="100000" kx="0" ky="0" algn="bl" rotWithShape="0" blurRad="127000" dist="25400" dir="5400000">
-              <a:srgbClr val="13134F">
+              <a:srgbClr val="1E2B4A">
                 <a:alpha val="18000"/>
               </a:srgbClr>
             </a:outerShdw>
@@ -7021,7 +7021,7 @@
             <a:r>
               <a:rPr lang="en-US" sz="3400" b="1" dirty="0">
                 <a:solidFill>
-                  <a:srgbClr val="E2E3EC"/>
+                  <a:srgbClr val="E3E7EE"/>
                 </a:solidFill>
                 <a:latin typeface="Calibri" pitchFamily="34" charset="0"/>
                 <a:ea typeface="Calibri" pitchFamily="34" charset="-122"/>
@@ -7136,7 +7136,7 @@
           <a:ln/>
           <a:effectLst>
             <a:outerShdw sx="100000" sy="100000" kx="0" ky="0" algn="bl" rotWithShape="0" blurRad="127000" dist="25400" dir="5400000">
-              <a:srgbClr val="13134F">
+              <a:srgbClr val="1E2B4A">
                 <a:alpha val="10000"/>
               </a:srgbClr>
             </a:outerShdw>
@@ -7158,7 +7158,7 @@
             <a:avLst/>
           </a:prstGeom>
           <a:solidFill>
-            <a:srgbClr val="2A2A80"/>
+            <a:srgbClr val="3E8C9A"/>
           </a:solidFill>
           <a:ln w="31750">
             <a:solidFill>
@@ -7168,7 +7168,7 @@
           </a:ln>
           <a:effectLst>
             <a:outerShdw sx="100000" sy="100000" kx="0" ky="0" algn="bl" rotWithShape="0" blurRad="127000" dist="25400" dir="5400000">
-              <a:srgbClr val="13134F">
+              <a:srgbClr val="1E2B4A">
                 <a:alpha val="18000"/>
               </a:srgbClr>
             </a:outerShdw>
@@ -7226,7 +7226,7 @@
             <a:r>
               <a:rPr lang="en-US" sz="3400" b="1" dirty="0">
                 <a:solidFill>
-                  <a:srgbClr val="E2E3EC"/>
+                  <a:srgbClr val="E3E7EE"/>
                 </a:solidFill>
                 <a:latin typeface="Calibri" pitchFamily="34" charset="0"/>
                 <a:ea typeface="Calibri" pitchFamily="34" charset="-122"/>
@@ -7341,7 +7341,7 @@
           <a:ln/>
           <a:effectLst>
             <a:outerShdw sx="100000" sy="100000" kx="0" ky="0" algn="bl" rotWithShape="0" blurRad="127000" dist="25400" dir="5400000">
-              <a:srgbClr val="13134F">
+              <a:srgbClr val="1E2B4A">
                 <a:alpha val="10000"/>
               </a:srgbClr>
             </a:outerShdw>
@@ -7373,7 +7373,7 @@
           </a:ln>
           <a:effectLst>
             <a:outerShdw sx="100000" sy="100000" kx="0" ky="0" algn="bl" rotWithShape="0" blurRad="127000" dist="25400" dir="5400000">
-              <a:srgbClr val="13134F">
+              <a:srgbClr val="1E2B4A">
                 <a:alpha val="18000"/>
               </a:srgbClr>
             </a:outerShdw>
@@ -7431,7 +7431,7 @@
             <a:r>
               <a:rPr lang="en-US" sz="3400" b="1" dirty="0">
                 <a:solidFill>
-                  <a:srgbClr val="E2E3EC"/>
+                  <a:srgbClr val="E3E7EE"/>
                 </a:solidFill>
                 <a:latin typeface="Calibri" pitchFamily="34" charset="0"/>
                 <a:ea typeface="Calibri" pitchFamily="34" charset="-122"/>
@@ -7541,12 +7541,12 @@
             </a:avLst>
           </a:prstGeom>
           <a:solidFill>
-            <a:srgbClr val="191970"/>
+            <a:srgbClr val="1E2B4A"/>
           </a:solidFill>
           <a:ln/>
           <a:effectLst>
             <a:outerShdw sx="100000" sy="100000" kx="0" ky="0" algn="bl" rotWithShape="0" blurRad="127000" dist="25400" dir="5400000">
-              <a:srgbClr val="13134F">
+              <a:srgbClr val="1E2B4A">
                 <a:alpha val="10000"/>
               </a:srgbClr>
             </a:outerShdw>
@@ -7672,7 +7672,7 @@
     <p:bg>
       <p:bgPr>
         <a:solidFill>
-          <a:srgbClr val="101038"/>
+          <a:srgbClr val="16213D"/>
         </a:solidFill>
       </p:bgPr>
     </p:bg>
@@ -7705,7 +7705,7 @@
             <a:avLst/>
           </a:prstGeom>
           <a:solidFill>
-            <a:srgbClr val="23236B"/>
+            <a:srgbClr val="24365E"/>
           </a:solidFill>
           <a:ln/>
         </p:spPr>
@@ -7725,7 +7725,7 @@
             <a:avLst/>
           </a:prstGeom>
           <a:solidFill>
-            <a:srgbClr val="23236B"/>
+            <a:srgbClr val="24365E"/>
           </a:solidFill>
           <a:ln/>
         </p:spPr>
@@ -7838,7 +7838,7 @@
             <a:r>
               <a:rPr lang="en-US" sz="1400" dirty="0">
                 <a:solidFill>
-                  <a:srgbClr val="B7B7DB"/>
+                  <a:srgbClr val="AFC0DA"/>
                 </a:solidFill>
                 <a:latin typeface="Calibri" pitchFamily="34" charset="0"/>
                 <a:ea typeface="Calibri" pitchFamily="34" charset="-122"/>
@@ -7909,7 +7909,7 @@
             <a:r>
               <a:rPr lang="en-US" sz="2700" b="1" dirty="0">
                 <a:solidFill>
-                  <a:srgbClr val="191970"/>
+                  <a:srgbClr val="1E2B4A"/>
                 </a:solidFill>
                 <a:latin typeface="Calibri" pitchFamily="34" charset="0"/>
                 <a:ea typeface="Calibri" pitchFamily="34" charset="-122"/>
@@ -7985,7 +7985,7 @@
           <a:ln/>
           <a:effectLst>
             <a:outerShdw sx="100000" sy="100000" kx="0" ky="0" algn="bl" rotWithShape="0" blurRad="127000" dist="25400" dir="5400000">
-              <a:srgbClr val="13134F">
+              <a:srgbClr val="1E2B4A">
                 <a:alpha val="10000"/>
               </a:srgbClr>
             </a:outerShdw>
@@ -8191,7 +8191,7 @@
             <a:avLst/>
           </a:prstGeom>
           <a:solidFill>
-            <a:srgbClr val="E2E3EC"/>
+            <a:srgbClr val="E3E7EE"/>
           </a:solidFill>
           <a:ln/>
         </p:spPr>
@@ -8262,7 +8262,7 @@
             <a:r>
               <a:rPr lang="en-US" sz="1500" b="1" dirty="0">
                 <a:solidFill>
-                  <a:srgbClr val="191970"/>
+                  <a:srgbClr val="1E2B4A"/>
                 </a:solidFill>
                 <a:latin typeface="Calibri" pitchFamily="34" charset="0"/>
                 <a:ea typeface="Calibri" pitchFamily="34" charset="-122"/>
@@ -8301,7 +8301,7 @@
             <a:r>
               <a:rPr lang="en-US" sz="1500" b="1" dirty="0">
                 <a:solidFill>
-                  <a:srgbClr val="191970"/>
+                  <a:srgbClr val="1E2B4A"/>
                 </a:solidFill>
                 <a:latin typeface="Calibri" pitchFamily="34" charset="0"/>
                 <a:ea typeface="Calibri" pitchFamily="34" charset="-122"/>
@@ -8367,7 +8367,7 @@
             <a:avLst/>
           </a:prstGeom>
           <a:solidFill>
-            <a:srgbClr val="E2E3EC"/>
+            <a:srgbClr val="E3E7EE"/>
           </a:solidFill>
           <a:ln/>
         </p:spPr>
@@ -8438,7 +8438,7 @@
             <a:r>
               <a:rPr lang="en-US" sz="1500" b="1" dirty="0">
                 <a:solidFill>
-                  <a:srgbClr val="191970"/>
+                  <a:srgbClr val="1E2B4A"/>
                 </a:solidFill>
                 <a:latin typeface="Calibri" pitchFamily="34" charset="0"/>
                 <a:ea typeface="Calibri" pitchFamily="34" charset="-122"/>
@@ -8477,7 +8477,7 @@
             <a:r>
               <a:rPr lang="en-US" sz="1500" b="1" dirty="0">
                 <a:solidFill>
-                  <a:srgbClr val="191970"/>
+                  <a:srgbClr val="1E2B4A"/>
                 </a:solidFill>
                 <a:latin typeface="Calibri" pitchFamily="34" charset="0"/>
                 <a:ea typeface="Calibri" pitchFamily="34" charset="-122"/>
@@ -8543,7 +8543,7 @@
             <a:avLst/>
           </a:prstGeom>
           <a:solidFill>
-            <a:srgbClr val="E2E3EC"/>
+            <a:srgbClr val="E3E7EE"/>
           </a:solidFill>
           <a:ln/>
         </p:spPr>
@@ -8614,7 +8614,7 @@
             <a:r>
               <a:rPr lang="en-US" sz="1500" b="1" dirty="0">
                 <a:solidFill>
-                  <a:srgbClr val="191970"/>
+                  <a:srgbClr val="1E2B4A"/>
                 </a:solidFill>
                 <a:latin typeface="Calibri" pitchFamily="34" charset="0"/>
                 <a:ea typeface="Calibri" pitchFamily="34" charset="-122"/>
@@ -8653,7 +8653,7 @@
             <a:r>
               <a:rPr lang="en-US" sz="1500" b="1" dirty="0">
                 <a:solidFill>
-                  <a:srgbClr val="191970"/>
+                  <a:srgbClr val="1E2B4A"/>
                 </a:solidFill>
                 <a:latin typeface="Calibri" pitchFamily="34" charset="0"/>
                 <a:ea typeface="Calibri" pitchFamily="34" charset="-122"/>
@@ -8768,7 +8768,7 @@
           <a:ln/>
           <a:effectLst>
             <a:outerShdw sx="100000" sy="100000" kx="0" ky="0" algn="bl" rotWithShape="0" blurRad="127000" dist="25400" dir="5400000">
-              <a:srgbClr val="13134F">
+              <a:srgbClr val="1E2B4A">
                 <a:alpha val="10000"/>
               </a:srgbClr>
             </a:outerShdw>
@@ -8909,7 +8909,7 @@
             </a:avLst>
           </a:prstGeom>
           <a:solidFill>
-            <a:srgbClr val="4444AD"/>
+            <a:srgbClr val="41639E"/>
           </a:solidFill>
           <a:ln/>
         </p:spPr>
@@ -9009,7 +9009,7 @@
             </a:avLst>
           </a:prstGeom>
           <a:solidFill>
-            <a:srgbClr val="4444AD"/>
+            <a:srgbClr val="41639E"/>
           </a:solidFill>
           <a:ln/>
         </p:spPr>
@@ -9495,7 +9495,7 @@
             <a:r>
               <a:rPr lang="en-US" sz="2700" b="1" dirty="0">
                 <a:solidFill>
-                  <a:srgbClr val="191970"/>
+                  <a:srgbClr val="1E2B4A"/>
                 </a:solidFill>
                 <a:latin typeface="Calibri" pitchFamily="34" charset="0"/>
                 <a:ea typeface="Calibri" pitchFamily="34" charset="-122"/>
@@ -9571,7 +9571,7 @@
           <a:ln/>
           <a:effectLst>
             <a:outerShdw sx="100000" sy="100000" kx="0" ky="0" algn="bl" rotWithShape="0" blurRad="127000" dist="25400" dir="5400000">
-              <a:srgbClr val="13134F">
+              <a:srgbClr val="1E2B4A">
                 <a:alpha val="10000"/>
               </a:srgbClr>
             </a:outerShdw>
@@ -9701,7 +9701,7 @@
           <a:ln/>
           <a:effectLst>
             <a:outerShdw sx="100000" sy="100000" kx="0" ky="0" algn="bl" rotWithShape="0" blurRad="127000" dist="25400" dir="5400000">
-              <a:srgbClr val="13134F">
+              <a:srgbClr val="1E2B4A">
                 <a:alpha val="10000"/>
               </a:srgbClr>
             </a:outerShdw>
@@ -9735,7 +9735,7 @@
             <a:r>
               <a:rPr lang="en-US" sz="3000" b="1" dirty="0">
                 <a:solidFill>
-                  <a:srgbClr val="2A2A80"/>
+                  <a:srgbClr val="3E8C9A"/>
                 </a:solidFill>
                 <a:latin typeface="Calibri" pitchFamily="34" charset="0"/>
                 <a:ea typeface="Calibri" pitchFamily="34" charset="-122"/>
@@ -9831,7 +9831,7 @@
           <a:ln/>
           <a:effectLst>
             <a:outerShdw sx="100000" sy="100000" kx="0" ky="0" algn="bl" rotWithShape="0" blurRad="127000" dist="25400" dir="5400000">
-              <a:srgbClr val="13134F">
+              <a:srgbClr val="1E2B4A">
                 <a:alpha val="10000"/>
               </a:srgbClr>
             </a:outerShdw>
@@ -9865,7 +9865,7 @@
             <a:r>
               <a:rPr lang="en-US" sz="3000" b="1" dirty="0">
                 <a:solidFill>
-                  <a:srgbClr val="4444AD"/>
+                  <a:srgbClr val="41639E"/>
                 </a:solidFill>
                 <a:latin typeface="Calibri" pitchFamily="34" charset="0"/>
                 <a:ea typeface="Calibri" pitchFamily="34" charset="-122"/>
@@ -9961,7 +9961,7 @@
           <a:ln/>
           <a:effectLst>
             <a:outerShdw sx="100000" sy="100000" kx="0" ky="0" algn="bl" rotWithShape="0" blurRad="127000" dist="25400" dir="5400000">
-              <a:srgbClr val="13134F">
+              <a:srgbClr val="1E2B4A">
                 <a:alpha val="10000"/>
               </a:srgbClr>
             </a:outerShdw>
@@ -9995,7 +9995,7 @@
             <a:r>
               <a:rPr lang="en-US" sz="3000" b="1" dirty="0">
                 <a:solidFill>
-                  <a:srgbClr val="4444AD"/>
+                  <a:srgbClr val="41639E"/>
                 </a:solidFill>
                 <a:latin typeface="Calibri" pitchFamily="34" charset="0"/>
                 <a:ea typeface="Calibri" pitchFamily="34" charset="-122"/>
@@ -10091,7 +10091,7 @@
           <a:ln/>
           <a:effectLst>
             <a:outerShdw sx="100000" sy="100000" kx="0" ky="0" algn="bl" rotWithShape="0" blurRad="127000" dist="25400" dir="5400000">
-              <a:srgbClr val="13134F">
+              <a:srgbClr val="1E2B4A">
                 <a:alpha val="10000"/>
               </a:srgbClr>
             </a:outerShdw>
@@ -10193,7 +10193,7 @@
             </a:avLst>
           </a:prstGeom>
           <a:solidFill>
-            <a:srgbClr val="E2E3EC"/>
+            <a:srgbClr val="E3E7EE"/>
           </a:solidFill>
           <a:ln/>
         </p:spPr>
@@ -10215,7 +10215,7 @@
             </a:avLst>
           </a:prstGeom>
           <a:solidFill>
-            <a:srgbClr val="2A2A80"/>
+            <a:srgbClr val="3E8C9A"/>
           </a:solidFill>
           <a:ln/>
         </p:spPr>
@@ -10315,7 +10315,7 @@
             </a:avLst>
           </a:prstGeom>
           <a:solidFill>
-            <a:srgbClr val="E2E3EC"/>
+            <a:srgbClr val="E3E7EE"/>
           </a:solidFill>
           <a:ln/>
         </p:spPr>
@@ -10337,7 +10337,7 @@
             </a:avLst>
           </a:prstGeom>
           <a:solidFill>
-            <a:srgbClr val="2A2A80"/>
+            <a:srgbClr val="3E8C9A"/>
           </a:solidFill>
           <a:ln/>
         </p:spPr>
@@ -10437,7 +10437,7 @@
             </a:avLst>
           </a:prstGeom>
           <a:solidFill>
-            <a:srgbClr val="E2E3EC"/>
+            <a:srgbClr val="E3E7EE"/>
           </a:solidFill>
           <a:ln/>
         </p:spPr>
@@ -10459,7 +10459,7 @@
             </a:avLst>
           </a:prstGeom>
           <a:solidFill>
-            <a:srgbClr val="2A2A80"/>
+            <a:srgbClr val="3E8C9A"/>
           </a:solidFill>
           <a:ln/>
         </p:spPr>
@@ -10559,7 +10559,7 @@
             </a:avLst>
           </a:prstGeom>
           <a:solidFill>
-            <a:srgbClr val="E2E3EC"/>
+            <a:srgbClr val="E3E7EE"/>
           </a:solidFill>
           <a:ln/>
         </p:spPr>
@@ -10581,7 +10581,7 @@
             </a:avLst>
           </a:prstGeom>
           <a:solidFill>
-            <a:srgbClr val="2A2A80"/>
+            <a:srgbClr val="3E8C9A"/>
           </a:solidFill>
           <a:ln/>
         </p:spPr>
@@ -10681,7 +10681,7 @@
             </a:avLst>
           </a:prstGeom>
           <a:solidFill>
-            <a:srgbClr val="E2E3EC"/>
+            <a:srgbClr val="E3E7EE"/>
           </a:solidFill>
           <a:ln/>
         </p:spPr>
@@ -10703,7 +10703,7 @@
             </a:avLst>
           </a:prstGeom>
           <a:solidFill>
-            <a:srgbClr val="2A2A80"/>
+            <a:srgbClr val="3E8C9A"/>
           </a:solidFill>
           <a:ln/>
         </p:spPr>
@@ -10803,7 +10803,7 @@
             </a:avLst>
           </a:prstGeom>
           <a:solidFill>
-            <a:srgbClr val="E2E3EC"/>
+            <a:srgbClr val="E3E7EE"/>
           </a:solidFill>
           <a:ln/>
         </p:spPr>
@@ -10825,7 +10825,7 @@
             </a:avLst>
           </a:prstGeom>
           <a:solidFill>
-            <a:srgbClr val="2A2A80"/>
+            <a:srgbClr val="3E8C9A"/>
           </a:solidFill>
           <a:ln/>
         </p:spPr>
@@ -11030,7 +11030,7 @@
             <a:r>
               <a:rPr lang="en-US" sz="2700" b="1" dirty="0">
                 <a:solidFill>
-                  <a:srgbClr val="191970"/>
+                  <a:srgbClr val="1E2B4A"/>
                 </a:solidFill>
                 <a:latin typeface="Calibri" pitchFamily="34" charset="0"/>
                 <a:ea typeface="Calibri" pitchFamily="34" charset="-122"/>
@@ -11059,12 +11059,12 @@
             </a:avLst>
           </a:prstGeom>
           <a:solidFill>
-            <a:srgbClr val="191970"/>
+            <a:srgbClr val="1E2B4A"/>
           </a:solidFill>
           <a:ln/>
           <a:effectLst>
             <a:outerShdw sx="100000" sy="100000" kx="0" ky="0" algn="bl" rotWithShape="0" blurRad="127000" dist="25400" dir="5400000">
-              <a:srgbClr val="13134F">
+              <a:srgbClr val="1E2B4A">
                 <a:alpha val="10000"/>
               </a:srgbClr>
             </a:outerShdw>
@@ -11252,7 +11252,7 @@
           <a:ln/>
           <a:effectLst>
             <a:outerShdw sx="100000" sy="100000" kx="0" ky="0" algn="bl" rotWithShape="0" blurRad="127000" dist="25400" dir="5400000">
-              <a:srgbClr val="13134F">
+              <a:srgbClr val="1E2B4A">
                 <a:alpha val="10000"/>
               </a:srgbClr>
             </a:outerShdw>
@@ -11418,7 +11418,7 @@
             </a:avLst>
           </a:prstGeom>
           <a:solidFill>
-            <a:srgbClr val="4444AD"/>
+            <a:srgbClr val="41639E"/>
           </a:solidFill>
           <a:ln/>
         </p:spPr>
@@ -11605,7 +11605,7 @@
           <a:ln/>
           <a:effectLst>
             <a:outerShdw sx="100000" sy="100000" kx="0" ky="0" algn="bl" rotWithShape="0" blurRad="127000" dist="25400" dir="5400000">
-              <a:srgbClr val="13134F">
+              <a:srgbClr val="1E2B4A">
                 <a:alpha val="10000"/>
               </a:srgbClr>
             </a:outerShdw>
@@ -11720,7 +11720,7 @@
             <a:r>
               <a:rPr lang="en-US" sz="1500" b="1" dirty="0">
                 <a:solidFill>
-                  <a:srgbClr val="191970"/>
+                  <a:srgbClr val="1E2B4A"/>
                 </a:solidFill>
                 <a:latin typeface="Calibri" pitchFamily="34" charset="0"/>
                 <a:ea typeface="Calibri" pitchFamily="34" charset="-122"/>
@@ -11747,7 +11747,7 @@
             <a:avLst/>
           </a:prstGeom>
           <a:solidFill>
-            <a:srgbClr val="E2E3EC"/>
+            <a:srgbClr val="E3E7EE"/>
           </a:solidFill>
           <a:ln/>
         </p:spPr>
@@ -11821,7 +11821,7 @@
             <a:r>
               <a:rPr lang="en-US" sz="1500" b="1" dirty="0">
                 <a:solidFill>
-                  <a:srgbClr val="191970"/>
+                  <a:srgbClr val="1E2B4A"/>
                 </a:solidFill>
                 <a:latin typeface="Calibri" pitchFamily="34" charset="0"/>
                 <a:ea typeface="Calibri" pitchFamily="34" charset="-122"/>
@@ -11848,7 +11848,7 @@
             <a:avLst/>
           </a:prstGeom>
           <a:solidFill>
-            <a:srgbClr val="E2E3EC"/>
+            <a:srgbClr val="E3E7EE"/>
           </a:solidFill>
           <a:ln/>
         </p:spPr>
@@ -11922,7 +11922,7 @@
             <a:r>
               <a:rPr lang="en-US" sz="1500" b="1" dirty="0">
                 <a:solidFill>
-                  <a:srgbClr val="191970"/>
+                  <a:srgbClr val="1E2B4A"/>
                 </a:solidFill>
                 <a:latin typeface="Calibri" pitchFamily="34" charset="0"/>
                 <a:ea typeface="Calibri" pitchFamily="34" charset="-122"/>
@@ -11949,7 +11949,7 @@
             <a:avLst/>
           </a:prstGeom>
           <a:solidFill>
-            <a:srgbClr val="E2E3EC"/>
+            <a:srgbClr val="E3E7EE"/>
           </a:solidFill>
           <a:ln/>
         </p:spPr>
@@ -12050,7 +12050,7 @@
             <a:avLst/>
           </a:prstGeom>
           <a:solidFill>
-            <a:srgbClr val="E2E3EC"/>
+            <a:srgbClr val="E3E7EE"/>
           </a:solidFill>
           <a:ln/>
         </p:spPr>
@@ -12258,7 +12258,7 @@
             <a:r>
               <a:rPr lang="en-US" sz="2700" b="1" dirty="0">
                 <a:solidFill>
-                  <a:srgbClr val="191970"/>
+                  <a:srgbClr val="1E2B4A"/>
                 </a:solidFill>
                 <a:latin typeface="Calibri" pitchFamily="34" charset="0"/>
                 <a:ea typeface="Calibri" pitchFamily="34" charset="-122"/>
@@ -12334,7 +12334,7 @@
           <a:ln/>
           <a:effectLst>
             <a:outerShdw sx="100000" sy="100000" kx="0" ky="0" algn="bl" rotWithShape="0" blurRad="127000" dist="25400" dir="5400000">
-              <a:srgbClr val="13134F">
+              <a:srgbClr val="1E2B4A">
                 <a:alpha val="10000"/>
               </a:srgbClr>
             </a:outerShdw>
@@ -12575,7 +12575,7 @@
             </a:avLst>
           </a:prstGeom>
           <a:solidFill>
-            <a:srgbClr val="E2E3EC"/>
+            <a:srgbClr val="E3E7EE"/>
           </a:solidFill>
           <a:ln/>
         </p:spPr>
@@ -12675,7 +12675,7 @@
             </a:avLst>
           </a:prstGeom>
           <a:solidFill>
-            <a:srgbClr val="E2E3EC"/>
+            <a:srgbClr val="E3E7EE"/>
           </a:solidFill>
           <a:ln/>
         </p:spPr>
@@ -12775,7 +12775,7 @@
             </a:avLst>
           </a:prstGeom>
           <a:solidFill>
-            <a:srgbClr val="E2E3EC"/>
+            <a:srgbClr val="E3E7EE"/>
           </a:solidFill>
           <a:ln/>
         </p:spPr>
@@ -12875,7 +12875,7 @@
             </a:avLst>
           </a:prstGeom>
           <a:solidFill>
-            <a:srgbClr val="E2E3EC"/>
+            <a:srgbClr val="E3E7EE"/>
           </a:solidFill>
           <a:ln/>
         </p:spPr>
@@ -12975,7 +12975,7 @@
             </a:avLst>
           </a:prstGeom>
           <a:solidFill>
-            <a:srgbClr val="E2E3EC"/>
+            <a:srgbClr val="E3E7EE"/>
           </a:solidFill>
           <a:ln/>
         </p:spPr>
@@ -13075,7 +13075,7 @@
             </a:avLst>
           </a:prstGeom>
           <a:solidFill>
-            <a:srgbClr val="E2E3EC"/>
+            <a:srgbClr val="E3E7EE"/>
           </a:solidFill>
           <a:ln/>
         </p:spPr>
@@ -13141,7 +13141,7 @@
           <a:ln/>
           <a:effectLst>
             <a:outerShdw sx="100000" sy="100000" kx="0" ky="0" algn="bl" rotWithShape="0" blurRad="127000" dist="25400" dir="5400000">
-              <a:srgbClr val="13134F">
+              <a:srgbClr val="1E2B4A">
                 <a:alpha val="10000"/>
               </a:srgbClr>
             </a:outerShdw>
@@ -13173,7 +13173,7 @@
           </a:ln>
           <a:effectLst>
             <a:outerShdw sx="100000" sy="100000" kx="0" ky="0" algn="bl" rotWithShape="0" blurRad="127000" dist="25400" dir="5400000">
-              <a:srgbClr val="13134F">
+              <a:srgbClr val="1E2B4A">
                 <a:alpha val="18000"/>
               </a:srgbClr>
             </a:outerShdw>
@@ -13310,7 +13310,7 @@
           <a:ln/>
           <a:effectLst>
             <a:outerShdw sx="100000" sy="100000" kx="0" ky="0" algn="bl" rotWithShape="0" blurRad="127000" dist="25400" dir="5400000">
-              <a:srgbClr val="13134F">
+              <a:srgbClr val="1E2B4A">
                 <a:alpha val="10000"/>
               </a:srgbClr>
             </a:outerShdw>
@@ -13790,7 +13790,7 @@
             <a:r>
               <a:rPr lang="en-US" sz="2700" b="1" dirty="0">
                 <a:solidFill>
-                  <a:srgbClr val="191970"/>
+                  <a:srgbClr val="1E2B4A"/>
                 </a:solidFill>
                 <a:latin typeface="Calibri" pitchFamily="34" charset="0"/>
                 <a:ea typeface="Calibri" pitchFamily="34" charset="-122"/>
@@ -13866,7 +13866,7 @@
           <a:ln/>
           <a:effectLst>
             <a:outerShdw sx="100000" sy="100000" kx="0" ky="0" algn="bl" rotWithShape="0" blurRad="127000" dist="25400" dir="5400000">
-              <a:srgbClr val="13134F">
+              <a:srgbClr val="1E2B4A">
                 <a:alpha val="10000"/>
               </a:srgbClr>
             </a:outerShdw>
@@ -14363,7 +14363,7 @@
             </a:avLst>
           </a:prstGeom>
           <a:solidFill>
-            <a:srgbClr val="E2E3EC"/>
+            <a:srgbClr val="E3E7EE"/>
           </a:solidFill>
           <a:ln/>
         </p:spPr>
@@ -14502,7 +14502,7 @@
             </a:avLst>
           </a:prstGeom>
           <a:solidFill>
-            <a:srgbClr val="E2E3EC"/>
+            <a:srgbClr val="E3E7EE"/>
           </a:solidFill>
           <a:ln/>
         </p:spPr>
@@ -14641,7 +14641,7 @@
             </a:avLst>
           </a:prstGeom>
           <a:solidFill>
-            <a:srgbClr val="E2E3EC"/>
+            <a:srgbClr val="E3E7EE"/>
           </a:solidFill>
           <a:ln/>
         </p:spPr>
@@ -14722,12 +14722,12 @@
             </a:avLst>
           </a:prstGeom>
           <a:solidFill>
-            <a:srgbClr val="191970"/>
+            <a:srgbClr val="1E2B4A"/>
           </a:solidFill>
           <a:ln/>
           <a:effectLst>
             <a:outerShdw sx="100000" sy="100000" kx="0" ky="0" algn="bl" rotWithShape="0" blurRad="127000" dist="25400" dir="5400000">
-              <a:srgbClr val="13134F">
+              <a:srgbClr val="1E2B4A">
                 <a:alpha val="10000"/>
               </a:srgbClr>
             </a:outerShdw>
@@ -14876,7 +14876,7 @@
           <a:ln/>
           <a:effectLst>
             <a:outerShdw sx="100000" sy="100000" kx="0" ky="0" algn="bl" rotWithShape="0" blurRad="127000" dist="25400" dir="5400000">
-              <a:srgbClr val="13134F">
+              <a:srgbClr val="1E2B4A">
                 <a:alpha val="10000"/>
               </a:srgbClr>
             </a:outerShdw>
@@ -15080,7 +15080,7 @@
     <p:bg>
       <p:bgPr>
         <a:solidFill>
-          <a:srgbClr val="101038"/>
+          <a:srgbClr val="16213D"/>
         </a:solidFill>
       </p:bgPr>
     </p:bg>
@@ -15113,7 +15113,7 @@
             <a:avLst/>
           </a:prstGeom>
           <a:solidFill>
-            <a:srgbClr val="23236B"/>
+            <a:srgbClr val="24365E"/>
           </a:solidFill>
           <a:ln/>
         </p:spPr>
@@ -15133,7 +15133,7 @@
             <a:avLst/>
           </a:prstGeom>
           <a:solidFill>
-            <a:srgbClr val="23236B"/>
+            <a:srgbClr val="24365E"/>
           </a:solidFill>
           <a:ln/>
         </p:spPr>
@@ -15246,7 +15246,7 @@
             <a:r>
               <a:rPr lang="en-US" sz="1400" dirty="0">
                 <a:solidFill>
-                  <a:srgbClr val="B7B7DB"/>
+                  <a:srgbClr val="AFC0DA"/>
                 </a:solidFill>
                 <a:latin typeface="Calibri" pitchFamily="34" charset="0"/>
                 <a:ea typeface="Calibri" pitchFamily="34" charset="-122"/>
@@ -15317,7 +15317,7 @@
             <a:r>
               <a:rPr lang="en-US" sz="2700" b="1" dirty="0">
                 <a:solidFill>
-                  <a:srgbClr val="191970"/>
+                  <a:srgbClr val="1E2B4A"/>
                 </a:solidFill>
                 <a:latin typeface="Calibri" pitchFamily="34" charset="0"/>
                 <a:ea typeface="Calibri" pitchFamily="34" charset="-122"/>
@@ -15351,7 +15351,7 @@
           <a:ln/>
           <a:effectLst>
             <a:outerShdw sx="100000" sy="100000" kx="0" ky="0" algn="bl" rotWithShape="0" blurRad="127000" dist="25400" dir="5400000">
-              <a:srgbClr val="13134F">
+              <a:srgbClr val="1E2B4A">
                 <a:alpha val="10000"/>
               </a:srgbClr>
             </a:outerShdw>
@@ -15373,7 +15373,7 @@
             <a:avLst/>
           </a:prstGeom>
           <a:solidFill>
-            <a:srgbClr val="4444AD"/>
+            <a:srgbClr val="41639E"/>
           </a:solidFill>
           <a:ln w="31750">
             <a:solidFill>
@@ -15383,7 +15383,7 @@
           </a:ln>
           <a:effectLst>
             <a:outerShdw sx="100000" sy="100000" kx="0" ky="0" algn="bl" rotWithShape="0" blurRad="127000" dist="25400" dir="5400000">
-              <a:srgbClr val="13134F">
+              <a:srgbClr val="1E2B4A">
                 <a:alpha val="18000"/>
               </a:srgbClr>
             </a:outerShdw>
@@ -15441,7 +15441,7 @@
             <a:r>
               <a:rPr lang="en-US" sz="3000" b="1" dirty="0">
                 <a:solidFill>
-                  <a:srgbClr val="E2E3EC"/>
+                  <a:srgbClr val="E3E7EE"/>
                 </a:solidFill>
                 <a:latin typeface="Calibri" pitchFamily="34" charset="0"/>
                 <a:ea typeface="Calibri" pitchFamily="34" charset="-122"/>
@@ -15553,7 +15553,7 @@
           <a:ln/>
           <a:effectLst>
             <a:outerShdw sx="100000" sy="100000" kx="0" ky="0" algn="bl" rotWithShape="0" blurRad="127000" dist="25400" dir="5400000">
-              <a:srgbClr val="13134F">
+              <a:srgbClr val="1E2B4A">
                 <a:alpha val="10000"/>
               </a:srgbClr>
             </a:outerShdw>
@@ -15585,7 +15585,7 @@
           </a:ln>
           <a:effectLst>
             <a:outerShdw sx="100000" sy="100000" kx="0" ky="0" algn="bl" rotWithShape="0" blurRad="127000" dist="25400" dir="5400000">
-              <a:srgbClr val="13134F">
+              <a:srgbClr val="1E2B4A">
                 <a:alpha val="18000"/>
               </a:srgbClr>
             </a:outerShdw>
@@ -15643,7 +15643,7 @@
             <a:r>
               <a:rPr lang="en-US" sz="3000" b="1" dirty="0">
                 <a:solidFill>
-                  <a:srgbClr val="E2E3EC"/>
+                  <a:srgbClr val="E3E7EE"/>
                 </a:solidFill>
                 <a:latin typeface="Calibri" pitchFamily="34" charset="0"/>
                 <a:ea typeface="Calibri" pitchFamily="34" charset="-122"/>
@@ -15755,7 +15755,7 @@
           <a:ln/>
           <a:effectLst>
             <a:outerShdw sx="100000" sy="100000" kx="0" ky="0" algn="bl" rotWithShape="0" blurRad="127000" dist="25400" dir="5400000">
-              <a:srgbClr val="13134F">
+              <a:srgbClr val="1E2B4A">
                 <a:alpha val="10000"/>
               </a:srgbClr>
             </a:outerShdw>
@@ -15777,7 +15777,7 @@
             <a:avLst/>
           </a:prstGeom>
           <a:solidFill>
-            <a:srgbClr val="2A2A80"/>
+            <a:srgbClr val="3E8C9A"/>
           </a:solidFill>
           <a:ln w="31750">
             <a:solidFill>
@@ -15787,7 +15787,7 @@
           </a:ln>
           <a:effectLst>
             <a:outerShdw sx="100000" sy="100000" kx="0" ky="0" algn="bl" rotWithShape="0" blurRad="127000" dist="25400" dir="5400000">
-              <a:srgbClr val="13134F">
+              <a:srgbClr val="1E2B4A">
                 <a:alpha val="18000"/>
               </a:srgbClr>
             </a:outerShdw>
@@ -15845,7 +15845,7 @@
             <a:r>
               <a:rPr lang="en-US" sz="3000" b="1" dirty="0">
                 <a:solidFill>
-                  <a:srgbClr val="E2E3EC"/>
+                  <a:srgbClr val="E3E7EE"/>
                 </a:solidFill>
                 <a:latin typeface="Calibri" pitchFamily="34" charset="0"/>
                 <a:ea typeface="Calibri" pitchFamily="34" charset="-122"/>
@@ -15957,7 +15957,7 @@
           <a:ln/>
           <a:effectLst>
             <a:outerShdw sx="100000" sy="100000" kx="0" ky="0" algn="bl" rotWithShape="0" blurRad="127000" dist="25400" dir="5400000">
-              <a:srgbClr val="13134F">
+              <a:srgbClr val="1E2B4A">
                 <a:alpha val="10000"/>
               </a:srgbClr>
             </a:outerShdw>
@@ -15979,7 +15979,7 @@
             <a:avLst/>
           </a:prstGeom>
           <a:solidFill>
-            <a:srgbClr val="6E6ECB"/>
+            <a:srgbClr val="C98A24"/>
           </a:solidFill>
           <a:ln w="31750">
             <a:solidFill>
@@ -15989,7 +15989,7 @@
           </a:ln>
           <a:effectLst>
             <a:outerShdw sx="100000" sy="100000" kx="0" ky="0" algn="bl" rotWithShape="0" blurRad="127000" dist="25400" dir="5400000">
-              <a:srgbClr val="13134F">
+              <a:srgbClr val="1E2B4A">
                 <a:alpha val="18000"/>
               </a:srgbClr>
             </a:outerShdw>
@@ -16047,7 +16047,7 @@
             <a:r>
               <a:rPr lang="en-US" sz="3000" b="1" dirty="0">
                 <a:solidFill>
-                  <a:srgbClr val="E2E3EC"/>
+                  <a:srgbClr val="E3E7EE"/>
                 </a:solidFill>
                 <a:latin typeface="Calibri" pitchFamily="34" charset="0"/>
                 <a:ea typeface="Calibri" pitchFamily="34" charset="-122"/>
@@ -16159,7 +16159,7 @@
           <a:ln/>
           <a:effectLst>
             <a:outerShdw sx="100000" sy="100000" kx="0" ky="0" algn="bl" rotWithShape="0" blurRad="127000" dist="25400" dir="5400000">
-              <a:srgbClr val="13134F">
+              <a:srgbClr val="1E2B4A">
                 <a:alpha val="10000"/>
               </a:srgbClr>
             </a:outerShdw>
@@ -16181,7 +16181,7 @@
             <a:avLst/>
           </a:prstGeom>
           <a:solidFill>
-            <a:srgbClr val="4444AD"/>
+            <a:srgbClr val="41639E"/>
           </a:solidFill>
           <a:ln w="31750">
             <a:solidFill>
@@ -16191,7 +16191,7 @@
           </a:ln>
           <a:effectLst>
             <a:outerShdw sx="100000" sy="100000" kx="0" ky="0" algn="bl" rotWithShape="0" blurRad="127000" dist="25400" dir="5400000">
-              <a:srgbClr val="13134F">
+              <a:srgbClr val="1E2B4A">
                 <a:alpha val="18000"/>
               </a:srgbClr>
             </a:outerShdw>
@@ -16249,7 +16249,7 @@
             <a:r>
               <a:rPr lang="en-US" sz="3000" b="1" dirty="0">
                 <a:solidFill>
-                  <a:srgbClr val="E2E3EC"/>
+                  <a:srgbClr val="E3E7EE"/>
                 </a:solidFill>
                 <a:latin typeface="Calibri" pitchFamily="34" charset="0"/>
                 <a:ea typeface="Calibri" pitchFamily="34" charset="-122"/>
@@ -16361,7 +16361,7 @@
           <a:ln/>
           <a:effectLst>
             <a:outerShdw sx="100000" sy="100000" kx="0" ky="0" algn="bl" rotWithShape="0" blurRad="127000" dist="25400" dir="5400000">
-              <a:srgbClr val="13134F">
+              <a:srgbClr val="1E2B4A">
                 <a:alpha val="10000"/>
               </a:srgbClr>
             </a:outerShdw>
@@ -16393,7 +16393,7 @@
           </a:ln>
           <a:effectLst>
             <a:outerShdw sx="100000" sy="100000" kx="0" ky="0" algn="bl" rotWithShape="0" blurRad="127000" dist="25400" dir="5400000">
-              <a:srgbClr val="13134F">
+              <a:srgbClr val="1E2B4A">
                 <a:alpha val="18000"/>
               </a:srgbClr>
             </a:outerShdw>
@@ -16451,7 +16451,7 @@
             <a:r>
               <a:rPr lang="en-US" sz="3000" b="1" dirty="0">
                 <a:solidFill>
-                  <a:srgbClr val="E2E3EC"/>
+                  <a:srgbClr val="E3E7EE"/>
                 </a:solidFill>
                 <a:latin typeface="Calibri" pitchFamily="34" charset="0"/>
                 <a:ea typeface="Calibri" pitchFamily="34" charset="-122"/>
@@ -16663,7 +16663,7 @@
             <a:r>
               <a:rPr lang="en-US" sz="2700" b="1" dirty="0">
                 <a:solidFill>
-                  <a:srgbClr val="191970"/>
+                  <a:srgbClr val="1E2B4A"/>
                 </a:solidFill>
                 <a:latin typeface="Calibri" pitchFamily="34" charset="0"/>
                 <a:ea typeface="Calibri" pitchFamily="34" charset="-122"/>
@@ -16697,7 +16697,7 @@
           <a:ln/>
           <a:effectLst>
             <a:outerShdw sx="100000" sy="100000" kx="0" ky="0" algn="bl" rotWithShape="0" blurRad="127000" dist="25400" dir="5400000">
-              <a:srgbClr val="13134F">
+              <a:srgbClr val="1E2B4A">
                 <a:alpha val="10000"/>
               </a:srgbClr>
             </a:outerShdw>
@@ -16719,7 +16719,7 @@
             <a:avLst/>
           </a:prstGeom>
           <a:solidFill>
-            <a:srgbClr val="4444AD"/>
+            <a:srgbClr val="41639E"/>
           </a:solidFill>
           <a:ln w="31750">
             <a:solidFill>
@@ -16729,7 +16729,7 @@
           </a:ln>
           <a:effectLst>
             <a:outerShdw sx="100000" sy="100000" kx="0" ky="0" algn="bl" rotWithShape="0" blurRad="127000" dist="25400" dir="5400000">
-              <a:srgbClr val="13134F">
+              <a:srgbClr val="1E2B4A">
                 <a:alpha val="18000"/>
               </a:srgbClr>
             </a:outerShdw>
@@ -16826,7 +16826,7 @@
             <a:r>
               <a:rPr lang="en-US" sz="1100" b="1" dirty="0">
                 <a:solidFill>
-                  <a:srgbClr val="4444AD"/>
+                  <a:srgbClr val="41639E"/>
                 </a:solidFill>
                 <a:latin typeface="Calibri" pitchFamily="34" charset="0"/>
                 <a:ea typeface="Calibri" pitchFamily="34" charset="-122"/>
@@ -16902,7 +16902,7 @@
           <a:ln/>
           <a:effectLst>
             <a:outerShdw sx="100000" sy="100000" kx="0" ky="0" algn="bl" rotWithShape="0" blurRad="127000" dist="25400" dir="5400000">
-              <a:srgbClr val="13134F">
+              <a:srgbClr val="1E2B4A">
                 <a:alpha val="10000"/>
               </a:srgbClr>
             </a:outerShdw>
@@ -16924,7 +16924,7 @@
             <a:avLst/>
           </a:prstGeom>
           <a:solidFill>
-            <a:srgbClr val="2A2A80"/>
+            <a:srgbClr val="3E8C9A"/>
           </a:solidFill>
           <a:ln w="31750">
             <a:solidFill>
@@ -16934,7 +16934,7 @@
           </a:ln>
           <a:effectLst>
             <a:outerShdw sx="100000" sy="100000" kx="0" ky="0" algn="bl" rotWithShape="0" blurRad="127000" dist="25400" dir="5400000">
-              <a:srgbClr val="13134F">
+              <a:srgbClr val="1E2B4A">
                 <a:alpha val="18000"/>
               </a:srgbClr>
             </a:outerShdw>
@@ -17031,7 +17031,7 @@
             <a:r>
               <a:rPr lang="en-US" sz="1100" b="1" dirty="0">
                 <a:solidFill>
-                  <a:srgbClr val="2A2A80"/>
+                  <a:srgbClr val="3E8C9A"/>
                 </a:solidFill>
                 <a:latin typeface="Calibri" pitchFamily="34" charset="0"/>
                 <a:ea typeface="Calibri" pitchFamily="34" charset="-122"/>
@@ -17107,7 +17107,7 @@
           <a:ln/>
           <a:effectLst>
             <a:outerShdw sx="100000" sy="100000" kx="0" ky="0" algn="bl" rotWithShape="0" blurRad="127000" dist="25400" dir="5400000">
-              <a:srgbClr val="13134F">
+              <a:srgbClr val="1E2B4A">
                 <a:alpha val="10000"/>
               </a:srgbClr>
             </a:outerShdw>
@@ -17129,7 +17129,7 @@
             <a:avLst/>
           </a:prstGeom>
           <a:solidFill>
-            <a:srgbClr val="6E6ECB"/>
+            <a:srgbClr val="C98A24"/>
           </a:solidFill>
           <a:ln w="31750">
             <a:solidFill>
@@ -17139,7 +17139,7 @@
           </a:ln>
           <a:effectLst>
             <a:outerShdw sx="100000" sy="100000" kx="0" ky="0" algn="bl" rotWithShape="0" blurRad="127000" dist="25400" dir="5400000">
-              <a:srgbClr val="13134F">
+              <a:srgbClr val="1E2B4A">
                 <a:alpha val="18000"/>
               </a:srgbClr>
             </a:outerShdw>
@@ -17236,7 +17236,7 @@
             <a:r>
               <a:rPr lang="en-US" sz="1100" b="1" dirty="0">
                 <a:solidFill>
-                  <a:srgbClr val="6E6ECB"/>
+                  <a:srgbClr val="C98A24"/>
                 </a:solidFill>
                 <a:latin typeface="Calibri" pitchFamily="34" charset="0"/>
                 <a:ea typeface="Calibri" pitchFamily="34" charset="-122"/>
@@ -17312,7 +17312,7 @@
           <a:ln/>
           <a:effectLst>
             <a:outerShdw sx="100000" sy="100000" kx="0" ky="0" algn="bl" rotWithShape="0" blurRad="127000" dist="25400" dir="5400000">
-              <a:srgbClr val="13134F">
+              <a:srgbClr val="1E2B4A">
                 <a:alpha val="10000"/>
               </a:srgbClr>
             </a:outerShdw>
@@ -17344,7 +17344,7 @@
           </a:ln>
           <a:effectLst>
             <a:outerShdw sx="100000" sy="100000" kx="0" ky="0" algn="bl" rotWithShape="0" blurRad="127000" dist="25400" dir="5400000">
-              <a:srgbClr val="13134F">
+              <a:srgbClr val="1E2B4A">
                 <a:alpha val="18000"/>
               </a:srgbClr>
             </a:outerShdw>
@@ -17517,7 +17517,7 @@
           <a:ln/>
           <a:effectLst>
             <a:outerShdw sx="100000" sy="100000" kx="0" ky="0" algn="bl" rotWithShape="0" blurRad="127000" dist="25400" dir="5400000">
-              <a:srgbClr val="13134F">
+              <a:srgbClr val="1E2B4A">
                 <a:alpha val="10000"/>
               </a:srgbClr>
             </a:outerShdw>
@@ -17685,7 +17685,7 @@
             <a:r>
               <a:rPr lang="en-US" sz="2700" b="1" dirty="0">
                 <a:solidFill>
-                  <a:srgbClr val="191970"/>
+                  <a:srgbClr val="1E2B4A"/>
                 </a:solidFill>
                 <a:latin typeface="Calibri" pitchFamily="34" charset="0"/>
                 <a:ea typeface="Calibri" pitchFamily="34" charset="-122"/>
@@ -17719,7 +17719,7 @@
           <a:ln/>
           <a:effectLst>
             <a:outerShdw sx="100000" sy="100000" kx="0" ky="0" algn="bl" rotWithShape="0" blurRad="127000" dist="25400" dir="5400000">
-              <a:srgbClr val="13134F">
+              <a:srgbClr val="1E2B4A">
                 <a:alpha val="10000"/>
               </a:srgbClr>
             </a:outerShdw>
@@ -17910,7 +17910,7 @@
           <a:ln/>
           <a:effectLst>
             <a:outerShdw sx="100000" sy="100000" kx="0" ky="0" algn="bl" rotWithShape="0" blurRad="127000" dist="25400" dir="5400000">
-              <a:srgbClr val="13134F">
+              <a:srgbClr val="1E2B4A">
                 <a:alpha val="10000"/>
               </a:srgbClr>
             </a:outerShdw>
@@ -17944,7 +17944,7 @@
             <a:r>
               <a:rPr lang="en-US" sz="2600" b="1" dirty="0">
                 <a:solidFill>
-                  <a:srgbClr val="2A2A80"/>
+                  <a:srgbClr val="3E8C9A"/>
                 </a:solidFill>
                 <a:latin typeface="Calibri" pitchFamily="34" charset="0"/>
                 <a:ea typeface="Calibri" pitchFamily="34" charset="-122"/>
@@ -18067,7 +18067,7 @@
             <a:r>
               <a:rPr lang="en-US" sz="1350" b="1" dirty="0">
                 <a:solidFill>
-                  <a:srgbClr val="2A2A80"/>
+                  <a:srgbClr val="3E8C9A"/>
                 </a:solidFill>
                 <a:latin typeface="Calibri" pitchFamily="34" charset="0"/>
                 <a:ea typeface="Calibri" pitchFamily="34" charset="-122"/>
@@ -18104,7 +18104,7 @@
           </a:ln>
           <a:effectLst>
             <a:outerShdw sx="100000" sy="100000" kx="0" ky="0" algn="bl" rotWithShape="0" blurRad="127000" dist="25400" dir="5400000">
-              <a:srgbClr val="13134F">
+              <a:srgbClr val="1E2B4A">
                 <a:alpha val="18000"/>
               </a:srgbClr>
             </a:outerShdw>
@@ -18150,7 +18150,7 @@
             <a:avLst/>
           </a:prstGeom>
           <a:solidFill>
-            <a:srgbClr val="2A2A80"/>
+            <a:srgbClr val="3E8C9A"/>
           </a:solidFill>
           <a:ln w="31750">
             <a:solidFill>
@@ -18160,7 +18160,7 @@
           </a:ln>
           <a:effectLst>
             <a:outerShdw sx="100000" sy="100000" kx="0" ky="0" algn="bl" rotWithShape="0" blurRad="127000" dist="25400" dir="5400000">
-              <a:srgbClr val="13134F">
+              <a:srgbClr val="1E2B4A">
                 <a:alpha val="18000"/>
               </a:srgbClr>
             </a:outerShdw>
@@ -18313,7 +18313,7 @@
             <a:r>
               <a:rPr lang="en-US" sz="2700" b="1" dirty="0">
                 <a:solidFill>
-                  <a:srgbClr val="191970"/>
+                  <a:srgbClr val="1E2B4A"/>
                 </a:solidFill>
                 <a:latin typeface="Calibri" pitchFamily="34" charset="0"/>
                 <a:ea typeface="Calibri" pitchFamily="34" charset="-122"/>
@@ -18389,7 +18389,7 @@
           <a:ln/>
           <a:effectLst>
             <a:outerShdw sx="100000" sy="100000" kx="0" ky="0" algn="bl" rotWithShape="0" blurRad="127000" dist="25400" dir="5400000">
-              <a:srgbClr val="13134F">
+              <a:srgbClr val="1E2B4A">
                 <a:alpha val="10000"/>
               </a:srgbClr>
             </a:outerShdw>
@@ -18411,7 +18411,7 @@
             <a:avLst/>
           </a:prstGeom>
           <a:solidFill>
-            <a:srgbClr val="6E6ECB"/>
+            <a:srgbClr val="C98A24"/>
           </a:solidFill>
           <a:ln w="31750">
             <a:solidFill>
@@ -18421,7 +18421,7 @@
           </a:ln>
           <a:effectLst>
             <a:outerShdw sx="100000" sy="100000" kx="0" ky="0" algn="bl" rotWithShape="0" blurRad="127000" dist="25400" dir="5400000">
-              <a:srgbClr val="13134F">
+              <a:srgbClr val="1E2B4A">
                 <a:alpha val="18000"/>
               </a:srgbClr>
             </a:outerShdw>
@@ -18558,7 +18558,7 @@
           <a:ln/>
           <a:effectLst>
             <a:outerShdw sx="100000" sy="100000" kx="0" ky="0" algn="bl" rotWithShape="0" blurRad="127000" dist="25400" dir="5400000">
-              <a:srgbClr val="13134F">
+              <a:srgbClr val="1E2B4A">
                 <a:alpha val="10000"/>
               </a:srgbClr>
             </a:outerShdw>
@@ -18580,7 +18580,7 @@
             <a:avLst/>
           </a:prstGeom>
           <a:solidFill>
-            <a:srgbClr val="4444AD"/>
+            <a:srgbClr val="41639E"/>
           </a:solidFill>
           <a:ln w="31750">
             <a:solidFill>
@@ -18590,7 +18590,7 @@
           </a:ln>
           <a:effectLst>
             <a:outerShdw sx="100000" sy="100000" kx="0" ky="0" algn="bl" rotWithShape="0" blurRad="127000" dist="25400" dir="5400000">
-              <a:srgbClr val="13134F">
+              <a:srgbClr val="1E2B4A">
                 <a:alpha val="18000"/>
               </a:srgbClr>
             </a:outerShdw>
@@ -18727,7 +18727,7 @@
           <a:ln/>
           <a:effectLst>
             <a:outerShdw sx="100000" sy="100000" kx="0" ky="0" algn="bl" rotWithShape="0" blurRad="127000" dist="25400" dir="5400000">
-              <a:srgbClr val="13134F">
+              <a:srgbClr val="1E2B4A">
                 <a:alpha val="10000"/>
               </a:srgbClr>
             </a:outerShdw>
@@ -18749,7 +18749,7 @@
             <a:avLst/>
           </a:prstGeom>
           <a:solidFill>
-            <a:srgbClr val="2A2A80"/>
+            <a:srgbClr val="3E8C9A"/>
           </a:solidFill>
           <a:ln w="31750">
             <a:solidFill>
@@ -18759,7 +18759,7 @@
           </a:ln>
           <a:effectLst>
             <a:outerShdw sx="100000" sy="100000" kx="0" ky="0" algn="bl" rotWithShape="0" blurRad="127000" dist="25400" dir="5400000">
-              <a:srgbClr val="13134F">
+              <a:srgbClr val="1E2B4A">
                 <a:alpha val="18000"/>
               </a:srgbClr>
             </a:outerShdw>
@@ -18996,7 +18996,7 @@
             <a:r>
               <a:rPr lang="en-US" sz="2700" b="1" dirty="0">
                 <a:solidFill>
-                  <a:srgbClr val="191970"/>
+                  <a:srgbClr val="1E2B4A"/>
                 </a:solidFill>
                 <a:latin typeface="Calibri" pitchFamily="34" charset="0"/>
                 <a:ea typeface="Calibri" pitchFamily="34" charset="-122"/>
@@ -19030,7 +19030,7 @@
           <a:ln/>
           <a:effectLst>
             <a:outerShdw sx="100000" sy="100000" kx="0" ky="0" algn="bl" rotWithShape="0" blurRad="127000" dist="25400" dir="5400000">
-              <a:srgbClr val="13134F">
+              <a:srgbClr val="1E2B4A">
                 <a:alpha val="10000"/>
               </a:srgbClr>
             </a:outerShdw>
@@ -19062,7 +19062,7 @@
           </a:ln>
           <a:effectLst>
             <a:outerShdw sx="100000" sy="100000" kx="0" ky="0" algn="bl" rotWithShape="0" blurRad="127000" dist="25400" dir="5400000">
-              <a:srgbClr val="13134F">
+              <a:srgbClr val="1E2B4A">
                 <a:alpha val="18000"/>
               </a:srgbClr>
             </a:outerShdw>
@@ -19316,7 +19316,7 @@
           <a:ln/>
           <a:effectLst>
             <a:outerShdw sx="100000" sy="100000" kx="0" ky="0" algn="bl" rotWithShape="0" blurRad="127000" dist="25400" dir="5400000">
-              <a:srgbClr val="13134F">
+              <a:srgbClr val="1E2B4A">
                 <a:alpha val="10000"/>
               </a:srgbClr>
             </a:outerShdw>
@@ -19338,7 +19338,7 @@
             <a:avLst/>
           </a:prstGeom>
           <a:solidFill>
-            <a:srgbClr val="2A2A80"/>
+            <a:srgbClr val="3E8C9A"/>
           </a:solidFill>
           <a:ln w="31750">
             <a:solidFill>
@@ -19348,7 +19348,7 @@
           </a:ln>
           <a:effectLst>
             <a:outerShdw sx="100000" sy="100000" kx="0" ky="0" algn="bl" rotWithShape="0" blurRad="127000" dist="25400" dir="5400000">
-              <a:srgbClr val="13134F">
+              <a:srgbClr val="1E2B4A">
                 <a:alpha val="18000"/>
               </a:srgbClr>
             </a:outerShdw>
@@ -19433,7 +19433,7 @@
             <a:avLst/>
           </a:prstGeom>
           <a:solidFill>
-            <a:srgbClr val="2A2A80"/>
+            <a:srgbClr val="3E8C9A"/>
           </a:solidFill>
           <a:ln/>
         </p:spPr>
@@ -19534,7 +19534,7 @@
             <a:avLst/>
           </a:prstGeom>
           <a:solidFill>
-            <a:srgbClr val="2A2A80"/>
+            <a:srgbClr val="3E8C9A"/>
           </a:solidFill>
           <a:ln/>
         </p:spPr>
@@ -19635,7 +19635,7 @@
             <a:avLst/>
           </a:prstGeom>
           <a:solidFill>
-            <a:srgbClr val="2A2A80"/>
+            <a:srgbClr val="3E8C9A"/>
           </a:solidFill>
           <a:ln/>
         </p:spPr>
@@ -19798,7 +19798,7 @@
     <p:bg>
       <p:bgPr>
         <a:solidFill>
-          <a:srgbClr val="101038"/>
+          <a:srgbClr val="16213D"/>
         </a:solidFill>
       </p:bgPr>
     </p:bg>
@@ -19831,7 +19831,7 @@
             <a:avLst/>
           </a:prstGeom>
           <a:solidFill>
-            <a:srgbClr val="23236B"/>
+            <a:srgbClr val="24365E"/>
           </a:solidFill>
           <a:ln/>
         </p:spPr>
@@ -19851,7 +19851,7 @@
             <a:avLst/>
           </a:prstGeom>
           <a:solidFill>
-            <a:srgbClr val="23236B"/>
+            <a:srgbClr val="24365E"/>
           </a:solidFill>
           <a:ln/>
         </p:spPr>
@@ -19964,7 +19964,7 @@
             <a:r>
               <a:rPr lang="en-US" sz="1400" dirty="0">
                 <a:solidFill>
-                  <a:srgbClr val="B7B7DB"/>
+                  <a:srgbClr val="AFC0DA"/>
                 </a:solidFill>
                 <a:latin typeface="Calibri" pitchFamily="34" charset="0"/>
                 <a:ea typeface="Calibri" pitchFamily="34" charset="-122"/>
@@ -20035,7 +20035,7 @@
             <a:r>
               <a:rPr lang="en-US" sz="2700" b="1" dirty="0">
                 <a:solidFill>
-                  <a:srgbClr val="191970"/>
+                  <a:srgbClr val="1E2B4A"/>
                 </a:solidFill>
                 <a:latin typeface="Calibri" pitchFamily="34" charset="0"/>
                 <a:ea typeface="Calibri" pitchFamily="34" charset="-122"/>
@@ -20064,12 +20064,12 @@
             </a:avLst>
           </a:prstGeom>
           <a:solidFill>
-            <a:srgbClr val="191970"/>
+            <a:srgbClr val="1E2B4A"/>
           </a:solidFill>
           <a:ln/>
           <a:effectLst>
             <a:outerShdw sx="100000" sy="100000" kx="0" ky="0" algn="bl" rotWithShape="0" blurRad="127000" dist="25400" dir="5400000">
-              <a:srgbClr val="13134F">
+              <a:srgbClr val="1E2B4A">
                 <a:alpha val="10000"/>
               </a:srgbClr>
             </a:outerShdw>
@@ -20140,7 +20140,7 @@
           <a:ln/>
           <a:effectLst>
             <a:outerShdw sx="100000" sy="100000" kx="0" ky="0" algn="bl" rotWithShape="0" blurRad="127000" dist="25400" dir="5400000">
-              <a:srgbClr val="13134F">
+              <a:srgbClr val="1E2B4A">
                 <a:alpha val="10000"/>
               </a:srgbClr>
             </a:outerShdw>
@@ -20289,7 +20289,7 @@
           <a:ln/>
           <a:effectLst>
             <a:outerShdw sx="100000" sy="100000" kx="0" ky="0" algn="bl" rotWithShape="0" blurRad="127000" dist="25400" dir="5400000">
-              <a:srgbClr val="13134F">
+              <a:srgbClr val="1E2B4A">
                 <a:alpha val="10000"/>
               </a:srgbClr>
             </a:outerShdw>
@@ -20323,7 +20323,7 @@
             <a:r>
               <a:rPr lang="en-US" sz="3600" b="1" dirty="0">
                 <a:solidFill>
-                  <a:srgbClr val="4444AD"/>
+                  <a:srgbClr val="41639E"/>
                 </a:solidFill>
                 <a:latin typeface="Calibri" pitchFamily="34" charset="0"/>
                 <a:ea typeface="Calibri" pitchFamily="34" charset="-122"/>
@@ -20438,7 +20438,7 @@
           <a:ln/>
           <a:effectLst>
             <a:outerShdw sx="100000" sy="100000" kx="0" ky="0" algn="bl" rotWithShape="0" blurRad="127000" dist="25400" dir="5400000">
-              <a:srgbClr val="13134F">
+              <a:srgbClr val="1E2B4A">
                 <a:alpha val="10000"/>
               </a:srgbClr>
             </a:outerShdw>
@@ -20472,7 +20472,7 @@
             <a:r>
               <a:rPr lang="en-US" sz="3600" b="1" dirty="0">
                 <a:solidFill>
-                  <a:srgbClr val="2A2A80"/>
+                  <a:srgbClr val="3E8C9A"/>
                 </a:solidFill>
                 <a:latin typeface="Calibri" pitchFamily="34" charset="0"/>
                 <a:ea typeface="Calibri" pitchFamily="34" charset="-122"/>
@@ -20587,7 +20587,7 @@
           <a:ln/>
           <a:effectLst>
             <a:outerShdw sx="100000" sy="100000" kx="0" ky="0" algn="bl" rotWithShape="0" blurRad="127000" dist="25400" dir="5400000">
-              <a:srgbClr val="13134F">
+              <a:srgbClr val="1E2B4A">
                 <a:alpha val="10000"/>
               </a:srgbClr>
             </a:outerShdw>
@@ -20621,7 +20621,7 @@
             <a:r>
               <a:rPr lang="en-US" sz="3600" b="1" dirty="0">
                 <a:solidFill>
-                  <a:srgbClr val="6E6ECB"/>
+                  <a:srgbClr val="C98A24"/>
                 </a:solidFill>
                 <a:latin typeface="Calibri" pitchFamily="34" charset="0"/>
                 <a:ea typeface="Calibri" pitchFamily="34" charset="-122"/>
@@ -20836,7 +20836,7 @@
             <a:r>
               <a:rPr lang="en-US" sz="2700" b="1" dirty="0">
                 <a:solidFill>
-                  <a:srgbClr val="191970"/>
+                  <a:srgbClr val="1E2B4A"/>
                 </a:solidFill>
                 <a:latin typeface="Calibri" pitchFamily="34" charset="0"/>
                 <a:ea typeface="Calibri" pitchFamily="34" charset="-122"/>
@@ -20912,7 +20912,7 @@
           <a:ln/>
           <a:effectLst>
             <a:outerShdw sx="100000" sy="100000" kx="0" ky="0" algn="bl" rotWithShape="0" blurRad="127000" dist="25400" dir="5400000">
-              <a:srgbClr val="13134F">
+              <a:srgbClr val="1E2B4A">
                 <a:alpha val="10000"/>
               </a:srgbClr>
             </a:outerShdw>
@@ -20934,7 +20934,7 @@
             <a:avLst/>
           </a:prstGeom>
           <a:solidFill>
-            <a:srgbClr val="6E6ECB"/>
+            <a:srgbClr val="C98A24"/>
           </a:solidFill>
           <a:ln w="31750">
             <a:solidFill>
@@ -20944,7 +20944,7 @@
           </a:ln>
           <a:effectLst>
             <a:outerShdw sx="100000" sy="100000" kx="0" ky="0" algn="bl" rotWithShape="0" blurRad="127000" dist="25400" dir="5400000">
-              <a:srgbClr val="13134F">
+              <a:srgbClr val="1E2B4A">
                 <a:alpha val="18000"/>
               </a:srgbClr>
             </a:outerShdw>
@@ -21081,7 +21081,7 @@
           <a:ln/>
           <a:effectLst>
             <a:outerShdw sx="100000" sy="100000" kx="0" ky="0" algn="bl" rotWithShape="0" blurRad="127000" dist="25400" dir="5400000">
-              <a:srgbClr val="13134F">
+              <a:srgbClr val="1E2B4A">
                 <a:alpha val="10000"/>
               </a:srgbClr>
             </a:outerShdw>
@@ -21103,7 +21103,7 @@
             <a:avLst/>
           </a:prstGeom>
           <a:solidFill>
-            <a:srgbClr val="4444AD"/>
+            <a:srgbClr val="41639E"/>
           </a:solidFill>
           <a:ln w="31750">
             <a:solidFill>
@@ -21113,7 +21113,7 @@
           </a:ln>
           <a:effectLst>
             <a:outerShdw sx="100000" sy="100000" kx="0" ky="0" algn="bl" rotWithShape="0" blurRad="127000" dist="25400" dir="5400000">
-              <a:srgbClr val="13134F">
+              <a:srgbClr val="1E2B4A">
                 <a:alpha val="18000"/>
               </a:srgbClr>
             </a:outerShdw>
@@ -21250,7 +21250,7 @@
           <a:ln/>
           <a:effectLst>
             <a:outerShdw sx="100000" sy="100000" kx="0" ky="0" algn="bl" rotWithShape="0" blurRad="127000" dist="25400" dir="5400000">
-              <a:srgbClr val="13134F">
+              <a:srgbClr val="1E2B4A">
                 <a:alpha val="10000"/>
               </a:srgbClr>
             </a:outerShdw>
@@ -21272,7 +21272,7 @@
             <a:avLst/>
           </a:prstGeom>
           <a:solidFill>
-            <a:srgbClr val="2A2A80"/>
+            <a:srgbClr val="3E8C9A"/>
           </a:solidFill>
           <a:ln w="31750">
             <a:solidFill>
@@ -21282,7 +21282,7 @@
           </a:ln>
           <a:effectLst>
             <a:outerShdw sx="100000" sy="100000" kx="0" ky="0" algn="bl" rotWithShape="0" blurRad="127000" dist="25400" dir="5400000">
-              <a:srgbClr val="13134F">
+              <a:srgbClr val="1E2B4A">
                 <a:alpha val="18000"/>
               </a:srgbClr>
             </a:outerShdw>
@@ -21474,7 +21474,7 @@
     <p:bg>
       <p:bgPr>
         <a:solidFill>
-          <a:srgbClr val="101038"/>
+          <a:srgbClr val="16213D"/>
         </a:solidFill>
       </p:bgPr>
     </p:bg>
@@ -21507,7 +21507,7 @@
             <a:avLst/>
           </a:prstGeom>
           <a:solidFill>
-            <a:srgbClr val="23236B"/>
+            <a:srgbClr val="24365E"/>
           </a:solidFill>
           <a:ln/>
         </p:spPr>
@@ -21527,7 +21527,7 @@
             <a:avLst/>
           </a:prstGeom>
           <a:solidFill>
-            <a:srgbClr val="23236B"/>
+            <a:srgbClr val="24365E"/>
           </a:solidFill>
           <a:ln/>
         </p:spPr>
@@ -21663,7 +21663,7 @@
     <p:bg>
       <p:bgPr>
         <a:solidFill>
-          <a:srgbClr val="101038"/>
+          <a:srgbClr val="16213D"/>
         </a:solidFill>
       </p:bgPr>
     </p:bg>
@@ -21696,7 +21696,7 @@
             <a:avLst/>
           </a:prstGeom>
           <a:solidFill>
-            <a:srgbClr val="23236B"/>
+            <a:srgbClr val="24365E"/>
           </a:solidFill>
           <a:ln/>
         </p:spPr>
@@ -21716,7 +21716,7 @@
             <a:avLst/>
           </a:prstGeom>
           <a:solidFill>
-            <a:srgbClr val="23236B"/>
+            <a:srgbClr val="24365E"/>
           </a:solidFill>
           <a:ln/>
         </p:spPr>
@@ -21829,7 +21829,7 @@
             <a:r>
               <a:rPr lang="en-US" sz="1400" dirty="0">
                 <a:solidFill>
-                  <a:srgbClr val="B7B7DB"/>
+                  <a:srgbClr val="AFC0DA"/>
                 </a:solidFill>
                 <a:latin typeface="Calibri" pitchFamily="34" charset="0"/>
                 <a:ea typeface="Calibri" pitchFamily="34" charset="-122"/>
@@ -21900,7 +21900,7 @@
             <a:r>
               <a:rPr lang="en-US" sz="2700" b="1" dirty="0">
                 <a:solidFill>
-                  <a:srgbClr val="191970"/>
+                  <a:srgbClr val="1E2B4A"/>
                 </a:solidFill>
                 <a:latin typeface="Calibri" pitchFamily="34" charset="0"/>
                 <a:ea typeface="Calibri" pitchFamily="34" charset="-122"/>
@@ -21934,7 +21934,7 @@
           <a:ln/>
           <a:effectLst>
             <a:outerShdw sx="100000" sy="100000" kx="0" ky="0" algn="bl" rotWithShape="0" blurRad="127000" dist="25400" dir="5400000">
-              <a:srgbClr val="13134F">
+              <a:srgbClr val="1E2B4A">
                 <a:alpha val="10000"/>
               </a:srgbClr>
             </a:outerShdw>
@@ -21956,7 +21956,7 @@
             <a:avLst/>
           </a:prstGeom>
           <a:solidFill>
-            <a:srgbClr val="4444AD"/>
+            <a:srgbClr val="41639E"/>
           </a:solidFill>
           <a:ln w="31750">
             <a:solidFill>
@@ -21966,7 +21966,7 @@
           </a:ln>
           <a:effectLst>
             <a:outerShdw sx="100000" sy="100000" kx="0" ky="0" algn="bl" rotWithShape="0" blurRad="127000" dist="25400" dir="5400000">
-              <a:srgbClr val="13134F">
+              <a:srgbClr val="1E2B4A">
                 <a:alpha val="18000"/>
               </a:srgbClr>
             </a:outerShdw>
@@ -22066,7 +22066,7 @@
             <a:r>
               <a:rPr lang="en-US" sz="3400" b="1" dirty="0">
                 <a:solidFill>
-                  <a:srgbClr val="4444AD"/>
+                  <a:srgbClr val="41639E"/>
                 </a:solidFill>
                 <a:latin typeface="Calibri" pitchFamily="34" charset="0"/>
                 <a:ea typeface="Calibri" pitchFamily="34" charset="-122"/>
@@ -22167,7 +22167,7 @@
             <a:r>
               <a:rPr lang="en-US" sz="3400" b="1" dirty="0">
                 <a:solidFill>
-                  <a:srgbClr val="4444AD"/>
+                  <a:srgbClr val="41639E"/>
                 </a:solidFill>
                 <a:latin typeface="Calibri" pitchFamily="34" charset="0"/>
                 <a:ea typeface="Calibri" pitchFamily="34" charset="-122"/>
@@ -22344,7 +22344,7 @@
           <a:ln/>
           <a:effectLst>
             <a:outerShdw sx="100000" sy="100000" kx="0" ky="0" algn="bl" rotWithShape="0" blurRad="127000" dist="25400" dir="5400000">
-              <a:srgbClr val="13134F">
+              <a:srgbClr val="1E2B4A">
                 <a:alpha val="10000"/>
               </a:srgbClr>
             </a:outerShdw>
@@ -22376,7 +22376,7 @@
           </a:ln>
           <a:effectLst>
             <a:outerShdw sx="100000" sy="100000" kx="0" ky="0" algn="bl" rotWithShape="0" blurRad="127000" dist="25400" dir="5400000">
-              <a:srgbClr val="13134F">
+              <a:srgbClr val="1E2B4A">
                 <a:alpha val="18000"/>
               </a:srgbClr>
             </a:outerShdw>
@@ -22854,7 +22854,7 @@
             <a:r>
               <a:rPr lang="en-US" sz="2700" b="1" dirty="0">
                 <a:solidFill>
-                  <a:srgbClr val="191970"/>
+                  <a:srgbClr val="1E2B4A"/>
                 </a:solidFill>
                 <a:latin typeface="Calibri" pitchFamily="34" charset="0"/>
                 <a:ea typeface="Calibri" pitchFamily="34" charset="-122"/>
@@ -22883,12 +22883,12 @@
             </a:avLst>
           </a:prstGeom>
           <a:solidFill>
-            <a:srgbClr val="191970"/>
+            <a:srgbClr val="1E2B4A"/>
           </a:solidFill>
           <a:ln/>
           <a:effectLst>
             <a:outerShdw sx="100000" sy="100000" kx="0" ky="0" algn="bl" rotWithShape="0" blurRad="127000" dist="25400" dir="5400000">
-              <a:srgbClr val="13134F">
+              <a:srgbClr val="1E2B4A">
                 <a:alpha val="10000"/>
               </a:srgbClr>
             </a:outerShdw>
@@ -22979,7 +22979,7 @@
           <a:ln/>
           <a:effectLst>
             <a:outerShdw sx="100000" sy="100000" kx="0" ky="0" algn="bl" rotWithShape="0" blurRad="127000" dist="25400" dir="5400000">
-              <a:srgbClr val="13134F">
+              <a:srgbClr val="1E2B4A">
                 <a:alpha val="10000"/>
               </a:srgbClr>
             </a:outerShdw>
@@ -23092,7 +23092,7 @@
           <a:ln/>
           <a:effectLst>
             <a:outerShdw sx="100000" sy="100000" kx="0" ky="0" algn="bl" rotWithShape="0" blurRad="127000" dist="25400" dir="5400000">
-              <a:srgbClr val="13134F">
+              <a:srgbClr val="1E2B4A">
                 <a:alpha val="10000"/>
               </a:srgbClr>
             </a:outerShdw>
@@ -23205,7 +23205,7 @@
           <a:ln/>
           <a:effectLst>
             <a:outerShdw sx="100000" sy="100000" kx="0" ky="0" algn="bl" rotWithShape="0" blurRad="127000" dist="25400" dir="5400000">
-              <a:srgbClr val="13134F">
+              <a:srgbClr val="1E2B4A">
                 <a:alpha val="10000"/>
               </a:srgbClr>
             </a:outerShdw>
@@ -23321,7 +23321,7 @@
           </a:ln>
           <a:effectLst>
             <a:outerShdw sx="100000" sy="100000" kx="0" ky="0" algn="bl" rotWithShape="0" blurRad="127000" dist="25400" dir="5400000">
-              <a:srgbClr val="13134F">
+              <a:srgbClr val="1E2B4A">
                 <a:alpha val="18000"/>
               </a:srgbClr>
             </a:outerShdw>
@@ -23367,7 +23367,7 @@
             <a:avLst/>
           </a:prstGeom>
           <a:solidFill>
-            <a:srgbClr val="6E6ECB"/>
+            <a:srgbClr val="C98A24"/>
           </a:solidFill>
           <a:ln w="31750">
             <a:solidFill>
@@ -23377,7 +23377,7 @@
           </a:ln>
           <a:effectLst>
             <a:outerShdw sx="100000" sy="100000" kx="0" ky="0" algn="bl" rotWithShape="0" blurRad="127000" dist="25400" dir="5400000">
-              <a:srgbClr val="13134F">
+              <a:srgbClr val="1E2B4A">
                 <a:alpha val="18000"/>
               </a:srgbClr>
             </a:outerShdw>
@@ -23423,7 +23423,7 @@
             <a:avLst/>
           </a:prstGeom>
           <a:solidFill>
-            <a:srgbClr val="2A2A80"/>
+            <a:srgbClr val="3E8C9A"/>
           </a:solidFill>
           <a:ln w="31750">
             <a:solidFill>
@@ -23433,7 +23433,7 @@
           </a:ln>
           <a:effectLst>
             <a:outerShdw sx="100000" sy="100000" kx="0" ky="0" algn="bl" rotWithShape="0" blurRad="127000" dist="25400" dir="5400000">
-              <a:srgbClr val="13134F">
+              <a:srgbClr val="1E2B4A">
                 <a:alpha val="18000"/>
               </a:srgbClr>
             </a:outerShdw>
@@ -23586,7 +23586,7 @@
             <a:r>
               <a:rPr lang="en-US" sz="2700" b="1" dirty="0">
                 <a:solidFill>
-                  <a:srgbClr val="191970"/>
+                  <a:srgbClr val="1E2B4A"/>
                 </a:solidFill>
                 <a:latin typeface="Calibri" pitchFamily="34" charset="0"/>
                 <a:ea typeface="Calibri" pitchFamily="34" charset="-122"/>
@@ -23620,7 +23620,7 @@
           <a:ln/>
           <a:effectLst>
             <a:outerShdw sx="100000" sy="100000" kx="0" ky="0" algn="bl" rotWithShape="0" blurRad="127000" dist="25400" dir="5400000">
-              <a:srgbClr val="13134F">
+              <a:srgbClr val="1E2B4A">
                 <a:alpha val="10000"/>
               </a:srgbClr>
             </a:outerShdw>
@@ -23642,7 +23642,7 @@
             <a:avLst/>
           </a:prstGeom>
           <a:solidFill>
-            <a:srgbClr val="4444AD"/>
+            <a:srgbClr val="41639E"/>
           </a:solidFill>
           <a:ln w="31750">
             <a:solidFill>
@@ -23652,7 +23652,7 @@
           </a:ln>
           <a:effectLst>
             <a:outerShdw sx="100000" sy="100000" kx="0" ky="0" algn="bl" rotWithShape="0" blurRad="127000" dist="25400" dir="5400000">
-              <a:srgbClr val="13134F">
+              <a:srgbClr val="1E2B4A">
                 <a:alpha val="18000"/>
               </a:srgbClr>
             </a:outerShdw>
@@ -23779,7 +23779,7 @@
             <a:avLst/>
           </a:prstGeom>
           <a:solidFill>
-            <a:srgbClr val="4444AD"/>
+            <a:srgbClr val="41639E"/>
           </a:solidFill>
           <a:ln/>
         </p:spPr>
@@ -23880,7 +23880,7 @@
             <a:avLst/>
           </a:prstGeom>
           <a:solidFill>
-            <a:srgbClr val="4444AD"/>
+            <a:srgbClr val="41639E"/>
           </a:solidFill>
           <a:ln/>
         </p:spPr>
@@ -23988,7 +23988,7 @@
           <a:ln/>
           <a:effectLst>
             <a:outerShdw sx="100000" sy="100000" kx="0" ky="0" algn="bl" rotWithShape="0" blurRad="127000" dist="25400" dir="5400000">
-              <a:srgbClr val="13134F">
+              <a:srgbClr val="1E2B4A">
                 <a:alpha val="10000"/>
               </a:srgbClr>
             </a:outerShdw>
@@ -24020,7 +24020,7 @@
           </a:ln>
           <a:effectLst>
             <a:outerShdw sx="100000" sy="100000" kx="0" ky="0" algn="bl" rotWithShape="0" blurRad="127000" dist="25400" dir="5400000">
-              <a:srgbClr val="13134F">
+              <a:srgbClr val="1E2B4A">
                 <a:alpha val="18000"/>
               </a:srgbClr>
             </a:outerShdw>
@@ -24107,12 +24107,12 @@
             </a:avLst>
           </a:prstGeom>
           <a:solidFill>
-            <a:srgbClr val="E7E7F3"/>
+            <a:srgbClr val="E5EEF4"/>
           </a:solidFill>
           <a:ln/>
           <a:effectLst>
             <a:outerShdw sx="100000" sy="100000" kx="0" ky="0" algn="bl" rotWithShape="0" blurRad="127000" dist="25400" dir="5400000">
-              <a:srgbClr val="13134F">
+              <a:srgbClr val="1E2B4A">
                 <a:alpha val="10000"/>
               </a:srgbClr>
             </a:outerShdw>
@@ -24217,12 +24217,12 @@
             </a:avLst>
           </a:prstGeom>
           <a:solidFill>
-            <a:srgbClr val="E7E7F3"/>
+            <a:srgbClr val="E5EEF4"/>
           </a:solidFill>
           <a:ln/>
           <a:effectLst>
             <a:outerShdw sx="100000" sy="100000" kx="0" ky="0" algn="bl" rotWithShape="0" blurRad="127000" dist="25400" dir="5400000">
-              <a:srgbClr val="13134F">
+              <a:srgbClr val="1E2B4A">
                 <a:alpha val="10000"/>
               </a:srgbClr>
             </a:outerShdw>
@@ -24387,7 +24387,7 @@
     <p:bg>
       <p:bgPr>
         <a:solidFill>
-          <a:srgbClr val="101038"/>
+          <a:srgbClr val="16213D"/>
         </a:solidFill>
       </p:bgPr>
     </p:bg>
@@ -24420,7 +24420,7 @@
             <a:avLst/>
           </a:prstGeom>
           <a:solidFill>
-            <a:srgbClr val="23236B"/>
+            <a:srgbClr val="24365E"/>
           </a:solidFill>
           <a:ln/>
         </p:spPr>
@@ -24440,7 +24440,7 @@
             <a:avLst/>
           </a:prstGeom>
           <a:solidFill>
-            <a:srgbClr val="23236B"/>
+            <a:srgbClr val="24365E"/>
           </a:solidFill>
           <a:ln/>
         </p:spPr>
@@ -24553,7 +24553,7 @@
             <a:r>
               <a:rPr lang="en-US" sz="1400" dirty="0">
                 <a:solidFill>
-                  <a:srgbClr val="B7B7DB"/>
+                  <a:srgbClr val="AFC0DA"/>
                 </a:solidFill>
                 <a:latin typeface="Calibri" pitchFamily="34" charset="0"/>
                 <a:ea typeface="Calibri" pitchFamily="34" charset="-122"/>
@@ -24624,7 +24624,7 @@
             <a:r>
               <a:rPr lang="en-US" sz="2700" b="1" dirty="0">
                 <a:solidFill>
-                  <a:srgbClr val="191970"/>
+                  <a:srgbClr val="1E2B4A"/>
                 </a:solidFill>
                 <a:latin typeface="Calibri" pitchFamily="34" charset="0"/>
                 <a:ea typeface="Calibri" pitchFamily="34" charset="-122"/>
@@ -24658,7 +24658,7 @@
           <a:ln/>
           <a:effectLst>
             <a:outerShdw sx="100000" sy="100000" kx="0" ky="0" algn="bl" rotWithShape="0" blurRad="127000" dist="25400" dir="5400000">
-              <a:srgbClr val="13134F">
+              <a:srgbClr val="1E2B4A">
                 <a:alpha val="10000"/>
               </a:srgbClr>
             </a:outerShdw>
@@ -24719,7 +24719,7 @@
             <a:avLst/>
           </a:prstGeom>
           <a:solidFill>
-            <a:srgbClr val="4444AD"/>
+            <a:srgbClr val="41639E"/>
           </a:solidFill>
           <a:ln/>
         </p:spPr>
@@ -24859,7 +24859,7 @@
             <a:avLst/>
           </a:prstGeom>
           <a:solidFill>
-            <a:srgbClr val="4444AD"/>
+            <a:srgbClr val="41639E"/>
           </a:solidFill>
           <a:ln/>
         </p:spPr>
@@ -24999,7 +24999,7 @@
             <a:avLst/>
           </a:prstGeom>
           <a:solidFill>
-            <a:srgbClr val="4444AD"/>
+            <a:srgbClr val="41639E"/>
           </a:solidFill>
           <a:ln/>
         </p:spPr>
@@ -25146,7 +25146,7 @@
           <a:ln/>
           <a:effectLst>
             <a:outerShdw sx="100000" sy="100000" kx="0" ky="0" algn="bl" rotWithShape="0" blurRad="127000" dist="25400" dir="5400000">
-              <a:srgbClr val="13134F">
+              <a:srgbClr val="1E2B4A">
                 <a:alpha val="10000"/>
               </a:srgbClr>
             </a:outerShdw>
@@ -25567,7 +25567,7 @@
             <a:avLst/>
           </a:prstGeom>
           <a:solidFill>
-            <a:srgbClr val="4444AD"/>
+            <a:srgbClr val="41639E"/>
           </a:solidFill>
           <a:ln w="31750">
             <a:solidFill>
@@ -25577,7 +25577,7 @@
           </a:ln>
           <a:effectLst>
             <a:outerShdw sx="100000" sy="100000" kx="0" ky="0" algn="bl" rotWithShape="0" blurRad="127000" dist="25400" dir="5400000">
-              <a:srgbClr val="13134F">
+              <a:srgbClr val="1E2B4A">
                 <a:alpha val="18000"/>
               </a:srgbClr>
             </a:outerShdw>
@@ -25623,7 +25623,7 @@
             <a:avLst/>
           </a:prstGeom>
           <a:solidFill>
-            <a:srgbClr val="6E6ECB"/>
+            <a:srgbClr val="C98A24"/>
           </a:solidFill>
           <a:ln w="31750">
             <a:solidFill>
@@ -25633,7 +25633,7 @@
           </a:ln>
           <a:effectLst>
             <a:outerShdw sx="100000" sy="100000" kx="0" ky="0" algn="bl" rotWithShape="0" blurRad="127000" dist="25400" dir="5400000">
-              <a:srgbClr val="13134F">
+              <a:srgbClr val="1E2B4A">
                 <a:alpha val="18000"/>
               </a:srgbClr>
             </a:outerShdw>
@@ -25689,7 +25689,7 @@
           </a:ln>
           <a:effectLst>
             <a:outerShdw sx="100000" sy="100000" kx="0" ky="0" algn="bl" rotWithShape="0" blurRad="127000" dist="25400" dir="5400000">
-              <a:srgbClr val="13134F">
+              <a:srgbClr val="1E2B4A">
                 <a:alpha val="18000"/>
               </a:srgbClr>
             </a:outerShdw>
@@ -25797,7 +25797,7 @@
     <p:bg>
       <p:bgPr>
         <a:solidFill>
-          <a:srgbClr val="101038"/>
+          <a:srgbClr val="16213D"/>
         </a:solidFill>
       </p:bgPr>
     </p:bg>
@@ -25830,7 +25830,7 @@
             <a:avLst/>
           </a:prstGeom>
           <a:solidFill>
-            <a:srgbClr val="23236B"/>
+            <a:srgbClr val="24365E"/>
           </a:solidFill>
           <a:ln/>
         </p:spPr>
@@ -25850,7 +25850,7 @@
             <a:avLst/>
           </a:prstGeom>
           <a:solidFill>
-            <a:srgbClr val="23236B"/>
+            <a:srgbClr val="24365E"/>
           </a:solidFill>
           <a:ln/>
         </p:spPr>
@@ -25963,7 +25963,7 @@
             <a:r>
               <a:rPr lang="en-US" sz="1400" dirty="0">
                 <a:solidFill>
-                  <a:srgbClr val="B7B7DB"/>
+                  <a:srgbClr val="AFC0DA"/>
                 </a:solidFill>
                 <a:latin typeface="Calibri" pitchFamily="34" charset="0"/>
                 <a:ea typeface="Calibri" pitchFamily="34" charset="-122"/>

</xml_diff>

<commit_message>
Colorer les icones de la presentation
Les pastilles passent de l'icone blanche sur disque plein a l'icone
saturee sur un disque eclairci de la meme teinte, avec un fin cerne.
Le rendu est plus lisible sur le fond blanc et chaque famille de
contenu garde sa couleur propre.

Co-Authored-By: Claude <noreply@anthropic.com>
Claude-Session: https://claude.ai/code/session_01837AJxDdpW6rUH9DV9QD1H
</commit_message>
<xml_diff>
--- a/infographie/presentation_infographique.pptx
+++ b/infographie/presentation_infographique.pptx
@@ -3950,18 +3950,18 @@
             <a:avLst/>
           </a:prstGeom>
           <a:solidFill>
-            <a:srgbClr val="41639E"/>
+            <a:srgbClr val="E1E6EF"/>
           </a:solidFill>
-          <a:ln w="31750">
+          <a:ln w="15875">
             <a:solidFill>
-              <a:srgbClr val="FFFFFF"/>
+              <a:srgbClr val="BBC7DC"/>
             </a:solidFill>
             <a:prstDash val="solid"/>
           </a:ln>
           <a:effectLst>
             <a:outerShdw sx="100000" sy="100000" kx="0" ky="0" algn="bl" rotWithShape="0" blurRad="127000" dist="25400" dir="5400000">
               <a:srgbClr val="1E2B4A">
-                <a:alpha val="18000"/>
+                <a:alpha val="8000"/>
               </a:srgbClr>
             </a:outerShdw>
           </a:effectLst>
@@ -4077,18 +4077,18 @@
             <a:avLst/>
           </a:prstGeom>
           <a:solidFill>
-            <a:srgbClr val="3E8C9A"/>
+            <a:srgbClr val="E0EDEF"/>
           </a:solidFill>
-          <a:ln w="31750">
+          <a:ln w="15875">
             <a:solidFill>
-              <a:srgbClr val="FFFFFF"/>
+              <a:srgbClr val="BAD6DB"/>
             </a:solidFill>
             <a:prstDash val="solid"/>
           </a:ln>
           <a:effectLst>
             <a:outerShdw sx="100000" sy="100000" kx="0" ky="0" algn="bl" rotWithShape="0" blurRad="127000" dist="25400" dir="5400000">
               <a:srgbClr val="1E2B4A">
-                <a:alpha val="18000"/>
+                <a:alpha val="8000"/>
               </a:srgbClr>
             </a:outerShdw>
           </a:effectLst>
@@ -4204,18 +4204,18 @@
             <a:avLst/>
           </a:prstGeom>
           <a:solidFill>
-            <a:srgbClr val="41639E"/>
+            <a:srgbClr val="E1E6EF"/>
           </a:solidFill>
-          <a:ln w="31750">
+          <a:ln w="15875">
             <a:solidFill>
-              <a:srgbClr val="FFFFFF"/>
+              <a:srgbClr val="BBC7DC"/>
             </a:solidFill>
             <a:prstDash val="solid"/>
           </a:ln>
           <a:effectLst>
             <a:outerShdw sx="100000" sy="100000" kx="0" ky="0" algn="bl" rotWithShape="0" blurRad="127000" dist="25400" dir="5400000">
               <a:srgbClr val="1E2B4A">
-                <a:alpha val="18000"/>
+                <a:alpha val="8000"/>
               </a:srgbClr>
             </a:outerShdw>
           </a:effectLst>
@@ -4331,18 +4331,18 @@
             <a:avLst/>
           </a:prstGeom>
           <a:solidFill>
-            <a:srgbClr val="D96F2B"/>
+            <a:srgbClr val="F9E8DD"/>
           </a:solidFill>
-          <a:ln w="31750">
+          <a:ln w="15875">
             <a:solidFill>
-              <a:srgbClr val="FFFFFF"/>
+              <a:srgbClr val="F1CBB3"/>
             </a:solidFill>
             <a:prstDash val="solid"/>
           </a:ln>
           <a:effectLst>
             <a:outerShdw sx="100000" sy="100000" kx="0" ky="0" algn="bl" rotWithShape="0" blurRad="127000" dist="25400" dir="5400000">
               <a:srgbClr val="1E2B4A">
-                <a:alpha val="18000"/>
+                <a:alpha val="8000"/>
               </a:srgbClr>
             </a:outerShdw>
           </a:effectLst>
@@ -4458,18 +4458,18 @@
             <a:avLst/>
           </a:prstGeom>
           <a:solidFill>
-            <a:srgbClr val="C98A24"/>
+            <a:srgbClr val="F6ECDC"/>
           </a:solidFill>
-          <a:ln w="31750">
+          <a:ln w="15875">
             <a:solidFill>
-              <a:srgbClr val="FFFFFF"/>
+              <a:srgbClr val="ECD5B0"/>
             </a:solidFill>
             <a:prstDash val="solid"/>
           </a:ln>
           <a:effectLst>
             <a:outerShdw sx="100000" sy="100000" kx="0" ky="0" algn="bl" rotWithShape="0" blurRad="127000" dist="25400" dir="5400000">
               <a:srgbClr val="1E2B4A">
-                <a:alpha val="18000"/>
+                <a:alpha val="8000"/>
               </a:srgbClr>
             </a:outerShdw>
           </a:effectLst>
@@ -4585,18 +4585,18 @@
             <a:avLst/>
           </a:prstGeom>
           <a:solidFill>
-            <a:srgbClr val="3E8C9A"/>
+            <a:srgbClr val="E0EDEF"/>
           </a:solidFill>
-          <a:ln w="31750">
+          <a:ln w="15875">
             <a:solidFill>
-              <a:srgbClr val="FFFFFF"/>
+              <a:srgbClr val="BAD6DB"/>
             </a:solidFill>
             <a:prstDash val="solid"/>
           </a:ln>
           <a:effectLst>
             <a:outerShdw sx="100000" sy="100000" kx="0" ky="0" algn="bl" rotWithShape="0" blurRad="127000" dist="25400" dir="5400000">
               <a:srgbClr val="1E2B4A">
-                <a:alpha val="18000"/>
+                <a:alpha val="8000"/>
               </a:srgbClr>
             </a:outerShdw>
           </a:effectLst>
@@ -4712,18 +4712,18 @@
             <a:avLst/>
           </a:prstGeom>
           <a:solidFill>
-            <a:srgbClr val="41639E"/>
+            <a:srgbClr val="E1E6EF"/>
           </a:solidFill>
-          <a:ln w="31750">
+          <a:ln w="15875">
             <a:solidFill>
-              <a:srgbClr val="FFFFFF"/>
+              <a:srgbClr val="BBC7DC"/>
             </a:solidFill>
             <a:prstDash val="solid"/>
           </a:ln>
           <a:effectLst>
             <a:outerShdw sx="100000" sy="100000" kx="0" ky="0" algn="bl" rotWithShape="0" blurRad="127000" dist="25400" dir="5400000">
               <a:srgbClr val="1E2B4A">
-                <a:alpha val="18000"/>
+                <a:alpha val="8000"/>
               </a:srgbClr>
             </a:outerShdw>
           </a:effectLst>
@@ -6048,18 +6048,18 @@
             <a:avLst/>
           </a:prstGeom>
           <a:solidFill>
-            <a:srgbClr val="3E8C9A"/>
+            <a:srgbClr val="E0EDEF"/>
           </a:solidFill>
-          <a:ln w="31750">
+          <a:ln w="15875">
             <a:solidFill>
-              <a:srgbClr val="FFFFFF"/>
+              <a:srgbClr val="BAD6DB"/>
             </a:solidFill>
             <a:prstDash val="solid"/>
           </a:ln>
           <a:effectLst>
             <a:outerShdw sx="100000" sy="100000" kx="0" ky="0" algn="bl" rotWithShape="0" blurRad="127000" dist="25400" dir="5400000">
               <a:srgbClr val="1E2B4A">
-                <a:alpha val="18000"/>
+                <a:alpha val="8000"/>
               </a:srgbClr>
             </a:outerShdw>
           </a:effectLst>
@@ -6214,18 +6214,18 @@
             <a:avLst/>
           </a:prstGeom>
           <a:solidFill>
-            <a:srgbClr val="C98A24"/>
+            <a:srgbClr val="F6ECDC"/>
           </a:solidFill>
-          <a:ln w="31750">
+          <a:ln w="15875">
             <a:solidFill>
-              <a:srgbClr val="FFFFFF"/>
+              <a:srgbClr val="ECD5B0"/>
             </a:solidFill>
             <a:prstDash val="solid"/>
           </a:ln>
           <a:effectLst>
             <a:outerShdw sx="100000" sy="100000" kx="0" ky="0" algn="bl" rotWithShape="0" blurRad="127000" dist="25400" dir="5400000">
               <a:srgbClr val="1E2B4A">
-                <a:alpha val="18000"/>
+                <a:alpha val="8000"/>
               </a:srgbClr>
             </a:outerShdw>
           </a:effectLst>
@@ -6953,18 +6953,18 @@
             <a:avLst/>
           </a:prstGeom>
           <a:solidFill>
-            <a:srgbClr val="41639E"/>
+            <a:srgbClr val="E1E6EF"/>
           </a:solidFill>
-          <a:ln w="31750">
+          <a:ln w="15875">
             <a:solidFill>
-              <a:srgbClr val="FFFFFF"/>
+              <a:srgbClr val="BBC7DC"/>
             </a:solidFill>
             <a:prstDash val="solid"/>
           </a:ln>
           <a:effectLst>
             <a:outerShdw sx="100000" sy="100000" kx="0" ky="0" algn="bl" rotWithShape="0" blurRad="127000" dist="25400" dir="5400000">
               <a:srgbClr val="1E2B4A">
-                <a:alpha val="18000"/>
+                <a:alpha val="8000"/>
               </a:srgbClr>
             </a:outerShdw>
           </a:effectLst>
@@ -7158,18 +7158,18 @@
             <a:avLst/>
           </a:prstGeom>
           <a:solidFill>
-            <a:srgbClr val="3E8C9A"/>
+            <a:srgbClr val="E0EDEF"/>
           </a:solidFill>
-          <a:ln w="31750">
+          <a:ln w="15875">
             <a:solidFill>
-              <a:srgbClr val="FFFFFF"/>
+              <a:srgbClr val="BAD6DB"/>
             </a:solidFill>
             <a:prstDash val="solid"/>
           </a:ln>
           <a:effectLst>
             <a:outerShdw sx="100000" sy="100000" kx="0" ky="0" algn="bl" rotWithShape="0" blurRad="127000" dist="25400" dir="5400000">
               <a:srgbClr val="1E2B4A">
-                <a:alpha val="18000"/>
+                <a:alpha val="8000"/>
               </a:srgbClr>
             </a:outerShdw>
           </a:effectLst>
@@ -7363,18 +7363,18 @@
             <a:avLst/>
           </a:prstGeom>
           <a:solidFill>
-            <a:srgbClr val="D96F2B"/>
+            <a:srgbClr val="F9E8DD"/>
           </a:solidFill>
-          <a:ln w="31750">
+          <a:ln w="15875">
             <a:solidFill>
-              <a:srgbClr val="FFFFFF"/>
+              <a:srgbClr val="F1CBB3"/>
             </a:solidFill>
             <a:prstDash val="solid"/>
           </a:ln>
           <a:effectLst>
             <a:outerShdw sx="100000" sy="100000" kx="0" ky="0" algn="bl" rotWithShape="0" blurRad="127000" dist="25400" dir="5400000">
               <a:srgbClr val="1E2B4A">
-                <a:alpha val="18000"/>
+                <a:alpha val="8000"/>
               </a:srgbClr>
             </a:outerShdw>
           </a:effectLst>
@@ -13163,18 +13163,18 @@
             <a:avLst/>
           </a:prstGeom>
           <a:solidFill>
-            <a:srgbClr val="D96F2B"/>
+            <a:srgbClr val="F9E8DD"/>
           </a:solidFill>
-          <a:ln w="31750">
+          <a:ln w="15875">
             <a:solidFill>
-              <a:srgbClr val="FFFFFF"/>
+              <a:srgbClr val="F1CBB3"/>
             </a:solidFill>
             <a:prstDash val="solid"/>
           </a:ln>
           <a:effectLst>
             <a:outerShdw sx="100000" sy="100000" kx="0" ky="0" algn="bl" rotWithShape="0" blurRad="127000" dist="25400" dir="5400000">
               <a:srgbClr val="1E2B4A">
-                <a:alpha val="18000"/>
+                <a:alpha val="8000"/>
               </a:srgbClr>
             </a:outerShdw>
           </a:effectLst>
@@ -15373,18 +15373,18 @@
             <a:avLst/>
           </a:prstGeom>
           <a:solidFill>
-            <a:srgbClr val="41639E"/>
+            <a:srgbClr val="E1E6EF"/>
           </a:solidFill>
-          <a:ln w="31750">
+          <a:ln w="15875">
             <a:solidFill>
-              <a:srgbClr val="FFFFFF"/>
+              <a:srgbClr val="BBC7DC"/>
             </a:solidFill>
             <a:prstDash val="solid"/>
           </a:ln>
           <a:effectLst>
             <a:outerShdw sx="100000" sy="100000" kx="0" ky="0" algn="bl" rotWithShape="0" blurRad="127000" dist="25400" dir="5400000">
               <a:srgbClr val="1E2B4A">
-                <a:alpha val="18000"/>
+                <a:alpha val="8000"/>
               </a:srgbClr>
             </a:outerShdw>
           </a:effectLst>
@@ -15575,18 +15575,18 @@
             <a:avLst/>
           </a:prstGeom>
           <a:solidFill>
-            <a:srgbClr val="D96F2B"/>
+            <a:srgbClr val="F9E8DD"/>
           </a:solidFill>
-          <a:ln w="31750">
+          <a:ln w="15875">
             <a:solidFill>
-              <a:srgbClr val="FFFFFF"/>
+              <a:srgbClr val="F1CBB3"/>
             </a:solidFill>
             <a:prstDash val="solid"/>
           </a:ln>
           <a:effectLst>
             <a:outerShdw sx="100000" sy="100000" kx="0" ky="0" algn="bl" rotWithShape="0" blurRad="127000" dist="25400" dir="5400000">
               <a:srgbClr val="1E2B4A">
-                <a:alpha val="18000"/>
+                <a:alpha val="8000"/>
               </a:srgbClr>
             </a:outerShdw>
           </a:effectLst>
@@ -15777,18 +15777,18 @@
             <a:avLst/>
           </a:prstGeom>
           <a:solidFill>
-            <a:srgbClr val="3E8C9A"/>
+            <a:srgbClr val="E0EDEF"/>
           </a:solidFill>
-          <a:ln w="31750">
+          <a:ln w="15875">
             <a:solidFill>
-              <a:srgbClr val="FFFFFF"/>
+              <a:srgbClr val="BAD6DB"/>
             </a:solidFill>
             <a:prstDash val="solid"/>
           </a:ln>
           <a:effectLst>
             <a:outerShdw sx="100000" sy="100000" kx="0" ky="0" algn="bl" rotWithShape="0" blurRad="127000" dist="25400" dir="5400000">
               <a:srgbClr val="1E2B4A">
-                <a:alpha val="18000"/>
+                <a:alpha val="8000"/>
               </a:srgbClr>
             </a:outerShdw>
           </a:effectLst>
@@ -15979,18 +15979,18 @@
             <a:avLst/>
           </a:prstGeom>
           <a:solidFill>
-            <a:srgbClr val="C98A24"/>
+            <a:srgbClr val="F6ECDC"/>
           </a:solidFill>
-          <a:ln w="31750">
+          <a:ln w="15875">
             <a:solidFill>
-              <a:srgbClr val="FFFFFF"/>
+              <a:srgbClr val="ECD5B0"/>
             </a:solidFill>
             <a:prstDash val="solid"/>
           </a:ln>
           <a:effectLst>
             <a:outerShdw sx="100000" sy="100000" kx="0" ky="0" algn="bl" rotWithShape="0" blurRad="127000" dist="25400" dir="5400000">
               <a:srgbClr val="1E2B4A">
-                <a:alpha val="18000"/>
+                <a:alpha val="8000"/>
               </a:srgbClr>
             </a:outerShdw>
           </a:effectLst>
@@ -16181,18 +16181,18 @@
             <a:avLst/>
           </a:prstGeom>
           <a:solidFill>
-            <a:srgbClr val="41639E"/>
+            <a:srgbClr val="E1E6EF"/>
           </a:solidFill>
-          <a:ln w="31750">
+          <a:ln w="15875">
             <a:solidFill>
-              <a:srgbClr val="FFFFFF"/>
+              <a:srgbClr val="BBC7DC"/>
             </a:solidFill>
             <a:prstDash val="solid"/>
           </a:ln>
           <a:effectLst>
             <a:outerShdw sx="100000" sy="100000" kx="0" ky="0" algn="bl" rotWithShape="0" blurRad="127000" dist="25400" dir="5400000">
               <a:srgbClr val="1E2B4A">
-                <a:alpha val="18000"/>
+                <a:alpha val="8000"/>
               </a:srgbClr>
             </a:outerShdw>
           </a:effectLst>
@@ -16383,18 +16383,18 @@
             <a:avLst/>
           </a:prstGeom>
           <a:solidFill>
-            <a:srgbClr val="D96F2B"/>
+            <a:srgbClr val="F9E8DD"/>
           </a:solidFill>
-          <a:ln w="31750">
+          <a:ln w="15875">
             <a:solidFill>
-              <a:srgbClr val="FFFFFF"/>
+              <a:srgbClr val="F1CBB3"/>
             </a:solidFill>
             <a:prstDash val="solid"/>
           </a:ln>
           <a:effectLst>
             <a:outerShdw sx="100000" sy="100000" kx="0" ky="0" algn="bl" rotWithShape="0" blurRad="127000" dist="25400" dir="5400000">
               <a:srgbClr val="1E2B4A">
-                <a:alpha val="18000"/>
+                <a:alpha val="8000"/>
               </a:srgbClr>
             </a:outerShdw>
           </a:effectLst>
@@ -16719,18 +16719,18 @@
             <a:avLst/>
           </a:prstGeom>
           <a:solidFill>
-            <a:srgbClr val="41639E"/>
+            <a:srgbClr val="E1E6EF"/>
           </a:solidFill>
-          <a:ln w="31750">
+          <a:ln w="15875">
             <a:solidFill>
-              <a:srgbClr val="FFFFFF"/>
+              <a:srgbClr val="BBC7DC"/>
             </a:solidFill>
             <a:prstDash val="solid"/>
           </a:ln>
           <a:effectLst>
             <a:outerShdw sx="100000" sy="100000" kx="0" ky="0" algn="bl" rotWithShape="0" blurRad="127000" dist="25400" dir="5400000">
               <a:srgbClr val="1E2B4A">
-                <a:alpha val="18000"/>
+                <a:alpha val="8000"/>
               </a:srgbClr>
             </a:outerShdw>
           </a:effectLst>
@@ -16924,18 +16924,18 @@
             <a:avLst/>
           </a:prstGeom>
           <a:solidFill>
-            <a:srgbClr val="3E8C9A"/>
+            <a:srgbClr val="E0EDEF"/>
           </a:solidFill>
-          <a:ln w="31750">
+          <a:ln w="15875">
             <a:solidFill>
-              <a:srgbClr val="FFFFFF"/>
+              <a:srgbClr val="BAD6DB"/>
             </a:solidFill>
             <a:prstDash val="solid"/>
           </a:ln>
           <a:effectLst>
             <a:outerShdw sx="100000" sy="100000" kx="0" ky="0" algn="bl" rotWithShape="0" blurRad="127000" dist="25400" dir="5400000">
               <a:srgbClr val="1E2B4A">
-                <a:alpha val="18000"/>
+                <a:alpha val="8000"/>
               </a:srgbClr>
             </a:outerShdw>
           </a:effectLst>
@@ -17129,18 +17129,18 @@
             <a:avLst/>
           </a:prstGeom>
           <a:solidFill>
-            <a:srgbClr val="C98A24"/>
+            <a:srgbClr val="F6ECDC"/>
           </a:solidFill>
-          <a:ln w="31750">
+          <a:ln w="15875">
             <a:solidFill>
-              <a:srgbClr val="FFFFFF"/>
+              <a:srgbClr val="ECD5B0"/>
             </a:solidFill>
             <a:prstDash val="solid"/>
           </a:ln>
           <a:effectLst>
             <a:outerShdw sx="100000" sy="100000" kx="0" ky="0" algn="bl" rotWithShape="0" blurRad="127000" dist="25400" dir="5400000">
               <a:srgbClr val="1E2B4A">
-                <a:alpha val="18000"/>
+                <a:alpha val="8000"/>
               </a:srgbClr>
             </a:outerShdw>
           </a:effectLst>
@@ -17334,18 +17334,18 @@
             <a:avLst/>
           </a:prstGeom>
           <a:solidFill>
-            <a:srgbClr val="D96F2B"/>
+            <a:srgbClr val="F9E8DD"/>
           </a:solidFill>
-          <a:ln w="31750">
+          <a:ln w="15875">
             <a:solidFill>
-              <a:srgbClr val="FFFFFF"/>
+              <a:srgbClr val="F1CBB3"/>
             </a:solidFill>
             <a:prstDash val="solid"/>
           </a:ln>
           <a:effectLst>
             <a:outerShdw sx="100000" sy="100000" kx="0" ky="0" algn="bl" rotWithShape="0" blurRad="127000" dist="25400" dir="5400000">
               <a:srgbClr val="1E2B4A">
-                <a:alpha val="18000"/>
+                <a:alpha val="8000"/>
               </a:srgbClr>
             </a:outerShdw>
           </a:effectLst>
@@ -18094,18 +18094,18 @@
             <a:avLst/>
           </a:prstGeom>
           <a:solidFill>
-            <a:srgbClr val="D96F2B"/>
+            <a:srgbClr val="F9E8DD"/>
           </a:solidFill>
-          <a:ln w="31750">
+          <a:ln w="15875">
             <a:solidFill>
-              <a:srgbClr val="FFFFFF"/>
+              <a:srgbClr val="F1CBB3"/>
             </a:solidFill>
             <a:prstDash val="solid"/>
           </a:ln>
           <a:effectLst>
             <a:outerShdw sx="100000" sy="100000" kx="0" ky="0" algn="bl" rotWithShape="0" blurRad="127000" dist="25400" dir="5400000">
               <a:srgbClr val="1E2B4A">
-                <a:alpha val="18000"/>
+                <a:alpha val="8000"/>
               </a:srgbClr>
             </a:outerShdw>
           </a:effectLst>
@@ -18150,18 +18150,18 @@
             <a:avLst/>
           </a:prstGeom>
           <a:solidFill>
-            <a:srgbClr val="3E8C9A"/>
+            <a:srgbClr val="E0EDEF"/>
           </a:solidFill>
-          <a:ln w="31750">
+          <a:ln w="15875">
             <a:solidFill>
-              <a:srgbClr val="FFFFFF"/>
+              <a:srgbClr val="BAD6DB"/>
             </a:solidFill>
             <a:prstDash val="solid"/>
           </a:ln>
           <a:effectLst>
             <a:outerShdw sx="100000" sy="100000" kx="0" ky="0" algn="bl" rotWithShape="0" blurRad="127000" dist="25400" dir="5400000">
               <a:srgbClr val="1E2B4A">
-                <a:alpha val="18000"/>
+                <a:alpha val="8000"/>
               </a:srgbClr>
             </a:outerShdw>
           </a:effectLst>
@@ -18411,18 +18411,18 @@
             <a:avLst/>
           </a:prstGeom>
           <a:solidFill>
-            <a:srgbClr val="C98A24"/>
+            <a:srgbClr val="F6ECDC"/>
           </a:solidFill>
-          <a:ln w="31750">
+          <a:ln w="15875">
             <a:solidFill>
-              <a:srgbClr val="FFFFFF"/>
+              <a:srgbClr val="ECD5B0"/>
             </a:solidFill>
             <a:prstDash val="solid"/>
           </a:ln>
           <a:effectLst>
             <a:outerShdw sx="100000" sy="100000" kx="0" ky="0" algn="bl" rotWithShape="0" blurRad="127000" dist="25400" dir="5400000">
               <a:srgbClr val="1E2B4A">
-                <a:alpha val="18000"/>
+                <a:alpha val="8000"/>
               </a:srgbClr>
             </a:outerShdw>
           </a:effectLst>
@@ -18580,18 +18580,18 @@
             <a:avLst/>
           </a:prstGeom>
           <a:solidFill>
-            <a:srgbClr val="41639E"/>
+            <a:srgbClr val="E1E6EF"/>
           </a:solidFill>
-          <a:ln w="31750">
+          <a:ln w="15875">
             <a:solidFill>
-              <a:srgbClr val="FFFFFF"/>
+              <a:srgbClr val="BBC7DC"/>
             </a:solidFill>
             <a:prstDash val="solid"/>
           </a:ln>
           <a:effectLst>
             <a:outerShdw sx="100000" sy="100000" kx="0" ky="0" algn="bl" rotWithShape="0" blurRad="127000" dist="25400" dir="5400000">
               <a:srgbClr val="1E2B4A">
-                <a:alpha val="18000"/>
+                <a:alpha val="8000"/>
               </a:srgbClr>
             </a:outerShdw>
           </a:effectLst>
@@ -18749,18 +18749,18 @@
             <a:avLst/>
           </a:prstGeom>
           <a:solidFill>
-            <a:srgbClr val="3E8C9A"/>
+            <a:srgbClr val="E0EDEF"/>
           </a:solidFill>
-          <a:ln w="31750">
+          <a:ln w="15875">
             <a:solidFill>
-              <a:srgbClr val="FFFFFF"/>
+              <a:srgbClr val="BAD6DB"/>
             </a:solidFill>
             <a:prstDash val="solid"/>
           </a:ln>
           <a:effectLst>
             <a:outerShdw sx="100000" sy="100000" kx="0" ky="0" algn="bl" rotWithShape="0" blurRad="127000" dist="25400" dir="5400000">
               <a:srgbClr val="1E2B4A">
-                <a:alpha val="18000"/>
+                <a:alpha val="8000"/>
               </a:srgbClr>
             </a:outerShdw>
           </a:effectLst>
@@ -19052,18 +19052,18 @@
             <a:avLst/>
           </a:prstGeom>
           <a:solidFill>
-            <a:srgbClr val="D96F2B"/>
+            <a:srgbClr val="F9E8DD"/>
           </a:solidFill>
-          <a:ln w="31750">
+          <a:ln w="15875">
             <a:solidFill>
-              <a:srgbClr val="FFFFFF"/>
+              <a:srgbClr val="F1CBB3"/>
             </a:solidFill>
             <a:prstDash val="solid"/>
           </a:ln>
           <a:effectLst>
             <a:outerShdw sx="100000" sy="100000" kx="0" ky="0" algn="bl" rotWithShape="0" blurRad="127000" dist="25400" dir="5400000">
               <a:srgbClr val="1E2B4A">
-                <a:alpha val="18000"/>
+                <a:alpha val="8000"/>
               </a:srgbClr>
             </a:outerShdw>
           </a:effectLst>
@@ -19338,18 +19338,18 @@
             <a:avLst/>
           </a:prstGeom>
           <a:solidFill>
-            <a:srgbClr val="3E8C9A"/>
+            <a:srgbClr val="E0EDEF"/>
           </a:solidFill>
-          <a:ln w="31750">
+          <a:ln w="15875">
             <a:solidFill>
-              <a:srgbClr val="FFFFFF"/>
+              <a:srgbClr val="BAD6DB"/>
             </a:solidFill>
             <a:prstDash val="solid"/>
           </a:ln>
           <a:effectLst>
             <a:outerShdw sx="100000" sy="100000" kx="0" ky="0" algn="bl" rotWithShape="0" blurRad="127000" dist="25400" dir="5400000">
               <a:srgbClr val="1E2B4A">
-                <a:alpha val="18000"/>
+                <a:alpha val="8000"/>
               </a:srgbClr>
             </a:outerShdw>
           </a:effectLst>
@@ -20934,18 +20934,18 @@
             <a:avLst/>
           </a:prstGeom>
           <a:solidFill>
-            <a:srgbClr val="C98A24"/>
+            <a:srgbClr val="F6ECDC"/>
           </a:solidFill>
-          <a:ln w="31750">
+          <a:ln w="15875">
             <a:solidFill>
-              <a:srgbClr val="FFFFFF"/>
+              <a:srgbClr val="ECD5B0"/>
             </a:solidFill>
             <a:prstDash val="solid"/>
           </a:ln>
           <a:effectLst>
             <a:outerShdw sx="100000" sy="100000" kx="0" ky="0" algn="bl" rotWithShape="0" blurRad="127000" dist="25400" dir="5400000">
               <a:srgbClr val="1E2B4A">
-                <a:alpha val="18000"/>
+                <a:alpha val="8000"/>
               </a:srgbClr>
             </a:outerShdw>
           </a:effectLst>
@@ -21103,18 +21103,18 @@
             <a:avLst/>
           </a:prstGeom>
           <a:solidFill>
-            <a:srgbClr val="41639E"/>
+            <a:srgbClr val="E1E6EF"/>
           </a:solidFill>
-          <a:ln w="31750">
+          <a:ln w="15875">
             <a:solidFill>
-              <a:srgbClr val="FFFFFF"/>
+              <a:srgbClr val="BBC7DC"/>
             </a:solidFill>
             <a:prstDash val="solid"/>
           </a:ln>
           <a:effectLst>
             <a:outerShdw sx="100000" sy="100000" kx="0" ky="0" algn="bl" rotWithShape="0" blurRad="127000" dist="25400" dir="5400000">
               <a:srgbClr val="1E2B4A">
-                <a:alpha val="18000"/>
+                <a:alpha val="8000"/>
               </a:srgbClr>
             </a:outerShdw>
           </a:effectLst>
@@ -21272,18 +21272,18 @@
             <a:avLst/>
           </a:prstGeom>
           <a:solidFill>
-            <a:srgbClr val="3E8C9A"/>
+            <a:srgbClr val="E0EDEF"/>
           </a:solidFill>
-          <a:ln w="31750">
+          <a:ln w="15875">
             <a:solidFill>
-              <a:srgbClr val="FFFFFF"/>
+              <a:srgbClr val="BAD6DB"/>
             </a:solidFill>
             <a:prstDash val="solid"/>
           </a:ln>
           <a:effectLst>
             <a:outerShdw sx="100000" sy="100000" kx="0" ky="0" algn="bl" rotWithShape="0" blurRad="127000" dist="25400" dir="5400000">
               <a:srgbClr val="1E2B4A">
-                <a:alpha val="18000"/>
+                <a:alpha val="8000"/>
               </a:srgbClr>
             </a:outerShdw>
           </a:effectLst>
@@ -21956,18 +21956,18 @@
             <a:avLst/>
           </a:prstGeom>
           <a:solidFill>
-            <a:srgbClr val="41639E"/>
+            <a:srgbClr val="E1E6EF"/>
           </a:solidFill>
-          <a:ln w="31750">
+          <a:ln w="15875">
             <a:solidFill>
-              <a:srgbClr val="FFFFFF"/>
+              <a:srgbClr val="BBC7DC"/>
             </a:solidFill>
             <a:prstDash val="solid"/>
           </a:ln>
           <a:effectLst>
             <a:outerShdw sx="100000" sy="100000" kx="0" ky="0" algn="bl" rotWithShape="0" blurRad="127000" dist="25400" dir="5400000">
               <a:srgbClr val="1E2B4A">
-                <a:alpha val="18000"/>
+                <a:alpha val="8000"/>
               </a:srgbClr>
             </a:outerShdw>
           </a:effectLst>
@@ -22366,18 +22366,18 @@
             <a:avLst/>
           </a:prstGeom>
           <a:solidFill>
-            <a:srgbClr val="D96F2B"/>
+            <a:srgbClr val="F9E8DD"/>
           </a:solidFill>
-          <a:ln w="31750">
+          <a:ln w="15875">
             <a:solidFill>
-              <a:srgbClr val="FFFFFF"/>
+              <a:srgbClr val="F1CBB3"/>
             </a:solidFill>
             <a:prstDash val="solid"/>
           </a:ln>
           <a:effectLst>
             <a:outerShdw sx="100000" sy="100000" kx="0" ky="0" algn="bl" rotWithShape="0" blurRad="127000" dist="25400" dir="5400000">
               <a:srgbClr val="1E2B4A">
-                <a:alpha val="18000"/>
+                <a:alpha val="8000"/>
               </a:srgbClr>
             </a:outerShdw>
           </a:effectLst>
@@ -23311,18 +23311,18 @@
             <a:avLst/>
           </a:prstGeom>
           <a:solidFill>
-            <a:srgbClr val="D96F2B"/>
+            <a:srgbClr val="F9E8DD"/>
           </a:solidFill>
-          <a:ln w="31750">
+          <a:ln w="15875">
             <a:solidFill>
-              <a:srgbClr val="FFFFFF"/>
+              <a:srgbClr val="F1CBB3"/>
             </a:solidFill>
             <a:prstDash val="solid"/>
           </a:ln>
           <a:effectLst>
             <a:outerShdw sx="100000" sy="100000" kx="0" ky="0" algn="bl" rotWithShape="0" blurRad="127000" dist="25400" dir="5400000">
               <a:srgbClr val="1E2B4A">
-                <a:alpha val="18000"/>
+                <a:alpha val="8000"/>
               </a:srgbClr>
             </a:outerShdw>
           </a:effectLst>
@@ -23367,18 +23367,18 @@
             <a:avLst/>
           </a:prstGeom>
           <a:solidFill>
-            <a:srgbClr val="C98A24"/>
+            <a:srgbClr val="F6ECDC"/>
           </a:solidFill>
-          <a:ln w="31750">
+          <a:ln w="15875">
             <a:solidFill>
-              <a:srgbClr val="FFFFFF"/>
+              <a:srgbClr val="ECD5B0"/>
             </a:solidFill>
             <a:prstDash val="solid"/>
           </a:ln>
           <a:effectLst>
             <a:outerShdw sx="100000" sy="100000" kx="0" ky="0" algn="bl" rotWithShape="0" blurRad="127000" dist="25400" dir="5400000">
               <a:srgbClr val="1E2B4A">
-                <a:alpha val="18000"/>
+                <a:alpha val="8000"/>
               </a:srgbClr>
             </a:outerShdw>
           </a:effectLst>
@@ -23423,18 +23423,18 @@
             <a:avLst/>
           </a:prstGeom>
           <a:solidFill>
-            <a:srgbClr val="3E8C9A"/>
+            <a:srgbClr val="E0EDEF"/>
           </a:solidFill>
-          <a:ln w="31750">
+          <a:ln w="15875">
             <a:solidFill>
-              <a:srgbClr val="FFFFFF"/>
+              <a:srgbClr val="BAD6DB"/>
             </a:solidFill>
             <a:prstDash val="solid"/>
           </a:ln>
           <a:effectLst>
             <a:outerShdw sx="100000" sy="100000" kx="0" ky="0" algn="bl" rotWithShape="0" blurRad="127000" dist="25400" dir="5400000">
               <a:srgbClr val="1E2B4A">
-                <a:alpha val="18000"/>
+                <a:alpha val="8000"/>
               </a:srgbClr>
             </a:outerShdw>
           </a:effectLst>
@@ -23642,18 +23642,18 @@
             <a:avLst/>
           </a:prstGeom>
           <a:solidFill>
-            <a:srgbClr val="41639E"/>
+            <a:srgbClr val="E1E6EF"/>
           </a:solidFill>
-          <a:ln w="31750">
+          <a:ln w="15875">
             <a:solidFill>
-              <a:srgbClr val="FFFFFF"/>
+              <a:srgbClr val="BBC7DC"/>
             </a:solidFill>
             <a:prstDash val="solid"/>
           </a:ln>
           <a:effectLst>
             <a:outerShdw sx="100000" sy="100000" kx="0" ky="0" algn="bl" rotWithShape="0" blurRad="127000" dist="25400" dir="5400000">
               <a:srgbClr val="1E2B4A">
-                <a:alpha val="18000"/>
+                <a:alpha val="8000"/>
               </a:srgbClr>
             </a:outerShdw>
           </a:effectLst>
@@ -24010,18 +24010,18 @@
             <a:avLst/>
           </a:prstGeom>
           <a:solidFill>
-            <a:srgbClr val="D96F2B"/>
+            <a:srgbClr val="F9E8DD"/>
           </a:solidFill>
-          <a:ln w="31750">
+          <a:ln w="15875">
             <a:solidFill>
-              <a:srgbClr val="FFFFFF"/>
+              <a:srgbClr val="F1CBB3"/>
             </a:solidFill>
             <a:prstDash val="solid"/>
           </a:ln>
           <a:effectLst>
             <a:outerShdw sx="100000" sy="100000" kx="0" ky="0" algn="bl" rotWithShape="0" blurRad="127000" dist="25400" dir="5400000">
               <a:srgbClr val="1E2B4A">
-                <a:alpha val="18000"/>
+                <a:alpha val="8000"/>
               </a:srgbClr>
             </a:outerShdw>
           </a:effectLst>
@@ -25567,18 +25567,18 @@
             <a:avLst/>
           </a:prstGeom>
           <a:solidFill>
-            <a:srgbClr val="41639E"/>
+            <a:srgbClr val="E1E6EF"/>
           </a:solidFill>
-          <a:ln w="31750">
+          <a:ln w="15875">
             <a:solidFill>
-              <a:srgbClr val="FFFFFF"/>
+              <a:srgbClr val="BBC7DC"/>
             </a:solidFill>
             <a:prstDash val="solid"/>
           </a:ln>
           <a:effectLst>
             <a:outerShdw sx="100000" sy="100000" kx="0" ky="0" algn="bl" rotWithShape="0" blurRad="127000" dist="25400" dir="5400000">
               <a:srgbClr val="1E2B4A">
-                <a:alpha val="18000"/>
+                <a:alpha val="8000"/>
               </a:srgbClr>
             </a:outerShdw>
           </a:effectLst>
@@ -25623,18 +25623,18 @@
             <a:avLst/>
           </a:prstGeom>
           <a:solidFill>
-            <a:srgbClr val="C98A24"/>
+            <a:srgbClr val="F6ECDC"/>
           </a:solidFill>
-          <a:ln w="31750">
+          <a:ln w="15875">
             <a:solidFill>
-              <a:srgbClr val="FFFFFF"/>
+              <a:srgbClr val="ECD5B0"/>
             </a:solidFill>
             <a:prstDash val="solid"/>
           </a:ln>
           <a:effectLst>
             <a:outerShdw sx="100000" sy="100000" kx="0" ky="0" algn="bl" rotWithShape="0" blurRad="127000" dist="25400" dir="5400000">
               <a:srgbClr val="1E2B4A">
-                <a:alpha val="18000"/>
+                <a:alpha val="8000"/>
               </a:srgbClr>
             </a:outerShdw>
           </a:effectLst>
@@ -25679,18 +25679,18 @@
             <a:avLst/>
           </a:prstGeom>
           <a:solidFill>
-            <a:srgbClr val="D96F2B"/>
+            <a:srgbClr val="F9E8DD"/>
           </a:solidFill>
-          <a:ln w="31750">
+          <a:ln w="15875">
             <a:solidFill>
-              <a:srgbClr val="FFFFFF"/>
+              <a:srgbClr val="F1CBB3"/>
             </a:solidFill>
             <a:prstDash val="solid"/>
           </a:ln>
           <a:effectLst>
             <a:outerShdw sx="100000" sy="100000" kx="0" ky="0" algn="bl" rotWithShape="0" blurRad="127000" dist="25400" dir="5400000">
               <a:srgbClr val="1E2B4A">
-                <a:alpha val="18000"/>
+                <a:alpha val="8000"/>
               </a:srgbClr>
             </a:outerShdw>
           </a:effectLst>

</xml_diff>

<commit_message>
Mettre les chiffres en encre neutre
Les valeurs numeriques ne sont plus coloriees : elles passent toutes
en encre sombre. La couleur reste portee par les barres, les icones
et les asterisques de significativite.

Co-Authored-By: Claude <noreply@anthropic.com>
Claude-Session: https://claude.ai/code/session_01837AJxDdpW6rUH9DV9QD1H
</commit_message>
<xml_diff>
--- a/infographie/presentation_infographique.pptx
+++ b/infographie/presentation_infographique.pptx
@@ -5020,7 +5020,7 @@
             <a:r>
               <a:rPr lang="en-US" sz="1250" b="1" dirty="0">
                 <a:solidFill>
-                  <a:srgbClr val="D96F2B"/>
+                  <a:srgbClr val="1D2433"/>
                 </a:solidFill>
                 <a:latin typeface="Calibri" pitchFamily="34" charset="0"/>
                 <a:ea typeface="Calibri" pitchFamily="34" charset="-122"/>
@@ -5098,7 +5098,7 @@
             <a:r>
               <a:rPr lang="en-US" sz="1250" b="1" dirty="0">
                 <a:solidFill>
-                  <a:srgbClr val="D96F2B"/>
+                  <a:srgbClr val="1D2433"/>
                 </a:solidFill>
                 <a:latin typeface="Calibri" pitchFamily="34" charset="0"/>
                 <a:ea typeface="Calibri" pitchFamily="34" charset="-122"/>
@@ -5176,7 +5176,7 @@
             <a:r>
               <a:rPr lang="en-US" sz="1250" b="1" dirty="0">
                 <a:solidFill>
-                  <a:srgbClr val="D96F2B"/>
+                  <a:srgbClr val="1D2433"/>
                 </a:solidFill>
                 <a:latin typeface="Calibri" pitchFamily="34" charset="0"/>
                 <a:ea typeface="Calibri" pitchFamily="34" charset="-122"/>
@@ -5540,7 +5540,7 @@
             <a:r>
               <a:rPr lang="en-US" sz="3200" b="1" dirty="0">
                 <a:solidFill>
-                  <a:srgbClr val="41639E"/>
+                  <a:srgbClr val="1E2B4A"/>
                 </a:solidFill>
                 <a:latin typeface="Calibri" pitchFamily="34" charset="0"/>
                 <a:ea typeface="Calibri" pitchFamily="34" charset="-122"/>
@@ -5670,7 +5670,7 @@
             <a:r>
               <a:rPr lang="en-US" sz="3200" b="1" dirty="0">
                 <a:solidFill>
-                  <a:srgbClr val="41639E"/>
+                  <a:srgbClr val="1E2B4A"/>
                 </a:solidFill>
                 <a:latin typeface="Calibri" pitchFamily="34" charset="0"/>
                 <a:ea typeface="Calibri" pitchFamily="34" charset="-122"/>
@@ -5800,7 +5800,7 @@
             <a:r>
               <a:rPr lang="en-US" sz="3200" b="1" dirty="0">
                 <a:solidFill>
-                  <a:srgbClr val="D96F2B"/>
+                  <a:srgbClr val="1E2B4A"/>
                 </a:solidFill>
                 <a:latin typeface="Calibri" pitchFamily="34" charset="0"/>
                 <a:ea typeface="Calibri" pitchFamily="34" charset="-122"/>
@@ -5930,7 +5930,7 @@
             <a:r>
               <a:rPr lang="en-US" sz="3200" b="1" dirty="0">
                 <a:solidFill>
-                  <a:srgbClr val="D96F2B"/>
+                  <a:srgbClr val="1E2B4A"/>
                 </a:solidFill>
                 <a:latin typeface="Calibri" pitchFamily="34" charset="0"/>
                 <a:ea typeface="Calibri" pitchFamily="34" charset="-122"/>
@@ -9605,7 +9605,7 @@
             <a:r>
               <a:rPr lang="en-US" sz="3000" b="1" dirty="0">
                 <a:solidFill>
-                  <a:srgbClr val="8A93A5"/>
+                  <a:srgbClr val="1E2B4A"/>
                 </a:solidFill>
                 <a:latin typeface="Calibri" pitchFamily="34" charset="0"/>
                 <a:ea typeface="Calibri" pitchFamily="34" charset="-122"/>
@@ -9735,7 +9735,7 @@
             <a:r>
               <a:rPr lang="en-US" sz="3000" b="1" dirty="0">
                 <a:solidFill>
-                  <a:srgbClr val="3E8C9A"/>
+                  <a:srgbClr val="1E2B4A"/>
                 </a:solidFill>
                 <a:latin typeface="Calibri" pitchFamily="34" charset="0"/>
                 <a:ea typeface="Calibri" pitchFamily="34" charset="-122"/>
@@ -9865,7 +9865,7 @@
             <a:r>
               <a:rPr lang="en-US" sz="3000" b="1" dirty="0">
                 <a:solidFill>
-                  <a:srgbClr val="41639E"/>
+                  <a:srgbClr val="1E2B4A"/>
                 </a:solidFill>
                 <a:latin typeface="Calibri" pitchFamily="34" charset="0"/>
                 <a:ea typeface="Calibri" pitchFamily="34" charset="-122"/>
@@ -9995,7 +9995,7 @@
             <a:r>
               <a:rPr lang="en-US" sz="3000" b="1" dirty="0">
                 <a:solidFill>
-                  <a:srgbClr val="41639E"/>
+                  <a:srgbClr val="1E2B4A"/>
                 </a:solidFill>
                 <a:latin typeface="Calibri" pitchFamily="34" charset="0"/>
                 <a:ea typeface="Calibri" pitchFamily="34" charset="-122"/>
@@ -12468,7 +12468,7 @@
             <a:r>
               <a:rPr lang="en-US" sz="1200" b="1" dirty="0">
                 <a:solidFill>
-                  <a:srgbClr val="D96F2B"/>
+                  <a:srgbClr val="1D2433"/>
                 </a:solidFill>
                 <a:latin typeface="Calibri" pitchFamily="34" charset="0"/>
                 <a:ea typeface="Calibri" pitchFamily="34" charset="-122"/>
@@ -12607,7 +12607,7 @@
             <a:r>
               <a:rPr lang="en-US" sz="1200" b="1" dirty="0">
                 <a:solidFill>
-                  <a:srgbClr val="4A5468"/>
+                  <a:srgbClr val="1D2433"/>
                 </a:solidFill>
                 <a:latin typeface="Calibri" pitchFamily="34" charset="0"/>
                 <a:ea typeface="Calibri" pitchFamily="34" charset="-122"/>
@@ -12707,7 +12707,7 @@
             <a:r>
               <a:rPr lang="en-US" sz="1200" b="1" dirty="0">
                 <a:solidFill>
-                  <a:srgbClr val="4A5468"/>
+                  <a:srgbClr val="1D2433"/>
                 </a:solidFill>
                 <a:latin typeface="Calibri" pitchFamily="34" charset="0"/>
                 <a:ea typeface="Calibri" pitchFamily="34" charset="-122"/>
@@ -12807,7 +12807,7 @@
             <a:r>
               <a:rPr lang="en-US" sz="1200" b="1" dirty="0">
                 <a:solidFill>
-                  <a:srgbClr val="4A5468"/>
+                  <a:srgbClr val="1D2433"/>
                 </a:solidFill>
                 <a:latin typeface="Calibri" pitchFamily="34" charset="0"/>
                 <a:ea typeface="Calibri" pitchFamily="34" charset="-122"/>
@@ -12907,7 +12907,7 @@
             <a:r>
               <a:rPr lang="en-US" sz="1200" b="1" dirty="0">
                 <a:solidFill>
-                  <a:srgbClr val="4A5468"/>
+                  <a:srgbClr val="1D2433"/>
                 </a:solidFill>
                 <a:latin typeface="Calibri" pitchFamily="34" charset="0"/>
                 <a:ea typeface="Calibri" pitchFamily="34" charset="-122"/>
@@ -13007,7 +13007,7 @@
             <a:r>
               <a:rPr lang="en-US" sz="1200" b="1" dirty="0">
                 <a:solidFill>
-                  <a:srgbClr val="4A5468"/>
+                  <a:srgbClr val="1D2433"/>
                 </a:solidFill>
                 <a:latin typeface="Calibri" pitchFamily="34" charset="0"/>
                 <a:ea typeface="Calibri" pitchFamily="34" charset="-122"/>
@@ -13107,7 +13107,7 @@
             <a:r>
               <a:rPr lang="en-US" sz="1200" b="1" dirty="0">
                 <a:solidFill>
-                  <a:srgbClr val="4A5468"/>
+                  <a:srgbClr val="1D2433"/>
                 </a:solidFill>
                 <a:latin typeface="Calibri" pitchFamily="34" charset="0"/>
                 <a:ea typeface="Calibri" pitchFamily="34" charset="-122"/>
@@ -13939,7 +13939,7 @@
             <a:r>
               <a:rPr lang="en-US" sz="1300" b="1" dirty="0">
                 <a:solidFill>
-                  <a:srgbClr val="D96F2B"/>
+                  <a:srgbClr val="1D2433"/>
                 </a:solidFill>
                 <a:latin typeface="Calibri" pitchFamily="34" charset="0"/>
                 <a:ea typeface="Calibri" pitchFamily="34" charset="-122"/>
@@ -14039,7 +14039,7 @@
             <a:r>
               <a:rPr lang="en-US" sz="1200" b="1" dirty="0">
                 <a:solidFill>
-                  <a:srgbClr val="D96F2B"/>
+                  <a:srgbClr val="1D2433"/>
                 </a:solidFill>
                 <a:latin typeface="Calibri" pitchFamily="34" charset="0"/>
                 <a:ea typeface="Calibri" pitchFamily="34" charset="-122"/>
@@ -14117,7 +14117,7 @@
             <a:r>
               <a:rPr lang="en-US" sz="1300" b="1" dirty="0">
                 <a:solidFill>
-                  <a:srgbClr val="D96F2B"/>
+                  <a:srgbClr val="1D2433"/>
                 </a:solidFill>
                 <a:latin typeface="Calibri" pitchFamily="34" charset="0"/>
                 <a:ea typeface="Calibri" pitchFamily="34" charset="-122"/>
@@ -14217,7 +14217,7 @@
             <a:r>
               <a:rPr lang="en-US" sz="1200" b="1" dirty="0">
                 <a:solidFill>
-                  <a:srgbClr val="D96F2B"/>
+                  <a:srgbClr val="1D2433"/>
                 </a:solidFill>
                 <a:latin typeface="Calibri" pitchFamily="34" charset="0"/>
                 <a:ea typeface="Calibri" pitchFamily="34" charset="-122"/>
@@ -14295,7 +14295,7 @@
             <a:r>
               <a:rPr lang="en-US" sz="1300" b="1" dirty="0">
                 <a:solidFill>
-                  <a:srgbClr val="4A5468"/>
+                  <a:srgbClr val="1D2433"/>
                 </a:solidFill>
                 <a:latin typeface="Calibri" pitchFamily="34" charset="0"/>
                 <a:ea typeface="Calibri" pitchFamily="34" charset="-122"/>
@@ -14395,7 +14395,7 @@
             <a:r>
               <a:rPr lang="en-US" sz="1200" b="1" dirty="0">
                 <a:solidFill>
-                  <a:srgbClr val="4A5468"/>
+                  <a:srgbClr val="1D2433"/>
                 </a:solidFill>
                 <a:latin typeface="Calibri" pitchFamily="34" charset="0"/>
                 <a:ea typeface="Calibri" pitchFamily="34" charset="-122"/>
@@ -14434,7 +14434,7 @@
             <a:r>
               <a:rPr lang="en-US" sz="1300" b="1" dirty="0">
                 <a:solidFill>
-                  <a:srgbClr val="4A5468"/>
+                  <a:srgbClr val="1D2433"/>
                 </a:solidFill>
                 <a:latin typeface="Calibri" pitchFamily="34" charset="0"/>
                 <a:ea typeface="Calibri" pitchFamily="34" charset="-122"/>
@@ -14534,7 +14534,7 @@
             <a:r>
               <a:rPr lang="en-US" sz="1200" b="1" dirty="0">
                 <a:solidFill>
-                  <a:srgbClr val="4A5468"/>
+                  <a:srgbClr val="1D2433"/>
                 </a:solidFill>
                 <a:latin typeface="Calibri" pitchFamily="34" charset="0"/>
                 <a:ea typeface="Calibri" pitchFamily="34" charset="-122"/>
@@ -14573,7 +14573,7 @@
             <a:r>
               <a:rPr lang="en-US" sz="1300" b="1" dirty="0">
                 <a:solidFill>
-                  <a:srgbClr val="4A5468"/>
+                  <a:srgbClr val="1D2433"/>
                 </a:solidFill>
                 <a:latin typeface="Calibri" pitchFamily="34" charset="0"/>
                 <a:ea typeface="Calibri" pitchFamily="34" charset="-122"/>
@@ -14673,7 +14673,7 @@
             <a:r>
               <a:rPr lang="en-US" sz="1200" b="1" dirty="0">
                 <a:solidFill>
-                  <a:srgbClr val="4A5468"/>
+                  <a:srgbClr val="1D2433"/>
                 </a:solidFill>
                 <a:latin typeface="Calibri" pitchFamily="34" charset="0"/>
                 <a:ea typeface="Calibri" pitchFamily="34" charset="-122"/>
@@ -22066,7 +22066,7 @@
             <a:r>
               <a:rPr lang="en-US" sz="3400" b="1" dirty="0">
                 <a:solidFill>
-                  <a:srgbClr val="41639E"/>
+                  <a:srgbClr val="1E2B4A"/>
                 </a:solidFill>
                 <a:latin typeface="Calibri" pitchFamily="34" charset="0"/>
                 <a:ea typeface="Calibri" pitchFamily="34" charset="-122"/>
@@ -22167,7 +22167,7 @@
             <a:r>
               <a:rPr lang="en-US" sz="3400" b="1" dirty="0">
                 <a:solidFill>
-                  <a:srgbClr val="41639E"/>
+                  <a:srgbClr val="1E2B4A"/>
                 </a:solidFill>
                 <a:latin typeface="Calibri" pitchFamily="34" charset="0"/>
                 <a:ea typeface="Calibri" pitchFamily="34" charset="-122"/>
@@ -22476,7 +22476,7 @@
             <a:r>
               <a:rPr lang="en-US" sz="3400" b="1" dirty="0">
                 <a:solidFill>
-                  <a:srgbClr val="D96F2B"/>
+                  <a:srgbClr val="1E2B4A"/>
                 </a:solidFill>
                 <a:latin typeface="Calibri" pitchFamily="34" charset="0"/>
                 <a:ea typeface="Calibri" pitchFamily="34" charset="-122"/>
@@ -22577,7 +22577,7 @@
             <a:r>
               <a:rPr lang="en-US" sz="3400" b="1" dirty="0">
                 <a:solidFill>
-                  <a:srgbClr val="D96F2B"/>
+                  <a:srgbClr val="1E2B4A"/>
                 </a:solidFill>
                 <a:latin typeface="Calibri" pitchFamily="34" charset="0"/>
                 <a:ea typeface="Calibri" pitchFamily="34" charset="-122"/>

</xml_diff>

<commit_message>
Colorer les icônes et neutraliser la couleur des chiffres (#703)
* Colorer les icones de la presentation

Les pastilles passent de l'icone blanche sur disque plein a l'icone
saturee sur un disque eclairci de la meme teinte, avec un fin cerne.
Le rendu est plus lisible sur le fond blanc et chaque famille de
contenu garde sa couleur propre.

Co-Authored-By: Claude <noreply@anthropic.com>
Claude-Session: https://claude.ai/code/session_01837AJxDdpW6rUH9DV9QD1H

* Mettre les chiffres en encre neutre

Les valeurs numeriques ne sont plus coloriees : elles passent toutes
en encre sombre. La couleur reste portee par les barres, les icones
et les asterisques de significativite.

Co-Authored-By: Claude <noreply@anthropic.com>
Claude-Session: https://claude.ai/code/session_01837AJxDdpW6rUH9DV9QD1H

---------

Co-authored-by: Claude <noreply@anthropic.com>
</commit_message>
<xml_diff>
--- a/infographie/presentation_infographique.pptx
+++ b/infographie/presentation_infographique.pptx
@@ -3950,18 +3950,18 @@
             <a:avLst/>
           </a:prstGeom>
           <a:solidFill>
-            <a:srgbClr val="41639E"/>
+            <a:srgbClr val="E1E6EF"/>
           </a:solidFill>
-          <a:ln w="31750">
+          <a:ln w="15875">
             <a:solidFill>
-              <a:srgbClr val="FFFFFF"/>
+              <a:srgbClr val="BBC7DC"/>
             </a:solidFill>
             <a:prstDash val="solid"/>
           </a:ln>
           <a:effectLst>
             <a:outerShdw sx="100000" sy="100000" kx="0" ky="0" algn="bl" rotWithShape="0" blurRad="127000" dist="25400" dir="5400000">
               <a:srgbClr val="1E2B4A">
-                <a:alpha val="18000"/>
+                <a:alpha val="8000"/>
               </a:srgbClr>
             </a:outerShdw>
           </a:effectLst>
@@ -4077,18 +4077,18 @@
             <a:avLst/>
           </a:prstGeom>
           <a:solidFill>
-            <a:srgbClr val="3E8C9A"/>
+            <a:srgbClr val="E0EDEF"/>
           </a:solidFill>
-          <a:ln w="31750">
+          <a:ln w="15875">
             <a:solidFill>
-              <a:srgbClr val="FFFFFF"/>
+              <a:srgbClr val="BAD6DB"/>
             </a:solidFill>
             <a:prstDash val="solid"/>
           </a:ln>
           <a:effectLst>
             <a:outerShdw sx="100000" sy="100000" kx="0" ky="0" algn="bl" rotWithShape="0" blurRad="127000" dist="25400" dir="5400000">
               <a:srgbClr val="1E2B4A">
-                <a:alpha val="18000"/>
+                <a:alpha val="8000"/>
               </a:srgbClr>
             </a:outerShdw>
           </a:effectLst>
@@ -4204,18 +4204,18 @@
             <a:avLst/>
           </a:prstGeom>
           <a:solidFill>
-            <a:srgbClr val="41639E"/>
+            <a:srgbClr val="E1E6EF"/>
           </a:solidFill>
-          <a:ln w="31750">
+          <a:ln w="15875">
             <a:solidFill>
-              <a:srgbClr val="FFFFFF"/>
+              <a:srgbClr val="BBC7DC"/>
             </a:solidFill>
             <a:prstDash val="solid"/>
           </a:ln>
           <a:effectLst>
             <a:outerShdw sx="100000" sy="100000" kx="0" ky="0" algn="bl" rotWithShape="0" blurRad="127000" dist="25400" dir="5400000">
               <a:srgbClr val="1E2B4A">
-                <a:alpha val="18000"/>
+                <a:alpha val="8000"/>
               </a:srgbClr>
             </a:outerShdw>
           </a:effectLst>
@@ -4331,18 +4331,18 @@
             <a:avLst/>
           </a:prstGeom>
           <a:solidFill>
-            <a:srgbClr val="D96F2B"/>
+            <a:srgbClr val="F9E8DD"/>
           </a:solidFill>
-          <a:ln w="31750">
+          <a:ln w="15875">
             <a:solidFill>
-              <a:srgbClr val="FFFFFF"/>
+              <a:srgbClr val="F1CBB3"/>
             </a:solidFill>
             <a:prstDash val="solid"/>
           </a:ln>
           <a:effectLst>
             <a:outerShdw sx="100000" sy="100000" kx="0" ky="0" algn="bl" rotWithShape="0" blurRad="127000" dist="25400" dir="5400000">
               <a:srgbClr val="1E2B4A">
-                <a:alpha val="18000"/>
+                <a:alpha val="8000"/>
               </a:srgbClr>
             </a:outerShdw>
           </a:effectLst>
@@ -4458,18 +4458,18 @@
             <a:avLst/>
           </a:prstGeom>
           <a:solidFill>
-            <a:srgbClr val="C98A24"/>
+            <a:srgbClr val="F6ECDC"/>
           </a:solidFill>
-          <a:ln w="31750">
+          <a:ln w="15875">
             <a:solidFill>
-              <a:srgbClr val="FFFFFF"/>
+              <a:srgbClr val="ECD5B0"/>
             </a:solidFill>
             <a:prstDash val="solid"/>
           </a:ln>
           <a:effectLst>
             <a:outerShdw sx="100000" sy="100000" kx="0" ky="0" algn="bl" rotWithShape="0" blurRad="127000" dist="25400" dir="5400000">
               <a:srgbClr val="1E2B4A">
-                <a:alpha val="18000"/>
+                <a:alpha val="8000"/>
               </a:srgbClr>
             </a:outerShdw>
           </a:effectLst>
@@ -4585,18 +4585,18 @@
             <a:avLst/>
           </a:prstGeom>
           <a:solidFill>
-            <a:srgbClr val="3E8C9A"/>
+            <a:srgbClr val="E0EDEF"/>
           </a:solidFill>
-          <a:ln w="31750">
+          <a:ln w="15875">
             <a:solidFill>
-              <a:srgbClr val="FFFFFF"/>
+              <a:srgbClr val="BAD6DB"/>
             </a:solidFill>
             <a:prstDash val="solid"/>
           </a:ln>
           <a:effectLst>
             <a:outerShdw sx="100000" sy="100000" kx="0" ky="0" algn="bl" rotWithShape="0" blurRad="127000" dist="25400" dir="5400000">
               <a:srgbClr val="1E2B4A">
-                <a:alpha val="18000"/>
+                <a:alpha val="8000"/>
               </a:srgbClr>
             </a:outerShdw>
           </a:effectLst>
@@ -4712,18 +4712,18 @@
             <a:avLst/>
           </a:prstGeom>
           <a:solidFill>
-            <a:srgbClr val="41639E"/>
+            <a:srgbClr val="E1E6EF"/>
           </a:solidFill>
-          <a:ln w="31750">
+          <a:ln w="15875">
             <a:solidFill>
-              <a:srgbClr val="FFFFFF"/>
+              <a:srgbClr val="BBC7DC"/>
             </a:solidFill>
             <a:prstDash val="solid"/>
           </a:ln>
           <a:effectLst>
             <a:outerShdw sx="100000" sy="100000" kx="0" ky="0" algn="bl" rotWithShape="0" blurRad="127000" dist="25400" dir="5400000">
               <a:srgbClr val="1E2B4A">
-                <a:alpha val="18000"/>
+                <a:alpha val="8000"/>
               </a:srgbClr>
             </a:outerShdw>
           </a:effectLst>
@@ -5020,7 +5020,7 @@
             <a:r>
               <a:rPr lang="en-US" sz="1250" b="1" dirty="0">
                 <a:solidFill>
-                  <a:srgbClr val="D96F2B"/>
+                  <a:srgbClr val="1D2433"/>
                 </a:solidFill>
                 <a:latin typeface="Calibri" pitchFamily="34" charset="0"/>
                 <a:ea typeface="Calibri" pitchFamily="34" charset="-122"/>
@@ -5098,7 +5098,7 @@
             <a:r>
               <a:rPr lang="en-US" sz="1250" b="1" dirty="0">
                 <a:solidFill>
-                  <a:srgbClr val="D96F2B"/>
+                  <a:srgbClr val="1D2433"/>
                 </a:solidFill>
                 <a:latin typeface="Calibri" pitchFamily="34" charset="0"/>
                 <a:ea typeface="Calibri" pitchFamily="34" charset="-122"/>
@@ -5176,7 +5176,7 @@
             <a:r>
               <a:rPr lang="en-US" sz="1250" b="1" dirty="0">
                 <a:solidFill>
-                  <a:srgbClr val="D96F2B"/>
+                  <a:srgbClr val="1D2433"/>
                 </a:solidFill>
                 <a:latin typeface="Calibri" pitchFamily="34" charset="0"/>
                 <a:ea typeface="Calibri" pitchFamily="34" charset="-122"/>
@@ -5540,7 +5540,7 @@
             <a:r>
               <a:rPr lang="en-US" sz="3200" b="1" dirty="0">
                 <a:solidFill>
-                  <a:srgbClr val="41639E"/>
+                  <a:srgbClr val="1E2B4A"/>
                 </a:solidFill>
                 <a:latin typeface="Calibri" pitchFamily="34" charset="0"/>
                 <a:ea typeface="Calibri" pitchFamily="34" charset="-122"/>
@@ -5670,7 +5670,7 @@
             <a:r>
               <a:rPr lang="en-US" sz="3200" b="1" dirty="0">
                 <a:solidFill>
-                  <a:srgbClr val="41639E"/>
+                  <a:srgbClr val="1E2B4A"/>
                 </a:solidFill>
                 <a:latin typeface="Calibri" pitchFamily="34" charset="0"/>
                 <a:ea typeface="Calibri" pitchFamily="34" charset="-122"/>
@@ -5800,7 +5800,7 @@
             <a:r>
               <a:rPr lang="en-US" sz="3200" b="1" dirty="0">
                 <a:solidFill>
-                  <a:srgbClr val="D96F2B"/>
+                  <a:srgbClr val="1E2B4A"/>
                 </a:solidFill>
                 <a:latin typeface="Calibri" pitchFamily="34" charset="0"/>
                 <a:ea typeface="Calibri" pitchFamily="34" charset="-122"/>
@@ -5930,7 +5930,7 @@
             <a:r>
               <a:rPr lang="en-US" sz="3200" b="1" dirty="0">
                 <a:solidFill>
-                  <a:srgbClr val="D96F2B"/>
+                  <a:srgbClr val="1E2B4A"/>
                 </a:solidFill>
                 <a:latin typeface="Calibri" pitchFamily="34" charset="0"/>
                 <a:ea typeface="Calibri" pitchFamily="34" charset="-122"/>
@@ -6048,18 +6048,18 @@
             <a:avLst/>
           </a:prstGeom>
           <a:solidFill>
-            <a:srgbClr val="3E8C9A"/>
+            <a:srgbClr val="E0EDEF"/>
           </a:solidFill>
-          <a:ln w="31750">
+          <a:ln w="15875">
             <a:solidFill>
-              <a:srgbClr val="FFFFFF"/>
+              <a:srgbClr val="BAD6DB"/>
             </a:solidFill>
             <a:prstDash val="solid"/>
           </a:ln>
           <a:effectLst>
             <a:outerShdw sx="100000" sy="100000" kx="0" ky="0" algn="bl" rotWithShape="0" blurRad="127000" dist="25400" dir="5400000">
               <a:srgbClr val="1E2B4A">
-                <a:alpha val="18000"/>
+                <a:alpha val="8000"/>
               </a:srgbClr>
             </a:outerShdw>
           </a:effectLst>
@@ -6214,18 +6214,18 @@
             <a:avLst/>
           </a:prstGeom>
           <a:solidFill>
-            <a:srgbClr val="C98A24"/>
+            <a:srgbClr val="F6ECDC"/>
           </a:solidFill>
-          <a:ln w="31750">
+          <a:ln w="15875">
             <a:solidFill>
-              <a:srgbClr val="FFFFFF"/>
+              <a:srgbClr val="ECD5B0"/>
             </a:solidFill>
             <a:prstDash val="solid"/>
           </a:ln>
           <a:effectLst>
             <a:outerShdw sx="100000" sy="100000" kx="0" ky="0" algn="bl" rotWithShape="0" blurRad="127000" dist="25400" dir="5400000">
               <a:srgbClr val="1E2B4A">
-                <a:alpha val="18000"/>
+                <a:alpha val="8000"/>
               </a:srgbClr>
             </a:outerShdw>
           </a:effectLst>
@@ -6953,18 +6953,18 @@
             <a:avLst/>
           </a:prstGeom>
           <a:solidFill>
-            <a:srgbClr val="41639E"/>
+            <a:srgbClr val="E1E6EF"/>
           </a:solidFill>
-          <a:ln w="31750">
+          <a:ln w="15875">
             <a:solidFill>
-              <a:srgbClr val="FFFFFF"/>
+              <a:srgbClr val="BBC7DC"/>
             </a:solidFill>
             <a:prstDash val="solid"/>
           </a:ln>
           <a:effectLst>
             <a:outerShdw sx="100000" sy="100000" kx="0" ky="0" algn="bl" rotWithShape="0" blurRad="127000" dist="25400" dir="5400000">
               <a:srgbClr val="1E2B4A">
-                <a:alpha val="18000"/>
+                <a:alpha val="8000"/>
               </a:srgbClr>
             </a:outerShdw>
           </a:effectLst>
@@ -7158,18 +7158,18 @@
             <a:avLst/>
           </a:prstGeom>
           <a:solidFill>
-            <a:srgbClr val="3E8C9A"/>
+            <a:srgbClr val="E0EDEF"/>
           </a:solidFill>
-          <a:ln w="31750">
+          <a:ln w="15875">
             <a:solidFill>
-              <a:srgbClr val="FFFFFF"/>
+              <a:srgbClr val="BAD6DB"/>
             </a:solidFill>
             <a:prstDash val="solid"/>
           </a:ln>
           <a:effectLst>
             <a:outerShdw sx="100000" sy="100000" kx="0" ky="0" algn="bl" rotWithShape="0" blurRad="127000" dist="25400" dir="5400000">
               <a:srgbClr val="1E2B4A">
-                <a:alpha val="18000"/>
+                <a:alpha val="8000"/>
               </a:srgbClr>
             </a:outerShdw>
           </a:effectLst>
@@ -7363,18 +7363,18 @@
             <a:avLst/>
           </a:prstGeom>
           <a:solidFill>
-            <a:srgbClr val="D96F2B"/>
+            <a:srgbClr val="F9E8DD"/>
           </a:solidFill>
-          <a:ln w="31750">
+          <a:ln w="15875">
             <a:solidFill>
-              <a:srgbClr val="FFFFFF"/>
+              <a:srgbClr val="F1CBB3"/>
             </a:solidFill>
             <a:prstDash val="solid"/>
           </a:ln>
           <a:effectLst>
             <a:outerShdw sx="100000" sy="100000" kx="0" ky="0" algn="bl" rotWithShape="0" blurRad="127000" dist="25400" dir="5400000">
               <a:srgbClr val="1E2B4A">
-                <a:alpha val="18000"/>
+                <a:alpha val="8000"/>
               </a:srgbClr>
             </a:outerShdw>
           </a:effectLst>
@@ -9605,7 +9605,7 @@
             <a:r>
               <a:rPr lang="en-US" sz="3000" b="1" dirty="0">
                 <a:solidFill>
-                  <a:srgbClr val="8A93A5"/>
+                  <a:srgbClr val="1E2B4A"/>
                 </a:solidFill>
                 <a:latin typeface="Calibri" pitchFamily="34" charset="0"/>
                 <a:ea typeface="Calibri" pitchFamily="34" charset="-122"/>
@@ -9735,7 +9735,7 @@
             <a:r>
               <a:rPr lang="en-US" sz="3000" b="1" dirty="0">
                 <a:solidFill>
-                  <a:srgbClr val="3E8C9A"/>
+                  <a:srgbClr val="1E2B4A"/>
                 </a:solidFill>
                 <a:latin typeface="Calibri" pitchFamily="34" charset="0"/>
                 <a:ea typeface="Calibri" pitchFamily="34" charset="-122"/>
@@ -9865,7 +9865,7 @@
             <a:r>
               <a:rPr lang="en-US" sz="3000" b="1" dirty="0">
                 <a:solidFill>
-                  <a:srgbClr val="41639E"/>
+                  <a:srgbClr val="1E2B4A"/>
                 </a:solidFill>
                 <a:latin typeface="Calibri" pitchFamily="34" charset="0"/>
                 <a:ea typeface="Calibri" pitchFamily="34" charset="-122"/>
@@ -9995,7 +9995,7 @@
             <a:r>
               <a:rPr lang="en-US" sz="3000" b="1" dirty="0">
                 <a:solidFill>
-                  <a:srgbClr val="41639E"/>
+                  <a:srgbClr val="1E2B4A"/>
                 </a:solidFill>
                 <a:latin typeface="Calibri" pitchFamily="34" charset="0"/>
                 <a:ea typeface="Calibri" pitchFamily="34" charset="-122"/>
@@ -12468,7 +12468,7 @@
             <a:r>
               <a:rPr lang="en-US" sz="1200" b="1" dirty="0">
                 <a:solidFill>
-                  <a:srgbClr val="D96F2B"/>
+                  <a:srgbClr val="1D2433"/>
                 </a:solidFill>
                 <a:latin typeface="Calibri" pitchFamily="34" charset="0"/>
                 <a:ea typeface="Calibri" pitchFamily="34" charset="-122"/>
@@ -12607,7 +12607,7 @@
             <a:r>
               <a:rPr lang="en-US" sz="1200" b="1" dirty="0">
                 <a:solidFill>
-                  <a:srgbClr val="4A5468"/>
+                  <a:srgbClr val="1D2433"/>
                 </a:solidFill>
                 <a:latin typeface="Calibri" pitchFamily="34" charset="0"/>
                 <a:ea typeface="Calibri" pitchFamily="34" charset="-122"/>
@@ -12707,7 +12707,7 @@
             <a:r>
               <a:rPr lang="en-US" sz="1200" b="1" dirty="0">
                 <a:solidFill>
-                  <a:srgbClr val="4A5468"/>
+                  <a:srgbClr val="1D2433"/>
                 </a:solidFill>
                 <a:latin typeface="Calibri" pitchFamily="34" charset="0"/>
                 <a:ea typeface="Calibri" pitchFamily="34" charset="-122"/>
@@ -12807,7 +12807,7 @@
             <a:r>
               <a:rPr lang="en-US" sz="1200" b="1" dirty="0">
                 <a:solidFill>
-                  <a:srgbClr val="4A5468"/>
+                  <a:srgbClr val="1D2433"/>
                 </a:solidFill>
                 <a:latin typeface="Calibri" pitchFamily="34" charset="0"/>
                 <a:ea typeface="Calibri" pitchFamily="34" charset="-122"/>
@@ -12907,7 +12907,7 @@
             <a:r>
               <a:rPr lang="en-US" sz="1200" b="1" dirty="0">
                 <a:solidFill>
-                  <a:srgbClr val="4A5468"/>
+                  <a:srgbClr val="1D2433"/>
                 </a:solidFill>
                 <a:latin typeface="Calibri" pitchFamily="34" charset="0"/>
                 <a:ea typeface="Calibri" pitchFamily="34" charset="-122"/>
@@ -13007,7 +13007,7 @@
             <a:r>
               <a:rPr lang="en-US" sz="1200" b="1" dirty="0">
                 <a:solidFill>
-                  <a:srgbClr val="4A5468"/>
+                  <a:srgbClr val="1D2433"/>
                 </a:solidFill>
                 <a:latin typeface="Calibri" pitchFamily="34" charset="0"/>
                 <a:ea typeface="Calibri" pitchFamily="34" charset="-122"/>
@@ -13107,7 +13107,7 @@
             <a:r>
               <a:rPr lang="en-US" sz="1200" b="1" dirty="0">
                 <a:solidFill>
-                  <a:srgbClr val="4A5468"/>
+                  <a:srgbClr val="1D2433"/>
                 </a:solidFill>
                 <a:latin typeface="Calibri" pitchFamily="34" charset="0"/>
                 <a:ea typeface="Calibri" pitchFamily="34" charset="-122"/>
@@ -13163,18 +13163,18 @@
             <a:avLst/>
           </a:prstGeom>
           <a:solidFill>
-            <a:srgbClr val="D96F2B"/>
+            <a:srgbClr val="F9E8DD"/>
           </a:solidFill>
-          <a:ln w="31750">
+          <a:ln w="15875">
             <a:solidFill>
-              <a:srgbClr val="FFFFFF"/>
+              <a:srgbClr val="F1CBB3"/>
             </a:solidFill>
             <a:prstDash val="solid"/>
           </a:ln>
           <a:effectLst>
             <a:outerShdw sx="100000" sy="100000" kx="0" ky="0" algn="bl" rotWithShape="0" blurRad="127000" dist="25400" dir="5400000">
               <a:srgbClr val="1E2B4A">
-                <a:alpha val="18000"/>
+                <a:alpha val="8000"/>
               </a:srgbClr>
             </a:outerShdw>
           </a:effectLst>
@@ -13939,7 +13939,7 @@
             <a:r>
               <a:rPr lang="en-US" sz="1300" b="1" dirty="0">
                 <a:solidFill>
-                  <a:srgbClr val="D96F2B"/>
+                  <a:srgbClr val="1D2433"/>
                 </a:solidFill>
                 <a:latin typeface="Calibri" pitchFamily="34" charset="0"/>
                 <a:ea typeface="Calibri" pitchFamily="34" charset="-122"/>
@@ -14039,7 +14039,7 @@
             <a:r>
               <a:rPr lang="en-US" sz="1200" b="1" dirty="0">
                 <a:solidFill>
-                  <a:srgbClr val="D96F2B"/>
+                  <a:srgbClr val="1D2433"/>
                 </a:solidFill>
                 <a:latin typeface="Calibri" pitchFamily="34" charset="0"/>
                 <a:ea typeface="Calibri" pitchFamily="34" charset="-122"/>
@@ -14117,7 +14117,7 @@
             <a:r>
               <a:rPr lang="en-US" sz="1300" b="1" dirty="0">
                 <a:solidFill>
-                  <a:srgbClr val="D96F2B"/>
+                  <a:srgbClr val="1D2433"/>
                 </a:solidFill>
                 <a:latin typeface="Calibri" pitchFamily="34" charset="0"/>
                 <a:ea typeface="Calibri" pitchFamily="34" charset="-122"/>
@@ -14217,7 +14217,7 @@
             <a:r>
               <a:rPr lang="en-US" sz="1200" b="1" dirty="0">
                 <a:solidFill>
-                  <a:srgbClr val="D96F2B"/>
+                  <a:srgbClr val="1D2433"/>
                 </a:solidFill>
                 <a:latin typeface="Calibri" pitchFamily="34" charset="0"/>
                 <a:ea typeface="Calibri" pitchFamily="34" charset="-122"/>
@@ -14295,7 +14295,7 @@
             <a:r>
               <a:rPr lang="en-US" sz="1300" b="1" dirty="0">
                 <a:solidFill>
-                  <a:srgbClr val="4A5468"/>
+                  <a:srgbClr val="1D2433"/>
                 </a:solidFill>
                 <a:latin typeface="Calibri" pitchFamily="34" charset="0"/>
                 <a:ea typeface="Calibri" pitchFamily="34" charset="-122"/>
@@ -14395,7 +14395,7 @@
             <a:r>
               <a:rPr lang="en-US" sz="1200" b="1" dirty="0">
                 <a:solidFill>
-                  <a:srgbClr val="4A5468"/>
+                  <a:srgbClr val="1D2433"/>
                 </a:solidFill>
                 <a:latin typeface="Calibri" pitchFamily="34" charset="0"/>
                 <a:ea typeface="Calibri" pitchFamily="34" charset="-122"/>
@@ -14434,7 +14434,7 @@
             <a:r>
               <a:rPr lang="en-US" sz="1300" b="1" dirty="0">
                 <a:solidFill>
-                  <a:srgbClr val="4A5468"/>
+                  <a:srgbClr val="1D2433"/>
                 </a:solidFill>
                 <a:latin typeface="Calibri" pitchFamily="34" charset="0"/>
                 <a:ea typeface="Calibri" pitchFamily="34" charset="-122"/>
@@ -14534,7 +14534,7 @@
             <a:r>
               <a:rPr lang="en-US" sz="1200" b="1" dirty="0">
                 <a:solidFill>
-                  <a:srgbClr val="4A5468"/>
+                  <a:srgbClr val="1D2433"/>
                 </a:solidFill>
                 <a:latin typeface="Calibri" pitchFamily="34" charset="0"/>
                 <a:ea typeface="Calibri" pitchFamily="34" charset="-122"/>
@@ -14573,7 +14573,7 @@
             <a:r>
               <a:rPr lang="en-US" sz="1300" b="1" dirty="0">
                 <a:solidFill>
-                  <a:srgbClr val="4A5468"/>
+                  <a:srgbClr val="1D2433"/>
                 </a:solidFill>
                 <a:latin typeface="Calibri" pitchFamily="34" charset="0"/>
                 <a:ea typeface="Calibri" pitchFamily="34" charset="-122"/>
@@ -14673,7 +14673,7 @@
             <a:r>
               <a:rPr lang="en-US" sz="1200" b="1" dirty="0">
                 <a:solidFill>
-                  <a:srgbClr val="4A5468"/>
+                  <a:srgbClr val="1D2433"/>
                 </a:solidFill>
                 <a:latin typeface="Calibri" pitchFamily="34" charset="0"/>
                 <a:ea typeface="Calibri" pitchFamily="34" charset="-122"/>
@@ -15373,18 +15373,18 @@
             <a:avLst/>
           </a:prstGeom>
           <a:solidFill>
-            <a:srgbClr val="41639E"/>
+            <a:srgbClr val="E1E6EF"/>
           </a:solidFill>
-          <a:ln w="31750">
+          <a:ln w="15875">
             <a:solidFill>
-              <a:srgbClr val="FFFFFF"/>
+              <a:srgbClr val="BBC7DC"/>
             </a:solidFill>
             <a:prstDash val="solid"/>
           </a:ln>
           <a:effectLst>
             <a:outerShdw sx="100000" sy="100000" kx="0" ky="0" algn="bl" rotWithShape="0" blurRad="127000" dist="25400" dir="5400000">
               <a:srgbClr val="1E2B4A">
-                <a:alpha val="18000"/>
+                <a:alpha val="8000"/>
               </a:srgbClr>
             </a:outerShdw>
           </a:effectLst>
@@ -15575,18 +15575,18 @@
             <a:avLst/>
           </a:prstGeom>
           <a:solidFill>
-            <a:srgbClr val="D96F2B"/>
+            <a:srgbClr val="F9E8DD"/>
           </a:solidFill>
-          <a:ln w="31750">
+          <a:ln w="15875">
             <a:solidFill>
-              <a:srgbClr val="FFFFFF"/>
+              <a:srgbClr val="F1CBB3"/>
             </a:solidFill>
             <a:prstDash val="solid"/>
           </a:ln>
           <a:effectLst>
             <a:outerShdw sx="100000" sy="100000" kx="0" ky="0" algn="bl" rotWithShape="0" blurRad="127000" dist="25400" dir="5400000">
               <a:srgbClr val="1E2B4A">
-                <a:alpha val="18000"/>
+                <a:alpha val="8000"/>
               </a:srgbClr>
             </a:outerShdw>
           </a:effectLst>
@@ -15777,18 +15777,18 @@
             <a:avLst/>
           </a:prstGeom>
           <a:solidFill>
-            <a:srgbClr val="3E8C9A"/>
+            <a:srgbClr val="E0EDEF"/>
           </a:solidFill>
-          <a:ln w="31750">
+          <a:ln w="15875">
             <a:solidFill>
-              <a:srgbClr val="FFFFFF"/>
+              <a:srgbClr val="BAD6DB"/>
             </a:solidFill>
             <a:prstDash val="solid"/>
           </a:ln>
           <a:effectLst>
             <a:outerShdw sx="100000" sy="100000" kx="0" ky="0" algn="bl" rotWithShape="0" blurRad="127000" dist="25400" dir="5400000">
               <a:srgbClr val="1E2B4A">
-                <a:alpha val="18000"/>
+                <a:alpha val="8000"/>
               </a:srgbClr>
             </a:outerShdw>
           </a:effectLst>
@@ -15979,18 +15979,18 @@
             <a:avLst/>
           </a:prstGeom>
           <a:solidFill>
-            <a:srgbClr val="C98A24"/>
+            <a:srgbClr val="F6ECDC"/>
           </a:solidFill>
-          <a:ln w="31750">
+          <a:ln w="15875">
             <a:solidFill>
-              <a:srgbClr val="FFFFFF"/>
+              <a:srgbClr val="ECD5B0"/>
             </a:solidFill>
             <a:prstDash val="solid"/>
           </a:ln>
           <a:effectLst>
             <a:outerShdw sx="100000" sy="100000" kx="0" ky="0" algn="bl" rotWithShape="0" blurRad="127000" dist="25400" dir="5400000">
               <a:srgbClr val="1E2B4A">
-                <a:alpha val="18000"/>
+                <a:alpha val="8000"/>
               </a:srgbClr>
             </a:outerShdw>
           </a:effectLst>
@@ -16181,18 +16181,18 @@
             <a:avLst/>
           </a:prstGeom>
           <a:solidFill>
-            <a:srgbClr val="41639E"/>
+            <a:srgbClr val="E1E6EF"/>
           </a:solidFill>
-          <a:ln w="31750">
+          <a:ln w="15875">
             <a:solidFill>
-              <a:srgbClr val="FFFFFF"/>
+              <a:srgbClr val="BBC7DC"/>
             </a:solidFill>
             <a:prstDash val="solid"/>
           </a:ln>
           <a:effectLst>
             <a:outerShdw sx="100000" sy="100000" kx="0" ky="0" algn="bl" rotWithShape="0" blurRad="127000" dist="25400" dir="5400000">
               <a:srgbClr val="1E2B4A">
-                <a:alpha val="18000"/>
+                <a:alpha val="8000"/>
               </a:srgbClr>
             </a:outerShdw>
           </a:effectLst>
@@ -16383,18 +16383,18 @@
             <a:avLst/>
           </a:prstGeom>
           <a:solidFill>
-            <a:srgbClr val="D96F2B"/>
+            <a:srgbClr val="F9E8DD"/>
           </a:solidFill>
-          <a:ln w="31750">
+          <a:ln w="15875">
             <a:solidFill>
-              <a:srgbClr val="FFFFFF"/>
+              <a:srgbClr val="F1CBB3"/>
             </a:solidFill>
             <a:prstDash val="solid"/>
           </a:ln>
           <a:effectLst>
             <a:outerShdw sx="100000" sy="100000" kx="0" ky="0" algn="bl" rotWithShape="0" blurRad="127000" dist="25400" dir="5400000">
               <a:srgbClr val="1E2B4A">
-                <a:alpha val="18000"/>
+                <a:alpha val="8000"/>
               </a:srgbClr>
             </a:outerShdw>
           </a:effectLst>
@@ -16719,18 +16719,18 @@
             <a:avLst/>
           </a:prstGeom>
           <a:solidFill>
-            <a:srgbClr val="41639E"/>
+            <a:srgbClr val="E1E6EF"/>
           </a:solidFill>
-          <a:ln w="31750">
+          <a:ln w="15875">
             <a:solidFill>
-              <a:srgbClr val="FFFFFF"/>
+              <a:srgbClr val="BBC7DC"/>
             </a:solidFill>
             <a:prstDash val="solid"/>
           </a:ln>
           <a:effectLst>
             <a:outerShdw sx="100000" sy="100000" kx="0" ky="0" algn="bl" rotWithShape="0" blurRad="127000" dist="25400" dir="5400000">
               <a:srgbClr val="1E2B4A">
-                <a:alpha val="18000"/>
+                <a:alpha val="8000"/>
               </a:srgbClr>
             </a:outerShdw>
           </a:effectLst>
@@ -16924,18 +16924,18 @@
             <a:avLst/>
           </a:prstGeom>
           <a:solidFill>
-            <a:srgbClr val="3E8C9A"/>
+            <a:srgbClr val="E0EDEF"/>
           </a:solidFill>
-          <a:ln w="31750">
+          <a:ln w="15875">
             <a:solidFill>
-              <a:srgbClr val="FFFFFF"/>
+              <a:srgbClr val="BAD6DB"/>
             </a:solidFill>
             <a:prstDash val="solid"/>
           </a:ln>
           <a:effectLst>
             <a:outerShdw sx="100000" sy="100000" kx="0" ky="0" algn="bl" rotWithShape="0" blurRad="127000" dist="25400" dir="5400000">
               <a:srgbClr val="1E2B4A">
-                <a:alpha val="18000"/>
+                <a:alpha val="8000"/>
               </a:srgbClr>
             </a:outerShdw>
           </a:effectLst>
@@ -17129,18 +17129,18 @@
             <a:avLst/>
           </a:prstGeom>
           <a:solidFill>
-            <a:srgbClr val="C98A24"/>
+            <a:srgbClr val="F6ECDC"/>
           </a:solidFill>
-          <a:ln w="31750">
+          <a:ln w="15875">
             <a:solidFill>
-              <a:srgbClr val="FFFFFF"/>
+              <a:srgbClr val="ECD5B0"/>
             </a:solidFill>
             <a:prstDash val="solid"/>
           </a:ln>
           <a:effectLst>
             <a:outerShdw sx="100000" sy="100000" kx="0" ky="0" algn="bl" rotWithShape="0" blurRad="127000" dist="25400" dir="5400000">
               <a:srgbClr val="1E2B4A">
-                <a:alpha val="18000"/>
+                <a:alpha val="8000"/>
               </a:srgbClr>
             </a:outerShdw>
           </a:effectLst>
@@ -17334,18 +17334,18 @@
             <a:avLst/>
           </a:prstGeom>
           <a:solidFill>
-            <a:srgbClr val="D96F2B"/>
+            <a:srgbClr val="F9E8DD"/>
           </a:solidFill>
-          <a:ln w="31750">
+          <a:ln w="15875">
             <a:solidFill>
-              <a:srgbClr val="FFFFFF"/>
+              <a:srgbClr val="F1CBB3"/>
             </a:solidFill>
             <a:prstDash val="solid"/>
           </a:ln>
           <a:effectLst>
             <a:outerShdw sx="100000" sy="100000" kx="0" ky="0" algn="bl" rotWithShape="0" blurRad="127000" dist="25400" dir="5400000">
               <a:srgbClr val="1E2B4A">
-                <a:alpha val="18000"/>
+                <a:alpha val="8000"/>
               </a:srgbClr>
             </a:outerShdw>
           </a:effectLst>
@@ -18094,18 +18094,18 @@
             <a:avLst/>
           </a:prstGeom>
           <a:solidFill>
-            <a:srgbClr val="D96F2B"/>
+            <a:srgbClr val="F9E8DD"/>
           </a:solidFill>
-          <a:ln w="31750">
+          <a:ln w="15875">
             <a:solidFill>
-              <a:srgbClr val="FFFFFF"/>
+              <a:srgbClr val="F1CBB3"/>
             </a:solidFill>
             <a:prstDash val="solid"/>
           </a:ln>
           <a:effectLst>
             <a:outerShdw sx="100000" sy="100000" kx="0" ky="0" algn="bl" rotWithShape="0" blurRad="127000" dist="25400" dir="5400000">
               <a:srgbClr val="1E2B4A">
-                <a:alpha val="18000"/>
+                <a:alpha val="8000"/>
               </a:srgbClr>
             </a:outerShdw>
           </a:effectLst>
@@ -18150,18 +18150,18 @@
             <a:avLst/>
           </a:prstGeom>
           <a:solidFill>
-            <a:srgbClr val="3E8C9A"/>
+            <a:srgbClr val="E0EDEF"/>
           </a:solidFill>
-          <a:ln w="31750">
+          <a:ln w="15875">
             <a:solidFill>
-              <a:srgbClr val="FFFFFF"/>
+              <a:srgbClr val="BAD6DB"/>
             </a:solidFill>
             <a:prstDash val="solid"/>
           </a:ln>
           <a:effectLst>
             <a:outerShdw sx="100000" sy="100000" kx="0" ky="0" algn="bl" rotWithShape="0" blurRad="127000" dist="25400" dir="5400000">
               <a:srgbClr val="1E2B4A">
-                <a:alpha val="18000"/>
+                <a:alpha val="8000"/>
               </a:srgbClr>
             </a:outerShdw>
           </a:effectLst>
@@ -18411,18 +18411,18 @@
             <a:avLst/>
           </a:prstGeom>
           <a:solidFill>
-            <a:srgbClr val="C98A24"/>
+            <a:srgbClr val="F6ECDC"/>
           </a:solidFill>
-          <a:ln w="31750">
+          <a:ln w="15875">
             <a:solidFill>
-              <a:srgbClr val="FFFFFF"/>
+              <a:srgbClr val="ECD5B0"/>
             </a:solidFill>
             <a:prstDash val="solid"/>
           </a:ln>
           <a:effectLst>
             <a:outerShdw sx="100000" sy="100000" kx="0" ky="0" algn="bl" rotWithShape="0" blurRad="127000" dist="25400" dir="5400000">
               <a:srgbClr val="1E2B4A">
-                <a:alpha val="18000"/>
+                <a:alpha val="8000"/>
               </a:srgbClr>
             </a:outerShdw>
           </a:effectLst>
@@ -18580,18 +18580,18 @@
             <a:avLst/>
           </a:prstGeom>
           <a:solidFill>
-            <a:srgbClr val="41639E"/>
+            <a:srgbClr val="E1E6EF"/>
           </a:solidFill>
-          <a:ln w="31750">
+          <a:ln w="15875">
             <a:solidFill>
-              <a:srgbClr val="FFFFFF"/>
+              <a:srgbClr val="BBC7DC"/>
             </a:solidFill>
             <a:prstDash val="solid"/>
           </a:ln>
           <a:effectLst>
             <a:outerShdw sx="100000" sy="100000" kx="0" ky="0" algn="bl" rotWithShape="0" blurRad="127000" dist="25400" dir="5400000">
               <a:srgbClr val="1E2B4A">
-                <a:alpha val="18000"/>
+                <a:alpha val="8000"/>
               </a:srgbClr>
             </a:outerShdw>
           </a:effectLst>
@@ -18749,18 +18749,18 @@
             <a:avLst/>
           </a:prstGeom>
           <a:solidFill>
-            <a:srgbClr val="3E8C9A"/>
+            <a:srgbClr val="E0EDEF"/>
           </a:solidFill>
-          <a:ln w="31750">
+          <a:ln w="15875">
             <a:solidFill>
-              <a:srgbClr val="FFFFFF"/>
+              <a:srgbClr val="BAD6DB"/>
             </a:solidFill>
             <a:prstDash val="solid"/>
           </a:ln>
           <a:effectLst>
             <a:outerShdw sx="100000" sy="100000" kx="0" ky="0" algn="bl" rotWithShape="0" blurRad="127000" dist="25400" dir="5400000">
               <a:srgbClr val="1E2B4A">
-                <a:alpha val="18000"/>
+                <a:alpha val="8000"/>
               </a:srgbClr>
             </a:outerShdw>
           </a:effectLst>
@@ -19052,18 +19052,18 @@
             <a:avLst/>
           </a:prstGeom>
           <a:solidFill>
-            <a:srgbClr val="D96F2B"/>
+            <a:srgbClr val="F9E8DD"/>
           </a:solidFill>
-          <a:ln w="31750">
+          <a:ln w="15875">
             <a:solidFill>
-              <a:srgbClr val="FFFFFF"/>
+              <a:srgbClr val="F1CBB3"/>
             </a:solidFill>
             <a:prstDash val="solid"/>
           </a:ln>
           <a:effectLst>
             <a:outerShdw sx="100000" sy="100000" kx="0" ky="0" algn="bl" rotWithShape="0" blurRad="127000" dist="25400" dir="5400000">
               <a:srgbClr val="1E2B4A">
-                <a:alpha val="18000"/>
+                <a:alpha val="8000"/>
               </a:srgbClr>
             </a:outerShdw>
           </a:effectLst>
@@ -19338,18 +19338,18 @@
             <a:avLst/>
           </a:prstGeom>
           <a:solidFill>
-            <a:srgbClr val="3E8C9A"/>
+            <a:srgbClr val="E0EDEF"/>
           </a:solidFill>
-          <a:ln w="31750">
+          <a:ln w="15875">
             <a:solidFill>
-              <a:srgbClr val="FFFFFF"/>
+              <a:srgbClr val="BAD6DB"/>
             </a:solidFill>
             <a:prstDash val="solid"/>
           </a:ln>
           <a:effectLst>
             <a:outerShdw sx="100000" sy="100000" kx="0" ky="0" algn="bl" rotWithShape="0" blurRad="127000" dist="25400" dir="5400000">
               <a:srgbClr val="1E2B4A">
-                <a:alpha val="18000"/>
+                <a:alpha val="8000"/>
               </a:srgbClr>
             </a:outerShdw>
           </a:effectLst>
@@ -20934,18 +20934,18 @@
             <a:avLst/>
           </a:prstGeom>
           <a:solidFill>
-            <a:srgbClr val="C98A24"/>
+            <a:srgbClr val="F6ECDC"/>
           </a:solidFill>
-          <a:ln w="31750">
+          <a:ln w="15875">
             <a:solidFill>
-              <a:srgbClr val="FFFFFF"/>
+              <a:srgbClr val="ECD5B0"/>
             </a:solidFill>
             <a:prstDash val="solid"/>
           </a:ln>
           <a:effectLst>
             <a:outerShdw sx="100000" sy="100000" kx="0" ky="0" algn="bl" rotWithShape="0" blurRad="127000" dist="25400" dir="5400000">
               <a:srgbClr val="1E2B4A">
-                <a:alpha val="18000"/>
+                <a:alpha val="8000"/>
               </a:srgbClr>
             </a:outerShdw>
           </a:effectLst>
@@ -21103,18 +21103,18 @@
             <a:avLst/>
           </a:prstGeom>
           <a:solidFill>
-            <a:srgbClr val="41639E"/>
+            <a:srgbClr val="E1E6EF"/>
           </a:solidFill>
-          <a:ln w="31750">
+          <a:ln w="15875">
             <a:solidFill>
-              <a:srgbClr val="FFFFFF"/>
+              <a:srgbClr val="BBC7DC"/>
             </a:solidFill>
             <a:prstDash val="solid"/>
           </a:ln>
           <a:effectLst>
             <a:outerShdw sx="100000" sy="100000" kx="0" ky="0" algn="bl" rotWithShape="0" blurRad="127000" dist="25400" dir="5400000">
               <a:srgbClr val="1E2B4A">
-                <a:alpha val="18000"/>
+                <a:alpha val="8000"/>
               </a:srgbClr>
             </a:outerShdw>
           </a:effectLst>
@@ -21272,18 +21272,18 @@
             <a:avLst/>
           </a:prstGeom>
           <a:solidFill>
-            <a:srgbClr val="3E8C9A"/>
+            <a:srgbClr val="E0EDEF"/>
           </a:solidFill>
-          <a:ln w="31750">
+          <a:ln w="15875">
             <a:solidFill>
-              <a:srgbClr val="FFFFFF"/>
+              <a:srgbClr val="BAD6DB"/>
             </a:solidFill>
             <a:prstDash val="solid"/>
           </a:ln>
           <a:effectLst>
             <a:outerShdw sx="100000" sy="100000" kx="0" ky="0" algn="bl" rotWithShape="0" blurRad="127000" dist="25400" dir="5400000">
               <a:srgbClr val="1E2B4A">
-                <a:alpha val="18000"/>
+                <a:alpha val="8000"/>
               </a:srgbClr>
             </a:outerShdw>
           </a:effectLst>
@@ -21956,18 +21956,18 @@
             <a:avLst/>
           </a:prstGeom>
           <a:solidFill>
-            <a:srgbClr val="41639E"/>
+            <a:srgbClr val="E1E6EF"/>
           </a:solidFill>
-          <a:ln w="31750">
+          <a:ln w="15875">
             <a:solidFill>
-              <a:srgbClr val="FFFFFF"/>
+              <a:srgbClr val="BBC7DC"/>
             </a:solidFill>
             <a:prstDash val="solid"/>
           </a:ln>
           <a:effectLst>
             <a:outerShdw sx="100000" sy="100000" kx="0" ky="0" algn="bl" rotWithShape="0" blurRad="127000" dist="25400" dir="5400000">
               <a:srgbClr val="1E2B4A">
-                <a:alpha val="18000"/>
+                <a:alpha val="8000"/>
               </a:srgbClr>
             </a:outerShdw>
           </a:effectLst>
@@ -22066,7 +22066,7 @@
             <a:r>
               <a:rPr lang="en-US" sz="3400" b="1" dirty="0">
                 <a:solidFill>
-                  <a:srgbClr val="41639E"/>
+                  <a:srgbClr val="1E2B4A"/>
                 </a:solidFill>
                 <a:latin typeface="Calibri" pitchFamily="34" charset="0"/>
                 <a:ea typeface="Calibri" pitchFamily="34" charset="-122"/>
@@ -22167,7 +22167,7 @@
             <a:r>
               <a:rPr lang="en-US" sz="3400" b="1" dirty="0">
                 <a:solidFill>
-                  <a:srgbClr val="41639E"/>
+                  <a:srgbClr val="1E2B4A"/>
                 </a:solidFill>
                 <a:latin typeface="Calibri" pitchFamily="34" charset="0"/>
                 <a:ea typeface="Calibri" pitchFamily="34" charset="-122"/>
@@ -22366,18 +22366,18 @@
             <a:avLst/>
           </a:prstGeom>
           <a:solidFill>
-            <a:srgbClr val="D96F2B"/>
+            <a:srgbClr val="F9E8DD"/>
           </a:solidFill>
-          <a:ln w="31750">
+          <a:ln w="15875">
             <a:solidFill>
-              <a:srgbClr val="FFFFFF"/>
+              <a:srgbClr val="F1CBB3"/>
             </a:solidFill>
             <a:prstDash val="solid"/>
           </a:ln>
           <a:effectLst>
             <a:outerShdw sx="100000" sy="100000" kx="0" ky="0" algn="bl" rotWithShape="0" blurRad="127000" dist="25400" dir="5400000">
               <a:srgbClr val="1E2B4A">
-                <a:alpha val="18000"/>
+                <a:alpha val="8000"/>
               </a:srgbClr>
             </a:outerShdw>
           </a:effectLst>
@@ -22476,7 +22476,7 @@
             <a:r>
               <a:rPr lang="en-US" sz="3400" b="1" dirty="0">
                 <a:solidFill>
-                  <a:srgbClr val="D96F2B"/>
+                  <a:srgbClr val="1E2B4A"/>
                 </a:solidFill>
                 <a:latin typeface="Calibri" pitchFamily="34" charset="0"/>
                 <a:ea typeface="Calibri" pitchFamily="34" charset="-122"/>
@@ -22577,7 +22577,7 @@
             <a:r>
               <a:rPr lang="en-US" sz="3400" b="1" dirty="0">
                 <a:solidFill>
-                  <a:srgbClr val="D96F2B"/>
+                  <a:srgbClr val="1E2B4A"/>
                 </a:solidFill>
                 <a:latin typeface="Calibri" pitchFamily="34" charset="0"/>
                 <a:ea typeface="Calibri" pitchFamily="34" charset="-122"/>
@@ -23311,18 +23311,18 @@
             <a:avLst/>
           </a:prstGeom>
           <a:solidFill>
-            <a:srgbClr val="D96F2B"/>
+            <a:srgbClr val="F9E8DD"/>
           </a:solidFill>
-          <a:ln w="31750">
+          <a:ln w="15875">
             <a:solidFill>
-              <a:srgbClr val="FFFFFF"/>
+              <a:srgbClr val="F1CBB3"/>
             </a:solidFill>
             <a:prstDash val="solid"/>
           </a:ln>
           <a:effectLst>
             <a:outerShdw sx="100000" sy="100000" kx="0" ky="0" algn="bl" rotWithShape="0" blurRad="127000" dist="25400" dir="5400000">
               <a:srgbClr val="1E2B4A">
-                <a:alpha val="18000"/>
+                <a:alpha val="8000"/>
               </a:srgbClr>
             </a:outerShdw>
           </a:effectLst>
@@ -23367,18 +23367,18 @@
             <a:avLst/>
           </a:prstGeom>
           <a:solidFill>
-            <a:srgbClr val="C98A24"/>
+            <a:srgbClr val="F6ECDC"/>
           </a:solidFill>
-          <a:ln w="31750">
+          <a:ln w="15875">
             <a:solidFill>
-              <a:srgbClr val="FFFFFF"/>
+              <a:srgbClr val="ECD5B0"/>
             </a:solidFill>
             <a:prstDash val="solid"/>
           </a:ln>
           <a:effectLst>
             <a:outerShdw sx="100000" sy="100000" kx="0" ky="0" algn="bl" rotWithShape="0" blurRad="127000" dist="25400" dir="5400000">
               <a:srgbClr val="1E2B4A">
-                <a:alpha val="18000"/>
+                <a:alpha val="8000"/>
               </a:srgbClr>
             </a:outerShdw>
           </a:effectLst>
@@ -23423,18 +23423,18 @@
             <a:avLst/>
           </a:prstGeom>
           <a:solidFill>
-            <a:srgbClr val="3E8C9A"/>
+            <a:srgbClr val="E0EDEF"/>
           </a:solidFill>
-          <a:ln w="31750">
+          <a:ln w="15875">
             <a:solidFill>
-              <a:srgbClr val="FFFFFF"/>
+              <a:srgbClr val="BAD6DB"/>
             </a:solidFill>
             <a:prstDash val="solid"/>
           </a:ln>
           <a:effectLst>
             <a:outerShdw sx="100000" sy="100000" kx="0" ky="0" algn="bl" rotWithShape="0" blurRad="127000" dist="25400" dir="5400000">
               <a:srgbClr val="1E2B4A">
-                <a:alpha val="18000"/>
+                <a:alpha val="8000"/>
               </a:srgbClr>
             </a:outerShdw>
           </a:effectLst>
@@ -23642,18 +23642,18 @@
             <a:avLst/>
           </a:prstGeom>
           <a:solidFill>
-            <a:srgbClr val="41639E"/>
+            <a:srgbClr val="E1E6EF"/>
           </a:solidFill>
-          <a:ln w="31750">
+          <a:ln w="15875">
             <a:solidFill>
-              <a:srgbClr val="FFFFFF"/>
+              <a:srgbClr val="BBC7DC"/>
             </a:solidFill>
             <a:prstDash val="solid"/>
           </a:ln>
           <a:effectLst>
             <a:outerShdw sx="100000" sy="100000" kx="0" ky="0" algn="bl" rotWithShape="0" blurRad="127000" dist="25400" dir="5400000">
               <a:srgbClr val="1E2B4A">
-                <a:alpha val="18000"/>
+                <a:alpha val="8000"/>
               </a:srgbClr>
             </a:outerShdw>
           </a:effectLst>
@@ -24010,18 +24010,18 @@
             <a:avLst/>
           </a:prstGeom>
           <a:solidFill>
-            <a:srgbClr val="D96F2B"/>
+            <a:srgbClr val="F9E8DD"/>
           </a:solidFill>
-          <a:ln w="31750">
+          <a:ln w="15875">
             <a:solidFill>
-              <a:srgbClr val="FFFFFF"/>
+              <a:srgbClr val="F1CBB3"/>
             </a:solidFill>
             <a:prstDash val="solid"/>
           </a:ln>
           <a:effectLst>
             <a:outerShdw sx="100000" sy="100000" kx="0" ky="0" algn="bl" rotWithShape="0" blurRad="127000" dist="25400" dir="5400000">
               <a:srgbClr val="1E2B4A">
-                <a:alpha val="18000"/>
+                <a:alpha val="8000"/>
               </a:srgbClr>
             </a:outerShdw>
           </a:effectLst>
@@ -25567,18 +25567,18 @@
             <a:avLst/>
           </a:prstGeom>
           <a:solidFill>
-            <a:srgbClr val="41639E"/>
+            <a:srgbClr val="E1E6EF"/>
           </a:solidFill>
-          <a:ln w="31750">
+          <a:ln w="15875">
             <a:solidFill>
-              <a:srgbClr val="FFFFFF"/>
+              <a:srgbClr val="BBC7DC"/>
             </a:solidFill>
             <a:prstDash val="solid"/>
           </a:ln>
           <a:effectLst>
             <a:outerShdw sx="100000" sy="100000" kx="0" ky="0" algn="bl" rotWithShape="0" blurRad="127000" dist="25400" dir="5400000">
               <a:srgbClr val="1E2B4A">
-                <a:alpha val="18000"/>
+                <a:alpha val="8000"/>
               </a:srgbClr>
             </a:outerShdw>
           </a:effectLst>
@@ -25623,18 +25623,18 @@
             <a:avLst/>
           </a:prstGeom>
           <a:solidFill>
-            <a:srgbClr val="C98A24"/>
+            <a:srgbClr val="F6ECDC"/>
           </a:solidFill>
-          <a:ln w="31750">
+          <a:ln w="15875">
             <a:solidFill>
-              <a:srgbClr val="FFFFFF"/>
+              <a:srgbClr val="ECD5B0"/>
             </a:solidFill>
             <a:prstDash val="solid"/>
           </a:ln>
           <a:effectLst>
             <a:outerShdw sx="100000" sy="100000" kx="0" ky="0" algn="bl" rotWithShape="0" blurRad="127000" dist="25400" dir="5400000">
               <a:srgbClr val="1E2B4A">
-                <a:alpha val="18000"/>
+                <a:alpha val="8000"/>
               </a:srgbClr>
             </a:outerShdw>
           </a:effectLst>
@@ -25679,18 +25679,18 @@
             <a:avLst/>
           </a:prstGeom>
           <a:solidFill>
-            <a:srgbClr val="D96F2B"/>
+            <a:srgbClr val="F9E8DD"/>
           </a:solidFill>
-          <a:ln w="31750">
+          <a:ln w="15875">
             <a:solidFill>
-              <a:srgbClr val="FFFFFF"/>
+              <a:srgbClr val="F1CBB3"/>
             </a:solidFill>
             <a:prstDash val="solid"/>
           </a:ln>
           <a:effectLst>
             <a:outerShdw sx="100000" sy="100000" kx="0" ky="0" algn="bl" rotWithShape="0" blurRad="127000" dist="25400" dir="5400000">
               <a:srgbClr val="1E2B4A">
-                <a:alpha val="18000"/>
+                <a:alpha val="8000"/>
               </a:srgbClr>
             </a:outerShdw>
           </a:effectLst>

</xml_diff>

<commit_message>
Moderniser la palette de la presentation
La palette passe a l'indigo #4F46E5 pour la couleur dominante et a
l'ambre #D97706 pour l'accent, sur une echelle d'ardoise pour les
textes. Chaque teinte est documentee par son code hexadecimal.

Co-Authored-By: Claude <noreply@anthropic.com>
Claude-Session: https://claude.ai/code/session_01837AJxDdpW6rUH9DV9QD1H
</commit_message>
<xml_diff>
--- a/infographie/presentation_infographique.pptx
+++ b/infographie/presentation_infographique.pptx
@@ -2637,7 +2637,7 @@
     <p:bg>
       <p:bgPr>
         <a:solidFill>
-          <a:srgbClr val="16213D"/>
+          <a:srgbClr val="1E1B4B"/>
         </a:solidFill>
       </p:bgPr>
     </p:bg>
@@ -2670,7 +2670,7 @@
             <a:avLst/>
           </a:prstGeom>
           <a:solidFill>
-            <a:srgbClr val="24365E"/>
+            <a:srgbClr val="312E81"/>
           </a:solidFill>
           <a:ln/>
         </p:spPr>
@@ -2690,7 +2690,7 @@
             <a:avLst/>
           </a:prstGeom>
           <a:solidFill>
-            <a:srgbClr val="24365E"/>
+            <a:srgbClr val="312E81"/>
           </a:solidFill>
           <a:ln/>
         </p:spPr>
@@ -2717,7 +2717,7 @@
           <a:ln/>
           <a:effectLst>
             <a:outerShdw sx="100000" sy="100000" kx="0" ky="0" algn="bl" rotWithShape="0" blurRad="127000" dist="25400" dir="5400000">
-              <a:srgbClr val="1E2B4A">
+              <a:srgbClr val="312E81">
                 <a:alpha val="22000"/>
               </a:srgbClr>
             </a:outerShdw>
@@ -2770,7 +2770,7 @@
           <a:ln/>
           <a:effectLst>
             <a:outerShdw sx="100000" sy="100000" kx="0" ky="0" algn="bl" rotWithShape="0" blurRad="127000" dist="25400" dir="5400000">
-              <a:srgbClr val="1E2B4A">
+              <a:srgbClr val="312E81">
                 <a:alpha val="22000"/>
               </a:srgbClr>
             </a:outerShdw>
@@ -2828,7 +2828,7 @@
             <a:r>
               <a:rPr lang="en-US" sz="1200" b="1" spc="200" kern="0" dirty="0">
                 <a:solidFill>
-                  <a:srgbClr val="8FA6CC"/>
+                  <a:srgbClr val="A5B4FC"/>
                 </a:solidFill>
                 <a:latin typeface="Calibri" pitchFamily="34" charset="0"/>
                 <a:ea typeface="Calibri" pitchFamily="34" charset="-122"/>
@@ -2867,7 +2867,7 @@
             <a:r>
               <a:rPr lang="en-US" sz="1250" dirty="0">
                 <a:solidFill>
-                  <a:srgbClr val="AFC0DA"/>
+                  <a:srgbClr val="A5B4FC"/>
                 </a:solidFill>
                 <a:latin typeface="Calibri" pitchFamily="34" charset="0"/>
                 <a:ea typeface="Calibri" pitchFamily="34" charset="-122"/>
@@ -2968,7 +2968,7 @@
             <a:r>
               <a:rPr lang="en-US" sz="1400" dirty="0">
                 <a:solidFill>
-                  <a:srgbClr val="D96F2B"/>
+                  <a:srgbClr val="D97706"/>
                 </a:solidFill>
                 <a:latin typeface="Calibri" pitchFamily="34" charset="0"/>
                 <a:ea typeface="Calibri" pitchFamily="34" charset="-122"/>
@@ -3007,7 +3007,7 @@
             <a:r>
               <a:rPr lang="en-US" sz="1100" dirty="0">
                 <a:solidFill>
-                  <a:srgbClr val="8FA6CC"/>
+                  <a:srgbClr val="A5B4FC"/>
                 </a:solidFill>
                 <a:latin typeface="Calibri" pitchFamily="34" charset="0"/>
                 <a:ea typeface="Calibri" pitchFamily="34" charset="-122"/>
@@ -3088,7 +3088,7 @@
             <a:r>
               <a:rPr lang="en-US" sz="1050" dirty="0">
                 <a:solidFill>
-                  <a:srgbClr val="AFC0DA"/>
+                  <a:srgbClr val="A5B4FC"/>
                 </a:solidFill>
                 <a:latin typeface="Calibri" pitchFamily="34" charset="0"/>
                 <a:ea typeface="Calibri" pitchFamily="34" charset="-122"/>
@@ -3127,7 +3127,7 @@
             <a:r>
               <a:rPr lang="en-US" sz="1100" dirty="0">
                 <a:solidFill>
-                  <a:srgbClr val="8FA6CC"/>
+                  <a:srgbClr val="A5B4FC"/>
                 </a:solidFill>
                 <a:latin typeface="Calibri" pitchFamily="34" charset="0"/>
                 <a:ea typeface="Calibri" pitchFamily="34" charset="-122"/>
@@ -3208,7 +3208,7 @@
             <a:r>
               <a:rPr lang="en-US" sz="1050" dirty="0">
                 <a:solidFill>
-                  <a:srgbClr val="AFC0DA"/>
+                  <a:srgbClr val="A5B4FC"/>
                 </a:solidFill>
                 <a:latin typeface="Calibri" pitchFamily="34" charset="0"/>
                 <a:ea typeface="Calibri" pitchFamily="34" charset="-122"/>
@@ -3247,7 +3247,7 @@
             <a:r>
               <a:rPr lang="en-US" sz="1300" dirty="0">
                 <a:solidFill>
-                  <a:srgbClr val="8FA6CC"/>
+                  <a:srgbClr val="A5B4FC"/>
                 </a:solidFill>
                 <a:latin typeface="Calibri" pitchFamily="34" charset="0"/>
                 <a:ea typeface="Calibri" pitchFamily="34" charset="-122"/>
@@ -3318,7 +3318,7 @@
             <a:r>
               <a:rPr lang="en-US" sz="2700" b="1" dirty="0">
                 <a:solidFill>
-                  <a:srgbClr val="1E2B4A"/>
+                  <a:srgbClr val="312E81"/>
                 </a:solidFill>
                 <a:latin typeface="Calibri" pitchFamily="34" charset="0"/>
                 <a:ea typeface="Calibri" pitchFamily="34" charset="-122"/>
@@ -3360,7 +3360,7 @@
             <a:r>
               <a:rPr lang="en-US" sz="1300" dirty="0">
                 <a:solidFill>
-                  <a:srgbClr val="4A5468"/>
+                  <a:srgbClr val="475569"/>
                 </a:solidFill>
                 <a:latin typeface="Calibri" pitchFamily="34" charset="0"/>
                 <a:ea typeface="Calibri" pitchFamily="34" charset="-122"/>
@@ -3399,7 +3399,7 @@
             <a:r>
               <a:rPr lang="en-US" sz="1500" b="1" dirty="0">
                 <a:solidFill>
-                  <a:srgbClr val="1D2433"/>
+                  <a:srgbClr val="0F172A"/>
                 </a:solidFill>
                 <a:latin typeface="Calibri" pitchFamily="34" charset="0"/>
                 <a:ea typeface="Calibri" pitchFamily="34" charset="-122"/>
@@ -3466,7 +3466,7 @@
             <a:r>
               <a:rPr lang="en-US" sz="1100" b="1" dirty="0">
                 <a:solidFill>
-                  <a:srgbClr val="8A93A5"/>
+                  <a:srgbClr val="94A3B8"/>
                 </a:solidFill>
                 <a:latin typeface="Calibri" pitchFamily="34" charset="0"/>
                 <a:ea typeface="Calibri" pitchFamily="34" charset="-122"/>
@@ -3505,7 +3505,7 @@
             <a:r>
               <a:rPr lang="en-US" sz="1100" b="1" dirty="0">
                 <a:solidFill>
-                  <a:srgbClr val="8A93A5"/>
+                  <a:srgbClr val="94A3B8"/>
                 </a:solidFill>
                 <a:latin typeface="Calibri" pitchFamily="34" charset="0"/>
                 <a:ea typeface="Calibri" pitchFamily="34" charset="-122"/>
@@ -3544,7 +3544,7 @@
             <a:r>
               <a:rPr lang="en-US" sz="1100" b="1" dirty="0">
                 <a:solidFill>
-                  <a:srgbClr val="8A93A5"/>
+                  <a:srgbClr val="94A3B8"/>
                 </a:solidFill>
                 <a:latin typeface="Calibri" pitchFamily="34" charset="0"/>
                 <a:ea typeface="Calibri" pitchFamily="34" charset="-122"/>
@@ -3571,7 +3571,7 @@
             <a:avLst/>
           </a:prstGeom>
           <a:solidFill>
-            <a:srgbClr val="E3E7EE"/>
+            <a:srgbClr val="E2E8F0"/>
           </a:solidFill>
           <a:ln/>
         </p:spPr>
@@ -3603,7 +3603,7 @@
             <a:r>
               <a:rPr lang="en-US" sz="1250" dirty="0">
                 <a:solidFill>
-                  <a:srgbClr val="4A5468"/>
+                  <a:srgbClr val="475569"/>
                 </a:solidFill>
                 <a:latin typeface="Calibri" pitchFamily="34" charset="0"/>
                 <a:ea typeface="Calibri" pitchFamily="34" charset="-122"/>
@@ -3642,7 +3642,7 @@
             <a:r>
               <a:rPr lang="en-US" sz="1500" b="1" dirty="0">
                 <a:solidFill>
-                  <a:srgbClr val="1E2B4A"/>
+                  <a:srgbClr val="312E81"/>
                 </a:solidFill>
                 <a:latin typeface="Calibri" pitchFamily="34" charset="0"/>
                 <a:ea typeface="Calibri" pitchFamily="34" charset="-122"/>
@@ -3681,7 +3681,7 @@
             <a:r>
               <a:rPr lang="en-US" sz="1500" b="1" dirty="0">
                 <a:solidFill>
-                  <a:srgbClr val="1E2B4A"/>
+                  <a:srgbClr val="312E81"/>
                 </a:solidFill>
                 <a:latin typeface="Calibri" pitchFamily="34" charset="0"/>
                 <a:ea typeface="Calibri" pitchFamily="34" charset="-122"/>
@@ -3720,7 +3720,7 @@
             <a:r>
               <a:rPr lang="en-US" sz="1500" b="1" dirty="0">
                 <a:solidFill>
-                  <a:srgbClr val="D96F2B"/>
+                  <a:srgbClr val="D97706"/>
                 </a:solidFill>
                 <a:latin typeface="Calibri" pitchFamily="34" charset="0"/>
                 <a:ea typeface="Calibri" pitchFamily="34" charset="-122"/>
@@ -3747,7 +3747,7 @@
             <a:avLst/>
           </a:prstGeom>
           <a:solidFill>
-            <a:srgbClr val="E3E7EE"/>
+            <a:srgbClr val="E2E8F0"/>
           </a:solidFill>
           <a:ln/>
         </p:spPr>
@@ -3779,7 +3779,7 @@
             <a:r>
               <a:rPr lang="en-US" sz="1250" dirty="0">
                 <a:solidFill>
-                  <a:srgbClr val="4A5468"/>
+                  <a:srgbClr val="475569"/>
                 </a:solidFill>
                 <a:latin typeface="Calibri" pitchFamily="34" charset="0"/>
                 <a:ea typeface="Calibri" pitchFamily="34" charset="-122"/>
@@ -3818,7 +3818,7 @@
             <a:r>
               <a:rPr lang="en-US" sz="1500" b="1" dirty="0">
                 <a:solidFill>
-                  <a:srgbClr val="1E2B4A"/>
+                  <a:srgbClr val="312E81"/>
                 </a:solidFill>
                 <a:latin typeface="Calibri" pitchFamily="34" charset="0"/>
                 <a:ea typeface="Calibri" pitchFamily="34" charset="-122"/>
@@ -3857,7 +3857,7 @@
             <a:r>
               <a:rPr lang="en-US" sz="1500" b="1" dirty="0">
                 <a:solidFill>
-                  <a:srgbClr val="1E2B4A"/>
+                  <a:srgbClr val="312E81"/>
                 </a:solidFill>
                 <a:latin typeface="Calibri" pitchFamily="34" charset="0"/>
                 <a:ea typeface="Calibri" pitchFamily="34" charset="-122"/>
@@ -3896,7 +3896,7 @@
             <a:r>
               <a:rPr lang="en-US" sz="1500" b="1" dirty="0">
                 <a:solidFill>
-                  <a:srgbClr val="D96F2B"/>
+                  <a:srgbClr val="D97706"/>
                 </a:solidFill>
                 <a:latin typeface="Calibri" pitchFamily="34" charset="0"/>
                 <a:ea typeface="Calibri" pitchFamily="34" charset="-122"/>
@@ -3923,7 +3923,7 @@
             <a:avLst/>
           </a:prstGeom>
           <a:solidFill>
-            <a:srgbClr val="E3E7EE"/>
+            <a:srgbClr val="E2E8F0"/>
           </a:solidFill>
           <a:ln/>
         </p:spPr>
@@ -3955,7 +3955,7 @@
             <a:r>
               <a:rPr lang="en-US" sz="1250" dirty="0">
                 <a:solidFill>
-                  <a:srgbClr val="4A5468"/>
+                  <a:srgbClr val="475569"/>
                 </a:solidFill>
                 <a:latin typeface="Calibri" pitchFamily="34" charset="0"/>
                 <a:ea typeface="Calibri" pitchFamily="34" charset="-122"/>
@@ -3994,7 +3994,7 @@
             <a:r>
               <a:rPr lang="en-US" sz="1500" b="1" dirty="0">
                 <a:solidFill>
-                  <a:srgbClr val="1E2B4A"/>
+                  <a:srgbClr val="312E81"/>
                 </a:solidFill>
                 <a:latin typeface="Calibri" pitchFamily="34" charset="0"/>
                 <a:ea typeface="Calibri" pitchFamily="34" charset="-122"/>
@@ -4033,7 +4033,7 @@
             <a:r>
               <a:rPr lang="en-US" sz="1500" b="1" dirty="0">
                 <a:solidFill>
-                  <a:srgbClr val="1E2B4A"/>
+                  <a:srgbClr val="312E81"/>
                 </a:solidFill>
                 <a:latin typeface="Calibri" pitchFamily="34" charset="0"/>
                 <a:ea typeface="Calibri" pitchFamily="34" charset="-122"/>
@@ -4072,7 +4072,7 @@
             <a:r>
               <a:rPr lang="en-US" sz="1500" b="1" dirty="0">
                 <a:solidFill>
-                  <a:srgbClr val="D96F2B"/>
+                  <a:srgbClr val="D97706"/>
                 </a:solidFill>
                 <a:latin typeface="Calibri" pitchFamily="34" charset="0"/>
                 <a:ea typeface="Calibri" pitchFamily="34" charset="-122"/>
@@ -4114,7 +4114,7 @@
             <a:r>
               <a:rPr lang="en-US" sz="1100" dirty="0">
                 <a:solidFill>
-                  <a:srgbClr val="4A5468"/>
+                  <a:srgbClr val="475569"/>
                 </a:solidFill>
                 <a:latin typeface="Calibri" pitchFamily="34" charset="0"/>
                 <a:ea typeface="Calibri" pitchFamily="34" charset="-122"/>
@@ -4153,7 +4153,7 @@
             <a:r>
               <a:rPr lang="en-US" sz="1500" b="1" dirty="0">
                 <a:solidFill>
-                  <a:srgbClr val="1D2433"/>
+                  <a:srgbClr val="0F172A"/>
                 </a:solidFill>
                 <a:latin typeface="Calibri" pitchFamily="34" charset="0"/>
                 <a:ea typeface="Calibri" pitchFamily="34" charset="-122"/>
@@ -4192,7 +4192,7 @@
             <a:r>
               <a:rPr lang="en-US" sz="1250" b="1" dirty="0">
                 <a:solidFill>
-                  <a:srgbClr val="1D2433"/>
+                  <a:srgbClr val="0F172A"/>
                 </a:solidFill>
                 <a:latin typeface="Calibri" pitchFamily="34" charset="0"/>
                 <a:ea typeface="Calibri" pitchFamily="34" charset="-122"/>
@@ -4231,7 +4231,7 @@
             <a:r>
               <a:rPr lang="en-US" sz="1050" dirty="0">
                 <a:solidFill>
-                  <a:srgbClr val="8A93A5"/>
+                  <a:srgbClr val="94A3B8"/>
                 </a:solidFill>
                 <a:latin typeface="Calibri" pitchFamily="34" charset="0"/>
                 <a:ea typeface="Calibri" pitchFamily="34" charset="-122"/>
@@ -4260,7 +4260,7 @@
             </a:avLst>
           </a:prstGeom>
           <a:solidFill>
-            <a:srgbClr val="41639E"/>
+            <a:srgbClr val="4F46E5"/>
           </a:solidFill>
           <a:ln/>
         </p:spPr>
@@ -4292,7 +4292,7 @@
             <a:r>
               <a:rPr lang="en-US" sz="1150" b="1" dirty="0">
                 <a:solidFill>
-                  <a:srgbClr val="1D2433"/>
+                  <a:srgbClr val="0F172A"/>
                 </a:solidFill>
                 <a:latin typeface="Calibri" pitchFamily="34" charset="0"/>
                 <a:ea typeface="Calibri" pitchFamily="34" charset="-122"/>
@@ -4331,7 +4331,7 @@
             <a:r>
               <a:rPr lang="en-US" sz="1050" dirty="0">
                 <a:solidFill>
-                  <a:srgbClr val="8A93A5"/>
+                  <a:srgbClr val="94A3B8"/>
                 </a:solidFill>
                 <a:latin typeface="Calibri" pitchFamily="34" charset="0"/>
                 <a:ea typeface="Calibri" pitchFamily="34" charset="-122"/>
@@ -4360,7 +4360,7 @@
             </a:avLst>
           </a:prstGeom>
           <a:solidFill>
-            <a:srgbClr val="41639E"/>
+            <a:srgbClr val="4F46E5"/>
           </a:solidFill>
           <a:ln/>
         </p:spPr>
@@ -4392,7 +4392,7 @@
             <a:r>
               <a:rPr lang="en-US" sz="1150" b="1" dirty="0">
                 <a:solidFill>
-                  <a:srgbClr val="1D2433"/>
+                  <a:srgbClr val="0F172A"/>
                 </a:solidFill>
                 <a:latin typeface="Calibri" pitchFamily="34" charset="0"/>
                 <a:ea typeface="Calibri" pitchFamily="34" charset="-122"/>
@@ -4431,7 +4431,7 @@
             <a:r>
               <a:rPr lang="en-US" sz="1250" b="1" dirty="0">
                 <a:solidFill>
-                  <a:srgbClr val="1D2433"/>
+                  <a:srgbClr val="0F172A"/>
                 </a:solidFill>
                 <a:latin typeface="Calibri" pitchFamily="34" charset="0"/>
                 <a:ea typeface="Calibri" pitchFamily="34" charset="-122"/>
@@ -4470,7 +4470,7 @@
             <a:r>
               <a:rPr lang="en-US" sz="1050" dirty="0">
                 <a:solidFill>
-                  <a:srgbClr val="8A93A5"/>
+                  <a:srgbClr val="94A3B8"/>
                 </a:solidFill>
                 <a:latin typeface="Calibri" pitchFamily="34" charset="0"/>
                 <a:ea typeface="Calibri" pitchFamily="34" charset="-122"/>
@@ -4499,7 +4499,7 @@
             </a:avLst>
           </a:prstGeom>
           <a:solidFill>
-            <a:srgbClr val="D96F2B"/>
+            <a:srgbClr val="D97706"/>
           </a:solidFill>
           <a:ln/>
         </p:spPr>
@@ -4531,7 +4531,7 @@
             <a:r>
               <a:rPr lang="en-US" sz="1150" b="1" dirty="0">
                 <a:solidFill>
-                  <a:srgbClr val="1D2433"/>
+                  <a:srgbClr val="0F172A"/>
                 </a:solidFill>
                 <a:latin typeface="Calibri" pitchFamily="34" charset="0"/>
                 <a:ea typeface="Calibri" pitchFamily="34" charset="-122"/>
@@ -4570,7 +4570,7 @@
             <a:r>
               <a:rPr lang="en-US" sz="1050" dirty="0">
                 <a:solidFill>
-                  <a:srgbClr val="8A93A5"/>
+                  <a:srgbClr val="94A3B8"/>
                 </a:solidFill>
                 <a:latin typeface="Calibri" pitchFamily="34" charset="0"/>
                 <a:ea typeface="Calibri" pitchFamily="34" charset="-122"/>
@@ -4599,7 +4599,7 @@
             </a:avLst>
           </a:prstGeom>
           <a:solidFill>
-            <a:srgbClr val="D96F2B"/>
+            <a:srgbClr val="D97706"/>
           </a:solidFill>
           <a:ln/>
         </p:spPr>
@@ -4631,7 +4631,7 @@
             <a:r>
               <a:rPr lang="en-US" sz="1150" b="1" dirty="0">
                 <a:solidFill>
-                  <a:srgbClr val="1D2433"/>
+                  <a:srgbClr val="0F172A"/>
                 </a:solidFill>
                 <a:latin typeface="Calibri" pitchFamily="34" charset="0"/>
                 <a:ea typeface="Calibri" pitchFamily="34" charset="-122"/>
@@ -4673,7 +4673,7 @@
             <a:r>
               <a:rPr lang="en-US" sz="1100" dirty="0">
                 <a:solidFill>
-                  <a:srgbClr val="4A5468"/>
+                  <a:srgbClr val="475569"/>
                 </a:solidFill>
                 <a:latin typeface="Calibri" pitchFamily="34" charset="0"/>
                 <a:ea typeface="Calibri" pitchFamily="34" charset="-122"/>
@@ -4712,7 +4712,7 @@
             <a:r>
               <a:rPr lang="en-US" sz="900" dirty="0">
                 <a:solidFill>
-                  <a:srgbClr val="8A93A5"/>
+                  <a:srgbClr val="94A3B8"/>
                 </a:solidFill>
                 <a:latin typeface="Calibri" pitchFamily="34" charset="0"/>
                 <a:ea typeface="Calibri" pitchFamily="34" charset="-122"/>
@@ -4751,7 +4751,7 @@
             <a:r>
               <a:rPr lang="en-US" sz="950" dirty="0">
                 <a:solidFill>
-                  <a:srgbClr val="8A93A5"/>
+                  <a:srgbClr val="94A3B8"/>
                 </a:solidFill>
                 <a:latin typeface="Calibri" pitchFamily="34" charset="0"/>
                 <a:ea typeface="Calibri" pitchFamily="34" charset="-122"/>
@@ -4846,7 +4846,7 @@
             <a:r>
               <a:rPr lang="en-US" sz="2700" b="1" dirty="0">
                 <a:solidFill>
-                  <a:srgbClr val="1E2B4A"/>
+                  <a:srgbClr val="312E81"/>
                 </a:solidFill>
                 <a:latin typeface="Calibri" pitchFamily="34" charset="0"/>
                 <a:ea typeface="Calibri" pitchFamily="34" charset="-122"/>
@@ -4888,7 +4888,7 @@
             <a:r>
               <a:rPr lang="en-US" sz="1300" dirty="0">
                 <a:solidFill>
-                  <a:srgbClr val="4A5468"/>
+                  <a:srgbClr val="475569"/>
                 </a:solidFill>
                 <a:latin typeface="Calibri" pitchFamily="34" charset="0"/>
                 <a:ea typeface="Calibri" pitchFamily="34" charset="-122"/>
@@ -4927,7 +4927,7 @@
             <a:r>
               <a:rPr lang="en-US" sz="3000" b="1" dirty="0">
                 <a:solidFill>
-                  <a:srgbClr val="1E2B4A"/>
+                  <a:srgbClr val="312E81"/>
                 </a:solidFill>
                 <a:latin typeface="Calibri" pitchFamily="34" charset="0"/>
                 <a:ea typeface="Calibri" pitchFamily="34" charset="-122"/>
@@ -4969,7 +4969,7 @@
             <a:r>
               <a:rPr lang="en-US" sz="1050" dirty="0">
                 <a:solidFill>
-                  <a:srgbClr val="4A5468"/>
+                  <a:srgbClr val="475569"/>
                 </a:solidFill>
                 <a:latin typeface="Calibri" pitchFamily="34" charset="0"/>
                 <a:ea typeface="Calibri" pitchFamily="34" charset="-122"/>
@@ -4989,7 +4989,7 @@
             <a:r>
               <a:rPr lang="en-US" sz="1050" dirty="0">
                 <a:solidFill>
-                  <a:srgbClr val="4A5468"/>
+                  <a:srgbClr val="475569"/>
                 </a:solidFill>
                 <a:latin typeface="Calibri" pitchFamily="34" charset="0"/>
                 <a:ea typeface="Calibri" pitchFamily="34" charset="-122"/>
@@ -5028,7 +5028,7 @@
             <a:r>
               <a:rPr lang="en-US" sz="3000" b="1" dirty="0">
                 <a:solidFill>
-                  <a:srgbClr val="1E2B4A"/>
+                  <a:srgbClr val="312E81"/>
                 </a:solidFill>
                 <a:latin typeface="Calibri" pitchFamily="34" charset="0"/>
                 <a:ea typeface="Calibri" pitchFamily="34" charset="-122"/>
@@ -5070,7 +5070,7 @@
             <a:r>
               <a:rPr lang="en-US" sz="1050" dirty="0">
                 <a:solidFill>
-                  <a:srgbClr val="4A5468"/>
+                  <a:srgbClr val="475569"/>
                 </a:solidFill>
                 <a:latin typeface="Calibri" pitchFamily="34" charset="0"/>
                 <a:ea typeface="Calibri" pitchFamily="34" charset="-122"/>
@@ -5090,7 +5090,7 @@
             <a:r>
               <a:rPr lang="en-US" sz="1050" dirty="0">
                 <a:solidFill>
-                  <a:srgbClr val="4A5468"/>
+                  <a:srgbClr val="475569"/>
                 </a:solidFill>
                 <a:latin typeface="Calibri" pitchFamily="34" charset="0"/>
                 <a:ea typeface="Calibri" pitchFamily="34" charset="-122"/>
@@ -5129,7 +5129,7 @@
             <a:r>
               <a:rPr lang="en-US" sz="3000" b="1" dirty="0">
                 <a:solidFill>
-                  <a:srgbClr val="1E2B4A"/>
+                  <a:srgbClr val="312E81"/>
                 </a:solidFill>
                 <a:latin typeface="Calibri" pitchFamily="34" charset="0"/>
                 <a:ea typeface="Calibri" pitchFamily="34" charset="-122"/>
@@ -5171,7 +5171,7 @@
             <a:r>
               <a:rPr lang="en-US" sz="1050" dirty="0">
                 <a:solidFill>
-                  <a:srgbClr val="4A5468"/>
+                  <a:srgbClr val="475569"/>
                 </a:solidFill>
                 <a:latin typeface="Calibri" pitchFamily="34" charset="0"/>
                 <a:ea typeface="Calibri" pitchFamily="34" charset="-122"/>
@@ -5191,7 +5191,7 @@
             <a:r>
               <a:rPr lang="en-US" sz="1050" dirty="0">
                 <a:solidFill>
-                  <a:srgbClr val="4A5468"/>
+                  <a:srgbClr val="475569"/>
                 </a:solidFill>
                 <a:latin typeface="Calibri" pitchFamily="34" charset="0"/>
                 <a:ea typeface="Calibri" pitchFamily="34" charset="-122"/>
@@ -5230,7 +5230,7 @@
             <a:r>
               <a:rPr lang="en-US" sz="3000" b="1" dirty="0">
                 <a:solidFill>
-                  <a:srgbClr val="1E2B4A"/>
+                  <a:srgbClr val="312E81"/>
                 </a:solidFill>
                 <a:latin typeface="Calibri" pitchFamily="34" charset="0"/>
                 <a:ea typeface="Calibri" pitchFamily="34" charset="-122"/>
@@ -5272,7 +5272,7 @@
             <a:r>
               <a:rPr lang="en-US" sz="1050" dirty="0">
                 <a:solidFill>
-                  <a:srgbClr val="4A5468"/>
+                  <a:srgbClr val="475569"/>
                 </a:solidFill>
                 <a:latin typeface="Calibri" pitchFamily="34" charset="0"/>
                 <a:ea typeface="Calibri" pitchFamily="34" charset="-122"/>
@@ -5292,7 +5292,7 @@
             <a:r>
               <a:rPr lang="en-US" sz="1050" dirty="0">
                 <a:solidFill>
-                  <a:srgbClr val="4A5468"/>
+                  <a:srgbClr val="475569"/>
                 </a:solidFill>
                 <a:latin typeface="Calibri" pitchFamily="34" charset="0"/>
                 <a:ea typeface="Calibri" pitchFamily="34" charset="-122"/>
@@ -5331,7 +5331,7 @@
             <a:r>
               <a:rPr lang="en-US" sz="1400" b="1" dirty="0">
                 <a:solidFill>
-                  <a:srgbClr val="1D2433"/>
+                  <a:srgbClr val="0F172A"/>
                 </a:solidFill>
                 <a:latin typeface="Calibri" pitchFamily="34" charset="0"/>
                 <a:ea typeface="Calibri" pitchFamily="34" charset="-122"/>
@@ -5370,7 +5370,7 @@
             <a:r>
               <a:rPr lang="en-US" sz="1100" dirty="0">
                 <a:solidFill>
-                  <a:srgbClr val="4A5468"/>
+                  <a:srgbClr val="475569"/>
                 </a:solidFill>
                 <a:latin typeface="Calibri" pitchFamily="34" charset="0"/>
                 <a:ea typeface="Calibri" pitchFamily="34" charset="-122"/>
@@ -5399,7 +5399,7 @@
             </a:avLst>
           </a:prstGeom>
           <a:solidFill>
-            <a:srgbClr val="E3E7EE"/>
+            <a:srgbClr val="E2E8F0"/>
           </a:solidFill>
           <a:ln/>
         </p:spPr>
@@ -5421,7 +5421,7 @@
             </a:avLst>
           </a:prstGeom>
           <a:solidFill>
-            <a:srgbClr val="3E8C9A"/>
+            <a:srgbClr val="DB2777"/>
           </a:solidFill>
           <a:ln/>
         </p:spPr>
@@ -5453,7 +5453,7 @@
             <a:r>
               <a:rPr lang="en-US" sz="1100" b="1" dirty="0">
                 <a:solidFill>
-                  <a:srgbClr val="1D2433"/>
+                  <a:srgbClr val="0F172A"/>
                 </a:solidFill>
                 <a:latin typeface="Calibri" pitchFamily="34" charset="0"/>
                 <a:ea typeface="Calibri" pitchFamily="34" charset="-122"/>
@@ -5492,7 +5492,7 @@
             <a:r>
               <a:rPr lang="en-US" sz="1100" dirty="0">
                 <a:solidFill>
-                  <a:srgbClr val="4A5468"/>
+                  <a:srgbClr val="475569"/>
                 </a:solidFill>
                 <a:latin typeface="Calibri" pitchFamily="34" charset="0"/>
                 <a:ea typeface="Calibri" pitchFamily="34" charset="-122"/>
@@ -5521,7 +5521,7 @@
             </a:avLst>
           </a:prstGeom>
           <a:solidFill>
-            <a:srgbClr val="E3E7EE"/>
+            <a:srgbClr val="E2E8F0"/>
           </a:solidFill>
           <a:ln/>
         </p:spPr>
@@ -5543,7 +5543,7 @@
             </a:avLst>
           </a:prstGeom>
           <a:solidFill>
-            <a:srgbClr val="3E8C9A"/>
+            <a:srgbClr val="DB2777"/>
           </a:solidFill>
           <a:ln/>
         </p:spPr>
@@ -5575,7 +5575,7 @@
             <a:r>
               <a:rPr lang="en-US" sz="1100" b="1" dirty="0">
                 <a:solidFill>
-                  <a:srgbClr val="1D2433"/>
+                  <a:srgbClr val="0F172A"/>
                 </a:solidFill>
                 <a:latin typeface="Calibri" pitchFamily="34" charset="0"/>
                 <a:ea typeface="Calibri" pitchFamily="34" charset="-122"/>
@@ -5614,7 +5614,7 @@
             <a:r>
               <a:rPr lang="en-US" sz="1100" dirty="0">
                 <a:solidFill>
-                  <a:srgbClr val="4A5468"/>
+                  <a:srgbClr val="475569"/>
                 </a:solidFill>
                 <a:latin typeface="Calibri" pitchFamily="34" charset="0"/>
                 <a:ea typeface="Calibri" pitchFamily="34" charset="-122"/>
@@ -5643,7 +5643,7 @@
             </a:avLst>
           </a:prstGeom>
           <a:solidFill>
-            <a:srgbClr val="E3E7EE"/>
+            <a:srgbClr val="E2E8F0"/>
           </a:solidFill>
           <a:ln/>
         </p:spPr>
@@ -5665,7 +5665,7 @@
             </a:avLst>
           </a:prstGeom>
           <a:solidFill>
-            <a:srgbClr val="3E8C9A"/>
+            <a:srgbClr val="DB2777"/>
           </a:solidFill>
           <a:ln/>
         </p:spPr>
@@ -5697,7 +5697,7 @@
             <a:r>
               <a:rPr lang="en-US" sz="1100" b="1" dirty="0">
                 <a:solidFill>
-                  <a:srgbClr val="1D2433"/>
+                  <a:srgbClr val="0F172A"/>
                 </a:solidFill>
                 <a:latin typeface="Calibri" pitchFamily="34" charset="0"/>
                 <a:ea typeface="Calibri" pitchFamily="34" charset="-122"/>
@@ -5736,7 +5736,7 @@
             <a:r>
               <a:rPr lang="en-US" sz="1100" dirty="0">
                 <a:solidFill>
-                  <a:srgbClr val="4A5468"/>
+                  <a:srgbClr val="475569"/>
                 </a:solidFill>
                 <a:latin typeface="Calibri" pitchFamily="34" charset="0"/>
                 <a:ea typeface="Calibri" pitchFamily="34" charset="-122"/>
@@ -5765,7 +5765,7 @@
             </a:avLst>
           </a:prstGeom>
           <a:solidFill>
-            <a:srgbClr val="E3E7EE"/>
+            <a:srgbClr val="E2E8F0"/>
           </a:solidFill>
           <a:ln/>
         </p:spPr>
@@ -5787,7 +5787,7 @@
             </a:avLst>
           </a:prstGeom>
           <a:solidFill>
-            <a:srgbClr val="3E8C9A"/>
+            <a:srgbClr val="DB2777"/>
           </a:solidFill>
           <a:ln/>
         </p:spPr>
@@ -5819,7 +5819,7 @@
             <a:r>
               <a:rPr lang="en-US" sz="1100" b="1" dirty="0">
                 <a:solidFill>
-                  <a:srgbClr val="1D2433"/>
+                  <a:srgbClr val="0F172A"/>
                 </a:solidFill>
                 <a:latin typeface="Calibri" pitchFamily="34" charset="0"/>
                 <a:ea typeface="Calibri" pitchFamily="34" charset="-122"/>
@@ -5858,7 +5858,7 @@
             <a:r>
               <a:rPr lang="en-US" sz="1100" dirty="0">
                 <a:solidFill>
-                  <a:srgbClr val="4A5468"/>
+                  <a:srgbClr val="475569"/>
                 </a:solidFill>
                 <a:latin typeface="Calibri" pitchFamily="34" charset="0"/>
                 <a:ea typeface="Calibri" pitchFamily="34" charset="-122"/>
@@ -5887,7 +5887,7 @@
             </a:avLst>
           </a:prstGeom>
           <a:solidFill>
-            <a:srgbClr val="E3E7EE"/>
+            <a:srgbClr val="E2E8F0"/>
           </a:solidFill>
           <a:ln/>
         </p:spPr>
@@ -5909,7 +5909,7 @@
             </a:avLst>
           </a:prstGeom>
           <a:solidFill>
-            <a:srgbClr val="3E8C9A"/>
+            <a:srgbClr val="DB2777"/>
           </a:solidFill>
           <a:ln/>
         </p:spPr>
@@ -5941,7 +5941,7 @@
             <a:r>
               <a:rPr lang="en-US" sz="1100" b="1" dirty="0">
                 <a:solidFill>
-                  <a:srgbClr val="1D2433"/>
+                  <a:srgbClr val="0F172A"/>
                 </a:solidFill>
                 <a:latin typeface="Calibri" pitchFamily="34" charset="0"/>
                 <a:ea typeface="Calibri" pitchFamily="34" charset="-122"/>
@@ -5980,7 +5980,7 @@
             <a:r>
               <a:rPr lang="en-US" sz="1100" dirty="0">
                 <a:solidFill>
-                  <a:srgbClr val="4A5468"/>
+                  <a:srgbClr val="475569"/>
                 </a:solidFill>
                 <a:latin typeface="Calibri" pitchFamily="34" charset="0"/>
                 <a:ea typeface="Calibri" pitchFamily="34" charset="-122"/>
@@ -6009,7 +6009,7 @@
             </a:avLst>
           </a:prstGeom>
           <a:solidFill>
-            <a:srgbClr val="E3E7EE"/>
+            <a:srgbClr val="E2E8F0"/>
           </a:solidFill>
           <a:ln/>
         </p:spPr>
@@ -6031,7 +6031,7 @@
             </a:avLst>
           </a:prstGeom>
           <a:solidFill>
-            <a:srgbClr val="3E8C9A"/>
+            <a:srgbClr val="DB2777"/>
           </a:solidFill>
           <a:ln/>
         </p:spPr>
@@ -6063,7 +6063,7 @@
             <a:r>
               <a:rPr lang="en-US" sz="1100" b="1" dirty="0">
                 <a:solidFill>
-                  <a:srgbClr val="1D2433"/>
+                  <a:srgbClr val="0F172A"/>
                 </a:solidFill>
                 <a:latin typeface="Calibri" pitchFamily="34" charset="0"/>
                 <a:ea typeface="Calibri" pitchFamily="34" charset="-122"/>
@@ -6102,7 +6102,7 @@
             <a:r>
               <a:rPr lang="en-US" sz="900" dirty="0">
                 <a:solidFill>
-                  <a:srgbClr val="8A93A5"/>
+                  <a:srgbClr val="94A3B8"/>
                 </a:solidFill>
                 <a:latin typeface="Calibri" pitchFamily="34" charset="0"/>
                 <a:ea typeface="Calibri" pitchFamily="34" charset="-122"/>
@@ -6141,7 +6141,7 @@
             <a:r>
               <a:rPr lang="en-US" sz="950" dirty="0">
                 <a:solidFill>
-                  <a:srgbClr val="8A93A5"/>
+                  <a:srgbClr val="94A3B8"/>
                 </a:solidFill>
                 <a:latin typeface="Calibri" pitchFamily="34" charset="0"/>
                 <a:ea typeface="Calibri" pitchFamily="34" charset="-122"/>
@@ -6236,7 +6236,7 @@
             <a:r>
               <a:rPr lang="en-US" sz="2700" b="1" dirty="0">
                 <a:solidFill>
-                  <a:srgbClr val="1E2B4A"/>
+                  <a:srgbClr val="312E81"/>
                 </a:solidFill>
                 <a:latin typeface="Calibri" pitchFamily="34" charset="0"/>
                 <a:ea typeface="Calibri" pitchFamily="34" charset="-122"/>
@@ -6265,7 +6265,7 @@
             </a:avLst>
           </a:prstGeom>
           <a:solidFill>
-            <a:srgbClr val="1E2B4A"/>
+            <a:srgbClr val="312E81"/>
           </a:solidFill>
           <a:ln/>
         </p:spPr>
@@ -6336,7 +6336,7 @@
             <a:r>
               <a:rPr lang="en-US" sz="1400" b="1" dirty="0">
                 <a:solidFill>
-                  <a:srgbClr val="D96F2B"/>
+                  <a:srgbClr val="D97706"/>
                 </a:solidFill>
                 <a:latin typeface="Calibri" pitchFamily="34" charset="0"/>
                 <a:ea typeface="Calibri" pitchFamily="34" charset="-122"/>
@@ -6417,7 +6417,7 @@
             <a:r>
               <a:rPr lang="en-US" sz="1500" b="1" dirty="0">
                 <a:solidFill>
-                  <a:srgbClr val="D96F2B"/>
+                  <a:srgbClr val="D97706"/>
                 </a:solidFill>
                 <a:latin typeface="Calibri" pitchFamily="34" charset="0"/>
                 <a:ea typeface="Calibri" pitchFamily="34" charset="-122"/>
@@ -6456,7 +6456,7 @@
             <a:r>
               <a:rPr lang="en-US" sz="1350" b="1" dirty="0">
                 <a:solidFill>
-                  <a:srgbClr val="1D2433"/>
+                  <a:srgbClr val="0F172A"/>
                 </a:solidFill>
                 <a:latin typeface="Calibri" pitchFamily="34" charset="0"/>
                 <a:ea typeface="Calibri" pitchFamily="34" charset="-122"/>
@@ -6485,7 +6485,7 @@
             </a:avLst>
           </a:prstGeom>
           <a:solidFill>
-            <a:srgbClr val="D96F2B"/>
+            <a:srgbClr val="D97706"/>
           </a:solidFill>
           <a:ln/>
         </p:spPr>
@@ -6517,7 +6517,7 @@
             <a:r>
               <a:rPr lang="en-US" sz="1500" b="1" dirty="0">
                 <a:solidFill>
-                  <a:srgbClr val="1D2433"/>
+                  <a:srgbClr val="0F172A"/>
                 </a:solidFill>
                 <a:latin typeface="Calibri" pitchFamily="34" charset="0"/>
                 <a:ea typeface="Calibri" pitchFamily="34" charset="-122"/>
@@ -6559,7 +6559,7 @@
             <a:r>
               <a:rPr lang="en-US" sz="1150" b="1" dirty="0">
                 <a:solidFill>
-                  <a:srgbClr val="4A5468"/>
+                  <a:srgbClr val="475569"/>
                 </a:solidFill>
                 <a:latin typeface="Calibri" pitchFamily="34" charset="0"/>
                 <a:ea typeface="Calibri" pitchFamily="34" charset="-122"/>
@@ -6588,7 +6588,7 @@
             </a:avLst>
           </a:prstGeom>
           <a:solidFill>
-            <a:srgbClr val="41639E"/>
+            <a:srgbClr val="4F46E5"/>
           </a:solidFill>
           <a:ln/>
         </p:spPr>
@@ -6620,7 +6620,7 @@
             <a:r>
               <a:rPr lang="en-US" sz="1500" b="1" dirty="0">
                 <a:solidFill>
-                  <a:srgbClr val="1D2433"/>
+                  <a:srgbClr val="0F172A"/>
                 </a:solidFill>
                 <a:latin typeface="Calibri" pitchFamily="34" charset="0"/>
                 <a:ea typeface="Calibri" pitchFamily="34" charset="-122"/>
@@ -6662,7 +6662,7 @@
             <a:r>
               <a:rPr lang="en-US" sz="1150" b="1" dirty="0">
                 <a:solidFill>
-                  <a:srgbClr val="4A5468"/>
+                  <a:srgbClr val="475569"/>
                 </a:solidFill>
                 <a:latin typeface="Calibri" pitchFamily="34" charset="0"/>
                 <a:ea typeface="Calibri" pitchFamily="34" charset="-122"/>
@@ -6682,7 +6682,7 @@
             <a:r>
               <a:rPr lang="en-US" sz="1150" b="1" dirty="0">
                 <a:solidFill>
-                  <a:srgbClr val="4A5468"/>
+                  <a:srgbClr val="475569"/>
                 </a:solidFill>
                 <a:latin typeface="Calibri" pitchFamily="34" charset="0"/>
                 <a:ea typeface="Calibri" pitchFamily="34" charset="-122"/>
@@ -6709,7 +6709,7 @@
             <a:avLst/>
           </a:prstGeom>
           <a:solidFill>
-            <a:srgbClr val="CFD4DD"/>
+            <a:srgbClr val="CBD5E1"/>
           </a:solidFill>
           <a:ln/>
         </p:spPr>
@@ -6741,7 +6741,7 @@
             <a:r>
               <a:rPr lang="en-US" sz="1100" dirty="0">
                 <a:solidFill>
-                  <a:srgbClr val="4A5468"/>
+                  <a:srgbClr val="475569"/>
                 </a:solidFill>
                 <a:latin typeface="Calibri" pitchFamily="34" charset="0"/>
                 <a:ea typeface="Calibri" pitchFamily="34" charset="-122"/>
@@ -6780,7 +6780,7 @@
             <a:r>
               <a:rPr lang="en-US" sz="1350" b="1" dirty="0">
                 <a:solidFill>
-                  <a:srgbClr val="1D2433"/>
+                  <a:srgbClr val="0F172A"/>
                 </a:solidFill>
                 <a:latin typeface="Calibri" pitchFamily="34" charset="0"/>
                 <a:ea typeface="Calibri" pitchFamily="34" charset="-122"/>
@@ -6822,7 +6822,7 @@
             <a:r>
               <a:rPr lang="en-US" sz="1100" dirty="0">
                 <a:solidFill>
-                  <a:srgbClr val="4A5468"/>
+                  <a:srgbClr val="475569"/>
                 </a:solidFill>
                 <a:latin typeface="Calibri" pitchFamily="34" charset="0"/>
                 <a:ea typeface="Calibri" pitchFamily="34" charset="-122"/>
@@ -6861,7 +6861,7 @@
             <a:r>
               <a:rPr lang="en-US" sz="1500" b="1" dirty="0">
                 <a:solidFill>
-                  <a:srgbClr val="1E2B4A"/>
+                  <a:srgbClr val="312E81"/>
                 </a:solidFill>
                 <a:latin typeface="Calibri" pitchFamily="34" charset="0"/>
                 <a:ea typeface="Calibri" pitchFamily="34" charset="-122"/>
@@ -6888,7 +6888,7 @@
             <a:avLst/>
           </a:prstGeom>
           <a:solidFill>
-            <a:srgbClr val="E3E7EE"/>
+            <a:srgbClr val="E2E8F0"/>
           </a:solidFill>
           <a:ln/>
         </p:spPr>
@@ -6923,7 +6923,7 @@
             <a:r>
               <a:rPr lang="en-US" sz="1100" dirty="0">
                 <a:solidFill>
-                  <a:srgbClr val="4A5468"/>
+                  <a:srgbClr val="475569"/>
                 </a:solidFill>
                 <a:latin typeface="Calibri" pitchFamily="34" charset="0"/>
                 <a:ea typeface="Calibri" pitchFamily="34" charset="-122"/>
@@ -6962,7 +6962,7 @@
             <a:r>
               <a:rPr lang="en-US" sz="1500" b="1" dirty="0">
                 <a:solidFill>
-                  <a:srgbClr val="1E2B4A"/>
+                  <a:srgbClr val="312E81"/>
                 </a:solidFill>
                 <a:latin typeface="Calibri" pitchFamily="34" charset="0"/>
                 <a:ea typeface="Calibri" pitchFamily="34" charset="-122"/>
@@ -6989,7 +6989,7 @@
             <a:avLst/>
           </a:prstGeom>
           <a:solidFill>
-            <a:srgbClr val="E3E7EE"/>
+            <a:srgbClr val="E2E8F0"/>
           </a:solidFill>
           <a:ln/>
         </p:spPr>
@@ -7024,7 +7024,7 @@
             <a:r>
               <a:rPr lang="en-US" sz="1100" dirty="0">
                 <a:solidFill>
-                  <a:srgbClr val="4A5468"/>
+                  <a:srgbClr val="475569"/>
                 </a:solidFill>
                 <a:latin typeface="Calibri" pitchFamily="34" charset="0"/>
                 <a:ea typeface="Calibri" pitchFamily="34" charset="-122"/>
@@ -7063,7 +7063,7 @@
             <a:r>
               <a:rPr lang="en-US" sz="1500" b="1" dirty="0">
                 <a:solidFill>
-                  <a:srgbClr val="1E2B4A"/>
+                  <a:srgbClr val="312E81"/>
                 </a:solidFill>
                 <a:latin typeface="Calibri" pitchFamily="34" charset="0"/>
                 <a:ea typeface="Calibri" pitchFamily="34" charset="-122"/>
@@ -7090,7 +7090,7 @@
             <a:avLst/>
           </a:prstGeom>
           <a:solidFill>
-            <a:srgbClr val="E3E7EE"/>
+            <a:srgbClr val="E2E8F0"/>
           </a:solidFill>
           <a:ln/>
         </p:spPr>
@@ -7125,7 +7125,7 @@
             <a:r>
               <a:rPr lang="en-US" sz="1100" dirty="0">
                 <a:solidFill>
-                  <a:srgbClr val="4A5468"/>
+                  <a:srgbClr val="475569"/>
                 </a:solidFill>
                 <a:latin typeface="Calibri" pitchFamily="34" charset="0"/>
                 <a:ea typeface="Calibri" pitchFamily="34" charset="-122"/>
@@ -7164,7 +7164,7 @@
             <a:r>
               <a:rPr lang="en-US" sz="1500" b="1" dirty="0">
                 <a:solidFill>
-                  <a:srgbClr val="8A93A5"/>
+                  <a:srgbClr val="94A3B8"/>
                 </a:solidFill>
                 <a:latin typeface="Calibri" pitchFamily="34" charset="0"/>
                 <a:ea typeface="Calibri" pitchFamily="34" charset="-122"/>
@@ -7191,7 +7191,7 @@
             <a:avLst/>
           </a:prstGeom>
           <a:solidFill>
-            <a:srgbClr val="E3E7EE"/>
+            <a:srgbClr val="E2E8F0"/>
           </a:solidFill>
           <a:ln/>
         </p:spPr>
@@ -7226,7 +7226,7 @@
             <a:r>
               <a:rPr lang="en-US" sz="1050" dirty="0">
                 <a:solidFill>
-                  <a:srgbClr val="4A5468"/>
+                  <a:srgbClr val="475569"/>
                 </a:solidFill>
                 <a:latin typeface="Calibri" pitchFamily="34" charset="0"/>
                 <a:ea typeface="Calibri" pitchFamily="34" charset="-122"/>
@@ -7265,7 +7265,7 @@
             <a:r>
               <a:rPr lang="en-US" sz="900" dirty="0">
                 <a:solidFill>
-                  <a:srgbClr val="8A93A5"/>
+                  <a:srgbClr val="94A3B8"/>
                 </a:solidFill>
                 <a:latin typeface="Calibri" pitchFamily="34" charset="0"/>
                 <a:ea typeface="Calibri" pitchFamily="34" charset="-122"/>
@@ -7304,7 +7304,7 @@
             <a:r>
               <a:rPr lang="en-US" sz="950" dirty="0">
                 <a:solidFill>
-                  <a:srgbClr val="8A93A5"/>
+                  <a:srgbClr val="94A3B8"/>
                 </a:solidFill>
                 <a:latin typeface="Calibri" pitchFamily="34" charset="0"/>
                 <a:ea typeface="Calibri" pitchFamily="34" charset="-122"/>
@@ -7399,7 +7399,7 @@
             <a:r>
               <a:rPr lang="en-US" sz="2700" b="1" dirty="0">
                 <a:solidFill>
-                  <a:srgbClr val="1E2B4A"/>
+                  <a:srgbClr val="312E81"/>
                 </a:solidFill>
                 <a:latin typeface="Calibri" pitchFamily="34" charset="0"/>
                 <a:ea typeface="Calibri" pitchFamily="34" charset="-122"/>
@@ -7441,7 +7441,7 @@
             <a:r>
               <a:rPr lang="en-US" sz="1300" dirty="0">
                 <a:solidFill>
-                  <a:srgbClr val="4A5468"/>
+                  <a:srgbClr val="475569"/>
                 </a:solidFill>
                 <a:latin typeface="Calibri" pitchFamily="34" charset="0"/>
                 <a:ea typeface="Calibri" pitchFamily="34" charset="-122"/>
@@ -7480,7 +7480,7 @@
             <a:r>
               <a:rPr lang="en-US" sz="1400" b="1" dirty="0">
                 <a:solidFill>
-                  <a:srgbClr val="1D2433"/>
+                  <a:srgbClr val="0F172A"/>
                 </a:solidFill>
                 <a:latin typeface="Calibri" pitchFamily="34" charset="0"/>
                 <a:ea typeface="Calibri" pitchFamily="34" charset="-122"/>
@@ -7519,7 +7519,7 @@
             <a:r>
               <a:rPr lang="en-US" sz="1150" b="1" dirty="0">
                 <a:solidFill>
-                  <a:srgbClr val="1D2433"/>
+                  <a:srgbClr val="0F172A"/>
                 </a:solidFill>
                 <a:latin typeface="Calibri" pitchFamily="34" charset="0"/>
                 <a:ea typeface="Calibri" pitchFamily="34" charset="-122"/>
@@ -7548,7 +7548,7 @@
             </a:avLst>
           </a:prstGeom>
           <a:solidFill>
-            <a:srgbClr val="D96F2B"/>
+            <a:srgbClr val="D97706"/>
           </a:solidFill>
           <a:ln/>
         </p:spPr>
@@ -7580,7 +7580,7 @@
             <a:r>
               <a:rPr lang="en-US" sz="1200" b="1" dirty="0">
                 <a:solidFill>
-                  <a:srgbClr val="1D2433"/>
+                  <a:srgbClr val="0F172A"/>
                 </a:solidFill>
                 <a:latin typeface="Calibri" pitchFamily="34" charset="0"/>
                 <a:ea typeface="Calibri" pitchFamily="34" charset="-122"/>
@@ -7619,7 +7619,7 @@
             <a:r>
               <a:rPr lang="en-US" sz="1400" b="1" dirty="0">
                 <a:solidFill>
-                  <a:srgbClr val="D96F2B"/>
+                  <a:srgbClr val="D97706"/>
                 </a:solidFill>
                 <a:latin typeface="Calibri" pitchFamily="34" charset="0"/>
                 <a:ea typeface="Calibri" pitchFamily="34" charset="-122"/>
@@ -7658,7 +7658,7 @@
             <a:r>
               <a:rPr lang="en-US" sz="1150" dirty="0">
                 <a:solidFill>
-                  <a:srgbClr val="4A5468"/>
+                  <a:srgbClr val="475569"/>
                 </a:solidFill>
                 <a:latin typeface="Calibri" pitchFamily="34" charset="0"/>
                 <a:ea typeface="Calibri" pitchFamily="34" charset="-122"/>
@@ -7687,7 +7687,7 @@
             </a:avLst>
           </a:prstGeom>
           <a:solidFill>
-            <a:srgbClr val="E3E7EE"/>
+            <a:srgbClr val="E2E8F0"/>
           </a:solidFill>
           <a:ln/>
         </p:spPr>
@@ -7719,7 +7719,7 @@
             <a:r>
               <a:rPr lang="en-US" sz="1200" b="1" dirty="0">
                 <a:solidFill>
-                  <a:srgbClr val="1D2433"/>
+                  <a:srgbClr val="0F172A"/>
                 </a:solidFill>
                 <a:latin typeface="Calibri" pitchFamily="34" charset="0"/>
                 <a:ea typeface="Calibri" pitchFamily="34" charset="-122"/>
@@ -7758,7 +7758,7 @@
             <a:r>
               <a:rPr lang="en-US" sz="1150" dirty="0">
                 <a:solidFill>
-                  <a:srgbClr val="4A5468"/>
+                  <a:srgbClr val="475569"/>
                 </a:solidFill>
                 <a:latin typeface="Calibri" pitchFamily="34" charset="0"/>
                 <a:ea typeface="Calibri" pitchFamily="34" charset="-122"/>
@@ -7787,7 +7787,7 @@
             </a:avLst>
           </a:prstGeom>
           <a:solidFill>
-            <a:srgbClr val="E3E7EE"/>
+            <a:srgbClr val="E2E8F0"/>
           </a:solidFill>
           <a:ln/>
         </p:spPr>
@@ -7819,7 +7819,7 @@
             <a:r>
               <a:rPr lang="en-US" sz="1200" b="1" dirty="0">
                 <a:solidFill>
-                  <a:srgbClr val="1D2433"/>
+                  <a:srgbClr val="0F172A"/>
                 </a:solidFill>
                 <a:latin typeface="Calibri" pitchFamily="34" charset="0"/>
                 <a:ea typeface="Calibri" pitchFamily="34" charset="-122"/>
@@ -7858,7 +7858,7 @@
             <a:r>
               <a:rPr lang="en-US" sz="1150" dirty="0">
                 <a:solidFill>
-                  <a:srgbClr val="4A5468"/>
+                  <a:srgbClr val="475569"/>
                 </a:solidFill>
                 <a:latin typeface="Calibri" pitchFamily="34" charset="0"/>
                 <a:ea typeface="Calibri" pitchFamily="34" charset="-122"/>
@@ -7887,7 +7887,7 @@
             </a:avLst>
           </a:prstGeom>
           <a:solidFill>
-            <a:srgbClr val="E3E7EE"/>
+            <a:srgbClr val="E2E8F0"/>
           </a:solidFill>
           <a:ln/>
         </p:spPr>
@@ -7919,7 +7919,7 @@
             <a:r>
               <a:rPr lang="en-US" sz="1200" b="1" dirty="0">
                 <a:solidFill>
-                  <a:srgbClr val="1D2433"/>
+                  <a:srgbClr val="0F172A"/>
                 </a:solidFill>
                 <a:latin typeface="Calibri" pitchFamily="34" charset="0"/>
                 <a:ea typeface="Calibri" pitchFamily="34" charset="-122"/>
@@ -7958,7 +7958,7 @@
             <a:r>
               <a:rPr lang="en-US" sz="1150" dirty="0">
                 <a:solidFill>
-                  <a:srgbClr val="4A5468"/>
+                  <a:srgbClr val="475569"/>
                 </a:solidFill>
                 <a:latin typeface="Calibri" pitchFamily="34" charset="0"/>
                 <a:ea typeface="Calibri" pitchFamily="34" charset="-122"/>
@@ -7987,7 +7987,7 @@
             </a:avLst>
           </a:prstGeom>
           <a:solidFill>
-            <a:srgbClr val="E3E7EE"/>
+            <a:srgbClr val="E2E8F0"/>
           </a:solidFill>
           <a:ln/>
         </p:spPr>
@@ -8019,7 +8019,7 @@
             <a:r>
               <a:rPr lang="en-US" sz="1200" b="1" dirty="0">
                 <a:solidFill>
-                  <a:srgbClr val="1D2433"/>
+                  <a:srgbClr val="0F172A"/>
                 </a:solidFill>
                 <a:latin typeface="Calibri" pitchFamily="34" charset="0"/>
                 <a:ea typeface="Calibri" pitchFamily="34" charset="-122"/>
@@ -8058,7 +8058,7 @@
             <a:r>
               <a:rPr lang="en-US" sz="1150" dirty="0">
                 <a:solidFill>
-                  <a:srgbClr val="4A5468"/>
+                  <a:srgbClr val="475569"/>
                 </a:solidFill>
                 <a:latin typeface="Calibri" pitchFamily="34" charset="0"/>
                 <a:ea typeface="Calibri" pitchFamily="34" charset="-122"/>
@@ -8087,7 +8087,7 @@
             </a:avLst>
           </a:prstGeom>
           <a:solidFill>
-            <a:srgbClr val="E3E7EE"/>
+            <a:srgbClr val="E2E8F0"/>
           </a:solidFill>
           <a:ln/>
         </p:spPr>
@@ -8119,7 +8119,7 @@
             <a:r>
               <a:rPr lang="en-US" sz="1200" b="1" dirty="0">
                 <a:solidFill>
-                  <a:srgbClr val="1D2433"/>
+                  <a:srgbClr val="0F172A"/>
                 </a:solidFill>
                 <a:latin typeface="Calibri" pitchFamily="34" charset="0"/>
                 <a:ea typeface="Calibri" pitchFamily="34" charset="-122"/>
@@ -8158,7 +8158,7 @@
             <a:r>
               <a:rPr lang="en-US" sz="1150" dirty="0">
                 <a:solidFill>
-                  <a:srgbClr val="4A5468"/>
+                  <a:srgbClr val="475569"/>
                 </a:solidFill>
                 <a:latin typeface="Calibri" pitchFamily="34" charset="0"/>
                 <a:ea typeface="Calibri" pitchFamily="34" charset="-122"/>
@@ -8187,7 +8187,7 @@
             </a:avLst>
           </a:prstGeom>
           <a:solidFill>
-            <a:srgbClr val="E3E7EE"/>
+            <a:srgbClr val="E2E8F0"/>
           </a:solidFill>
           <a:ln/>
         </p:spPr>
@@ -8219,7 +8219,7 @@
             <a:r>
               <a:rPr lang="en-US" sz="1200" b="1" dirty="0">
                 <a:solidFill>
-                  <a:srgbClr val="1D2433"/>
+                  <a:srgbClr val="0F172A"/>
                 </a:solidFill>
                 <a:latin typeface="Calibri" pitchFamily="34" charset="0"/>
                 <a:ea typeface="Calibri" pitchFamily="34" charset="-122"/>
@@ -8248,7 +8248,7 @@
             </a:avLst>
           </a:prstGeom>
           <a:solidFill>
-            <a:srgbClr val="F7EAE4"/>
+            <a:srgbClr val="FEF3C7"/>
           </a:solidFill>
           <a:ln/>
         </p:spPr>
@@ -8268,17 +8268,17 @@
             <a:avLst/>
           </a:prstGeom>
           <a:solidFill>
-            <a:srgbClr val="F9E8DD"/>
+            <a:srgbClr val="F9E9D7"/>
           </a:solidFill>
           <a:ln w="15875">
             <a:solidFill>
-              <a:srgbClr val="F1CBB3"/>
+              <a:srgbClr val="F1CEA5"/>
             </a:solidFill>
             <a:prstDash val="solid"/>
           </a:ln>
           <a:effectLst>
             <a:outerShdw sx="100000" sy="100000" kx="0" ky="0" algn="bl" rotWithShape="0" blurRad="127000" dist="25400" dir="5400000">
-              <a:srgbClr val="1E2B4A">
+              <a:srgbClr val="312E81">
                 <a:alpha val="8000"/>
               </a:srgbClr>
             </a:outerShdw>
@@ -8339,7 +8339,7 @@
             <a:r>
               <a:rPr lang="en-US" sz="1400" b="1" dirty="0">
                 <a:solidFill>
-                  <a:srgbClr val="1D2433"/>
+                  <a:srgbClr val="0F172A"/>
                 </a:solidFill>
                 <a:latin typeface="Calibri" pitchFamily="34" charset="0"/>
                 <a:ea typeface="Calibri" pitchFamily="34" charset="-122"/>
@@ -8381,7 +8381,7 @@
             <a:r>
               <a:rPr lang="en-US" sz="1100" dirty="0">
                 <a:solidFill>
-                  <a:srgbClr val="4A5468"/>
+                  <a:srgbClr val="475569"/>
                 </a:solidFill>
                 <a:latin typeface="Calibri" pitchFamily="34" charset="0"/>
                 <a:ea typeface="Calibri" pitchFamily="34" charset="-122"/>
@@ -8420,7 +8420,7 @@
             <a:r>
               <a:rPr lang="en-US" sz="1400" b="1" dirty="0">
                 <a:solidFill>
-                  <a:srgbClr val="1D2433"/>
+                  <a:srgbClr val="0F172A"/>
                 </a:solidFill>
                 <a:latin typeface="Calibri" pitchFamily="34" charset="0"/>
                 <a:ea typeface="Calibri" pitchFamily="34" charset="-122"/>
@@ -8459,7 +8459,7 @@
             <a:r>
               <a:rPr lang="en-US" sz="1150" dirty="0">
                 <a:solidFill>
-                  <a:srgbClr val="4A5468"/>
+                  <a:srgbClr val="475569"/>
                 </a:solidFill>
                 <a:latin typeface="Calibri" pitchFamily="34" charset="0"/>
                 <a:ea typeface="Calibri" pitchFamily="34" charset="-122"/>
@@ -8498,7 +8498,7 @@
             <a:r>
               <a:rPr lang="en-US" sz="1150" b="1" dirty="0">
                 <a:solidFill>
-                  <a:srgbClr val="1D2433"/>
+                  <a:srgbClr val="0F172A"/>
                 </a:solidFill>
                 <a:latin typeface="Calibri" pitchFamily="34" charset="0"/>
                 <a:ea typeface="Calibri" pitchFamily="34" charset="-122"/>
@@ -8537,7 +8537,7 @@
             <a:r>
               <a:rPr lang="en-US" sz="1150" dirty="0">
                 <a:solidFill>
-                  <a:srgbClr val="4A5468"/>
+                  <a:srgbClr val="475569"/>
                 </a:solidFill>
                 <a:latin typeface="Calibri" pitchFamily="34" charset="0"/>
                 <a:ea typeface="Calibri" pitchFamily="34" charset="-122"/>
@@ -8576,7 +8576,7 @@
             <a:r>
               <a:rPr lang="en-US" sz="1150" b="1" dirty="0">
                 <a:solidFill>
-                  <a:srgbClr val="1D2433"/>
+                  <a:srgbClr val="0F172A"/>
                 </a:solidFill>
                 <a:latin typeface="Calibri" pitchFamily="34" charset="0"/>
                 <a:ea typeface="Calibri" pitchFamily="34" charset="-122"/>
@@ -8615,7 +8615,7 @@
             <a:r>
               <a:rPr lang="en-US" sz="1150" dirty="0">
                 <a:solidFill>
-                  <a:srgbClr val="4A5468"/>
+                  <a:srgbClr val="475569"/>
                 </a:solidFill>
                 <a:latin typeface="Calibri" pitchFamily="34" charset="0"/>
                 <a:ea typeface="Calibri" pitchFamily="34" charset="-122"/>
@@ -8654,7 +8654,7 @@
             <a:r>
               <a:rPr lang="en-US" sz="1150" b="1" dirty="0">
                 <a:solidFill>
-                  <a:srgbClr val="1D2433"/>
+                  <a:srgbClr val="0F172A"/>
                 </a:solidFill>
                 <a:latin typeface="Calibri" pitchFamily="34" charset="0"/>
                 <a:ea typeface="Calibri" pitchFamily="34" charset="-122"/>
@@ -8732,7 +8732,7 @@
             <a:r>
               <a:rPr lang="en-US" sz="900" dirty="0">
                 <a:solidFill>
-                  <a:srgbClr val="8A93A5"/>
+                  <a:srgbClr val="94A3B8"/>
                 </a:solidFill>
                 <a:latin typeface="Calibri" pitchFamily="34" charset="0"/>
                 <a:ea typeface="Calibri" pitchFamily="34" charset="-122"/>
@@ -8771,7 +8771,7 @@
             <a:r>
               <a:rPr lang="en-US" sz="950" dirty="0">
                 <a:solidFill>
-                  <a:srgbClr val="8A93A5"/>
+                  <a:srgbClr val="94A3B8"/>
                 </a:solidFill>
                 <a:latin typeface="Calibri" pitchFamily="34" charset="0"/>
                 <a:ea typeface="Calibri" pitchFamily="34" charset="-122"/>
@@ -8866,7 +8866,7 @@
             <a:r>
               <a:rPr lang="en-US" sz="2700" b="1" dirty="0">
                 <a:solidFill>
-                  <a:srgbClr val="1E2B4A"/>
+                  <a:srgbClr val="312E81"/>
                 </a:solidFill>
                 <a:latin typeface="Calibri" pitchFamily="34" charset="0"/>
                 <a:ea typeface="Calibri" pitchFamily="34" charset="-122"/>
@@ -8908,7 +8908,7 @@
             <a:r>
               <a:rPr lang="en-US" sz="1300" dirty="0">
                 <a:solidFill>
-                  <a:srgbClr val="4A5468"/>
+                  <a:srgbClr val="475569"/>
                 </a:solidFill>
                 <a:latin typeface="Calibri" pitchFamily="34" charset="0"/>
                 <a:ea typeface="Calibri" pitchFamily="34" charset="-122"/>
@@ -8947,7 +8947,7 @@
             <a:r>
               <a:rPr lang="en-US" sz="1400" b="1" dirty="0">
                 <a:solidFill>
-                  <a:srgbClr val="1D2433"/>
+                  <a:srgbClr val="0F172A"/>
                 </a:solidFill>
                 <a:latin typeface="Calibri" pitchFamily="34" charset="0"/>
                 <a:ea typeface="Calibri" pitchFamily="34" charset="-122"/>
@@ -8986,7 +8986,7 @@
             <a:r>
               <a:rPr lang="en-US" sz="1300" b="1" dirty="0">
                 <a:solidFill>
-                  <a:srgbClr val="1D2433"/>
+                  <a:srgbClr val="0F172A"/>
                 </a:solidFill>
                 <a:latin typeface="Calibri" pitchFamily="34" charset="0"/>
                 <a:ea typeface="Calibri" pitchFamily="34" charset="-122"/>
@@ -9025,7 +9025,7 @@
             <a:r>
               <a:rPr lang="en-US" sz="1050" dirty="0">
                 <a:solidFill>
-                  <a:srgbClr val="8A93A5"/>
+                  <a:srgbClr val="94A3B8"/>
                 </a:solidFill>
                 <a:latin typeface="Calibri" pitchFamily="34" charset="0"/>
                 <a:ea typeface="Calibri" pitchFamily="34" charset="-122"/>
@@ -9054,7 +9054,7 @@
             </a:avLst>
           </a:prstGeom>
           <a:solidFill>
-            <a:srgbClr val="D96F2B"/>
+            <a:srgbClr val="D97706"/>
           </a:solidFill>
           <a:ln/>
         </p:spPr>
@@ -9086,7 +9086,7 @@
             <a:r>
               <a:rPr lang="en-US" sz="1200" b="1" dirty="0">
                 <a:solidFill>
-                  <a:srgbClr val="1D2433"/>
+                  <a:srgbClr val="0F172A"/>
                 </a:solidFill>
                 <a:latin typeface="Calibri" pitchFamily="34" charset="0"/>
                 <a:ea typeface="Calibri" pitchFamily="34" charset="-122"/>
@@ -9125,7 +9125,7 @@
             <a:r>
               <a:rPr lang="en-US" sz="1300" b="1" dirty="0">
                 <a:solidFill>
-                  <a:srgbClr val="D96F2B"/>
+                  <a:srgbClr val="D97706"/>
                 </a:solidFill>
                 <a:latin typeface="Calibri" pitchFamily="34" charset="0"/>
                 <a:ea typeface="Calibri" pitchFamily="34" charset="-122"/>
@@ -9164,7 +9164,7 @@
             <a:r>
               <a:rPr lang="en-US" sz="1300" b="1" dirty="0">
                 <a:solidFill>
-                  <a:srgbClr val="1D2433"/>
+                  <a:srgbClr val="0F172A"/>
                 </a:solidFill>
                 <a:latin typeface="Calibri" pitchFamily="34" charset="0"/>
                 <a:ea typeface="Calibri" pitchFamily="34" charset="-122"/>
@@ -9203,7 +9203,7 @@
             <a:r>
               <a:rPr lang="en-US" sz="1050" dirty="0">
                 <a:solidFill>
-                  <a:srgbClr val="8A93A5"/>
+                  <a:srgbClr val="94A3B8"/>
                 </a:solidFill>
                 <a:latin typeface="Calibri" pitchFamily="34" charset="0"/>
                 <a:ea typeface="Calibri" pitchFamily="34" charset="-122"/>
@@ -9232,7 +9232,7 @@
             </a:avLst>
           </a:prstGeom>
           <a:solidFill>
-            <a:srgbClr val="D96F2B"/>
+            <a:srgbClr val="D97706"/>
           </a:solidFill>
           <a:ln/>
         </p:spPr>
@@ -9264,7 +9264,7 @@
             <a:r>
               <a:rPr lang="en-US" sz="1200" b="1" dirty="0">
                 <a:solidFill>
-                  <a:srgbClr val="1D2433"/>
+                  <a:srgbClr val="0F172A"/>
                 </a:solidFill>
                 <a:latin typeface="Calibri" pitchFamily="34" charset="0"/>
                 <a:ea typeface="Calibri" pitchFamily="34" charset="-122"/>
@@ -9303,7 +9303,7 @@
             <a:r>
               <a:rPr lang="en-US" sz="1300" b="1" dirty="0">
                 <a:solidFill>
-                  <a:srgbClr val="D96F2B"/>
+                  <a:srgbClr val="D97706"/>
                 </a:solidFill>
                 <a:latin typeface="Calibri" pitchFamily="34" charset="0"/>
                 <a:ea typeface="Calibri" pitchFamily="34" charset="-122"/>
@@ -9342,7 +9342,7 @@
             <a:r>
               <a:rPr lang="en-US" sz="1300" b="1" dirty="0">
                 <a:solidFill>
-                  <a:srgbClr val="1D2433"/>
+                  <a:srgbClr val="0F172A"/>
                 </a:solidFill>
                 <a:latin typeface="Calibri" pitchFamily="34" charset="0"/>
                 <a:ea typeface="Calibri" pitchFamily="34" charset="-122"/>
@@ -9381,7 +9381,7 @@
             <a:r>
               <a:rPr lang="en-US" sz="1050" dirty="0">
                 <a:solidFill>
-                  <a:srgbClr val="8A93A5"/>
+                  <a:srgbClr val="94A3B8"/>
                 </a:solidFill>
                 <a:latin typeface="Calibri" pitchFamily="34" charset="0"/>
                 <a:ea typeface="Calibri" pitchFamily="34" charset="-122"/>
@@ -9410,7 +9410,7 @@
             </a:avLst>
           </a:prstGeom>
           <a:solidFill>
-            <a:srgbClr val="E3E7EE"/>
+            <a:srgbClr val="E2E8F0"/>
           </a:solidFill>
           <a:ln/>
         </p:spPr>
@@ -9442,7 +9442,7 @@
             <a:r>
               <a:rPr lang="en-US" sz="1200" b="1" dirty="0">
                 <a:solidFill>
-                  <a:srgbClr val="1D2433"/>
+                  <a:srgbClr val="0F172A"/>
                 </a:solidFill>
                 <a:latin typeface="Calibri" pitchFamily="34" charset="0"/>
                 <a:ea typeface="Calibri" pitchFamily="34" charset="-122"/>
@@ -9481,7 +9481,7 @@
             <a:r>
               <a:rPr lang="en-US" sz="1300" b="1" dirty="0">
                 <a:solidFill>
-                  <a:srgbClr val="1D2433"/>
+                  <a:srgbClr val="0F172A"/>
                 </a:solidFill>
                 <a:latin typeface="Calibri" pitchFamily="34" charset="0"/>
                 <a:ea typeface="Calibri" pitchFamily="34" charset="-122"/>
@@ -9520,7 +9520,7 @@
             <a:r>
               <a:rPr lang="en-US" sz="1050" dirty="0">
                 <a:solidFill>
-                  <a:srgbClr val="8A93A5"/>
+                  <a:srgbClr val="94A3B8"/>
                 </a:solidFill>
                 <a:latin typeface="Calibri" pitchFamily="34" charset="0"/>
                 <a:ea typeface="Calibri" pitchFamily="34" charset="-122"/>
@@ -9549,7 +9549,7 @@
             </a:avLst>
           </a:prstGeom>
           <a:solidFill>
-            <a:srgbClr val="E3E7EE"/>
+            <a:srgbClr val="E2E8F0"/>
           </a:solidFill>
           <a:ln/>
         </p:spPr>
@@ -9581,7 +9581,7 @@
             <a:r>
               <a:rPr lang="en-US" sz="1200" b="1" dirty="0">
                 <a:solidFill>
-                  <a:srgbClr val="1D2433"/>
+                  <a:srgbClr val="0F172A"/>
                 </a:solidFill>
                 <a:latin typeface="Calibri" pitchFamily="34" charset="0"/>
                 <a:ea typeface="Calibri" pitchFamily="34" charset="-122"/>
@@ -9620,7 +9620,7 @@
             <a:r>
               <a:rPr lang="en-US" sz="1300" b="1" dirty="0">
                 <a:solidFill>
-                  <a:srgbClr val="1D2433"/>
+                  <a:srgbClr val="0F172A"/>
                 </a:solidFill>
                 <a:latin typeface="Calibri" pitchFamily="34" charset="0"/>
                 <a:ea typeface="Calibri" pitchFamily="34" charset="-122"/>
@@ -9659,7 +9659,7 @@
             <a:r>
               <a:rPr lang="en-US" sz="1050" dirty="0">
                 <a:solidFill>
-                  <a:srgbClr val="8A93A5"/>
+                  <a:srgbClr val="94A3B8"/>
                 </a:solidFill>
                 <a:latin typeface="Calibri" pitchFamily="34" charset="0"/>
                 <a:ea typeface="Calibri" pitchFamily="34" charset="-122"/>
@@ -9688,7 +9688,7 @@
             </a:avLst>
           </a:prstGeom>
           <a:solidFill>
-            <a:srgbClr val="E3E7EE"/>
+            <a:srgbClr val="E2E8F0"/>
           </a:solidFill>
           <a:ln/>
         </p:spPr>
@@ -9720,7 +9720,7 @@
             <a:r>
               <a:rPr lang="en-US" sz="1200" b="1" dirty="0">
                 <a:solidFill>
-                  <a:srgbClr val="1D2433"/>
+                  <a:srgbClr val="0F172A"/>
                 </a:solidFill>
                 <a:latin typeface="Calibri" pitchFamily="34" charset="0"/>
                 <a:ea typeface="Calibri" pitchFamily="34" charset="-122"/>
@@ -9747,7 +9747,7 @@
             <a:avLst/>
           </a:prstGeom>
           <a:solidFill>
-            <a:srgbClr val="B9C0CC"/>
+            <a:srgbClr val="CBD5E1"/>
           </a:solidFill>
           <a:ln/>
         </p:spPr>
@@ -9769,7 +9769,7 @@
             </a:avLst>
           </a:prstGeom>
           <a:solidFill>
-            <a:srgbClr val="1E2B4A"/>
+            <a:srgbClr val="312E81"/>
           </a:solidFill>
           <a:ln/>
         </p:spPr>
@@ -9840,7 +9840,7 @@
             <a:r>
               <a:rPr lang="en-US" sz="1150" b="1" dirty="0">
                 <a:solidFill>
-                  <a:srgbClr val="D96F2B"/>
+                  <a:srgbClr val="D97706"/>
                 </a:solidFill>
                 <a:latin typeface="Calibri" pitchFamily="34" charset="0"/>
                 <a:ea typeface="Calibri" pitchFamily="34" charset="-122"/>
@@ -9921,7 +9921,7 @@
             <a:r>
               <a:rPr lang="en-US" sz="1400" b="1" dirty="0">
                 <a:solidFill>
-                  <a:srgbClr val="1D2433"/>
+                  <a:srgbClr val="0F172A"/>
                 </a:solidFill>
                 <a:latin typeface="Calibri" pitchFamily="34" charset="0"/>
                 <a:ea typeface="Calibri" pitchFamily="34" charset="-122"/>
@@ -9963,7 +9963,7 @@
             <a:r>
               <a:rPr lang="en-US" sz="1100" dirty="0">
                 <a:solidFill>
-                  <a:srgbClr val="4A5468"/>
+                  <a:srgbClr val="475569"/>
                 </a:solidFill>
                 <a:latin typeface="Calibri" pitchFamily="34" charset="0"/>
                 <a:ea typeface="Calibri" pitchFamily="34" charset="-122"/>
@@ -10002,7 +10002,7 @@
             <a:r>
               <a:rPr lang="en-US" sz="900" dirty="0">
                 <a:solidFill>
-                  <a:srgbClr val="8A93A5"/>
+                  <a:srgbClr val="94A3B8"/>
                 </a:solidFill>
                 <a:latin typeface="Calibri" pitchFamily="34" charset="0"/>
                 <a:ea typeface="Calibri" pitchFamily="34" charset="-122"/>
@@ -10041,7 +10041,7 @@
             <a:r>
               <a:rPr lang="en-US" sz="950" dirty="0">
                 <a:solidFill>
-                  <a:srgbClr val="8A93A5"/>
+                  <a:srgbClr val="94A3B8"/>
                 </a:solidFill>
                 <a:latin typeface="Calibri" pitchFamily="34" charset="0"/>
                 <a:ea typeface="Calibri" pitchFamily="34" charset="-122"/>
@@ -10136,7 +10136,7 @@
             <a:r>
               <a:rPr lang="en-US" sz="2700" b="1" dirty="0">
                 <a:solidFill>
-                  <a:srgbClr val="1E2B4A"/>
+                  <a:srgbClr val="312E81"/>
                 </a:solidFill>
                 <a:latin typeface="Calibri" pitchFamily="34" charset="0"/>
                 <a:ea typeface="Calibri" pitchFamily="34" charset="-122"/>
@@ -10163,17 +10163,17 @@
             <a:avLst/>
           </a:prstGeom>
           <a:solidFill>
-            <a:srgbClr val="E1E6EF"/>
+            <a:srgbClr val="E3E1FB"/>
           </a:solidFill>
           <a:ln w="15875">
             <a:solidFill>
-              <a:srgbClr val="BBC7DC"/>
+              <a:srgbClr val="C0BCF6"/>
             </a:solidFill>
             <a:prstDash val="solid"/>
           </a:ln>
           <a:effectLst>
             <a:outerShdw sx="100000" sy="100000" kx="0" ky="0" algn="bl" rotWithShape="0" blurRad="127000" dist="25400" dir="5400000">
-              <a:srgbClr val="1E2B4A">
+              <a:srgbClr val="312E81">
                 <a:alpha val="8000"/>
               </a:srgbClr>
             </a:outerShdw>
@@ -10231,7 +10231,7 @@
             <a:r>
               <a:rPr lang="en-US" sz="1500" b="1" dirty="0">
                 <a:solidFill>
-                  <a:srgbClr val="1D2433"/>
+                  <a:srgbClr val="0F172A"/>
                 </a:solidFill>
                 <a:latin typeface="Calibri" pitchFamily="34" charset="0"/>
                 <a:ea typeface="Calibri" pitchFamily="34" charset="-122"/>
@@ -10270,7 +10270,7 @@
             <a:r>
               <a:rPr lang="en-US" sz="1100" b="1" dirty="0">
                 <a:solidFill>
-                  <a:srgbClr val="41639E"/>
+                  <a:srgbClr val="4F46E5"/>
                 </a:solidFill>
                 <a:latin typeface="Calibri" pitchFamily="34" charset="0"/>
                 <a:ea typeface="Calibri" pitchFamily="34" charset="-122"/>
@@ -10312,7 +10312,7 @@
             <a:r>
               <a:rPr lang="en-US" sz="1200" dirty="0">
                 <a:solidFill>
-                  <a:srgbClr val="4A5468"/>
+                  <a:srgbClr val="475569"/>
                 </a:solidFill>
                 <a:latin typeface="Calibri" pitchFamily="34" charset="0"/>
                 <a:ea typeface="Calibri" pitchFamily="34" charset="-122"/>
@@ -10339,17 +10339,17 @@
             <a:avLst/>
           </a:prstGeom>
           <a:solidFill>
-            <a:srgbClr val="E0EDEF"/>
+            <a:srgbClr val="F9DCE9"/>
           </a:solidFill>
           <a:ln w="15875">
             <a:solidFill>
-              <a:srgbClr val="BAD6DB"/>
+              <a:srgbClr val="F2B1CE"/>
             </a:solidFill>
             <a:prstDash val="solid"/>
           </a:ln>
           <a:effectLst>
             <a:outerShdw sx="100000" sy="100000" kx="0" ky="0" algn="bl" rotWithShape="0" blurRad="127000" dist="25400" dir="5400000">
-              <a:srgbClr val="1E2B4A">
+              <a:srgbClr val="312E81">
                 <a:alpha val="8000"/>
               </a:srgbClr>
             </a:outerShdw>
@@ -10407,7 +10407,7 @@
             <a:r>
               <a:rPr lang="en-US" sz="1500" b="1" dirty="0">
                 <a:solidFill>
-                  <a:srgbClr val="1D2433"/>
+                  <a:srgbClr val="0F172A"/>
                 </a:solidFill>
                 <a:latin typeface="Calibri" pitchFamily="34" charset="0"/>
                 <a:ea typeface="Calibri" pitchFamily="34" charset="-122"/>
@@ -10446,7 +10446,7 @@
             <a:r>
               <a:rPr lang="en-US" sz="1100" b="1" dirty="0">
                 <a:solidFill>
-                  <a:srgbClr val="3E8C9A"/>
+                  <a:srgbClr val="DB2777"/>
                 </a:solidFill>
                 <a:latin typeface="Calibri" pitchFamily="34" charset="0"/>
                 <a:ea typeface="Calibri" pitchFamily="34" charset="-122"/>
@@ -10488,7 +10488,7 @@
             <a:r>
               <a:rPr lang="en-US" sz="1200" dirty="0">
                 <a:solidFill>
-                  <a:srgbClr val="4A5468"/>
+                  <a:srgbClr val="475569"/>
                 </a:solidFill>
                 <a:latin typeface="Calibri" pitchFamily="34" charset="0"/>
                 <a:ea typeface="Calibri" pitchFamily="34" charset="-122"/>
@@ -10515,17 +10515,17 @@
             <a:avLst/>
           </a:prstGeom>
           <a:solidFill>
-            <a:srgbClr val="F6ECDC"/>
+            <a:srgbClr val="D7EDF3"/>
           </a:solidFill>
           <a:ln w="15875">
             <a:solidFill>
-              <a:srgbClr val="ECD5B0"/>
+              <a:srgbClr val="A6D7E3"/>
             </a:solidFill>
             <a:prstDash val="solid"/>
           </a:ln>
           <a:effectLst>
             <a:outerShdw sx="100000" sy="100000" kx="0" ky="0" algn="bl" rotWithShape="0" blurRad="127000" dist="25400" dir="5400000">
-              <a:srgbClr val="1E2B4A">
+              <a:srgbClr val="312E81">
                 <a:alpha val="8000"/>
               </a:srgbClr>
             </a:outerShdw>
@@ -10583,7 +10583,7 @@
             <a:r>
               <a:rPr lang="en-US" sz="1500" b="1" dirty="0">
                 <a:solidFill>
-                  <a:srgbClr val="1D2433"/>
+                  <a:srgbClr val="0F172A"/>
                 </a:solidFill>
                 <a:latin typeface="Calibri" pitchFamily="34" charset="0"/>
                 <a:ea typeface="Calibri" pitchFamily="34" charset="-122"/>
@@ -10622,7 +10622,7 @@
             <a:r>
               <a:rPr lang="en-US" sz="1100" b="1" dirty="0">
                 <a:solidFill>
-                  <a:srgbClr val="C98A24"/>
+                  <a:srgbClr val="0891B2"/>
                 </a:solidFill>
                 <a:latin typeface="Calibri" pitchFamily="34" charset="0"/>
                 <a:ea typeface="Calibri" pitchFamily="34" charset="-122"/>
@@ -10664,7 +10664,7 @@
             <a:r>
               <a:rPr lang="en-US" sz="1200" dirty="0">
                 <a:solidFill>
-                  <a:srgbClr val="4A5468"/>
+                  <a:srgbClr val="475569"/>
                 </a:solidFill>
                 <a:latin typeface="Calibri" pitchFamily="34" charset="0"/>
                 <a:ea typeface="Calibri" pitchFamily="34" charset="-122"/>
@@ -10691,17 +10691,17 @@
             <a:avLst/>
           </a:prstGeom>
           <a:solidFill>
-            <a:srgbClr val="F9E8DD"/>
+            <a:srgbClr val="F9E9D7"/>
           </a:solidFill>
           <a:ln w="15875">
             <a:solidFill>
-              <a:srgbClr val="F1CBB3"/>
+              <a:srgbClr val="F1CEA5"/>
             </a:solidFill>
             <a:prstDash val="solid"/>
           </a:ln>
           <a:effectLst>
             <a:outerShdw sx="100000" sy="100000" kx="0" ky="0" algn="bl" rotWithShape="0" blurRad="127000" dist="25400" dir="5400000">
-              <a:srgbClr val="1E2B4A">
+              <a:srgbClr val="312E81">
                 <a:alpha val="8000"/>
               </a:srgbClr>
             </a:outerShdw>
@@ -10759,7 +10759,7 @@
             <a:r>
               <a:rPr lang="en-US" sz="1500" b="1" dirty="0">
                 <a:solidFill>
-                  <a:srgbClr val="1D2433"/>
+                  <a:srgbClr val="0F172A"/>
                 </a:solidFill>
                 <a:latin typeface="Calibri" pitchFamily="34" charset="0"/>
                 <a:ea typeface="Calibri" pitchFamily="34" charset="-122"/>
@@ -10798,7 +10798,7 @@
             <a:r>
               <a:rPr lang="en-US" sz="1100" b="1" dirty="0">
                 <a:solidFill>
-                  <a:srgbClr val="D96F2B"/>
+                  <a:srgbClr val="D97706"/>
                 </a:solidFill>
                 <a:latin typeface="Calibri" pitchFamily="34" charset="0"/>
                 <a:ea typeface="Calibri" pitchFamily="34" charset="-122"/>
@@ -10840,7 +10840,7 @@
             <a:r>
               <a:rPr lang="en-US" sz="1200" dirty="0">
                 <a:solidFill>
-                  <a:srgbClr val="4A5468"/>
+                  <a:srgbClr val="475569"/>
                 </a:solidFill>
                 <a:latin typeface="Calibri" pitchFamily="34" charset="0"/>
                 <a:ea typeface="Calibri" pitchFamily="34" charset="-122"/>
@@ -10901,7 +10901,7 @@
             <a:r>
               <a:rPr lang="en-US" sz="900" dirty="0">
                 <a:solidFill>
-                  <a:srgbClr val="8A93A5"/>
+                  <a:srgbClr val="94A3B8"/>
                 </a:solidFill>
                 <a:latin typeface="Calibri" pitchFamily="34" charset="0"/>
                 <a:ea typeface="Calibri" pitchFamily="34" charset="-122"/>
@@ -10940,7 +10940,7 @@
             <a:r>
               <a:rPr lang="en-US" sz="950" dirty="0">
                 <a:solidFill>
-                  <a:srgbClr val="8A93A5"/>
+                  <a:srgbClr val="94A3B8"/>
                 </a:solidFill>
                 <a:latin typeface="Calibri" pitchFamily="34" charset="0"/>
                 <a:ea typeface="Calibri" pitchFamily="34" charset="-122"/>
@@ -11035,7 +11035,7 @@
             <a:r>
               <a:rPr lang="en-US" sz="2700" b="1" dirty="0">
                 <a:solidFill>
-                  <a:srgbClr val="1E2B4A"/>
+                  <a:srgbClr val="312E81"/>
                 </a:solidFill>
                 <a:latin typeface="Calibri" pitchFamily="34" charset="0"/>
                 <a:ea typeface="Calibri" pitchFamily="34" charset="-122"/>
@@ -11074,7 +11074,7 @@
             <a:r>
               <a:rPr lang="en-US" sz="2600" b="1" dirty="0">
                 <a:solidFill>
-                  <a:srgbClr val="D96F2B"/>
+                  <a:srgbClr val="D97706"/>
                 </a:solidFill>
                 <a:latin typeface="Calibri" pitchFamily="34" charset="0"/>
                 <a:ea typeface="Calibri" pitchFamily="34" charset="-122"/>
@@ -11116,7 +11116,7 @@
             <a:r>
               <a:rPr lang="en-US" sz="1200" i="1" dirty="0">
                 <a:solidFill>
-                  <a:srgbClr val="4A5468"/>
+                  <a:srgbClr val="475569"/>
                 </a:solidFill>
                 <a:latin typeface="Calibri" pitchFamily="34" charset="0"/>
                 <a:ea typeface="Calibri" pitchFamily="34" charset="-122"/>
@@ -11158,7 +11158,7 @@
             <a:r>
               <a:rPr lang="en-US" sz="1250" dirty="0">
                 <a:solidFill>
-                  <a:srgbClr val="1D2433"/>
+                  <a:srgbClr val="0F172A"/>
                 </a:solidFill>
                 <a:latin typeface="Calibri" pitchFamily="34" charset="0"/>
                 <a:ea typeface="Calibri" pitchFamily="34" charset="-122"/>
@@ -11197,7 +11197,7 @@
             <a:r>
               <a:rPr lang="en-US" sz="1350" b="1" dirty="0">
                 <a:solidFill>
-                  <a:srgbClr val="D96F2B"/>
+                  <a:srgbClr val="D97706"/>
                 </a:solidFill>
                 <a:latin typeface="Calibri" pitchFamily="34" charset="0"/>
                 <a:ea typeface="Calibri" pitchFamily="34" charset="-122"/>
@@ -11236,7 +11236,7 @@
             <a:r>
               <a:rPr lang="en-US" sz="2600" b="1" dirty="0">
                 <a:solidFill>
-                  <a:srgbClr val="3E8C9A"/>
+                  <a:srgbClr val="DB2777"/>
                 </a:solidFill>
                 <a:latin typeface="Calibri" pitchFamily="34" charset="0"/>
                 <a:ea typeface="Calibri" pitchFamily="34" charset="-122"/>
@@ -11278,7 +11278,7 @@
             <a:r>
               <a:rPr lang="en-US" sz="1200" i="1" dirty="0">
                 <a:solidFill>
-                  <a:srgbClr val="4A5468"/>
+                  <a:srgbClr val="475569"/>
                 </a:solidFill>
                 <a:latin typeface="Calibri" pitchFamily="34" charset="0"/>
                 <a:ea typeface="Calibri" pitchFamily="34" charset="-122"/>
@@ -11320,7 +11320,7 @@
             <a:r>
               <a:rPr lang="en-US" sz="1250" dirty="0">
                 <a:solidFill>
-                  <a:srgbClr val="1D2433"/>
+                  <a:srgbClr val="0F172A"/>
                 </a:solidFill>
                 <a:latin typeface="Calibri" pitchFamily="34" charset="0"/>
                 <a:ea typeface="Calibri" pitchFamily="34" charset="-122"/>
@@ -11359,7 +11359,7 @@
             <a:r>
               <a:rPr lang="en-US" sz="1350" b="1" dirty="0">
                 <a:solidFill>
-                  <a:srgbClr val="3E8C9A"/>
+                  <a:srgbClr val="DB2777"/>
                 </a:solidFill>
                 <a:latin typeface="Calibri" pitchFamily="34" charset="0"/>
                 <a:ea typeface="Calibri" pitchFamily="34" charset="-122"/>
@@ -11386,17 +11386,17 @@
             <a:avLst/>
           </a:prstGeom>
           <a:solidFill>
-            <a:srgbClr val="F9E8DD"/>
+            <a:srgbClr val="F9E9D7"/>
           </a:solidFill>
           <a:ln w="15875">
             <a:solidFill>
-              <a:srgbClr val="F1CBB3"/>
+              <a:srgbClr val="F1CEA5"/>
             </a:solidFill>
             <a:prstDash val="solid"/>
           </a:ln>
           <a:effectLst>
             <a:outerShdw sx="100000" sy="100000" kx="0" ky="0" algn="bl" rotWithShape="0" blurRad="127000" dist="25400" dir="5400000">
-              <a:srgbClr val="1E2B4A">
+              <a:srgbClr val="312E81">
                 <a:alpha val="8000"/>
               </a:srgbClr>
             </a:outerShdw>
@@ -11442,17 +11442,17 @@
             <a:avLst/>
           </a:prstGeom>
           <a:solidFill>
-            <a:srgbClr val="E0EDEF"/>
+            <a:srgbClr val="F9DCE9"/>
           </a:solidFill>
           <a:ln w="15875">
             <a:solidFill>
-              <a:srgbClr val="BAD6DB"/>
+              <a:srgbClr val="F2B1CE"/>
             </a:solidFill>
             <a:prstDash val="solid"/>
           </a:ln>
           <a:effectLst>
             <a:outerShdw sx="100000" sy="100000" kx="0" ky="0" algn="bl" rotWithShape="0" blurRad="127000" dist="25400" dir="5400000">
-              <a:srgbClr val="1E2B4A">
+              <a:srgbClr val="312E81">
                 <a:alpha val="8000"/>
               </a:srgbClr>
             </a:outerShdw>
@@ -11510,7 +11510,7 @@
             <a:r>
               <a:rPr lang="en-US" sz="950" dirty="0">
                 <a:solidFill>
-                  <a:srgbClr val="8A93A5"/>
+                  <a:srgbClr val="94A3B8"/>
                 </a:solidFill>
                 <a:latin typeface="Calibri" pitchFamily="34" charset="0"/>
                 <a:ea typeface="Calibri" pitchFamily="34" charset="-122"/>
@@ -11605,7 +11605,7 @@
             <a:r>
               <a:rPr lang="en-US" sz="2700" b="1" dirty="0">
                 <a:solidFill>
-                  <a:srgbClr val="1E2B4A"/>
+                  <a:srgbClr val="312E81"/>
                 </a:solidFill>
                 <a:latin typeface="Calibri" pitchFamily="34" charset="0"/>
                 <a:ea typeface="Calibri" pitchFamily="34" charset="-122"/>
@@ -11647,7 +11647,7 @@
             <a:r>
               <a:rPr lang="en-US" sz="1300" dirty="0">
                 <a:solidFill>
-                  <a:srgbClr val="4A5468"/>
+                  <a:srgbClr val="475569"/>
                 </a:solidFill>
                 <a:latin typeface="Calibri" pitchFamily="34" charset="0"/>
                 <a:ea typeface="Calibri" pitchFamily="34" charset="-122"/>
@@ -11674,17 +11674,17 @@
             <a:avLst/>
           </a:prstGeom>
           <a:solidFill>
-            <a:srgbClr val="F6ECDC"/>
+            <a:srgbClr val="D7EDF3"/>
           </a:solidFill>
           <a:ln w="15875">
             <a:solidFill>
-              <a:srgbClr val="ECD5B0"/>
+              <a:srgbClr val="A6D7E3"/>
             </a:solidFill>
             <a:prstDash val="solid"/>
           </a:ln>
           <a:effectLst>
             <a:outerShdw sx="100000" sy="100000" kx="0" ky="0" algn="bl" rotWithShape="0" blurRad="127000" dist="25400" dir="5400000">
-              <a:srgbClr val="1E2B4A">
+              <a:srgbClr val="312E81">
                 <a:alpha val="8000"/>
               </a:srgbClr>
             </a:outerShdw>
@@ -11745,7 +11745,7 @@
             <a:r>
               <a:rPr lang="en-US" sz="1450" b="1" dirty="0">
                 <a:solidFill>
-                  <a:srgbClr val="1D2433"/>
+                  <a:srgbClr val="0F172A"/>
                 </a:solidFill>
                 <a:latin typeface="Calibri" pitchFamily="34" charset="0"/>
                 <a:ea typeface="Calibri" pitchFamily="34" charset="-122"/>
@@ -11787,7 +11787,7 @@
             <a:r>
               <a:rPr lang="en-US" sz="1150" dirty="0">
                 <a:solidFill>
-                  <a:srgbClr val="4A5468"/>
+                  <a:srgbClr val="475569"/>
                 </a:solidFill>
                 <a:latin typeface="Calibri" pitchFamily="34" charset="0"/>
                 <a:ea typeface="Calibri" pitchFamily="34" charset="-122"/>
@@ -11814,17 +11814,17 @@
             <a:avLst/>
           </a:prstGeom>
           <a:solidFill>
-            <a:srgbClr val="E1E6EF"/>
+            <a:srgbClr val="E3E1FB"/>
           </a:solidFill>
           <a:ln w="15875">
             <a:solidFill>
-              <a:srgbClr val="BBC7DC"/>
+              <a:srgbClr val="C0BCF6"/>
             </a:solidFill>
             <a:prstDash val="solid"/>
           </a:ln>
           <a:effectLst>
             <a:outerShdw sx="100000" sy="100000" kx="0" ky="0" algn="bl" rotWithShape="0" blurRad="127000" dist="25400" dir="5400000">
-              <a:srgbClr val="1E2B4A">
+              <a:srgbClr val="312E81">
                 <a:alpha val="8000"/>
               </a:srgbClr>
             </a:outerShdw>
@@ -11885,7 +11885,7 @@
             <a:r>
               <a:rPr lang="en-US" sz="1450" b="1" dirty="0">
                 <a:solidFill>
-                  <a:srgbClr val="1D2433"/>
+                  <a:srgbClr val="0F172A"/>
                 </a:solidFill>
                 <a:latin typeface="Calibri" pitchFamily="34" charset="0"/>
                 <a:ea typeface="Calibri" pitchFamily="34" charset="-122"/>
@@ -11927,7 +11927,7 @@
             <a:r>
               <a:rPr lang="en-US" sz="1150" dirty="0">
                 <a:solidFill>
-                  <a:srgbClr val="4A5468"/>
+                  <a:srgbClr val="475569"/>
                 </a:solidFill>
                 <a:latin typeface="Calibri" pitchFamily="34" charset="0"/>
                 <a:ea typeface="Calibri" pitchFamily="34" charset="-122"/>
@@ -11954,17 +11954,17 @@
             <a:avLst/>
           </a:prstGeom>
           <a:solidFill>
-            <a:srgbClr val="E0EDEF"/>
+            <a:srgbClr val="F9DCE9"/>
           </a:solidFill>
           <a:ln w="15875">
             <a:solidFill>
-              <a:srgbClr val="BAD6DB"/>
+              <a:srgbClr val="F2B1CE"/>
             </a:solidFill>
             <a:prstDash val="solid"/>
           </a:ln>
           <a:effectLst>
             <a:outerShdw sx="100000" sy="100000" kx="0" ky="0" algn="bl" rotWithShape="0" blurRad="127000" dist="25400" dir="5400000">
-              <a:srgbClr val="1E2B4A">
+              <a:srgbClr val="312E81">
                 <a:alpha val="8000"/>
               </a:srgbClr>
             </a:outerShdw>
@@ -12025,7 +12025,7 @@
             <a:r>
               <a:rPr lang="en-US" sz="1450" b="1" dirty="0">
                 <a:solidFill>
-                  <a:srgbClr val="1D2433"/>
+                  <a:srgbClr val="0F172A"/>
                 </a:solidFill>
                 <a:latin typeface="Calibri" pitchFamily="34" charset="0"/>
                 <a:ea typeface="Calibri" pitchFamily="34" charset="-122"/>
@@ -12067,7 +12067,7 @@
             <a:r>
               <a:rPr lang="en-US" sz="1150" dirty="0">
                 <a:solidFill>
-                  <a:srgbClr val="4A5468"/>
+                  <a:srgbClr val="475569"/>
                 </a:solidFill>
                 <a:latin typeface="Calibri" pitchFamily="34" charset="0"/>
                 <a:ea typeface="Calibri" pitchFamily="34" charset="-122"/>
@@ -12106,7 +12106,7 @@
             <a:r>
               <a:rPr lang="en-US" sz="950" dirty="0">
                 <a:solidFill>
-                  <a:srgbClr val="8A93A5"/>
+                  <a:srgbClr val="94A3B8"/>
                 </a:solidFill>
                 <a:latin typeface="Calibri" pitchFamily="34" charset="0"/>
                 <a:ea typeface="Calibri" pitchFamily="34" charset="-122"/>
@@ -12201,7 +12201,7 @@
             <a:r>
               <a:rPr lang="en-US" sz="2700" b="1" dirty="0">
                 <a:solidFill>
-                  <a:srgbClr val="1E2B4A"/>
+                  <a:srgbClr val="312E81"/>
                 </a:solidFill>
                 <a:latin typeface="Calibri" pitchFamily="34" charset="0"/>
                 <a:ea typeface="Calibri" pitchFamily="34" charset="-122"/>
@@ -12228,17 +12228,17 @@
             <a:avLst/>
           </a:prstGeom>
           <a:solidFill>
-            <a:srgbClr val="F9E8DD"/>
+            <a:srgbClr val="F9E9D7"/>
           </a:solidFill>
           <a:ln w="15875">
             <a:solidFill>
-              <a:srgbClr val="F1CBB3"/>
+              <a:srgbClr val="F1CEA5"/>
             </a:solidFill>
             <a:prstDash val="solid"/>
           </a:ln>
           <a:effectLst>
             <a:outerShdw sx="100000" sy="100000" kx="0" ky="0" algn="bl" rotWithShape="0" blurRad="127000" dist="25400" dir="5400000">
-              <a:srgbClr val="1E2B4A">
+              <a:srgbClr val="312E81">
                 <a:alpha val="8000"/>
               </a:srgbClr>
             </a:outerShdw>
@@ -12296,7 +12296,7 @@
             <a:r>
               <a:rPr lang="en-US" sz="1700" b="1" dirty="0">
                 <a:solidFill>
-                  <a:srgbClr val="1D2433"/>
+                  <a:srgbClr val="0F172A"/>
                 </a:solidFill>
                 <a:latin typeface="Calibri" pitchFamily="34" charset="0"/>
                 <a:ea typeface="Calibri" pitchFamily="34" charset="-122"/>
@@ -12335,7 +12335,7 @@
             <a:r>
               <a:rPr lang="en-US" sz="1350" b="1" dirty="0">
                 <a:solidFill>
-                  <a:srgbClr val="D96F2B"/>
+                  <a:srgbClr val="D97706"/>
                 </a:solidFill>
                 <a:latin typeface="Calibri" pitchFamily="34" charset="0"/>
                 <a:ea typeface="Calibri" pitchFamily="34" charset="-122"/>
@@ -12377,7 +12377,7 @@
             <a:r>
               <a:rPr lang="en-US" sz="1200" dirty="0">
                 <a:solidFill>
-                  <a:srgbClr val="4A5468"/>
+                  <a:srgbClr val="475569"/>
                 </a:solidFill>
                 <a:latin typeface="Calibri" pitchFamily="34" charset="0"/>
                 <a:ea typeface="Calibri" pitchFamily="34" charset="-122"/>
@@ -12416,7 +12416,7 @@
             <a:r>
               <a:rPr lang="en-US" sz="1350" b="1" dirty="0">
                 <a:solidFill>
-                  <a:srgbClr val="D96F2B"/>
+                  <a:srgbClr val="D97706"/>
                 </a:solidFill>
                 <a:latin typeface="Calibri" pitchFamily="34" charset="0"/>
                 <a:ea typeface="Calibri" pitchFamily="34" charset="-122"/>
@@ -12458,7 +12458,7 @@
             <a:r>
               <a:rPr lang="en-US" sz="1200" dirty="0">
                 <a:solidFill>
-                  <a:srgbClr val="4A5468"/>
+                  <a:srgbClr val="475569"/>
                 </a:solidFill>
                 <a:latin typeface="Calibri" pitchFamily="34" charset="0"/>
                 <a:ea typeface="Calibri" pitchFamily="34" charset="-122"/>
@@ -12485,17 +12485,17 @@
             <a:avLst/>
           </a:prstGeom>
           <a:solidFill>
-            <a:srgbClr val="E0EDEF"/>
+            <a:srgbClr val="F9DCE9"/>
           </a:solidFill>
           <a:ln w="15875">
             <a:solidFill>
-              <a:srgbClr val="BAD6DB"/>
+              <a:srgbClr val="F2B1CE"/>
             </a:solidFill>
             <a:prstDash val="solid"/>
           </a:ln>
           <a:effectLst>
             <a:outerShdw sx="100000" sy="100000" kx="0" ky="0" algn="bl" rotWithShape="0" blurRad="127000" dist="25400" dir="5400000">
-              <a:srgbClr val="1E2B4A">
+              <a:srgbClr val="312E81">
                 <a:alpha val="8000"/>
               </a:srgbClr>
             </a:outerShdw>
@@ -12553,7 +12553,7 @@
             <a:r>
               <a:rPr lang="en-US" sz="1700" b="1" dirty="0">
                 <a:solidFill>
-                  <a:srgbClr val="1D2433"/>
+                  <a:srgbClr val="0F172A"/>
                 </a:solidFill>
                 <a:latin typeface="Calibri" pitchFamily="34" charset="0"/>
                 <a:ea typeface="Calibri" pitchFamily="34" charset="-122"/>
@@ -12580,7 +12580,7 @@
             <a:avLst/>
           </a:prstGeom>
           <a:solidFill>
-            <a:srgbClr val="3E8C9A"/>
+            <a:srgbClr val="DB2777"/>
           </a:solidFill>
           <a:ln/>
         </p:spPr>
@@ -12654,7 +12654,7 @@
             <a:r>
               <a:rPr lang="en-US" sz="1200" dirty="0">
                 <a:solidFill>
-                  <a:srgbClr val="4A5468"/>
+                  <a:srgbClr val="475569"/>
                 </a:solidFill>
                 <a:latin typeface="Calibri" pitchFamily="34" charset="0"/>
                 <a:ea typeface="Calibri" pitchFamily="34" charset="-122"/>
@@ -12681,7 +12681,7 @@
             <a:avLst/>
           </a:prstGeom>
           <a:solidFill>
-            <a:srgbClr val="3E8C9A"/>
+            <a:srgbClr val="DB2777"/>
           </a:solidFill>
           <a:ln/>
         </p:spPr>
@@ -12755,7 +12755,7 @@
             <a:r>
               <a:rPr lang="en-US" sz="1200" dirty="0">
                 <a:solidFill>
-                  <a:srgbClr val="4A5468"/>
+                  <a:srgbClr val="475569"/>
                 </a:solidFill>
                 <a:latin typeface="Calibri" pitchFamily="34" charset="0"/>
                 <a:ea typeface="Calibri" pitchFamily="34" charset="-122"/>
@@ -12782,7 +12782,7 @@
             <a:avLst/>
           </a:prstGeom>
           <a:solidFill>
-            <a:srgbClr val="3E8C9A"/>
+            <a:srgbClr val="DB2777"/>
           </a:solidFill>
           <a:ln/>
         </p:spPr>
@@ -12856,7 +12856,7 @@
             <a:r>
               <a:rPr lang="en-US" sz="1200" dirty="0">
                 <a:solidFill>
-                  <a:srgbClr val="4A5468"/>
+                  <a:srgbClr val="475569"/>
                 </a:solidFill>
                 <a:latin typeface="Calibri" pitchFamily="34" charset="0"/>
                 <a:ea typeface="Calibri" pitchFamily="34" charset="-122"/>
@@ -12895,7 +12895,7 @@
             <a:r>
               <a:rPr lang="en-US" sz="950" dirty="0">
                 <a:solidFill>
-                  <a:srgbClr val="8A93A5"/>
+                  <a:srgbClr val="94A3B8"/>
                 </a:solidFill>
                 <a:latin typeface="Calibri" pitchFamily="34" charset="0"/>
                 <a:ea typeface="Calibri" pitchFamily="34" charset="-122"/>
@@ -12990,7 +12990,7 @@
             <a:r>
               <a:rPr lang="en-US" sz="2700" b="1" dirty="0">
                 <a:solidFill>
-                  <a:srgbClr val="1E2B4A"/>
+                  <a:srgbClr val="312E81"/>
                 </a:solidFill>
                 <a:latin typeface="Calibri" pitchFamily="34" charset="0"/>
                 <a:ea typeface="Calibri" pitchFamily="34" charset="-122"/>
@@ -13019,7 +13019,7 @@
             </a:avLst>
           </a:prstGeom>
           <a:solidFill>
-            <a:srgbClr val="1E2B4A"/>
+            <a:srgbClr val="312E81"/>
           </a:solidFill>
           <a:ln/>
         </p:spPr>
@@ -13093,7 +13093,7 @@
             <a:r>
               <a:rPr lang="en-US" sz="3600" b="1" dirty="0">
                 <a:solidFill>
-                  <a:srgbClr val="D96F2B"/>
+                  <a:srgbClr val="D97706"/>
                 </a:solidFill>
                 <a:latin typeface="Calibri" pitchFamily="34" charset="0"/>
                 <a:ea typeface="Calibri" pitchFamily="34" charset="-122"/>
@@ -13132,7 +13132,7 @@
             <a:r>
               <a:rPr lang="en-US" sz="1200" b="1" dirty="0">
                 <a:solidFill>
-                  <a:srgbClr val="1D2433"/>
+                  <a:srgbClr val="0F172A"/>
                 </a:solidFill>
                 <a:latin typeface="Calibri" pitchFamily="34" charset="0"/>
                 <a:ea typeface="Calibri" pitchFamily="34" charset="-122"/>
@@ -13174,7 +13174,7 @@
             <a:r>
               <a:rPr lang="en-US" sz="1150" dirty="0">
                 <a:solidFill>
-                  <a:srgbClr val="4A5468"/>
+                  <a:srgbClr val="475569"/>
                 </a:solidFill>
                 <a:latin typeface="Calibri" pitchFamily="34" charset="0"/>
                 <a:ea typeface="Calibri" pitchFamily="34" charset="-122"/>
@@ -13213,7 +13213,7 @@
             <a:r>
               <a:rPr lang="en-US" sz="3600" b="1" dirty="0">
                 <a:solidFill>
-                  <a:srgbClr val="41639E"/>
+                  <a:srgbClr val="4F46E5"/>
                 </a:solidFill>
                 <a:latin typeface="Calibri" pitchFamily="34" charset="0"/>
                 <a:ea typeface="Calibri" pitchFamily="34" charset="-122"/>
@@ -13252,7 +13252,7 @@
             <a:r>
               <a:rPr lang="en-US" sz="1200" b="1" dirty="0">
                 <a:solidFill>
-                  <a:srgbClr val="1D2433"/>
+                  <a:srgbClr val="0F172A"/>
                 </a:solidFill>
                 <a:latin typeface="Calibri" pitchFamily="34" charset="0"/>
                 <a:ea typeface="Calibri" pitchFamily="34" charset="-122"/>
@@ -13294,7 +13294,7 @@
             <a:r>
               <a:rPr lang="en-US" sz="1150" dirty="0">
                 <a:solidFill>
-                  <a:srgbClr val="4A5468"/>
+                  <a:srgbClr val="475569"/>
                 </a:solidFill>
                 <a:latin typeface="Calibri" pitchFamily="34" charset="0"/>
                 <a:ea typeface="Calibri" pitchFamily="34" charset="-122"/>
@@ -13333,7 +13333,7 @@
             <a:r>
               <a:rPr lang="en-US" sz="3600" b="1" dirty="0">
                 <a:solidFill>
-                  <a:srgbClr val="3E8C9A"/>
+                  <a:srgbClr val="DB2777"/>
                 </a:solidFill>
                 <a:latin typeface="Calibri" pitchFamily="34" charset="0"/>
                 <a:ea typeface="Calibri" pitchFamily="34" charset="-122"/>
@@ -13372,7 +13372,7 @@
             <a:r>
               <a:rPr lang="en-US" sz="1200" b="1" dirty="0">
                 <a:solidFill>
-                  <a:srgbClr val="1D2433"/>
+                  <a:srgbClr val="0F172A"/>
                 </a:solidFill>
                 <a:latin typeface="Calibri" pitchFamily="34" charset="0"/>
                 <a:ea typeface="Calibri" pitchFamily="34" charset="-122"/>
@@ -13414,7 +13414,7 @@
             <a:r>
               <a:rPr lang="en-US" sz="1150" dirty="0">
                 <a:solidFill>
-                  <a:srgbClr val="4A5468"/>
+                  <a:srgbClr val="475569"/>
                 </a:solidFill>
                 <a:latin typeface="Calibri" pitchFamily="34" charset="0"/>
                 <a:ea typeface="Calibri" pitchFamily="34" charset="-122"/>
@@ -13453,7 +13453,7 @@
             <a:r>
               <a:rPr lang="en-US" sz="3600" b="1" dirty="0">
                 <a:solidFill>
-                  <a:srgbClr val="C98A24"/>
+                  <a:srgbClr val="0891B2"/>
                 </a:solidFill>
                 <a:latin typeface="Calibri" pitchFamily="34" charset="0"/>
                 <a:ea typeface="Calibri" pitchFamily="34" charset="-122"/>
@@ -13492,7 +13492,7 @@
             <a:r>
               <a:rPr lang="en-US" sz="1200" b="1" dirty="0">
                 <a:solidFill>
-                  <a:srgbClr val="1D2433"/>
+                  <a:srgbClr val="0F172A"/>
                 </a:solidFill>
                 <a:latin typeface="Calibri" pitchFamily="34" charset="0"/>
                 <a:ea typeface="Calibri" pitchFamily="34" charset="-122"/>
@@ -13534,7 +13534,7 @@
             <a:r>
               <a:rPr lang="en-US" sz="1150" dirty="0">
                 <a:solidFill>
-                  <a:srgbClr val="4A5468"/>
+                  <a:srgbClr val="475569"/>
                 </a:solidFill>
                 <a:latin typeface="Calibri" pitchFamily="34" charset="0"/>
                 <a:ea typeface="Calibri" pitchFamily="34" charset="-122"/>
@@ -13573,7 +13573,7 @@
             <a:r>
               <a:rPr lang="en-US" sz="950" dirty="0">
                 <a:solidFill>
-                  <a:srgbClr val="8A93A5"/>
+                  <a:srgbClr val="94A3B8"/>
                 </a:solidFill>
                 <a:latin typeface="Calibri" pitchFamily="34" charset="0"/>
                 <a:ea typeface="Calibri" pitchFamily="34" charset="-122"/>
@@ -13668,7 +13668,7 @@
             <a:r>
               <a:rPr lang="en-US" sz="2700" b="1" dirty="0">
                 <a:solidFill>
-                  <a:srgbClr val="1E2B4A"/>
+                  <a:srgbClr val="312E81"/>
                 </a:solidFill>
                 <a:latin typeface="Calibri" pitchFamily="34" charset="0"/>
                 <a:ea typeface="Calibri" pitchFamily="34" charset="-122"/>
@@ -13695,17 +13695,17 @@
             <a:avLst/>
           </a:prstGeom>
           <a:solidFill>
-            <a:srgbClr val="E1E6EF"/>
+            <a:srgbClr val="E3E1FB"/>
           </a:solidFill>
           <a:ln w="15875">
             <a:solidFill>
-              <a:srgbClr val="BBC7DC"/>
+              <a:srgbClr val="C0BCF6"/>
             </a:solidFill>
             <a:prstDash val="solid"/>
           </a:ln>
           <a:effectLst>
             <a:outerShdw sx="100000" sy="100000" kx="0" ky="0" algn="bl" rotWithShape="0" blurRad="127000" dist="25400" dir="5400000">
-              <a:srgbClr val="1E2B4A">
+              <a:srgbClr val="312E81">
                 <a:alpha val="8000"/>
               </a:srgbClr>
             </a:outerShdw>
@@ -13763,7 +13763,7 @@
             <a:r>
               <a:rPr lang="en-US" sz="3000" b="1" dirty="0">
                 <a:solidFill>
-                  <a:srgbClr val="E3E7EE"/>
+                  <a:srgbClr val="E2E8F0"/>
                 </a:solidFill>
                 <a:latin typeface="Calibri" pitchFamily="34" charset="0"/>
                 <a:ea typeface="Calibri" pitchFamily="34" charset="-122"/>
@@ -13802,7 +13802,7 @@
             <a:r>
               <a:rPr lang="en-US" sz="1450" b="1" dirty="0">
                 <a:solidFill>
-                  <a:srgbClr val="1D2433"/>
+                  <a:srgbClr val="0F172A"/>
                 </a:solidFill>
                 <a:latin typeface="Calibri" pitchFamily="34" charset="0"/>
                 <a:ea typeface="Calibri" pitchFamily="34" charset="-122"/>
@@ -13841,7 +13841,7 @@
             <a:r>
               <a:rPr lang="en-US" sz="1100" dirty="0">
                 <a:solidFill>
-                  <a:srgbClr val="4A5468"/>
+                  <a:srgbClr val="475569"/>
                 </a:solidFill>
                 <a:latin typeface="Calibri" pitchFamily="34" charset="0"/>
                 <a:ea typeface="Calibri" pitchFamily="34" charset="-122"/>
@@ -13868,17 +13868,17 @@
             <a:avLst/>
           </a:prstGeom>
           <a:solidFill>
-            <a:srgbClr val="F9E8DD"/>
+            <a:srgbClr val="F9E9D7"/>
           </a:solidFill>
           <a:ln w="15875">
             <a:solidFill>
-              <a:srgbClr val="F1CBB3"/>
+              <a:srgbClr val="F1CEA5"/>
             </a:solidFill>
             <a:prstDash val="solid"/>
           </a:ln>
           <a:effectLst>
             <a:outerShdw sx="100000" sy="100000" kx="0" ky="0" algn="bl" rotWithShape="0" blurRad="127000" dist="25400" dir="5400000">
-              <a:srgbClr val="1E2B4A">
+              <a:srgbClr val="312E81">
                 <a:alpha val="8000"/>
               </a:srgbClr>
             </a:outerShdw>
@@ -13936,7 +13936,7 @@
             <a:r>
               <a:rPr lang="en-US" sz="3000" b="1" dirty="0">
                 <a:solidFill>
-                  <a:srgbClr val="E3E7EE"/>
+                  <a:srgbClr val="E2E8F0"/>
                 </a:solidFill>
                 <a:latin typeface="Calibri" pitchFamily="34" charset="0"/>
                 <a:ea typeface="Calibri" pitchFamily="34" charset="-122"/>
@@ -13975,7 +13975,7 @@
             <a:r>
               <a:rPr lang="en-US" sz="1450" b="1" dirty="0">
                 <a:solidFill>
-                  <a:srgbClr val="1D2433"/>
+                  <a:srgbClr val="0F172A"/>
                 </a:solidFill>
                 <a:latin typeface="Calibri" pitchFamily="34" charset="0"/>
                 <a:ea typeface="Calibri" pitchFamily="34" charset="-122"/>
@@ -14014,7 +14014,7 @@
             <a:r>
               <a:rPr lang="en-US" sz="1100" dirty="0">
                 <a:solidFill>
-                  <a:srgbClr val="4A5468"/>
+                  <a:srgbClr val="475569"/>
                 </a:solidFill>
                 <a:latin typeface="Calibri" pitchFamily="34" charset="0"/>
                 <a:ea typeface="Calibri" pitchFamily="34" charset="-122"/>
@@ -14041,17 +14041,17 @@
             <a:avLst/>
           </a:prstGeom>
           <a:solidFill>
-            <a:srgbClr val="E0EDEF"/>
+            <a:srgbClr val="F9DCE9"/>
           </a:solidFill>
           <a:ln w="15875">
             <a:solidFill>
-              <a:srgbClr val="BAD6DB"/>
+              <a:srgbClr val="F2B1CE"/>
             </a:solidFill>
             <a:prstDash val="solid"/>
           </a:ln>
           <a:effectLst>
             <a:outerShdw sx="100000" sy="100000" kx="0" ky="0" algn="bl" rotWithShape="0" blurRad="127000" dist="25400" dir="5400000">
-              <a:srgbClr val="1E2B4A">
+              <a:srgbClr val="312E81">
                 <a:alpha val="8000"/>
               </a:srgbClr>
             </a:outerShdw>
@@ -14109,7 +14109,7 @@
             <a:r>
               <a:rPr lang="en-US" sz="3000" b="1" dirty="0">
                 <a:solidFill>
-                  <a:srgbClr val="E3E7EE"/>
+                  <a:srgbClr val="E2E8F0"/>
                 </a:solidFill>
                 <a:latin typeface="Calibri" pitchFamily="34" charset="0"/>
                 <a:ea typeface="Calibri" pitchFamily="34" charset="-122"/>
@@ -14148,7 +14148,7 @@
             <a:r>
               <a:rPr lang="en-US" sz="1450" b="1" dirty="0">
                 <a:solidFill>
-                  <a:srgbClr val="1D2433"/>
+                  <a:srgbClr val="0F172A"/>
                 </a:solidFill>
                 <a:latin typeface="Calibri" pitchFamily="34" charset="0"/>
                 <a:ea typeface="Calibri" pitchFamily="34" charset="-122"/>
@@ -14187,7 +14187,7 @@
             <a:r>
               <a:rPr lang="en-US" sz="1100" dirty="0">
                 <a:solidFill>
-                  <a:srgbClr val="4A5468"/>
+                  <a:srgbClr val="475569"/>
                 </a:solidFill>
                 <a:latin typeface="Calibri" pitchFamily="34" charset="0"/>
                 <a:ea typeface="Calibri" pitchFamily="34" charset="-122"/>
@@ -14214,17 +14214,17 @@
             <a:avLst/>
           </a:prstGeom>
           <a:solidFill>
-            <a:srgbClr val="F6ECDC"/>
+            <a:srgbClr val="D7EDF3"/>
           </a:solidFill>
           <a:ln w="15875">
             <a:solidFill>
-              <a:srgbClr val="ECD5B0"/>
+              <a:srgbClr val="A6D7E3"/>
             </a:solidFill>
             <a:prstDash val="solid"/>
           </a:ln>
           <a:effectLst>
             <a:outerShdw sx="100000" sy="100000" kx="0" ky="0" algn="bl" rotWithShape="0" blurRad="127000" dist="25400" dir="5400000">
-              <a:srgbClr val="1E2B4A">
+              <a:srgbClr val="312E81">
                 <a:alpha val="8000"/>
               </a:srgbClr>
             </a:outerShdw>
@@ -14282,7 +14282,7 @@
             <a:r>
               <a:rPr lang="en-US" sz="3000" b="1" dirty="0">
                 <a:solidFill>
-                  <a:srgbClr val="E3E7EE"/>
+                  <a:srgbClr val="E2E8F0"/>
                 </a:solidFill>
                 <a:latin typeface="Calibri" pitchFamily="34" charset="0"/>
                 <a:ea typeface="Calibri" pitchFamily="34" charset="-122"/>
@@ -14321,7 +14321,7 @@
             <a:r>
               <a:rPr lang="en-US" sz="1450" b="1" dirty="0">
                 <a:solidFill>
-                  <a:srgbClr val="1D2433"/>
+                  <a:srgbClr val="0F172A"/>
                 </a:solidFill>
                 <a:latin typeface="Calibri" pitchFamily="34" charset="0"/>
                 <a:ea typeface="Calibri" pitchFamily="34" charset="-122"/>
@@ -14360,7 +14360,7 @@
             <a:r>
               <a:rPr lang="en-US" sz="1100" dirty="0">
                 <a:solidFill>
-                  <a:srgbClr val="4A5468"/>
+                  <a:srgbClr val="475569"/>
                 </a:solidFill>
                 <a:latin typeface="Calibri" pitchFamily="34" charset="0"/>
                 <a:ea typeface="Calibri" pitchFamily="34" charset="-122"/>
@@ -14387,17 +14387,17 @@
             <a:avLst/>
           </a:prstGeom>
           <a:solidFill>
-            <a:srgbClr val="E1E6EF"/>
+            <a:srgbClr val="E3E1FB"/>
           </a:solidFill>
           <a:ln w="15875">
             <a:solidFill>
-              <a:srgbClr val="BBC7DC"/>
+              <a:srgbClr val="C0BCF6"/>
             </a:solidFill>
             <a:prstDash val="solid"/>
           </a:ln>
           <a:effectLst>
             <a:outerShdw sx="100000" sy="100000" kx="0" ky="0" algn="bl" rotWithShape="0" blurRad="127000" dist="25400" dir="5400000">
-              <a:srgbClr val="1E2B4A">
+              <a:srgbClr val="312E81">
                 <a:alpha val="8000"/>
               </a:srgbClr>
             </a:outerShdw>
@@ -14455,7 +14455,7 @@
             <a:r>
               <a:rPr lang="en-US" sz="3000" b="1" dirty="0">
                 <a:solidFill>
-                  <a:srgbClr val="E3E7EE"/>
+                  <a:srgbClr val="E2E8F0"/>
                 </a:solidFill>
                 <a:latin typeface="Calibri" pitchFamily="34" charset="0"/>
                 <a:ea typeface="Calibri" pitchFamily="34" charset="-122"/>
@@ -14494,7 +14494,7 @@
             <a:r>
               <a:rPr lang="en-US" sz="1450" b="1" dirty="0">
                 <a:solidFill>
-                  <a:srgbClr val="1D2433"/>
+                  <a:srgbClr val="0F172A"/>
                 </a:solidFill>
                 <a:latin typeface="Calibri" pitchFamily="34" charset="0"/>
                 <a:ea typeface="Calibri" pitchFamily="34" charset="-122"/>
@@ -14533,7 +14533,7 @@
             <a:r>
               <a:rPr lang="en-US" sz="1100" dirty="0">
                 <a:solidFill>
-                  <a:srgbClr val="4A5468"/>
+                  <a:srgbClr val="475569"/>
                 </a:solidFill>
                 <a:latin typeface="Calibri" pitchFamily="34" charset="0"/>
                 <a:ea typeface="Calibri" pitchFamily="34" charset="-122"/>
@@ -14560,17 +14560,17 @@
             <a:avLst/>
           </a:prstGeom>
           <a:solidFill>
-            <a:srgbClr val="F9E8DD"/>
+            <a:srgbClr val="F9E9D7"/>
           </a:solidFill>
           <a:ln w="15875">
             <a:solidFill>
-              <a:srgbClr val="F1CBB3"/>
+              <a:srgbClr val="F1CEA5"/>
             </a:solidFill>
             <a:prstDash val="solid"/>
           </a:ln>
           <a:effectLst>
             <a:outerShdw sx="100000" sy="100000" kx="0" ky="0" algn="bl" rotWithShape="0" blurRad="127000" dist="25400" dir="5400000">
-              <a:srgbClr val="1E2B4A">
+              <a:srgbClr val="312E81">
                 <a:alpha val="8000"/>
               </a:srgbClr>
             </a:outerShdw>
@@ -14628,7 +14628,7 @@
             <a:r>
               <a:rPr lang="en-US" sz="3000" b="1" dirty="0">
                 <a:solidFill>
-                  <a:srgbClr val="E3E7EE"/>
+                  <a:srgbClr val="E2E8F0"/>
                 </a:solidFill>
                 <a:latin typeface="Calibri" pitchFamily="34" charset="0"/>
                 <a:ea typeface="Calibri" pitchFamily="34" charset="-122"/>
@@ -14667,7 +14667,7 @@
             <a:r>
               <a:rPr lang="en-US" sz="1450" b="1" dirty="0">
                 <a:solidFill>
-                  <a:srgbClr val="1D2433"/>
+                  <a:srgbClr val="0F172A"/>
                 </a:solidFill>
                 <a:latin typeface="Calibri" pitchFamily="34" charset="0"/>
                 <a:ea typeface="Calibri" pitchFamily="34" charset="-122"/>
@@ -14706,7 +14706,7 @@
             <a:r>
               <a:rPr lang="en-US" sz="1100" dirty="0">
                 <a:solidFill>
-                  <a:srgbClr val="4A5468"/>
+                  <a:srgbClr val="475569"/>
                 </a:solidFill>
                 <a:latin typeface="Calibri" pitchFamily="34" charset="0"/>
                 <a:ea typeface="Calibri" pitchFamily="34" charset="-122"/>
@@ -14745,7 +14745,7 @@
             <a:r>
               <a:rPr lang="en-US" sz="950" dirty="0">
                 <a:solidFill>
-                  <a:srgbClr val="8A93A5"/>
+                  <a:srgbClr val="94A3B8"/>
                 </a:solidFill>
                 <a:latin typeface="Calibri" pitchFamily="34" charset="0"/>
                 <a:ea typeface="Calibri" pitchFamily="34" charset="-122"/>
@@ -14840,7 +14840,7 @@
             <a:r>
               <a:rPr lang="en-US" sz="2700" b="1" dirty="0">
                 <a:solidFill>
-                  <a:srgbClr val="1E2B4A"/>
+                  <a:srgbClr val="312E81"/>
                 </a:solidFill>
                 <a:latin typeface="Calibri" pitchFamily="34" charset="0"/>
                 <a:ea typeface="Calibri" pitchFamily="34" charset="-122"/>
@@ -14882,7 +14882,7 @@
             <a:r>
               <a:rPr lang="en-US" sz="1300" dirty="0">
                 <a:solidFill>
-                  <a:srgbClr val="4A5468"/>
+                  <a:srgbClr val="475569"/>
                 </a:solidFill>
                 <a:latin typeface="Calibri" pitchFamily="34" charset="0"/>
                 <a:ea typeface="Calibri" pitchFamily="34" charset="-122"/>
@@ -14909,17 +14909,17 @@
             <a:avLst/>
           </a:prstGeom>
           <a:solidFill>
-            <a:srgbClr val="F6ECDC"/>
+            <a:srgbClr val="D7EDF3"/>
           </a:solidFill>
           <a:ln w="15875">
             <a:solidFill>
-              <a:srgbClr val="ECD5B0"/>
+              <a:srgbClr val="A6D7E3"/>
             </a:solidFill>
             <a:prstDash val="solid"/>
           </a:ln>
           <a:effectLst>
             <a:outerShdw sx="100000" sy="100000" kx="0" ky="0" algn="bl" rotWithShape="0" blurRad="127000" dist="25400" dir="5400000">
-              <a:srgbClr val="1E2B4A">
+              <a:srgbClr val="312E81">
                 <a:alpha val="8000"/>
               </a:srgbClr>
             </a:outerShdw>
@@ -14980,7 +14980,7 @@
             <a:r>
               <a:rPr lang="en-US" sz="1450" b="1" dirty="0">
                 <a:solidFill>
-                  <a:srgbClr val="1D2433"/>
+                  <a:srgbClr val="0F172A"/>
                 </a:solidFill>
                 <a:latin typeface="Calibri" pitchFamily="34" charset="0"/>
                 <a:ea typeface="Calibri" pitchFamily="34" charset="-122"/>
@@ -15022,7 +15022,7 @@
             <a:r>
               <a:rPr lang="en-US" sz="1200" dirty="0">
                 <a:solidFill>
-                  <a:srgbClr val="4A5468"/>
+                  <a:srgbClr val="475569"/>
                 </a:solidFill>
                 <a:latin typeface="Calibri" pitchFamily="34" charset="0"/>
                 <a:ea typeface="Calibri" pitchFamily="34" charset="-122"/>
@@ -15049,17 +15049,17 @@
             <a:avLst/>
           </a:prstGeom>
           <a:solidFill>
-            <a:srgbClr val="E1E6EF"/>
+            <a:srgbClr val="E3E1FB"/>
           </a:solidFill>
           <a:ln w="15875">
             <a:solidFill>
-              <a:srgbClr val="BBC7DC"/>
+              <a:srgbClr val="C0BCF6"/>
             </a:solidFill>
             <a:prstDash val="solid"/>
           </a:ln>
           <a:effectLst>
             <a:outerShdw sx="100000" sy="100000" kx="0" ky="0" algn="bl" rotWithShape="0" blurRad="127000" dist="25400" dir="5400000">
-              <a:srgbClr val="1E2B4A">
+              <a:srgbClr val="312E81">
                 <a:alpha val="8000"/>
               </a:srgbClr>
             </a:outerShdw>
@@ -15120,7 +15120,7 @@
             <a:r>
               <a:rPr lang="en-US" sz="1450" b="1" dirty="0">
                 <a:solidFill>
-                  <a:srgbClr val="1D2433"/>
+                  <a:srgbClr val="0F172A"/>
                 </a:solidFill>
                 <a:latin typeface="Calibri" pitchFamily="34" charset="0"/>
                 <a:ea typeface="Calibri" pitchFamily="34" charset="-122"/>
@@ -15162,7 +15162,7 @@
             <a:r>
               <a:rPr lang="en-US" sz="1200" dirty="0">
                 <a:solidFill>
-                  <a:srgbClr val="4A5468"/>
+                  <a:srgbClr val="475569"/>
                 </a:solidFill>
                 <a:latin typeface="Calibri" pitchFamily="34" charset="0"/>
                 <a:ea typeface="Calibri" pitchFamily="34" charset="-122"/>
@@ -15189,17 +15189,17 @@
             <a:avLst/>
           </a:prstGeom>
           <a:solidFill>
-            <a:srgbClr val="E0EDEF"/>
+            <a:srgbClr val="F9DCE9"/>
           </a:solidFill>
           <a:ln w="15875">
             <a:solidFill>
-              <a:srgbClr val="BAD6DB"/>
+              <a:srgbClr val="F2B1CE"/>
             </a:solidFill>
             <a:prstDash val="solid"/>
           </a:ln>
           <a:effectLst>
             <a:outerShdw sx="100000" sy="100000" kx="0" ky="0" algn="bl" rotWithShape="0" blurRad="127000" dist="25400" dir="5400000">
-              <a:srgbClr val="1E2B4A">
+              <a:srgbClr val="312E81">
                 <a:alpha val="8000"/>
               </a:srgbClr>
             </a:outerShdw>
@@ -15260,7 +15260,7 @@
             <a:r>
               <a:rPr lang="en-US" sz="1450" b="1" dirty="0">
                 <a:solidFill>
-                  <a:srgbClr val="1D2433"/>
+                  <a:srgbClr val="0F172A"/>
                 </a:solidFill>
                 <a:latin typeface="Calibri" pitchFamily="34" charset="0"/>
                 <a:ea typeface="Calibri" pitchFamily="34" charset="-122"/>
@@ -15302,7 +15302,7 @@
             <a:r>
               <a:rPr lang="en-US" sz="1200" dirty="0">
                 <a:solidFill>
-                  <a:srgbClr val="4A5468"/>
+                  <a:srgbClr val="475569"/>
                 </a:solidFill>
                 <a:latin typeface="Calibri" pitchFamily="34" charset="0"/>
                 <a:ea typeface="Calibri" pitchFamily="34" charset="-122"/>
@@ -15341,7 +15341,7 @@
             <a:r>
               <a:rPr lang="en-US" sz="950" dirty="0">
                 <a:solidFill>
-                  <a:srgbClr val="8A93A5"/>
+                  <a:srgbClr val="94A3B8"/>
                 </a:solidFill>
                 <a:latin typeface="Calibri" pitchFamily="34" charset="0"/>
                 <a:ea typeface="Calibri" pitchFamily="34" charset="-122"/>
@@ -15391,7 +15391,7 @@
     <p:bg>
       <p:bgPr>
         <a:solidFill>
-          <a:srgbClr val="16213D"/>
+          <a:srgbClr val="1E1B4B"/>
         </a:solidFill>
       </p:bgPr>
     </p:bg>
@@ -15424,7 +15424,7 @@
             <a:avLst/>
           </a:prstGeom>
           <a:solidFill>
-            <a:srgbClr val="24365E"/>
+            <a:srgbClr val="312E81"/>
           </a:solidFill>
           <a:ln/>
         </p:spPr>
@@ -15444,7 +15444,7 @@
             <a:avLst/>
           </a:prstGeom>
           <a:solidFill>
-            <a:srgbClr val="24365E"/>
+            <a:srgbClr val="312E81"/>
           </a:solidFill>
           <a:ln/>
         </p:spPr>
@@ -15515,7 +15515,7 @@
             <a:r>
               <a:rPr lang="en-US" sz="1400" dirty="0">
                 <a:solidFill>
-                  <a:srgbClr val="D96F2B"/>
+                  <a:srgbClr val="D97706"/>
                 </a:solidFill>
                 <a:latin typeface="Calibri" pitchFamily="34" charset="0"/>
                 <a:ea typeface="Calibri" pitchFamily="34" charset="-122"/>
@@ -15554,7 +15554,7 @@
             <a:r>
               <a:rPr lang="en-US" sz="1250" dirty="0">
                 <a:solidFill>
-                  <a:srgbClr val="8FA6CC"/>
+                  <a:srgbClr val="A5B4FC"/>
                 </a:solidFill>
                 <a:latin typeface="Calibri" pitchFamily="34" charset="0"/>
                 <a:ea typeface="Calibri" pitchFamily="34" charset="-122"/>
@@ -15625,7 +15625,7 @@
             <a:r>
               <a:rPr lang="en-US" sz="2700" b="1" dirty="0">
                 <a:solidFill>
-                  <a:srgbClr val="1E2B4A"/>
+                  <a:srgbClr val="312E81"/>
                 </a:solidFill>
                 <a:latin typeface="Calibri" pitchFamily="34" charset="0"/>
                 <a:ea typeface="Calibri" pitchFamily="34" charset="-122"/>
@@ -15652,17 +15652,17 @@
             <a:avLst/>
           </a:prstGeom>
           <a:solidFill>
-            <a:srgbClr val="E1E6EF"/>
+            <a:srgbClr val="E3E1FB"/>
           </a:solidFill>
           <a:ln w="15875">
             <a:solidFill>
-              <a:srgbClr val="BBC7DC"/>
+              <a:srgbClr val="C0BCF6"/>
             </a:solidFill>
             <a:prstDash val="solid"/>
           </a:ln>
           <a:effectLst>
             <a:outerShdw sx="100000" sy="100000" kx="0" ky="0" algn="bl" rotWithShape="0" blurRad="127000" dist="25400" dir="5400000">
-              <a:srgbClr val="1E2B4A">
+              <a:srgbClr val="312E81">
                 <a:alpha val="8000"/>
               </a:srgbClr>
             </a:outerShdw>
@@ -15723,7 +15723,7 @@
             <a:r>
               <a:rPr lang="en-US" sz="1600" b="1" dirty="0">
                 <a:solidFill>
-                  <a:srgbClr val="1D2433"/>
+                  <a:srgbClr val="0F172A"/>
                 </a:solidFill>
                 <a:latin typeface="Calibri" pitchFamily="34" charset="0"/>
                 <a:ea typeface="Calibri" pitchFamily="34" charset="-122"/>
@@ -15762,7 +15762,7 @@
             <a:r>
               <a:rPr lang="en-US" sz="3400" b="1" dirty="0">
                 <a:solidFill>
-                  <a:srgbClr val="1E2B4A"/>
+                  <a:srgbClr val="312E81"/>
                 </a:solidFill>
                 <a:latin typeface="Calibri" pitchFamily="34" charset="0"/>
                 <a:ea typeface="Calibri" pitchFamily="34" charset="-122"/>
@@ -15804,7 +15804,7 @@
             <a:r>
               <a:rPr lang="en-US" sz="1050" dirty="0">
                 <a:solidFill>
-                  <a:srgbClr val="4A5468"/>
+                  <a:srgbClr val="475569"/>
                 </a:solidFill>
                 <a:latin typeface="Calibri" pitchFamily="34" charset="0"/>
                 <a:ea typeface="Calibri" pitchFamily="34" charset="-122"/>
@@ -15824,7 +15824,7 @@
             <a:r>
               <a:rPr lang="en-US" sz="1050" dirty="0">
                 <a:solidFill>
-                  <a:srgbClr val="4A5468"/>
+                  <a:srgbClr val="475569"/>
                 </a:solidFill>
                 <a:latin typeface="Calibri" pitchFamily="34" charset="0"/>
                 <a:ea typeface="Calibri" pitchFamily="34" charset="-122"/>
@@ -15863,7 +15863,7 @@
             <a:r>
               <a:rPr lang="en-US" sz="3400" b="1" dirty="0">
                 <a:solidFill>
-                  <a:srgbClr val="1E2B4A"/>
+                  <a:srgbClr val="312E81"/>
                 </a:solidFill>
                 <a:latin typeface="Calibri" pitchFamily="34" charset="0"/>
                 <a:ea typeface="Calibri" pitchFamily="34" charset="-122"/>
@@ -15905,7 +15905,7 @@
             <a:r>
               <a:rPr lang="en-US" sz="1050" dirty="0">
                 <a:solidFill>
-                  <a:srgbClr val="4A5468"/>
+                  <a:srgbClr val="475569"/>
                 </a:solidFill>
                 <a:latin typeface="Calibri" pitchFamily="34" charset="0"/>
                 <a:ea typeface="Calibri" pitchFamily="34" charset="-122"/>
@@ -15925,7 +15925,7 @@
             <a:r>
               <a:rPr lang="en-US" sz="1050" dirty="0">
                 <a:solidFill>
-                  <a:srgbClr val="4A5468"/>
+                  <a:srgbClr val="475569"/>
                 </a:solidFill>
                 <a:latin typeface="Calibri" pitchFamily="34" charset="0"/>
                 <a:ea typeface="Calibri" pitchFamily="34" charset="-122"/>
@@ -15967,7 +15967,7 @@
             <a:r>
               <a:rPr lang="en-US" sz="1250" dirty="0">
                 <a:solidFill>
-                  <a:srgbClr val="4A5468"/>
+                  <a:srgbClr val="475569"/>
                 </a:solidFill>
                 <a:latin typeface="Calibri" pitchFamily="34" charset="0"/>
                 <a:ea typeface="Calibri" pitchFamily="34" charset="-122"/>
@@ -16006,7 +16006,7 @@
             <a:r>
               <a:rPr lang="en-US" sz="950" dirty="0">
                 <a:solidFill>
-                  <a:srgbClr val="8A93A5"/>
+                  <a:srgbClr val="94A3B8"/>
                 </a:solidFill>
                 <a:latin typeface="Calibri" pitchFamily="34" charset="0"/>
                 <a:ea typeface="Calibri" pitchFamily="34" charset="-122"/>
@@ -16033,17 +16033,17 @@
             <a:avLst/>
           </a:prstGeom>
           <a:solidFill>
-            <a:srgbClr val="F9E8DD"/>
+            <a:srgbClr val="F9E9D7"/>
           </a:solidFill>
           <a:ln w="15875">
             <a:solidFill>
-              <a:srgbClr val="F1CBB3"/>
+              <a:srgbClr val="F1CEA5"/>
             </a:solidFill>
             <a:prstDash val="solid"/>
           </a:ln>
           <a:effectLst>
             <a:outerShdw sx="100000" sy="100000" kx="0" ky="0" algn="bl" rotWithShape="0" blurRad="127000" dist="25400" dir="5400000">
-              <a:srgbClr val="1E2B4A">
+              <a:srgbClr val="312E81">
                 <a:alpha val="8000"/>
               </a:srgbClr>
             </a:outerShdw>
@@ -16104,7 +16104,7 @@
             <a:r>
               <a:rPr lang="en-US" sz="1600" b="1" dirty="0">
                 <a:solidFill>
-                  <a:srgbClr val="1D2433"/>
+                  <a:srgbClr val="0F172A"/>
                 </a:solidFill>
                 <a:latin typeface="Calibri" pitchFamily="34" charset="0"/>
                 <a:ea typeface="Calibri" pitchFamily="34" charset="-122"/>
@@ -16143,7 +16143,7 @@
             <a:r>
               <a:rPr lang="en-US" sz="3400" b="1" dirty="0">
                 <a:solidFill>
-                  <a:srgbClr val="1E2B4A"/>
+                  <a:srgbClr val="312E81"/>
                 </a:solidFill>
                 <a:latin typeface="Calibri" pitchFamily="34" charset="0"/>
                 <a:ea typeface="Calibri" pitchFamily="34" charset="-122"/>
@@ -16185,7 +16185,7 @@
             <a:r>
               <a:rPr lang="en-US" sz="1050" dirty="0">
                 <a:solidFill>
-                  <a:srgbClr val="4A5468"/>
+                  <a:srgbClr val="475569"/>
                 </a:solidFill>
                 <a:latin typeface="Calibri" pitchFamily="34" charset="0"/>
                 <a:ea typeface="Calibri" pitchFamily="34" charset="-122"/>
@@ -16205,7 +16205,7 @@
             <a:r>
               <a:rPr lang="en-US" sz="1050" dirty="0">
                 <a:solidFill>
-                  <a:srgbClr val="4A5468"/>
+                  <a:srgbClr val="475569"/>
                 </a:solidFill>
                 <a:latin typeface="Calibri" pitchFamily="34" charset="0"/>
                 <a:ea typeface="Calibri" pitchFamily="34" charset="-122"/>
@@ -16244,7 +16244,7 @@
             <a:r>
               <a:rPr lang="en-US" sz="3400" b="1" dirty="0">
                 <a:solidFill>
-                  <a:srgbClr val="1E2B4A"/>
+                  <a:srgbClr val="312E81"/>
                 </a:solidFill>
                 <a:latin typeface="Calibri" pitchFamily="34" charset="0"/>
                 <a:ea typeface="Calibri" pitchFamily="34" charset="-122"/>
@@ -16286,7 +16286,7 @@
             <a:r>
               <a:rPr lang="en-US" sz="1050" dirty="0">
                 <a:solidFill>
-                  <a:srgbClr val="4A5468"/>
+                  <a:srgbClr val="475569"/>
                 </a:solidFill>
                 <a:latin typeface="Calibri" pitchFamily="34" charset="0"/>
                 <a:ea typeface="Calibri" pitchFamily="34" charset="-122"/>
@@ -16306,7 +16306,7 @@
             <a:r>
               <a:rPr lang="en-US" sz="1050" dirty="0">
                 <a:solidFill>
-                  <a:srgbClr val="4A5468"/>
+                  <a:srgbClr val="475569"/>
                 </a:solidFill>
                 <a:latin typeface="Calibri" pitchFamily="34" charset="0"/>
                 <a:ea typeface="Calibri" pitchFamily="34" charset="-122"/>
@@ -16348,7 +16348,7 @@
             <a:r>
               <a:rPr lang="en-US" sz="1250" dirty="0">
                 <a:solidFill>
-                  <a:srgbClr val="4A5468"/>
+                  <a:srgbClr val="475569"/>
                 </a:solidFill>
                 <a:latin typeface="Calibri" pitchFamily="34" charset="0"/>
                 <a:ea typeface="Calibri" pitchFamily="34" charset="-122"/>
@@ -16387,7 +16387,7 @@
             <a:r>
               <a:rPr lang="en-US" sz="950" dirty="0">
                 <a:solidFill>
-                  <a:srgbClr val="8A93A5"/>
+                  <a:srgbClr val="94A3B8"/>
                 </a:solidFill>
                 <a:latin typeface="Calibri" pitchFamily="34" charset="0"/>
                 <a:ea typeface="Calibri" pitchFamily="34" charset="-122"/>
@@ -16426,7 +16426,7 @@
             <a:r>
               <a:rPr lang="en-US" sz="950" dirty="0">
                 <a:solidFill>
-                  <a:srgbClr val="8A93A5"/>
+                  <a:srgbClr val="94A3B8"/>
                 </a:solidFill>
                 <a:latin typeface="Calibri" pitchFamily="34" charset="0"/>
                 <a:ea typeface="Calibri" pitchFamily="34" charset="-122"/>
@@ -16521,7 +16521,7 @@
             <a:r>
               <a:rPr lang="en-US" sz="2700" b="1" dirty="0">
                 <a:solidFill>
-                  <a:srgbClr val="1E2B4A"/>
+                  <a:srgbClr val="312E81"/>
                 </a:solidFill>
                 <a:latin typeface="Calibri" pitchFamily="34" charset="0"/>
                 <a:ea typeface="Calibri" pitchFamily="34" charset="-122"/>
@@ -16550,7 +16550,7 @@
             </a:avLst>
           </a:prstGeom>
           <a:solidFill>
-            <a:srgbClr val="1E2B4A"/>
+            <a:srgbClr val="312E81"/>
           </a:solidFill>
           <a:ln/>
         </p:spPr>
@@ -16647,7 +16647,7 @@
             <a:r>
               <a:rPr lang="en-US" sz="1400" b="1" dirty="0">
                 <a:solidFill>
-                  <a:srgbClr val="1D2433"/>
+                  <a:srgbClr val="0F172A"/>
                 </a:solidFill>
                 <a:latin typeface="Calibri" pitchFamily="34" charset="0"/>
                 <a:ea typeface="Calibri" pitchFamily="34" charset="-122"/>
@@ -16689,7 +16689,7 @@
             <a:r>
               <a:rPr lang="en-US" sz="1200" dirty="0">
                 <a:solidFill>
-                  <a:srgbClr val="4A5468"/>
+                  <a:srgbClr val="475569"/>
                 </a:solidFill>
                 <a:latin typeface="Calibri" pitchFamily="34" charset="0"/>
                 <a:ea typeface="Calibri" pitchFamily="34" charset="-122"/>
@@ -16731,7 +16731,7 @@
             <a:r>
               <a:rPr lang="en-US" sz="1400" b="1" dirty="0">
                 <a:solidFill>
-                  <a:srgbClr val="1D2433"/>
+                  <a:srgbClr val="0F172A"/>
                 </a:solidFill>
                 <a:latin typeface="Calibri" pitchFamily="34" charset="0"/>
                 <a:ea typeface="Calibri" pitchFamily="34" charset="-122"/>
@@ -16773,7 +16773,7 @@
             <a:r>
               <a:rPr lang="en-US" sz="1200" dirty="0">
                 <a:solidFill>
-                  <a:srgbClr val="4A5468"/>
+                  <a:srgbClr val="475569"/>
                 </a:solidFill>
                 <a:latin typeface="Calibri" pitchFamily="34" charset="0"/>
                 <a:ea typeface="Calibri" pitchFamily="34" charset="-122"/>
@@ -16815,7 +16815,7 @@
             <a:r>
               <a:rPr lang="en-US" sz="1400" b="1" dirty="0">
                 <a:solidFill>
-                  <a:srgbClr val="1D2433"/>
+                  <a:srgbClr val="0F172A"/>
                 </a:solidFill>
                 <a:latin typeface="Calibri" pitchFamily="34" charset="0"/>
                 <a:ea typeface="Calibri" pitchFamily="34" charset="-122"/>
@@ -16857,7 +16857,7 @@
             <a:r>
               <a:rPr lang="en-US" sz="1200" dirty="0">
                 <a:solidFill>
-                  <a:srgbClr val="4A5468"/>
+                  <a:srgbClr val="475569"/>
                 </a:solidFill>
                 <a:latin typeface="Calibri" pitchFamily="34" charset="0"/>
                 <a:ea typeface="Calibri" pitchFamily="34" charset="-122"/>
@@ -16884,17 +16884,17 @@
             <a:avLst/>
           </a:prstGeom>
           <a:solidFill>
-            <a:srgbClr val="F9E8DD"/>
+            <a:srgbClr val="F9E9D7"/>
           </a:solidFill>
           <a:ln w="15875">
             <a:solidFill>
-              <a:srgbClr val="F1CBB3"/>
+              <a:srgbClr val="F1CEA5"/>
             </a:solidFill>
             <a:prstDash val="solid"/>
           </a:ln>
           <a:effectLst>
             <a:outerShdw sx="100000" sy="100000" kx="0" ky="0" algn="bl" rotWithShape="0" blurRad="127000" dist="25400" dir="5400000">
-              <a:srgbClr val="1E2B4A">
+              <a:srgbClr val="312E81">
                 <a:alpha val="8000"/>
               </a:srgbClr>
             </a:outerShdw>
@@ -16940,17 +16940,17 @@
             <a:avLst/>
           </a:prstGeom>
           <a:solidFill>
-            <a:srgbClr val="F6ECDC"/>
+            <a:srgbClr val="D7EDF3"/>
           </a:solidFill>
           <a:ln w="15875">
             <a:solidFill>
-              <a:srgbClr val="ECD5B0"/>
+              <a:srgbClr val="A6D7E3"/>
             </a:solidFill>
             <a:prstDash val="solid"/>
           </a:ln>
           <a:effectLst>
             <a:outerShdw sx="100000" sy="100000" kx="0" ky="0" algn="bl" rotWithShape="0" blurRad="127000" dist="25400" dir="5400000">
-              <a:srgbClr val="1E2B4A">
+              <a:srgbClr val="312E81">
                 <a:alpha val="8000"/>
               </a:srgbClr>
             </a:outerShdw>
@@ -16996,17 +16996,17 @@
             <a:avLst/>
           </a:prstGeom>
           <a:solidFill>
-            <a:srgbClr val="E0EDEF"/>
+            <a:srgbClr val="F9DCE9"/>
           </a:solidFill>
           <a:ln w="15875">
             <a:solidFill>
-              <a:srgbClr val="BAD6DB"/>
+              <a:srgbClr val="F2B1CE"/>
             </a:solidFill>
             <a:prstDash val="solid"/>
           </a:ln>
           <a:effectLst>
             <a:outerShdw sx="100000" sy="100000" kx="0" ky="0" algn="bl" rotWithShape="0" blurRad="127000" dist="25400" dir="5400000">
-              <a:srgbClr val="1E2B4A">
+              <a:srgbClr val="312E81">
                 <a:alpha val="8000"/>
               </a:srgbClr>
             </a:outerShdw>
@@ -17064,7 +17064,7 @@
             <a:r>
               <a:rPr lang="en-US" sz="950" dirty="0">
                 <a:solidFill>
-                  <a:srgbClr val="8A93A5"/>
+                  <a:srgbClr val="94A3B8"/>
                 </a:solidFill>
                 <a:latin typeface="Calibri" pitchFamily="34" charset="0"/>
                 <a:ea typeface="Calibri" pitchFamily="34" charset="-122"/>
@@ -17159,7 +17159,7 @@
             <a:r>
               <a:rPr lang="en-US" sz="2700" b="1" dirty="0">
                 <a:solidFill>
-                  <a:srgbClr val="1E2B4A"/>
+                  <a:srgbClr val="312E81"/>
                 </a:solidFill>
                 <a:latin typeface="Calibri" pitchFamily="34" charset="0"/>
                 <a:ea typeface="Calibri" pitchFamily="34" charset="-122"/>
@@ -17186,17 +17186,17 @@
             <a:avLst/>
           </a:prstGeom>
           <a:solidFill>
-            <a:srgbClr val="E1E6EF"/>
+            <a:srgbClr val="E3E1FB"/>
           </a:solidFill>
           <a:ln w="15875">
             <a:solidFill>
-              <a:srgbClr val="BBC7DC"/>
+              <a:srgbClr val="C0BCF6"/>
             </a:solidFill>
             <a:prstDash val="solid"/>
           </a:ln>
           <a:effectLst>
             <a:outerShdw sx="100000" sy="100000" kx="0" ky="0" algn="bl" rotWithShape="0" blurRad="127000" dist="25400" dir="5400000">
-              <a:srgbClr val="1E2B4A">
+              <a:srgbClr val="312E81">
                 <a:alpha val="8000"/>
               </a:srgbClr>
             </a:outerShdw>
@@ -17254,7 +17254,7 @@
             <a:r>
               <a:rPr lang="en-US" sz="1800" b="1" dirty="0">
                 <a:solidFill>
-                  <a:srgbClr val="1D2433"/>
+                  <a:srgbClr val="0F172A"/>
                 </a:solidFill>
                 <a:latin typeface="Calibri" pitchFamily="34" charset="0"/>
                 <a:ea typeface="Calibri" pitchFamily="34" charset="-122"/>
@@ -17296,7 +17296,7 @@
             <a:r>
               <a:rPr lang="en-US" sz="1350" b="1" dirty="0">
                 <a:solidFill>
-                  <a:srgbClr val="1D2433"/>
+                  <a:srgbClr val="0F172A"/>
                 </a:solidFill>
                 <a:latin typeface="Calibri" pitchFamily="34" charset="0"/>
                 <a:ea typeface="Calibri" pitchFamily="34" charset="-122"/>
@@ -17323,7 +17323,7 @@
             <a:avLst/>
           </a:prstGeom>
           <a:solidFill>
-            <a:srgbClr val="41639E"/>
+            <a:srgbClr val="4F46E5"/>
           </a:solidFill>
           <a:ln/>
         </p:spPr>
@@ -17397,7 +17397,7 @@
             <a:r>
               <a:rPr lang="en-US" sz="1250" dirty="0">
                 <a:solidFill>
-                  <a:srgbClr val="4A5468"/>
+                  <a:srgbClr val="475569"/>
                 </a:solidFill>
                 <a:latin typeface="Calibri" pitchFamily="34" charset="0"/>
                 <a:ea typeface="Calibri" pitchFamily="34" charset="-122"/>
@@ -17424,7 +17424,7 @@
             <a:avLst/>
           </a:prstGeom>
           <a:solidFill>
-            <a:srgbClr val="41639E"/>
+            <a:srgbClr val="4F46E5"/>
           </a:solidFill>
           <a:ln/>
         </p:spPr>
@@ -17498,7 +17498,7 @@
             <a:r>
               <a:rPr lang="en-US" sz="1250" dirty="0">
                 <a:solidFill>
-                  <a:srgbClr val="4A5468"/>
+                  <a:srgbClr val="475569"/>
                 </a:solidFill>
                 <a:latin typeface="Calibri" pitchFamily="34" charset="0"/>
                 <a:ea typeface="Calibri" pitchFamily="34" charset="-122"/>
@@ -17525,17 +17525,17 @@
             <a:avLst/>
           </a:prstGeom>
           <a:solidFill>
-            <a:srgbClr val="F9E8DD"/>
+            <a:srgbClr val="F9E9D7"/>
           </a:solidFill>
           <a:ln w="15875">
             <a:solidFill>
-              <a:srgbClr val="F1CBB3"/>
+              <a:srgbClr val="F1CEA5"/>
             </a:solidFill>
             <a:prstDash val="solid"/>
           </a:ln>
           <a:effectLst>
             <a:outerShdw sx="100000" sy="100000" kx="0" ky="0" algn="bl" rotWithShape="0" blurRad="127000" dist="25400" dir="5400000">
-              <a:srgbClr val="1E2B4A">
+              <a:srgbClr val="312E81">
                 <a:alpha val="8000"/>
               </a:srgbClr>
             </a:outerShdw>
@@ -17593,7 +17593,7 @@
             <a:r>
               <a:rPr lang="en-US" sz="1800" b="1" dirty="0">
                 <a:solidFill>
-                  <a:srgbClr val="1D2433"/>
+                  <a:srgbClr val="0F172A"/>
                 </a:solidFill>
                 <a:latin typeface="Calibri" pitchFamily="34" charset="0"/>
                 <a:ea typeface="Calibri" pitchFamily="34" charset="-122"/>
@@ -17622,7 +17622,7 @@
             </a:avLst>
           </a:prstGeom>
           <a:solidFill>
-            <a:srgbClr val="E5EEF4"/>
+            <a:srgbClr val="EEF2FF"/>
           </a:solidFill>
           <a:ln/>
         </p:spPr>
@@ -17654,7 +17654,7 @@
             <a:r>
               <a:rPr lang="en-US" sz="2200" b="1" dirty="0">
                 <a:solidFill>
-                  <a:srgbClr val="D96F2B"/>
+                  <a:srgbClr val="D97706"/>
                 </a:solidFill>
                 <a:latin typeface="Calibri" pitchFamily="34" charset="0"/>
                 <a:ea typeface="Calibri" pitchFamily="34" charset="-122"/>
@@ -17696,7 +17696,7 @@
             <a:r>
               <a:rPr lang="en-US" sz="1200" dirty="0">
                 <a:solidFill>
-                  <a:srgbClr val="1D2433"/>
+                  <a:srgbClr val="0F172A"/>
                 </a:solidFill>
                 <a:latin typeface="Calibri" pitchFamily="34" charset="0"/>
                 <a:ea typeface="Calibri" pitchFamily="34" charset="-122"/>
@@ -17725,7 +17725,7 @@
             </a:avLst>
           </a:prstGeom>
           <a:solidFill>
-            <a:srgbClr val="E5EEF4"/>
+            <a:srgbClr val="EEF2FF"/>
           </a:solidFill>
           <a:ln/>
         </p:spPr>
@@ -17757,7 +17757,7 @@
             <a:r>
               <a:rPr lang="en-US" sz="2200" b="1" dirty="0">
                 <a:solidFill>
-                  <a:srgbClr val="D96F2B"/>
+                  <a:srgbClr val="D97706"/>
                 </a:solidFill>
                 <a:latin typeface="Calibri" pitchFamily="34" charset="0"/>
                 <a:ea typeface="Calibri" pitchFamily="34" charset="-122"/>
@@ -17799,7 +17799,7 @@
             <a:r>
               <a:rPr lang="en-US" sz="1200" dirty="0">
                 <a:solidFill>
-                  <a:srgbClr val="1D2433"/>
+                  <a:srgbClr val="0F172A"/>
                 </a:solidFill>
                 <a:latin typeface="Calibri" pitchFamily="34" charset="0"/>
                 <a:ea typeface="Calibri" pitchFamily="34" charset="-122"/>
@@ -17838,7 +17838,7 @@
             <a:r>
               <a:rPr lang="en-US" sz="950" dirty="0">
                 <a:solidFill>
-                  <a:srgbClr val="8A93A5"/>
+                  <a:srgbClr val="94A3B8"/>
                 </a:solidFill>
                 <a:latin typeface="Calibri" pitchFamily="34" charset="0"/>
                 <a:ea typeface="Calibri" pitchFamily="34" charset="-122"/>
@@ -17933,7 +17933,7 @@
             <a:r>
               <a:rPr lang="en-US" sz="2700" b="1" dirty="0">
                 <a:solidFill>
-                  <a:srgbClr val="1E2B4A"/>
+                  <a:srgbClr val="312E81"/>
                 </a:solidFill>
                 <a:latin typeface="Calibri" pitchFamily="34" charset="0"/>
                 <a:ea typeface="Calibri" pitchFamily="34" charset="-122"/>
@@ -17972,7 +17972,7 @@
             <a:r>
               <a:rPr lang="en-US" sz="1700" b="1" dirty="0">
                 <a:solidFill>
-                  <a:srgbClr val="1D2433"/>
+                  <a:srgbClr val="0F172A"/>
                 </a:solidFill>
                 <a:latin typeface="Calibri" pitchFamily="34" charset="0"/>
                 <a:ea typeface="Calibri" pitchFamily="34" charset="-122"/>
@@ -17999,7 +17999,7 @@
             <a:avLst/>
           </a:prstGeom>
           <a:solidFill>
-            <a:srgbClr val="41639E"/>
+            <a:srgbClr val="4F46E5"/>
           </a:solidFill>
           <a:ln/>
         </p:spPr>
@@ -18031,7 +18031,7 @@
             <a:r>
               <a:rPr lang="en-US" sz="1400" b="1" dirty="0">
                 <a:solidFill>
-                  <a:srgbClr val="1D2433"/>
+                  <a:srgbClr val="0F172A"/>
                 </a:solidFill>
                 <a:latin typeface="Calibri" pitchFamily="34" charset="0"/>
                 <a:ea typeface="Calibri" pitchFamily="34" charset="-122"/>
@@ -18073,7 +18073,7 @@
             <a:r>
               <a:rPr lang="en-US" sz="1200" dirty="0">
                 <a:solidFill>
-                  <a:srgbClr val="4A5468"/>
+                  <a:srgbClr val="475569"/>
                 </a:solidFill>
                 <a:latin typeface="Calibri" pitchFamily="34" charset="0"/>
                 <a:ea typeface="Calibri" pitchFamily="34" charset="-122"/>
@@ -18112,7 +18112,7 @@
             <a:r>
               <a:rPr lang="en-US" sz="1050" i="1" dirty="0">
                 <a:solidFill>
-                  <a:srgbClr val="8A93A5"/>
+                  <a:srgbClr val="94A3B8"/>
                 </a:solidFill>
                 <a:latin typeface="Calibri" pitchFamily="34" charset="0"/>
                 <a:ea typeface="Calibri" pitchFamily="34" charset="-122"/>
@@ -18139,7 +18139,7 @@
             <a:avLst/>
           </a:prstGeom>
           <a:solidFill>
-            <a:srgbClr val="41639E"/>
+            <a:srgbClr val="4F46E5"/>
           </a:solidFill>
           <a:ln/>
         </p:spPr>
@@ -18171,7 +18171,7 @@
             <a:r>
               <a:rPr lang="en-US" sz="1400" b="1" dirty="0">
                 <a:solidFill>
-                  <a:srgbClr val="1D2433"/>
+                  <a:srgbClr val="0F172A"/>
                 </a:solidFill>
                 <a:latin typeface="Calibri" pitchFamily="34" charset="0"/>
                 <a:ea typeface="Calibri" pitchFamily="34" charset="-122"/>
@@ -18213,7 +18213,7 @@
             <a:r>
               <a:rPr lang="en-US" sz="1200" dirty="0">
                 <a:solidFill>
-                  <a:srgbClr val="4A5468"/>
+                  <a:srgbClr val="475569"/>
                 </a:solidFill>
                 <a:latin typeface="Calibri" pitchFamily="34" charset="0"/>
                 <a:ea typeface="Calibri" pitchFamily="34" charset="-122"/>
@@ -18252,7 +18252,7 @@
             <a:r>
               <a:rPr lang="en-US" sz="1050" i="1" dirty="0">
                 <a:solidFill>
-                  <a:srgbClr val="8A93A5"/>
+                  <a:srgbClr val="94A3B8"/>
                 </a:solidFill>
                 <a:latin typeface="Calibri" pitchFamily="34" charset="0"/>
                 <a:ea typeface="Calibri" pitchFamily="34" charset="-122"/>
@@ -18279,7 +18279,7 @@
             <a:avLst/>
           </a:prstGeom>
           <a:solidFill>
-            <a:srgbClr val="41639E"/>
+            <a:srgbClr val="4F46E5"/>
           </a:solidFill>
           <a:ln/>
         </p:spPr>
@@ -18311,7 +18311,7 @@
             <a:r>
               <a:rPr lang="en-US" sz="1400" b="1" dirty="0">
                 <a:solidFill>
-                  <a:srgbClr val="1D2433"/>
+                  <a:srgbClr val="0F172A"/>
                 </a:solidFill>
                 <a:latin typeface="Calibri" pitchFamily="34" charset="0"/>
                 <a:ea typeface="Calibri" pitchFamily="34" charset="-122"/>
@@ -18353,7 +18353,7 @@
             <a:r>
               <a:rPr lang="en-US" sz="1200" dirty="0">
                 <a:solidFill>
-                  <a:srgbClr val="4A5468"/>
+                  <a:srgbClr val="475569"/>
                 </a:solidFill>
                 <a:latin typeface="Calibri" pitchFamily="34" charset="0"/>
                 <a:ea typeface="Calibri" pitchFamily="34" charset="-122"/>
@@ -18392,7 +18392,7 @@
             <a:r>
               <a:rPr lang="en-US" sz="1050" i="1" dirty="0">
                 <a:solidFill>
-                  <a:srgbClr val="8A93A5"/>
+                  <a:srgbClr val="94A3B8"/>
                 </a:solidFill>
                 <a:latin typeface="Calibri" pitchFamily="34" charset="0"/>
                 <a:ea typeface="Calibri" pitchFamily="34" charset="-122"/>
@@ -18431,7 +18431,7 @@
             <a:r>
               <a:rPr lang="en-US" sz="1700" b="1" dirty="0">
                 <a:solidFill>
-                  <a:srgbClr val="1D2433"/>
+                  <a:srgbClr val="0F172A"/>
                 </a:solidFill>
                 <a:latin typeface="Calibri" pitchFamily="34" charset="0"/>
                 <a:ea typeface="Calibri" pitchFamily="34" charset="-122"/>
@@ -18470,7 +18470,7 @@
             <a:r>
               <a:rPr lang="en-US" sz="1400" b="1" dirty="0">
                 <a:solidFill>
-                  <a:srgbClr val="1D2433"/>
+                  <a:srgbClr val="0F172A"/>
                 </a:solidFill>
                 <a:latin typeface="Calibri" pitchFamily="34" charset="0"/>
                 <a:ea typeface="Calibri" pitchFamily="34" charset="-122"/>
@@ -18512,7 +18512,7 @@
             <a:r>
               <a:rPr lang="en-US" sz="1200" dirty="0">
                 <a:solidFill>
-                  <a:srgbClr val="4A5468"/>
+                  <a:srgbClr val="475569"/>
                 </a:solidFill>
                 <a:latin typeface="Calibri" pitchFamily="34" charset="0"/>
                 <a:ea typeface="Calibri" pitchFamily="34" charset="-122"/>
@@ -18551,7 +18551,7 @@
             <a:r>
               <a:rPr lang="en-US" sz="1050" i="1" dirty="0">
                 <a:solidFill>
-                  <a:srgbClr val="8A93A5"/>
+                  <a:srgbClr val="94A3B8"/>
                 </a:solidFill>
                 <a:latin typeface="Calibri" pitchFamily="34" charset="0"/>
                 <a:ea typeface="Calibri" pitchFamily="34" charset="-122"/>
@@ -18590,7 +18590,7 @@
             <a:r>
               <a:rPr lang="en-US" sz="1400" b="1" dirty="0">
                 <a:solidFill>
-                  <a:srgbClr val="1D2433"/>
+                  <a:srgbClr val="0F172A"/>
                 </a:solidFill>
                 <a:latin typeface="Calibri" pitchFamily="34" charset="0"/>
                 <a:ea typeface="Calibri" pitchFamily="34" charset="-122"/>
@@ -18632,7 +18632,7 @@
             <a:r>
               <a:rPr lang="en-US" sz="1200" dirty="0">
                 <a:solidFill>
-                  <a:srgbClr val="4A5468"/>
+                  <a:srgbClr val="475569"/>
                 </a:solidFill>
                 <a:latin typeface="Calibri" pitchFamily="34" charset="0"/>
                 <a:ea typeface="Calibri" pitchFamily="34" charset="-122"/>
@@ -18671,7 +18671,7 @@
             <a:r>
               <a:rPr lang="en-US" sz="1050" i="1" dirty="0">
                 <a:solidFill>
-                  <a:srgbClr val="8A93A5"/>
+                  <a:srgbClr val="94A3B8"/>
                 </a:solidFill>
                 <a:latin typeface="Calibri" pitchFamily="34" charset="0"/>
                 <a:ea typeface="Calibri" pitchFamily="34" charset="-122"/>
@@ -18710,7 +18710,7 @@
             <a:r>
               <a:rPr lang="en-US" sz="1400" b="1" dirty="0">
                 <a:solidFill>
-                  <a:srgbClr val="1D2433"/>
+                  <a:srgbClr val="0F172A"/>
                 </a:solidFill>
                 <a:latin typeface="Calibri" pitchFamily="34" charset="0"/>
                 <a:ea typeface="Calibri" pitchFamily="34" charset="-122"/>
@@ -18752,7 +18752,7 @@
             <a:r>
               <a:rPr lang="en-US" sz="1200" dirty="0">
                 <a:solidFill>
-                  <a:srgbClr val="4A5468"/>
+                  <a:srgbClr val="475569"/>
                 </a:solidFill>
                 <a:latin typeface="Calibri" pitchFamily="34" charset="0"/>
                 <a:ea typeface="Calibri" pitchFamily="34" charset="-122"/>
@@ -18791,7 +18791,7 @@
             <a:r>
               <a:rPr lang="en-US" sz="1050" i="1" dirty="0">
                 <a:solidFill>
-                  <a:srgbClr val="8A93A5"/>
+                  <a:srgbClr val="94A3B8"/>
                 </a:solidFill>
                 <a:latin typeface="Calibri" pitchFamily="34" charset="0"/>
                 <a:ea typeface="Calibri" pitchFamily="34" charset="-122"/>
@@ -18818,17 +18818,17 @@
             <a:avLst/>
           </a:prstGeom>
           <a:solidFill>
-            <a:srgbClr val="E1E6EF"/>
+            <a:srgbClr val="E3E1FB"/>
           </a:solidFill>
           <a:ln w="15875">
             <a:solidFill>
-              <a:srgbClr val="BBC7DC"/>
+              <a:srgbClr val="C0BCF6"/>
             </a:solidFill>
             <a:prstDash val="solid"/>
           </a:ln>
           <a:effectLst>
             <a:outerShdw sx="100000" sy="100000" kx="0" ky="0" algn="bl" rotWithShape="0" blurRad="127000" dist="25400" dir="5400000">
-              <a:srgbClr val="1E2B4A">
+              <a:srgbClr val="312E81">
                 <a:alpha val="8000"/>
               </a:srgbClr>
             </a:outerShdw>
@@ -18874,17 +18874,17 @@
             <a:avLst/>
           </a:prstGeom>
           <a:solidFill>
-            <a:srgbClr val="F6ECDC"/>
+            <a:srgbClr val="D7EDF3"/>
           </a:solidFill>
           <a:ln w="15875">
             <a:solidFill>
-              <a:srgbClr val="ECD5B0"/>
+              <a:srgbClr val="A6D7E3"/>
             </a:solidFill>
             <a:prstDash val="solid"/>
           </a:ln>
           <a:effectLst>
             <a:outerShdw sx="100000" sy="100000" kx="0" ky="0" algn="bl" rotWithShape="0" blurRad="127000" dist="25400" dir="5400000">
-              <a:srgbClr val="1E2B4A">
+              <a:srgbClr val="312E81">
                 <a:alpha val="8000"/>
               </a:srgbClr>
             </a:outerShdw>
@@ -18930,17 +18930,17 @@
             <a:avLst/>
           </a:prstGeom>
           <a:solidFill>
-            <a:srgbClr val="F9E8DD"/>
+            <a:srgbClr val="F9E9D7"/>
           </a:solidFill>
           <a:ln w="15875">
             <a:solidFill>
-              <a:srgbClr val="F1CBB3"/>
+              <a:srgbClr val="F1CEA5"/>
             </a:solidFill>
             <a:prstDash val="solid"/>
           </a:ln>
           <a:effectLst>
             <a:outerShdw sx="100000" sy="100000" kx="0" ky="0" algn="bl" rotWithShape="0" blurRad="127000" dist="25400" dir="5400000">
-              <a:srgbClr val="1E2B4A">
+              <a:srgbClr val="312E81">
                 <a:alpha val="8000"/>
               </a:srgbClr>
             </a:outerShdw>
@@ -18998,7 +18998,7 @@
             <a:r>
               <a:rPr lang="en-US" sz="950" dirty="0">
                 <a:solidFill>
-                  <a:srgbClr val="8A93A5"/>
+                  <a:srgbClr val="94A3B8"/>
                 </a:solidFill>
                 <a:latin typeface="Calibri" pitchFamily="34" charset="0"/>
                 <a:ea typeface="Calibri" pitchFamily="34" charset="-122"/>
@@ -19093,7 +19093,7 @@
             <a:r>
               <a:rPr lang="en-US" sz="2700" b="1" dirty="0">
                 <a:solidFill>
-                  <a:srgbClr val="1E2B4A"/>
+                  <a:srgbClr val="312E81"/>
                 </a:solidFill>
                 <a:latin typeface="Calibri" pitchFamily="34" charset="0"/>
                 <a:ea typeface="Calibri" pitchFamily="34" charset="-122"/>
@@ -19135,7 +19135,7 @@
             <a:r>
               <a:rPr lang="en-US" sz="1300" dirty="0">
                 <a:solidFill>
-                  <a:srgbClr val="4A5468"/>
+                  <a:srgbClr val="475569"/>
                 </a:solidFill>
                 <a:latin typeface="Calibri" pitchFamily="34" charset="0"/>
                 <a:ea typeface="Calibri" pitchFamily="34" charset="-122"/>
@@ -19162,17 +19162,17 @@
             <a:avLst/>
           </a:prstGeom>
           <a:solidFill>
-            <a:srgbClr val="E1E6EF"/>
+            <a:srgbClr val="E3E1FB"/>
           </a:solidFill>
           <a:ln w="15875">
             <a:solidFill>
-              <a:srgbClr val="BBC7DC"/>
+              <a:srgbClr val="C0BCF6"/>
             </a:solidFill>
             <a:prstDash val="solid"/>
           </a:ln>
           <a:effectLst>
             <a:outerShdw sx="100000" sy="100000" kx="0" ky="0" algn="bl" rotWithShape="0" blurRad="127000" dist="25400" dir="5400000">
-              <a:srgbClr val="1E2B4A">
+              <a:srgbClr val="312E81">
                 <a:alpha val="8000"/>
               </a:srgbClr>
             </a:outerShdw>
@@ -19233,7 +19233,7 @@
             <a:r>
               <a:rPr lang="en-US" sz="1150" b="1" dirty="0">
                 <a:solidFill>
-                  <a:srgbClr val="1D2433"/>
+                  <a:srgbClr val="0F172A"/>
                 </a:solidFill>
                 <a:latin typeface="Calibri" pitchFamily="34" charset="0"/>
                 <a:ea typeface="Calibri" pitchFamily="34" charset="-122"/>
@@ -19260,17 +19260,17 @@
             <a:avLst/>
           </a:prstGeom>
           <a:solidFill>
-            <a:srgbClr val="E0EDEF"/>
+            <a:srgbClr val="F9DCE9"/>
           </a:solidFill>
           <a:ln w="15875">
             <a:solidFill>
-              <a:srgbClr val="BAD6DB"/>
+              <a:srgbClr val="F2B1CE"/>
             </a:solidFill>
             <a:prstDash val="solid"/>
           </a:ln>
           <a:effectLst>
             <a:outerShdw sx="100000" sy="100000" kx="0" ky="0" algn="bl" rotWithShape="0" blurRad="127000" dist="25400" dir="5400000">
-              <a:srgbClr val="1E2B4A">
+              <a:srgbClr val="312E81">
                 <a:alpha val="8000"/>
               </a:srgbClr>
             </a:outerShdw>
@@ -19331,7 +19331,7 @@
             <a:r>
               <a:rPr lang="en-US" sz="1150" b="1" dirty="0">
                 <a:solidFill>
-                  <a:srgbClr val="1D2433"/>
+                  <a:srgbClr val="0F172A"/>
                 </a:solidFill>
                 <a:latin typeface="Calibri" pitchFamily="34" charset="0"/>
                 <a:ea typeface="Calibri" pitchFamily="34" charset="-122"/>
@@ -19358,17 +19358,17 @@
             <a:avLst/>
           </a:prstGeom>
           <a:solidFill>
-            <a:srgbClr val="E1E6EF"/>
+            <a:srgbClr val="E3E1FB"/>
           </a:solidFill>
           <a:ln w="15875">
             <a:solidFill>
-              <a:srgbClr val="BBC7DC"/>
+              <a:srgbClr val="C0BCF6"/>
             </a:solidFill>
             <a:prstDash val="solid"/>
           </a:ln>
           <a:effectLst>
             <a:outerShdw sx="100000" sy="100000" kx="0" ky="0" algn="bl" rotWithShape="0" blurRad="127000" dist="25400" dir="5400000">
-              <a:srgbClr val="1E2B4A">
+              <a:srgbClr val="312E81">
                 <a:alpha val="8000"/>
               </a:srgbClr>
             </a:outerShdw>
@@ -19429,7 +19429,7 @@
             <a:r>
               <a:rPr lang="en-US" sz="1150" b="1" dirty="0">
                 <a:solidFill>
-                  <a:srgbClr val="1D2433"/>
+                  <a:srgbClr val="0F172A"/>
                 </a:solidFill>
                 <a:latin typeface="Calibri" pitchFamily="34" charset="0"/>
                 <a:ea typeface="Calibri" pitchFamily="34" charset="-122"/>
@@ -19456,17 +19456,17 @@
             <a:avLst/>
           </a:prstGeom>
           <a:solidFill>
-            <a:srgbClr val="F9E8DD"/>
+            <a:srgbClr val="F9E9D7"/>
           </a:solidFill>
           <a:ln w="15875">
             <a:solidFill>
-              <a:srgbClr val="F1CBB3"/>
+              <a:srgbClr val="F1CEA5"/>
             </a:solidFill>
             <a:prstDash val="solid"/>
           </a:ln>
           <a:effectLst>
             <a:outerShdw sx="100000" sy="100000" kx="0" ky="0" algn="bl" rotWithShape="0" blurRad="127000" dist="25400" dir="5400000">
-              <a:srgbClr val="1E2B4A">
+              <a:srgbClr val="312E81">
                 <a:alpha val="8000"/>
               </a:srgbClr>
             </a:outerShdw>
@@ -19527,7 +19527,7 @@
             <a:r>
               <a:rPr lang="en-US" sz="1150" b="1" dirty="0">
                 <a:solidFill>
-                  <a:srgbClr val="1D2433"/>
+                  <a:srgbClr val="0F172A"/>
                 </a:solidFill>
                 <a:latin typeface="Calibri" pitchFamily="34" charset="0"/>
                 <a:ea typeface="Calibri" pitchFamily="34" charset="-122"/>
@@ -19554,17 +19554,17 @@
             <a:avLst/>
           </a:prstGeom>
           <a:solidFill>
-            <a:srgbClr val="F6ECDC"/>
+            <a:srgbClr val="D7EDF3"/>
           </a:solidFill>
           <a:ln w="15875">
             <a:solidFill>
-              <a:srgbClr val="ECD5B0"/>
+              <a:srgbClr val="A6D7E3"/>
             </a:solidFill>
             <a:prstDash val="solid"/>
           </a:ln>
           <a:effectLst>
             <a:outerShdw sx="100000" sy="100000" kx="0" ky="0" algn="bl" rotWithShape="0" blurRad="127000" dist="25400" dir="5400000">
-              <a:srgbClr val="1E2B4A">
+              <a:srgbClr val="312E81">
                 <a:alpha val="8000"/>
               </a:srgbClr>
             </a:outerShdw>
@@ -19625,7 +19625,7 @@
             <a:r>
               <a:rPr lang="en-US" sz="1150" b="1" dirty="0">
                 <a:solidFill>
-                  <a:srgbClr val="1D2433"/>
+                  <a:srgbClr val="0F172A"/>
                 </a:solidFill>
                 <a:latin typeface="Calibri" pitchFamily="34" charset="0"/>
                 <a:ea typeface="Calibri" pitchFamily="34" charset="-122"/>
@@ -19652,17 +19652,17 @@
             <a:avLst/>
           </a:prstGeom>
           <a:solidFill>
-            <a:srgbClr val="E0EDEF"/>
+            <a:srgbClr val="F9DCE9"/>
           </a:solidFill>
           <a:ln w="15875">
             <a:solidFill>
-              <a:srgbClr val="BAD6DB"/>
+              <a:srgbClr val="F2B1CE"/>
             </a:solidFill>
             <a:prstDash val="solid"/>
           </a:ln>
           <a:effectLst>
             <a:outerShdw sx="100000" sy="100000" kx="0" ky="0" algn="bl" rotWithShape="0" blurRad="127000" dist="25400" dir="5400000">
-              <a:srgbClr val="1E2B4A">
+              <a:srgbClr val="312E81">
                 <a:alpha val="8000"/>
               </a:srgbClr>
             </a:outerShdw>
@@ -19723,7 +19723,7 @@
             <a:r>
               <a:rPr lang="en-US" sz="1150" b="1" dirty="0">
                 <a:solidFill>
-                  <a:srgbClr val="1D2433"/>
+                  <a:srgbClr val="0F172A"/>
                 </a:solidFill>
                 <a:latin typeface="Calibri" pitchFamily="34" charset="0"/>
                 <a:ea typeface="Calibri" pitchFamily="34" charset="-122"/>
@@ -19750,17 +19750,17 @@
             <a:avLst/>
           </a:prstGeom>
           <a:solidFill>
-            <a:srgbClr val="E1E6EF"/>
+            <a:srgbClr val="E3E1FB"/>
           </a:solidFill>
           <a:ln w="15875">
             <a:solidFill>
-              <a:srgbClr val="BBC7DC"/>
+              <a:srgbClr val="C0BCF6"/>
             </a:solidFill>
             <a:prstDash val="solid"/>
           </a:ln>
           <a:effectLst>
             <a:outerShdw sx="100000" sy="100000" kx="0" ky="0" algn="bl" rotWithShape="0" blurRad="127000" dist="25400" dir="5400000">
-              <a:srgbClr val="1E2B4A">
+              <a:srgbClr val="312E81">
                 <a:alpha val="8000"/>
               </a:srgbClr>
             </a:outerShdw>
@@ -19821,7 +19821,7 @@
             <a:r>
               <a:rPr lang="en-US" sz="1150" b="1" dirty="0">
                 <a:solidFill>
-                  <a:srgbClr val="1D2433"/>
+                  <a:srgbClr val="0F172A"/>
                 </a:solidFill>
                 <a:latin typeface="Calibri" pitchFamily="34" charset="0"/>
                 <a:ea typeface="Calibri" pitchFamily="34" charset="-122"/>
@@ -19860,7 +19860,7 @@
             <a:r>
               <a:rPr lang="en-US" sz="1450" b="1" dirty="0">
                 <a:solidFill>
-                  <a:srgbClr val="1D2433"/>
+                  <a:srgbClr val="0F172A"/>
                 </a:solidFill>
                 <a:latin typeface="Calibri" pitchFamily="34" charset="0"/>
                 <a:ea typeface="Calibri" pitchFamily="34" charset="-122"/>
@@ -19902,7 +19902,7 @@
             <a:r>
               <a:rPr lang="en-US" sz="1200" dirty="0">
                 <a:solidFill>
-                  <a:srgbClr val="4A5468"/>
+                  <a:srgbClr val="475569"/>
                 </a:solidFill>
                 <a:latin typeface="Calibri" pitchFamily="34" charset="0"/>
                 <a:ea typeface="Calibri" pitchFamily="34" charset="-122"/>
@@ -19922,7 +19922,7 @@
             <a:r>
               <a:rPr lang="en-US" sz="1200" dirty="0">
                 <a:solidFill>
-                  <a:srgbClr val="4A5468"/>
+                  <a:srgbClr val="475569"/>
                 </a:solidFill>
                 <a:latin typeface="Calibri" pitchFamily="34" charset="0"/>
                 <a:ea typeface="Calibri" pitchFamily="34" charset="-122"/>
@@ -19961,7 +19961,7 @@
             <a:r>
               <a:rPr lang="en-US" sz="1450" b="1" dirty="0">
                 <a:solidFill>
-                  <a:srgbClr val="1D2433"/>
+                  <a:srgbClr val="0F172A"/>
                 </a:solidFill>
                 <a:latin typeface="Calibri" pitchFamily="34" charset="0"/>
                 <a:ea typeface="Calibri" pitchFamily="34" charset="-122"/>
@@ -20000,7 +20000,7 @@
             <a:r>
               <a:rPr lang="en-US" sz="1250" b="1" dirty="0">
                 <a:solidFill>
-                  <a:srgbClr val="1D2433"/>
+                  <a:srgbClr val="0F172A"/>
                 </a:solidFill>
                 <a:latin typeface="Calibri" pitchFamily="34" charset="0"/>
                 <a:ea typeface="Calibri" pitchFamily="34" charset="-122"/>
@@ -20039,7 +20039,7 @@
             <a:r>
               <a:rPr lang="en-US" sz="1150" dirty="0">
                 <a:solidFill>
-                  <a:srgbClr val="4A5468"/>
+                  <a:srgbClr val="475569"/>
                 </a:solidFill>
                 <a:latin typeface="Calibri" pitchFamily="34" charset="0"/>
                 <a:ea typeface="Calibri" pitchFamily="34" charset="-122"/>
@@ -20078,7 +20078,7 @@
             <a:r>
               <a:rPr lang="en-US" sz="1250" b="1" dirty="0">
                 <a:solidFill>
-                  <a:srgbClr val="1D2433"/>
+                  <a:srgbClr val="0F172A"/>
                 </a:solidFill>
                 <a:latin typeface="Calibri" pitchFamily="34" charset="0"/>
                 <a:ea typeface="Calibri" pitchFamily="34" charset="-122"/>
@@ -20117,7 +20117,7 @@
             <a:r>
               <a:rPr lang="en-US" sz="1150" dirty="0">
                 <a:solidFill>
-                  <a:srgbClr val="4A5468"/>
+                  <a:srgbClr val="475569"/>
                 </a:solidFill>
                 <a:latin typeface="Calibri" pitchFamily="34" charset="0"/>
                 <a:ea typeface="Calibri" pitchFamily="34" charset="-122"/>
@@ -20156,7 +20156,7 @@
             <a:r>
               <a:rPr lang="en-US" sz="1250" b="1" dirty="0">
                 <a:solidFill>
-                  <a:srgbClr val="1D2433"/>
+                  <a:srgbClr val="0F172A"/>
                 </a:solidFill>
                 <a:latin typeface="Calibri" pitchFamily="34" charset="0"/>
                 <a:ea typeface="Calibri" pitchFamily="34" charset="-122"/>
@@ -20195,7 +20195,7 @@
             <a:r>
               <a:rPr lang="en-US" sz="1150" dirty="0">
                 <a:solidFill>
-                  <a:srgbClr val="4A5468"/>
+                  <a:srgbClr val="475569"/>
                 </a:solidFill>
                 <a:latin typeface="Calibri" pitchFamily="34" charset="0"/>
                 <a:ea typeface="Calibri" pitchFamily="34" charset="-122"/>
@@ -20237,7 +20237,7 @@
             <a:r>
               <a:rPr lang="en-US" sz="1100" dirty="0">
                 <a:solidFill>
-                  <a:srgbClr val="4A5468"/>
+                  <a:srgbClr val="475569"/>
                 </a:solidFill>
                 <a:latin typeface="Calibri" pitchFamily="34" charset="0"/>
                 <a:ea typeface="Calibri" pitchFamily="34" charset="-122"/>
@@ -20276,7 +20276,7 @@
             <a:r>
               <a:rPr lang="en-US" sz="900" dirty="0">
                 <a:solidFill>
-                  <a:srgbClr val="8A93A5"/>
+                  <a:srgbClr val="94A3B8"/>
                 </a:solidFill>
                 <a:latin typeface="Calibri" pitchFamily="34" charset="0"/>
                 <a:ea typeface="Calibri" pitchFamily="34" charset="-122"/>
@@ -20315,7 +20315,7 @@
             <a:r>
               <a:rPr lang="en-US" sz="950" dirty="0">
                 <a:solidFill>
-                  <a:srgbClr val="8A93A5"/>
+                  <a:srgbClr val="94A3B8"/>
                 </a:solidFill>
                 <a:latin typeface="Calibri" pitchFamily="34" charset="0"/>
                 <a:ea typeface="Calibri" pitchFamily="34" charset="-122"/>
@@ -20410,7 +20410,7 @@
             <a:r>
               <a:rPr lang="en-US" sz="2700" b="1" dirty="0">
                 <a:solidFill>
-                  <a:srgbClr val="1E2B4A"/>
+                  <a:srgbClr val="312E81"/>
                 </a:solidFill>
                 <a:latin typeface="Calibri" pitchFamily="34" charset="0"/>
                 <a:ea typeface="Calibri" pitchFamily="34" charset="-122"/>
@@ -20452,7 +20452,7 @@
             <a:r>
               <a:rPr lang="en-US" sz="1300" dirty="0">
                 <a:solidFill>
-                  <a:srgbClr val="4A5468"/>
+                  <a:srgbClr val="475569"/>
                 </a:solidFill>
                 <a:latin typeface="Calibri" pitchFamily="34" charset="0"/>
                 <a:ea typeface="Calibri" pitchFamily="34" charset="-122"/>
@@ -20491,7 +20491,7 @@
             <a:r>
               <a:rPr lang="en-US" sz="3200" b="1" dirty="0">
                 <a:solidFill>
-                  <a:srgbClr val="1E2B4A"/>
+                  <a:srgbClr val="312E81"/>
                 </a:solidFill>
                 <a:latin typeface="Calibri" pitchFamily="34" charset="0"/>
                 <a:ea typeface="Calibri" pitchFamily="34" charset="-122"/>
@@ -20533,7 +20533,7 @@
             <a:r>
               <a:rPr lang="en-US" sz="1050" dirty="0">
                 <a:solidFill>
-                  <a:srgbClr val="4A5468"/>
+                  <a:srgbClr val="475569"/>
                 </a:solidFill>
                 <a:latin typeface="Calibri" pitchFamily="34" charset="0"/>
                 <a:ea typeface="Calibri" pitchFamily="34" charset="-122"/>
@@ -20553,7 +20553,7 @@
             <a:r>
               <a:rPr lang="en-US" sz="1050" dirty="0">
                 <a:solidFill>
-                  <a:srgbClr val="4A5468"/>
+                  <a:srgbClr val="475569"/>
                 </a:solidFill>
                 <a:latin typeface="Calibri" pitchFamily="34" charset="0"/>
                 <a:ea typeface="Calibri" pitchFamily="34" charset="-122"/>
@@ -20592,7 +20592,7 @@
             <a:r>
               <a:rPr lang="en-US" sz="3200" b="1" dirty="0">
                 <a:solidFill>
-                  <a:srgbClr val="1E2B4A"/>
+                  <a:srgbClr val="312E81"/>
                 </a:solidFill>
                 <a:latin typeface="Calibri" pitchFamily="34" charset="0"/>
                 <a:ea typeface="Calibri" pitchFamily="34" charset="-122"/>
@@ -20634,7 +20634,7 @@
             <a:r>
               <a:rPr lang="en-US" sz="1050" dirty="0">
                 <a:solidFill>
-                  <a:srgbClr val="4A5468"/>
+                  <a:srgbClr val="475569"/>
                 </a:solidFill>
                 <a:latin typeface="Calibri" pitchFamily="34" charset="0"/>
                 <a:ea typeface="Calibri" pitchFamily="34" charset="-122"/>
@@ -20654,7 +20654,7 @@
             <a:r>
               <a:rPr lang="en-US" sz="1050" dirty="0">
                 <a:solidFill>
-                  <a:srgbClr val="4A5468"/>
+                  <a:srgbClr val="475569"/>
                 </a:solidFill>
                 <a:latin typeface="Calibri" pitchFamily="34" charset="0"/>
                 <a:ea typeface="Calibri" pitchFamily="34" charset="-122"/>
@@ -20693,7 +20693,7 @@
             <a:r>
               <a:rPr lang="en-US" sz="3200" b="1" dirty="0">
                 <a:solidFill>
-                  <a:srgbClr val="1E2B4A"/>
+                  <a:srgbClr val="312E81"/>
                 </a:solidFill>
                 <a:latin typeface="Calibri" pitchFamily="34" charset="0"/>
                 <a:ea typeface="Calibri" pitchFamily="34" charset="-122"/>
@@ -20735,7 +20735,7 @@
             <a:r>
               <a:rPr lang="en-US" sz="1050" dirty="0">
                 <a:solidFill>
-                  <a:srgbClr val="4A5468"/>
+                  <a:srgbClr val="475569"/>
                 </a:solidFill>
                 <a:latin typeface="Calibri" pitchFamily="34" charset="0"/>
                 <a:ea typeface="Calibri" pitchFamily="34" charset="-122"/>
@@ -20755,7 +20755,7 @@
             <a:r>
               <a:rPr lang="en-US" sz="1050" dirty="0">
                 <a:solidFill>
-                  <a:srgbClr val="4A5468"/>
+                  <a:srgbClr val="475569"/>
                 </a:solidFill>
                 <a:latin typeface="Calibri" pitchFamily="34" charset="0"/>
                 <a:ea typeface="Calibri" pitchFamily="34" charset="-122"/>
@@ -20794,7 +20794,7 @@
             <a:r>
               <a:rPr lang="en-US" sz="3200" b="1" dirty="0">
                 <a:solidFill>
-                  <a:srgbClr val="1E2B4A"/>
+                  <a:srgbClr val="312E81"/>
                 </a:solidFill>
                 <a:latin typeface="Calibri" pitchFamily="34" charset="0"/>
                 <a:ea typeface="Calibri" pitchFamily="34" charset="-122"/>
@@ -20836,7 +20836,7 @@
             <a:r>
               <a:rPr lang="en-US" sz="1050" dirty="0">
                 <a:solidFill>
-                  <a:srgbClr val="4A5468"/>
+                  <a:srgbClr val="475569"/>
                 </a:solidFill>
                 <a:latin typeface="Calibri" pitchFamily="34" charset="0"/>
                 <a:ea typeface="Calibri" pitchFamily="34" charset="-122"/>
@@ -20856,7 +20856,7 @@
             <a:r>
               <a:rPr lang="en-US" sz="1050" dirty="0">
                 <a:solidFill>
-                  <a:srgbClr val="4A5468"/>
+                  <a:srgbClr val="475569"/>
                 </a:solidFill>
                 <a:latin typeface="Calibri" pitchFamily="34" charset="0"/>
                 <a:ea typeface="Calibri" pitchFamily="34" charset="-122"/>
@@ -20883,17 +20883,17 @@
             <a:avLst/>
           </a:prstGeom>
           <a:solidFill>
-            <a:srgbClr val="E0EDEF"/>
+            <a:srgbClr val="F9DCE9"/>
           </a:solidFill>
           <a:ln w="15875">
             <a:solidFill>
-              <a:srgbClr val="BAD6DB"/>
+              <a:srgbClr val="F2B1CE"/>
             </a:solidFill>
             <a:prstDash val="solid"/>
           </a:ln>
           <a:effectLst>
             <a:outerShdw sx="100000" sy="100000" kx="0" ky="0" algn="bl" rotWithShape="0" blurRad="127000" dist="25400" dir="5400000">
-              <a:srgbClr val="1E2B4A">
+              <a:srgbClr val="312E81">
                 <a:alpha val="8000"/>
               </a:srgbClr>
             </a:outerShdw>
@@ -20951,7 +20951,7 @@
             <a:r>
               <a:rPr lang="en-US" sz="1500" b="1" dirty="0">
                 <a:solidFill>
-                  <a:srgbClr val="1D2433"/>
+                  <a:srgbClr val="0F172A"/>
                 </a:solidFill>
                 <a:latin typeface="Calibri" pitchFamily="34" charset="0"/>
                 <a:ea typeface="Calibri" pitchFamily="34" charset="-122"/>
@@ -20993,7 +20993,7 @@
             <a:r>
               <a:rPr lang="en-US" sz="1200" dirty="0">
                 <a:solidFill>
-                  <a:srgbClr val="4A5468"/>
+                  <a:srgbClr val="475569"/>
                 </a:solidFill>
                 <a:latin typeface="Calibri" pitchFamily="34" charset="0"/>
                 <a:ea typeface="Calibri" pitchFamily="34" charset="-122"/>
@@ -21020,17 +21020,17 @@
             <a:avLst/>
           </a:prstGeom>
           <a:solidFill>
-            <a:srgbClr val="F6ECDC"/>
+            <a:srgbClr val="D7EDF3"/>
           </a:solidFill>
           <a:ln w="15875">
             <a:solidFill>
-              <a:srgbClr val="ECD5B0"/>
+              <a:srgbClr val="A6D7E3"/>
             </a:solidFill>
             <a:prstDash val="solid"/>
           </a:ln>
           <a:effectLst>
             <a:outerShdw sx="100000" sy="100000" kx="0" ky="0" algn="bl" rotWithShape="0" blurRad="127000" dist="25400" dir="5400000">
-              <a:srgbClr val="1E2B4A">
+              <a:srgbClr val="312E81">
                 <a:alpha val="8000"/>
               </a:srgbClr>
             </a:outerShdw>
@@ -21088,7 +21088,7 @@
             <a:r>
               <a:rPr lang="en-US" sz="1500" b="1" dirty="0">
                 <a:solidFill>
-                  <a:srgbClr val="1D2433"/>
+                  <a:srgbClr val="0F172A"/>
                 </a:solidFill>
                 <a:latin typeface="Calibri" pitchFamily="34" charset="0"/>
                 <a:ea typeface="Calibri" pitchFamily="34" charset="-122"/>
@@ -21127,7 +21127,7 @@
             <a:r>
               <a:rPr lang="en-US" sz="1100" dirty="0">
                 <a:solidFill>
-                  <a:srgbClr val="4A5468"/>
+                  <a:srgbClr val="475569"/>
                 </a:solidFill>
                 <a:latin typeface="Calibri" pitchFamily="34" charset="0"/>
                 <a:ea typeface="Calibri" pitchFamily="34" charset="-122"/>
@@ -21156,7 +21156,7 @@
             </a:avLst>
           </a:prstGeom>
           <a:solidFill>
-            <a:srgbClr val="C98A24"/>
+            <a:srgbClr val="0891B2"/>
           </a:solidFill>
           <a:ln/>
         </p:spPr>
@@ -21188,7 +21188,7 @@
             <a:r>
               <a:rPr lang="en-US" sz="1100" b="1" dirty="0">
                 <a:solidFill>
-                  <a:srgbClr val="1D2433"/>
+                  <a:srgbClr val="0F172A"/>
                 </a:solidFill>
                 <a:latin typeface="Calibri" pitchFamily="34" charset="0"/>
                 <a:ea typeface="Calibri" pitchFamily="34" charset="-122"/>
@@ -21227,7 +21227,7 @@
             <a:r>
               <a:rPr lang="en-US" sz="1100" dirty="0">
                 <a:solidFill>
-                  <a:srgbClr val="4A5468"/>
+                  <a:srgbClr val="475569"/>
                 </a:solidFill>
                 <a:latin typeface="Calibri" pitchFamily="34" charset="0"/>
                 <a:ea typeface="Calibri" pitchFamily="34" charset="-122"/>
@@ -21256,7 +21256,7 @@
             </a:avLst>
           </a:prstGeom>
           <a:solidFill>
-            <a:srgbClr val="E3E7EE"/>
+            <a:srgbClr val="E2E8F0"/>
           </a:solidFill>
           <a:ln/>
         </p:spPr>
@@ -21288,7 +21288,7 @@
             <a:r>
               <a:rPr lang="en-US" sz="1100" b="1" dirty="0">
                 <a:solidFill>
-                  <a:srgbClr val="1D2433"/>
+                  <a:srgbClr val="0F172A"/>
                 </a:solidFill>
                 <a:latin typeface="Calibri" pitchFamily="34" charset="0"/>
                 <a:ea typeface="Calibri" pitchFamily="34" charset="-122"/>
@@ -21327,7 +21327,7 @@
             <a:r>
               <a:rPr lang="en-US" sz="1100" dirty="0">
                 <a:solidFill>
-                  <a:srgbClr val="4A5468"/>
+                  <a:srgbClr val="475569"/>
                 </a:solidFill>
                 <a:latin typeface="Calibri" pitchFamily="34" charset="0"/>
                 <a:ea typeface="Calibri" pitchFamily="34" charset="-122"/>
@@ -21356,7 +21356,7 @@
             </a:avLst>
           </a:prstGeom>
           <a:solidFill>
-            <a:srgbClr val="E3E7EE"/>
+            <a:srgbClr val="E2E8F0"/>
           </a:solidFill>
           <a:ln/>
         </p:spPr>
@@ -21388,7 +21388,7 @@
             <a:r>
               <a:rPr lang="en-US" sz="1100" b="1" dirty="0">
                 <a:solidFill>
-                  <a:srgbClr val="1D2433"/>
+                  <a:srgbClr val="0F172A"/>
                 </a:solidFill>
                 <a:latin typeface="Calibri" pitchFamily="34" charset="0"/>
                 <a:ea typeface="Calibri" pitchFamily="34" charset="-122"/>
@@ -21427,7 +21427,7 @@
             <a:r>
               <a:rPr lang="en-US" sz="1100" dirty="0">
                 <a:solidFill>
-                  <a:srgbClr val="4A5468"/>
+                  <a:srgbClr val="475569"/>
                 </a:solidFill>
                 <a:latin typeface="Calibri" pitchFamily="34" charset="0"/>
                 <a:ea typeface="Calibri" pitchFamily="34" charset="-122"/>
@@ -21456,7 +21456,7 @@
             </a:avLst>
           </a:prstGeom>
           <a:solidFill>
-            <a:srgbClr val="E3E7EE"/>
+            <a:srgbClr val="E2E8F0"/>
           </a:solidFill>
           <a:ln/>
         </p:spPr>
@@ -21488,7 +21488,7 @@
             <a:r>
               <a:rPr lang="en-US" sz="1100" b="1" dirty="0">
                 <a:solidFill>
-                  <a:srgbClr val="1D2433"/>
+                  <a:srgbClr val="0F172A"/>
                 </a:solidFill>
                 <a:latin typeface="Calibri" pitchFamily="34" charset="0"/>
                 <a:ea typeface="Calibri" pitchFamily="34" charset="-122"/>
@@ -21527,7 +21527,7 @@
             <a:r>
               <a:rPr lang="en-US" sz="900" dirty="0">
                 <a:solidFill>
-                  <a:srgbClr val="8A93A5"/>
+                  <a:srgbClr val="94A3B8"/>
                 </a:solidFill>
                 <a:latin typeface="Calibri" pitchFamily="34" charset="0"/>
                 <a:ea typeface="Calibri" pitchFamily="34" charset="-122"/>
@@ -21566,7 +21566,7 @@
             <a:r>
               <a:rPr lang="en-US" sz="950" dirty="0">
                 <a:solidFill>
-                  <a:srgbClr val="8A93A5"/>
+                  <a:srgbClr val="94A3B8"/>
                 </a:solidFill>
                 <a:latin typeface="Calibri" pitchFamily="34" charset="0"/>
                 <a:ea typeface="Calibri" pitchFamily="34" charset="-122"/>
@@ -21661,7 +21661,7 @@
             <a:r>
               <a:rPr lang="en-US" sz="2700" b="1" dirty="0">
                 <a:solidFill>
-                  <a:srgbClr val="1E2B4A"/>
+                  <a:srgbClr val="312E81"/>
                 </a:solidFill>
                 <a:latin typeface="Calibri" pitchFamily="34" charset="0"/>
                 <a:ea typeface="Calibri" pitchFamily="34" charset="-122"/>
@@ -21703,7 +21703,7 @@
             <a:r>
               <a:rPr lang="en-US" sz="1300" dirty="0">
                 <a:solidFill>
-                  <a:srgbClr val="4A5468"/>
+                  <a:srgbClr val="475569"/>
                 </a:solidFill>
                 <a:latin typeface="Calibri" pitchFamily="34" charset="0"/>
                 <a:ea typeface="Calibri" pitchFamily="34" charset="-122"/>
@@ -21730,17 +21730,17 @@
             <a:avLst/>
           </a:prstGeom>
           <a:solidFill>
-            <a:srgbClr val="E1E6EF"/>
+            <a:srgbClr val="E3E1FB"/>
           </a:solidFill>
           <a:ln w="15875">
             <a:solidFill>
-              <a:srgbClr val="BBC7DC"/>
+              <a:srgbClr val="C0BCF6"/>
             </a:solidFill>
             <a:prstDash val="solid"/>
           </a:ln>
           <a:effectLst>
             <a:outerShdw sx="100000" sy="100000" kx="0" ky="0" algn="bl" rotWithShape="0" blurRad="127000" dist="25400" dir="5400000">
-              <a:srgbClr val="1E2B4A">
+              <a:srgbClr val="312E81">
                 <a:alpha val="8000"/>
               </a:srgbClr>
             </a:outerShdw>
@@ -21798,7 +21798,7 @@
             <a:r>
               <a:rPr lang="en-US" sz="3400" b="1" dirty="0">
                 <a:solidFill>
-                  <a:srgbClr val="E3E7EE"/>
+                  <a:srgbClr val="E2E8F0"/>
                 </a:solidFill>
                 <a:latin typeface="Calibri" pitchFamily="34" charset="0"/>
                 <a:ea typeface="Calibri" pitchFamily="34" charset="-122"/>
@@ -21837,7 +21837,7 @@
             <a:r>
               <a:rPr lang="en-US" sz="1500" b="1" dirty="0">
                 <a:solidFill>
-                  <a:srgbClr val="1D2433"/>
+                  <a:srgbClr val="0F172A"/>
                 </a:solidFill>
                 <a:latin typeface="Calibri" pitchFamily="34" charset="0"/>
                 <a:ea typeface="Calibri" pitchFamily="34" charset="-122"/>
@@ -21879,7 +21879,7 @@
             <a:r>
               <a:rPr lang="en-US" sz="1150" dirty="0">
                 <a:solidFill>
-                  <a:srgbClr val="4A5468"/>
+                  <a:srgbClr val="475569"/>
                 </a:solidFill>
                 <a:latin typeface="Calibri" pitchFamily="34" charset="0"/>
                 <a:ea typeface="Calibri" pitchFamily="34" charset="-122"/>
@@ -21906,17 +21906,17 @@
             <a:avLst/>
           </a:prstGeom>
           <a:solidFill>
-            <a:srgbClr val="E0EDEF"/>
+            <a:srgbClr val="F9DCE9"/>
           </a:solidFill>
           <a:ln w="15875">
             <a:solidFill>
-              <a:srgbClr val="BAD6DB"/>
+              <a:srgbClr val="F2B1CE"/>
             </a:solidFill>
             <a:prstDash val="solid"/>
           </a:ln>
           <a:effectLst>
             <a:outerShdw sx="100000" sy="100000" kx="0" ky="0" algn="bl" rotWithShape="0" blurRad="127000" dist="25400" dir="5400000">
-              <a:srgbClr val="1E2B4A">
+              <a:srgbClr val="312E81">
                 <a:alpha val="8000"/>
               </a:srgbClr>
             </a:outerShdw>
@@ -21974,7 +21974,7 @@
             <a:r>
               <a:rPr lang="en-US" sz="3400" b="1" dirty="0">
                 <a:solidFill>
-                  <a:srgbClr val="E3E7EE"/>
+                  <a:srgbClr val="E2E8F0"/>
                 </a:solidFill>
                 <a:latin typeface="Calibri" pitchFamily="34" charset="0"/>
                 <a:ea typeface="Calibri" pitchFamily="34" charset="-122"/>
@@ -22013,7 +22013,7 @@
             <a:r>
               <a:rPr lang="en-US" sz="1500" b="1" dirty="0">
                 <a:solidFill>
-                  <a:srgbClr val="1D2433"/>
+                  <a:srgbClr val="0F172A"/>
                 </a:solidFill>
                 <a:latin typeface="Calibri" pitchFamily="34" charset="0"/>
                 <a:ea typeface="Calibri" pitchFamily="34" charset="-122"/>
@@ -22055,7 +22055,7 @@
             <a:r>
               <a:rPr lang="en-US" sz="1150" dirty="0">
                 <a:solidFill>
-                  <a:srgbClr val="4A5468"/>
+                  <a:srgbClr val="475569"/>
                 </a:solidFill>
                 <a:latin typeface="Calibri" pitchFamily="34" charset="0"/>
                 <a:ea typeface="Calibri" pitchFamily="34" charset="-122"/>
@@ -22082,17 +22082,17 @@
             <a:avLst/>
           </a:prstGeom>
           <a:solidFill>
-            <a:srgbClr val="F9E8DD"/>
+            <a:srgbClr val="F9E9D7"/>
           </a:solidFill>
           <a:ln w="15875">
             <a:solidFill>
-              <a:srgbClr val="F1CBB3"/>
+              <a:srgbClr val="F1CEA5"/>
             </a:solidFill>
             <a:prstDash val="solid"/>
           </a:ln>
           <a:effectLst>
             <a:outerShdw sx="100000" sy="100000" kx="0" ky="0" algn="bl" rotWithShape="0" blurRad="127000" dist="25400" dir="5400000">
-              <a:srgbClr val="1E2B4A">
+              <a:srgbClr val="312E81">
                 <a:alpha val="8000"/>
               </a:srgbClr>
             </a:outerShdw>
@@ -22150,7 +22150,7 @@
             <a:r>
               <a:rPr lang="en-US" sz="3400" b="1" dirty="0">
                 <a:solidFill>
-                  <a:srgbClr val="E3E7EE"/>
+                  <a:srgbClr val="E2E8F0"/>
                 </a:solidFill>
                 <a:latin typeface="Calibri" pitchFamily="34" charset="0"/>
                 <a:ea typeface="Calibri" pitchFamily="34" charset="-122"/>
@@ -22189,7 +22189,7 @@
             <a:r>
               <a:rPr lang="en-US" sz="1500" b="1" dirty="0">
                 <a:solidFill>
-                  <a:srgbClr val="1D2433"/>
+                  <a:srgbClr val="0F172A"/>
                 </a:solidFill>
                 <a:latin typeface="Calibri" pitchFamily="34" charset="0"/>
                 <a:ea typeface="Calibri" pitchFamily="34" charset="-122"/>
@@ -22231,7 +22231,7 @@
             <a:r>
               <a:rPr lang="en-US" sz="1150" dirty="0">
                 <a:solidFill>
-                  <a:srgbClr val="4A5468"/>
+                  <a:srgbClr val="475569"/>
                 </a:solidFill>
                 <a:latin typeface="Calibri" pitchFamily="34" charset="0"/>
                 <a:ea typeface="Calibri" pitchFamily="34" charset="-122"/>
@@ -22260,7 +22260,7 @@
             </a:avLst>
           </a:prstGeom>
           <a:solidFill>
-            <a:srgbClr val="1E2B4A"/>
+            <a:srgbClr val="312E81"/>
           </a:solidFill>
           <a:ln/>
         </p:spPr>
@@ -22334,7 +22334,7 @@
             <a:r>
               <a:rPr lang="en-US" sz="950" dirty="0">
                 <a:solidFill>
-                  <a:srgbClr val="8A93A5"/>
+                  <a:srgbClr val="94A3B8"/>
                 </a:solidFill>
                 <a:latin typeface="Calibri" pitchFamily="34" charset="0"/>
                 <a:ea typeface="Calibri" pitchFamily="34" charset="-122"/>

</xml_diff>

<commit_message>
Moderniser la palette de la presentation (#705)
La palette passe a l'indigo #4F46E5 pour la couleur dominante et a
l'ambre #D97706 pour l'accent, sur une echelle d'ardoise pour les
textes. Chaque teinte est documentee par son code hexadecimal.


Claude-Session: https://claude.ai/code/session_01837AJxDdpW6rUH9DV9QD1H

Co-authored-by: Claude <noreply@anthropic.com>
</commit_message>
<xml_diff>
--- a/infographie/presentation_infographique.pptx
+++ b/infographie/presentation_infographique.pptx
@@ -2637,7 +2637,7 @@
     <p:bg>
       <p:bgPr>
         <a:solidFill>
-          <a:srgbClr val="16213D"/>
+          <a:srgbClr val="1E1B4B"/>
         </a:solidFill>
       </p:bgPr>
     </p:bg>
@@ -2670,7 +2670,7 @@
             <a:avLst/>
           </a:prstGeom>
           <a:solidFill>
-            <a:srgbClr val="24365E"/>
+            <a:srgbClr val="312E81"/>
           </a:solidFill>
           <a:ln/>
         </p:spPr>
@@ -2690,7 +2690,7 @@
             <a:avLst/>
           </a:prstGeom>
           <a:solidFill>
-            <a:srgbClr val="24365E"/>
+            <a:srgbClr val="312E81"/>
           </a:solidFill>
           <a:ln/>
         </p:spPr>
@@ -2717,7 +2717,7 @@
           <a:ln/>
           <a:effectLst>
             <a:outerShdw sx="100000" sy="100000" kx="0" ky="0" algn="bl" rotWithShape="0" blurRad="127000" dist="25400" dir="5400000">
-              <a:srgbClr val="1E2B4A">
+              <a:srgbClr val="312E81">
                 <a:alpha val="22000"/>
               </a:srgbClr>
             </a:outerShdw>
@@ -2770,7 +2770,7 @@
           <a:ln/>
           <a:effectLst>
             <a:outerShdw sx="100000" sy="100000" kx="0" ky="0" algn="bl" rotWithShape="0" blurRad="127000" dist="25400" dir="5400000">
-              <a:srgbClr val="1E2B4A">
+              <a:srgbClr val="312E81">
                 <a:alpha val="22000"/>
               </a:srgbClr>
             </a:outerShdw>
@@ -2828,7 +2828,7 @@
             <a:r>
               <a:rPr lang="en-US" sz="1200" b="1" spc="200" kern="0" dirty="0">
                 <a:solidFill>
-                  <a:srgbClr val="8FA6CC"/>
+                  <a:srgbClr val="A5B4FC"/>
                 </a:solidFill>
                 <a:latin typeface="Calibri" pitchFamily="34" charset="0"/>
                 <a:ea typeface="Calibri" pitchFamily="34" charset="-122"/>
@@ -2867,7 +2867,7 @@
             <a:r>
               <a:rPr lang="en-US" sz="1250" dirty="0">
                 <a:solidFill>
-                  <a:srgbClr val="AFC0DA"/>
+                  <a:srgbClr val="A5B4FC"/>
                 </a:solidFill>
                 <a:latin typeface="Calibri" pitchFamily="34" charset="0"/>
                 <a:ea typeface="Calibri" pitchFamily="34" charset="-122"/>
@@ -2968,7 +2968,7 @@
             <a:r>
               <a:rPr lang="en-US" sz="1400" dirty="0">
                 <a:solidFill>
-                  <a:srgbClr val="D96F2B"/>
+                  <a:srgbClr val="D97706"/>
                 </a:solidFill>
                 <a:latin typeface="Calibri" pitchFamily="34" charset="0"/>
                 <a:ea typeface="Calibri" pitchFamily="34" charset="-122"/>
@@ -3007,7 +3007,7 @@
             <a:r>
               <a:rPr lang="en-US" sz="1100" dirty="0">
                 <a:solidFill>
-                  <a:srgbClr val="8FA6CC"/>
+                  <a:srgbClr val="A5B4FC"/>
                 </a:solidFill>
                 <a:latin typeface="Calibri" pitchFamily="34" charset="0"/>
                 <a:ea typeface="Calibri" pitchFamily="34" charset="-122"/>
@@ -3088,7 +3088,7 @@
             <a:r>
               <a:rPr lang="en-US" sz="1050" dirty="0">
                 <a:solidFill>
-                  <a:srgbClr val="AFC0DA"/>
+                  <a:srgbClr val="A5B4FC"/>
                 </a:solidFill>
                 <a:latin typeface="Calibri" pitchFamily="34" charset="0"/>
                 <a:ea typeface="Calibri" pitchFamily="34" charset="-122"/>
@@ -3127,7 +3127,7 @@
             <a:r>
               <a:rPr lang="en-US" sz="1100" dirty="0">
                 <a:solidFill>
-                  <a:srgbClr val="8FA6CC"/>
+                  <a:srgbClr val="A5B4FC"/>
                 </a:solidFill>
                 <a:latin typeface="Calibri" pitchFamily="34" charset="0"/>
                 <a:ea typeface="Calibri" pitchFamily="34" charset="-122"/>
@@ -3208,7 +3208,7 @@
             <a:r>
               <a:rPr lang="en-US" sz="1050" dirty="0">
                 <a:solidFill>
-                  <a:srgbClr val="AFC0DA"/>
+                  <a:srgbClr val="A5B4FC"/>
                 </a:solidFill>
                 <a:latin typeface="Calibri" pitchFamily="34" charset="0"/>
                 <a:ea typeface="Calibri" pitchFamily="34" charset="-122"/>
@@ -3247,7 +3247,7 @@
             <a:r>
               <a:rPr lang="en-US" sz="1300" dirty="0">
                 <a:solidFill>
-                  <a:srgbClr val="8FA6CC"/>
+                  <a:srgbClr val="A5B4FC"/>
                 </a:solidFill>
                 <a:latin typeface="Calibri" pitchFamily="34" charset="0"/>
                 <a:ea typeface="Calibri" pitchFamily="34" charset="-122"/>
@@ -3318,7 +3318,7 @@
             <a:r>
               <a:rPr lang="en-US" sz="2700" b="1" dirty="0">
                 <a:solidFill>
-                  <a:srgbClr val="1E2B4A"/>
+                  <a:srgbClr val="312E81"/>
                 </a:solidFill>
                 <a:latin typeface="Calibri" pitchFamily="34" charset="0"/>
                 <a:ea typeface="Calibri" pitchFamily="34" charset="-122"/>
@@ -3360,7 +3360,7 @@
             <a:r>
               <a:rPr lang="en-US" sz="1300" dirty="0">
                 <a:solidFill>
-                  <a:srgbClr val="4A5468"/>
+                  <a:srgbClr val="475569"/>
                 </a:solidFill>
                 <a:latin typeface="Calibri" pitchFamily="34" charset="0"/>
                 <a:ea typeface="Calibri" pitchFamily="34" charset="-122"/>
@@ -3399,7 +3399,7 @@
             <a:r>
               <a:rPr lang="en-US" sz="1500" b="1" dirty="0">
                 <a:solidFill>
-                  <a:srgbClr val="1D2433"/>
+                  <a:srgbClr val="0F172A"/>
                 </a:solidFill>
                 <a:latin typeface="Calibri" pitchFamily="34" charset="0"/>
                 <a:ea typeface="Calibri" pitchFamily="34" charset="-122"/>
@@ -3466,7 +3466,7 @@
             <a:r>
               <a:rPr lang="en-US" sz="1100" b="1" dirty="0">
                 <a:solidFill>
-                  <a:srgbClr val="8A93A5"/>
+                  <a:srgbClr val="94A3B8"/>
                 </a:solidFill>
                 <a:latin typeface="Calibri" pitchFamily="34" charset="0"/>
                 <a:ea typeface="Calibri" pitchFamily="34" charset="-122"/>
@@ -3505,7 +3505,7 @@
             <a:r>
               <a:rPr lang="en-US" sz="1100" b="1" dirty="0">
                 <a:solidFill>
-                  <a:srgbClr val="8A93A5"/>
+                  <a:srgbClr val="94A3B8"/>
                 </a:solidFill>
                 <a:latin typeface="Calibri" pitchFamily="34" charset="0"/>
                 <a:ea typeface="Calibri" pitchFamily="34" charset="-122"/>
@@ -3544,7 +3544,7 @@
             <a:r>
               <a:rPr lang="en-US" sz="1100" b="1" dirty="0">
                 <a:solidFill>
-                  <a:srgbClr val="8A93A5"/>
+                  <a:srgbClr val="94A3B8"/>
                 </a:solidFill>
                 <a:latin typeface="Calibri" pitchFamily="34" charset="0"/>
                 <a:ea typeface="Calibri" pitchFamily="34" charset="-122"/>
@@ -3571,7 +3571,7 @@
             <a:avLst/>
           </a:prstGeom>
           <a:solidFill>
-            <a:srgbClr val="E3E7EE"/>
+            <a:srgbClr val="E2E8F0"/>
           </a:solidFill>
           <a:ln/>
         </p:spPr>
@@ -3603,7 +3603,7 @@
             <a:r>
               <a:rPr lang="en-US" sz="1250" dirty="0">
                 <a:solidFill>
-                  <a:srgbClr val="4A5468"/>
+                  <a:srgbClr val="475569"/>
                 </a:solidFill>
                 <a:latin typeface="Calibri" pitchFamily="34" charset="0"/>
                 <a:ea typeface="Calibri" pitchFamily="34" charset="-122"/>
@@ -3642,7 +3642,7 @@
             <a:r>
               <a:rPr lang="en-US" sz="1500" b="1" dirty="0">
                 <a:solidFill>
-                  <a:srgbClr val="1E2B4A"/>
+                  <a:srgbClr val="312E81"/>
                 </a:solidFill>
                 <a:latin typeface="Calibri" pitchFamily="34" charset="0"/>
                 <a:ea typeface="Calibri" pitchFamily="34" charset="-122"/>
@@ -3681,7 +3681,7 @@
             <a:r>
               <a:rPr lang="en-US" sz="1500" b="1" dirty="0">
                 <a:solidFill>
-                  <a:srgbClr val="1E2B4A"/>
+                  <a:srgbClr val="312E81"/>
                 </a:solidFill>
                 <a:latin typeface="Calibri" pitchFamily="34" charset="0"/>
                 <a:ea typeface="Calibri" pitchFamily="34" charset="-122"/>
@@ -3720,7 +3720,7 @@
             <a:r>
               <a:rPr lang="en-US" sz="1500" b="1" dirty="0">
                 <a:solidFill>
-                  <a:srgbClr val="D96F2B"/>
+                  <a:srgbClr val="D97706"/>
                 </a:solidFill>
                 <a:latin typeface="Calibri" pitchFamily="34" charset="0"/>
                 <a:ea typeface="Calibri" pitchFamily="34" charset="-122"/>
@@ -3747,7 +3747,7 @@
             <a:avLst/>
           </a:prstGeom>
           <a:solidFill>
-            <a:srgbClr val="E3E7EE"/>
+            <a:srgbClr val="E2E8F0"/>
           </a:solidFill>
           <a:ln/>
         </p:spPr>
@@ -3779,7 +3779,7 @@
             <a:r>
               <a:rPr lang="en-US" sz="1250" dirty="0">
                 <a:solidFill>
-                  <a:srgbClr val="4A5468"/>
+                  <a:srgbClr val="475569"/>
                 </a:solidFill>
                 <a:latin typeface="Calibri" pitchFamily="34" charset="0"/>
                 <a:ea typeface="Calibri" pitchFamily="34" charset="-122"/>
@@ -3818,7 +3818,7 @@
             <a:r>
               <a:rPr lang="en-US" sz="1500" b="1" dirty="0">
                 <a:solidFill>
-                  <a:srgbClr val="1E2B4A"/>
+                  <a:srgbClr val="312E81"/>
                 </a:solidFill>
                 <a:latin typeface="Calibri" pitchFamily="34" charset="0"/>
                 <a:ea typeface="Calibri" pitchFamily="34" charset="-122"/>
@@ -3857,7 +3857,7 @@
             <a:r>
               <a:rPr lang="en-US" sz="1500" b="1" dirty="0">
                 <a:solidFill>
-                  <a:srgbClr val="1E2B4A"/>
+                  <a:srgbClr val="312E81"/>
                 </a:solidFill>
                 <a:latin typeface="Calibri" pitchFamily="34" charset="0"/>
                 <a:ea typeface="Calibri" pitchFamily="34" charset="-122"/>
@@ -3896,7 +3896,7 @@
             <a:r>
               <a:rPr lang="en-US" sz="1500" b="1" dirty="0">
                 <a:solidFill>
-                  <a:srgbClr val="D96F2B"/>
+                  <a:srgbClr val="D97706"/>
                 </a:solidFill>
                 <a:latin typeface="Calibri" pitchFamily="34" charset="0"/>
                 <a:ea typeface="Calibri" pitchFamily="34" charset="-122"/>
@@ -3923,7 +3923,7 @@
             <a:avLst/>
           </a:prstGeom>
           <a:solidFill>
-            <a:srgbClr val="E3E7EE"/>
+            <a:srgbClr val="E2E8F0"/>
           </a:solidFill>
           <a:ln/>
         </p:spPr>
@@ -3955,7 +3955,7 @@
             <a:r>
               <a:rPr lang="en-US" sz="1250" dirty="0">
                 <a:solidFill>
-                  <a:srgbClr val="4A5468"/>
+                  <a:srgbClr val="475569"/>
                 </a:solidFill>
                 <a:latin typeface="Calibri" pitchFamily="34" charset="0"/>
                 <a:ea typeface="Calibri" pitchFamily="34" charset="-122"/>
@@ -3994,7 +3994,7 @@
             <a:r>
               <a:rPr lang="en-US" sz="1500" b="1" dirty="0">
                 <a:solidFill>
-                  <a:srgbClr val="1E2B4A"/>
+                  <a:srgbClr val="312E81"/>
                 </a:solidFill>
                 <a:latin typeface="Calibri" pitchFamily="34" charset="0"/>
                 <a:ea typeface="Calibri" pitchFamily="34" charset="-122"/>
@@ -4033,7 +4033,7 @@
             <a:r>
               <a:rPr lang="en-US" sz="1500" b="1" dirty="0">
                 <a:solidFill>
-                  <a:srgbClr val="1E2B4A"/>
+                  <a:srgbClr val="312E81"/>
                 </a:solidFill>
                 <a:latin typeface="Calibri" pitchFamily="34" charset="0"/>
                 <a:ea typeface="Calibri" pitchFamily="34" charset="-122"/>
@@ -4072,7 +4072,7 @@
             <a:r>
               <a:rPr lang="en-US" sz="1500" b="1" dirty="0">
                 <a:solidFill>
-                  <a:srgbClr val="D96F2B"/>
+                  <a:srgbClr val="D97706"/>
                 </a:solidFill>
                 <a:latin typeface="Calibri" pitchFamily="34" charset="0"/>
                 <a:ea typeface="Calibri" pitchFamily="34" charset="-122"/>
@@ -4114,7 +4114,7 @@
             <a:r>
               <a:rPr lang="en-US" sz="1100" dirty="0">
                 <a:solidFill>
-                  <a:srgbClr val="4A5468"/>
+                  <a:srgbClr val="475569"/>
                 </a:solidFill>
                 <a:latin typeface="Calibri" pitchFamily="34" charset="0"/>
                 <a:ea typeface="Calibri" pitchFamily="34" charset="-122"/>
@@ -4153,7 +4153,7 @@
             <a:r>
               <a:rPr lang="en-US" sz="1500" b="1" dirty="0">
                 <a:solidFill>
-                  <a:srgbClr val="1D2433"/>
+                  <a:srgbClr val="0F172A"/>
                 </a:solidFill>
                 <a:latin typeface="Calibri" pitchFamily="34" charset="0"/>
                 <a:ea typeface="Calibri" pitchFamily="34" charset="-122"/>
@@ -4192,7 +4192,7 @@
             <a:r>
               <a:rPr lang="en-US" sz="1250" b="1" dirty="0">
                 <a:solidFill>
-                  <a:srgbClr val="1D2433"/>
+                  <a:srgbClr val="0F172A"/>
                 </a:solidFill>
                 <a:latin typeface="Calibri" pitchFamily="34" charset="0"/>
                 <a:ea typeface="Calibri" pitchFamily="34" charset="-122"/>
@@ -4231,7 +4231,7 @@
             <a:r>
               <a:rPr lang="en-US" sz="1050" dirty="0">
                 <a:solidFill>
-                  <a:srgbClr val="8A93A5"/>
+                  <a:srgbClr val="94A3B8"/>
                 </a:solidFill>
                 <a:latin typeface="Calibri" pitchFamily="34" charset="0"/>
                 <a:ea typeface="Calibri" pitchFamily="34" charset="-122"/>
@@ -4260,7 +4260,7 @@
             </a:avLst>
           </a:prstGeom>
           <a:solidFill>
-            <a:srgbClr val="41639E"/>
+            <a:srgbClr val="4F46E5"/>
           </a:solidFill>
           <a:ln/>
         </p:spPr>
@@ -4292,7 +4292,7 @@
             <a:r>
               <a:rPr lang="en-US" sz="1150" b="1" dirty="0">
                 <a:solidFill>
-                  <a:srgbClr val="1D2433"/>
+                  <a:srgbClr val="0F172A"/>
                 </a:solidFill>
                 <a:latin typeface="Calibri" pitchFamily="34" charset="0"/>
                 <a:ea typeface="Calibri" pitchFamily="34" charset="-122"/>
@@ -4331,7 +4331,7 @@
             <a:r>
               <a:rPr lang="en-US" sz="1050" dirty="0">
                 <a:solidFill>
-                  <a:srgbClr val="8A93A5"/>
+                  <a:srgbClr val="94A3B8"/>
                 </a:solidFill>
                 <a:latin typeface="Calibri" pitchFamily="34" charset="0"/>
                 <a:ea typeface="Calibri" pitchFamily="34" charset="-122"/>
@@ -4360,7 +4360,7 @@
             </a:avLst>
           </a:prstGeom>
           <a:solidFill>
-            <a:srgbClr val="41639E"/>
+            <a:srgbClr val="4F46E5"/>
           </a:solidFill>
           <a:ln/>
         </p:spPr>
@@ -4392,7 +4392,7 @@
             <a:r>
               <a:rPr lang="en-US" sz="1150" b="1" dirty="0">
                 <a:solidFill>
-                  <a:srgbClr val="1D2433"/>
+                  <a:srgbClr val="0F172A"/>
                 </a:solidFill>
                 <a:latin typeface="Calibri" pitchFamily="34" charset="0"/>
                 <a:ea typeface="Calibri" pitchFamily="34" charset="-122"/>
@@ -4431,7 +4431,7 @@
             <a:r>
               <a:rPr lang="en-US" sz="1250" b="1" dirty="0">
                 <a:solidFill>
-                  <a:srgbClr val="1D2433"/>
+                  <a:srgbClr val="0F172A"/>
                 </a:solidFill>
                 <a:latin typeface="Calibri" pitchFamily="34" charset="0"/>
                 <a:ea typeface="Calibri" pitchFamily="34" charset="-122"/>
@@ -4470,7 +4470,7 @@
             <a:r>
               <a:rPr lang="en-US" sz="1050" dirty="0">
                 <a:solidFill>
-                  <a:srgbClr val="8A93A5"/>
+                  <a:srgbClr val="94A3B8"/>
                 </a:solidFill>
                 <a:latin typeface="Calibri" pitchFamily="34" charset="0"/>
                 <a:ea typeface="Calibri" pitchFamily="34" charset="-122"/>
@@ -4499,7 +4499,7 @@
             </a:avLst>
           </a:prstGeom>
           <a:solidFill>
-            <a:srgbClr val="D96F2B"/>
+            <a:srgbClr val="D97706"/>
           </a:solidFill>
           <a:ln/>
         </p:spPr>
@@ -4531,7 +4531,7 @@
             <a:r>
               <a:rPr lang="en-US" sz="1150" b="1" dirty="0">
                 <a:solidFill>
-                  <a:srgbClr val="1D2433"/>
+                  <a:srgbClr val="0F172A"/>
                 </a:solidFill>
                 <a:latin typeface="Calibri" pitchFamily="34" charset="0"/>
                 <a:ea typeface="Calibri" pitchFamily="34" charset="-122"/>
@@ -4570,7 +4570,7 @@
             <a:r>
               <a:rPr lang="en-US" sz="1050" dirty="0">
                 <a:solidFill>
-                  <a:srgbClr val="8A93A5"/>
+                  <a:srgbClr val="94A3B8"/>
                 </a:solidFill>
                 <a:latin typeface="Calibri" pitchFamily="34" charset="0"/>
                 <a:ea typeface="Calibri" pitchFamily="34" charset="-122"/>
@@ -4599,7 +4599,7 @@
             </a:avLst>
           </a:prstGeom>
           <a:solidFill>
-            <a:srgbClr val="D96F2B"/>
+            <a:srgbClr val="D97706"/>
           </a:solidFill>
           <a:ln/>
         </p:spPr>
@@ -4631,7 +4631,7 @@
             <a:r>
               <a:rPr lang="en-US" sz="1150" b="1" dirty="0">
                 <a:solidFill>
-                  <a:srgbClr val="1D2433"/>
+                  <a:srgbClr val="0F172A"/>
                 </a:solidFill>
                 <a:latin typeface="Calibri" pitchFamily="34" charset="0"/>
                 <a:ea typeface="Calibri" pitchFamily="34" charset="-122"/>
@@ -4673,7 +4673,7 @@
             <a:r>
               <a:rPr lang="en-US" sz="1100" dirty="0">
                 <a:solidFill>
-                  <a:srgbClr val="4A5468"/>
+                  <a:srgbClr val="475569"/>
                 </a:solidFill>
                 <a:latin typeface="Calibri" pitchFamily="34" charset="0"/>
                 <a:ea typeface="Calibri" pitchFamily="34" charset="-122"/>
@@ -4712,7 +4712,7 @@
             <a:r>
               <a:rPr lang="en-US" sz="900" dirty="0">
                 <a:solidFill>
-                  <a:srgbClr val="8A93A5"/>
+                  <a:srgbClr val="94A3B8"/>
                 </a:solidFill>
                 <a:latin typeface="Calibri" pitchFamily="34" charset="0"/>
                 <a:ea typeface="Calibri" pitchFamily="34" charset="-122"/>
@@ -4751,7 +4751,7 @@
             <a:r>
               <a:rPr lang="en-US" sz="950" dirty="0">
                 <a:solidFill>
-                  <a:srgbClr val="8A93A5"/>
+                  <a:srgbClr val="94A3B8"/>
                 </a:solidFill>
                 <a:latin typeface="Calibri" pitchFamily="34" charset="0"/>
                 <a:ea typeface="Calibri" pitchFamily="34" charset="-122"/>
@@ -4846,7 +4846,7 @@
             <a:r>
               <a:rPr lang="en-US" sz="2700" b="1" dirty="0">
                 <a:solidFill>
-                  <a:srgbClr val="1E2B4A"/>
+                  <a:srgbClr val="312E81"/>
                 </a:solidFill>
                 <a:latin typeface="Calibri" pitchFamily="34" charset="0"/>
                 <a:ea typeface="Calibri" pitchFamily="34" charset="-122"/>
@@ -4888,7 +4888,7 @@
             <a:r>
               <a:rPr lang="en-US" sz="1300" dirty="0">
                 <a:solidFill>
-                  <a:srgbClr val="4A5468"/>
+                  <a:srgbClr val="475569"/>
                 </a:solidFill>
                 <a:latin typeface="Calibri" pitchFamily="34" charset="0"/>
                 <a:ea typeface="Calibri" pitchFamily="34" charset="-122"/>
@@ -4927,7 +4927,7 @@
             <a:r>
               <a:rPr lang="en-US" sz="3000" b="1" dirty="0">
                 <a:solidFill>
-                  <a:srgbClr val="1E2B4A"/>
+                  <a:srgbClr val="312E81"/>
                 </a:solidFill>
                 <a:latin typeface="Calibri" pitchFamily="34" charset="0"/>
                 <a:ea typeface="Calibri" pitchFamily="34" charset="-122"/>
@@ -4969,7 +4969,7 @@
             <a:r>
               <a:rPr lang="en-US" sz="1050" dirty="0">
                 <a:solidFill>
-                  <a:srgbClr val="4A5468"/>
+                  <a:srgbClr val="475569"/>
                 </a:solidFill>
                 <a:latin typeface="Calibri" pitchFamily="34" charset="0"/>
                 <a:ea typeface="Calibri" pitchFamily="34" charset="-122"/>
@@ -4989,7 +4989,7 @@
             <a:r>
               <a:rPr lang="en-US" sz="1050" dirty="0">
                 <a:solidFill>
-                  <a:srgbClr val="4A5468"/>
+                  <a:srgbClr val="475569"/>
                 </a:solidFill>
                 <a:latin typeface="Calibri" pitchFamily="34" charset="0"/>
                 <a:ea typeface="Calibri" pitchFamily="34" charset="-122"/>
@@ -5028,7 +5028,7 @@
             <a:r>
               <a:rPr lang="en-US" sz="3000" b="1" dirty="0">
                 <a:solidFill>
-                  <a:srgbClr val="1E2B4A"/>
+                  <a:srgbClr val="312E81"/>
                 </a:solidFill>
                 <a:latin typeface="Calibri" pitchFamily="34" charset="0"/>
                 <a:ea typeface="Calibri" pitchFamily="34" charset="-122"/>
@@ -5070,7 +5070,7 @@
             <a:r>
               <a:rPr lang="en-US" sz="1050" dirty="0">
                 <a:solidFill>
-                  <a:srgbClr val="4A5468"/>
+                  <a:srgbClr val="475569"/>
                 </a:solidFill>
                 <a:latin typeface="Calibri" pitchFamily="34" charset="0"/>
                 <a:ea typeface="Calibri" pitchFamily="34" charset="-122"/>
@@ -5090,7 +5090,7 @@
             <a:r>
               <a:rPr lang="en-US" sz="1050" dirty="0">
                 <a:solidFill>
-                  <a:srgbClr val="4A5468"/>
+                  <a:srgbClr val="475569"/>
                 </a:solidFill>
                 <a:latin typeface="Calibri" pitchFamily="34" charset="0"/>
                 <a:ea typeface="Calibri" pitchFamily="34" charset="-122"/>
@@ -5129,7 +5129,7 @@
             <a:r>
               <a:rPr lang="en-US" sz="3000" b="1" dirty="0">
                 <a:solidFill>
-                  <a:srgbClr val="1E2B4A"/>
+                  <a:srgbClr val="312E81"/>
                 </a:solidFill>
                 <a:latin typeface="Calibri" pitchFamily="34" charset="0"/>
                 <a:ea typeface="Calibri" pitchFamily="34" charset="-122"/>
@@ -5171,7 +5171,7 @@
             <a:r>
               <a:rPr lang="en-US" sz="1050" dirty="0">
                 <a:solidFill>
-                  <a:srgbClr val="4A5468"/>
+                  <a:srgbClr val="475569"/>
                 </a:solidFill>
                 <a:latin typeface="Calibri" pitchFamily="34" charset="0"/>
                 <a:ea typeface="Calibri" pitchFamily="34" charset="-122"/>
@@ -5191,7 +5191,7 @@
             <a:r>
               <a:rPr lang="en-US" sz="1050" dirty="0">
                 <a:solidFill>
-                  <a:srgbClr val="4A5468"/>
+                  <a:srgbClr val="475569"/>
                 </a:solidFill>
                 <a:latin typeface="Calibri" pitchFamily="34" charset="0"/>
                 <a:ea typeface="Calibri" pitchFamily="34" charset="-122"/>
@@ -5230,7 +5230,7 @@
             <a:r>
               <a:rPr lang="en-US" sz="3000" b="1" dirty="0">
                 <a:solidFill>
-                  <a:srgbClr val="1E2B4A"/>
+                  <a:srgbClr val="312E81"/>
                 </a:solidFill>
                 <a:latin typeface="Calibri" pitchFamily="34" charset="0"/>
                 <a:ea typeface="Calibri" pitchFamily="34" charset="-122"/>
@@ -5272,7 +5272,7 @@
             <a:r>
               <a:rPr lang="en-US" sz="1050" dirty="0">
                 <a:solidFill>
-                  <a:srgbClr val="4A5468"/>
+                  <a:srgbClr val="475569"/>
                 </a:solidFill>
                 <a:latin typeface="Calibri" pitchFamily="34" charset="0"/>
                 <a:ea typeface="Calibri" pitchFamily="34" charset="-122"/>
@@ -5292,7 +5292,7 @@
             <a:r>
               <a:rPr lang="en-US" sz="1050" dirty="0">
                 <a:solidFill>
-                  <a:srgbClr val="4A5468"/>
+                  <a:srgbClr val="475569"/>
                 </a:solidFill>
                 <a:latin typeface="Calibri" pitchFamily="34" charset="0"/>
                 <a:ea typeface="Calibri" pitchFamily="34" charset="-122"/>
@@ -5331,7 +5331,7 @@
             <a:r>
               <a:rPr lang="en-US" sz="1400" b="1" dirty="0">
                 <a:solidFill>
-                  <a:srgbClr val="1D2433"/>
+                  <a:srgbClr val="0F172A"/>
                 </a:solidFill>
                 <a:latin typeface="Calibri" pitchFamily="34" charset="0"/>
                 <a:ea typeface="Calibri" pitchFamily="34" charset="-122"/>
@@ -5370,7 +5370,7 @@
             <a:r>
               <a:rPr lang="en-US" sz="1100" dirty="0">
                 <a:solidFill>
-                  <a:srgbClr val="4A5468"/>
+                  <a:srgbClr val="475569"/>
                 </a:solidFill>
                 <a:latin typeface="Calibri" pitchFamily="34" charset="0"/>
                 <a:ea typeface="Calibri" pitchFamily="34" charset="-122"/>
@@ -5399,7 +5399,7 @@
             </a:avLst>
           </a:prstGeom>
           <a:solidFill>
-            <a:srgbClr val="E3E7EE"/>
+            <a:srgbClr val="E2E8F0"/>
           </a:solidFill>
           <a:ln/>
         </p:spPr>
@@ -5421,7 +5421,7 @@
             </a:avLst>
           </a:prstGeom>
           <a:solidFill>
-            <a:srgbClr val="3E8C9A"/>
+            <a:srgbClr val="DB2777"/>
           </a:solidFill>
           <a:ln/>
         </p:spPr>
@@ -5453,7 +5453,7 @@
             <a:r>
               <a:rPr lang="en-US" sz="1100" b="1" dirty="0">
                 <a:solidFill>
-                  <a:srgbClr val="1D2433"/>
+                  <a:srgbClr val="0F172A"/>
                 </a:solidFill>
                 <a:latin typeface="Calibri" pitchFamily="34" charset="0"/>
                 <a:ea typeface="Calibri" pitchFamily="34" charset="-122"/>
@@ -5492,7 +5492,7 @@
             <a:r>
               <a:rPr lang="en-US" sz="1100" dirty="0">
                 <a:solidFill>
-                  <a:srgbClr val="4A5468"/>
+                  <a:srgbClr val="475569"/>
                 </a:solidFill>
                 <a:latin typeface="Calibri" pitchFamily="34" charset="0"/>
                 <a:ea typeface="Calibri" pitchFamily="34" charset="-122"/>
@@ -5521,7 +5521,7 @@
             </a:avLst>
           </a:prstGeom>
           <a:solidFill>
-            <a:srgbClr val="E3E7EE"/>
+            <a:srgbClr val="E2E8F0"/>
           </a:solidFill>
           <a:ln/>
         </p:spPr>
@@ -5543,7 +5543,7 @@
             </a:avLst>
           </a:prstGeom>
           <a:solidFill>
-            <a:srgbClr val="3E8C9A"/>
+            <a:srgbClr val="DB2777"/>
           </a:solidFill>
           <a:ln/>
         </p:spPr>
@@ -5575,7 +5575,7 @@
             <a:r>
               <a:rPr lang="en-US" sz="1100" b="1" dirty="0">
                 <a:solidFill>
-                  <a:srgbClr val="1D2433"/>
+                  <a:srgbClr val="0F172A"/>
                 </a:solidFill>
                 <a:latin typeface="Calibri" pitchFamily="34" charset="0"/>
                 <a:ea typeface="Calibri" pitchFamily="34" charset="-122"/>
@@ -5614,7 +5614,7 @@
             <a:r>
               <a:rPr lang="en-US" sz="1100" dirty="0">
                 <a:solidFill>
-                  <a:srgbClr val="4A5468"/>
+                  <a:srgbClr val="475569"/>
                 </a:solidFill>
                 <a:latin typeface="Calibri" pitchFamily="34" charset="0"/>
                 <a:ea typeface="Calibri" pitchFamily="34" charset="-122"/>
@@ -5643,7 +5643,7 @@
             </a:avLst>
           </a:prstGeom>
           <a:solidFill>
-            <a:srgbClr val="E3E7EE"/>
+            <a:srgbClr val="E2E8F0"/>
           </a:solidFill>
           <a:ln/>
         </p:spPr>
@@ -5665,7 +5665,7 @@
             </a:avLst>
           </a:prstGeom>
           <a:solidFill>
-            <a:srgbClr val="3E8C9A"/>
+            <a:srgbClr val="DB2777"/>
           </a:solidFill>
           <a:ln/>
         </p:spPr>
@@ -5697,7 +5697,7 @@
             <a:r>
               <a:rPr lang="en-US" sz="1100" b="1" dirty="0">
                 <a:solidFill>
-                  <a:srgbClr val="1D2433"/>
+                  <a:srgbClr val="0F172A"/>
                 </a:solidFill>
                 <a:latin typeface="Calibri" pitchFamily="34" charset="0"/>
                 <a:ea typeface="Calibri" pitchFamily="34" charset="-122"/>
@@ -5736,7 +5736,7 @@
             <a:r>
               <a:rPr lang="en-US" sz="1100" dirty="0">
                 <a:solidFill>
-                  <a:srgbClr val="4A5468"/>
+                  <a:srgbClr val="475569"/>
                 </a:solidFill>
                 <a:latin typeface="Calibri" pitchFamily="34" charset="0"/>
                 <a:ea typeface="Calibri" pitchFamily="34" charset="-122"/>
@@ -5765,7 +5765,7 @@
             </a:avLst>
           </a:prstGeom>
           <a:solidFill>
-            <a:srgbClr val="E3E7EE"/>
+            <a:srgbClr val="E2E8F0"/>
           </a:solidFill>
           <a:ln/>
         </p:spPr>
@@ -5787,7 +5787,7 @@
             </a:avLst>
           </a:prstGeom>
           <a:solidFill>
-            <a:srgbClr val="3E8C9A"/>
+            <a:srgbClr val="DB2777"/>
           </a:solidFill>
           <a:ln/>
         </p:spPr>
@@ -5819,7 +5819,7 @@
             <a:r>
               <a:rPr lang="en-US" sz="1100" b="1" dirty="0">
                 <a:solidFill>
-                  <a:srgbClr val="1D2433"/>
+                  <a:srgbClr val="0F172A"/>
                 </a:solidFill>
                 <a:latin typeface="Calibri" pitchFamily="34" charset="0"/>
                 <a:ea typeface="Calibri" pitchFamily="34" charset="-122"/>
@@ -5858,7 +5858,7 @@
             <a:r>
               <a:rPr lang="en-US" sz="1100" dirty="0">
                 <a:solidFill>
-                  <a:srgbClr val="4A5468"/>
+                  <a:srgbClr val="475569"/>
                 </a:solidFill>
                 <a:latin typeface="Calibri" pitchFamily="34" charset="0"/>
                 <a:ea typeface="Calibri" pitchFamily="34" charset="-122"/>
@@ -5887,7 +5887,7 @@
             </a:avLst>
           </a:prstGeom>
           <a:solidFill>
-            <a:srgbClr val="E3E7EE"/>
+            <a:srgbClr val="E2E8F0"/>
           </a:solidFill>
           <a:ln/>
         </p:spPr>
@@ -5909,7 +5909,7 @@
             </a:avLst>
           </a:prstGeom>
           <a:solidFill>
-            <a:srgbClr val="3E8C9A"/>
+            <a:srgbClr val="DB2777"/>
           </a:solidFill>
           <a:ln/>
         </p:spPr>
@@ -5941,7 +5941,7 @@
             <a:r>
               <a:rPr lang="en-US" sz="1100" b="1" dirty="0">
                 <a:solidFill>
-                  <a:srgbClr val="1D2433"/>
+                  <a:srgbClr val="0F172A"/>
                 </a:solidFill>
                 <a:latin typeface="Calibri" pitchFamily="34" charset="0"/>
                 <a:ea typeface="Calibri" pitchFamily="34" charset="-122"/>
@@ -5980,7 +5980,7 @@
             <a:r>
               <a:rPr lang="en-US" sz="1100" dirty="0">
                 <a:solidFill>
-                  <a:srgbClr val="4A5468"/>
+                  <a:srgbClr val="475569"/>
                 </a:solidFill>
                 <a:latin typeface="Calibri" pitchFamily="34" charset="0"/>
                 <a:ea typeface="Calibri" pitchFamily="34" charset="-122"/>
@@ -6009,7 +6009,7 @@
             </a:avLst>
           </a:prstGeom>
           <a:solidFill>
-            <a:srgbClr val="E3E7EE"/>
+            <a:srgbClr val="E2E8F0"/>
           </a:solidFill>
           <a:ln/>
         </p:spPr>
@@ -6031,7 +6031,7 @@
             </a:avLst>
           </a:prstGeom>
           <a:solidFill>
-            <a:srgbClr val="3E8C9A"/>
+            <a:srgbClr val="DB2777"/>
           </a:solidFill>
           <a:ln/>
         </p:spPr>
@@ -6063,7 +6063,7 @@
             <a:r>
               <a:rPr lang="en-US" sz="1100" b="1" dirty="0">
                 <a:solidFill>
-                  <a:srgbClr val="1D2433"/>
+                  <a:srgbClr val="0F172A"/>
                 </a:solidFill>
                 <a:latin typeface="Calibri" pitchFamily="34" charset="0"/>
                 <a:ea typeface="Calibri" pitchFamily="34" charset="-122"/>
@@ -6102,7 +6102,7 @@
             <a:r>
               <a:rPr lang="en-US" sz="900" dirty="0">
                 <a:solidFill>
-                  <a:srgbClr val="8A93A5"/>
+                  <a:srgbClr val="94A3B8"/>
                 </a:solidFill>
                 <a:latin typeface="Calibri" pitchFamily="34" charset="0"/>
                 <a:ea typeface="Calibri" pitchFamily="34" charset="-122"/>
@@ -6141,7 +6141,7 @@
             <a:r>
               <a:rPr lang="en-US" sz="950" dirty="0">
                 <a:solidFill>
-                  <a:srgbClr val="8A93A5"/>
+                  <a:srgbClr val="94A3B8"/>
                 </a:solidFill>
                 <a:latin typeface="Calibri" pitchFamily="34" charset="0"/>
                 <a:ea typeface="Calibri" pitchFamily="34" charset="-122"/>
@@ -6236,7 +6236,7 @@
             <a:r>
               <a:rPr lang="en-US" sz="2700" b="1" dirty="0">
                 <a:solidFill>
-                  <a:srgbClr val="1E2B4A"/>
+                  <a:srgbClr val="312E81"/>
                 </a:solidFill>
                 <a:latin typeface="Calibri" pitchFamily="34" charset="0"/>
                 <a:ea typeface="Calibri" pitchFamily="34" charset="-122"/>
@@ -6265,7 +6265,7 @@
             </a:avLst>
           </a:prstGeom>
           <a:solidFill>
-            <a:srgbClr val="1E2B4A"/>
+            <a:srgbClr val="312E81"/>
           </a:solidFill>
           <a:ln/>
         </p:spPr>
@@ -6336,7 +6336,7 @@
             <a:r>
               <a:rPr lang="en-US" sz="1400" b="1" dirty="0">
                 <a:solidFill>
-                  <a:srgbClr val="D96F2B"/>
+                  <a:srgbClr val="D97706"/>
                 </a:solidFill>
                 <a:latin typeface="Calibri" pitchFamily="34" charset="0"/>
                 <a:ea typeface="Calibri" pitchFamily="34" charset="-122"/>
@@ -6417,7 +6417,7 @@
             <a:r>
               <a:rPr lang="en-US" sz="1500" b="1" dirty="0">
                 <a:solidFill>
-                  <a:srgbClr val="D96F2B"/>
+                  <a:srgbClr val="D97706"/>
                 </a:solidFill>
                 <a:latin typeface="Calibri" pitchFamily="34" charset="0"/>
                 <a:ea typeface="Calibri" pitchFamily="34" charset="-122"/>
@@ -6456,7 +6456,7 @@
             <a:r>
               <a:rPr lang="en-US" sz="1350" b="1" dirty="0">
                 <a:solidFill>
-                  <a:srgbClr val="1D2433"/>
+                  <a:srgbClr val="0F172A"/>
                 </a:solidFill>
                 <a:latin typeface="Calibri" pitchFamily="34" charset="0"/>
                 <a:ea typeface="Calibri" pitchFamily="34" charset="-122"/>
@@ -6485,7 +6485,7 @@
             </a:avLst>
           </a:prstGeom>
           <a:solidFill>
-            <a:srgbClr val="D96F2B"/>
+            <a:srgbClr val="D97706"/>
           </a:solidFill>
           <a:ln/>
         </p:spPr>
@@ -6517,7 +6517,7 @@
             <a:r>
               <a:rPr lang="en-US" sz="1500" b="1" dirty="0">
                 <a:solidFill>
-                  <a:srgbClr val="1D2433"/>
+                  <a:srgbClr val="0F172A"/>
                 </a:solidFill>
                 <a:latin typeface="Calibri" pitchFamily="34" charset="0"/>
                 <a:ea typeface="Calibri" pitchFamily="34" charset="-122"/>
@@ -6559,7 +6559,7 @@
             <a:r>
               <a:rPr lang="en-US" sz="1150" b="1" dirty="0">
                 <a:solidFill>
-                  <a:srgbClr val="4A5468"/>
+                  <a:srgbClr val="475569"/>
                 </a:solidFill>
                 <a:latin typeface="Calibri" pitchFamily="34" charset="0"/>
                 <a:ea typeface="Calibri" pitchFamily="34" charset="-122"/>
@@ -6588,7 +6588,7 @@
             </a:avLst>
           </a:prstGeom>
           <a:solidFill>
-            <a:srgbClr val="41639E"/>
+            <a:srgbClr val="4F46E5"/>
           </a:solidFill>
           <a:ln/>
         </p:spPr>
@@ -6620,7 +6620,7 @@
             <a:r>
               <a:rPr lang="en-US" sz="1500" b="1" dirty="0">
                 <a:solidFill>
-                  <a:srgbClr val="1D2433"/>
+                  <a:srgbClr val="0F172A"/>
                 </a:solidFill>
                 <a:latin typeface="Calibri" pitchFamily="34" charset="0"/>
                 <a:ea typeface="Calibri" pitchFamily="34" charset="-122"/>
@@ -6662,7 +6662,7 @@
             <a:r>
               <a:rPr lang="en-US" sz="1150" b="1" dirty="0">
                 <a:solidFill>
-                  <a:srgbClr val="4A5468"/>
+                  <a:srgbClr val="475569"/>
                 </a:solidFill>
                 <a:latin typeface="Calibri" pitchFamily="34" charset="0"/>
                 <a:ea typeface="Calibri" pitchFamily="34" charset="-122"/>
@@ -6682,7 +6682,7 @@
             <a:r>
               <a:rPr lang="en-US" sz="1150" b="1" dirty="0">
                 <a:solidFill>
-                  <a:srgbClr val="4A5468"/>
+                  <a:srgbClr val="475569"/>
                 </a:solidFill>
                 <a:latin typeface="Calibri" pitchFamily="34" charset="0"/>
                 <a:ea typeface="Calibri" pitchFamily="34" charset="-122"/>
@@ -6709,7 +6709,7 @@
             <a:avLst/>
           </a:prstGeom>
           <a:solidFill>
-            <a:srgbClr val="CFD4DD"/>
+            <a:srgbClr val="CBD5E1"/>
           </a:solidFill>
           <a:ln/>
         </p:spPr>
@@ -6741,7 +6741,7 @@
             <a:r>
               <a:rPr lang="en-US" sz="1100" dirty="0">
                 <a:solidFill>
-                  <a:srgbClr val="4A5468"/>
+                  <a:srgbClr val="475569"/>
                 </a:solidFill>
                 <a:latin typeface="Calibri" pitchFamily="34" charset="0"/>
                 <a:ea typeface="Calibri" pitchFamily="34" charset="-122"/>
@@ -6780,7 +6780,7 @@
             <a:r>
               <a:rPr lang="en-US" sz="1350" b="1" dirty="0">
                 <a:solidFill>
-                  <a:srgbClr val="1D2433"/>
+                  <a:srgbClr val="0F172A"/>
                 </a:solidFill>
                 <a:latin typeface="Calibri" pitchFamily="34" charset="0"/>
                 <a:ea typeface="Calibri" pitchFamily="34" charset="-122"/>
@@ -6822,7 +6822,7 @@
             <a:r>
               <a:rPr lang="en-US" sz="1100" dirty="0">
                 <a:solidFill>
-                  <a:srgbClr val="4A5468"/>
+                  <a:srgbClr val="475569"/>
                 </a:solidFill>
                 <a:latin typeface="Calibri" pitchFamily="34" charset="0"/>
                 <a:ea typeface="Calibri" pitchFamily="34" charset="-122"/>
@@ -6861,7 +6861,7 @@
             <a:r>
               <a:rPr lang="en-US" sz="1500" b="1" dirty="0">
                 <a:solidFill>
-                  <a:srgbClr val="1E2B4A"/>
+                  <a:srgbClr val="312E81"/>
                 </a:solidFill>
                 <a:latin typeface="Calibri" pitchFamily="34" charset="0"/>
                 <a:ea typeface="Calibri" pitchFamily="34" charset="-122"/>
@@ -6888,7 +6888,7 @@
             <a:avLst/>
           </a:prstGeom>
           <a:solidFill>
-            <a:srgbClr val="E3E7EE"/>
+            <a:srgbClr val="E2E8F0"/>
           </a:solidFill>
           <a:ln/>
         </p:spPr>
@@ -6923,7 +6923,7 @@
             <a:r>
               <a:rPr lang="en-US" sz="1100" dirty="0">
                 <a:solidFill>
-                  <a:srgbClr val="4A5468"/>
+                  <a:srgbClr val="475569"/>
                 </a:solidFill>
                 <a:latin typeface="Calibri" pitchFamily="34" charset="0"/>
                 <a:ea typeface="Calibri" pitchFamily="34" charset="-122"/>
@@ -6962,7 +6962,7 @@
             <a:r>
               <a:rPr lang="en-US" sz="1500" b="1" dirty="0">
                 <a:solidFill>
-                  <a:srgbClr val="1E2B4A"/>
+                  <a:srgbClr val="312E81"/>
                 </a:solidFill>
                 <a:latin typeface="Calibri" pitchFamily="34" charset="0"/>
                 <a:ea typeface="Calibri" pitchFamily="34" charset="-122"/>
@@ -6989,7 +6989,7 @@
             <a:avLst/>
           </a:prstGeom>
           <a:solidFill>
-            <a:srgbClr val="E3E7EE"/>
+            <a:srgbClr val="E2E8F0"/>
           </a:solidFill>
           <a:ln/>
         </p:spPr>
@@ -7024,7 +7024,7 @@
             <a:r>
               <a:rPr lang="en-US" sz="1100" dirty="0">
                 <a:solidFill>
-                  <a:srgbClr val="4A5468"/>
+                  <a:srgbClr val="475569"/>
                 </a:solidFill>
                 <a:latin typeface="Calibri" pitchFamily="34" charset="0"/>
                 <a:ea typeface="Calibri" pitchFamily="34" charset="-122"/>
@@ -7063,7 +7063,7 @@
             <a:r>
               <a:rPr lang="en-US" sz="1500" b="1" dirty="0">
                 <a:solidFill>
-                  <a:srgbClr val="1E2B4A"/>
+                  <a:srgbClr val="312E81"/>
                 </a:solidFill>
                 <a:latin typeface="Calibri" pitchFamily="34" charset="0"/>
                 <a:ea typeface="Calibri" pitchFamily="34" charset="-122"/>
@@ -7090,7 +7090,7 @@
             <a:avLst/>
           </a:prstGeom>
           <a:solidFill>
-            <a:srgbClr val="E3E7EE"/>
+            <a:srgbClr val="E2E8F0"/>
           </a:solidFill>
           <a:ln/>
         </p:spPr>
@@ -7125,7 +7125,7 @@
             <a:r>
               <a:rPr lang="en-US" sz="1100" dirty="0">
                 <a:solidFill>
-                  <a:srgbClr val="4A5468"/>
+                  <a:srgbClr val="475569"/>
                 </a:solidFill>
                 <a:latin typeface="Calibri" pitchFamily="34" charset="0"/>
                 <a:ea typeface="Calibri" pitchFamily="34" charset="-122"/>
@@ -7164,7 +7164,7 @@
             <a:r>
               <a:rPr lang="en-US" sz="1500" b="1" dirty="0">
                 <a:solidFill>
-                  <a:srgbClr val="8A93A5"/>
+                  <a:srgbClr val="94A3B8"/>
                 </a:solidFill>
                 <a:latin typeface="Calibri" pitchFamily="34" charset="0"/>
                 <a:ea typeface="Calibri" pitchFamily="34" charset="-122"/>
@@ -7191,7 +7191,7 @@
             <a:avLst/>
           </a:prstGeom>
           <a:solidFill>
-            <a:srgbClr val="E3E7EE"/>
+            <a:srgbClr val="E2E8F0"/>
           </a:solidFill>
           <a:ln/>
         </p:spPr>
@@ -7226,7 +7226,7 @@
             <a:r>
               <a:rPr lang="en-US" sz="1050" dirty="0">
                 <a:solidFill>
-                  <a:srgbClr val="4A5468"/>
+                  <a:srgbClr val="475569"/>
                 </a:solidFill>
                 <a:latin typeface="Calibri" pitchFamily="34" charset="0"/>
                 <a:ea typeface="Calibri" pitchFamily="34" charset="-122"/>
@@ -7265,7 +7265,7 @@
             <a:r>
               <a:rPr lang="en-US" sz="900" dirty="0">
                 <a:solidFill>
-                  <a:srgbClr val="8A93A5"/>
+                  <a:srgbClr val="94A3B8"/>
                 </a:solidFill>
                 <a:latin typeface="Calibri" pitchFamily="34" charset="0"/>
                 <a:ea typeface="Calibri" pitchFamily="34" charset="-122"/>
@@ -7304,7 +7304,7 @@
             <a:r>
               <a:rPr lang="en-US" sz="950" dirty="0">
                 <a:solidFill>
-                  <a:srgbClr val="8A93A5"/>
+                  <a:srgbClr val="94A3B8"/>
                 </a:solidFill>
                 <a:latin typeface="Calibri" pitchFamily="34" charset="0"/>
                 <a:ea typeface="Calibri" pitchFamily="34" charset="-122"/>
@@ -7399,7 +7399,7 @@
             <a:r>
               <a:rPr lang="en-US" sz="2700" b="1" dirty="0">
                 <a:solidFill>
-                  <a:srgbClr val="1E2B4A"/>
+                  <a:srgbClr val="312E81"/>
                 </a:solidFill>
                 <a:latin typeface="Calibri" pitchFamily="34" charset="0"/>
                 <a:ea typeface="Calibri" pitchFamily="34" charset="-122"/>
@@ -7441,7 +7441,7 @@
             <a:r>
               <a:rPr lang="en-US" sz="1300" dirty="0">
                 <a:solidFill>
-                  <a:srgbClr val="4A5468"/>
+                  <a:srgbClr val="475569"/>
                 </a:solidFill>
                 <a:latin typeface="Calibri" pitchFamily="34" charset="0"/>
                 <a:ea typeface="Calibri" pitchFamily="34" charset="-122"/>
@@ -7480,7 +7480,7 @@
             <a:r>
               <a:rPr lang="en-US" sz="1400" b="1" dirty="0">
                 <a:solidFill>
-                  <a:srgbClr val="1D2433"/>
+                  <a:srgbClr val="0F172A"/>
                 </a:solidFill>
                 <a:latin typeface="Calibri" pitchFamily="34" charset="0"/>
                 <a:ea typeface="Calibri" pitchFamily="34" charset="-122"/>
@@ -7519,7 +7519,7 @@
             <a:r>
               <a:rPr lang="en-US" sz="1150" b="1" dirty="0">
                 <a:solidFill>
-                  <a:srgbClr val="1D2433"/>
+                  <a:srgbClr val="0F172A"/>
                 </a:solidFill>
                 <a:latin typeface="Calibri" pitchFamily="34" charset="0"/>
                 <a:ea typeface="Calibri" pitchFamily="34" charset="-122"/>
@@ -7548,7 +7548,7 @@
             </a:avLst>
           </a:prstGeom>
           <a:solidFill>
-            <a:srgbClr val="D96F2B"/>
+            <a:srgbClr val="D97706"/>
           </a:solidFill>
           <a:ln/>
         </p:spPr>
@@ -7580,7 +7580,7 @@
             <a:r>
               <a:rPr lang="en-US" sz="1200" b="1" dirty="0">
                 <a:solidFill>
-                  <a:srgbClr val="1D2433"/>
+                  <a:srgbClr val="0F172A"/>
                 </a:solidFill>
                 <a:latin typeface="Calibri" pitchFamily="34" charset="0"/>
                 <a:ea typeface="Calibri" pitchFamily="34" charset="-122"/>
@@ -7619,7 +7619,7 @@
             <a:r>
               <a:rPr lang="en-US" sz="1400" b="1" dirty="0">
                 <a:solidFill>
-                  <a:srgbClr val="D96F2B"/>
+                  <a:srgbClr val="D97706"/>
                 </a:solidFill>
                 <a:latin typeface="Calibri" pitchFamily="34" charset="0"/>
                 <a:ea typeface="Calibri" pitchFamily="34" charset="-122"/>
@@ -7658,7 +7658,7 @@
             <a:r>
               <a:rPr lang="en-US" sz="1150" dirty="0">
                 <a:solidFill>
-                  <a:srgbClr val="4A5468"/>
+                  <a:srgbClr val="475569"/>
                 </a:solidFill>
                 <a:latin typeface="Calibri" pitchFamily="34" charset="0"/>
                 <a:ea typeface="Calibri" pitchFamily="34" charset="-122"/>
@@ -7687,7 +7687,7 @@
             </a:avLst>
           </a:prstGeom>
           <a:solidFill>
-            <a:srgbClr val="E3E7EE"/>
+            <a:srgbClr val="E2E8F0"/>
           </a:solidFill>
           <a:ln/>
         </p:spPr>
@@ -7719,7 +7719,7 @@
             <a:r>
               <a:rPr lang="en-US" sz="1200" b="1" dirty="0">
                 <a:solidFill>
-                  <a:srgbClr val="1D2433"/>
+                  <a:srgbClr val="0F172A"/>
                 </a:solidFill>
                 <a:latin typeface="Calibri" pitchFamily="34" charset="0"/>
                 <a:ea typeface="Calibri" pitchFamily="34" charset="-122"/>
@@ -7758,7 +7758,7 @@
             <a:r>
               <a:rPr lang="en-US" sz="1150" dirty="0">
                 <a:solidFill>
-                  <a:srgbClr val="4A5468"/>
+                  <a:srgbClr val="475569"/>
                 </a:solidFill>
                 <a:latin typeface="Calibri" pitchFamily="34" charset="0"/>
                 <a:ea typeface="Calibri" pitchFamily="34" charset="-122"/>
@@ -7787,7 +7787,7 @@
             </a:avLst>
           </a:prstGeom>
           <a:solidFill>
-            <a:srgbClr val="E3E7EE"/>
+            <a:srgbClr val="E2E8F0"/>
           </a:solidFill>
           <a:ln/>
         </p:spPr>
@@ -7819,7 +7819,7 @@
             <a:r>
               <a:rPr lang="en-US" sz="1200" b="1" dirty="0">
                 <a:solidFill>
-                  <a:srgbClr val="1D2433"/>
+                  <a:srgbClr val="0F172A"/>
                 </a:solidFill>
                 <a:latin typeface="Calibri" pitchFamily="34" charset="0"/>
                 <a:ea typeface="Calibri" pitchFamily="34" charset="-122"/>
@@ -7858,7 +7858,7 @@
             <a:r>
               <a:rPr lang="en-US" sz="1150" dirty="0">
                 <a:solidFill>
-                  <a:srgbClr val="4A5468"/>
+                  <a:srgbClr val="475569"/>
                 </a:solidFill>
                 <a:latin typeface="Calibri" pitchFamily="34" charset="0"/>
                 <a:ea typeface="Calibri" pitchFamily="34" charset="-122"/>
@@ -7887,7 +7887,7 @@
             </a:avLst>
           </a:prstGeom>
           <a:solidFill>
-            <a:srgbClr val="E3E7EE"/>
+            <a:srgbClr val="E2E8F0"/>
           </a:solidFill>
           <a:ln/>
         </p:spPr>
@@ -7919,7 +7919,7 @@
             <a:r>
               <a:rPr lang="en-US" sz="1200" b="1" dirty="0">
                 <a:solidFill>
-                  <a:srgbClr val="1D2433"/>
+                  <a:srgbClr val="0F172A"/>
                 </a:solidFill>
                 <a:latin typeface="Calibri" pitchFamily="34" charset="0"/>
                 <a:ea typeface="Calibri" pitchFamily="34" charset="-122"/>
@@ -7958,7 +7958,7 @@
             <a:r>
               <a:rPr lang="en-US" sz="1150" dirty="0">
                 <a:solidFill>
-                  <a:srgbClr val="4A5468"/>
+                  <a:srgbClr val="475569"/>
                 </a:solidFill>
                 <a:latin typeface="Calibri" pitchFamily="34" charset="0"/>
                 <a:ea typeface="Calibri" pitchFamily="34" charset="-122"/>
@@ -7987,7 +7987,7 @@
             </a:avLst>
           </a:prstGeom>
           <a:solidFill>
-            <a:srgbClr val="E3E7EE"/>
+            <a:srgbClr val="E2E8F0"/>
           </a:solidFill>
           <a:ln/>
         </p:spPr>
@@ -8019,7 +8019,7 @@
             <a:r>
               <a:rPr lang="en-US" sz="1200" b="1" dirty="0">
                 <a:solidFill>
-                  <a:srgbClr val="1D2433"/>
+                  <a:srgbClr val="0F172A"/>
                 </a:solidFill>
                 <a:latin typeface="Calibri" pitchFamily="34" charset="0"/>
                 <a:ea typeface="Calibri" pitchFamily="34" charset="-122"/>
@@ -8058,7 +8058,7 @@
             <a:r>
               <a:rPr lang="en-US" sz="1150" dirty="0">
                 <a:solidFill>
-                  <a:srgbClr val="4A5468"/>
+                  <a:srgbClr val="475569"/>
                 </a:solidFill>
                 <a:latin typeface="Calibri" pitchFamily="34" charset="0"/>
                 <a:ea typeface="Calibri" pitchFamily="34" charset="-122"/>
@@ -8087,7 +8087,7 @@
             </a:avLst>
           </a:prstGeom>
           <a:solidFill>
-            <a:srgbClr val="E3E7EE"/>
+            <a:srgbClr val="E2E8F0"/>
           </a:solidFill>
           <a:ln/>
         </p:spPr>
@@ -8119,7 +8119,7 @@
             <a:r>
               <a:rPr lang="en-US" sz="1200" b="1" dirty="0">
                 <a:solidFill>
-                  <a:srgbClr val="1D2433"/>
+                  <a:srgbClr val="0F172A"/>
                 </a:solidFill>
                 <a:latin typeface="Calibri" pitchFamily="34" charset="0"/>
                 <a:ea typeface="Calibri" pitchFamily="34" charset="-122"/>
@@ -8158,7 +8158,7 @@
             <a:r>
               <a:rPr lang="en-US" sz="1150" dirty="0">
                 <a:solidFill>
-                  <a:srgbClr val="4A5468"/>
+                  <a:srgbClr val="475569"/>
                 </a:solidFill>
                 <a:latin typeface="Calibri" pitchFamily="34" charset="0"/>
                 <a:ea typeface="Calibri" pitchFamily="34" charset="-122"/>
@@ -8187,7 +8187,7 @@
             </a:avLst>
           </a:prstGeom>
           <a:solidFill>
-            <a:srgbClr val="E3E7EE"/>
+            <a:srgbClr val="E2E8F0"/>
           </a:solidFill>
           <a:ln/>
         </p:spPr>
@@ -8219,7 +8219,7 @@
             <a:r>
               <a:rPr lang="en-US" sz="1200" b="1" dirty="0">
                 <a:solidFill>
-                  <a:srgbClr val="1D2433"/>
+                  <a:srgbClr val="0F172A"/>
                 </a:solidFill>
                 <a:latin typeface="Calibri" pitchFamily="34" charset="0"/>
                 <a:ea typeface="Calibri" pitchFamily="34" charset="-122"/>
@@ -8248,7 +8248,7 @@
             </a:avLst>
           </a:prstGeom>
           <a:solidFill>
-            <a:srgbClr val="F7EAE4"/>
+            <a:srgbClr val="FEF3C7"/>
           </a:solidFill>
           <a:ln/>
         </p:spPr>
@@ -8268,17 +8268,17 @@
             <a:avLst/>
           </a:prstGeom>
           <a:solidFill>
-            <a:srgbClr val="F9E8DD"/>
+            <a:srgbClr val="F9E9D7"/>
           </a:solidFill>
           <a:ln w="15875">
             <a:solidFill>
-              <a:srgbClr val="F1CBB3"/>
+              <a:srgbClr val="F1CEA5"/>
             </a:solidFill>
             <a:prstDash val="solid"/>
           </a:ln>
           <a:effectLst>
             <a:outerShdw sx="100000" sy="100000" kx="0" ky="0" algn="bl" rotWithShape="0" blurRad="127000" dist="25400" dir="5400000">
-              <a:srgbClr val="1E2B4A">
+              <a:srgbClr val="312E81">
                 <a:alpha val="8000"/>
               </a:srgbClr>
             </a:outerShdw>
@@ -8339,7 +8339,7 @@
             <a:r>
               <a:rPr lang="en-US" sz="1400" b="1" dirty="0">
                 <a:solidFill>
-                  <a:srgbClr val="1D2433"/>
+                  <a:srgbClr val="0F172A"/>
                 </a:solidFill>
                 <a:latin typeface="Calibri" pitchFamily="34" charset="0"/>
                 <a:ea typeface="Calibri" pitchFamily="34" charset="-122"/>
@@ -8381,7 +8381,7 @@
             <a:r>
               <a:rPr lang="en-US" sz="1100" dirty="0">
                 <a:solidFill>
-                  <a:srgbClr val="4A5468"/>
+                  <a:srgbClr val="475569"/>
                 </a:solidFill>
                 <a:latin typeface="Calibri" pitchFamily="34" charset="0"/>
                 <a:ea typeface="Calibri" pitchFamily="34" charset="-122"/>
@@ -8420,7 +8420,7 @@
             <a:r>
               <a:rPr lang="en-US" sz="1400" b="1" dirty="0">
                 <a:solidFill>
-                  <a:srgbClr val="1D2433"/>
+                  <a:srgbClr val="0F172A"/>
                 </a:solidFill>
                 <a:latin typeface="Calibri" pitchFamily="34" charset="0"/>
                 <a:ea typeface="Calibri" pitchFamily="34" charset="-122"/>
@@ -8459,7 +8459,7 @@
             <a:r>
               <a:rPr lang="en-US" sz="1150" dirty="0">
                 <a:solidFill>
-                  <a:srgbClr val="4A5468"/>
+                  <a:srgbClr val="475569"/>
                 </a:solidFill>
                 <a:latin typeface="Calibri" pitchFamily="34" charset="0"/>
                 <a:ea typeface="Calibri" pitchFamily="34" charset="-122"/>
@@ -8498,7 +8498,7 @@
             <a:r>
               <a:rPr lang="en-US" sz="1150" b="1" dirty="0">
                 <a:solidFill>
-                  <a:srgbClr val="1D2433"/>
+                  <a:srgbClr val="0F172A"/>
                 </a:solidFill>
                 <a:latin typeface="Calibri" pitchFamily="34" charset="0"/>
                 <a:ea typeface="Calibri" pitchFamily="34" charset="-122"/>
@@ -8537,7 +8537,7 @@
             <a:r>
               <a:rPr lang="en-US" sz="1150" dirty="0">
                 <a:solidFill>
-                  <a:srgbClr val="4A5468"/>
+                  <a:srgbClr val="475569"/>
                 </a:solidFill>
                 <a:latin typeface="Calibri" pitchFamily="34" charset="0"/>
                 <a:ea typeface="Calibri" pitchFamily="34" charset="-122"/>
@@ -8576,7 +8576,7 @@
             <a:r>
               <a:rPr lang="en-US" sz="1150" b="1" dirty="0">
                 <a:solidFill>
-                  <a:srgbClr val="1D2433"/>
+                  <a:srgbClr val="0F172A"/>
                 </a:solidFill>
                 <a:latin typeface="Calibri" pitchFamily="34" charset="0"/>
                 <a:ea typeface="Calibri" pitchFamily="34" charset="-122"/>
@@ -8615,7 +8615,7 @@
             <a:r>
               <a:rPr lang="en-US" sz="1150" dirty="0">
                 <a:solidFill>
-                  <a:srgbClr val="4A5468"/>
+                  <a:srgbClr val="475569"/>
                 </a:solidFill>
                 <a:latin typeface="Calibri" pitchFamily="34" charset="0"/>
                 <a:ea typeface="Calibri" pitchFamily="34" charset="-122"/>
@@ -8654,7 +8654,7 @@
             <a:r>
               <a:rPr lang="en-US" sz="1150" b="1" dirty="0">
                 <a:solidFill>
-                  <a:srgbClr val="1D2433"/>
+                  <a:srgbClr val="0F172A"/>
                 </a:solidFill>
                 <a:latin typeface="Calibri" pitchFamily="34" charset="0"/>
                 <a:ea typeface="Calibri" pitchFamily="34" charset="-122"/>
@@ -8732,7 +8732,7 @@
             <a:r>
               <a:rPr lang="en-US" sz="900" dirty="0">
                 <a:solidFill>
-                  <a:srgbClr val="8A93A5"/>
+                  <a:srgbClr val="94A3B8"/>
                 </a:solidFill>
                 <a:latin typeface="Calibri" pitchFamily="34" charset="0"/>
                 <a:ea typeface="Calibri" pitchFamily="34" charset="-122"/>
@@ -8771,7 +8771,7 @@
             <a:r>
               <a:rPr lang="en-US" sz="950" dirty="0">
                 <a:solidFill>
-                  <a:srgbClr val="8A93A5"/>
+                  <a:srgbClr val="94A3B8"/>
                 </a:solidFill>
                 <a:latin typeface="Calibri" pitchFamily="34" charset="0"/>
                 <a:ea typeface="Calibri" pitchFamily="34" charset="-122"/>
@@ -8866,7 +8866,7 @@
             <a:r>
               <a:rPr lang="en-US" sz="2700" b="1" dirty="0">
                 <a:solidFill>
-                  <a:srgbClr val="1E2B4A"/>
+                  <a:srgbClr val="312E81"/>
                 </a:solidFill>
                 <a:latin typeface="Calibri" pitchFamily="34" charset="0"/>
                 <a:ea typeface="Calibri" pitchFamily="34" charset="-122"/>
@@ -8908,7 +8908,7 @@
             <a:r>
               <a:rPr lang="en-US" sz="1300" dirty="0">
                 <a:solidFill>
-                  <a:srgbClr val="4A5468"/>
+                  <a:srgbClr val="475569"/>
                 </a:solidFill>
                 <a:latin typeface="Calibri" pitchFamily="34" charset="0"/>
                 <a:ea typeface="Calibri" pitchFamily="34" charset="-122"/>
@@ -8947,7 +8947,7 @@
             <a:r>
               <a:rPr lang="en-US" sz="1400" b="1" dirty="0">
                 <a:solidFill>
-                  <a:srgbClr val="1D2433"/>
+                  <a:srgbClr val="0F172A"/>
                 </a:solidFill>
                 <a:latin typeface="Calibri" pitchFamily="34" charset="0"/>
                 <a:ea typeface="Calibri" pitchFamily="34" charset="-122"/>
@@ -8986,7 +8986,7 @@
             <a:r>
               <a:rPr lang="en-US" sz="1300" b="1" dirty="0">
                 <a:solidFill>
-                  <a:srgbClr val="1D2433"/>
+                  <a:srgbClr val="0F172A"/>
                 </a:solidFill>
                 <a:latin typeface="Calibri" pitchFamily="34" charset="0"/>
                 <a:ea typeface="Calibri" pitchFamily="34" charset="-122"/>
@@ -9025,7 +9025,7 @@
             <a:r>
               <a:rPr lang="en-US" sz="1050" dirty="0">
                 <a:solidFill>
-                  <a:srgbClr val="8A93A5"/>
+                  <a:srgbClr val="94A3B8"/>
                 </a:solidFill>
                 <a:latin typeface="Calibri" pitchFamily="34" charset="0"/>
                 <a:ea typeface="Calibri" pitchFamily="34" charset="-122"/>
@@ -9054,7 +9054,7 @@
             </a:avLst>
           </a:prstGeom>
           <a:solidFill>
-            <a:srgbClr val="D96F2B"/>
+            <a:srgbClr val="D97706"/>
           </a:solidFill>
           <a:ln/>
         </p:spPr>
@@ -9086,7 +9086,7 @@
             <a:r>
               <a:rPr lang="en-US" sz="1200" b="1" dirty="0">
                 <a:solidFill>
-                  <a:srgbClr val="1D2433"/>
+                  <a:srgbClr val="0F172A"/>
                 </a:solidFill>
                 <a:latin typeface="Calibri" pitchFamily="34" charset="0"/>
                 <a:ea typeface="Calibri" pitchFamily="34" charset="-122"/>
@@ -9125,7 +9125,7 @@
             <a:r>
               <a:rPr lang="en-US" sz="1300" b="1" dirty="0">
                 <a:solidFill>
-                  <a:srgbClr val="D96F2B"/>
+                  <a:srgbClr val="D97706"/>
                 </a:solidFill>
                 <a:latin typeface="Calibri" pitchFamily="34" charset="0"/>
                 <a:ea typeface="Calibri" pitchFamily="34" charset="-122"/>
@@ -9164,7 +9164,7 @@
             <a:r>
               <a:rPr lang="en-US" sz="1300" b="1" dirty="0">
                 <a:solidFill>
-                  <a:srgbClr val="1D2433"/>
+                  <a:srgbClr val="0F172A"/>
                 </a:solidFill>
                 <a:latin typeface="Calibri" pitchFamily="34" charset="0"/>
                 <a:ea typeface="Calibri" pitchFamily="34" charset="-122"/>
@@ -9203,7 +9203,7 @@
             <a:r>
               <a:rPr lang="en-US" sz="1050" dirty="0">
                 <a:solidFill>
-                  <a:srgbClr val="8A93A5"/>
+                  <a:srgbClr val="94A3B8"/>
                 </a:solidFill>
                 <a:latin typeface="Calibri" pitchFamily="34" charset="0"/>
                 <a:ea typeface="Calibri" pitchFamily="34" charset="-122"/>
@@ -9232,7 +9232,7 @@
             </a:avLst>
           </a:prstGeom>
           <a:solidFill>
-            <a:srgbClr val="D96F2B"/>
+            <a:srgbClr val="D97706"/>
           </a:solidFill>
           <a:ln/>
         </p:spPr>
@@ -9264,7 +9264,7 @@
             <a:r>
               <a:rPr lang="en-US" sz="1200" b="1" dirty="0">
                 <a:solidFill>
-                  <a:srgbClr val="1D2433"/>
+                  <a:srgbClr val="0F172A"/>
                 </a:solidFill>
                 <a:latin typeface="Calibri" pitchFamily="34" charset="0"/>
                 <a:ea typeface="Calibri" pitchFamily="34" charset="-122"/>
@@ -9303,7 +9303,7 @@
             <a:r>
               <a:rPr lang="en-US" sz="1300" b="1" dirty="0">
                 <a:solidFill>
-                  <a:srgbClr val="D96F2B"/>
+                  <a:srgbClr val="D97706"/>
                 </a:solidFill>
                 <a:latin typeface="Calibri" pitchFamily="34" charset="0"/>
                 <a:ea typeface="Calibri" pitchFamily="34" charset="-122"/>
@@ -9342,7 +9342,7 @@
             <a:r>
               <a:rPr lang="en-US" sz="1300" b="1" dirty="0">
                 <a:solidFill>
-                  <a:srgbClr val="1D2433"/>
+                  <a:srgbClr val="0F172A"/>
                 </a:solidFill>
                 <a:latin typeface="Calibri" pitchFamily="34" charset="0"/>
                 <a:ea typeface="Calibri" pitchFamily="34" charset="-122"/>
@@ -9381,7 +9381,7 @@
             <a:r>
               <a:rPr lang="en-US" sz="1050" dirty="0">
                 <a:solidFill>
-                  <a:srgbClr val="8A93A5"/>
+                  <a:srgbClr val="94A3B8"/>
                 </a:solidFill>
                 <a:latin typeface="Calibri" pitchFamily="34" charset="0"/>
                 <a:ea typeface="Calibri" pitchFamily="34" charset="-122"/>
@@ -9410,7 +9410,7 @@
             </a:avLst>
           </a:prstGeom>
           <a:solidFill>
-            <a:srgbClr val="E3E7EE"/>
+            <a:srgbClr val="E2E8F0"/>
           </a:solidFill>
           <a:ln/>
         </p:spPr>
@@ -9442,7 +9442,7 @@
             <a:r>
               <a:rPr lang="en-US" sz="1200" b="1" dirty="0">
                 <a:solidFill>
-                  <a:srgbClr val="1D2433"/>
+                  <a:srgbClr val="0F172A"/>
                 </a:solidFill>
                 <a:latin typeface="Calibri" pitchFamily="34" charset="0"/>
                 <a:ea typeface="Calibri" pitchFamily="34" charset="-122"/>
@@ -9481,7 +9481,7 @@
             <a:r>
               <a:rPr lang="en-US" sz="1300" b="1" dirty="0">
                 <a:solidFill>
-                  <a:srgbClr val="1D2433"/>
+                  <a:srgbClr val="0F172A"/>
                 </a:solidFill>
                 <a:latin typeface="Calibri" pitchFamily="34" charset="0"/>
                 <a:ea typeface="Calibri" pitchFamily="34" charset="-122"/>
@@ -9520,7 +9520,7 @@
             <a:r>
               <a:rPr lang="en-US" sz="1050" dirty="0">
                 <a:solidFill>
-                  <a:srgbClr val="8A93A5"/>
+                  <a:srgbClr val="94A3B8"/>
                 </a:solidFill>
                 <a:latin typeface="Calibri" pitchFamily="34" charset="0"/>
                 <a:ea typeface="Calibri" pitchFamily="34" charset="-122"/>
@@ -9549,7 +9549,7 @@
             </a:avLst>
           </a:prstGeom>
           <a:solidFill>
-            <a:srgbClr val="E3E7EE"/>
+            <a:srgbClr val="E2E8F0"/>
           </a:solidFill>
           <a:ln/>
         </p:spPr>
@@ -9581,7 +9581,7 @@
             <a:r>
               <a:rPr lang="en-US" sz="1200" b="1" dirty="0">
                 <a:solidFill>
-                  <a:srgbClr val="1D2433"/>
+                  <a:srgbClr val="0F172A"/>
                 </a:solidFill>
                 <a:latin typeface="Calibri" pitchFamily="34" charset="0"/>
                 <a:ea typeface="Calibri" pitchFamily="34" charset="-122"/>
@@ -9620,7 +9620,7 @@
             <a:r>
               <a:rPr lang="en-US" sz="1300" b="1" dirty="0">
                 <a:solidFill>
-                  <a:srgbClr val="1D2433"/>
+                  <a:srgbClr val="0F172A"/>
                 </a:solidFill>
                 <a:latin typeface="Calibri" pitchFamily="34" charset="0"/>
                 <a:ea typeface="Calibri" pitchFamily="34" charset="-122"/>
@@ -9659,7 +9659,7 @@
             <a:r>
               <a:rPr lang="en-US" sz="1050" dirty="0">
                 <a:solidFill>
-                  <a:srgbClr val="8A93A5"/>
+                  <a:srgbClr val="94A3B8"/>
                 </a:solidFill>
                 <a:latin typeface="Calibri" pitchFamily="34" charset="0"/>
                 <a:ea typeface="Calibri" pitchFamily="34" charset="-122"/>
@@ -9688,7 +9688,7 @@
             </a:avLst>
           </a:prstGeom>
           <a:solidFill>
-            <a:srgbClr val="E3E7EE"/>
+            <a:srgbClr val="E2E8F0"/>
           </a:solidFill>
           <a:ln/>
         </p:spPr>
@@ -9720,7 +9720,7 @@
             <a:r>
               <a:rPr lang="en-US" sz="1200" b="1" dirty="0">
                 <a:solidFill>
-                  <a:srgbClr val="1D2433"/>
+                  <a:srgbClr val="0F172A"/>
                 </a:solidFill>
                 <a:latin typeface="Calibri" pitchFamily="34" charset="0"/>
                 <a:ea typeface="Calibri" pitchFamily="34" charset="-122"/>
@@ -9747,7 +9747,7 @@
             <a:avLst/>
           </a:prstGeom>
           <a:solidFill>
-            <a:srgbClr val="B9C0CC"/>
+            <a:srgbClr val="CBD5E1"/>
           </a:solidFill>
           <a:ln/>
         </p:spPr>
@@ -9769,7 +9769,7 @@
             </a:avLst>
           </a:prstGeom>
           <a:solidFill>
-            <a:srgbClr val="1E2B4A"/>
+            <a:srgbClr val="312E81"/>
           </a:solidFill>
           <a:ln/>
         </p:spPr>
@@ -9840,7 +9840,7 @@
             <a:r>
               <a:rPr lang="en-US" sz="1150" b="1" dirty="0">
                 <a:solidFill>
-                  <a:srgbClr val="D96F2B"/>
+                  <a:srgbClr val="D97706"/>
                 </a:solidFill>
                 <a:latin typeface="Calibri" pitchFamily="34" charset="0"/>
                 <a:ea typeface="Calibri" pitchFamily="34" charset="-122"/>
@@ -9921,7 +9921,7 @@
             <a:r>
               <a:rPr lang="en-US" sz="1400" b="1" dirty="0">
                 <a:solidFill>
-                  <a:srgbClr val="1D2433"/>
+                  <a:srgbClr val="0F172A"/>
                 </a:solidFill>
                 <a:latin typeface="Calibri" pitchFamily="34" charset="0"/>
                 <a:ea typeface="Calibri" pitchFamily="34" charset="-122"/>
@@ -9963,7 +9963,7 @@
             <a:r>
               <a:rPr lang="en-US" sz="1100" dirty="0">
                 <a:solidFill>
-                  <a:srgbClr val="4A5468"/>
+                  <a:srgbClr val="475569"/>
                 </a:solidFill>
                 <a:latin typeface="Calibri" pitchFamily="34" charset="0"/>
                 <a:ea typeface="Calibri" pitchFamily="34" charset="-122"/>
@@ -10002,7 +10002,7 @@
             <a:r>
               <a:rPr lang="en-US" sz="900" dirty="0">
                 <a:solidFill>
-                  <a:srgbClr val="8A93A5"/>
+                  <a:srgbClr val="94A3B8"/>
                 </a:solidFill>
                 <a:latin typeface="Calibri" pitchFamily="34" charset="0"/>
                 <a:ea typeface="Calibri" pitchFamily="34" charset="-122"/>
@@ -10041,7 +10041,7 @@
             <a:r>
               <a:rPr lang="en-US" sz="950" dirty="0">
                 <a:solidFill>
-                  <a:srgbClr val="8A93A5"/>
+                  <a:srgbClr val="94A3B8"/>
                 </a:solidFill>
                 <a:latin typeface="Calibri" pitchFamily="34" charset="0"/>
                 <a:ea typeface="Calibri" pitchFamily="34" charset="-122"/>
@@ -10136,7 +10136,7 @@
             <a:r>
               <a:rPr lang="en-US" sz="2700" b="1" dirty="0">
                 <a:solidFill>
-                  <a:srgbClr val="1E2B4A"/>
+                  <a:srgbClr val="312E81"/>
                 </a:solidFill>
                 <a:latin typeface="Calibri" pitchFamily="34" charset="0"/>
                 <a:ea typeface="Calibri" pitchFamily="34" charset="-122"/>
@@ -10163,17 +10163,17 @@
             <a:avLst/>
           </a:prstGeom>
           <a:solidFill>
-            <a:srgbClr val="E1E6EF"/>
+            <a:srgbClr val="E3E1FB"/>
           </a:solidFill>
           <a:ln w="15875">
             <a:solidFill>
-              <a:srgbClr val="BBC7DC"/>
+              <a:srgbClr val="C0BCF6"/>
             </a:solidFill>
             <a:prstDash val="solid"/>
           </a:ln>
           <a:effectLst>
             <a:outerShdw sx="100000" sy="100000" kx="0" ky="0" algn="bl" rotWithShape="0" blurRad="127000" dist="25400" dir="5400000">
-              <a:srgbClr val="1E2B4A">
+              <a:srgbClr val="312E81">
                 <a:alpha val="8000"/>
               </a:srgbClr>
             </a:outerShdw>
@@ -10231,7 +10231,7 @@
             <a:r>
               <a:rPr lang="en-US" sz="1500" b="1" dirty="0">
                 <a:solidFill>
-                  <a:srgbClr val="1D2433"/>
+                  <a:srgbClr val="0F172A"/>
                 </a:solidFill>
                 <a:latin typeface="Calibri" pitchFamily="34" charset="0"/>
                 <a:ea typeface="Calibri" pitchFamily="34" charset="-122"/>
@@ -10270,7 +10270,7 @@
             <a:r>
               <a:rPr lang="en-US" sz="1100" b="1" dirty="0">
                 <a:solidFill>
-                  <a:srgbClr val="41639E"/>
+                  <a:srgbClr val="4F46E5"/>
                 </a:solidFill>
                 <a:latin typeface="Calibri" pitchFamily="34" charset="0"/>
                 <a:ea typeface="Calibri" pitchFamily="34" charset="-122"/>
@@ -10312,7 +10312,7 @@
             <a:r>
               <a:rPr lang="en-US" sz="1200" dirty="0">
                 <a:solidFill>
-                  <a:srgbClr val="4A5468"/>
+                  <a:srgbClr val="475569"/>
                 </a:solidFill>
                 <a:latin typeface="Calibri" pitchFamily="34" charset="0"/>
                 <a:ea typeface="Calibri" pitchFamily="34" charset="-122"/>
@@ -10339,17 +10339,17 @@
             <a:avLst/>
           </a:prstGeom>
           <a:solidFill>
-            <a:srgbClr val="E0EDEF"/>
+            <a:srgbClr val="F9DCE9"/>
           </a:solidFill>
           <a:ln w="15875">
             <a:solidFill>
-              <a:srgbClr val="BAD6DB"/>
+              <a:srgbClr val="F2B1CE"/>
             </a:solidFill>
             <a:prstDash val="solid"/>
           </a:ln>
           <a:effectLst>
             <a:outerShdw sx="100000" sy="100000" kx="0" ky="0" algn="bl" rotWithShape="0" blurRad="127000" dist="25400" dir="5400000">
-              <a:srgbClr val="1E2B4A">
+              <a:srgbClr val="312E81">
                 <a:alpha val="8000"/>
               </a:srgbClr>
             </a:outerShdw>
@@ -10407,7 +10407,7 @@
             <a:r>
               <a:rPr lang="en-US" sz="1500" b="1" dirty="0">
                 <a:solidFill>
-                  <a:srgbClr val="1D2433"/>
+                  <a:srgbClr val="0F172A"/>
                 </a:solidFill>
                 <a:latin typeface="Calibri" pitchFamily="34" charset="0"/>
                 <a:ea typeface="Calibri" pitchFamily="34" charset="-122"/>
@@ -10446,7 +10446,7 @@
             <a:r>
               <a:rPr lang="en-US" sz="1100" b="1" dirty="0">
                 <a:solidFill>
-                  <a:srgbClr val="3E8C9A"/>
+                  <a:srgbClr val="DB2777"/>
                 </a:solidFill>
                 <a:latin typeface="Calibri" pitchFamily="34" charset="0"/>
                 <a:ea typeface="Calibri" pitchFamily="34" charset="-122"/>
@@ -10488,7 +10488,7 @@
             <a:r>
               <a:rPr lang="en-US" sz="1200" dirty="0">
                 <a:solidFill>
-                  <a:srgbClr val="4A5468"/>
+                  <a:srgbClr val="475569"/>
                 </a:solidFill>
                 <a:latin typeface="Calibri" pitchFamily="34" charset="0"/>
                 <a:ea typeface="Calibri" pitchFamily="34" charset="-122"/>
@@ -10515,17 +10515,17 @@
             <a:avLst/>
           </a:prstGeom>
           <a:solidFill>
-            <a:srgbClr val="F6ECDC"/>
+            <a:srgbClr val="D7EDF3"/>
           </a:solidFill>
           <a:ln w="15875">
             <a:solidFill>
-              <a:srgbClr val="ECD5B0"/>
+              <a:srgbClr val="A6D7E3"/>
             </a:solidFill>
             <a:prstDash val="solid"/>
           </a:ln>
           <a:effectLst>
             <a:outerShdw sx="100000" sy="100000" kx="0" ky="0" algn="bl" rotWithShape="0" blurRad="127000" dist="25400" dir="5400000">
-              <a:srgbClr val="1E2B4A">
+              <a:srgbClr val="312E81">
                 <a:alpha val="8000"/>
               </a:srgbClr>
             </a:outerShdw>
@@ -10583,7 +10583,7 @@
             <a:r>
               <a:rPr lang="en-US" sz="1500" b="1" dirty="0">
                 <a:solidFill>
-                  <a:srgbClr val="1D2433"/>
+                  <a:srgbClr val="0F172A"/>
                 </a:solidFill>
                 <a:latin typeface="Calibri" pitchFamily="34" charset="0"/>
                 <a:ea typeface="Calibri" pitchFamily="34" charset="-122"/>
@@ -10622,7 +10622,7 @@
             <a:r>
               <a:rPr lang="en-US" sz="1100" b="1" dirty="0">
                 <a:solidFill>
-                  <a:srgbClr val="C98A24"/>
+                  <a:srgbClr val="0891B2"/>
                 </a:solidFill>
                 <a:latin typeface="Calibri" pitchFamily="34" charset="0"/>
                 <a:ea typeface="Calibri" pitchFamily="34" charset="-122"/>
@@ -10664,7 +10664,7 @@
             <a:r>
               <a:rPr lang="en-US" sz="1200" dirty="0">
                 <a:solidFill>
-                  <a:srgbClr val="4A5468"/>
+                  <a:srgbClr val="475569"/>
                 </a:solidFill>
                 <a:latin typeface="Calibri" pitchFamily="34" charset="0"/>
                 <a:ea typeface="Calibri" pitchFamily="34" charset="-122"/>
@@ -10691,17 +10691,17 @@
             <a:avLst/>
           </a:prstGeom>
           <a:solidFill>
-            <a:srgbClr val="F9E8DD"/>
+            <a:srgbClr val="F9E9D7"/>
           </a:solidFill>
           <a:ln w="15875">
             <a:solidFill>
-              <a:srgbClr val="F1CBB3"/>
+              <a:srgbClr val="F1CEA5"/>
             </a:solidFill>
             <a:prstDash val="solid"/>
           </a:ln>
           <a:effectLst>
             <a:outerShdw sx="100000" sy="100000" kx="0" ky="0" algn="bl" rotWithShape="0" blurRad="127000" dist="25400" dir="5400000">
-              <a:srgbClr val="1E2B4A">
+              <a:srgbClr val="312E81">
                 <a:alpha val="8000"/>
               </a:srgbClr>
             </a:outerShdw>
@@ -10759,7 +10759,7 @@
             <a:r>
               <a:rPr lang="en-US" sz="1500" b="1" dirty="0">
                 <a:solidFill>
-                  <a:srgbClr val="1D2433"/>
+                  <a:srgbClr val="0F172A"/>
                 </a:solidFill>
                 <a:latin typeface="Calibri" pitchFamily="34" charset="0"/>
                 <a:ea typeface="Calibri" pitchFamily="34" charset="-122"/>
@@ -10798,7 +10798,7 @@
             <a:r>
               <a:rPr lang="en-US" sz="1100" b="1" dirty="0">
                 <a:solidFill>
-                  <a:srgbClr val="D96F2B"/>
+                  <a:srgbClr val="D97706"/>
                 </a:solidFill>
                 <a:latin typeface="Calibri" pitchFamily="34" charset="0"/>
                 <a:ea typeface="Calibri" pitchFamily="34" charset="-122"/>
@@ -10840,7 +10840,7 @@
             <a:r>
               <a:rPr lang="en-US" sz="1200" dirty="0">
                 <a:solidFill>
-                  <a:srgbClr val="4A5468"/>
+                  <a:srgbClr val="475569"/>
                 </a:solidFill>
                 <a:latin typeface="Calibri" pitchFamily="34" charset="0"/>
                 <a:ea typeface="Calibri" pitchFamily="34" charset="-122"/>
@@ -10901,7 +10901,7 @@
             <a:r>
               <a:rPr lang="en-US" sz="900" dirty="0">
                 <a:solidFill>
-                  <a:srgbClr val="8A93A5"/>
+                  <a:srgbClr val="94A3B8"/>
                 </a:solidFill>
                 <a:latin typeface="Calibri" pitchFamily="34" charset="0"/>
                 <a:ea typeface="Calibri" pitchFamily="34" charset="-122"/>
@@ -10940,7 +10940,7 @@
             <a:r>
               <a:rPr lang="en-US" sz="950" dirty="0">
                 <a:solidFill>
-                  <a:srgbClr val="8A93A5"/>
+                  <a:srgbClr val="94A3B8"/>
                 </a:solidFill>
                 <a:latin typeface="Calibri" pitchFamily="34" charset="0"/>
                 <a:ea typeface="Calibri" pitchFamily="34" charset="-122"/>
@@ -11035,7 +11035,7 @@
             <a:r>
               <a:rPr lang="en-US" sz="2700" b="1" dirty="0">
                 <a:solidFill>
-                  <a:srgbClr val="1E2B4A"/>
+                  <a:srgbClr val="312E81"/>
                 </a:solidFill>
                 <a:latin typeface="Calibri" pitchFamily="34" charset="0"/>
                 <a:ea typeface="Calibri" pitchFamily="34" charset="-122"/>
@@ -11074,7 +11074,7 @@
             <a:r>
               <a:rPr lang="en-US" sz="2600" b="1" dirty="0">
                 <a:solidFill>
-                  <a:srgbClr val="D96F2B"/>
+                  <a:srgbClr val="D97706"/>
                 </a:solidFill>
                 <a:latin typeface="Calibri" pitchFamily="34" charset="0"/>
                 <a:ea typeface="Calibri" pitchFamily="34" charset="-122"/>
@@ -11116,7 +11116,7 @@
             <a:r>
               <a:rPr lang="en-US" sz="1200" i="1" dirty="0">
                 <a:solidFill>
-                  <a:srgbClr val="4A5468"/>
+                  <a:srgbClr val="475569"/>
                 </a:solidFill>
                 <a:latin typeface="Calibri" pitchFamily="34" charset="0"/>
                 <a:ea typeface="Calibri" pitchFamily="34" charset="-122"/>
@@ -11158,7 +11158,7 @@
             <a:r>
               <a:rPr lang="en-US" sz="1250" dirty="0">
                 <a:solidFill>
-                  <a:srgbClr val="1D2433"/>
+                  <a:srgbClr val="0F172A"/>
                 </a:solidFill>
                 <a:latin typeface="Calibri" pitchFamily="34" charset="0"/>
                 <a:ea typeface="Calibri" pitchFamily="34" charset="-122"/>
@@ -11197,7 +11197,7 @@
             <a:r>
               <a:rPr lang="en-US" sz="1350" b="1" dirty="0">
                 <a:solidFill>
-                  <a:srgbClr val="D96F2B"/>
+                  <a:srgbClr val="D97706"/>
                 </a:solidFill>
                 <a:latin typeface="Calibri" pitchFamily="34" charset="0"/>
                 <a:ea typeface="Calibri" pitchFamily="34" charset="-122"/>
@@ -11236,7 +11236,7 @@
             <a:r>
               <a:rPr lang="en-US" sz="2600" b="1" dirty="0">
                 <a:solidFill>
-                  <a:srgbClr val="3E8C9A"/>
+                  <a:srgbClr val="DB2777"/>
                 </a:solidFill>
                 <a:latin typeface="Calibri" pitchFamily="34" charset="0"/>
                 <a:ea typeface="Calibri" pitchFamily="34" charset="-122"/>
@@ -11278,7 +11278,7 @@
             <a:r>
               <a:rPr lang="en-US" sz="1200" i="1" dirty="0">
                 <a:solidFill>
-                  <a:srgbClr val="4A5468"/>
+                  <a:srgbClr val="475569"/>
                 </a:solidFill>
                 <a:latin typeface="Calibri" pitchFamily="34" charset="0"/>
                 <a:ea typeface="Calibri" pitchFamily="34" charset="-122"/>
@@ -11320,7 +11320,7 @@
             <a:r>
               <a:rPr lang="en-US" sz="1250" dirty="0">
                 <a:solidFill>
-                  <a:srgbClr val="1D2433"/>
+                  <a:srgbClr val="0F172A"/>
                 </a:solidFill>
                 <a:latin typeface="Calibri" pitchFamily="34" charset="0"/>
                 <a:ea typeface="Calibri" pitchFamily="34" charset="-122"/>
@@ -11359,7 +11359,7 @@
             <a:r>
               <a:rPr lang="en-US" sz="1350" b="1" dirty="0">
                 <a:solidFill>
-                  <a:srgbClr val="3E8C9A"/>
+                  <a:srgbClr val="DB2777"/>
                 </a:solidFill>
                 <a:latin typeface="Calibri" pitchFamily="34" charset="0"/>
                 <a:ea typeface="Calibri" pitchFamily="34" charset="-122"/>
@@ -11386,17 +11386,17 @@
             <a:avLst/>
           </a:prstGeom>
           <a:solidFill>
-            <a:srgbClr val="F9E8DD"/>
+            <a:srgbClr val="F9E9D7"/>
           </a:solidFill>
           <a:ln w="15875">
             <a:solidFill>
-              <a:srgbClr val="F1CBB3"/>
+              <a:srgbClr val="F1CEA5"/>
             </a:solidFill>
             <a:prstDash val="solid"/>
           </a:ln>
           <a:effectLst>
             <a:outerShdw sx="100000" sy="100000" kx="0" ky="0" algn="bl" rotWithShape="0" blurRad="127000" dist="25400" dir="5400000">
-              <a:srgbClr val="1E2B4A">
+              <a:srgbClr val="312E81">
                 <a:alpha val="8000"/>
               </a:srgbClr>
             </a:outerShdw>
@@ -11442,17 +11442,17 @@
             <a:avLst/>
           </a:prstGeom>
           <a:solidFill>
-            <a:srgbClr val="E0EDEF"/>
+            <a:srgbClr val="F9DCE9"/>
           </a:solidFill>
           <a:ln w="15875">
             <a:solidFill>
-              <a:srgbClr val="BAD6DB"/>
+              <a:srgbClr val="F2B1CE"/>
             </a:solidFill>
             <a:prstDash val="solid"/>
           </a:ln>
           <a:effectLst>
             <a:outerShdw sx="100000" sy="100000" kx="0" ky="0" algn="bl" rotWithShape="0" blurRad="127000" dist="25400" dir="5400000">
-              <a:srgbClr val="1E2B4A">
+              <a:srgbClr val="312E81">
                 <a:alpha val="8000"/>
               </a:srgbClr>
             </a:outerShdw>
@@ -11510,7 +11510,7 @@
             <a:r>
               <a:rPr lang="en-US" sz="950" dirty="0">
                 <a:solidFill>
-                  <a:srgbClr val="8A93A5"/>
+                  <a:srgbClr val="94A3B8"/>
                 </a:solidFill>
                 <a:latin typeface="Calibri" pitchFamily="34" charset="0"/>
                 <a:ea typeface="Calibri" pitchFamily="34" charset="-122"/>
@@ -11605,7 +11605,7 @@
             <a:r>
               <a:rPr lang="en-US" sz="2700" b="1" dirty="0">
                 <a:solidFill>
-                  <a:srgbClr val="1E2B4A"/>
+                  <a:srgbClr val="312E81"/>
                 </a:solidFill>
                 <a:latin typeface="Calibri" pitchFamily="34" charset="0"/>
                 <a:ea typeface="Calibri" pitchFamily="34" charset="-122"/>
@@ -11647,7 +11647,7 @@
             <a:r>
               <a:rPr lang="en-US" sz="1300" dirty="0">
                 <a:solidFill>
-                  <a:srgbClr val="4A5468"/>
+                  <a:srgbClr val="475569"/>
                 </a:solidFill>
                 <a:latin typeface="Calibri" pitchFamily="34" charset="0"/>
                 <a:ea typeface="Calibri" pitchFamily="34" charset="-122"/>
@@ -11674,17 +11674,17 @@
             <a:avLst/>
           </a:prstGeom>
           <a:solidFill>
-            <a:srgbClr val="F6ECDC"/>
+            <a:srgbClr val="D7EDF3"/>
           </a:solidFill>
           <a:ln w="15875">
             <a:solidFill>
-              <a:srgbClr val="ECD5B0"/>
+              <a:srgbClr val="A6D7E3"/>
             </a:solidFill>
             <a:prstDash val="solid"/>
           </a:ln>
           <a:effectLst>
             <a:outerShdw sx="100000" sy="100000" kx="0" ky="0" algn="bl" rotWithShape="0" blurRad="127000" dist="25400" dir="5400000">
-              <a:srgbClr val="1E2B4A">
+              <a:srgbClr val="312E81">
                 <a:alpha val="8000"/>
               </a:srgbClr>
             </a:outerShdw>
@@ -11745,7 +11745,7 @@
             <a:r>
               <a:rPr lang="en-US" sz="1450" b="1" dirty="0">
                 <a:solidFill>
-                  <a:srgbClr val="1D2433"/>
+                  <a:srgbClr val="0F172A"/>
                 </a:solidFill>
                 <a:latin typeface="Calibri" pitchFamily="34" charset="0"/>
                 <a:ea typeface="Calibri" pitchFamily="34" charset="-122"/>
@@ -11787,7 +11787,7 @@
             <a:r>
               <a:rPr lang="en-US" sz="1150" dirty="0">
                 <a:solidFill>
-                  <a:srgbClr val="4A5468"/>
+                  <a:srgbClr val="475569"/>
                 </a:solidFill>
                 <a:latin typeface="Calibri" pitchFamily="34" charset="0"/>
                 <a:ea typeface="Calibri" pitchFamily="34" charset="-122"/>
@@ -11814,17 +11814,17 @@
             <a:avLst/>
           </a:prstGeom>
           <a:solidFill>
-            <a:srgbClr val="E1E6EF"/>
+            <a:srgbClr val="E3E1FB"/>
           </a:solidFill>
           <a:ln w="15875">
             <a:solidFill>
-              <a:srgbClr val="BBC7DC"/>
+              <a:srgbClr val="C0BCF6"/>
             </a:solidFill>
             <a:prstDash val="solid"/>
           </a:ln>
           <a:effectLst>
             <a:outerShdw sx="100000" sy="100000" kx="0" ky="0" algn="bl" rotWithShape="0" blurRad="127000" dist="25400" dir="5400000">
-              <a:srgbClr val="1E2B4A">
+              <a:srgbClr val="312E81">
                 <a:alpha val="8000"/>
               </a:srgbClr>
             </a:outerShdw>
@@ -11885,7 +11885,7 @@
             <a:r>
               <a:rPr lang="en-US" sz="1450" b="1" dirty="0">
                 <a:solidFill>
-                  <a:srgbClr val="1D2433"/>
+                  <a:srgbClr val="0F172A"/>
                 </a:solidFill>
                 <a:latin typeface="Calibri" pitchFamily="34" charset="0"/>
                 <a:ea typeface="Calibri" pitchFamily="34" charset="-122"/>
@@ -11927,7 +11927,7 @@
             <a:r>
               <a:rPr lang="en-US" sz="1150" dirty="0">
                 <a:solidFill>
-                  <a:srgbClr val="4A5468"/>
+                  <a:srgbClr val="475569"/>
                 </a:solidFill>
                 <a:latin typeface="Calibri" pitchFamily="34" charset="0"/>
                 <a:ea typeface="Calibri" pitchFamily="34" charset="-122"/>
@@ -11954,17 +11954,17 @@
             <a:avLst/>
           </a:prstGeom>
           <a:solidFill>
-            <a:srgbClr val="E0EDEF"/>
+            <a:srgbClr val="F9DCE9"/>
           </a:solidFill>
           <a:ln w="15875">
             <a:solidFill>
-              <a:srgbClr val="BAD6DB"/>
+              <a:srgbClr val="F2B1CE"/>
             </a:solidFill>
             <a:prstDash val="solid"/>
           </a:ln>
           <a:effectLst>
             <a:outerShdw sx="100000" sy="100000" kx="0" ky="0" algn="bl" rotWithShape="0" blurRad="127000" dist="25400" dir="5400000">
-              <a:srgbClr val="1E2B4A">
+              <a:srgbClr val="312E81">
                 <a:alpha val="8000"/>
               </a:srgbClr>
             </a:outerShdw>
@@ -12025,7 +12025,7 @@
             <a:r>
               <a:rPr lang="en-US" sz="1450" b="1" dirty="0">
                 <a:solidFill>
-                  <a:srgbClr val="1D2433"/>
+                  <a:srgbClr val="0F172A"/>
                 </a:solidFill>
                 <a:latin typeface="Calibri" pitchFamily="34" charset="0"/>
                 <a:ea typeface="Calibri" pitchFamily="34" charset="-122"/>
@@ -12067,7 +12067,7 @@
             <a:r>
               <a:rPr lang="en-US" sz="1150" dirty="0">
                 <a:solidFill>
-                  <a:srgbClr val="4A5468"/>
+                  <a:srgbClr val="475569"/>
                 </a:solidFill>
                 <a:latin typeface="Calibri" pitchFamily="34" charset="0"/>
                 <a:ea typeface="Calibri" pitchFamily="34" charset="-122"/>
@@ -12106,7 +12106,7 @@
             <a:r>
               <a:rPr lang="en-US" sz="950" dirty="0">
                 <a:solidFill>
-                  <a:srgbClr val="8A93A5"/>
+                  <a:srgbClr val="94A3B8"/>
                 </a:solidFill>
                 <a:latin typeface="Calibri" pitchFamily="34" charset="0"/>
                 <a:ea typeface="Calibri" pitchFamily="34" charset="-122"/>
@@ -12201,7 +12201,7 @@
             <a:r>
               <a:rPr lang="en-US" sz="2700" b="1" dirty="0">
                 <a:solidFill>
-                  <a:srgbClr val="1E2B4A"/>
+                  <a:srgbClr val="312E81"/>
                 </a:solidFill>
                 <a:latin typeface="Calibri" pitchFamily="34" charset="0"/>
                 <a:ea typeface="Calibri" pitchFamily="34" charset="-122"/>
@@ -12228,17 +12228,17 @@
             <a:avLst/>
           </a:prstGeom>
           <a:solidFill>
-            <a:srgbClr val="F9E8DD"/>
+            <a:srgbClr val="F9E9D7"/>
           </a:solidFill>
           <a:ln w="15875">
             <a:solidFill>
-              <a:srgbClr val="F1CBB3"/>
+              <a:srgbClr val="F1CEA5"/>
             </a:solidFill>
             <a:prstDash val="solid"/>
           </a:ln>
           <a:effectLst>
             <a:outerShdw sx="100000" sy="100000" kx="0" ky="0" algn="bl" rotWithShape="0" blurRad="127000" dist="25400" dir="5400000">
-              <a:srgbClr val="1E2B4A">
+              <a:srgbClr val="312E81">
                 <a:alpha val="8000"/>
               </a:srgbClr>
             </a:outerShdw>
@@ -12296,7 +12296,7 @@
             <a:r>
               <a:rPr lang="en-US" sz="1700" b="1" dirty="0">
                 <a:solidFill>
-                  <a:srgbClr val="1D2433"/>
+                  <a:srgbClr val="0F172A"/>
                 </a:solidFill>
                 <a:latin typeface="Calibri" pitchFamily="34" charset="0"/>
                 <a:ea typeface="Calibri" pitchFamily="34" charset="-122"/>
@@ -12335,7 +12335,7 @@
             <a:r>
               <a:rPr lang="en-US" sz="1350" b="1" dirty="0">
                 <a:solidFill>
-                  <a:srgbClr val="D96F2B"/>
+                  <a:srgbClr val="D97706"/>
                 </a:solidFill>
                 <a:latin typeface="Calibri" pitchFamily="34" charset="0"/>
                 <a:ea typeface="Calibri" pitchFamily="34" charset="-122"/>
@@ -12377,7 +12377,7 @@
             <a:r>
               <a:rPr lang="en-US" sz="1200" dirty="0">
                 <a:solidFill>
-                  <a:srgbClr val="4A5468"/>
+                  <a:srgbClr val="475569"/>
                 </a:solidFill>
                 <a:latin typeface="Calibri" pitchFamily="34" charset="0"/>
                 <a:ea typeface="Calibri" pitchFamily="34" charset="-122"/>
@@ -12416,7 +12416,7 @@
             <a:r>
               <a:rPr lang="en-US" sz="1350" b="1" dirty="0">
                 <a:solidFill>
-                  <a:srgbClr val="D96F2B"/>
+                  <a:srgbClr val="D97706"/>
                 </a:solidFill>
                 <a:latin typeface="Calibri" pitchFamily="34" charset="0"/>
                 <a:ea typeface="Calibri" pitchFamily="34" charset="-122"/>
@@ -12458,7 +12458,7 @@
             <a:r>
               <a:rPr lang="en-US" sz="1200" dirty="0">
                 <a:solidFill>
-                  <a:srgbClr val="4A5468"/>
+                  <a:srgbClr val="475569"/>
                 </a:solidFill>
                 <a:latin typeface="Calibri" pitchFamily="34" charset="0"/>
                 <a:ea typeface="Calibri" pitchFamily="34" charset="-122"/>
@@ -12485,17 +12485,17 @@
             <a:avLst/>
           </a:prstGeom>
           <a:solidFill>
-            <a:srgbClr val="E0EDEF"/>
+            <a:srgbClr val="F9DCE9"/>
           </a:solidFill>
           <a:ln w="15875">
             <a:solidFill>
-              <a:srgbClr val="BAD6DB"/>
+              <a:srgbClr val="F2B1CE"/>
             </a:solidFill>
             <a:prstDash val="solid"/>
           </a:ln>
           <a:effectLst>
             <a:outerShdw sx="100000" sy="100000" kx="0" ky="0" algn="bl" rotWithShape="0" blurRad="127000" dist="25400" dir="5400000">
-              <a:srgbClr val="1E2B4A">
+              <a:srgbClr val="312E81">
                 <a:alpha val="8000"/>
               </a:srgbClr>
             </a:outerShdw>
@@ -12553,7 +12553,7 @@
             <a:r>
               <a:rPr lang="en-US" sz="1700" b="1" dirty="0">
                 <a:solidFill>
-                  <a:srgbClr val="1D2433"/>
+                  <a:srgbClr val="0F172A"/>
                 </a:solidFill>
                 <a:latin typeface="Calibri" pitchFamily="34" charset="0"/>
                 <a:ea typeface="Calibri" pitchFamily="34" charset="-122"/>
@@ -12580,7 +12580,7 @@
             <a:avLst/>
           </a:prstGeom>
           <a:solidFill>
-            <a:srgbClr val="3E8C9A"/>
+            <a:srgbClr val="DB2777"/>
           </a:solidFill>
           <a:ln/>
         </p:spPr>
@@ -12654,7 +12654,7 @@
             <a:r>
               <a:rPr lang="en-US" sz="1200" dirty="0">
                 <a:solidFill>
-                  <a:srgbClr val="4A5468"/>
+                  <a:srgbClr val="475569"/>
                 </a:solidFill>
                 <a:latin typeface="Calibri" pitchFamily="34" charset="0"/>
                 <a:ea typeface="Calibri" pitchFamily="34" charset="-122"/>
@@ -12681,7 +12681,7 @@
             <a:avLst/>
           </a:prstGeom>
           <a:solidFill>
-            <a:srgbClr val="3E8C9A"/>
+            <a:srgbClr val="DB2777"/>
           </a:solidFill>
           <a:ln/>
         </p:spPr>
@@ -12755,7 +12755,7 @@
             <a:r>
               <a:rPr lang="en-US" sz="1200" dirty="0">
                 <a:solidFill>
-                  <a:srgbClr val="4A5468"/>
+                  <a:srgbClr val="475569"/>
                 </a:solidFill>
                 <a:latin typeface="Calibri" pitchFamily="34" charset="0"/>
                 <a:ea typeface="Calibri" pitchFamily="34" charset="-122"/>
@@ -12782,7 +12782,7 @@
             <a:avLst/>
           </a:prstGeom>
           <a:solidFill>
-            <a:srgbClr val="3E8C9A"/>
+            <a:srgbClr val="DB2777"/>
           </a:solidFill>
           <a:ln/>
         </p:spPr>
@@ -12856,7 +12856,7 @@
             <a:r>
               <a:rPr lang="en-US" sz="1200" dirty="0">
                 <a:solidFill>
-                  <a:srgbClr val="4A5468"/>
+                  <a:srgbClr val="475569"/>
                 </a:solidFill>
                 <a:latin typeface="Calibri" pitchFamily="34" charset="0"/>
                 <a:ea typeface="Calibri" pitchFamily="34" charset="-122"/>
@@ -12895,7 +12895,7 @@
             <a:r>
               <a:rPr lang="en-US" sz="950" dirty="0">
                 <a:solidFill>
-                  <a:srgbClr val="8A93A5"/>
+                  <a:srgbClr val="94A3B8"/>
                 </a:solidFill>
                 <a:latin typeface="Calibri" pitchFamily="34" charset="0"/>
                 <a:ea typeface="Calibri" pitchFamily="34" charset="-122"/>
@@ -12990,7 +12990,7 @@
             <a:r>
               <a:rPr lang="en-US" sz="2700" b="1" dirty="0">
                 <a:solidFill>
-                  <a:srgbClr val="1E2B4A"/>
+                  <a:srgbClr val="312E81"/>
                 </a:solidFill>
                 <a:latin typeface="Calibri" pitchFamily="34" charset="0"/>
                 <a:ea typeface="Calibri" pitchFamily="34" charset="-122"/>
@@ -13019,7 +13019,7 @@
             </a:avLst>
           </a:prstGeom>
           <a:solidFill>
-            <a:srgbClr val="1E2B4A"/>
+            <a:srgbClr val="312E81"/>
           </a:solidFill>
           <a:ln/>
         </p:spPr>
@@ -13093,7 +13093,7 @@
             <a:r>
               <a:rPr lang="en-US" sz="3600" b="1" dirty="0">
                 <a:solidFill>
-                  <a:srgbClr val="D96F2B"/>
+                  <a:srgbClr val="D97706"/>
                 </a:solidFill>
                 <a:latin typeface="Calibri" pitchFamily="34" charset="0"/>
                 <a:ea typeface="Calibri" pitchFamily="34" charset="-122"/>
@@ -13132,7 +13132,7 @@
             <a:r>
               <a:rPr lang="en-US" sz="1200" b="1" dirty="0">
                 <a:solidFill>
-                  <a:srgbClr val="1D2433"/>
+                  <a:srgbClr val="0F172A"/>
                 </a:solidFill>
                 <a:latin typeface="Calibri" pitchFamily="34" charset="0"/>
                 <a:ea typeface="Calibri" pitchFamily="34" charset="-122"/>
@@ -13174,7 +13174,7 @@
             <a:r>
               <a:rPr lang="en-US" sz="1150" dirty="0">
                 <a:solidFill>
-                  <a:srgbClr val="4A5468"/>
+                  <a:srgbClr val="475569"/>
                 </a:solidFill>
                 <a:latin typeface="Calibri" pitchFamily="34" charset="0"/>
                 <a:ea typeface="Calibri" pitchFamily="34" charset="-122"/>
@@ -13213,7 +13213,7 @@
             <a:r>
               <a:rPr lang="en-US" sz="3600" b="1" dirty="0">
                 <a:solidFill>
-                  <a:srgbClr val="41639E"/>
+                  <a:srgbClr val="4F46E5"/>
                 </a:solidFill>
                 <a:latin typeface="Calibri" pitchFamily="34" charset="0"/>
                 <a:ea typeface="Calibri" pitchFamily="34" charset="-122"/>
@@ -13252,7 +13252,7 @@
             <a:r>
               <a:rPr lang="en-US" sz="1200" b="1" dirty="0">
                 <a:solidFill>
-                  <a:srgbClr val="1D2433"/>
+                  <a:srgbClr val="0F172A"/>
                 </a:solidFill>
                 <a:latin typeface="Calibri" pitchFamily="34" charset="0"/>
                 <a:ea typeface="Calibri" pitchFamily="34" charset="-122"/>
@@ -13294,7 +13294,7 @@
             <a:r>
               <a:rPr lang="en-US" sz="1150" dirty="0">
                 <a:solidFill>
-                  <a:srgbClr val="4A5468"/>
+                  <a:srgbClr val="475569"/>
                 </a:solidFill>
                 <a:latin typeface="Calibri" pitchFamily="34" charset="0"/>
                 <a:ea typeface="Calibri" pitchFamily="34" charset="-122"/>
@@ -13333,7 +13333,7 @@
             <a:r>
               <a:rPr lang="en-US" sz="3600" b="1" dirty="0">
                 <a:solidFill>
-                  <a:srgbClr val="3E8C9A"/>
+                  <a:srgbClr val="DB2777"/>
                 </a:solidFill>
                 <a:latin typeface="Calibri" pitchFamily="34" charset="0"/>
                 <a:ea typeface="Calibri" pitchFamily="34" charset="-122"/>
@@ -13372,7 +13372,7 @@
             <a:r>
               <a:rPr lang="en-US" sz="1200" b="1" dirty="0">
                 <a:solidFill>
-                  <a:srgbClr val="1D2433"/>
+                  <a:srgbClr val="0F172A"/>
                 </a:solidFill>
                 <a:latin typeface="Calibri" pitchFamily="34" charset="0"/>
                 <a:ea typeface="Calibri" pitchFamily="34" charset="-122"/>
@@ -13414,7 +13414,7 @@
             <a:r>
               <a:rPr lang="en-US" sz="1150" dirty="0">
                 <a:solidFill>
-                  <a:srgbClr val="4A5468"/>
+                  <a:srgbClr val="475569"/>
                 </a:solidFill>
                 <a:latin typeface="Calibri" pitchFamily="34" charset="0"/>
                 <a:ea typeface="Calibri" pitchFamily="34" charset="-122"/>
@@ -13453,7 +13453,7 @@
             <a:r>
               <a:rPr lang="en-US" sz="3600" b="1" dirty="0">
                 <a:solidFill>
-                  <a:srgbClr val="C98A24"/>
+                  <a:srgbClr val="0891B2"/>
                 </a:solidFill>
                 <a:latin typeface="Calibri" pitchFamily="34" charset="0"/>
                 <a:ea typeface="Calibri" pitchFamily="34" charset="-122"/>
@@ -13492,7 +13492,7 @@
             <a:r>
               <a:rPr lang="en-US" sz="1200" b="1" dirty="0">
                 <a:solidFill>
-                  <a:srgbClr val="1D2433"/>
+                  <a:srgbClr val="0F172A"/>
                 </a:solidFill>
                 <a:latin typeface="Calibri" pitchFamily="34" charset="0"/>
                 <a:ea typeface="Calibri" pitchFamily="34" charset="-122"/>
@@ -13534,7 +13534,7 @@
             <a:r>
               <a:rPr lang="en-US" sz="1150" dirty="0">
                 <a:solidFill>
-                  <a:srgbClr val="4A5468"/>
+                  <a:srgbClr val="475569"/>
                 </a:solidFill>
                 <a:latin typeface="Calibri" pitchFamily="34" charset="0"/>
                 <a:ea typeface="Calibri" pitchFamily="34" charset="-122"/>
@@ -13573,7 +13573,7 @@
             <a:r>
               <a:rPr lang="en-US" sz="950" dirty="0">
                 <a:solidFill>
-                  <a:srgbClr val="8A93A5"/>
+                  <a:srgbClr val="94A3B8"/>
                 </a:solidFill>
                 <a:latin typeface="Calibri" pitchFamily="34" charset="0"/>
                 <a:ea typeface="Calibri" pitchFamily="34" charset="-122"/>
@@ -13668,7 +13668,7 @@
             <a:r>
               <a:rPr lang="en-US" sz="2700" b="1" dirty="0">
                 <a:solidFill>
-                  <a:srgbClr val="1E2B4A"/>
+                  <a:srgbClr val="312E81"/>
                 </a:solidFill>
                 <a:latin typeface="Calibri" pitchFamily="34" charset="0"/>
                 <a:ea typeface="Calibri" pitchFamily="34" charset="-122"/>
@@ -13695,17 +13695,17 @@
             <a:avLst/>
           </a:prstGeom>
           <a:solidFill>
-            <a:srgbClr val="E1E6EF"/>
+            <a:srgbClr val="E3E1FB"/>
           </a:solidFill>
           <a:ln w="15875">
             <a:solidFill>
-              <a:srgbClr val="BBC7DC"/>
+              <a:srgbClr val="C0BCF6"/>
             </a:solidFill>
             <a:prstDash val="solid"/>
           </a:ln>
           <a:effectLst>
             <a:outerShdw sx="100000" sy="100000" kx="0" ky="0" algn="bl" rotWithShape="0" blurRad="127000" dist="25400" dir="5400000">
-              <a:srgbClr val="1E2B4A">
+              <a:srgbClr val="312E81">
                 <a:alpha val="8000"/>
               </a:srgbClr>
             </a:outerShdw>
@@ -13763,7 +13763,7 @@
             <a:r>
               <a:rPr lang="en-US" sz="3000" b="1" dirty="0">
                 <a:solidFill>
-                  <a:srgbClr val="E3E7EE"/>
+                  <a:srgbClr val="E2E8F0"/>
                 </a:solidFill>
                 <a:latin typeface="Calibri" pitchFamily="34" charset="0"/>
                 <a:ea typeface="Calibri" pitchFamily="34" charset="-122"/>
@@ -13802,7 +13802,7 @@
             <a:r>
               <a:rPr lang="en-US" sz="1450" b="1" dirty="0">
                 <a:solidFill>
-                  <a:srgbClr val="1D2433"/>
+                  <a:srgbClr val="0F172A"/>
                 </a:solidFill>
                 <a:latin typeface="Calibri" pitchFamily="34" charset="0"/>
                 <a:ea typeface="Calibri" pitchFamily="34" charset="-122"/>
@@ -13841,7 +13841,7 @@
             <a:r>
               <a:rPr lang="en-US" sz="1100" dirty="0">
                 <a:solidFill>
-                  <a:srgbClr val="4A5468"/>
+                  <a:srgbClr val="475569"/>
                 </a:solidFill>
                 <a:latin typeface="Calibri" pitchFamily="34" charset="0"/>
                 <a:ea typeface="Calibri" pitchFamily="34" charset="-122"/>
@@ -13868,17 +13868,17 @@
             <a:avLst/>
           </a:prstGeom>
           <a:solidFill>
-            <a:srgbClr val="F9E8DD"/>
+            <a:srgbClr val="F9E9D7"/>
           </a:solidFill>
           <a:ln w="15875">
             <a:solidFill>
-              <a:srgbClr val="F1CBB3"/>
+              <a:srgbClr val="F1CEA5"/>
             </a:solidFill>
             <a:prstDash val="solid"/>
           </a:ln>
           <a:effectLst>
             <a:outerShdw sx="100000" sy="100000" kx="0" ky="0" algn="bl" rotWithShape="0" blurRad="127000" dist="25400" dir="5400000">
-              <a:srgbClr val="1E2B4A">
+              <a:srgbClr val="312E81">
                 <a:alpha val="8000"/>
               </a:srgbClr>
             </a:outerShdw>
@@ -13936,7 +13936,7 @@
             <a:r>
               <a:rPr lang="en-US" sz="3000" b="1" dirty="0">
                 <a:solidFill>
-                  <a:srgbClr val="E3E7EE"/>
+                  <a:srgbClr val="E2E8F0"/>
                 </a:solidFill>
                 <a:latin typeface="Calibri" pitchFamily="34" charset="0"/>
                 <a:ea typeface="Calibri" pitchFamily="34" charset="-122"/>
@@ -13975,7 +13975,7 @@
             <a:r>
               <a:rPr lang="en-US" sz="1450" b="1" dirty="0">
                 <a:solidFill>
-                  <a:srgbClr val="1D2433"/>
+                  <a:srgbClr val="0F172A"/>
                 </a:solidFill>
                 <a:latin typeface="Calibri" pitchFamily="34" charset="0"/>
                 <a:ea typeface="Calibri" pitchFamily="34" charset="-122"/>
@@ -14014,7 +14014,7 @@
             <a:r>
               <a:rPr lang="en-US" sz="1100" dirty="0">
                 <a:solidFill>
-                  <a:srgbClr val="4A5468"/>
+                  <a:srgbClr val="475569"/>
                 </a:solidFill>
                 <a:latin typeface="Calibri" pitchFamily="34" charset="0"/>
                 <a:ea typeface="Calibri" pitchFamily="34" charset="-122"/>
@@ -14041,17 +14041,17 @@
             <a:avLst/>
           </a:prstGeom>
           <a:solidFill>
-            <a:srgbClr val="E0EDEF"/>
+            <a:srgbClr val="F9DCE9"/>
           </a:solidFill>
           <a:ln w="15875">
             <a:solidFill>
-              <a:srgbClr val="BAD6DB"/>
+              <a:srgbClr val="F2B1CE"/>
             </a:solidFill>
             <a:prstDash val="solid"/>
           </a:ln>
           <a:effectLst>
             <a:outerShdw sx="100000" sy="100000" kx="0" ky="0" algn="bl" rotWithShape="0" blurRad="127000" dist="25400" dir="5400000">
-              <a:srgbClr val="1E2B4A">
+              <a:srgbClr val="312E81">
                 <a:alpha val="8000"/>
               </a:srgbClr>
             </a:outerShdw>
@@ -14109,7 +14109,7 @@
             <a:r>
               <a:rPr lang="en-US" sz="3000" b="1" dirty="0">
                 <a:solidFill>
-                  <a:srgbClr val="E3E7EE"/>
+                  <a:srgbClr val="E2E8F0"/>
                 </a:solidFill>
                 <a:latin typeface="Calibri" pitchFamily="34" charset="0"/>
                 <a:ea typeface="Calibri" pitchFamily="34" charset="-122"/>
@@ -14148,7 +14148,7 @@
             <a:r>
               <a:rPr lang="en-US" sz="1450" b="1" dirty="0">
                 <a:solidFill>
-                  <a:srgbClr val="1D2433"/>
+                  <a:srgbClr val="0F172A"/>
                 </a:solidFill>
                 <a:latin typeface="Calibri" pitchFamily="34" charset="0"/>
                 <a:ea typeface="Calibri" pitchFamily="34" charset="-122"/>
@@ -14187,7 +14187,7 @@
             <a:r>
               <a:rPr lang="en-US" sz="1100" dirty="0">
                 <a:solidFill>
-                  <a:srgbClr val="4A5468"/>
+                  <a:srgbClr val="475569"/>
                 </a:solidFill>
                 <a:latin typeface="Calibri" pitchFamily="34" charset="0"/>
                 <a:ea typeface="Calibri" pitchFamily="34" charset="-122"/>
@@ -14214,17 +14214,17 @@
             <a:avLst/>
           </a:prstGeom>
           <a:solidFill>
-            <a:srgbClr val="F6ECDC"/>
+            <a:srgbClr val="D7EDF3"/>
           </a:solidFill>
           <a:ln w="15875">
             <a:solidFill>
-              <a:srgbClr val="ECD5B0"/>
+              <a:srgbClr val="A6D7E3"/>
             </a:solidFill>
             <a:prstDash val="solid"/>
           </a:ln>
           <a:effectLst>
             <a:outerShdw sx="100000" sy="100000" kx="0" ky="0" algn="bl" rotWithShape="0" blurRad="127000" dist="25400" dir="5400000">
-              <a:srgbClr val="1E2B4A">
+              <a:srgbClr val="312E81">
                 <a:alpha val="8000"/>
               </a:srgbClr>
             </a:outerShdw>
@@ -14282,7 +14282,7 @@
             <a:r>
               <a:rPr lang="en-US" sz="3000" b="1" dirty="0">
                 <a:solidFill>
-                  <a:srgbClr val="E3E7EE"/>
+                  <a:srgbClr val="E2E8F0"/>
                 </a:solidFill>
                 <a:latin typeface="Calibri" pitchFamily="34" charset="0"/>
                 <a:ea typeface="Calibri" pitchFamily="34" charset="-122"/>
@@ -14321,7 +14321,7 @@
             <a:r>
               <a:rPr lang="en-US" sz="1450" b="1" dirty="0">
                 <a:solidFill>
-                  <a:srgbClr val="1D2433"/>
+                  <a:srgbClr val="0F172A"/>
                 </a:solidFill>
                 <a:latin typeface="Calibri" pitchFamily="34" charset="0"/>
                 <a:ea typeface="Calibri" pitchFamily="34" charset="-122"/>
@@ -14360,7 +14360,7 @@
             <a:r>
               <a:rPr lang="en-US" sz="1100" dirty="0">
                 <a:solidFill>
-                  <a:srgbClr val="4A5468"/>
+                  <a:srgbClr val="475569"/>
                 </a:solidFill>
                 <a:latin typeface="Calibri" pitchFamily="34" charset="0"/>
                 <a:ea typeface="Calibri" pitchFamily="34" charset="-122"/>
@@ -14387,17 +14387,17 @@
             <a:avLst/>
           </a:prstGeom>
           <a:solidFill>
-            <a:srgbClr val="E1E6EF"/>
+            <a:srgbClr val="E3E1FB"/>
           </a:solidFill>
           <a:ln w="15875">
             <a:solidFill>
-              <a:srgbClr val="BBC7DC"/>
+              <a:srgbClr val="C0BCF6"/>
             </a:solidFill>
             <a:prstDash val="solid"/>
           </a:ln>
           <a:effectLst>
             <a:outerShdw sx="100000" sy="100000" kx="0" ky="0" algn="bl" rotWithShape="0" blurRad="127000" dist="25400" dir="5400000">
-              <a:srgbClr val="1E2B4A">
+              <a:srgbClr val="312E81">
                 <a:alpha val="8000"/>
               </a:srgbClr>
             </a:outerShdw>
@@ -14455,7 +14455,7 @@
             <a:r>
               <a:rPr lang="en-US" sz="3000" b="1" dirty="0">
                 <a:solidFill>
-                  <a:srgbClr val="E3E7EE"/>
+                  <a:srgbClr val="E2E8F0"/>
                 </a:solidFill>
                 <a:latin typeface="Calibri" pitchFamily="34" charset="0"/>
                 <a:ea typeface="Calibri" pitchFamily="34" charset="-122"/>
@@ -14494,7 +14494,7 @@
             <a:r>
               <a:rPr lang="en-US" sz="1450" b="1" dirty="0">
                 <a:solidFill>
-                  <a:srgbClr val="1D2433"/>
+                  <a:srgbClr val="0F172A"/>
                 </a:solidFill>
                 <a:latin typeface="Calibri" pitchFamily="34" charset="0"/>
                 <a:ea typeface="Calibri" pitchFamily="34" charset="-122"/>
@@ -14533,7 +14533,7 @@
             <a:r>
               <a:rPr lang="en-US" sz="1100" dirty="0">
                 <a:solidFill>
-                  <a:srgbClr val="4A5468"/>
+                  <a:srgbClr val="475569"/>
                 </a:solidFill>
                 <a:latin typeface="Calibri" pitchFamily="34" charset="0"/>
                 <a:ea typeface="Calibri" pitchFamily="34" charset="-122"/>
@@ -14560,17 +14560,17 @@
             <a:avLst/>
           </a:prstGeom>
           <a:solidFill>
-            <a:srgbClr val="F9E8DD"/>
+            <a:srgbClr val="F9E9D7"/>
           </a:solidFill>
           <a:ln w="15875">
             <a:solidFill>
-              <a:srgbClr val="F1CBB3"/>
+              <a:srgbClr val="F1CEA5"/>
             </a:solidFill>
             <a:prstDash val="solid"/>
           </a:ln>
           <a:effectLst>
             <a:outerShdw sx="100000" sy="100000" kx="0" ky="0" algn="bl" rotWithShape="0" blurRad="127000" dist="25400" dir="5400000">
-              <a:srgbClr val="1E2B4A">
+              <a:srgbClr val="312E81">
                 <a:alpha val="8000"/>
               </a:srgbClr>
             </a:outerShdw>
@@ -14628,7 +14628,7 @@
             <a:r>
               <a:rPr lang="en-US" sz="3000" b="1" dirty="0">
                 <a:solidFill>
-                  <a:srgbClr val="E3E7EE"/>
+                  <a:srgbClr val="E2E8F0"/>
                 </a:solidFill>
                 <a:latin typeface="Calibri" pitchFamily="34" charset="0"/>
                 <a:ea typeface="Calibri" pitchFamily="34" charset="-122"/>
@@ -14667,7 +14667,7 @@
             <a:r>
               <a:rPr lang="en-US" sz="1450" b="1" dirty="0">
                 <a:solidFill>
-                  <a:srgbClr val="1D2433"/>
+                  <a:srgbClr val="0F172A"/>
                 </a:solidFill>
                 <a:latin typeface="Calibri" pitchFamily="34" charset="0"/>
                 <a:ea typeface="Calibri" pitchFamily="34" charset="-122"/>
@@ -14706,7 +14706,7 @@
             <a:r>
               <a:rPr lang="en-US" sz="1100" dirty="0">
                 <a:solidFill>
-                  <a:srgbClr val="4A5468"/>
+                  <a:srgbClr val="475569"/>
                 </a:solidFill>
                 <a:latin typeface="Calibri" pitchFamily="34" charset="0"/>
                 <a:ea typeface="Calibri" pitchFamily="34" charset="-122"/>
@@ -14745,7 +14745,7 @@
             <a:r>
               <a:rPr lang="en-US" sz="950" dirty="0">
                 <a:solidFill>
-                  <a:srgbClr val="8A93A5"/>
+                  <a:srgbClr val="94A3B8"/>
                 </a:solidFill>
                 <a:latin typeface="Calibri" pitchFamily="34" charset="0"/>
                 <a:ea typeface="Calibri" pitchFamily="34" charset="-122"/>
@@ -14840,7 +14840,7 @@
             <a:r>
               <a:rPr lang="en-US" sz="2700" b="1" dirty="0">
                 <a:solidFill>
-                  <a:srgbClr val="1E2B4A"/>
+                  <a:srgbClr val="312E81"/>
                 </a:solidFill>
                 <a:latin typeface="Calibri" pitchFamily="34" charset="0"/>
                 <a:ea typeface="Calibri" pitchFamily="34" charset="-122"/>
@@ -14882,7 +14882,7 @@
             <a:r>
               <a:rPr lang="en-US" sz="1300" dirty="0">
                 <a:solidFill>
-                  <a:srgbClr val="4A5468"/>
+                  <a:srgbClr val="475569"/>
                 </a:solidFill>
                 <a:latin typeface="Calibri" pitchFamily="34" charset="0"/>
                 <a:ea typeface="Calibri" pitchFamily="34" charset="-122"/>
@@ -14909,17 +14909,17 @@
             <a:avLst/>
           </a:prstGeom>
           <a:solidFill>
-            <a:srgbClr val="F6ECDC"/>
+            <a:srgbClr val="D7EDF3"/>
           </a:solidFill>
           <a:ln w="15875">
             <a:solidFill>
-              <a:srgbClr val="ECD5B0"/>
+              <a:srgbClr val="A6D7E3"/>
             </a:solidFill>
             <a:prstDash val="solid"/>
           </a:ln>
           <a:effectLst>
             <a:outerShdw sx="100000" sy="100000" kx="0" ky="0" algn="bl" rotWithShape="0" blurRad="127000" dist="25400" dir="5400000">
-              <a:srgbClr val="1E2B4A">
+              <a:srgbClr val="312E81">
                 <a:alpha val="8000"/>
               </a:srgbClr>
             </a:outerShdw>
@@ -14980,7 +14980,7 @@
             <a:r>
               <a:rPr lang="en-US" sz="1450" b="1" dirty="0">
                 <a:solidFill>
-                  <a:srgbClr val="1D2433"/>
+                  <a:srgbClr val="0F172A"/>
                 </a:solidFill>
                 <a:latin typeface="Calibri" pitchFamily="34" charset="0"/>
                 <a:ea typeface="Calibri" pitchFamily="34" charset="-122"/>
@@ -15022,7 +15022,7 @@
             <a:r>
               <a:rPr lang="en-US" sz="1200" dirty="0">
                 <a:solidFill>
-                  <a:srgbClr val="4A5468"/>
+                  <a:srgbClr val="475569"/>
                 </a:solidFill>
                 <a:latin typeface="Calibri" pitchFamily="34" charset="0"/>
                 <a:ea typeface="Calibri" pitchFamily="34" charset="-122"/>
@@ -15049,17 +15049,17 @@
             <a:avLst/>
           </a:prstGeom>
           <a:solidFill>
-            <a:srgbClr val="E1E6EF"/>
+            <a:srgbClr val="E3E1FB"/>
           </a:solidFill>
           <a:ln w="15875">
             <a:solidFill>
-              <a:srgbClr val="BBC7DC"/>
+              <a:srgbClr val="C0BCF6"/>
             </a:solidFill>
             <a:prstDash val="solid"/>
           </a:ln>
           <a:effectLst>
             <a:outerShdw sx="100000" sy="100000" kx="0" ky="0" algn="bl" rotWithShape="0" blurRad="127000" dist="25400" dir="5400000">
-              <a:srgbClr val="1E2B4A">
+              <a:srgbClr val="312E81">
                 <a:alpha val="8000"/>
               </a:srgbClr>
             </a:outerShdw>
@@ -15120,7 +15120,7 @@
             <a:r>
               <a:rPr lang="en-US" sz="1450" b="1" dirty="0">
                 <a:solidFill>
-                  <a:srgbClr val="1D2433"/>
+                  <a:srgbClr val="0F172A"/>
                 </a:solidFill>
                 <a:latin typeface="Calibri" pitchFamily="34" charset="0"/>
                 <a:ea typeface="Calibri" pitchFamily="34" charset="-122"/>
@@ -15162,7 +15162,7 @@
             <a:r>
               <a:rPr lang="en-US" sz="1200" dirty="0">
                 <a:solidFill>
-                  <a:srgbClr val="4A5468"/>
+                  <a:srgbClr val="475569"/>
                 </a:solidFill>
                 <a:latin typeface="Calibri" pitchFamily="34" charset="0"/>
                 <a:ea typeface="Calibri" pitchFamily="34" charset="-122"/>
@@ -15189,17 +15189,17 @@
             <a:avLst/>
           </a:prstGeom>
           <a:solidFill>
-            <a:srgbClr val="E0EDEF"/>
+            <a:srgbClr val="F9DCE9"/>
           </a:solidFill>
           <a:ln w="15875">
             <a:solidFill>
-              <a:srgbClr val="BAD6DB"/>
+              <a:srgbClr val="F2B1CE"/>
             </a:solidFill>
             <a:prstDash val="solid"/>
           </a:ln>
           <a:effectLst>
             <a:outerShdw sx="100000" sy="100000" kx="0" ky="0" algn="bl" rotWithShape="0" blurRad="127000" dist="25400" dir="5400000">
-              <a:srgbClr val="1E2B4A">
+              <a:srgbClr val="312E81">
                 <a:alpha val="8000"/>
               </a:srgbClr>
             </a:outerShdw>
@@ -15260,7 +15260,7 @@
             <a:r>
               <a:rPr lang="en-US" sz="1450" b="1" dirty="0">
                 <a:solidFill>
-                  <a:srgbClr val="1D2433"/>
+                  <a:srgbClr val="0F172A"/>
                 </a:solidFill>
                 <a:latin typeface="Calibri" pitchFamily="34" charset="0"/>
                 <a:ea typeface="Calibri" pitchFamily="34" charset="-122"/>
@@ -15302,7 +15302,7 @@
             <a:r>
               <a:rPr lang="en-US" sz="1200" dirty="0">
                 <a:solidFill>
-                  <a:srgbClr val="4A5468"/>
+                  <a:srgbClr val="475569"/>
                 </a:solidFill>
                 <a:latin typeface="Calibri" pitchFamily="34" charset="0"/>
                 <a:ea typeface="Calibri" pitchFamily="34" charset="-122"/>
@@ -15341,7 +15341,7 @@
             <a:r>
               <a:rPr lang="en-US" sz="950" dirty="0">
                 <a:solidFill>
-                  <a:srgbClr val="8A93A5"/>
+                  <a:srgbClr val="94A3B8"/>
                 </a:solidFill>
                 <a:latin typeface="Calibri" pitchFamily="34" charset="0"/>
                 <a:ea typeface="Calibri" pitchFamily="34" charset="-122"/>
@@ -15391,7 +15391,7 @@
     <p:bg>
       <p:bgPr>
         <a:solidFill>
-          <a:srgbClr val="16213D"/>
+          <a:srgbClr val="1E1B4B"/>
         </a:solidFill>
       </p:bgPr>
     </p:bg>
@@ -15424,7 +15424,7 @@
             <a:avLst/>
           </a:prstGeom>
           <a:solidFill>
-            <a:srgbClr val="24365E"/>
+            <a:srgbClr val="312E81"/>
           </a:solidFill>
           <a:ln/>
         </p:spPr>
@@ -15444,7 +15444,7 @@
             <a:avLst/>
           </a:prstGeom>
           <a:solidFill>
-            <a:srgbClr val="24365E"/>
+            <a:srgbClr val="312E81"/>
           </a:solidFill>
           <a:ln/>
         </p:spPr>
@@ -15515,7 +15515,7 @@
             <a:r>
               <a:rPr lang="en-US" sz="1400" dirty="0">
                 <a:solidFill>
-                  <a:srgbClr val="D96F2B"/>
+                  <a:srgbClr val="D97706"/>
                 </a:solidFill>
                 <a:latin typeface="Calibri" pitchFamily="34" charset="0"/>
                 <a:ea typeface="Calibri" pitchFamily="34" charset="-122"/>
@@ -15554,7 +15554,7 @@
             <a:r>
               <a:rPr lang="en-US" sz="1250" dirty="0">
                 <a:solidFill>
-                  <a:srgbClr val="8FA6CC"/>
+                  <a:srgbClr val="A5B4FC"/>
                 </a:solidFill>
                 <a:latin typeface="Calibri" pitchFamily="34" charset="0"/>
                 <a:ea typeface="Calibri" pitchFamily="34" charset="-122"/>
@@ -15625,7 +15625,7 @@
             <a:r>
               <a:rPr lang="en-US" sz="2700" b="1" dirty="0">
                 <a:solidFill>
-                  <a:srgbClr val="1E2B4A"/>
+                  <a:srgbClr val="312E81"/>
                 </a:solidFill>
                 <a:latin typeface="Calibri" pitchFamily="34" charset="0"/>
                 <a:ea typeface="Calibri" pitchFamily="34" charset="-122"/>
@@ -15652,17 +15652,17 @@
             <a:avLst/>
           </a:prstGeom>
           <a:solidFill>
-            <a:srgbClr val="E1E6EF"/>
+            <a:srgbClr val="E3E1FB"/>
           </a:solidFill>
           <a:ln w="15875">
             <a:solidFill>
-              <a:srgbClr val="BBC7DC"/>
+              <a:srgbClr val="C0BCF6"/>
             </a:solidFill>
             <a:prstDash val="solid"/>
           </a:ln>
           <a:effectLst>
             <a:outerShdw sx="100000" sy="100000" kx="0" ky="0" algn="bl" rotWithShape="0" blurRad="127000" dist="25400" dir="5400000">
-              <a:srgbClr val="1E2B4A">
+              <a:srgbClr val="312E81">
                 <a:alpha val="8000"/>
               </a:srgbClr>
             </a:outerShdw>
@@ -15723,7 +15723,7 @@
             <a:r>
               <a:rPr lang="en-US" sz="1600" b="1" dirty="0">
                 <a:solidFill>
-                  <a:srgbClr val="1D2433"/>
+                  <a:srgbClr val="0F172A"/>
                 </a:solidFill>
                 <a:latin typeface="Calibri" pitchFamily="34" charset="0"/>
                 <a:ea typeface="Calibri" pitchFamily="34" charset="-122"/>
@@ -15762,7 +15762,7 @@
             <a:r>
               <a:rPr lang="en-US" sz="3400" b="1" dirty="0">
                 <a:solidFill>
-                  <a:srgbClr val="1E2B4A"/>
+                  <a:srgbClr val="312E81"/>
                 </a:solidFill>
                 <a:latin typeface="Calibri" pitchFamily="34" charset="0"/>
                 <a:ea typeface="Calibri" pitchFamily="34" charset="-122"/>
@@ -15804,7 +15804,7 @@
             <a:r>
               <a:rPr lang="en-US" sz="1050" dirty="0">
                 <a:solidFill>
-                  <a:srgbClr val="4A5468"/>
+                  <a:srgbClr val="475569"/>
                 </a:solidFill>
                 <a:latin typeface="Calibri" pitchFamily="34" charset="0"/>
                 <a:ea typeface="Calibri" pitchFamily="34" charset="-122"/>
@@ -15824,7 +15824,7 @@
             <a:r>
               <a:rPr lang="en-US" sz="1050" dirty="0">
                 <a:solidFill>
-                  <a:srgbClr val="4A5468"/>
+                  <a:srgbClr val="475569"/>
                 </a:solidFill>
                 <a:latin typeface="Calibri" pitchFamily="34" charset="0"/>
                 <a:ea typeface="Calibri" pitchFamily="34" charset="-122"/>
@@ -15863,7 +15863,7 @@
             <a:r>
               <a:rPr lang="en-US" sz="3400" b="1" dirty="0">
                 <a:solidFill>
-                  <a:srgbClr val="1E2B4A"/>
+                  <a:srgbClr val="312E81"/>
                 </a:solidFill>
                 <a:latin typeface="Calibri" pitchFamily="34" charset="0"/>
                 <a:ea typeface="Calibri" pitchFamily="34" charset="-122"/>
@@ -15905,7 +15905,7 @@
             <a:r>
               <a:rPr lang="en-US" sz="1050" dirty="0">
                 <a:solidFill>
-                  <a:srgbClr val="4A5468"/>
+                  <a:srgbClr val="475569"/>
                 </a:solidFill>
                 <a:latin typeface="Calibri" pitchFamily="34" charset="0"/>
                 <a:ea typeface="Calibri" pitchFamily="34" charset="-122"/>
@@ -15925,7 +15925,7 @@
             <a:r>
               <a:rPr lang="en-US" sz="1050" dirty="0">
                 <a:solidFill>
-                  <a:srgbClr val="4A5468"/>
+                  <a:srgbClr val="475569"/>
                 </a:solidFill>
                 <a:latin typeface="Calibri" pitchFamily="34" charset="0"/>
                 <a:ea typeface="Calibri" pitchFamily="34" charset="-122"/>
@@ -15967,7 +15967,7 @@
             <a:r>
               <a:rPr lang="en-US" sz="1250" dirty="0">
                 <a:solidFill>
-                  <a:srgbClr val="4A5468"/>
+                  <a:srgbClr val="475569"/>
                 </a:solidFill>
                 <a:latin typeface="Calibri" pitchFamily="34" charset="0"/>
                 <a:ea typeface="Calibri" pitchFamily="34" charset="-122"/>
@@ -16006,7 +16006,7 @@
             <a:r>
               <a:rPr lang="en-US" sz="950" dirty="0">
                 <a:solidFill>
-                  <a:srgbClr val="8A93A5"/>
+                  <a:srgbClr val="94A3B8"/>
                 </a:solidFill>
                 <a:latin typeface="Calibri" pitchFamily="34" charset="0"/>
                 <a:ea typeface="Calibri" pitchFamily="34" charset="-122"/>
@@ -16033,17 +16033,17 @@
             <a:avLst/>
           </a:prstGeom>
           <a:solidFill>
-            <a:srgbClr val="F9E8DD"/>
+            <a:srgbClr val="F9E9D7"/>
           </a:solidFill>
           <a:ln w="15875">
             <a:solidFill>
-              <a:srgbClr val="F1CBB3"/>
+              <a:srgbClr val="F1CEA5"/>
             </a:solidFill>
             <a:prstDash val="solid"/>
           </a:ln>
           <a:effectLst>
             <a:outerShdw sx="100000" sy="100000" kx="0" ky="0" algn="bl" rotWithShape="0" blurRad="127000" dist="25400" dir="5400000">
-              <a:srgbClr val="1E2B4A">
+              <a:srgbClr val="312E81">
                 <a:alpha val="8000"/>
               </a:srgbClr>
             </a:outerShdw>
@@ -16104,7 +16104,7 @@
             <a:r>
               <a:rPr lang="en-US" sz="1600" b="1" dirty="0">
                 <a:solidFill>
-                  <a:srgbClr val="1D2433"/>
+                  <a:srgbClr val="0F172A"/>
                 </a:solidFill>
                 <a:latin typeface="Calibri" pitchFamily="34" charset="0"/>
                 <a:ea typeface="Calibri" pitchFamily="34" charset="-122"/>
@@ -16143,7 +16143,7 @@
             <a:r>
               <a:rPr lang="en-US" sz="3400" b="1" dirty="0">
                 <a:solidFill>
-                  <a:srgbClr val="1E2B4A"/>
+                  <a:srgbClr val="312E81"/>
                 </a:solidFill>
                 <a:latin typeface="Calibri" pitchFamily="34" charset="0"/>
                 <a:ea typeface="Calibri" pitchFamily="34" charset="-122"/>
@@ -16185,7 +16185,7 @@
             <a:r>
               <a:rPr lang="en-US" sz="1050" dirty="0">
                 <a:solidFill>
-                  <a:srgbClr val="4A5468"/>
+                  <a:srgbClr val="475569"/>
                 </a:solidFill>
                 <a:latin typeface="Calibri" pitchFamily="34" charset="0"/>
                 <a:ea typeface="Calibri" pitchFamily="34" charset="-122"/>
@@ -16205,7 +16205,7 @@
             <a:r>
               <a:rPr lang="en-US" sz="1050" dirty="0">
                 <a:solidFill>
-                  <a:srgbClr val="4A5468"/>
+                  <a:srgbClr val="475569"/>
                 </a:solidFill>
                 <a:latin typeface="Calibri" pitchFamily="34" charset="0"/>
                 <a:ea typeface="Calibri" pitchFamily="34" charset="-122"/>
@@ -16244,7 +16244,7 @@
             <a:r>
               <a:rPr lang="en-US" sz="3400" b="1" dirty="0">
                 <a:solidFill>
-                  <a:srgbClr val="1E2B4A"/>
+                  <a:srgbClr val="312E81"/>
                 </a:solidFill>
                 <a:latin typeface="Calibri" pitchFamily="34" charset="0"/>
                 <a:ea typeface="Calibri" pitchFamily="34" charset="-122"/>
@@ -16286,7 +16286,7 @@
             <a:r>
               <a:rPr lang="en-US" sz="1050" dirty="0">
                 <a:solidFill>
-                  <a:srgbClr val="4A5468"/>
+                  <a:srgbClr val="475569"/>
                 </a:solidFill>
                 <a:latin typeface="Calibri" pitchFamily="34" charset="0"/>
                 <a:ea typeface="Calibri" pitchFamily="34" charset="-122"/>
@@ -16306,7 +16306,7 @@
             <a:r>
               <a:rPr lang="en-US" sz="1050" dirty="0">
                 <a:solidFill>
-                  <a:srgbClr val="4A5468"/>
+                  <a:srgbClr val="475569"/>
                 </a:solidFill>
                 <a:latin typeface="Calibri" pitchFamily="34" charset="0"/>
                 <a:ea typeface="Calibri" pitchFamily="34" charset="-122"/>
@@ -16348,7 +16348,7 @@
             <a:r>
               <a:rPr lang="en-US" sz="1250" dirty="0">
                 <a:solidFill>
-                  <a:srgbClr val="4A5468"/>
+                  <a:srgbClr val="475569"/>
                 </a:solidFill>
                 <a:latin typeface="Calibri" pitchFamily="34" charset="0"/>
                 <a:ea typeface="Calibri" pitchFamily="34" charset="-122"/>
@@ -16387,7 +16387,7 @@
             <a:r>
               <a:rPr lang="en-US" sz="950" dirty="0">
                 <a:solidFill>
-                  <a:srgbClr val="8A93A5"/>
+                  <a:srgbClr val="94A3B8"/>
                 </a:solidFill>
                 <a:latin typeface="Calibri" pitchFamily="34" charset="0"/>
                 <a:ea typeface="Calibri" pitchFamily="34" charset="-122"/>
@@ -16426,7 +16426,7 @@
             <a:r>
               <a:rPr lang="en-US" sz="950" dirty="0">
                 <a:solidFill>
-                  <a:srgbClr val="8A93A5"/>
+                  <a:srgbClr val="94A3B8"/>
                 </a:solidFill>
                 <a:latin typeface="Calibri" pitchFamily="34" charset="0"/>
                 <a:ea typeface="Calibri" pitchFamily="34" charset="-122"/>
@@ -16521,7 +16521,7 @@
             <a:r>
               <a:rPr lang="en-US" sz="2700" b="1" dirty="0">
                 <a:solidFill>
-                  <a:srgbClr val="1E2B4A"/>
+                  <a:srgbClr val="312E81"/>
                 </a:solidFill>
                 <a:latin typeface="Calibri" pitchFamily="34" charset="0"/>
                 <a:ea typeface="Calibri" pitchFamily="34" charset="-122"/>
@@ -16550,7 +16550,7 @@
             </a:avLst>
           </a:prstGeom>
           <a:solidFill>
-            <a:srgbClr val="1E2B4A"/>
+            <a:srgbClr val="312E81"/>
           </a:solidFill>
           <a:ln/>
         </p:spPr>
@@ -16647,7 +16647,7 @@
             <a:r>
               <a:rPr lang="en-US" sz="1400" b="1" dirty="0">
                 <a:solidFill>
-                  <a:srgbClr val="1D2433"/>
+                  <a:srgbClr val="0F172A"/>
                 </a:solidFill>
                 <a:latin typeface="Calibri" pitchFamily="34" charset="0"/>
                 <a:ea typeface="Calibri" pitchFamily="34" charset="-122"/>
@@ -16689,7 +16689,7 @@
             <a:r>
               <a:rPr lang="en-US" sz="1200" dirty="0">
                 <a:solidFill>
-                  <a:srgbClr val="4A5468"/>
+                  <a:srgbClr val="475569"/>
                 </a:solidFill>
                 <a:latin typeface="Calibri" pitchFamily="34" charset="0"/>
                 <a:ea typeface="Calibri" pitchFamily="34" charset="-122"/>
@@ -16731,7 +16731,7 @@
             <a:r>
               <a:rPr lang="en-US" sz="1400" b="1" dirty="0">
                 <a:solidFill>
-                  <a:srgbClr val="1D2433"/>
+                  <a:srgbClr val="0F172A"/>
                 </a:solidFill>
                 <a:latin typeface="Calibri" pitchFamily="34" charset="0"/>
                 <a:ea typeface="Calibri" pitchFamily="34" charset="-122"/>
@@ -16773,7 +16773,7 @@
             <a:r>
               <a:rPr lang="en-US" sz="1200" dirty="0">
                 <a:solidFill>
-                  <a:srgbClr val="4A5468"/>
+                  <a:srgbClr val="475569"/>
                 </a:solidFill>
                 <a:latin typeface="Calibri" pitchFamily="34" charset="0"/>
                 <a:ea typeface="Calibri" pitchFamily="34" charset="-122"/>
@@ -16815,7 +16815,7 @@
             <a:r>
               <a:rPr lang="en-US" sz="1400" b="1" dirty="0">
                 <a:solidFill>
-                  <a:srgbClr val="1D2433"/>
+                  <a:srgbClr val="0F172A"/>
                 </a:solidFill>
                 <a:latin typeface="Calibri" pitchFamily="34" charset="0"/>
                 <a:ea typeface="Calibri" pitchFamily="34" charset="-122"/>
@@ -16857,7 +16857,7 @@
             <a:r>
               <a:rPr lang="en-US" sz="1200" dirty="0">
                 <a:solidFill>
-                  <a:srgbClr val="4A5468"/>
+                  <a:srgbClr val="475569"/>
                 </a:solidFill>
                 <a:latin typeface="Calibri" pitchFamily="34" charset="0"/>
                 <a:ea typeface="Calibri" pitchFamily="34" charset="-122"/>
@@ -16884,17 +16884,17 @@
             <a:avLst/>
           </a:prstGeom>
           <a:solidFill>
-            <a:srgbClr val="F9E8DD"/>
+            <a:srgbClr val="F9E9D7"/>
           </a:solidFill>
           <a:ln w="15875">
             <a:solidFill>
-              <a:srgbClr val="F1CBB3"/>
+              <a:srgbClr val="F1CEA5"/>
             </a:solidFill>
             <a:prstDash val="solid"/>
           </a:ln>
           <a:effectLst>
             <a:outerShdw sx="100000" sy="100000" kx="0" ky="0" algn="bl" rotWithShape="0" blurRad="127000" dist="25400" dir="5400000">
-              <a:srgbClr val="1E2B4A">
+              <a:srgbClr val="312E81">
                 <a:alpha val="8000"/>
               </a:srgbClr>
             </a:outerShdw>
@@ -16940,17 +16940,17 @@
             <a:avLst/>
           </a:prstGeom>
           <a:solidFill>
-            <a:srgbClr val="F6ECDC"/>
+            <a:srgbClr val="D7EDF3"/>
           </a:solidFill>
           <a:ln w="15875">
             <a:solidFill>
-              <a:srgbClr val="ECD5B0"/>
+              <a:srgbClr val="A6D7E3"/>
             </a:solidFill>
             <a:prstDash val="solid"/>
           </a:ln>
           <a:effectLst>
             <a:outerShdw sx="100000" sy="100000" kx="0" ky="0" algn="bl" rotWithShape="0" blurRad="127000" dist="25400" dir="5400000">
-              <a:srgbClr val="1E2B4A">
+              <a:srgbClr val="312E81">
                 <a:alpha val="8000"/>
               </a:srgbClr>
             </a:outerShdw>
@@ -16996,17 +16996,17 @@
             <a:avLst/>
           </a:prstGeom>
           <a:solidFill>
-            <a:srgbClr val="E0EDEF"/>
+            <a:srgbClr val="F9DCE9"/>
           </a:solidFill>
           <a:ln w="15875">
             <a:solidFill>
-              <a:srgbClr val="BAD6DB"/>
+              <a:srgbClr val="F2B1CE"/>
             </a:solidFill>
             <a:prstDash val="solid"/>
           </a:ln>
           <a:effectLst>
             <a:outerShdw sx="100000" sy="100000" kx="0" ky="0" algn="bl" rotWithShape="0" blurRad="127000" dist="25400" dir="5400000">
-              <a:srgbClr val="1E2B4A">
+              <a:srgbClr val="312E81">
                 <a:alpha val="8000"/>
               </a:srgbClr>
             </a:outerShdw>
@@ -17064,7 +17064,7 @@
             <a:r>
               <a:rPr lang="en-US" sz="950" dirty="0">
                 <a:solidFill>
-                  <a:srgbClr val="8A93A5"/>
+                  <a:srgbClr val="94A3B8"/>
                 </a:solidFill>
                 <a:latin typeface="Calibri" pitchFamily="34" charset="0"/>
                 <a:ea typeface="Calibri" pitchFamily="34" charset="-122"/>
@@ -17159,7 +17159,7 @@
             <a:r>
               <a:rPr lang="en-US" sz="2700" b="1" dirty="0">
                 <a:solidFill>
-                  <a:srgbClr val="1E2B4A"/>
+                  <a:srgbClr val="312E81"/>
                 </a:solidFill>
                 <a:latin typeface="Calibri" pitchFamily="34" charset="0"/>
                 <a:ea typeface="Calibri" pitchFamily="34" charset="-122"/>
@@ -17186,17 +17186,17 @@
             <a:avLst/>
           </a:prstGeom>
           <a:solidFill>
-            <a:srgbClr val="E1E6EF"/>
+            <a:srgbClr val="E3E1FB"/>
           </a:solidFill>
           <a:ln w="15875">
             <a:solidFill>
-              <a:srgbClr val="BBC7DC"/>
+              <a:srgbClr val="C0BCF6"/>
             </a:solidFill>
             <a:prstDash val="solid"/>
           </a:ln>
           <a:effectLst>
             <a:outerShdw sx="100000" sy="100000" kx="0" ky="0" algn="bl" rotWithShape="0" blurRad="127000" dist="25400" dir="5400000">
-              <a:srgbClr val="1E2B4A">
+              <a:srgbClr val="312E81">
                 <a:alpha val="8000"/>
               </a:srgbClr>
             </a:outerShdw>
@@ -17254,7 +17254,7 @@
             <a:r>
               <a:rPr lang="en-US" sz="1800" b="1" dirty="0">
                 <a:solidFill>
-                  <a:srgbClr val="1D2433"/>
+                  <a:srgbClr val="0F172A"/>
                 </a:solidFill>
                 <a:latin typeface="Calibri" pitchFamily="34" charset="0"/>
                 <a:ea typeface="Calibri" pitchFamily="34" charset="-122"/>
@@ -17296,7 +17296,7 @@
             <a:r>
               <a:rPr lang="en-US" sz="1350" b="1" dirty="0">
                 <a:solidFill>
-                  <a:srgbClr val="1D2433"/>
+                  <a:srgbClr val="0F172A"/>
                 </a:solidFill>
                 <a:latin typeface="Calibri" pitchFamily="34" charset="0"/>
                 <a:ea typeface="Calibri" pitchFamily="34" charset="-122"/>
@@ -17323,7 +17323,7 @@
             <a:avLst/>
           </a:prstGeom>
           <a:solidFill>
-            <a:srgbClr val="41639E"/>
+            <a:srgbClr val="4F46E5"/>
           </a:solidFill>
           <a:ln/>
         </p:spPr>
@@ -17397,7 +17397,7 @@
             <a:r>
               <a:rPr lang="en-US" sz="1250" dirty="0">
                 <a:solidFill>
-                  <a:srgbClr val="4A5468"/>
+                  <a:srgbClr val="475569"/>
                 </a:solidFill>
                 <a:latin typeface="Calibri" pitchFamily="34" charset="0"/>
                 <a:ea typeface="Calibri" pitchFamily="34" charset="-122"/>
@@ -17424,7 +17424,7 @@
             <a:avLst/>
           </a:prstGeom>
           <a:solidFill>
-            <a:srgbClr val="41639E"/>
+            <a:srgbClr val="4F46E5"/>
           </a:solidFill>
           <a:ln/>
         </p:spPr>
@@ -17498,7 +17498,7 @@
             <a:r>
               <a:rPr lang="en-US" sz="1250" dirty="0">
                 <a:solidFill>
-                  <a:srgbClr val="4A5468"/>
+                  <a:srgbClr val="475569"/>
                 </a:solidFill>
                 <a:latin typeface="Calibri" pitchFamily="34" charset="0"/>
                 <a:ea typeface="Calibri" pitchFamily="34" charset="-122"/>
@@ -17525,17 +17525,17 @@
             <a:avLst/>
           </a:prstGeom>
           <a:solidFill>
-            <a:srgbClr val="F9E8DD"/>
+            <a:srgbClr val="F9E9D7"/>
           </a:solidFill>
           <a:ln w="15875">
             <a:solidFill>
-              <a:srgbClr val="F1CBB3"/>
+              <a:srgbClr val="F1CEA5"/>
             </a:solidFill>
             <a:prstDash val="solid"/>
           </a:ln>
           <a:effectLst>
             <a:outerShdw sx="100000" sy="100000" kx="0" ky="0" algn="bl" rotWithShape="0" blurRad="127000" dist="25400" dir="5400000">
-              <a:srgbClr val="1E2B4A">
+              <a:srgbClr val="312E81">
                 <a:alpha val="8000"/>
               </a:srgbClr>
             </a:outerShdw>
@@ -17593,7 +17593,7 @@
             <a:r>
               <a:rPr lang="en-US" sz="1800" b="1" dirty="0">
                 <a:solidFill>
-                  <a:srgbClr val="1D2433"/>
+                  <a:srgbClr val="0F172A"/>
                 </a:solidFill>
                 <a:latin typeface="Calibri" pitchFamily="34" charset="0"/>
                 <a:ea typeface="Calibri" pitchFamily="34" charset="-122"/>
@@ -17622,7 +17622,7 @@
             </a:avLst>
           </a:prstGeom>
           <a:solidFill>
-            <a:srgbClr val="E5EEF4"/>
+            <a:srgbClr val="EEF2FF"/>
           </a:solidFill>
           <a:ln/>
         </p:spPr>
@@ -17654,7 +17654,7 @@
             <a:r>
               <a:rPr lang="en-US" sz="2200" b="1" dirty="0">
                 <a:solidFill>
-                  <a:srgbClr val="D96F2B"/>
+                  <a:srgbClr val="D97706"/>
                 </a:solidFill>
                 <a:latin typeface="Calibri" pitchFamily="34" charset="0"/>
                 <a:ea typeface="Calibri" pitchFamily="34" charset="-122"/>
@@ -17696,7 +17696,7 @@
             <a:r>
               <a:rPr lang="en-US" sz="1200" dirty="0">
                 <a:solidFill>
-                  <a:srgbClr val="1D2433"/>
+                  <a:srgbClr val="0F172A"/>
                 </a:solidFill>
                 <a:latin typeface="Calibri" pitchFamily="34" charset="0"/>
                 <a:ea typeface="Calibri" pitchFamily="34" charset="-122"/>
@@ -17725,7 +17725,7 @@
             </a:avLst>
           </a:prstGeom>
           <a:solidFill>
-            <a:srgbClr val="E5EEF4"/>
+            <a:srgbClr val="EEF2FF"/>
           </a:solidFill>
           <a:ln/>
         </p:spPr>
@@ -17757,7 +17757,7 @@
             <a:r>
               <a:rPr lang="en-US" sz="2200" b="1" dirty="0">
                 <a:solidFill>
-                  <a:srgbClr val="D96F2B"/>
+                  <a:srgbClr val="D97706"/>
                 </a:solidFill>
                 <a:latin typeface="Calibri" pitchFamily="34" charset="0"/>
                 <a:ea typeface="Calibri" pitchFamily="34" charset="-122"/>
@@ -17799,7 +17799,7 @@
             <a:r>
               <a:rPr lang="en-US" sz="1200" dirty="0">
                 <a:solidFill>
-                  <a:srgbClr val="1D2433"/>
+                  <a:srgbClr val="0F172A"/>
                 </a:solidFill>
                 <a:latin typeface="Calibri" pitchFamily="34" charset="0"/>
                 <a:ea typeface="Calibri" pitchFamily="34" charset="-122"/>
@@ -17838,7 +17838,7 @@
             <a:r>
               <a:rPr lang="en-US" sz="950" dirty="0">
                 <a:solidFill>
-                  <a:srgbClr val="8A93A5"/>
+                  <a:srgbClr val="94A3B8"/>
                 </a:solidFill>
                 <a:latin typeface="Calibri" pitchFamily="34" charset="0"/>
                 <a:ea typeface="Calibri" pitchFamily="34" charset="-122"/>
@@ -17933,7 +17933,7 @@
             <a:r>
               <a:rPr lang="en-US" sz="2700" b="1" dirty="0">
                 <a:solidFill>
-                  <a:srgbClr val="1E2B4A"/>
+                  <a:srgbClr val="312E81"/>
                 </a:solidFill>
                 <a:latin typeface="Calibri" pitchFamily="34" charset="0"/>
                 <a:ea typeface="Calibri" pitchFamily="34" charset="-122"/>
@@ -17972,7 +17972,7 @@
             <a:r>
               <a:rPr lang="en-US" sz="1700" b="1" dirty="0">
                 <a:solidFill>
-                  <a:srgbClr val="1D2433"/>
+                  <a:srgbClr val="0F172A"/>
                 </a:solidFill>
                 <a:latin typeface="Calibri" pitchFamily="34" charset="0"/>
                 <a:ea typeface="Calibri" pitchFamily="34" charset="-122"/>
@@ -17999,7 +17999,7 @@
             <a:avLst/>
           </a:prstGeom>
           <a:solidFill>
-            <a:srgbClr val="41639E"/>
+            <a:srgbClr val="4F46E5"/>
           </a:solidFill>
           <a:ln/>
         </p:spPr>
@@ -18031,7 +18031,7 @@
             <a:r>
               <a:rPr lang="en-US" sz="1400" b="1" dirty="0">
                 <a:solidFill>
-                  <a:srgbClr val="1D2433"/>
+                  <a:srgbClr val="0F172A"/>
                 </a:solidFill>
                 <a:latin typeface="Calibri" pitchFamily="34" charset="0"/>
                 <a:ea typeface="Calibri" pitchFamily="34" charset="-122"/>
@@ -18073,7 +18073,7 @@
             <a:r>
               <a:rPr lang="en-US" sz="1200" dirty="0">
                 <a:solidFill>
-                  <a:srgbClr val="4A5468"/>
+                  <a:srgbClr val="475569"/>
                 </a:solidFill>
                 <a:latin typeface="Calibri" pitchFamily="34" charset="0"/>
                 <a:ea typeface="Calibri" pitchFamily="34" charset="-122"/>
@@ -18112,7 +18112,7 @@
             <a:r>
               <a:rPr lang="en-US" sz="1050" i="1" dirty="0">
                 <a:solidFill>
-                  <a:srgbClr val="8A93A5"/>
+                  <a:srgbClr val="94A3B8"/>
                 </a:solidFill>
                 <a:latin typeface="Calibri" pitchFamily="34" charset="0"/>
                 <a:ea typeface="Calibri" pitchFamily="34" charset="-122"/>
@@ -18139,7 +18139,7 @@
             <a:avLst/>
           </a:prstGeom>
           <a:solidFill>
-            <a:srgbClr val="41639E"/>
+            <a:srgbClr val="4F46E5"/>
           </a:solidFill>
           <a:ln/>
         </p:spPr>
@@ -18171,7 +18171,7 @@
             <a:r>
               <a:rPr lang="en-US" sz="1400" b="1" dirty="0">
                 <a:solidFill>
-                  <a:srgbClr val="1D2433"/>
+                  <a:srgbClr val="0F172A"/>
                 </a:solidFill>
                 <a:latin typeface="Calibri" pitchFamily="34" charset="0"/>
                 <a:ea typeface="Calibri" pitchFamily="34" charset="-122"/>
@@ -18213,7 +18213,7 @@
             <a:r>
               <a:rPr lang="en-US" sz="1200" dirty="0">
                 <a:solidFill>
-                  <a:srgbClr val="4A5468"/>
+                  <a:srgbClr val="475569"/>
                 </a:solidFill>
                 <a:latin typeface="Calibri" pitchFamily="34" charset="0"/>
                 <a:ea typeface="Calibri" pitchFamily="34" charset="-122"/>
@@ -18252,7 +18252,7 @@
             <a:r>
               <a:rPr lang="en-US" sz="1050" i="1" dirty="0">
                 <a:solidFill>
-                  <a:srgbClr val="8A93A5"/>
+                  <a:srgbClr val="94A3B8"/>
                 </a:solidFill>
                 <a:latin typeface="Calibri" pitchFamily="34" charset="0"/>
                 <a:ea typeface="Calibri" pitchFamily="34" charset="-122"/>
@@ -18279,7 +18279,7 @@
             <a:avLst/>
           </a:prstGeom>
           <a:solidFill>
-            <a:srgbClr val="41639E"/>
+            <a:srgbClr val="4F46E5"/>
           </a:solidFill>
           <a:ln/>
         </p:spPr>
@@ -18311,7 +18311,7 @@
             <a:r>
               <a:rPr lang="en-US" sz="1400" b="1" dirty="0">
                 <a:solidFill>
-                  <a:srgbClr val="1D2433"/>
+                  <a:srgbClr val="0F172A"/>
                 </a:solidFill>
                 <a:latin typeface="Calibri" pitchFamily="34" charset="0"/>
                 <a:ea typeface="Calibri" pitchFamily="34" charset="-122"/>
@@ -18353,7 +18353,7 @@
             <a:r>
               <a:rPr lang="en-US" sz="1200" dirty="0">
                 <a:solidFill>
-                  <a:srgbClr val="4A5468"/>
+                  <a:srgbClr val="475569"/>
                 </a:solidFill>
                 <a:latin typeface="Calibri" pitchFamily="34" charset="0"/>
                 <a:ea typeface="Calibri" pitchFamily="34" charset="-122"/>
@@ -18392,7 +18392,7 @@
             <a:r>
               <a:rPr lang="en-US" sz="1050" i="1" dirty="0">
                 <a:solidFill>
-                  <a:srgbClr val="8A93A5"/>
+                  <a:srgbClr val="94A3B8"/>
                 </a:solidFill>
                 <a:latin typeface="Calibri" pitchFamily="34" charset="0"/>
                 <a:ea typeface="Calibri" pitchFamily="34" charset="-122"/>
@@ -18431,7 +18431,7 @@
             <a:r>
               <a:rPr lang="en-US" sz="1700" b="1" dirty="0">
                 <a:solidFill>
-                  <a:srgbClr val="1D2433"/>
+                  <a:srgbClr val="0F172A"/>
                 </a:solidFill>
                 <a:latin typeface="Calibri" pitchFamily="34" charset="0"/>
                 <a:ea typeface="Calibri" pitchFamily="34" charset="-122"/>
@@ -18470,7 +18470,7 @@
             <a:r>
               <a:rPr lang="en-US" sz="1400" b="1" dirty="0">
                 <a:solidFill>
-                  <a:srgbClr val="1D2433"/>
+                  <a:srgbClr val="0F172A"/>
                 </a:solidFill>
                 <a:latin typeface="Calibri" pitchFamily="34" charset="0"/>
                 <a:ea typeface="Calibri" pitchFamily="34" charset="-122"/>
@@ -18512,7 +18512,7 @@
             <a:r>
               <a:rPr lang="en-US" sz="1200" dirty="0">
                 <a:solidFill>
-                  <a:srgbClr val="4A5468"/>
+                  <a:srgbClr val="475569"/>
                 </a:solidFill>
                 <a:latin typeface="Calibri" pitchFamily="34" charset="0"/>
                 <a:ea typeface="Calibri" pitchFamily="34" charset="-122"/>
@@ -18551,7 +18551,7 @@
             <a:r>
               <a:rPr lang="en-US" sz="1050" i="1" dirty="0">
                 <a:solidFill>
-                  <a:srgbClr val="8A93A5"/>
+                  <a:srgbClr val="94A3B8"/>
                 </a:solidFill>
                 <a:latin typeface="Calibri" pitchFamily="34" charset="0"/>
                 <a:ea typeface="Calibri" pitchFamily="34" charset="-122"/>
@@ -18590,7 +18590,7 @@
             <a:r>
               <a:rPr lang="en-US" sz="1400" b="1" dirty="0">
                 <a:solidFill>
-                  <a:srgbClr val="1D2433"/>
+                  <a:srgbClr val="0F172A"/>
                 </a:solidFill>
                 <a:latin typeface="Calibri" pitchFamily="34" charset="0"/>
                 <a:ea typeface="Calibri" pitchFamily="34" charset="-122"/>
@@ -18632,7 +18632,7 @@
             <a:r>
               <a:rPr lang="en-US" sz="1200" dirty="0">
                 <a:solidFill>
-                  <a:srgbClr val="4A5468"/>
+                  <a:srgbClr val="475569"/>
                 </a:solidFill>
                 <a:latin typeface="Calibri" pitchFamily="34" charset="0"/>
                 <a:ea typeface="Calibri" pitchFamily="34" charset="-122"/>
@@ -18671,7 +18671,7 @@
             <a:r>
               <a:rPr lang="en-US" sz="1050" i="1" dirty="0">
                 <a:solidFill>
-                  <a:srgbClr val="8A93A5"/>
+                  <a:srgbClr val="94A3B8"/>
                 </a:solidFill>
                 <a:latin typeface="Calibri" pitchFamily="34" charset="0"/>
                 <a:ea typeface="Calibri" pitchFamily="34" charset="-122"/>
@@ -18710,7 +18710,7 @@
             <a:r>
               <a:rPr lang="en-US" sz="1400" b="1" dirty="0">
                 <a:solidFill>
-                  <a:srgbClr val="1D2433"/>
+                  <a:srgbClr val="0F172A"/>
                 </a:solidFill>
                 <a:latin typeface="Calibri" pitchFamily="34" charset="0"/>
                 <a:ea typeface="Calibri" pitchFamily="34" charset="-122"/>
@@ -18752,7 +18752,7 @@
             <a:r>
               <a:rPr lang="en-US" sz="1200" dirty="0">
                 <a:solidFill>
-                  <a:srgbClr val="4A5468"/>
+                  <a:srgbClr val="475569"/>
                 </a:solidFill>
                 <a:latin typeface="Calibri" pitchFamily="34" charset="0"/>
                 <a:ea typeface="Calibri" pitchFamily="34" charset="-122"/>
@@ -18791,7 +18791,7 @@
             <a:r>
               <a:rPr lang="en-US" sz="1050" i="1" dirty="0">
                 <a:solidFill>
-                  <a:srgbClr val="8A93A5"/>
+                  <a:srgbClr val="94A3B8"/>
                 </a:solidFill>
                 <a:latin typeface="Calibri" pitchFamily="34" charset="0"/>
                 <a:ea typeface="Calibri" pitchFamily="34" charset="-122"/>
@@ -18818,17 +18818,17 @@
             <a:avLst/>
           </a:prstGeom>
           <a:solidFill>
-            <a:srgbClr val="E1E6EF"/>
+            <a:srgbClr val="E3E1FB"/>
           </a:solidFill>
           <a:ln w="15875">
             <a:solidFill>
-              <a:srgbClr val="BBC7DC"/>
+              <a:srgbClr val="C0BCF6"/>
             </a:solidFill>
             <a:prstDash val="solid"/>
           </a:ln>
           <a:effectLst>
             <a:outerShdw sx="100000" sy="100000" kx="0" ky="0" algn="bl" rotWithShape="0" blurRad="127000" dist="25400" dir="5400000">
-              <a:srgbClr val="1E2B4A">
+              <a:srgbClr val="312E81">
                 <a:alpha val="8000"/>
               </a:srgbClr>
             </a:outerShdw>
@@ -18874,17 +18874,17 @@
             <a:avLst/>
           </a:prstGeom>
           <a:solidFill>
-            <a:srgbClr val="F6ECDC"/>
+            <a:srgbClr val="D7EDF3"/>
           </a:solidFill>
           <a:ln w="15875">
             <a:solidFill>
-              <a:srgbClr val="ECD5B0"/>
+              <a:srgbClr val="A6D7E3"/>
             </a:solidFill>
             <a:prstDash val="solid"/>
           </a:ln>
           <a:effectLst>
             <a:outerShdw sx="100000" sy="100000" kx="0" ky="0" algn="bl" rotWithShape="0" blurRad="127000" dist="25400" dir="5400000">
-              <a:srgbClr val="1E2B4A">
+              <a:srgbClr val="312E81">
                 <a:alpha val="8000"/>
               </a:srgbClr>
             </a:outerShdw>
@@ -18930,17 +18930,17 @@
             <a:avLst/>
           </a:prstGeom>
           <a:solidFill>
-            <a:srgbClr val="F9E8DD"/>
+            <a:srgbClr val="F9E9D7"/>
           </a:solidFill>
           <a:ln w="15875">
             <a:solidFill>
-              <a:srgbClr val="F1CBB3"/>
+              <a:srgbClr val="F1CEA5"/>
             </a:solidFill>
             <a:prstDash val="solid"/>
           </a:ln>
           <a:effectLst>
             <a:outerShdw sx="100000" sy="100000" kx="0" ky="0" algn="bl" rotWithShape="0" blurRad="127000" dist="25400" dir="5400000">
-              <a:srgbClr val="1E2B4A">
+              <a:srgbClr val="312E81">
                 <a:alpha val="8000"/>
               </a:srgbClr>
             </a:outerShdw>
@@ -18998,7 +18998,7 @@
             <a:r>
               <a:rPr lang="en-US" sz="950" dirty="0">
                 <a:solidFill>
-                  <a:srgbClr val="8A93A5"/>
+                  <a:srgbClr val="94A3B8"/>
                 </a:solidFill>
                 <a:latin typeface="Calibri" pitchFamily="34" charset="0"/>
                 <a:ea typeface="Calibri" pitchFamily="34" charset="-122"/>
@@ -19093,7 +19093,7 @@
             <a:r>
               <a:rPr lang="en-US" sz="2700" b="1" dirty="0">
                 <a:solidFill>
-                  <a:srgbClr val="1E2B4A"/>
+                  <a:srgbClr val="312E81"/>
                 </a:solidFill>
                 <a:latin typeface="Calibri" pitchFamily="34" charset="0"/>
                 <a:ea typeface="Calibri" pitchFamily="34" charset="-122"/>
@@ -19135,7 +19135,7 @@
             <a:r>
               <a:rPr lang="en-US" sz="1300" dirty="0">
                 <a:solidFill>
-                  <a:srgbClr val="4A5468"/>
+                  <a:srgbClr val="475569"/>
                 </a:solidFill>
                 <a:latin typeface="Calibri" pitchFamily="34" charset="0"/>
                 <a:ea typeface="Calibri" pitchFamily="34" charset="-122"/>
@@ -19162,17 +19162,17 @@
             <a:avLst/>
           </a:prstGeom>
           <a:solidFill>
-            <a:srgbClr val="E1E6EF"/>
+            <a:srgbClr val="E3E1FB"/>
           </a:solidFill>
           <a:ln w="15875">
             <a:solidFill>
-              <a:srgbClr val="BBC7DC"/>
+              <a:srgbClr val="C0BCF6"/>
             </a:solidFill>
             <a:prstDash val="solid"/>
           </a:ln>
           <a:effectLst>
             <a:outerShdw sx="100000" sy="100000" kx="0" ky="0" algn="bl" rotWithShape="0" blurRad="127000" dist="25400" dir="5400000">
-              <a:srgbClr val="1E2B4A">
+              <a:srgbClr val="312E81">
                 <a:alpha val="8000"/>
               </a:srgbClr>
             </a:outerShdw>
@@ -19233,7 +19233,7 @@
             <a:r>
               <a:rPr lang="en-US" sz="1150" b="1" dirty="0">
                 <a:solidFill>
-                  <a:srgbClr val="1D2433"/>
+                  <a:srgbClr val="0F172A"/>
                 </a:solidFill>
                 <a:latin typeface="Calibri" pitchFamily="34" charset="0"/>
                 <a:ea typeface="Calibri" pitchFamily="34" charset="-122"/>
@@ -19260,17 +19260,17 @@
             <a:avLst/>
           </a:prstGeom>
           <a:solidFill>
-            <a:srgbClr val="E0EDEF"/>
+            <a:srgbClr val="F9DCE9"/>
           </a:solidFill>
           <a:ln w="15875">
             <a:solidFill>
-              <a:srgbClr val="BAD6DB"/>
+              <a:srgbClr val="F2B1CE"/>
             </a:solidFill>
             <a:prstDash val="solid"/>
           </a:ln>
           <a:effectLst>
             <a:outerShdw sx="100000" sy="100000" kx="0" ky="0" algn="bl" rotWithShape="0" blurRad="127000" dist="25400" dir="5400000">
-              <a:srgbClr val="1E2B4A">
+              <a:srgbClr val="312E81">
                 <a:alpha val="8000"/>
               </a:srgbClr>
             </a:outerShdw>
@@ -19331,7 +19331,7 @@
             <a:r>
               <a:rPr lang="en-US" sz="1150" b="1" dirty="0">
                 <a:solidFill>
-                  <a:srgbClr val="1D2433"/>
+                  <a:srgbClr val="0F172A"/>
                 </a:solidFill>
                 <a:latin typeface="Calibri" pitchFamily="34" charset="0"/>
                 <a:ea typeface="Calibri" pitchFamily="34" charset="-122"/>
@@ -19358,17 +19358,17 @@
             <a:avLst/>
           </a:prstGeom>
           <a:solidFill>
-            <a:srgbClr val="E1E6EF"/>
+            <a:srgbClr val="E3E1FB"/>
           </a:solidFill>
           <a:ln w="15875">
             <a:solidFill>
-              <a:srgbClr val="BBC7DC"/>
+              <a:srgbClr val="C0BCF6"/>
             </a:solidFill>
             <a:prstDash val="solid"/>
           </a:ln>
           <a:effectLst>
             <a:outerShdw sx="100000" sy="100000" kx="0" ky="0" algn="bl" rotWithShape="0" blurRad="127000" dist="25400" dir="5400000">
-              <a:srgbClr val="1E2B4A">
+              <a:srgbClr val="312E81">
                 <a:alpha val="8000"/>
               </a:srgbClr>
             </a:outerShdw>
@@ -19429,7 +19429,7 @@
             <a:r>
               <a:rPr lang="en-US" sz="1150" b="1" dirty="0">
                 <a:solidFill>
-                  <a:srgbClr val="1D2433"/>
+                  <a:srgbClr val="0F172A"/>
                 </a:solidFill>
                 <a:latin typeface="Calibri" pitchFamily="34" charset="0"/>
                 <a:ea typeface="Calibri" pitchFamily="34" charset="-122"/>
@@ -19456,17 +19456,17 @@
             <a:avLst/>
           </a:prstGeom>
           <a:solidFill>
-            <a:srgbClr val="F9E8DD"/>
+            <a:srgbClr val="F9E9D7"/>
           </a:solidFill>
           <a:ln w="15875">
             <a:solidFill>
-              <a:srgbClr val="F1CBB3"/>
+              <a:srgbClr val="F1CEA5"/>
             </a:solidFill>
             <a:prstDash val="solid"/>
           </a:ln>
           <a:effectLst>
             <a:outerShdw sx="100000" sy="100000" kx="0" ky="0" algn="bl" rotWithShape="0" blurRad="127000" dist="25400" dir="5400000">
-              <a:srgbClr val="1E2B4A">
+              <a:srgbClr val="312E81">
                 <a:alpha val="8000"/>
               </a:srgbClr>
             </a:outerShdw>
@@ -19527,7 +19527,7 @@
             <a:r>
               <a:rPr lang="en-US" sz="1150" b="1" dirty="0">
                 <a:solidFill>
-                  <a:srgbClr val="1D2433"/>
+                  <a:srgbClr val="0F172A"/>
                 </a:solidFill>
                 <a:latin typeface="Calibri" pitchFamily="34" charset="0"/>
                 <a:ea typeface="Calibri" pitchFamily="34" charset="-122"/>
@@ -19554,17 +19554,17 @@
             <a:avLst/>
           </a:prstGeom>
           <a:solidFill>
-            <a:srgbClr val="F6ECDC"/>
+            <a:srgbClr val="D7EDF3"/>
           </a:solidFill>
           <a:ln w="15875">
             <a:solidFill>
-              <a:srgbClr val="ECD5B0"/>
+              <a:srgbClr val="A6D7E3"/>
             </a:solidFill>
             <a:prstDash val="solid"/>
           </a:ln>
           <a:effectLst>
             <a:outerShdw sx="100000" sy="100000" kx="0" ky="0" algn="bl" rotWithShape="0" blurRad="127000" dist="25400" dir="5400000">
-              <a:srgbClr val="1E2B4A">
+              <a:srgbClr val="312E81">
                 <a:alpha val="8000"/>
               </a:srgbClr>
             </a:outerShdw>
@@ -19625,7 +19625,7 @@
             <a:r>
               <a:rPr lang="en-US" sz="1150" b="1" dirty="0">
                 <a:solidFill>
-                  <a:srgbClr val="1D2433"/>
+                  <a:srgbClr val="0F172A"/>
                 </a:solidFill>
                 <a:latin typeface="Calibri" pitchFamily="34" charset="0"/>
                 <a:ea typeface="Calibri" pitchFamily="34" charset="-122"/>
@@ -19652,17 +19652,17 @@
             <a:avLst/>
           </a:prstGeom>
           <a:solidFill>
-            <a:srgbClr val="E0EDEF"/>
+            <a:srgbClr val="F9DCE9"/>
           </a:solidFill>
           <a:ln w="15875">
             <a:solidFill>
-              <a:srgbClr val="BAD6DB"/>
+              <a:srgbClr val="F2B1CE"/>
             </a:solidFill>
             <a:prstDash val="solid"/>
           </a:ln>
           <a:effectLst>
             <a:outerShdw sx="100000" sy="100000" kx="0" ky="0" algn="bl" rotWithShape="0" blurRad="127000" dist="25400" dir="5400000">
-              <a:srgbClr val="1E2B4A">
+              <a:srgbClr val="312E81">
                 <a:alpha val="8000"/>
               </a:srgbClr>
             </a:outerShdw>
@@ -19723,7 +19723,7 @@
             <a:r>
               <a:rPr lang="en-US" sz="1150" b="1" dirty="0">
                 <a:solidFill>
-                  <a:srgbClr val="1D2433"/>
+                  <a:srgbClr val="0F172A"/>
                 </a:solidFill>
                 <a:latin typeface="Calibri" pitchFamily="34" charset="0"/>
                 <a:ea typeface="Calibri" pitchFamily="34" charset="-122"/>
@@ -19750,17 +19750,17 @@
             <a:avLst/>
           </a:prstGeom>
           <a:solidFill>
-            <a:srgbClr val="E1E6EF"/>
+            <a:srgbClr val="E3E1FB"/>
           </a:solidFill>
           <a:ln w="15875">
             <a:solidFill>
-              <a:srgbClr val="BBC7DC"/>
+              <a:srgbClr val="C0BCF6"/>
             </a:solidFill>
             <a:prstDash val="solid"/>
           </a:ln>
           <a:effectLst>
             <a:outerShdw sx="100000" sy="100000" kx="0" ky="0" algn="bl" rotWithShape="0" blurRad="127000" dist="25400" dir="5400000">
-              <a:srgbClr val="1E2B4A">
+              <a:srgbClr val="312E81">
                 <a:alpha val="8000"/>
               </a:srgbClr>
             </a:outerShdw>
@@ -19821,7 +19821,7 @@
             <a:r>
               <a:rPr lang="en-US" sz="1150" b="1" dirty="0">
                 <a:solidFill>
-                  <a:srgbClr val="1D2433"/>
+                  <a:srgbClr val="0F172A"/>
                 </a:solidFill>
                 <a:latin typeface="Calibri" pitchFamily="34" charset="0"/>
                 <a:ea typeface="Calibri" pitchFamily="34" charset="-122"/>
@@ -19860,7 +19860,7 @@
             <a:r>
               <a:rPr lang="en-US" sz="1450" b="1" dirty="0">
                 <a:solidFill>
-                  <a:srgbClr val="1D2433"/>
+                  <a:srgbClr val="0F172A"/>
                 </a:solidFill>
                 <a:latin typeface="Calibri" pitchFamily="34" charset="0"/>
                 <a:ea typeface="Calibri" pitchFamily="34" charset="-122"/>
@@ -19902,7 +19902,7 @@
             <a:r>
               <a:rPr lang="en-US" sz="1200" dirty="0">
                 <a:solidFill>
-                  <a:srgbClr val="4A5468"/>
+                  <a:srgbClr val="475569"/>
                 </a:solidFill>
                 <a:latin typeface="Calibri" pitchFamily="34" charset="0"/>
                 <a:ea typeface="Calibri" pitchFamily="34" charset="-122"/>
@@ -19922,7 +19922,7 @@
             <a:r>
               <a:rPr lang="en-US" sz="1200" dirty="0">
                 <a:solidFill>
-                  <a:srgbClr val="4A5468"/>
+                  <a:srgbClr val="475569"/>
                 </a:solidFill>
                 <a:latin typeface="Calibri" pitchFamily="34" charset="0"/>
                 <a:ea typeface="Calibri" pitchFamily="34" charset="-122"/>
@@ -19961,7 +19961,7 @@
             <a:r>
               <a:rPr lang="en-US" sz="1450" b="1" dirty="0">
                 <a:solidFill>
-                  <a:srgbClr val="1D2433"/>
+                  <a:srgbClr val="0F172A"/>
                 </a:solidFill>
                 <a:latin typeface="Calibri" pitchFamily="34" charset="0"/>
                 <a:ea typeface="Calibri" pitchFamily="34" charset="-122"/>
@@ -20000,7 +20000,7 @@
             <a:r>
               <a:rPr lang="en-US" sz="1250" b="1" dirty="0">
                 <a:solidFill>
-                  <a:srgbClr val="1D2433"/>
+                  <a:srgbClr val="0F172A"/>
                 </a:solidFill>
                 <a:latin typeface="Calibri" pitchFamily="34" charset="0"/>
                 <a:ea typeface="Calibri" pitchFamily="34" charset="-122"/>
@@ -20039,7 +20039,7 @@
             <a:r>
               <a:rPr lang="en-US" sz="1150" dirty="0">
                 <a:solidFill>
-                  <a:srgbClr val="4A5468"/>
+                  <a:srgbClr val="475569"/>
                 </a:solidFill>
                 <a:latin typeface="Calibri" pitchFamily="34" charset="0"/>
                 <a:ea typeface="Calibri" pitchFamily="34" charset="-122"/>
@@ -20078,7 +20078,7 @@
             <a:r>
               <a:rPr lang="en-US" sz="1250" b="1" dirty="0">
                 <a:solidFill>
-                  <a:srgbClr val="1D2433"/>
+                  <a:srgbClr val="0F172A"/>
                 </a:solidFill>
                 <a:latin typeface="Calibri" pitchFamily="34" charset="0"/>
                 <a:ea typeface="Calibri" pitchFamily="34" charset="-122"/>
@@ -20117,7 +20117,7 @@
             <a:r>
               <a:rPr lang="en-US" sz="1150" dirty="0">
                 <a:solidFill>
-                  <a:srgbClr val="4A5468"/>
+                  <a:srgbClr val="475569"/>
                 </a:solidFill>
                 <a:latin typeface="Calibri" pitchFamily="34" charset="0"/>
                 <a:ea typeface="Calibri" pitchFamily="34" charset="-122"/>
@@ -20156,7 +20156,7 @@
             <a:r>
               <a:rPr lang="en-US" sz="1250" b="1" dirty="0">
                 <a:solidFill>
-                  <a:srgbClr val="1D2433"/>
+                  <a:srgbClr val="0F172A"/>
                 </a:solidFill>
                 <a:latin typeface="Calibri" pitchFamily="34" charset="0"/>
                 <a:ea typeface="Calibri" pitchFamily="34" charset="-122"/>
@@ -20195,7 +20195,7 @@
             <a:r>
               <a:rPr lang="en-US" sz="1150" dirty="0">
                 <a:solidFill>
-                  <a:srgbClr val="4A5468"/>
+                  <a:srgbClr val="475569"/>
                 </a:solidFill>
                 <a:latin typeface="Calibri" pitchFamily="34" charset="0"/>
                 <a:ea typeface="Calibri" pitchFamily="34" charset="-122"/>
@@ -20237,7 +20237,7 @@
             <a:r>
               <a:rPr lang="en-US" sz="1100" dirty="0">
                 <a:solidFill>
-                  <a:srgbClr val="4A5468"/>
+                  <a:srgbClr val="475569"/>
                 </a:solidFill>
                 <a:latin typeface="Calibri" pitchFamily="34" charset="0"/>
                 <a:ea typeface="Calibri" pitchFamily="34" charset="-122"/>
@@ -20276,7 +20276,7 @@
             <a:r>
               <a:rPr lang="en-US" sz="900" dirty="0">
                 <a:solidFill>
-                  <a:srgbClr val="8A93A5"/>
+                  <a:srgbClr val="94A3B8"/>
                 </a:solidFill>
                 <a:latin typeface="Calibri" pitchFamily="34" charset="0"/>
                 <a:ea typeface="Calibri" pitchFamily="34" charset="-122"/>
@@ -20315,7 +20315,7 @@
             <a:r>
               <a:rPr lang="en-US" sz="950" dirty="0">
                 <a:solidFill>
-                  <a:srgbClr val="8A93A5"/>
+                  <a:srgbClr val="94A3B8"/>
                 </a:solidFill>
                 <a:latin typeface="Calibri" pitchFamily="34" charset="0"/>
                 <a:ea typeface="Calibri" pitchFamily="34" charset="-122"/>
@@ -20410,7 +20410,7 @@
             <a:r>
               <a:rPr lang="en-US" sz="2700" b="1" dirty="0">
                 <a:solidFill>
-                  <a:srgbClr val="1E2B4A"/>
+                  <a:srgbClr val="312E81"/>
                 </a:solidFill>
                 <a:latin typeface="Calibri" pitchFamily="34" charset="0"/>
                 <a:ea typeface="Calibri" pitchFamily="34" charset="-122"/>
@@ -20452,7 +20452,7 @@
             <a:r>
               <a:rPr lang="en-US" sz="1300" dirty="0">
                 <a:solidFill>
-                  <a:srgbClr val="4A5468"/>
+                  <a:srgbClr val="475569"/>
                 </a:solidFill>
                 <a:latin typeface="Calibri" pitchFamily="34" charset="0"/>
                 <a:ea typeface="Calibri" pitchFamily="34" charset="-122"/>
@@ -20491,7 +20491,7 @@
             <a:r>
               <a:rPr lang="en-US" sz="3200" b="1" dirty="0">
                 <a:solidFill>
-                  <a:srgbClr val="1E2B4A"/>
+                  <a:srgbClr val="312E81"/>
                 </a:solidFill>
                 <a:latin typeface="Calibri" pitchFamily="34" charset="0"/>
                 <a:ea typeface="Calibri" pitchFamily="34" charset="-122"/>
@@ -20533,7 +20533,7 @@
             <a:r>
               <a:rPr lang="en-US" sz="1050" dirty="0">
                 <a:solidFill>
-                  <a:srgbClr val="4A5468"/>
+                  <a:srgbClr val="475569"/>
                 </a:solidFill>
                 <a:latin typeface="Calibri" pitchFamily="34" charset="0"/>
                 <a:ea typeface="Calibri" pitchFamily="34" charset="-122"/>
@@ -20553,7 +20553,7 @@
             <a:r>
               <a:rPr lang="en-US" sz="1050" dirty="0">
                 <a:solidFill>
-                  <a:srgbClr val="4A5468"/>
+                  <a:srgbClr val="475569"/>
                 </a:solidFill>
                 <a:latin typeface="Calibri" pitchFamily="34" charset="0"/>
                 <a:ea typeface="Calibri" pitchFamily="34" charset="-122"/>
@@ -20592,7 +20592,7 @@
             <a:r>
               <a:rPr lang="en-US" sz="3200" b="1" dirty="0">
                 <a:solidFill>
-                  <a:srgbClr val="1E2B4A"/>
+                  <a:srgbClr val="312E81"/>
                 </a:solidFill>
                 <a:latin typeface="Calibri" pitchFamily="34" charset="0"/>
                 <a:ea typeface="Calibri" pitchFamily="34" charset="-122"/>
@@ -20634,7 +20634,7 @@
             <a:r>
               <a:rPr lang="en-US" sz="1050" dirty="0">
                 <a:solidFill>
-                  <a:srgbClr val="4A5468"/>
+                  <a:srgbClr val="475569"/>
                 </a:solidFill>
                 <a:latin typeface="Calibri" pitchFamily="34" charset="0"/>
                 <a:ea typeface="Calibri" pitchFamily="34" charset="-122"/>
@@ -20654,7 +20654,7 @@
             <a:r>
               <a:rPr lang="en-US" sz="1050" dirty="0">
                 <a:solidFill>
-                  <a:srgbClr val="4A5468"/>
+                  <a:srgbClr val="475569"/>
                 </a:solidFill>
                 <a:latin typeface="Calibri" pitchFamily="34" charset="0"/>
                 <a:ea typeface="Calibri" pitchFamily="34" charset="-122"/>
@@ -20693,7 +20693,7 @@
             <a:r>
               <a:rPr lang="en-US" sz="3200" b="1" dirty="0">
                 <a:solidFill>
-                  <a:srgbClr val="1E2B4A"/>
+                  <a:srgbClr val="312E81"/>
                 </a:solidFill>
                 <a:latin typeface="Calibri" pitchFamily="34" charset="0"/>
                 <a:ea typeface="Calibri" pitchFamily="34" charset="-122"/>
@@ -20735,7 +20735,7 @@
             <a:r>
               <a:rPr lang="en-US" sz="1050" dirty="0">
                 <a:solidFill>
-                  <a:srgbClr val="4A5468"/>
+                  <a:srgbClr val="475569"/>
                 </a:solidFill>
                 <a:latin typeface="Calibri" pitchFamily="34" charset="0"/>
                 <a:ea typeface="Calibri" pitchFamily="34" charset="-122"/>
@@ -20755,7 +20755,7 @@
             <a:r>
               <a:rPr lang="en-US" sz="1050" dirty="0">
                 <a:solidFill>
-                  <a:srgbClr val="4A5468"/>
+                  <a:srgbClr val="475569"/>
                 </a:solidFill>
                 <a:latin typeface="Calibri" pitchFamily="34" charset="0"/>
                 <a:ea typeface="Calibri" pitchFamily="34" charset="-122"/>
@@ -20794,7 +20794,7 @@
             <a:r>
               <a:rPr lang="en-US" sz="3200" b="1" dirty="0">
                 <a:solidFill>
-                  <a:srgbClr val="1E2B4A"/>
+                  <a:srgbClr val="312E81"/>
                 </a:solidFill>
                 <a:latin typeface="Calibri" pitchFamily="34" charset="0"/>
                 <a:ea typeface="Calibri" pitchFamily="34" charset="-122"/>
@@ -20836,7 +20836,7 @@
             <a:r>
               <a:rPr lang="en-US" sz="1050" dirty="0">
                 <a:solidFill>
-                  <a:srgbClr val="4A5468"/>
+                  <a:srgbClr val="475569"/>
                 </a:solidFill>
                 <a:latin typeface="Calibri" pitchFamily="34" charset="0"/>
                 <a:ea typeface="Calibri" pitchFamily="34" charset="-122"/>
@@ -20856,7 +20856,7 @@
             <a:r>
               <a:rPr lang="en-US" sz="1050" dirty="0">
                 <a:solidFill>
-                  <a:srgbClr val="4A5468"/>
+                  <a:srgbClr val="475569"/>
                 </a:solidFill>
                 <a:latin typeface="Calibri" pitchFamily="34" charset="0"/>
                 <a:ea typeface="Calibri" pitchFamily="34" charset="-122"/>
@@ -20883,17 +20883,17 @@
             <a:avLst/>
           </a:prstGeom>
           <a:solidFill>
-            <a:srgbClr val="E0EDEF"/>
+            <a:srgbClr val="F9DCE9"/>
           </a:solidFill>
           <a:ln w="15875">
             <a:solidFill>
-              <a:srgbClr val="BAD6DB"/>
+              <a:srgbClr val="F2B1CE"/>
             </a:solidFill>
             <a:prstDash val="solid"/>
           </a:ln>
           <a:effectLst>
             <a:outerShdw sx="100000" sy="100000" kx="0" ky="0" algn="bl" rotWithShape="0" blurRad="127000" dist="25400" dir="5400000">
-              <a:srgbClr val="1E2B4A">
+              <a:srgbClr val="312E81">
                 <a:alpha val="8000"/>
               </a:srgbClr>
             </a:outerShdw>
@@ -20951,7 +20951,7 @@
             <a:r>
               <a:rPr lang="en-US" sz="1500" b="1" dirty="0">
                 <a:solidFill>
-                  <a:srgbClr val="1D2433"/>
+                  <a:srgbClr val="0F172A"/>
                 </a:solidFill>
                 <a:latin typeface="Calibri" pitchFamily="34" charset="0"/>
                 <a:ea typeface="Calibri" pitchFamily="34" charset="-122"/>
@@ -20993,7 +20993,7 @@
             <a:r>
               <a:rPr lang="en-US" sz="1200" dirty="0">
                 <a:solidFill>
-                  <a:srgbClr val="4A5468"/>
+                  <a:srgbClr val="475569"/>
                 </a:solidFill>
                 <a:latin typeface="Calibri" pitchFamily="34" charset="0"/>
                 <a:ea typeface="Calibri" pitchFamily="34" charset="-122"/>
@@ -21020,17 +21020,17 @@
             <a:avLst/>
           </a:prstGeom>
           <a:solidFill>
-            <a:srgbClr val="F6ECDC"/>
+            <a:srgbClr val="D7EDF3"/>
           </a:solidFill>
           <a:ln w="15875">
             <a:solidFill>
-              <a:srgbClr val="ECD5B0"/>
+              <a:srgbClr val="A6D7E3"/>
             </a:solidFill>
             <a:prstDash val="solid"/>
           </a:ln>
           <a:effectLst>
             <a:outerShdw sx="100000" sy="100000" kx="0" ky="0" algn="bl" rotWithShape="0" blurRad="127000" dist="25400" dir="5400000">
-              <a:srgbClr val="1E2B4A">
+              <a:srgbClr val="312E81">
                 <a:alpha val="8000"/>
               </a:srgbClr>
             </a:outerShdw>
@@ -21088,7 +21088,7 @@
             <a:r>
               <a:rPr lang="en-US" sz="1500" b="1" dirty="0">
                 <a:solidFill>
-                  <a:srgbClr val="1D2433"/>
+                  <a:srgbClr val="0F172A"/>
                 </a:solidFill>
                 <a:latin typeface="Calibri" pitchFamily="34" charset="0"/>
                 <a:ea typeface="Calibri" pitchFamily="34" charset="-122"/>
@@ -21127,7 +21127,7 @@
             <a:r>
               <a:rPr lang="en-US" sz="1100" dirty="0">
                 <a:solidFill>
-                  <a:srgbClr val="4A5468"/>
+                  <a:srgbClr val="475569"/>
                 </a:solidFill>
                 <a:latin typeface="Calibri" pitchFamily="34" charset="0"/>
                 <a:ea typeface="Calibri" pitchFamily="34" charset="-122"/>
@@ -21156,7 +21156,7 @@
             </a:avLst>
           </a:prstGeom>
           <a:solidFill>
-            <a:srgbClr val="C98A24"/>
+            <a:srgbClr val="0891B2"/>
           </a:solidFill>
           <a:ln/>
         </p:spPr>
@@ -21188,7 +21188,7 @@
             <a:r>
               <a:rPr lang="en-US" sz="1100" b="1" dirty="0">
                 <a:solidFill>
-                  <a:srgbClr val="1D2433"/>
+                  <a:srgbClr val="0F172A"/>
                 </a:solidFill>
                 <a:latin typeface="Calibri" pitchFamily="34" charset="0"/>
                 <a:ea typeface="Calibri" pitchFamily="34" charset="-122"/>
@@ -21227,7 +21227,7 @@
             <a:r>
               <a:rPr lang="en-US" sz="1100" dirty="0">
                 <a:solidFill>
-                  <a:srgbClr val="4A5468"/>
+                  <a:srgbClr val="475569"/>
                 </a:solidFill>
                 <a:latin typeface="Calibri" pitchFamily="34" charset="0"/>
                 <a:ea typeface="Calibri" pitchFamily="34" charset="-122"/>
@@ -21256,7 +21256,7 @@
             </a:avLst>
           </a:prstGeom>
           <a:solidFill>
-            <a:srgbClr val="E3E7EE"/>
+            <a:srgbClr val="E2E8F0"/>
           </a:solidFill>
           <a:ln/>
         </p:spPr>
@@ -21288,7 +21288,7 @@
             <a:r>
               <a:rPr lang="en-US" sz="1100" b="1" dirty="0">
                 <a:solidFill>
-                  <a:srgbClr val="1D2433"/>
+                  <a:srgbClr val="0F172A"/>
                 </a:solidFill>
                 <a:latin typeface="Calibri" pitchFamily="34" charset="0"/>
                 <a:ea typeface="Calibri" pitchFamily="34" charset="-122"/>
@@ -21327,7 +21327,7 @@
             <a:r>
               <a:rPr lang="en-US" sz="1100" dirty="0">
                 <a:solidFill>
-                  <a:srgbClr val="4A5468"/>
+                  <a:srgbClr val="475569"/>
                 </a:solidFill>
                 <a:latin typeface="Calibri" pitchFamily="34" charset="0"/>
                 <a:ea typeface="Calibri" pitchFamily="34" charset="-122"/>
@@ -21356,7 +21356,7 @@
             </a:avLst>
           </a:prstGeom>
           <a:solidFill>
-            <a:srgbClr val="E3E7EE"/>
+            <a:srgbClr val="E2E8F0"/>
           </a:solidFill>
           <a:ln/>
         </p:spPr>
@@ -21388,7 +21388,7 @@
             <a:r>
               <a:rPr lang="en-US" sz="1100" b="1" dirty="0">
                 <a:solidFill>
-                  <a:srgbClr val="1D2433"/>
+                  <a:srgbClr val="0F172A"/>
                 </a:solidFill>
                 <a:latin typeface="Calibri" pitchFamily="34" charset="0"/>
                 <a:ea typeface="Calibri" pitchFamily="34" charset="-122"/>
@@ -21427,7 +21427,7 @@
             <a:r>
               <a:rPr lang="en-US" sz="1100" dirty="0">
                 <a:solidFill>
-                  <a:srgbClr val="4A5468"/>
+                  <a:srgbClr val="475569"/>
                 </a:solidFill>
                 <a:latin typeface="Calibri" pitchFamily="34" charset="0"/>
                 <a:ea typeface="Calibri" pitchFamily="34" charset="-122"/>
@@ -21456,7 +21456,7 @@
             </a:avLst>
           </a:prstGeom>
           <a:solidFill>
-            <a:srgbClr val="E3E7EE"/>
+            <a:srgbClr val="E2E8F0"/>
           </a:solidFill>
           <a:ln/>
         </p:spPr>
@@ -21488,7 +21488,7 @@
             <a:r>
               <a:rPr lang="en-US" sz="1100" b="1" dirty="0">
                 <a:solidFill>
-                  <a:srgbClr val="1D2433"/>
+                  <a:srgbClr val="0F172A"/>
                 </a:solidFill>
                 <a:latin typeface="Calibri" pitchFamily="34" charset="0"/>
                 <a:ea typeface="Calibri" pitchFamily="34" charset="-122"/>
@@ -21527,7 +21527,7 @@
             <a:r>
               <a:rPr lang="en-US" sz="900" dirty="0">
                 <a:solidFill>
-                  <a:srgbClr val="8A93A5"/>
+                  <a:srgbClr val="94A3B8"/>
                 </a:solidFill>
                 <a:latin typeface="Calibri" pitchFamily="34" charset="0"/>
                 <a:ea typeface="Calibri" pitchFamily="34" charset="-122"/>
@@ -21566,7 +21566,7 @@
             <a:r>
               <a:rPr lang="en-US" sz="950" dirty="0">
                 <a:solidFill>
-                  <a:srgbClr val="8A93A5"/>
+                  <a:srgbClr val="94A3B8"/>
                 </a:solidFill>
                 <a:latin typeface="Calibri" pitchFamily="34" charset="0"/>
                 <a:ea typeface="Calibri" pitchFamily="34" charset="-122"/>
@@ -21661,7 +21661,7 @@
             <a:r>
               <a:rPr lang="en-US" sz="2700" b="1" dirty="0">
                 <a:solidFill>
-                  <a:srgbClr val="1E2B4A"/>
+                  <a:srgbClr val="312E81"/>
                 </a:solidFill>
                 <a:latin typeface="Calibri" pitchFamily="34" charset="0"/>
                 <a:ea typeface="Calibri" pitchFamily="34" charset="-122"/>
@@ -21703,7 +21703,7 @@
             <a:r>
               <a:rPr lang="en-US" sz="1300" dirty="0">
                 <a:solidFill>
-                  <a:srgbClr val="4A5468"/>
+                  <a:srgbClr val="475569"/>
                 </a:solidFill>
                 <a:latin typeface="Calibri" pitchFamily="34" charset="0"/>
                 <a:ea typeface="Calibri" pitchFamily="34" charset="-122"/>
@@ -21730,17 +21730,17 @@
             <a:avLst/>
           </a:prstGeom>
           <a:solidFill>
-            <a:srgbClr val="E1E6EF"/>
+            <a:srgbClr val="E3E1FB"/>
           </a:solidFill>
           <a:ln w="15875">
             <a:solidFill>
-              <a:srgbClr val="BBC7DC"/>
+              <a:srgbClr val="C0BCF6"/>
             </a:solidFill>
             <a:prstDash val="solid"/>
           </a:ln>
           <a:effectLst>
             <a:outerShdw sx="100000" sy="100000" kx="0" ky="0" algn="bl" rotWithShape="0" blurRad="127000" dist="25400" dir="5400000">
-              <a:srgbClr val="1E2B4A">
+              <a:srgbClr val="312E81">
                 <a:alpha val="8000"/>
               </a:srgbClr>
             </a:outerShdw>
@@ -21798,7 +21798,7 @@
             <a:r>
               <a:rPr lang="en-US" sz="3400" b="1" dirty="0">
                 <a:solidFill>
-                  <a:srgbClr val="E3E7EE"/>
+                  <a:srgbClr val="E2E8F0"/>
                 </a:solidFill>
                 <a:latin typeface="Calibri" pitchFamily="34" charset="0"/>
                 <a:ea typeface="Calibri" pitchFamily="34" charset="-122"/>
@@ -21837,7 +21837,7 @@
             <a:r>
               <a:rPr lang="en-US" sz="1500" b="1" dirty="0">
                 <a:solidFill>
-                  <a:srgbClr val="1D2433"/>
+                  <a:srgbClr val="0F172A"/>
                 </a:solidFill>
                 <a:latin typeface="Calibri" pitchFamily="34" charset="0"/>
                 <a:ea typeface="Calibri" pitchFamily="34" charset="-122"/>
@@ -21879,7 +21879,7 @@
             <a:r>
               <a:rPr lang="en-US" sz="1150" dirty="0">
                 <a:solidFill>
-                  <a:srgbClr val="4A5468"/>
+                  <a:srgbClr val="475569"/>
                 </a:solidFill>
                 <a:latin typeface="Calibri" pitchFamily="34" charset="0"/>
                 <a:ea typeface="Calibri" pitchFamily="34" charset="-122"/>
@@ -21906,17 +21906,17 @@
             <a:avLst/>
           </a:prstGeom>
           <a:solidFill>
-            <a:srgbClr val="E0EDEF"/>
+            <a:srgbClr val="F9DCE9"/>
           </a:solidFill>
           <a:ln w="15875">
             <a:solidFill>
-              <a:srgbClr val="BAD6DB"/>
+              <a:srgbClr val="F2B1CE"/>
             </a:solidFill>
             <a:prstDash val="solid"/>
           </a:ln>
           <a:effectLst>
             <a:outerShdw sx="100000" sy="100000" kx="0" ky="0" algn="bl" rotWithShape="0" blurRad="127000" dist="25400" dir="5400000">
-              <a:srgbClr val="1E2B4A">
+              <a:srgbClr val="312E81">
                 <a:alpha val="8000"/>
               </a:srgbClr>
             </a:outerShdw>
@@ -21974,7 +21974,7 @@
             <a:r>
               <a:rPr lang="en-US" sz="3400" b="1" dirty="0">
                 <a:solidFill>
-                  <a:srgbClr val="E3E7EE"/>
+                  <a:srgbClr val="E2E8F0"/>
                 </a:solidFill>
                 <a:latin typeface="Calibri" pitchFamily="34" charset="0"/>
                 <a:ea typeface="Calibri" pitchFamily="34" charset="-122"/>
@@ -22013,7 +22013,7 @@
             <a:r>
               <a:rPr lang="en-US" sz="1500" b="1" dirty="0">
                 <a:solidFill>
-                  <a:srgbClr val="1D2433"/>
+                  <a:srgbClr val="0F172A"/>
                 </a:solidFill>
                 <a:latin typeface="Calibri" pitchFamily="34" charset="0"/>
                 <a:ea typeface="Calibri" pitchFamily="34" charset="-122"/>
@@ -22055,7 +22055,7 @@
             <a:r>
               <a:rPr lang="en-US" sz="1150" dirty="0">
                 <a:solidFill>
-                  <a:srgbClr val="4A5468"/>
+                  <a:srgbClr val="475569"/>
                 </a:solidFill>
                 <a:latin typeface="Calibri" pitchFamily="34" charset="0"/>
                 <a:ea typeface="Calibri" pitchFamily="34" charset="-122"/>
@@ -22082,17 +22082,17 @@
             <a:avLst/>
           </a:prstGeom>
           <a:solidFill>
-            <a:srgbClr val="F9E8DD"/>
+            <a:srgbClr val="F9E9D7"/>
           </a:solidFill>
           <a:ln w="15875">
             <a:solidFill>
-              <a:srgbClr val="F1CBB3"/>
+              <a:srgbClr val="F1CEA5"/>
             </a:solidFill>
             <a:prstDash val="solid"/>
           </a:ln>
           <a:effectLst>
             <a:outerShdw sx="100000" sy="100000" kx="0" ky="0" algn="bl" rotWithShape="0" blurRad="127000" dist="25400" dir="5400000">
-              <a:srgbClr val="1E2B4A">
+              <a:srgbClr val="312E81">
                 <a:alpha val="8000"/>
               </a:srgbClr>
             </a:outerShdw>
@@ -22150,7 +22150,7 @@
             <a:r>
               <a:rPr lang="en-US" sz="3400" b="1" dirty="0">
                 <a:solidFill>
-                  <a:srgbClr val="E3E7EE"/>
+                  <a:srgbClr val="E2E8F0"/>
                 </a:solidFill>
                 <a:latin typeface="Calibri" pitchFamily="34" charset="0"/>
                 <a:ea typeface="Calibri" pitchFamily="34" charset="-122"/>
@@ -22189,7 +22189,7 @@
             <a:r>
               <a:rPr lang="en-US" sz="1500" b="1" dirty="0">
                 <a:solidFill>
-                  <a:srgbClr val="1D2433"/>
+                  <a:srgbClr val="0F172A"/>
                 </a:solidFill>
                 <a:latin typeface="Calibri" pitchFamily="34" charset="0"/>
                 <a:ea typeface="Calibri" pitchFamily="34" charset="-122"/>
@@ -22231,7 +22231,7 @@
             <a:r>
               <a:rPr lang="en-US" sz="1150" dirty="0">
                 <a:solidFill>
-                  <a:srgbClr val="4A5468"/>
+                  <a:srgbClr val="475569"/>
                 </a:solidFill>
                 <a:latin typeface="Calibri" pitchFamily="34" charset="0"/>
                 <a:ea typeface="Calibri" pitchFamily="34" charset="-122"/>
@@ -22260,7 +22260,7 @@
             </a:avLst>
           </a:prstGeom>
           <a:solidFill>
-            <a:srgbClr val="1E2B4A"/>
+            <a:srgbClr val="312E81"/>
           </a:solidFill>
           <a:ln/>
         </p:spPr>
@@ -22334,7 +22334,7 @@
             <a:r>
               <a:rPr lang="en-US" sz="950" dirty="0">
                 <a:solidFill>
-                  <a:srgbClr val="8A93A5"/>
+                  <a:srgbClr val="94A3B8"/>
                 </a:solidFill>
                 <a:latin typeface="Calibri" pitchFamily="34" charset="0"/>
                 <a:ea typeface="Calibri" pitchFamily="34" charset="-122"/>

</xml_diff>